<commit_message>
deck slide 14: schematic simplified to the TG (Dave 2026-08-30)
The three-panel version drew a Mach-Zehnder with a transmission sample
beside a talk about measuring a MIRROR -- an MZ has no natural seat for
one, and a Michelson panel would draw the same topology as the TG twice
(a Twyman-Green IS a Michelson fed with collimated light).  Now: the TG
panel carries the lineage note and the PSI mechanics in-figure (lambda/4
-> opposite circular, analyzer theta -> fringe phase 2theta, four theta
= the four steps); the splitter plate-vs-cube panel stays; the MZ point
lives in bullet 1 as words ('no natural seat for a mirror').  Edit deck
+ pass-3 baseline re-synced to this build (verified untouched first).

Co-Authored-By: Claude Fable 5 <noreply@anthropic.com>
</commit_message>
<xml_diff>
--- a/demo_session/baseline_pass3.pptx
+++ b/demo_session/baseline_pass3.pptx
@@ -5992,7 +5992,7 @@
                 </a:solidFill>
                 <a:latin typeface="Arial"/>
               </a:rPr>
-              <a:t>•  Why a Twyman–Green for a DM: normal incidence, double pass (height counts twice), a natural null against the flat reference — the fewest reference surfaces of any two-beam layout.  A Mach–Zehnder buys isolated arms and two ports: dynamics and transmission, not figure.</a:t>
+              <a:t>•  Why a Twyman–Green for a DM: it is the Michelson topology fed with collimated light — both arms end on mirrors, so the DM takes one arm whole, at normal incidence, double pass (height counts twice), with a natural null against the reference flat.  A transmission layout like the Mach–Zehnder has no natural seat for a mirror; its isolated arms and two ports serve dynamics and transmission testing, not figure.</a:t>
             </a:r>
           </a:p>
           <a:p>
@@ -6287,8 +6287,8 @@
         </p:blipFill>
         <p:spPr>
           <a:xfrm>
-            <a:off x="1467487" y="4443984"/>
-            <a:ext cx="9256720" cy="2020316"/>
+            <a:off x="1833205" y="4603623"/>
+            <a:ext cx="8525283" cy="1860676"/>
           </a:xfrm>
           <a:prstGeom prst="rect">
             <a:avLst/>
@@ -6329,7 +6329,7 @@
                 </a:solidFill>
                 <a:latin typeface="Arial"/>
               </a:rPr>
-              <a:t>Two-beam topologies, and the splitter that decides the error budget.</a:t>
+              <a:t>The demo rig, and the splitter that decides its error budget.</a:t>
             </a:r>
           </a:p>
         </p:txBody>

</xml_diff>

<commit_message>
deck: slides 20-22 rebalanced -- big figures, no dead columns (Dave 2026-08-30)
Slide 20: the illegible light-order flow chart is replaced by the traced
37-element train iso (white-trimmed crop of the committed r2_train_iso),
filling the left column at 4.3"; the shroud end-on grows to 3.7" and
fills the right; the light-order chart is pointed to in the footnote.
Slide 21: the MET view moves under the bullets at 4.3" (left) and the
dwdx channel stack takes the right column at 5.0".  Slide 22: the
400 s series grows 3.6 -> 5.0", filling its column with all three
panels readable.  Edit deck + pass-3 baseline re-synced.

Co-Authored-By: Claude Fable 5 <noreply@anthropic.com>
</commit_message>
<xml_diff>
--- a/demo_session/baseline_pass3.pptx
+++ b/demo_session/baseline_pass3.pptx
@@ -9402,7 +9402,7 @@
       </p:sp>
       <p:pic>
         <p:nvPicPr>
-          <p:cNvPr id="5" name="Picture 4" descr="r2_sequence.png"/>
+          <p:cNvPr id="5" name="Picture 4" descr="crop_r2_train_iso.png"/>
           <p:cNvPicPr>
             <a:picLocks noChangeAspect="1"/>
           </p:cNvPicPr>
@@ -9416,8 +9416,8 @@
         </p:blipFill>
         <p:spPr>
           <a:xfrm>
-            <a:off x="1328979" y="2218182"/>
-            <a:ext cx="3971440" cy="1343152"/>
+            <a:off x="859353" y="2218182"/>
+            <a:ext cx="4910692" cy="3537712"/>
           </a:xfrm>
           <a:prstGeom prst="rect">
             <a:avLst/>
@@ -9432,7 +9432,7 @@
         </p:nvSpPr>
         <p:spPr>
           <a:xfrm>
-            <a:off x="411480" y="3579622"/>
+            <a:off x="411480" y="5774181"/>
             <a:ext cx="5806440" cy="394208"/>
           </a:xfrm>
           <a:prstGeom prst="rect">
@@ -9458,7 +9458,7 @@
                 </a:solidFill>
                 <a:latin typeface="Arial"/>
               </a:rPr>
-              <a:t>The light order, both instruments: the shared trunk, the deployable-pick-off imager leg, and the DM-bearing coronagraph leg.</a:t>
+              <a:t>The full train, traced: the segmented 6 m primary feeding the DM-bearing back end — 37 elements across the two instrument legs.</a:t>
             </a:r>
           </a:p>
         </p:txBody>
@@ -9479,8 +9479,8 @@
         </p:blipFill>
         <p:spPr>
           <a:xfrm>
-            <a:off x="7536686" y="2218182"/>
-            <a:ext cx="3123186" cy="2257552"/>
+            <a:off x="7030679" y="2218182"/>
+            <a:ext cx="4135200" cy="2989072"/>
           </a:xfrm>
           <a:prstGeom prst="rect">
             <a:avLst/>
@@ -9495,7 +9495,7 @@
         </p:nvSpPr>
         <p:spPr>
           <a:xfrm>
-            <a:off x="6400800" y="4494022"/>
+            <a:off x="6400800" y="5225542"/>
             <a:ext cx="5394960" cy="394208"/>
           </a:xfrm>
           <a:prstGeom prst="rect">
@@ -9534,7 +9534,7 @@
         </p:nvSpPr>
         <p:spPr>
           <a:xfrm>
-            <a:off x="6400800" y="4924806"/>
+            <a:off x="6400800" y="5656326"/>
             <a:ext cx="5394960" cy="274320"/>
           </a:xfrm>
           <a:prstGeom prst="rect">
@@ -9560,7 +9560,7 @@
                 </a:solidFill>
                 <a:latin typeface="Arial"/>
               </a:rPr>
-              <a:t>The telescope is one of the design-layer templates, diffraction-limited at 500 nm (imaging-leg Strehl 0.9993).  Record: templates/80_end_to_end/e2e6m_r2.</a:t>
+              <a:t>The telescope is one of the design-layer templates, diffraction-limited at 500 nm (imaging-leg Strehl 0.9993); the two-leg light-order chart is in the record.  Record: templates/80_end_to_end/e2e6m_r2.</a:t>
             </a:r>
           </a:p>
         </p:txBody>
@@ -9753,8 +9753,8 @@
         </p:blipFill>
         <p:spPr>
           <a:xfrm>
-            <a:off x="7579124" y="1298448"/>
-            <a:ext cx="3038311" cy="1983232"/>
+            <a:off x="511032" y="2804160"/>
+            <a:ext cx="5607334" cy="3660140"/>
           </a:xfrm>
           <a:prstGeom prst="rect">
             <a:avLst/>
@@ -9769,8 +9769,8 @@
         </p:nvSpPr>
         <p:spPr>
           <a:xfrm>
-            <a:off x="6400800" y="3299968"/>
-            <a:ext cx="5394960" cy="394208"/>
+            <a:off x="411480" y="6482588"/>
+            <a:ext cx="5806440" cy="229107"/>
           </a:xfrm>
           <a:prstGeom prst="rect">
             <a:avLst/>
@@ -9816,8 +9816,8 @@
         </p:blipFill>
         <p:spPr>
           <a:xfrm>
-            <a:off x="8314811" y="3730752"/>
-            <a:ext cx="1566937" cy="1553972"/>
+            <a:off x="6908717" y="1298448"/>
+            <a:ext cx="4379125" cy="4342892"/>
           </a:xfrm>
           <a:prstGeom prst="rect">
             <a:avLst/>
@@ -9832,7 +9832,7 @@
         </p:nvSpPr>
         <p:spPr>
           <a:xfrm>
-            <a:off x="6400800" y="5303012"/>
+            <a:off x="6400800" y="5659627"/>
             <a:ext cx="5394960" cy="229107"/>
           </a:xfrm>
           <a:prstGeom prst="rect">
@@ -9871,7 +9871,7 @@
         </p:nvSpPr>
         <p:spPr>
           <a:xfrm>
-            <a:off x="6400800" y="5568696"/>
+            <a:off x="6400800" y="5925312"/>
             <a:ext cx="5394960" cy="274320"/>
           </a:xfrm>
           <a:prstGeom prst="rect">
@@ -10106,8 +10106,8 @@
         </p:blipFill>
         <p:spPr>
           <a:xfrm>
-            <a:off x="7589880" y="1298448"/>
-            <a:ext cx="3016798" cy="2897632"/>
+            <a:off x="6923477" y="1298448"/>
+            <a:ext cx="4349605" cy="4177792"/>
           </a:xfrm>
           <a:prstGeom prst="rect">
             <a:avLst/>
@@ -10122,7 +10122,7 @@
         </p:nvSpPr>
         <p:spPr>
           <a:xfrm>
-            <a:off x="6400800" y="4214367"/>
+            <a:off x="6400800" y="5494528"/>
             <a:ext cx="5394960" cy="394208"/>
           </a:xfrm>
           <a:prstGeom prst="rect">
@@ -10161,7 +10161,7 @@
         </p:nvSpPr>
         <p:spPr>
           <a:xfrm>
-            <a:off x="6400800" y="4645151"/>
+            <a:off x="6400800" y="5925312"/>
             <a:ext cx="5394960" cy="274320"/>
           </a:xfrm>
           <a:prstGeom prst="rect">

</xml_diff>

<commit_message>
deck slide 14: how the polarization angles are collected (Dave 2026-08-31)
'No moving parts' overstated the modeled rig: v1/v2 step phase by
ROTATING the output analyzer -- a mover, but in the recombined beam
where its motion adds only common phase; the precise claim is 'nothing
in the interferometer moves' (the rig README's own words).  The
snapshot register: a polarization-multiplexed (pixelated) camera with
0/45/90/135 deg analyzers per 2x2 tile collects all four steps in one
frame.  Bullet 2 and the schematic's camera/footer labels now say
exactly that.  Pre-sync full diff: clean (no new Dave edits).

Co-Authored-By: Claude Fable 5 <noreply@anthropic.com>
</commit_message>
<xml_diff>
--- a/demo_session/baseline_pass3.pptx
+++ b/demo_session/baseline_pass3.pptx
@@ -6009,7 +6009,7 @@
                 </a:solidFill>
                 <a:latin typeface="Arial"/>
               </a:rPr>
-              <a:t>•  Why a Twyman–Green for a DM: it is the Michelson topology fed with collimated light — both arms end on mirrors, so the DM takes one arm whole, at normal incidence, double pass (height counts twice), with a natural null against the reference flat.  A transmission layout like the Mach–Zehnder has no natural seat for a mirror; its isolated arms and two ports serve dynamics and transmission testing, not figure.</a:t>
+              <a:t>•  Why a Twyman–Green for a DM: it is the Michelson topology fed with collimated light — both arms end on mirrors, so the DM takes one arm whole, at normal incidence, double pass (height counts twice), with a natural null against the reference flat.  A Mach–Zehnder has no natural seat for a mirror — its isolated arms and two ports serve dynamics and transmission, not figure.</a:t>
             </a:r>
           </a:p>
           <a:p>
@@ -6025,7 +6025,7 @@
                 </a:solidFill>
                 <a:latin typeface="Arial"/>
               </a:rPr>
-              <a:t>•  Phase shifting with no moving parts: the arms carry orthogonal polarizations; a quarter-wave plate makes them opposite circular, and the analyzer angle θ writes fringe phase 2θ — four angles are the four PSI steps.</a:t>
+              <a:t>•  Phase shifting, nothing moving in the interferometer: the arms carry orthogonal polarizations; a quarter-wave plate makes them opposite circular; the analyzer angle θ writes fringe phase 2θ.  The analyzer sits in the recombined beam, where its motion adds only common phase — or is a pixelated camera (0/45/90/135° per 2×2 tile): all four steps in one snapshot.</a:t>
             </a:r>
           </a:p>
           <a:p>
@@ -6304,8 +6304,8 @@
         </p:blipFill>
         <p:spPr>
           <a:xfrm>
-            <a:off x="1833205" y="4603623"/>
-            <a:ext cx="8525283" cy="1860676"/>
+            <a:off x="2268169" y="4793488"/>
+            <a:ext cx="7655356" cy="1670811"/>
           </a:xfrm>
           <a:prstGeom prst="rect">
             <a:avLst/>

</xml_diff>

<commit_message>
deck slide 15: Dave's layout pass recovered from the LO backup; sync is now GATED
An unconditionally chained cp overwrote Dave's 07:58 save (the check
printed non-zero counts and the copy ran anyway).  Recovered from
~/.config/libreoffice/4/user/backup: bullets to 14 pt, the sweep figure
to 4.75x2.36 at the column top, the sensitivity figure to 5.61x2.27,
table and captions repositioned -- all folded into the sidecar.  One
small TEXT edit from his final save is not in the backup and was lost
with the unsaved Impress close; flagged to Dave.

sync_edit_deck.sh replaces the manual cp: it REFUSES to sync while the
Impress lock exists or while the edit deck differs from the baseline
(text or deliberate geometry), --force only after Dave declares the
edits disposable.  The check is now a gate, not a printout.

Co-Authored-By: Claude Fable 5 <noreply@anthropic.com>
</commit_message>
<xml_diff>
--- a/demo_session/baseline_pass3.pptx
+++ b/demo_session/baseline_pass3.pptx
@@ -6496,7 +6496,7 @@
               </a:spcAft>
             </a:pPr>
             <a:r>
-              <a:rPr sz="1200" b="0">
+              <a:rPr sz="1400" b="0">
                 <a:solidFill>
                   <a:srgbClr val="282828"/>
                 </a:solidFill>
@@ -6512,7 +6512,7 @@
               </a:spcAft>
             </a:pPr>
             <a:r>
-              <a:rPr sz="1200" b="0">
+              <a:rPr sz="1400" b="0">
                 <a:solidFill>
                   <a:srgbClr val="282828"/>
                 </a:solidFill>
@@ -6528,7 +6528,7 @@
               </a:spcAft>
             </a:pPr>
             <a:r>
-              <a:rPr sz="1200" b="0">
+              <a:rPr sz="1400" b="0">
                 <a:solidFill>
                   <a:srgbClr val="282828"/>
                 </a:solidFill>
@@ -6548,7 +6548,7 @@
           <p:nvPr/>
         </p:nvGraphicFramePr>
         <p:xfrm>
-          <a:off x="411480" y="4133087"/>
+          <a:off x="411480" y="4425696"/>
           <a:ext cx="5806439" cy="1680210"/>
         </p:xfrm>
         <a:graphic>
@@ -6980,8 +6980,8 @@
         </p:blipFill>
         <p:spPr>
           <a:xfrm>
-            <a:off x="7561919" y="1298448"/>
-            <a:ext cx="3072721" cy="1434592"/>
+            <a:off x="6858000" y="914400"/>
+            <a:ext cx="4343400" cy="2157984"/>
           </a:xfrm>
           <a:prstGeom prst="rect">
             <a:avLst/>
@@ -6996,7 +6996,7 @@
         </p:nvSpPr>
         <p:spPr>
           <a:xfrm>
-            <a:off x="6400800" y="2751328"/>
+            <a:off x="6400800" y="3072384"/>
             <a:ext cx="5394960" cy="394208"/>
           </a:xfrm>
           <a:prstGeom prst="rect">
@@ -7043,8 +7043,8 @@
         </p:blipFill>
         <p:spPr>
           <a:xfrm>
-            <a:off x="7493905" y="3182112"/>
-            <a:ext cx="3208749" cy="1297432"/>
+            <a:off x="6592824" y="3575304"/>
+            <a:ext cx="5129784" cy="2075688"/>
           </a:xfrm>
           <a:prstGeom prst="rect">
             <a:avLst/>
@@ -7059,7 +7059,7 @@
         </p:nvSpPr>
         <p:spPr>
           <a:xfrm>
-            <a:off x="6400800" y="4497832"/>
+            <a:off x="6400800" y="5687568"/>
             <a:ext cx="5394960" cy="394208"/>
           </a:xfrm>
           <a:prstGeom prst="rect">
@@ -7098,7 +7098,7 @@
         </p:nvSpPr>
         <p:spPr>
           <a:xfrm>
-            <a:off x="6400800" y="4928616"/>
+            <a:off x="6400800" y="6117336"/>
             <a:ext cx="5394960" cy="274320"/>
           </a:xfrm>
           <a:prstGeom prst="rect">

</xml_diff>

<commit_message>
deck: Dave's CTB-block pass recovered via the gate (slides 14, 16-19)
The gate refused the sync, the diffs were read in FULL, and everything
folded: slide-19 caption drops 'sub-nanometer'; fonts up (16: 18pt,
17: 16pt, 18: 18pt narrowed to 5.80, 19: 15pt narrowed to 5.55); the
slide-14 schematic pinned at 10.63x2.57; CTB figures enlarged and
repositioned with captions/footnotes following (sweep 6.50x4.52, EFC
strip 7.07 wide, bandwidth 3.89x2.89, train render + mask compare
moved).  sync_edit_deck.sh gains --folded (diffs incorporated into the
build) as distinct from --force (diffs discarded, Dave's say-so only).

Co-Authored-By: Claude Fable 5 <noreply@anthropic.com>
</commit_message>
<xml_diff>
--- a/demo_session/baseline_pass3.pptx
+++ b/demo_session/baseline_pass3.pptx
@@ -6304,8 +6304,8 @@
         </p:blipFill>
         <p:spPr>
           <a:xfrm>
-            <a:off x="2268169" y="4793488"/>
-            <a:ext cx="7655356" cy="1670811"/>
+            <a:off x="1024128" y="4133087"/>
+            <a:ext cx="9720072" cy="2350008"/>
           </a:xfrm>
           <a:prstGeom prst="rect">
             <a:avLst/>
@@ -6320,8 +6320,8 @@
         </p:nvSpPr>
         <p:spPr>
           <a:xfrm>
-            <a:off x="411480" y="6482588"/>
-            <a:ext cx="11368735" cy="229107"/>
+            <a:off x="1024128" y="6501383"/>
+            <a:ext cx="9720072" cy="229107"/>
           </a:xfrm>
           <a:prstGeom prst="rect">
             <a:avLst/>
@@ -7274,7 +7274,7 @@
               </a:spcAft>
             </a:pPr>
             <a:r>
-              <a:rPr sz="1200" b="0">
+              <a:rPr sz="1800" b="0">
                 <a:solidFill>
                   <a:srgbClr val="282828"/>
                 </a:solidFill>
@@ -7290,7 +7290,7 @@
               </a:spcAft>
             </a:pPr>
             <a:r>
-              <a:rPr sz="1200" b="0">
+              <a:rPr sz="1800" b="0">
                 <a:solidFill>
                   <a:srgbClr val="282828"/>
                 </a:solidFill>
@@ -7306,7 +7306,7 @@
               </a:spcAft>
             </a:pPr>
             <a:r>
-              <a:rPr sz="1200" b="0">
+              <a:rPr sz="1800" b="0">
                 <a:solidFill>
                   <a:srgbClr val="282828"/>
                 </a:solidFill>
@@ -7627,7 +7627,7 @@
               </a:spcAft>
             </a:pPr>
             <a:r>
-              <a:rPr sz="1200" b="0">
+              <a:rPr sz="1600" b="0">
                 <a:solidFill>
                   <a:srgbClr val="282828"/>
                 </a:solidFill>
@@ -7643,7 +7643,7 @@
               </a:spcAft>
             </a:pPr>
             <a:r>
-              <a:rPr sz="1200" b="0">
+              <a:rPr sz="1600" b="0">
                 <a:solidFill>
                   <a:srgbClr val="282828"/>
                 </a:solidFill>
@@ -7663,7 +7663,7 @@
           <p:nvPr/>
         </p:nvGraphicFramePr>
         <p:xfrm>
-          <a:off x="411480" y="2804160"/>
+          <a:off x="411480" y="3849624"/>
           <a:ext cx="5806439" cy="1680210"/>
         </p:xfrm>
         <a:graphic>
@@ -8105,8 +8105,8 @@
         </p:blipFill>
         <p:spPr>
           <a:xfrm>
-            <a:off x="7891737" y="1298448"/>
-            <a:ext cx="2413084" cy="1068832"/>
+            <a:off x="7086600" y="1261872"/>
+            <a:ext cx="4297680" cy="1362456"/>
           </a:xfrm>
           <a:prstGeom prst="rect">
             <a:avLst/>
@@ -8121,7 +8121,7 @@
         </p:nvSpPr>
         <p:spPr>
           <a:xfrm>
-            <a:off x="6400800" y="2385568"/>
+            <a:off x="6400800" y="2706624"/>
             <a:ext cx="5394960" cy="394208"/>
           </a:xfrm>
           <a:prstGeom prst="rect">
@@ -8168,8 +8168,8 @@
         </p:blipFill>
         <p:spPr>
           <a:xfrm>
-            <a:off x="7274555" y="2816352"/>
-            <a:ext cx="3647449" cy="1955292"/>
+            <a:off x="6629400" y="3118104"/>
+            <a:ext cx="4736592" cy="2542032"/>
           </a:xfrm>
           <a:prstGeom prst="rect">
             <a:avLst/>
@@ -8184,7 +8184,7 @@
         </p:nvSpPr>
         <p:spPr>
           <a:xfrm>
-            <a:off x="6400800" y="4789932"/>
+            <a:off x="6400800" y="5614416"/>
             <a:ext cx="5394960" cy="559307"/>
           </a:xfrm>
           <a:prstGeom prst="rect">
@@ -8223,7 +8223,7 @@
         </p:nvSpPr>
         <p:spPr>
           <a:xfrm>
-            <a:off x="6400800" y="5385816"/>
+            <a:off x="6400800" y="6071616"/>
             <a:ext cx="5394960" cy="274320"/>
           </a:xfrm>
           <a:prstGeom prst="rect">
@@ -8380,7 +8380,7 @@
         <p:spPr>
           <a:xfrm>
             <a:off x="411480" y="1298448"/>
-            <a:ext cx="5806440" cy="274320"/>
+            <a:ext cx="5303520" cy="274320"/>
           </a:xfrm>
           <a:prstGeom prst="rect">
             <a:avLst/>
@@ -8399,7 +8399,7 @@
               </a:spcAft>
             </a:pPr>
             <a:r>
-              <a:rPr sz="1200" b="0">
+              <a:rPr sz="1800" b="0">
                 <a:solidFill>
                   <a:srgbClr val="282828"/>
                 </a:solidFill>
@@ -8415,7 +8415,7 @@
               </a:spcAft>
             </a:pPr>
             <a:r>
-              <a:rPr sz="1200" b="0">
+              <a:rPr sz="1800" b="0">
                 <a:solidFill>
                   <a:srgbClr val="282828"/>
                 </a:solidFill>
@@ -8431,7 +8431,7 @@
               </a:spcAft>
             </a:pPr>
             <a:r>
-              <a:rPr sz="1200" b="0">
+              <a:rPr sz="1800" b="0">
                 <a:solidFill>
                   <a:srgbClr val="282828"/>
                 </a:solidFill>
@@ -8458,8 +8458,8 @@
         </p:blipFill>
         <p:spPr>
           <a:xfrm>
-            <a:off x="7079575" y="1298448"/>
-            <a:ext cx="4037408" cy="2806192"/>
+            <a:off x="5934456" y="1353312"/>
+            <a:ext cx="5943600" cy="4133087"/>
           </a:xfrm>
           <a:prstGeom prst="rect">
             <a:avLst/>
@@ -8474,7 +8474,7 @@
         </p:nvSpPr>
         <p:spPr>
           <a:xfrm>
-            <a:off x="6400800" y="4122927"/>
+            <a:off x="6400800" y="5596128"/>
             <a:ext cx="5394960" cy="394208"/>
           </a:xfrm>
           <a:prstGeom prst="rect">
@@ -8513,7 +8513,7 @@
         </p:nvSpPr>
         <p:spPr>
           <a:xfrm>
-            <a:off x="6400800" y="4553712"/>
+            <a:off x="6400800" y="6025896"/>
             <a:ext cx="5394960" cy="274320"/>
           </a:xfrm>
           <a:prstGeom prst="rect">
@@ -8670,7 +8670,7 @@
         <p:spPr>
           <a:xfrm>
             <a:off x="411480" y="1298448"/>
-            <a:ext cx="5806440" cy="274320"/>
+            <a:ext cx="5074920" cy="274320"/>
           </a:xfrm>
           <a:prstGeom prst="rect">
             <a:avLst/>
@@ -8689,7 +8689,7 @@
               </a:spcAft>
             </a:pPr>
             <a:r>
-              <a:rPr sz="1200" b="0">
+              <a:rPr sz="1500" b="0">
                 <a:solidFill>
                   <a:srgbClr val="282828"/>
                 </a:solidFill>
@@ -8705,7 +8705,7 @@
               </a:spcAft>
             </a:pPr>
             <a:r>
-              <a:rPr sz="1200" b="0">
+              <a:rPr sz="1500" b="0">
                 <a:solidFill>
                   <a:srgbClr val="282828"/>
                 </a:solidFill>
@@ -8721,7 +8721,7 @@
               </a:spcAft>
             </a:pPr>
             <a:r>
-              <a:rPr sz="1200" b="0">
+              <a:rPr sz="1500" b="0">
                 <a:solidFill>
                   <a:srgbClr val="282828"/>
                 </a:solidFill>
@@ -8737,7 +8737,7 @@
               </a:spcAft>
             </a:pPr>
             <a:r>
-              <a:rPr sz="1200" b="0">
+              <a:rPr sz="1500" b="0">
                 <a:solidFill>
                   <a:srgbClr val="282828"/>
                 </a:solidFill>
@@ -8764,8 +8764,8 @@
         </p:blipFill>
         <p:spPr>
           <a:xfrm>
-            <a:off x="6400800" y="1298448"/>
-            <a:ext cx="5394960" cy="1205662"/>
+            <a:off x="5641848" y="1298448"/>
+            <a:ext cx="6464808" cy="1444752"/>
           </a:xfrm>
           <a:prstGeom prst="rect">
             <a:avLst/>
@@ -8780,8 +8780,8 @@
         </p:nvSpPr>
         <p:spPr>
           <a:xfrm>
-            <a:off x="6400800" y="2522398"/>
-            <a:ext cx="5394960" cy="394208"/>
+            <a:off x="5486400" y="2807208"/>
+            <a:ext cx="6309360" cy="394208"/>
           </a:xfrm>
           <a:prstGeom prst="rect">
             <a:avLst/>
@@ -8806,7 +8806,7 @@
                 </a:solidFill>
                 <a:latin typeface="Arial"/>
               </a:rPr>
-              <a:t>The vortex-chain dark hole: before and after (color floor 10⁻¹⁴), convergence, and the sub-nanometer command maps.</a:t>
+              <a:t>The vortex-chain dark hole: before and after (color floor 10⁻¹⁴), convergence, and the command maps.</a:t>
             </a:r>
           </a:p>
         </p:txBody>
@@ -8827,8 +8827,8 @@
         </p:blipFill>
         <p:spPr>
           <a:xfrm>
-            <a:off x="8011995" y="2953182"/>
-            <a:ext cx="2172568" cy="1617472"/>
+            <a:off x="7086600" y="3136392"/>
+            <a:ext cx="3557016" cy="2642616"/>
           </a:xfrm>
           <a:prstGeom prst="rect">
             <a:avLst/>
@@ -8843,8 +8843,8 @@
         </p:nvSpPr>
         <p:spPr>
           <a:xfrm>
-            <a:off x="6400800" y="4588942"/>
-            <a:ext cx="5394960" cy="394208"/>
+            <a:off x="5742432" y="5769864"/>
+            <a:ext cx="6300216" cy="229107"/>
           </a:xfrm>
           <a:prstGeom prst="rect">
             <a:avLst/>
@@ -8882,8 +8882,8 @@
         </p:nvSpPr>
         <p:spPr>
           <a:xfrm>
-            <a:off x="6400800" y="5019726"/>
-            <a:ext cx="5394960" cy="274320"/>
+            <a:off x="5751576" y="5989320"/>
+            <a:ext cx="6300216" cy="274320"/>
           </a:xfrm>
           <a:prstGeom prst="rect">
             <a:avLst/>
@@ -9412,7 +9412,23 @@
                 </a:solidFill>
                 <a:latin typeface="Arial"/>
               </a:rPr>
-              <a:t>•  The testbed is where the models are built and proven; the same modeling then builds the flight-like system: an unobscured 6 m telescope from the design-layer templates — imaging leg and coronagraph leg, with the same DMs, apodizer, focal-plane mask and Lyot machinery — packaged to an 8 m launch shroud, drawn and checked.</a:t>
+              <a:t>•  The testbed is where the models are built and proven; the same modeling then builds the flight-like system: an unobscured 6 m telescope from the design-layer templates — imaging leg and coronagraph leg, with the same DMs, apodizer, focal-plane mask and Lyot machinery — the telescope packaged to an 8 m launch shroud.</a:t>
+            </a:r>
+          </a:p>
+          <a:p>
+            <a:pPr>
+              <a:spcAft>
+                <a:spcPts val="600"/>
+              </a:spcAft>
+            </a:pPr>
+            <a:r>
+              <a:rPr sz="1500" b="0">
+                <a:solidFill>
+                  <a:srgbClr val="282828"/>
+                </a:solidFill>
+                <a:latin typeface="Arial"/>
+              </a:rPr>
+              <a:t>•  The coronagraph bench still needs packaging work: the body-in-beam gate built for challenge 2, run on this train, finds the bench nicking the M1–M2 beam and the DM pocket's folded legs overlapping.  In the days ahead: the gate joins the template's standing checks; the bench clocks and drops out of the trunk beam by re-posing its pickoff fold — an optical null; the pocket's fold angles open with a small re-solve, priced in wavefront; the train re-verifies end to end.</a:t>
             </a:r>
           </a:p>
         </p:txBody>
@@ -9433,8 +9449,8 @@
         </p:blipFill>
         <p:spPr>
           <a:xfrm>
-            <a:off x="859353" y="2218182"/>
-            <a:ext cx="4910692" cy="3537712"/>
+            <a:off x="1684384" y="3348989"/>
+            <a:ext cx="3260631" cy="2348992"/>
           </a:xfrm>
           <a:prstGeom prst="rect">
             <a:avLst/>
@@ -9449,7 +9465,7 @@
         </p:nvSpPr>
         <p:spPr>
           <a:xfrm>
-            <a:off x="411480" y="5774181"/>
+            <a:off x="411480" y="5716269"/>
             <a:ext cx="5806440" cy="394208"/>
           </a:xfrm>
           <a:prstGeom prst="rect">
@@ -9480,9 +9496,48 @@
           </a:p>
         </p:txBody>
       </p:sp>
+      <p:sp>
+        <p:nvSpPr>
+          <p:cNvPr id="7" name="TextBox 6"/>
+          <p:cNvSpPr txBox="1"/>
+          <p:nvPr/>
+        </p:nvSpPr>
+        <p:spPr>
+          <a:xfrm>
+            <a:off x="411480" y="6147053"/>
+            <a:ext cx="5806440" cy="274320"/>
+          </a:xfrm>
+          <a:prstGeom prst="rect">
+            <a:avLst/>
+          </a:prstGeom>
+          <a:noFill/>
+        </p:spPr>
+        <p:txBody>
+          <a:bodyPr wrap="square">
+            <a:spAutoFit/>
+          </a:bodyPr>
+          <a:lstStyle/>
+          <a:p>
+            <a:pPr>
+              <a:spcAft>
+                <a:spcPts val="600"/>
+              </a:spcAft>
+            </a:pPr>
+            <a:r>
+              <a:rPr sz="1050" b="0">
+                <a:solidFill>
+                  <a:srgbClr val="6E6E6E"/>
+                </a:solidFill>
+                <a:latin typeface="Arial"/>
+              </a:rPr>
+              <a:t>The telescope is diffraction-limited at 500 nm (imaging-leg Strehl 0.9993).  Record: templates/80_end_to_end/e2e6m_r2.</a:t>
+            </a:r>
+          </a:p>
+        </p:txBody>
+      </p:sp>
       <p:pic>
         <p:nvPicPr>
-          <p:cNvPr id="7" name="Picture 6" descr="r1_seg_d110_shroud.png"/>
+          <p:cNvPr id="8" name="Picture 7" descr="r1_seg_d110_shroud.png"/>
           <p:cNvPicPr>
             <a:picLocks noChangeAspect="1"/>
           </p:cNvPicPr>
@@ -9496,8 +9551,8 @@
         </p:blipFill>
         <p:spPr>
           <a:xfrm>
-            <a:off x="7030679" y="2218182"/>
-            <a:ext cx="4135200" cy="2989072"/>
+            <a:off x="7410184" y="3348989"/>
+            <a:ext cx="3376190" cy="2440432"/>
           </a:xfrm>
           <a:prstGeom prst="rect">
             <a:avLst/>
@@ -9506,13 +9561,13 @@
       </p:pic>
       <p:sp>
         <p:nvSpPr>
-          <p:cNvPr id="8" name="TextBox 7"/>
+          <p:cNvPr id="9" name="TextBox 8"/>
           <p:cNvSpPr txBox="1"/>
           <p:nvPr/>
         </p:nvSpPr>
         <p:spPr>
           <a:xfrm>
-            <a:off x="6400800" y="5225542"/>
+            <a:off x="6400800" y="5807709"/>
             <a:ext cx="5394960" cy="394208"/>
           </a:xfrm>
           <a:prstGeom prst="rect">
@@ -9539,45 +9594,6 @@
                 <a:latin typeface="Arial"/>
               </a:rPr>
               <a:t>End-on in the shroud: the hex-19 telescope and instrument legs — hardware union 7.451 m against the 8.0 m gate.</a:t>
-            </a:r>
-          </a:p>
-        </p:txBody>
-      </p:sp>
-      <p:sp>
-        <p:nvSpPr>
-          <p:cNvPr id="9" name="TextBox 8"/>
-          <p:cNvSpPr txBox="1"/>
-          <p:nvPr/>
-        </p:nvSpPr>
-        <p:spPr>
-          <a:xfrm>
-            <a:off x="6400800" y="5656326"/>
-            <a:ext cx="5394960" cy="274320"/>
-          </a:xfrm>
-          <a:prstGeom prst="rect">
-            <a:avLst/>
-          </a:prstGeom>
-          <a:noFill/>
-        </p:spPr>
-        <p:txBody>
-          <a:bodyPr wrap="square">
-            <a:spAutoFit/>
-          </a:bodyPr>
-          <a:lstStyle/>
-          <a:p>
-            <a:pPr>
-              <a:spcAft>
-                <a:spcPts val="600"/>
-              </a:spcAft>
-            </a:pPr>
-            <a:r>
-              <a:rPr sz="1050" b="0">
-                <a:solidFill>
-                  <a:srgbClr val="6E6E6E"/>
-                </a:solidFill>
-                <a:latin typeface="Arial"/>
-              </a:rPr>
-              <a:t>The telescope is one of the design-layer templates, diffraction-limited at 500 nm (imaging-leg Strehl 0.9993); the two-leg light-order chart is in the record.  Record: templates/80_end_to_end/e2e6m_r2.</a:t>
             </a:r>
           </a:p>
         </p:txBody>

</xml_diff>

<commit_message>
demo_session: edit deck + baseline synced to the control-basis build (gate clean)
Co-Authored-By: Claude Fable 5 <noreply@anthropic.com>
</commit_message>
<xml_diff>
--- a/demo_session/baseline_pass3.pptx
+++ b/demo_session/baseline_pass3.pptx
@@ -40,6 +40,9 @@
     <p:sldId id="288" r:id="rId39"/>
     <p:sldId id="289" r:id="rId40"/>
     <p:sldId id="290" r:id="rId41"/>
+    <p:sldId id="291" r:id="rId42"/>
+    <p:sldId id="292" r:id="rId43"/>
+    <p:sldId id="293" r:id="rId44"/>
   </p:sldIdLst>
   <p:sldSz cx="12191695" cy="6858000" type="screen4x3"/>
   <p:notesSz cx="6858000" cy="9144000"/>
@@ -9768,6 +9771,22 @@
               <a:t>•  Metrology and edge sensors are designed ON that Jacobian — 114 beams from the launcher stations shown — and the same matrices drive the estimator and the closed loop.</a:t>
             </a:r>
           </a:p>
+          <a:p>
+            <a:pPr>
+              <a:spcAft>
+                <a:spcPts val="600"/>
+              </a:spcAft>
+            </a:pPr>
+            <a:r>
+              <a:rPr sz="1200" b="0">
+                <a:solidFill>
+                  <a:srgbClr val="282828"/>
+                </a:solidFill>
+                <a:latin typeface="Arial"/>
+              </a:rPr>
+              <a:t>•  The channels themselves — dw/dx, dw/dz, dw/dgrid — follow on the next three slides, at readable size.</a:t>
+            </a:r>
+          </a:p>
         </p:txBody>
       </p:sp>
       <p:pic>
@@ -9786,8 +9805,8 @@
         </p:blipFill>
         <p:spPr>
           <a:xfrm>
-            <a:off x="511032" y="2804160"/>
-            <a:ext cx="5607334" cy="3660140"/>
+            <a:off x="6400800" y="1298448"/>
+            <a:ext cx="5394960" cy="3521514"/>
           </a:xfrm>
           <a:prstGeom prst="rect">
             <a:avLst/>
@@ -9802,8 +9821,8 @@
         </p:nvSpPr>
         <p:spPr>
           <a:xfrm>
-            <a:off x="411480" y="6482588"/>
-            <a:ext cx="5806440" cy="229107"/>
+            <a:off x="6400800" y="4838250"/>
+            <a:ext cx="5394960" cy="394208"/>
           </a:xfrm>
           <a:prstGeom prst="rect">
             <a:avLst/>
@@ -9833,78 +9852,15 @@
           </a:p>
         </p:txBody>
       </p:sp>
-      <p:pic>
-        <p:nvPicPr>
-          <p:cNvPr id="7" name="Picture 6" descr="r3_dwdx_channels.png"/>
-          <p:cNvPicPr>
-            <a:picLocks noChangeAspect="1"/>
-          </p:cNvPicPr>
-          <p:nvPr/>
-        </p:nvPicPr>
-        <p:blipFill>
-          <a:blip r:embed="rId3"/>
-          <a:stretch>
-            <a:fillRect/>
-          </a:stretch>
-        </p:blipFill>
-        <p:spPr>
-          <a:xfrm>
-            <a:off x="6908717" y="1298448"/>
-            <a:ext cx="4379125" cy="4342892"/>
-          </a:xfrm>
-          <a:prstGeom prst="rect">
-            <a:avLst/>
-          </a:prstGeom>
-        </p:spPr>
-      </p:pic>
-      <p:sp>
-        <p:nvSpPr>
-          <p:cNvPr id="8" name="TextBox 7"/>
+      <p:sp>
+        <p:nvSpPr>
+          <p:cNvPr id="7" name="TextBox 6"/>
           <p:cNvSpPr txBox="1"/>
           <p:nvPr/>
         </p:nvSpPr>
         <p:spPr>
           <a:xfrm>
-            <a:off x="6400800" y="5659627"/>
-            <a:ext cx="5394960" cy="229107"/>
-          </a:xfrm>
-          <a:prstGeom prst="rect">
-            <a:avLst/>
-          </a:prstGeom>
-          <a:noFill/>
-        </p:spPr>
-        <p:txBody>
-          <a:bodyPr wrap="square">
-            <a:spAutoFit/>
-          </a:bodyPr>
-          <a:lstStyle/>
-          <a:p>
-            <a:pPr algn="ctr">
-              <a:spcAft>
-                <a:spcPts val="0"/>
-              </a:spcAft>
-            </a:pPr>
-            <a:r>
-              <a:rPr sz="1000" b="0">
-                <a:solidFill>
-                  <a:srgbClr val="6E6E6E"/>
-                </a:solidFill>
-                <a:latin typeface="Arial"/>
-              </a:rPr>
-              <a:t>Per-segment wavefront sensitivity channels — the control basis.</a:t>
-            </a:r>
-          </a:p>
-        </p:txBody>
-      </p:sp>
-      <p:sp>
-        <p:nvSpPr>
-          <p:cNvPr id="9" name="TextBox 8"/>
-          <p:cNvSpPr txBox="1"/>
-          <p:nvPr/>
-        </p:nvSpPr>
-        <p:spPr>
-          <a:xfrm>
-            <a:off x="6400800" y="5925312"/>
+            <a:off x="6400800" y="5269034"/>
             <a:ext cx="5394960" cy="274320"/>
           </a:xfrm>
           <a:prstGeom prst="rect">
@@ -9987,7 +9943,7 @@
                 </a:solidFill>
                 <a:latin typeface="Arial"/>
               </a:rPr>
-              <a:t>A randomly disturbed observatory, simulated</a:t>
+              <a:t>The control basis I: rigid-body channels — dw/dx</a:t>
             </a:r>
           </a:p>
           <a:p>
@@ -10003,7 +9959,7 @@
                 </a:solidFill>
                 <a:latin typeface="Arial"/>
               </a:rPr>
-              <a:t>The closed loop holds dark-zone contrast at 2.5×10⁻⁷ where the uncontrolled series drifts to 1.7×10⁻⁶</a:t>
+              <a:t>Runner: macos.dw_dx_multi, harvested by run_sensitivities (stage r3) — OPD at the coronagraph exit pupil per unit rigid-body motion</a:t>
             </a:r>
           </a:p>
         </p:txBody>
@@ -10052,80 +10008,9 @@
           </a:p>
         </p:txBody>
       </p:sp>
-      <p:sp>
-        <p:nvSpPr>
-          <p:cNvPr id="4" name="TextBox 3"/>
-          <p:cNvSpPr txBox="1"/>
-          <p:nvPr/>
-        </p:nvSpPr>
-        <p:spPr>
-          <a:xfrm>
-            <a:off x="411480" y="1298448"/>
-            <a:ext cx="5806440" cy="274320"/>
-          </a:xfrm>
-          <a:prstGeom prst="rect">
-            <a:avLst/>
-          </a:prstGeom>
-          <a:noFill/>
-        </p:spPr>
-        <p:txBody>
-          <a:bodyPr wrap="square">
-            <a:spAutoFit/>
-          </a:bodyPr>
-          <a:lstStyle/>
-          <a:p>
-            <a:pPr>
-              <a:spcAft>
-                <a:spcPts val="600"/>
-              </a:spcAft>
-            </a:pPr>
-            <a:r>
-              <a:rPr sz="1200" b="0">
-                <a:solidFill>
-                  <a:srgbClr val="282828"/>
-                </a:solidFill>
-                <a:latin typeface="Arial"/>
-              </a:rPr>
-              <a:t>•  Random segment drift is injected; the rigid-body loop senses through the designed metrology, estimates and corrects, while EFC re-solves the dark zone per scored frame — all on one model.</a:t>
-            </a:r>
-          </a:p>
-          <a:p>
-            <a:pPr>
-              <a:spcAft>
-                <a:spcPts val="600"/>
-              </a:spcAft>
-            </a:pPr>
-            <a:r>
-              <a:rPr sz="1200" b="0">
-                <a:solidFill>
-                  <a:srgbClr val="282828"/>
-                </a:solidFill>
-                <a:latin typeface="Arial"/>
-              </a:rPr>
-              <a:t>•  The disturbance interface is the point: the same channels are built to ingest dynamical- and thermal-model time histories — simulating performance in the space environment.  Work in progress.</a:t>
-            </a:r>
-          </a:p>
-          <a:p>
-            <a:pPr>
-              <a:spcAft>
-                <a:spcPts val="600"/>
-              </a:spcAft>
-            </a:pPr>
-            <a:r>
-              <a:rPr sz="1200" b="0">
-                <a:solidFill>
-                  <a:srgbClr val="282828"/>
-                </a:solidFill>
-                <a:latin typeface="Arial"/>
-              </a:rPr>
-              <a:t>•  Honest gap, attributed: the segmented-pupil contrast floor sits above the clear-pupil testbed's — the gaps and edges carry it, not the control.</a:t>
-            </a:r>
-          </a:p>
-        </p:txBody>
-      </p:sp>
       <p:pic>
         <p:nvPicPr>
-          <p:cNvPr id="5" name="Picture 4" descr="r4_series_3nm.png"/>
+          <p:cNvPr id="4" name="Picture 3" descr="fig_dwdx_read.png"/>
           <p:cNvPicPr>
             <a:picLocks noChangeAspect="1"/>
           </p:cNvPicPr>
@@ -10139,8 +10024,8 @@
         </p:blipFill>
         <p:spPr>
           <a:xfrm>
-            <a:off x="6923477" y="1298448"/>
-            <a:ext cx="4349605" cy="4177792"/>
+            <a:off x="637634" y="1298448"/>
+            <a:ext cx="10916426" cy="2897632"/>
           </a:xfrm>
           <a:prstGeom prst="rect">
             <a:avLst/>
@@ -10149,14 +10034,14 @@
       </p:pic>
       <p:sp>
         <p:nvSpPr>
-          <p:cNvPr id="6" name="TextBox 5"/>
+          <p:cNvPr id="5" name="TextBox 4"/>
           <p:cNvSpPr txBox="1"/>
           <p:nvPr/>
         </p:nvSpPr>
         <p:spPr>
           <a:xfrm>
-            <a:off x="6400800" y="5494528"/>
-            <a:ext cx="5394960" cy="394208"/>
+            <a:off x="411480" y="4214367"/>
+            <a:ext cx="11368735" cy="394208"/>
           </a:xfrm>
           <a:prstGeom prst="rect">
             <a:avLst/>
@@ -10181,21 +10066,21 @@
                 </a:solidFill>
                 <a:latin typeface="Arial"/>
               </a:rPr>
-              <a:t>Four hundred seconds under drift: segment rigid-body state, wavefront at the coronagraph exit pupil, and science-plane contrast — open loop against closed.</a:t>
-            </a:r>
-          </a:p>
-        </p:txBody>
-      </p:sp>
-      <p:sp>
-        <p:nvSpPr>
-          <p:cNvPr id="7" name="TextBox 6"/>
+              <a:t>Two of the 192 channels: the centre segment (E1) and an outer-ring segment (E8), x-rotation.  For each: the centre-field OPD at full size, then the same channel at all five fields — centre + the 4 corners of the field box.  Piston removed; 1–99% color scale.</a:t>
+            </a:r>
+          </a:p>
+        </p:txBody>
+      </p:sp>
+      <p:sp>
+        <p:nvSpPr>
+          <p:cNvPr id="6" name="TextBox 5"/>
           <p:cNvSpPr txBox="1"/>
           <p:nvPr/>
         </p:nvSpPr>
         <p:spPr>
           <a:xfrm>
-            <a:off x="6400800" y="5925312"/>
-            <a:ext cx="5394960" cy="274320"/>
+            <a:off x="411480" y="4645151"/>
+            <a:ext cx="11368735" cy="274320"/>
           </a:xfrm>
           <a:prstGeom prst="rect">
             <a:avLst/>
@@ -10214,13 +10099,52 @@
               </a:spcAft>
             </a:pPr>
             <a:r>
+              <a:rPr sz="1500" b="0">
+                <a:solidFill>
+                  <a:srgbClr val="282828"/>
+                </a:solidFill>
+                <a:latin typeface="Arial"/>
+              </a:rPr>
+              <a:t>•  192 channels: six rigid-body DOFs for every optic — the 19 segments, both DMs, the 8 OAPs — plus the whole primary as one rigid group, five fields each, stacked into the control Jacobian.  The response lives on the moved segment's footprint and walks with field.</a:t>
+            </a:r>
+          </a:p>
+        </p:txBody>
+      </p:sp>
+      <p:sp>
+        <p:nvSpPr>
+          <p:cNvPr id="7" name="TextBox 6"/>
+          <p:cNvSpPr txBox="1"/>
+          <p:nvPr/>
+        </p:nvSpPr>
+        <p:spPr>
+          <a:xfrm>
+            <a:off x="411480" y="5564885"/>
+            <a:ext cx="11368735" cy="274320"/>
+          </a:xfrm>
+          <a:prstGeom prst="rect">
+            <a:avLst/>
+          </a:prstGeom>
+          <a:noFill/>
+        </p:spPr>
+        <p:txBody>
+          <a:bodyPr wrap="square">
+            <a:spAutoFit/>
+          </a:bodyPr>
+          <a:lstStyle/>
+          <a:p>
+            <a:pPr>
+              <a:spcAft>
+                <a:spcPts val="600"/>
+              </a:spcAft>
+            </a:pPr>
+            <a:r>
               <a:rPr sz="1050" b="0">
                 <a:solidFill>
                   <a:srgbClr val="6E6E6E"/>
                 </a:solidFill>
                 <a:latin typeface="Arial"/>
               </a:rPr>
-              <a:t>Record: templates/80_end_to_end/e2e6m_r2, time-series stage.</a:t>
+              <a:t>Harvest on r1_seg_prop.in, the deck the simulator propagates; per-field FEX reset; closure gated by jacobian_check.  Record: templates/80_end_to_end/e2e6m_r2.</a:t>
             </a:r>
           </a:p>
         </p:txBody>
@@ -10277,7 +10201,7 @@
                 </a:solidFill>
                 <a:latin typeface="Arial"/>
               </a:rPr>
-              <a:t>The live design, revealed</a:t>
+              <a:t>The control basis II: segment-figure channels — dw/dz</a:t>
             </a:r>
           </a:p>
           <a:p>
@@ -10293,7 +10217,7 @@
                 </a:solidFill>
                 <a:latin typeface="Arial"/>
               </a:rPr>
-              <a:t>Predicted from the frontier before solving; solved in one warm-started step while we talked</a:t>
+              <a:t>Runner: macos.dw_dz_zernike_multi, harvested by run_sensitivities (stage r3) — MonZernike modes 4–11 on each segment</a:t>
             </a:r>
           </a:p>
         </p:txBody>
@@ -10342,80 +10266,9 @@
           </a:p>
         </p:txBody>
       </p:sp>
-      <p:sp>
-        <p:nvSpPr>
-          <p:cNvPr id="4" name="TextBox 3"/>
-          <p:cNvSpPr txBox="1"/>
-          <p:nvPr/>
-        </p:nvSpPr>
-        <p:spPr>
-          <a:xfrm>
-            <a:off x="411480" y="1298448"/>
-            <a:ext cx="5806440" cy="274320"/>
-          </a:xfrm>
-          <a:prstGeom prst="rect">
-            <a:avLst/>
-          </a:prstGeom>
-          <a:noFill/>
-        </p:spPr>
-        <p:txBody>
-          <a:bodyPr wrap="square">
-            <a:spAutoFit/>
-          </a:bodyPr>
-          <a:lstStyle/>
-          <a:p>
-            <a:pPr>
-              <a:spcAft>
-                <a:spcPts val="600"/>
-              </a:spcAft>
-            </a:pPr>
-            <a:r>
-              <a:rPr sz="1200" b="0">
-                <a:solidFill>
-                  <a:srgbClr val="282828"/>
-                </a:solidFill>
-                <a:latin typeface="Arial"/>
-              </a:rPr>
-              <a:t>•  The ask: a field-box width, anywhere in 5–15°.  The prediction, stated before the solve: interpolated from the committed frontier rows.</a:t>
-            </a:r>
-          </a:p>
-          <a:p>
-            <a:pPr>
-              <a:spcAft>
-                <a:spcPts val="600"/>
-              </a:spcAft>
-            </a:pPr>
-            <a:r>
-              <a:rPr sz="1200" b="0">
-                <a:solidFill>
-                  <a:srgbClr val="282828"/>
-                </a:solidFill>
-                <a:latin typeface="Arial"/>
-              </a:rPr>
-              <a:t>•  The pre-run rehearsal of the default ask (12°): predicted 33.7 nm; solved 33.6 nm — 1.00× — at a 24.9 mm clearance floor, both checks pass, in 15 minutes.</a:t>
-            </a:r>
-          </a:p>
-          <a:p>
-            <a:pPr>
-              <a:spcAft>
-                <a:spcPts val="600"/>
-              </a:spcAft>
-            </a:pPr>
-            <a:r>
-              <a:rPr sz="1200" b="0">
-                <a:solidFill>
-                  <a:srgbClr val="282828"/>
-                </a:solidFill>
-                <a:latin typeface="Arial"/>
-              </a:rPr>
-              <a:t>•  The run is deterministic to every printed digit, and every ask is a genuine continuation step — never a re-score of a stored design.</a:t>
-            </a:r>
-          </a:p>
-        </p:txBody>
-      </p:sp>
       <p:pic>
         <p:nvPicPr>
-          <p:cNvPr id="5" name="Picture 4" descr="oi_demo_12deg_layout.png"/>
+          <p:cNvPr id="4" name="Picture 3" descr="fig_dwdz_read.png"/>
           <p:cNvPicPr>
             <a:picLocks noChangeAspect="1"/>
           </p:cNvPicPr>
@@ -10429,8 +10282,8 @@
         </p:blipFill>
         <p:spPr>
           <a:xfrm>
-            <a:off x="8000103" y="1298448"/>
-            <a:ext cx="2196352" cy="1891792"/>
+            <a:off x="411480" y="1298448"/>
+            <a:ext cx="11368735" cy="3017691"/>
           </a:xfrm>
           <a:prstGeom prst="rect">
             <a:avLst/>
@@ -10439,14 +10292,14 @@
       </p:pic>
       <p:sp>
         <p:nvSpPr>
-          <p:cNvPr id="6" name="TextBox 5"/>
+          <p:cNvPr id="5" name="TextBox 4"/>
           <p:cNvSpPr txBox="1"/>
           <p:nvPr/>
         </p:nvSpPr>
         <p:spPr>
           <a:xfrm>
-            <a:off x="6400800" y="3208528"/>
-            <a:ext cx="5394960" cy="394208"/>
+            <a:off x="411480" y="4334427"/>
+            <a:ext cx="11368735" cy="229107"/>
           </a:xfrm>
           <a:prstGeom prst="rect">
             <a:avLst/>
@@ -10471,45 +10324,21 @@
                 </a:solidFill>
                 <a:latin typeface="Arial"/>
               </a:rPr>
-              <a:t>The 12° rehearsal design and its field map: 33.6 nm max against a 33.7 nm prediction.</a:t>
-            </a:r>
-          </a:p>
-        </p:txBody>
-      </p:sp>
-      <p:pic>
-        <p:nvPicPr>
-          <p:cNvPr id="7" name="Picture 6" descr="oi_demo_12deg_map.png"/>
-          <p:cNvPicPr>
-            <a:picLocks noChangeAspect="1"/>
-          </p:cNvPicPr>
-          <p:nvPr/>
-        </p:nvPicPr>
-        <p:blipFill>
-          <a:blip r:embed="rId3"/>
-          <a:stretch>
-            <a:fillRect/>
-          </a:stretch>
-        </p:blipFill>
-        <p:spPr>
-          <a:xfrm>
-            <a:off x="7951092" y="3639312"/>
-            <a:ext cx="2294375" cy="2011680"/>
-          </a:xfrm>
-          <a:prstGeom prst="rect">
-            <a:avLst/>
-          </a:prstGeom>
-        </p:spPr>
-      </p:pic>
-      <p:sp>
-        <p:nvSpPr>
-          <p:cNvPr id="8" name="TextBox 7"/>
+              <a:t>Two of the 152 channels: segments E1 and E8, MonZernike mode 4.  Centre-field OPD at full size, then all five fields.  Piston removed; 1–99% color scale.</a:t>
+            </a:r>
+          </a:p>
+        </p:txBody>
+      </p:sp>
+      <p:sp>
+        <p:nvSpPr>
+          <p:cNvPr id="6" name="TextBox 5"/>
           <p:cNvSpPr txBox="1"/>
           <p:nvPr/>
         </p:nvSpPr>
         <p:spPr>
           <a:xfrm>
-            <a:off x="6400800" y="5650992"/>
-            <a:ext cx="5394960" cy="274320"/>
+            <a:off x="411480" y="4600111"/>
+            <a:ext cx="11368735" cy="274320"/>
           </a:xfrm>
           <a:prstGeom prst="rect">
             <a:avLst/>
@@ -10528,13 +10357,52 @@
               </a:spcAft>
             </a:pPr>
             <a:r>
+              <a:rPr sz="1500" b="0">
+                <a:solidFill>
+                  <a:srgbClr val="282828"/>
+                </a:solidFill>
+                <a:latin typeface="Arial"/>
+              </a:rPr>
+              <a:t>•  152 channels: MonZernike figure modes 4–11 on each of the 19 segments — the low-order surface deformations a segment can carry — five fields each.  Each channel is confined to its own segment; the mode shape is visible at a glance.</a:t>
+            </a:r>
+          </a:p>
+        </p:txBody>
+      </p:sp>
+      <p:sp>
+        <p:nvSpPr>
+          <p:cNvPr id="7" name="TextBox 6"/>
+          <p:cNvSpPr txBox="1"/>
+          <p:nvPr/>
+        </p:nvSpPr>
+        <p:spPr>
+          <a:xfrm>
+            <a:off x="411480" y="5272195"/>
+            <a:ext cx="11368735" cy="274320"/>
+          </a:xfrm>
+          <a:prstGeom prst="rect">
+            <a:avLst/>
+          </a:prstGeom>
+          <a:noFill/>
+        </p:spPr>
+        <p:txBody>
+          <a:bodyPr wrap="square">
+            <a:spAutoFit/>
+          </a:bodyPr>
+          <a:lstStyle/>
+          <a:p>
+            <a:pPr>
+              <a:spcAft>
+                <a:spcPts val="600"/>
+              </a:spcAft>
+            </a:pPr>
+            <a:r>
               <a:rPr sz="1050" b="0">
                 <a:solidFill>
                   <a:srgbClr val="6E6E6E"/>
                 </a:solidFill>
                 <a:latin typeface="Arial"/>
               </a:rPr>
-              <a:t>On demo day the live run's figures replace these panels; this pre-generated bundle is the fallback if the room's ask matches nothing better.</a:t>
+              <a:t>Same harvest, metric and gates as dw/dx.  Record: templates/80_end_to_end/e2e6m_r2.</a:t>
             </a:r>
           </a:p>
         </p:txBody>
@@ -10591,7 +10459,7 @@
                 </a:solidFill>
                 <a:latin typeface="Arial"/>
               </a:rPr>
-              <a:t>AI in design and analysis — the working questions</a:t>
+              <a:t>The control basis III: segment-influence channels — dw/dgrid</a:t>
             </a:r>
           </a:p>
           <a:p>
@@ -10607,7 +10475,7 @@
                 </a:solidFill>
                 <a:latin typeface="Arial"/>
               </a:rPr>
-              <a:t>What we ask of an AI-driven study before believing it</a:t>
+              <a:t>Runner: macos.dw_dgrid_multi, harvested by run_sensitivities (stage r3) — the grid influence basis on each segment</a:t>
             </a:r>
           </a:p>
         </p:txBody>
@@ -10656,16 +10524,40 @@
           </a:p>
         </p:txBody>
       </p:sp>
-      <p:sp>
-        <p:nvSpPr>
-          <p:cNvPr id="4" name="TextBox 3"/>
+      <p:pic>
+        <p:nvPicPr>
+          <p:cNvPr id="4" name="Picture 3" descr="fig_dwdgrid_read.png"/>
+          <p:cNvPicPr>
+            <a:picLocks noChangeAspect="1"/>
+          </p:cNvPicPr>
+          <p:nvPr/>
+        </p:nvPicPr>
+        <p:blipFill>
+          <a:blip r:embed="rId2"/>
+          <a:stretch>
+            <a:fillRect/>
+          </a:stretch>
+        </p:blipFill>
+        <p:spPr>
+          <a:xfrm>
+            <a:off x="411480" y="1298448"/>
+            <a:ext cx="11368735" cy="3017691"/>
+          </a:xfrm>
+          <a:prstGeom prst="rect">
+            <a:avLst/>
+          </a:prstGeom>
+        </p:spPr>
+      </p:pic>
+      <p:sp>
+        <p:nvSpPr>
+          <p:cNvPr id="5" name="TextBox 4"/>
           <p:cNvSpPr txBox="1"/>
           <p:nvPr/>
         </p:nvSpPr>
         <p:spPr>
           <a:xfrm>
-            <a:off x="411480" y="1298448"/>
-            <a:ext cx="11368735" cy="274320"/>
+            <a:off x="411480" y="4334427"/>
+            <a:ext cx="11368735" cy="229107"/>
           </a:xfrm>
           <a:prstGeom prst="rect">
             <a:avLst/>
@@ -10678,64 +10570,32 @@
           </a:bodyPr>
           <a:lstStyle/>
           <a:p>
-            <a:pPr>
-              <a:spcAft>
-                <a:spcPts val="600"/>
-              </a:spcAft>
-            </a:pPr>
-            <a:r>
-              <a:rPr sz="1500" b="0">
-                <a:solidFill>
-                  <a:srgbClr val="282828"/>
-                </a:solidFill>
-                <a:latin typeface="Arial"/>
-              </a:rPr>
-              <a:t>•  How is a result verified when the designer is a machine?  Here: regression checks with negative controls, layout figures read against every claim, and corrected signed measures — the checks caught the errors shown today.</a:t>
-            </a:r>
-          </a:p>
-          <a:p>
-            <a:pPr>
-              <a:spcAft>
-                <a:spcPts val="600"/>
-              </a:spcAft>
-            </a:pPr>
-            <a:r>
-              <a:rPr sz="1500" b="0">
-                <a:solidFill>
-                  <a:srgbClr val="282828"/>
-                </a:solidFill>
-                <a:latin typeface="Arial"/>
-              </a:rPr>
-              <a:t>•  Where does the human rule?  Constraint choices, metric definitions, and every outward claim carry a human sign-off; the AI proposes, the record decides.</a:t>
-            </a:r>
-          </a:p>
-          <a:p>
-            <a:pPr>
-              <a:spcAft>
-                <a:spcPts val="600"/>
-              </a:spcAft>
-            </a:pPr>
-            <a:r>
-              <a:rPr sz="1500" b="0">
-                <a:solidFill>
-                  <a:srgbClr val="282828"/>
-                </a:solidFill>
-                <a:latin typeface="Arial"/>
-              </a:rPr>
-              <a:t>•  Is it reproducible?  Every number in this deck rebuilds from committed scripts and committed records — including the design solved during this talk.</a:t>
-            </a:r>
-          </a:p>
-        </p:txBody>
-      </p:sp>
-      <p:sp>
-        <p:nvSpPr>
-          <p:cNvPr id="5" name="TextBox 4"/>
+            <a:pPr algn="ctr">
+              <a:spcAft>
+                <a:spcPts val="0"/>
+              </a:spcAft>
+            </a:pPr>
+            <a:r>
+              <a:rPr sz="1000" b="0">
+                <a:solidFill>
+                  <a:srgbClr val="6E6E6E"/>
+                </a:solidFill>
+                <a:latin typeface="Arial"/>
+              </a:rPr>
+              <a:t>Two of the 114 channels: segments E1 and E8, grid mode 4.  Centre-field OPD at full size, then all five fields.  Piston removed; 1–99% color scale.</a:t>
+            </a:r>
+          </a:p>
+        </p:txBody>
+      </p:sp>
+      <p:sp>
+        <p:nvSpPr>
+          <p:cNvPr id="6" name="TextBox 5"/>
           <p:cNvSpPr txBox="1"/>
           <p:nvPr/>
         </p:nvSpPr>
         <p:spPr>
           <a:xfrm>
-            <a:off x="411480" y="3241547"/>
+            <a:off x="411480" y="4600111"/>
             <a:ext cx="11368735" cy="274320"/>
           </a:xfrm>
           <a:prstGeom prst="rect">
@@ -10755,13 +10615,52 @@
               </a:spcAft>
             </a:pPr>
             <a:r>
+              <a:rPr sz="1500" b="0">
+                <a:solidFill>
+                  <a:srgbClr val="282828"/>
+                </a:solidFill>
+                <a:latin typeface="Arial"/>
+              </a:rPr>
+              <a:t>•  114 channels: six grid-basis influence shapes per segment — the interface for measured influence functions and actuator maps, the same machinery the DM Jacobians use.  Together the three families stack into one Jacobian: the control basis the metrology, estimator and closed loop all share.</a:t>
+            </a:r>
+          </a:p>
+        </p:txBody>
+      </p:sp>
+      <p:sp>
+        <p:nvSpPr>
+          <p:cNvPr id="7" name="TextBox 6"/>
+          <p:cNvSpPr txBox="1"/>
+          <p:nvPr/>
+        </p:nvSpPr>
+        <p:spPr>
+          <a:xfrm>
+            <a:off x="411480" y="5519845"/>
+            <a:ext cx="11368735" cy="274320"/>
+          </a:xfrm>
+          <a:prstGeom prst="rect">
+            <a:avLst/>
+          </a:prstGeom>
+          <a:noFill/>
+        </p:spPr>
+        <p:txBody>
+          <a:bodyPr wrap="square">
+            <a:spAutoFit/>
+          </a:bodyPr>
+          <a:lstStyle/>
+          <a:p>
+            <a:pPr>
+              <a:spcAft>
+                <a:spcPts val="600"/>
+              </a:spcAft>
+            </a:pPr>
+            <a:r>
               <a:rPr sz="1050" b="0">
                 <a:solidFill>
                   <a:srgbClr val="6E6E6E"/>
                 </a:solidFill>
                 <a:latin typeface="Arial"/>
               </a:rPr>
-              <a:t>These are offered as discussion questions, not settled doctrine.</a:t>
+              <a:t>Same harvest, metric and gates as dw/dx.  Record: templates/80_end_to_end/e2e6m_r2.</a:t>
             </a:r>
           </a:p>
         </p:txBody>
@@ -10818,7 +10717,7 @@
                 </a:solidFill>
                 <a:latin typeface="Arial"/>
               </a:rPr>
-              <a:t>Summary</a:t>
+              <a:t>A randomly disturbed observatory, simulated</a:t>
             </a:r>
           </a:p>
           <a:p>
@@ -10834,7 +10733,7 @@
                 </a:solidFill>
                 <a:latin typeface="Arial"/>
               </a:rPr>
-              <a:t>One engine, validated; a toolbox that designs; an AI that drives it — all public</a:t>
+              <a:t>The closed loop holds dark-zone contrast at 2.5×10⁻⁷ where the uncontrolled series drifts to 1.7×10⁻⁶</a:t>
             </a:r>
           </a:p>
         </p:txBody>
@@ -10892,7 +10791,7 @@
         <p:spPr>
           <a:xfrm>
             <a:off x="411480" y="1298448"/>
-            <a:ext cx="11368735" cy="274320"/>
+            <a:ext cx="5806440" cy="274320"/>
           </a:xfrm>
           <a:prstGeom prst="rect">
             <a:avLst/>
@@ -10911,13 +10810,13 @@
               </a:spcAft>
             </a:pPr>
             <a:r>
-              <a:rPr sz="1500" b="0">
+              <a:rPr sz="1200" b="0">
                 <a:solidFill>
                   <a:srgbClr val="282828"/>
                 </a:solidFill>
                 <a:latin typeface="Arial"/>
               </a:rPr>
-              <a:t>•  One validated engine behind four language surfaces; a MATLAB design layer that took three CODE V benchmark studies from reproduction to extension.</a:t>
+              <a:t>•  Random segment drift is injected; the rigid-body loop senses through the designed metrology, estimates and corrects, while EFC re-solves the dark zone per scored frame — all on one model.</a:t>
             </a:r>
           </a:p>
           <a:p>
@@ -10927,13 +10826,13 @@
               </a:spcAft>
             </a:pPr>
             <a:r>
-              <a:rPr sz="1500" b="0">
+              <a:rPr sz="1200" b="0">
                 <a:solidFill>
                   <a:srgbClr val="282828"/>
                 </a:solidFill>
                 <a:latin typeface="Arial"/>
               </a:rPr>
-              <a:t>•  Two things happened live: a telescope designed to the audience's field specification in one warm-started step, and a polarization interferometer measuring a deformable mirror to 0.18 nm.</a:t>
+              <a:t>•  The disturbance interface is the point: the same channels are built to ingest dynamical- and thermal-model time histories — simulating performance in the space environment.  Work in progress.</a:t>
             </a:r>
           </a:p>
           <a:p>
@@ -10943,27 +10842,51 @@
               </a:spcAft>
             </a:pPr>
             <a:r>
-              <a:rPr sz="1500" b="0">
+              <a:rPr sz="1200" b="0">
                 <a:solidFill>
                   <a:srgbClr val="282828"/>
                 </a:solidFill>
                 <a:latin typeface="Arial"/>
               </a:rPr>
-              <a:t>•  The code is public: github.com/nasa-jpl/macos.</a:t>
-            </a:r>
-          </a:p>
-        </p:txBody>
-      </p:sp>
-      <p:sp>
-        <p:nvSpPr>
-          <p:cNvPr id="5" name="TextBox 4"/>
+              <a:t>•  Honest gap, attributed: the segmented-pupil contrast floor sits above the clear-pupil testbed's — the gaps and edges carry it, not the control.</a:t>
+            </a:r>
+          </a:p>
+        </p:txBody>
+      </p:sp>
+      <p:pic>
+        <p:nvPicPr>
+          <p:cNvPr id="5" name="Picture 4" descr="r4_series_3nm.png"/>
+          <p:cNvPicPr>
+            <a:picLocks noChangeAspect="1"/>
+          </p:cNvPicPr>
+          <p:nvPr/>
+        </p:nvPicPr>
+        <p:blipFill>
+          <a:blip r:embed="rId2"/>
+          <a:stretch>
+            <a:fillRect/>
+          </a:stretch>
+        </p:blipFill>
+        <p:spPr>
+          <a:xfrm>
+            <a:off x="6923477" y="1298448"/>
+            <a:ext cx="4349605" cy="4177792"/>
+          </a:xfrm>
+          <a:prstGeom prst="rect">
+            <a:avLst/>
+          </a:prstGeom>
+        </p:spPr>
+      </p:pic>
+      <p:sp>
+        <p:nvSpPr>
+          <p:cNvPr id="6" name="TextBox 5"/>
           <p:cNvSpPr txBox="1"/>
           <p:nvPr/>
         </p:nvSpPr>
         <p:spPr>
           <a:xfrm>
-            <a:off x="411480" y="2993898"/>
-            <a:ext cx="11368735" cy="274320"/>
+            <a:off x="6400800" y="5494528"/>
+            <a:ext cx="5394960" cy="394208"/>
           </a:xfrm>
           <a:prstGeom prst="rect">
             <a:avLst/>
@@ -10976,6 +10899,45 @@
           </a:bodyPr>
           <a:lstStyle/>
           <a:p>
+            <a:pPr algn="ctr">
+              <a:spcAft>
+                <a:spcPts val="0"/>
+              </a:spcAft>
+            </a:pPr>
+            <a:r>
+              <a:rPr sz="1000" b="0">
+                <a:solidFill>
+                  <a:srgbClr val="6E6E6E"/>
+                </a:solidFill>
+                <a:latin typeface="Arial"/>
+              </a:rPr>
+              <a:t>Four hundred seconds under drift: segment rigid-body state, wavefront at the coronagraph exit pupil, and science-plane contrast — open loop against closed.</a:t>
+            </a:r>
+          </a:p>
+        </p:txBody>
+      </p:sp>
+      <p:sp>
+        <p:nvSpPr>
+          <p:cNvPr id="7" name="TextBox 6"/>
+          <p:cNvSpPr txBox="1"/>
+          <p:nvPr/>
+        </p:nvSpPr>
+        <p:spPr>
+          <a:xfrm>
+            <a:off x="6400800" y="5925312"/>
+            <a:ext cx="5394960" cy="274320"/>
+          </a:xfrm>
+          <a:prstGeom prst="rect">
+            <a:avLst/>
+          </a:prstGeom>
+          <a:noFill/>
+        </p:spPr>
+        <p:txBody>
+          <a:bodyPr wrap="square">
+            <a:spAutoFit/>
+          </a:bodyPr>
+          <a:lstStyle/>
+          <a:p>
             <a:pPr>
               <a:spcAft>
                 <a:spcPts val="600"/>
@@ -10988,7 +10950,7 @@
                 </a:solidFill>
                 <a:latin typeface="Arial"/>
               </a:rPr>
-              <a:t>Contact and records: all studies cited are committed with packets and regression checks.</a:t>
+              <a:t>Record: templates/80_end_to_end/e2e6m_r2, time-series stage.</a:t>
             </a:r>
           </a:p>
         </p:txBody>
@@ -11045,7 +11007,23 @@
                 </a:solidFill>
                 <a:latin typeface="Arial"/>
               </a:rPr>
-              <a:t>Backup Slides</a:t>
+              <a:t>The live design, revealed</a:t>
+            </a:r>
+          </a:p>
+          <a:p>
+            <a:pPr>
+              <a:spcAft>
+                <a:spcPts val="0"/>
+              </a:spcAft>
+            </a:pPr>
+            <a:r>
+              <a:rPr sz="1250" b="0">
+                <a:solidFill>
+                  <a:srgbClr val="6E6E6E"/>
+                </a:solidFill>
+                <a:latin typeface="Arial"/>
+              </a:rPr>
+              <a:t>Predicted from the frontier before solving; solved in one warm-started step while we talked</a:t>
             </a:r>
           </a:p>
         </p:txBody>
@@ -11058,7 +11036,7 @@
         </p:nvSpPr>
         <p:spPr>
           <a:xfrm>
-            <a:off x="411480" y="914400"/>
+            <a:off x="411480" y="1133856"/>
             <a:ext cx="11368735" cy="20320"/>
           </a:xfrm>
           <a:prstGeom prst="rect">
@@ -11091,6 +11069,203 @@
           <a:lstStyle/>
           <a:p>
             <a:pPr algn="ctr"/>
+          </a:p>
+        </p:txBody>
+      </p:sp>
+      <p:sp>
+        <p:nvSpPr>
+          <p:cNvPr id="4" name="TextBox 3"/>
+          <p:cNvSpPr txBox="1"/>
+          <p:nvPr/>
+        </p:nvSpPr>
+        <p:spPr>
+          <a:xfrm>
+            <a:off x="411480" y="1298448"/>
+            <a:ext cx="5806440" cy="274320"/>
+          </a:xfrm>
+          <a:prstGeom prst="rect">
+            <a:avLst/>
+          </a:prstGeom>
+          <a:noFill/>
+        </p:spPr>
+        <p:txBody>
+          <a:bodyPr wrap="square">
+            <a:spAutoFit/>
+          </a:bodyPr>
+          <a:lstStyle/>
+          <a:p>
+            <a:pPr>
+              <a:spcAft>
+                <a:spcPts val="600"/>
+              </a:spcAft>
+            </a:pPr>
+            <a:r>
+              <a:rPr sz="1200" b="0">
+                <a:solidFill>
+                  <a:srgbClr val="282828"/>
+                </a:solidFill>
+                <a:latin typeface="Arial"/>
+              </a:rPr>
+              <a:t>•  The ask: a field-box width, anywhere in 5–15°.  The prediction, stated before the solve: interpolated from the committed frontier rows.</a:t>
+            </a:r>
+          </a:p>
+          <a:p>
+            <a:pPr>
+              <a:spcAft>
+                <a:spcPts val="600"/>
+              </a:spcAft>
+            </a:pPr>
+            <a:r>
+              <a:rPr sz="1200" b="0">
+                <a:solidFill>
+                  <a:srgbClr val="282828"/>
+                </a:solidFill>
+                <a:latin typeface="Arial"/>
+              </a:rPr>
+              <a:t>•  The pre-run rehearsal of the default ask (12°): predicted 33.7 nm; solved 33.6 nm — 1.00× — at a 24.9 mm clearance floor, both checks pass, in 15 minutes.</a:t>
+            </a:r>
+          </a:p>
+          <a:p>
+            <a:pPr>
+              <a:spcAft>
+                <a:spcPts val="600"/>
+              </a:spcAft>
+            </a:pPr>
+            <a:r>
+              <a:rPr sz="1200" b="0">
+                <a:solidFill>
+                  <a:srgbClr val="282828"/>
+                </a:solidFill>
+                <a:latin typeface="Arial"/>
+              </a:rPr>
+              <a:t>•  The run is deterministic to every printed digit, and every ask is a genuine continuation step — never a re-score of a stored design.</a:t>
+            </a:r>
+          </a:p>
+        </p:txBody>
+      </p:sp>
+      <p:pic>
+        <p:nvPicPr>
+          <p:cNvPr id="5" name="Picture 4" descr="oi_demo_12deg_layout.png"/>
+          <p:cNvPicPr>
+            <a:picLocks noChangeAspect="1"/>
+          </p:cNvPicPr>
+          <p:nvPr/>
+        </p:nvPicPr>
+        <p:blipFill>
+          <a:blip r:embed="rId2"/>
+          <a:stretch>
+            <a:fillRect/>
+          </a:stretch>
+        </p:blipFill>
+        <p:spPr>
+          <a:xfrm>
+            <a:off x="8000103" y="1298448"/>
+            <a:ext cx="2196352" cy="1891792"/>
+          </a:xfrm>
+          <a:prstGeom prst="rect">
+            <a:avLst/>
+          </a:prstGeom>
+        </p:spPr>
+      </p:pic>
+      <p:sp>
+        <p:nvSpPr>
+          <p:cNvPr id="6" name="TextBox 5"/>
+          <p:cNvSpPr txBox="1"/>
+          <p:nvPr/>
+        </p:nvSpPr>
+        <p:spPr>
+          <a:xfrm>
+            <a:off x="6400800" y="3208528"/>
+            <a:ext cx="5394960" cy="394208"/>
+          </a:xfrm>
+          <a:prstGeom prst="rect">
+            <a:avLst/>
+          </a:prstGeom>
+          <a:noFill/>
+        </p:spPr>
+        <p:txBody>
+          <a:bodyPr wrap="square">
+            <a:spAutoFit/>
+          </a:bodyPr>
+          <a:lstStyle/>
+          <a:p>
+            <a:pPr algn="ctr">
+              <a:spcAft>
+                <a:spcPts val="0"/>
+              </a:spcAft>
+            </a:pPr>
+            <a:r>
+              <a:rPr sz="1000" b="0">
+                <a:solidFill>
+                  <a:srgbClr val="6E6E6E"/>
+                </a:solidFill>
+                <a:latin typeface="Arial"/>
+              </a:rPr>
+              <a:t>The 12° rehearsal design and its field map: 33.6 nm max against a 33.7 nm prediction.</a:t>
+            </a:r>
+          </a:p>
+        </p:txBody>
+      </p:sp>
+      <p:pic>
+        <p:nvPicPr>
+          <p:cNvPr id="7" name="Picture 6" descr="oi_demo_12deg_map.png"/>
+          <p:cNvPicPr>
+            <a:picLocks noChangeAspect="1"/>
+          </p:cNvPicPr>
+          <p:nvPr/>
+        </p:nvPicPr>
+        <p:blipFill>
+          <a:blip r:embed="rId3"/>
+          <a:stretch>
+            <a:fillRect/>
+          </a:stretch>
+        </p:blipFill>
+        <p:spPr>
+          <a:xfrm>
+            <a:off x="7951092" y="3639312"/>
+            <a:ext cx="2294375" cy="2011680"/>
+          </a:xfrm>
+          <a:prstGeom prst="rect">
+            <a:avLst/>
+          </a:prstGeom>
+        </p:spPr>
+      </p:pic>
+      <p:sp>
+        <p:nvSpPr>
+          <p:cNvPr id="8" name="TextBox 7"/>
+          <p:cNvSpPr txBox="1"/>
+          <p:nvPr/>
+        </p:nvSpPr>
+        <p:spPr>
+          <a:xfrm>
+            <a:off x="6400800" y="5650992"/>
+            <a:ext cx="5394960" cy="274320"/>
+          </a:xfrm>
+          <a:prstGeom prst="rect">
+            <a:avLst/>
+          </a:prstGeom>
+          <a:noFill/>
+        </p:spPr>
+        <p:txBody>
+          <a:bodyPr wrap="square">
+            <a:spAutoFit/>
+          </a:bodyPr>
+          <a:lstStyle/>
+          <a:p>
+            <a:pPr>
+              <a:spcAft>
+                <a:spcPts val="600"/>
+              </a:spcAft>
+            </a:pPr>
+            <a:r>
+              <a:rPr sz="1050" b="0">
+                <a:solidFill>
+                  <a:srgbClr val="6E6E6E"/>
+                </a:solidFill>
+                <a:latin typeface="Arial"/>
+              </a:rPr>
+              <a:t>On demo day the live run's figures replace these panels; this pre-generated bundle is the fallback if the room's ask matches nothing better.</a:t>
+            </a:r>
           </a:p>
         </p:txBody>
       </p:sp>
@@ -11146,7 +11321,7 @@
                 </a:solidFill>
                 <a:latin typeface="Arial"/>
               </a:rPr>
-              <a:t>What MACOS does today</a:t>
+              <a:t>AI in design and analysis — the working questions</a:t>
             </a:r>
           </a:p>
           <a:p>
@@ -11162,7 +11337,7 @@
                 </a:solidFill>
                 <a:latin typeface="Arial"/>
               </a:rPr>
-              <a:t>System-level modeling from design through control</a:t>
+              <a:t>What we ask of an AI-driven study before believing it</a:t>
             </a:r>
           </a:p>
         </p:txBody>
@@ -11245,7 +11420,7 @@
                 </a:solidFill>
                 <a:latin typeface="Arial"/>
               </a:rPr>
-              <a:t>•  Applications: error budgeting, integrated observatory simulation, wavefront sensing and control for segmented telescopes, coronagraph testbeds and instruments.</a:t>
+              <a:t>•  How is a result verified when the designer is a machine?  Here: regression checks with negative controls, layout figures read against every claim, and corrected signed measures — the checks caught the errors shown today.</a:t>
             </a:r>
           </a:p>
           <a:p>
@@ -11261,7 +11436,7 @@
                 </a:solidFill>
                 <a:latin typeface="Arial"/>
               </a:rPr>
-              <a:t>•  The linear-model workflow: w = J·x + w₀ — wavefront sensitivity channels per element, per segment, per surface mode; stacked over fields and configurations; element groups move as one.</a:t>
+              <a:t>•  Where does the human rule?  Constraint choices, metric definitions, and every outward claim carry a human sign-off; the AI proposes, the record decides.</a:t>
             </a:r>
           </a:p>
           <a:p>
@@ -11277,7 +11452,7 @@
                 </a:solidFill>
                 <a:latin typeface="Arial"/>
               </a:rPr>
-              <a:t>•  From model to control: the same sensitivity matrices drive metrology design, estimator synthesis, and closed-loop simulation — one model, one bookkeeping, design to control.</a:t>
+              <a:t>•  Is it reproducible?  Every number in this deck rebuilds from committed scripts and committed records — including the design solved during this talk.</a:t>
             </a:r>
           </a:p>
         </p:txBody>
@@ -11316,7 +11491,7 @@
                 </a:solidFill>
                 <a:latin typeface="Arial"/>
               </a:rPr>
-              <a:t>Every capability shown today is in the committed test suites; validation anchors: next slide.</a:t>
+              <a:t>These are offered as discussion questions, not settled doctrine.</a:t>
             </a:r>
           </a:p>
         </p:txBody>
@@ -11373,7 +11548,7 @@
                 </a:solidFill>
                 <a:latin typeface="Arial"/>
               </a:rPr>
-              <a:t>The MATLAB toolbox and the design layer</a:t>
+              <a:t>Summary</a:t>
             </a:r>
           </a:p>
           <a:p>
@@ -11389,7 +11564,7 @@
                 </a:solidFill>
                 <a:latin typeface="Arial"/>
               </a:rPr>
-              <a:t>Design → segmentation → sensitivities → metrology → simulation, each one call — fully public-domain</a:t>
+              <a:t>One engine, validated; a toolbox that designs; an AI that drives it — all public</a:t>
             </a:r>
           </a:p>
         </p:txBody>
@@ -11447,7 +11622,7 @@
         <p:spPr>
           <a:xfrm>
             <a:off x="411480" y="1298448"/>
-            <a:ext cx="5806440" cy="274320"/>
+            <a:ext cx="11368735" cy="274320"/>
           </a:xfrm>
           <a:prstGeom prst="rect">
             <a:avLst/>
@@ -11466,13 +11641,13 @@
               </a:spcAft>
             </a:pPr>
             <a:r>
-              <a:rPr sz="1200" b="0">
+              <a:rPr sz="1500" b="0">
                 <a:solidFill>
                   <a:srgbClr val="282828"/>
                 </a:solidFill>
                 <a:latin typeface="Arial"/>
               </a:rPr>
-              <a:t>•  Drivers: telescope/bench design builders, sensitivity supervisors (rigid-body, alignment, surface-grid), metrology placement, model-vs-model comparison, closed-loop simulators, study orchestrators.</a:t>
+              <a:t>•  One validated engine behind four language surfaces; a MATLAB design layer that took three CODE V benchmark studies from reproduction to extension.</a:t>
             </a:r>
           </a:p>
           <a:p>
@@ -11482,13 +11657,29 @@
               </a:spcAft>
             </a:pPr>
             <a:r>
-              <a:rPr sz="1200" b="0">
+              <a:rPr sz="1500" b="0">
                 <a:solidFill>
                   <a:srgbClr val="282828"/>
                 </a:solidFill>
                 <a:latin typeface="Arial"/>
               </a:rPr>
-              <a:t>•  One-call reconstructible studies: every figure in this deck rebuilds from a committed script and committed records.</a:t>
+              <a:t>•  Two things happened live: a telescope designed to the audience's field specification in one warm-started step, and a polarization interferometer measuring a deformable mirror to 0.18 nm.</a:t>
+            </a:r>
+          </a:p>
+          <a:p>
+            <a:pPr>
+              <a:spcAft>
+                <a:spcPts val="600"/>
+              </a:spcAft>
+            </a:pPr>
+            <a:r>
+              <a:rPr sz="1500" b="0">
+                <a:solidFill>
+                  <a:srgbClr val="282828"/>
+                </a:solidFill>
+                <a:latin typeface="Arial"/>
+              </a:rPr>
+              <a:t>•  The code is public: github.com/nasa-jpl/macos.</a:t>
             </a:r>
           </a:p>
         </p:txBody>
@@ -11501,8 +11692,8 @@
         </p:nvSpPr>
         <p:spPr>
           <a:xfrm>
-            <a:off x="6400800" y="1298448"/>
-            <a:ext cx="5394960" cy="274320"/>
+            <a:off x="411480" y="2993898"/>
+            <a:ext cx="11368735" cy="274320"/>
           </a:xfrm>
           <a:prstGeom prst="rect">
             <a:avLst/>
@@ -11521,68 +11712,13 @@
               </a:spcAft>
             </a:pPr>
             <a:r>
-              <a:rPr sz="1200" b="0">
-                <a:solidFill>
-                  <a:srgbClr val="282828"/>
-                </a:solidFill>
-                <a:latin typeface="Arial"/>
-              </a:rPr>
-              <a:t>•  Utilities: trace, wavefront, perturb, pupil find; layout and ray-bundle viewers; Jones pupils, polarization elements; segment grid bases and grid file IO; multi-wavelength composition; spot, intensity, complex field.</a:t>
-            </a:r>
-          </a:p>
-          <a:p>
-            <a:pPr>
-              <a:spcAft>
-                <a:spcPts val="600"/>
-              </a:spcAft>
-            </a:pPr>
-            <a:r>
-              <a:rPr sz="1200" b="0">
-                <a:solidFill>
-                  <a:srgbClr val="282828"/>
-                </a:solidFill>
-                <a:latin typeface="Arial"/>
-              </a:rPr>
-              <a:t>•  Why a design layer: the whole stack is public-domain — a design study needs no proprietary prescription to start from.</a:t>
-            </a:r>
-          </a:p>
-        </p:txBody>
-      </p:sp>
-      <p:sp>
-        <p:nvSpPr>
-          <p:cNvPr id="6" name="TextBox 5"/>
-          <p:cNvSpPr txBox="1"/>
-          <p:nvPr/>
-        </p:nvSpPr>
-        <p:spPr>
-          <a:xfrm>
-            <a:off x="6400800" y="2804160"/>
-            <a:ext cx="5394960" cy="274320"/>
-          </a:xfrm>
-          <a:prstGeom prst="rect">
-            <a:avLst/>
-          </a:prstGeom>
-          <a:noFill/>
-        </p:spPr>
-        <p:txBody>
-          <a:bodyPr wrap="square">
-            <a:spAutoFit/>
-          </a:bodyPr>
-          <a:lstStyle/>
-          <a:p>
-            <a:pPr>
-              <a:spcAft>
-                <a:spcPts val="600"/>
-              </a:spcAft>
-            </a:pPr>
-            <a:r>
               <a:rPr sz="1050" b="0">
                 <a:solidFill>
                   <a:srgbClr val="6E6E6E"/>
                 </a:solidFill>
                 <a:latin typeface="Arial"/>
               </a:rPr>
-              <a:t>The two live demonstrations exercised exactly these layers: the bench builder and a design-family driver.</a:t>
+              <a:t>Contact and records: all studies cited are committed with packets and regression checks.</a:t>
             </a:r>
           </a:p>
         </p:txBody>
@@ -11596,6 +11732,844 @@
 </file>
 
 <file path=ppt/slides/slide29.xml><?xml version="1.0" encoding="utf-8"?>
+<p:sld xmlns:a="http://schemas.openxmlformats.org/drawingml/2006/main" xmlns:p="http://schemas.openxmlformats.org/presentationml/2006/main" xmlns:r="http://schemas.openxmlformats.org/officeDocument/2006/relationships">
+  <p:cSld>
+    <p:spTree>
+      <p:nvGrpSpPr>
+        <p:cNvPr id="1" name=""/>
+        <p:cNvGrpSpPr/>
+        <p:nvPr/>
+      </p:nvGrpSpPr>
+      <p:grpSpPr/>
+      <p:sp>
+        <p:nvSpPr>
+          <p:cNvPr id="2" name="TextBox 1"/>
+          <p:cNvSpPr txBox="1"/>
+          <p:nvPr/>
+        </p:nvSpPr>
+        <p:spPr>
+          <a:xfrm>
+            <a:off x="411480" y="201168"/>
+            <a:ext cx="11368735" cy="914400"/>
+          </a:xfrm>
+          <a:prstGeom prst="rect">
+            <a:avLst/>
+          </a:prstGeom>
+          <a:noFill/>
+        </p:spPr>
+        <p:txBody>
+          <a:bodyPr wrap="square">
+            <a:spAutoFit/>
+          </a:bodyPr>
+          <a:lstStyle/>
+          <a:p>
+            <a:pPr>
+              <a:spcAft>
+                <a:spcPts val="400"/>
+              </a:spcAft>
+            </a:pPr>
+            <a:r>
+              <a:rPr sz="2400" b="1">
+                <a:solidFill>
+                  <a:srgbClr val="1F4E79"/>
+                </a:solidFill>
+                <a:latin typeface="Arial"/>
+              </a:rPr>
+              <a:t>Backup Slides</a:t>
+            </a:r>
+          </a:p>
+        </p:txBody>
+      </p:sp>
+      <p:sp>
+        <p:nvSpPr>
+          <p:cNvPr id="3" name="Rectangle 2"/>
+          <p:cNvSpPr/>
+          <p:nvPr/>
+        </p:nvSpPr>
+        <p:spPr>
+          <a:xfrm>
+            <a:off x="411480" y="914400"/>
+            <a:ext cx="11368735" cy="20320"/>
+          </a:xfrm>
+          <a:prstGeom prst="rect">
+            <a:avLst/>
+          </a:prstGeom>
+          <a:solidFill>
+            <a:srgbClr val="B8C6D4"/>
+          </a:solidFill>
+          <a:ln>
+            <a:noFill/>
+          </a:ln>
+          <a:effectLst/>
+        </p:spPr>
+        <p:style>
+          <a:lnRef idx="1">
+            <a:schemeClr val="accent1"/>
+          </a:lnRef>
+          <a:fillRef idx="3">
+            <a:schemeClr val="accent1"/>
+          </a:fillRef>
+          <a:effectRef idx="2">
+            <a:schemeClr val="accent1"/>
+          </a:effectRef>
+          <a:fontRef idx="minor">
+            <a:schemeClr val="lt1"/>
+          </a:fontRef>
+        </p:style>
+        <p:txBody>
+          <a:bodyPr rtlCol="0" anchor="ctr"/>
+          <a:lstStyle/>
+          <a:p>
+            <a:pPr algn="ctr"/>
+          </a:p>
+        </p:txBody>
+      </p:sp>
+    </p:spTree>
+  </p:cSld>
+  <p:clrMapOvr>
+    <a:masterClrMapping/>
+  </p:clrMapOvr>
+</p:sld>
+</file>
+
+<file path=ppt/slides/slide3.xml><?xml version="1.0" encoding="utf-8"?>
+<p:sld xmlns:a="http://schemas.openxmlformats.org/drawingml/2006/main" xmlns:p="http://schemas.openxmlformats.org/presentationml/2006/main" xmlns:r="http://schemas.openxmlformats.org/officeDocument/2006/relationships">
+  <p:cSld>
+    <p:spTree>
+      <p:nvGrpSpPr>
+        <p:cNvPr id="1" name=""/>
+        <p:cNvGrpSpPr/>
+        <p:nvPr/>
+      </p:nvGrpSpPr>
+      <p:grpSpPr/>
+      <p:sp>
+        <p:nvSpPr>
+          <p:cNvPr id="2" name="TextBox 1"/>
+          <p:cNvSpPr txBox="1"/>
+          <p:nvPr/>
+        </p:nvSpPr>
+        <p:spPr>
+          <a:xfrm>
+            <a:off x="411480" y="201168"/>
+            <a:ext cx="11368735" cy="914400"/>
+          </a:xfrm>
+          <a:prstGeom prst="rect">
+            <a:avLst/>
+          </a:prstGeom>
+          <a:noFill/>
+        </p:spPr>
+        <p:txBody>
+          <a:bodyPr wrap="square">
+            <a:spAutoFit/>
+          </a:bodyPr>
+          <a:lstStyle/>
+          <a:p>
+            <a:pPr>
+              <a:spcAft>
+                <a:spcPts val="400"/>
+              </a:spcAft>
+            </a:pPr>
+            <a:r>
+              <a:rPr sz="2400" b="1">
+                <a:solidFill>
+                  <a:srgbClr val="1F4E79"/>
+                </a:solidFill>
+                <a:latin typeface="Arial"/>
+              </a:rPr>
+              <a:t>One engine, four surfaces</a:t>
+            </a:r>
+          </a:p>
+          <a:p>
+            <a:pPr>
+              <a:spcAft>
+                <a:spcPts val="0"/>
+              </a:spcAft>
+            </a:pPr>
+            <a:r>
+              <a:rPr sz="1250" b="0">
+                <a:solidFill>
+                  <a:srgbClr val="6E6E6E"/>
+                </a:solidFill>
+                <a:latin typeface="Arial"/>
+              </a:rPr>
+              <a:t>The same Fortran core answers a terminal, a library call, MATLAB, and Python</a:t>
+            </a:r>
+          </a:p>
+        </p:txBody>
+      </p:sp>
+      <p:sp>
+        <p:nvSpPr>
+          <p:cNvPr id="3" name="Rectangle 2"/>
+          <p:cNvSpPr/>
+          <p:nvPr/>
+        </p:nvSpPr>
+        <p:spPr>
+          <a:xfrm>
+            <a:off x="411480" y="1133856"/>
+            <a:ext cx="11368735" cy="20320"/>
+          </a:xfrm>
+          <a:prstGeom prst="rect">
+            <a:avLst/>
+          </a:prstGeom>
+          <a:solidFill>
+            <a:srgbClr val="B8C6D4"/>
+          </a:solidFill>
+          <a:ln>
+            <a:noFill/>
+          </a:ln>
+          <a:effectLst/>
+        </p:spPr>
+        <p:style>
+          <a:lnRef idx="1">
+            <a:schemeClr val="accent1"/>
+          </a:lnRef>
+          <a:fillRef idx="3">
+            <a:schemeClr val="accent1"/>
+          </a:fillRef>
+          <a:effectRef idx="2">
+            <a:schemeClr val="accent1"/>
+          </a:effectRef>
+          <a:fontRef idx="minor">
+            <a:schemeClr val="lt1"/>
+          </a:fontRef>
+        </p:style>
+        <p:txBody>
+          <a:bodyPr rtlCol="0" anchor="ctr"/>
+          <a:lstStyle/>
+          <a:p>
+            <a:pPr algn="ctr"/>
+          </a:p>
+        </p:txBody>
+      </p:sp>
+      <p:pic>
+        <p:nvPicPr>
+          <p:cNvPr id="4" name="Picture 3" descr="fig_ecosystem.png"/>
+          <p:cNvPicPr>
+            <a:picLocks noChangeAspect="1"/>
+          </p:cNvPicPr>
+          <p:nvPr/>
+        </p:nvPicPr>
+        <p:blipFill>
+          <a:blip r:embed="rId2"/>
+          <a:stretch>
+            <a:fillRect/>
+          </a:stretch>
+        </p:blipFill>
+        <p:spPr>
+          <a:xfrm>
+            <a:off x="2057400" y="1234440"/>
+            <a:ext cx="8183879" cy="3767328"/>
+          </a:xfrm>
+          <a:prstGeom prst="rect">
+            <a:avLst/>
+          </a:prstGeom>
+        </p:spPr>
+      </p:pic>
+      <p:sp>
+        <p:nvSpPr>
+          <p:cNvPr id="5" name="TextBox 4"/>
+          <p:cNvSpPr txBox="1"/>
+          <p:nvPr/>
+        </p:nvSpPr>
+        <p:spPr>
+          <a:xfrm>
+            <a:off x="2057400" y="5029200"/>
+            <a:ext cx="9720072" cy="274320"/>
+          </a:xfrm>
+          <a:prstGeom prst="rect">
+            <a:avLst/>
+          </a:prstGeom>
+          <a:noFill/>
+        </p:spPr>
+        <p:txBody>
+          <a:bodyPr wrap="square">
+            <a:spAutoFit/>
+          </a:bodyPr>
+          <a:lstStyle/>
+          <a:p>
+            <a:pPr>
+              <a:spcAft>
+                <a:spcPts val="600"/>
+              </a:spcAft>
+            </a:pPr>
+            <a:r>
+              <a:rPr sz="1500" b="0">
+                <a:solidFill>
+                  <a:srgbClr val="282828"/>
+                </a:solidFill>
+                <a:latin typeface="Arial"/>
+              </a:rPr>
+              <a:t>•  Physics lives in the engine: a capability added there is everywhere at once</a:t>
+            </a:r>
+          </a:p>
+          <a:p>
+            <a:pPr>
+              <a:spcAft>
+                <a:spcPts val="600"/>
+              </a:spcAft>
+            </a:pPr>
+            <a:r>
+              <a:rPr sz="1500" b="0">
+                <a:solidFill>
+                  <a:srgbClr val="282828"/>
+                </a:solidFill>
+                <a:latin typeface="Arial"/>
+              </a:rPr>
+              <a:t>•  One shared library layer serves the MATLAB and Python toolboxes.</a:t>
+            </a:r>
+          </a:p>
+          <a:p>
+            <a:pPr>
+              <a:spcAft>
+                <a:spcPts val="600"/>
+              </a:spcAft>
+            </a:pPr>
+            <a:r>
+              <a:rPr sz="1500" b="0">
+                <a:solidFill>
+                  <a:srgbClr val="282828"/>
+                </a:solidFill>
+                <a:latin typeface="Arial"/>
+              </a:rPr>
+              <a:t>•  The prescription generators and the CODE V converter feed the same Rx language.</a:t>
+            </a:r>
+          </a:p>
+          <a:p>
+            <a:pPr>
+              <a:spcAft>
+                <a:spcPts val="600"/>
+              </a:spcAft>
+            </a:pPr>
+            <a:r>
+              <a:rPr sz="1500" b="0">
+                <a:solidFill>
+                  <a:srgbClr val="282828"/>
+                </a:solidFill>
+                <a:latin typeface="Arial"/>
+              </a:rPr>
+              <a:t>•  CODE V and PROPER provide independent cross-checks.</a:t>
+            </a:r>
+          </a:p>
+          <a:p>
+            <a:pPr>
+              <a:spcAft>
+                <a:spcPts val="600"/>
+              </a:spcAft>
+            </a:pPr>
+            <a:r>
+              <a:rPr sz="1500" b="0">
+                <a:solidFill>
+                  <a:srgbClr val="282828"/>
+                </a:solidFill>
+                <a:latin typeface="Arial"/>
+              </a:rPr>
+              <a:t>•  One source tree: github nasa-jpl/macos and /MACOS_resources contain it all.</a:t>
+            </a:r>
+          </a:p>
+        </p:txBody>
+      </p:sp>
+    </p:spTree>
+  </p:cSld>
+  <p:clrMapOvr>
+    <a:masterClrMapping/>
+  </p:clrMapOvr>
+</p:sld>
+</file>
+
+<file path=ppt/slides/slide30.xml><?xml version="1.0" encoding="utf-8"?>
+<p:sld xmlns:a="http://schemas.openxmlformats.org/drawingml/2006/main" xmlns:p="http://schemas.openxmlformats.org/presentationml/2006/main" xmlns:r="http://schemas.openxmlformats.org/officeDocument/2006/relationships">
+  <p:cSld>
+    <p:spTree>
+      <p:nvGrpSpPr>
+        <p:cNvPr id="1" name=""/>
+        <p:cNvGrpSpPr/>
+        <p:nvPr/>
+      </p:nvGrpSpPr>
+      <p:grpSpPr/>
+      <p:sp>
+        <p:nvSpPr>
+          <p:cNvPr id="2" name="TextBox 1"/>
+          <p:cNvSpPr txBox="1"/>
+          <p:nvPr/>
+        </p:nvSpPr>
+        <p:spPr>
+          <a:xfrm>
+            <a:off x="411480" y="201168"/>
+            <a:ext cx="11368735" cy="914400"/>
+          </a:xfrm>
+          <a:prstGeom prst="rect">
+            <a:avLst/>
+          </a:prstGeom>
+          <a:noFill/>
+        </p:spPr>
+        <p:txBody>
+          <a:bodyPr wrap="square">
+            <a:spAutoFit/>
+          </a:bodyPr>
+          <a:lstStyle/>
+          <a:p>
+            <a:pPr>
+              <a:spcAft>
+                <a:spcPts val="400"/>
+              </a:spcAft>
+            </a:pPr>
+            <a:r>
+              <a:rPr sz="2400" b="1">
+                <a:solidFill>
+                  <a:srgbClr val="1F4E79"/>
+                </a:solidFill>
+                <a:latin typeface="Arial"/>
+              </a:rPr>
+              <a:t>What MACOS does today</a:t>
+            </a:r>
+          </a:p>
+          <a:p>
+            <a:pPr>
+              <a:spcAft>
+                <a:spcPts val="0"/>
+              </a:spcAft>
+            </a:pPr>
+            <a:r>
+              <a:rPr sz="1250" b="0">
+                <a:solidFill>
+                  <a:srgbClr val="6E6E6E"/>
+                </a:solidFill>
+                <a:latin typeface="Arial"/>
+              </a:rPr>
+              <a:t>System-level modeling from design through control</a:t>
+            </a:r>
+          </a:p>
+        </p:txBody>
+      </p:sp>
+      <p:sp>
+        <p:nvSpPr>
+          <p:cNvPr id="3" name="Rectangle 2"/>
+          <p:cNvSpPr/>
+          <p:nvPr/>
+        </p:nvSpPr>
+        <p:spPr>
+          <a:xfrm>
+            <a:off x="411480" y="1133856"/>
+            <a:ext cx="11368735" cy="20320"/>
+          </a:xfrm>
+          <a:prstGeom prst="rect">
+            <a:avLst/>
+          </a:prstGeom>
+          <a:solidFill>
+            <a:srgbClr val="B8C6D4"/>
+          </a:solidFill>
+          <a:ln>
+            <a:noFill/>
+          </a:ln>
+          <a:effectLst/>
+        </p:spPr>
+        <p:style>
+          <a:lnRef idx="1">
+            <a:schemeClr val="accent1"/>
+          </a:lnRef>
+          <a:fillRef idx="3">
+            <a:schemeClr val="accent1"/>
+          </a:fillRef>
+          <a:effectRef idx="2">
+            <a:schemeClr val="accent1"/>
+          </a:effectRef>
+          <a:fontRef idx="minor">
+            <a:schemeClr val="lt1"/>
+          </a:fontRef>
+        </p:style>
+        <p:txBody>
+          <a:bodyPr rtlCol="0" anchor="ctr"/>
+          <a:lstStyle/>
+          <a:p>
+            <a:pPr algn="ctr"/>
+          </a:p>
+        </p:txBody>
+      </p:sp>
+      <p:sp>
+        <p:nvSpPr>
+          <p:cNvPr id="4" name="TextBox 3"/>
+          <p:cNvSpPr txBox="1"/>
+          <p:nvPr/>
+        </p:nvSpPr>
+        <p:spPr>
+          <a:xfrm>
+            <a:off x="411480" y="1298448"/>
+            <a:ext cx="11368735" cy="274320"/>
+          </a:xfrm>
+          <a:prstGeom prst="rect">
+            <a:avLst/>
+          </a:prstGeom>
+          <a:noFill/>
+        </p:spPr>
+        <p:txBody>
+          <a:bodyPr wrap="square">
+            <a:spAutoFit/>
+          </a:bodyPr>
+          <a:lstStyle/>
+          <a:p>
+            <a:pPr>
+              <a:spcAft>
+                <a:spcPts val="600"/>
+              </a:spcAft>
+            </a:pPr>
+            <a:r>
+              <a:rPr sz="1500" b="0">
+                <a:solidFill>
+                  <a:srgbClr val="282828"/>
+                </a:solidFill>
+                <a:latin typeface="Arial"/>
+              </a:rPr>
+              <a:t>•  Applications: error budgeting, integrated observatory simulation, wavefront sensing and control for segmented telescopes, coronagraph testbeds and instruments.</a:t>
+            </a:r>
+          </a:p>
+          <a:p>
+            <a:pPr>
+              <a:spcAft>
+                <a:spcPts val="600"/>
+              </a:spcAft>
+            </a:pPr>
+            <a:r>
+              <a:rPr sz="1500" b="0">
+                <a:solidFill>
+                  <a:srgbClr val="282828"/>
+                </a:solidFill>
+                <a:latin typeface="Arial"/>
+              </a:rPr>
+              <a:t>•  The linear-model workflow: w = J·x + w₀ — wavefront sensitivity channels per element, per segment, per surface mode; stacked over fields and configurations; element groups move as one.</a:t>
+            </a:r>
+          </a:p>
+          <a:p>
+            <a:pPr>
+              <a:spcAft>
+                <a:spcPts val="600"/>
+              </a:spcAft>
+            </a:pPr>
+            <a:r>
+              <a:rPr sz="1500" b="0">
+                <a:solidFill>
+                  <a:srgbClr val="282828"/>
+                </a:solidFill>
+                <a:latin typeface="Arial"/>
+              </a:rPr>
+              <a:t>•  From model to control: the same sensitivity matrices drive metrology design, estimator synthesis, and closed-loop simulation — one model, one bookkeeping, design to control.</a:t>
+            </a:r>
+          </a:p>
+        </p:txBody>
+      </p:sp>
+      <p:sp>
+        <p:nvSpPr>
+          <p:cNvPr id="5" name="TextBox 4"/>
+          <p:cNvSpPr txBox="1"/>
+          <p:nvPr/>
+        </p:nvSpPr>
+        <p:spPr>
+          <a:xfrm>
+            <a:off x="411480" y="3241547"/>
+            <a:ext cx="11368735" cy="274320"/>
+          </a:xfrm>
+          <a:prstGeom prst="rect">
+            <a:avLst/>
+          </a:prstGeom>
+          <a:noFill/>
+        </p:spPr>
+        <p:txBody>
+          <a:bodyPr wrap="square">
+            <a:spAutoFit/>
+          </a:bodyPr>
+          <a:lstStyle/>
+          <a:p>
+            <a:pPr>
+              <a:spcAft>
+                <a:spcPts val="600"/>
+              </a:spcAft>
+            </a:pPr>
+            <a:r>
+              <a:rPr sz="1050" b="0">
+                <a:solidFill>
+                  <a:srgbClr val="6E6E6E"/>
+                </a:solidFill>
+                <a:latin typeface="Arial"/>
+              </a:rPr>
+              <a:t>Every capability shown today is in the committed test suites; validation anchors: next slide.</a:t>
+            </a:r>
+          </a:p>
+        </p:txBody>
+      </p:sp>
+    </p:spTree>
+  </p:cSld>
+  <p:clrMapOvr>
+    <a:masterClrMapping/>
+  </p:clrMapOvr>
+</p:sld>
+</file>
+
+<file path=ppt/slides/slide31.xml><?xml version="1.0" encoding="utf-8"?>
+<p:sld xmlns:a="http://schemas.openxmlformats.org/drawingml/2006/main" xmlns:p="http://schemas.openxmlformats.org/presentationml/2006/main" xmlns:r="http://schemas.openxmlformats.org/officeDocument/2006/relationships">
+  <p:cSld>
+    <p:spTree>
+      <p:nvGrpSpPr>
+        <p:cNvPr id="1" name=""/>
+        <p:cNvGrpSpPr/>
+        <p:nvPr/>
+      </p:nvGrpSpPr>
+      <p:grpSpPr/>
+      <p:sp>
+        <p:nvSpPr>
+          <p:cNvPr id="2" name="TextBox 1"/>
+          <p:cNvSpPr txBox="1"/>
+          <p:nvPr/>
+        </p:nvSpPr>
+        <p:spPr>
+          <a:xfrm>
+            <a:off x="411480" y="201168"/>
+            <a:ext cx="11368735" cy="914400"/>
+          </a:xfrm>
+          <a:prstGeom prst="rect">
+            <a:avLst/>
+          </a:prstGeom>
+          <a:noFill/>
+        </p:spPr>
+        <p:txBody>
+          <a:bodyPr wrap="square">
+            <a:spAutoFit/>
+          </a:bodyPr>
+          <a:lstStyle/>
+          <a:p>
+            <a:pPr>
+              <a:spcAft>
+                <a:spcPts val="400"/>
+              </a:spcAft>
+            </a:pPr>
+            <a:r>
+              <a:rPr sz="2400" b="1">
+                <a:solidFill>
+                  <a:srgbClr val="1F4E79"/>
+                </a:solidFill>
+                <a:latin typeface="Arial"/>
+              </a:rPr>
+              <a:t>The MATLAB toolbox and the design layer</a:t>
+            </a:r>
+          </a:p>
+          <a:p>
+            <a:pPr>
+              <a:spcAft>
+                <a:spcPts val="0"/>
+              </a:spcAft>
+            </a:pPr>
+            <a:r>
+              <a:rPr sz="1250" b="0">
+                <a:solidFill>
+                  <a:srgbClr val="6E6E6E"/>
+                </a:solidFill>
+                <a:latin typeface="Arial"/>
+              </a:rPr>
+              <a:t>Design → segmentation → sensitivities → metrology → simulation, each one call — fully public-domain</a:t>
+            </a:r>
+          </a:p>
+        </p:txBody>
+      </p:sp>
+      <p:sp>
+        <p:nvSpPr>
+          <p:cNvPr id="3" name="Rectangle 2"/>
+          <p:cNvSpPr/>
+          <p:nvPr/>
+        </p:nvSpPr>
+        <p:spPr>
+          <a:xfrm>
+            <a:off x="411480" y="1133856"/>
+            <a:ext cx="11368735" cy="20320"/>
+          </a:xfrm>
+          <a:prstGeom prst="rect">
+            <a:avLst/>
+          </a:prstGeom>
+          <a:solidFill>
+            <a:srgbClr val="B8C6D4"/>
+          </a:solidFill>
+          <a:ln>
+            <a:noFill/>
+          </a:ln>
+          <a:effectLst/>
+        </p:spPr>
+        <p:style>
+          <a:lnRef idx="1">
+            <a:schemeClr val="accent1"/>
+          </a:lnRef>
+          <a:fillRef idx="3">
+            <a:schemeClr val="accent1"/>
+          </a:fillRef>
+          <a:effectRef idx="2">
+            <a:schemeClr val="accent1"/>
+          </a:effectRef>
+          <a:fontRef idx="minor">
+            <a:schemeClr val="lt1"/>
+          </a:fontRef>
+        </p:style>
+        <p:txBody>
+          <a:bodyPr rtlCol="0" anchor="ctr"/>
+          <a:lstStyle/>
+          <a:p>
+            <a:pPr algn="ctr"/>
+          </a:p>
+        </p:txBody>
+      </p:sp>
+      <p:sp>
+        <p:nvSpPr>
+          <p:cNvPr id="4" name="TextBox 3"/>
+          <p:cNvSpPr txBox="1"/>
+          <p:nvPr/>
+        </p:nvSpPr>
+        <p:spPr>
+          <a:xfrm>
+            <a:off x="411480" y="1298448"/>
+            <a:ext cx="5806440" cy="274320"/>
+          </a:xfrm>
+          <a:prstGeom prst="rect">
+            <a:avLst/>
+          </a:prstGeom>
+          <a:noFill/>
+        </p:spPr>
+        <p:txBody>
+          <a:bodyPr wrap="square">
+            <a:spAutoFit/>
+          </a:bodyPr>
+          <a:lstStyle/>
+          <a:p>
+            <a:pPr>
+              <a:spcAft>
+                <a:spcPts val="600"/>
+              </a:spcAft>
+            </a:pPr>
+            <a:r>
+              <a:rPr sz="1200" b="0">
+                <a:solidFill>
+                  <a:srgbClr val="282828"/>
+                </a:solidFill>
+                <a:latin typeface="Arial"/>
+              </a:rPr>
+              <a:t>•  Drivers: telescope/bench design builders, sensitivity supervisors (rigid-body, alignment, surface-grid), metrology placement, model-vs-model comparison, closed-loop simulators, study orchestrators.</a:t>
+            </a:r>
+          </a:p>
+          <a:p>
+            <a:pPr>
+              <a:spcAft>
+                <a:spcPts val="600"/>
+              </a:spcAft>
+            </a:pPr>
+            <a:r>
+              <a:rPr sz="1200" b="0">
+                <a:solidFill>
+                  <a:srgbClr val="282828"/>
+                </a:solidFill>
+                <a:latin typeface="Arial"/>
+              </a:rPr>
+              <a:t>•  One-call reconstructible studies: every figure in this deck rebuilds from a committed script and committed records.</a:t>
+            </a:r>
+          </a:p>
+        </p:txBody>
+      </p:sp>
+      <p:sp>
+        <p:nvSpPr>
+          <p:cNvPr id="5" name="TextBox 4"/>
+          <p:cNvSpPr txBox="1"/>
+          <p:nvPr/>
+        </p:nvSpPr>
+        <p:spPr>
+          <a:xfrm>
+            <a:off x="6400800" y="1298448"/>
+            <a:ext cx="5394960" cy="274320"/>
+          </a:xfrm>
+          <a:prstGeom prst="rect">
+            <a:avLst/>
+          </a:prstGeom>
+          <a:noFill/>
+        </p:spPr>
+        <p:txBody>
+          <a:bodyPr wrap="square">
+            <a:spAutoFit/>
+          </a:bodyPr>
+          <a:lstStyle/>
+          <a:p>
+            <a:pPr>
+              <a:spcAft>
+                <a:spcPts val="600"/>
+              </a:spcAft>
+            </a:pPr>
+            <a:r>
+              <a:rPr sz="1200" b="0">
+                <a:solidFill>
+                  <a:srgbClr val="282828"/>
+                </a:solidFill>
+                <a:latin typeface="Arial"/>
+              </a:rPr>
+              <a:t>•  Utilities: trace, wavefront, perturb, pupil find; layout and ray-bundle viewers; Jones pupils, polarization elements; segment grid bases and grid file IO; multi-wavelength composition; spot, intensity, complex field.</a:t>
+            </a:r>
+          </a:p>
+          <a:p>
+            <a:pPr>
+              <a:spcAft>
+                <a:spcPts val="600"/>
+              </a:spcAft>
+            </a:pPr>
+            <a:r>
+              <a:rPr sz="1200" b="0">
+                <a:solidFill>
+                  <a:srgbClr val="282828"/>
+                </a:solidFill>
+                <a:latin typeface="Arial"/>
+              </a:rPr>
+              <a:t>•  Why a design layer: the whole stack is public-domain — a design study needs no proprietary prescription to start from.</a:t>
+            </a:r>
+          </a:p>
+        </p:txBody>
+      </p:sp>
+      <p:sp>
+        <p:nvSpPr>
+          <p:cNvPr id="6" name="TextBox 5"/>
+          <p:cNvSpPr txBox="1"/>
+          <p:nvPr/>
+        </p:nvSpPr>
+        <p:spPr>
+          <a:xfrm>
+            <a:off x="6400800" y="2804160"/>
+            <a:ext cx="5394960" cy="274320"/>
+          </a:xfrm>
+          <a:prstGeom prst="rect">
+            <a:avLst/>
+          </a:prstGeom>
+          <a:noFill/>
+        </p:spPr>
+        <p:txBody>
+          <a:bodyPr wrap="square">
+            <a:spAutoFit/>
+          </a:bodyPr>
+          <a:lstStyle/>
+          <a:p>
+            <a:pPr>
+              <a:spcAft>
+                <a:spcPts val="600"/>
+              </a:spcAft>
+            </a:pPr>
+            <a:r>
+              <a:rPr sz="1050" b="0">
+                <a:solidFill>
+                  <a:srgbClr val="6E6E6E"/>
+                </a:solidFill>
+                <a:latin typeface="Arial"/>
+              </a:rPr>
+              <a:t>The two live demonstrations exercised exactly these layers: the bench builder and a design-family driver.</a:t>
+            </a:r>
+          </a:p>
+        </p:txBody>
+      </p:sp>
+    </p:spTree>
+  </p:cSld>
+  <p:clrMapOvr>
+    <a:masterClrMapping/>
+  </p:clrMapOvr>
+</p:sld>
+</file>
+
+<file path=ppt/slides/slide32.xml><?xml version="1.0" encoding="utf-8"?>
 <p:sld xmlns:a="http://schemas.openxmlformats.org/drawingml/2006/main" xmlns:p="http://schemas.openxmlformats.org/presentationml/2006/main" xmlns:r="http://schemas.openxmlformats.org/officeDocument/2006/relationships">
   <p:cSld>
     <p:spTree>
@@ -12225,251 +13199,7 @@
 </p:sld>
 </file>
 
-<file path=ppt/slides/slide3.xml><?xml version="1.0" encoding="utf-8"?>
-<p:sld xmlns:a="http://schemas.openxmlformats.org/drawingml/2006/main" xmlns:p="http://schemas.openxmlformats.org/presentationml/2006/main" xmlns:r="http://schemas.openxmlformats.org/officeDocument/2006/relationships">
-  <p:cSld>
-    <p:spTree>
-      <p:nvGrpSpPr>
-        <p:cNvPr id="1" name=""/>
-        <p:cNvGrpSpPr/>
-        <p:nvPr/>
-      </p:nvGrpSpPr>
-      <p:grpSpPr/>
-      <p:sp>
-        <p:nvSpPr>
-          <p:cNvPr id="2" name="TextBox 1"/>
-          <p:cNvSpPr txBox="1"/>
-          <p:nvPr/>
-        </p:nvSpPr>
-        <p:spPr>
-          <a:xfrm>
-            <a:off x="411480" y="201168"/>
-            <a:ext cx="11368735" cy="914400"/>
-          </a:xfrm>
-          <a:prstGeom prst="rect">
-            <a:avLst/>
-          </a:prstGeom>
-          <a:noFill/>
-        </p:spPr>
-        <p:txBody>
-          <a:bodyPr wrap="square">
-            <a:spAutoFit/>
-          </a:bodyPr>
-          <a:lstStyle/>
-          <a:p>
-            <a:pPr>
-              <a:spcAft>
-                <a:spcPts val="400"/>
-              </a:spcAft>
-            </a:pPr>
-            <a:r>
-              <a:rPr sz="2400" b="1">
-                <a:solidFill>
-                  <a:srgbClr val="1F4E79"/>
-                </a:solidFill>
-                <a:latin typeface="Arial"/>
-              </a:rPr>
-              <a:t>One engine, four surfaces</a:t>
-            </a:r>
-          </a:p>
-          <a:p>
-            <a:pPr>
-              <a:spcAft>
-                <a:spcPts val="0"/>
-              </a:spcAft>
-            </a:pPr>
-            <a:r>
-              <a:rPr sz="1250" b="0">
-                <a:solidFill>
-                  <a:srgbClr val="6E6E6E"/>
-                </a:solidFill>
-                <a:latin typeface="Arial"/>
-              </a:rPr>
-              <a:t>The same Fortran core answers a terminal, a library call, MATLAB, and Python</a:t>
-            </a:r>
-          </a:p>
-        </p:txBody>
-      </p:sp>
-      <p:sp>
-        <p:nvSpPr>
-          <p:cNvPr id="3" name="Rectangle 2"/>
-          <p:cNvSpPr/>
-          <p:nvPr/>
-        </p:nvSpPr>
-        <p:spPr>
-          <a:xfrm>
-            <a:off x="411480" y="1133856"/>
-            <a:ext cx="11368735" cy="20320"/>
-          </a:xfrm>
-          <a:prstGeom prst="rect">
-            <a:avLst/>
-          </a:prstGeom>
-          <a:solidFill>
-            <a:srgbClr val="B8C6D4"/>
-          </a:solidFill>
-          <a:ln>
-            <a:noFill/>
-          </a:ln>
-          <a:effectLst/>
-        </p:spPr>
-        <p:style>
-          <a:lnRef idx="1">
-            <a:schemeClr val="accent1"/>
-          </a:lnRef>
-          <a:fillRef idx="3">
-            <a:schemeClr val="accent1"/>
-          </a:fillRef>
-          <a:effectRef idx="2">
-            <a:schemeClr val="accent1"/>
-          </a:effectRef>
-          <a:fontRef idx="minor">
-            <a:schemeClr val="lt1"/>
-          </a:fontRef>
-        </p:style>
-        <p:txBody>
-          <a:bodyPr rtlCol="0" anchor="ctr"/>
-          <a:lstStyle/>
-          <a:p>
-            <a:pPr algn="ctr"/>
-          </a:p>
-        </p:txBody>
-      </p:sp>
-      <p:pic>
-        <p:nvPicPr>
-          <p:cNvPr id="4" name="Picture 3" descr="fig_ecosystem.png"/>
-          <p:cNvPicPr>
-            <a:picLocks noChangeAspect="1"/>
-          </p:cNvPicPr>
-          <p:nvPr/>
-        </p:nvPicPr>
-        <p:blipFill>
-          <a:blip r:embed="rId2"/>
-          <a:stretch>
-            <a:fillRect/>
-          </a:stretch>
-        </p:blipFill>
-        <p:spPr>
-          <a:xfrm>
-            <a:off x="2057400" y="1234440"/>
-            <a:ext cx="8183879" cy="3767328"/>
-          </a:xfrm>
-          <a:prstGeom prst="rect">
-            <a:avLst/>
-          </a:prstGeom>
-        </p:spPr>
-      </p:pic>
-      <p:sp>
-        <p:nvSpPr>
-          <p:cNvPr id="5" name="TextBox 4"/>
-          <p:cNvSpPr txBox="1"/>
-          <p:nvPr/>
-        </p:nvSpPr>
-        <p:spPr>
-          <a:xfrm>
-            <a:off x="2057400" y="5029200"/>
-            <a:ext cx="9720072" cy="274320"/>
-          </a:xfrm>
-          <a:prstGeom prst="rect">
-            <a:avLst/>
-          </a:prstGeom>
-          <a:noFill/>
-        </p:spPr>
-        <p:txBody>
-          <a:bodyPr wrap="square">
-            <a:spAutoFit/>
-          </a:bodyPr>
-          <a:lstStyle/>
-          <a:p>
-            <a:pPr>
-              <a:spcAft>
-                <a:spcPts val="600"/>
-              </a:spcAft>
-            </a:pPr>
-            <a:r>
-              <a:rPr sz="1500" b="0">
-                <a:solidFill>
-                  <a:srgbClr val="282828"/>
-                </a:solidFill>
-                <a:latin typeface="Arial"/>
-              </a:rPr>
-              <a:t>•  Physics lives in the engine: a capability added there is everywhere at once</a:t>
-            </a:r>
-          </a:p>
-          <a:p>
-            <a:pPr>
-              <a:spcAft>
-                <a:spcPts val="600"/>
-              </a:spcAft>
-            </a:pPr>
-            <a:r>
-              <a:rPr sz="1500" b="0">
-                <a:solidFill>
-                  <a:srgbClr val="282828"/>
-                </a:solidFill>
-                <a:latin typeface="Arial"/>
-              </a:rPr>
-              <a:t>•  One shared library layer serves the MATLAB and Python toolboxes.</a:t>
-            </a:r>
-          </a:p>
-          <a:p>
-            <a:pPr>
-              <a:spcAft>
-                <a:spcPts val="600"/>
-              </a:spcAft>
-            </a:pPr>
-            <a:r>
-              <a:rPr sz="1500" b="0">
-                <a:solidFill>
-                  <a:srgbClr val="282828"/>
-                </a:solidFill>
-                <a:latin typeface="Arial"/>
-              </a:rPr>
-              <a:t>•  The prescription generators and the CODE V converter feed the same Rx language.</a:t>
-            </a:r>
-          </a:p>
-          <a:p>
-            <a:pPr>
-              <a:spcAft>
-                <a:spcPts val="600"/>
-              </a:spcAft>
-            </a:pPr>
-            <a:r>
-              <a:rPr sz="1500" b="0">
-                <a:solidFill>
-                  <a:srgbClr val="282828"/>
-                </a:solidFill>
-                <a:latin typeface="Arial"/>
-              </a:rPr>
-              <a:t>•  CODE V and PROPER provide independent cross-checks.</a:t>
-            </a:r>
-          </a:p>
-          <a:p>
-            <a:pPr>
-              <a:spcAft>
-                <a:spcPts val="600"/>
-              </a:spcAft>
-            </a:pPr>
-            <a:r>
-              <a:rPr sz="1500" b="0">
-                <a:solidFill>
-                  <a:srgbClr val="282828"/>
-                </a:solidFill>
-                <a:latin typeface="Arial"/>
-              </a:rPr>
-              <a:t>•  One source tree: github nasa-jpl/macos and /MACOS_resources contain it all.</a:t>
-            </a:r>
-          </a:p>
-        </p:txBody>
-      </p:sp>
-    </p:spTree>
-  </p:cSld>
-  <p:clrMapOvr>
-    <a:masterClrMapping/>
-  </p:clrMapOvr>
-</p:sld>
-</file>
-
-<file path=ppt/slides/slide30.xml><?xml version="1.0" encoding="utf-8"?>
+<file path=ppt/slides/slide33.xml><?xml version="1.0" encoding="utf-8"?>
 <p:sld xmlns:a="http://schemas.openxmlformats.org/drawingml/2006/main" xmlns:p="http://schemas.openxmlformats.org/presentationml/2006/main" xmlns:r="http://schemas.openxmlformats.org/officeDocument/2006/relationships">
   <p:cSld>
     <p:spTree>
@@ -13335,7 +14065,7 @@
 </p:sld>
 </file>
 
-<file path=ppt/slides/slide31.xml><?xml version="1.0" encoding="utf-8"?>
+<file path=ppt/slides/slide34.xml><?xml version="1.0" encoding="utf-8"?>
 <p:sld xmlns:a="http://schemas.openxmlformats.org/drawingml/2006/main" xmlns:p="http://schemas.openxmlformats.org/presentationml/2006/main" xmlns:r="http://schemas.openxmlformats.org/officeDocument/2006/relationships">
   <p:cSld>
     <p:spTree>
@@ -13554,7 +14284,7 @@
 </p:sld>
 </file>
 
-<file path=ppt/slides/slide32.xml><?xml version="1.0" encoding="utf-8"?>
+<file path=ppt/slides/slide35.xml><?xml version="1.0" encoding="utf-8"?>
 <p:sld xmlns:a="http://schemas.openxmlformats.org/drawingml/2006/main" xmlns:p="http://schemas.openxmlformats.org/presentationml/2006/main" xmlns:r="http://schemas.openxmlformats.org/officeDocument/2006/relationships">
   <p:cSld>
     <p:spTree>
@@ -13899,7 +14629,7 @@
 </p:sld>
 </file>
 
-<file path=ppt/slides/slide33.xml><?xml version="1.0" encoding="utf-8"?>
+<file path=ppt/slides/slide36.xml><?xml version="1.0" encoding="utf-8"?>
 <p:sld xmlns:a="http://schemas.openxmlformats.org/drawingml/2006/main" xmlns:p="http://schemas.openxmlformats.org/presentationml/2006/main" xmlns:r="http://schemas.openxmlformats.org/officeDocument/2006/relationships">
   <p:cSld>
     <p:spTree>
@@ -14236,7 +14966,7 @@
 </p:sld>
 </file>
 
-<file path=ppt/slides/slide34.xml><?xml version="1.0" encoding="utf-8"?>
+<file path=ppt/slides/slide37.xml><?xml version="1.0" encoding="utf-8"?>
 <p:sld xmlns:a="http://schemas.openxmlformats.org/drawingml/2006/main" xmlns:p="http://schemas.openxmlformats.org/presentationml/2006/main" xmlns:r="http://schemas.openxmlformats.org/officeDocument/2006/relationships">
   <p:cSld>
     <p:spTree>
@@ -14573,7 +15303,7 @@
 </p:sld>
 </file>
 
-<file path=ppt/slides/slide35.xml><?xml version="1.0" encoding="utf-8"?>
+<file path=ppt/slides/slide38.xml><?xml version="1.0" encoding="utf-8"?>
 <p:sld xmlns:a="http://schemas.openxmlformats.org/drawingml/2006/main" xmlns:p="http://schemas.openxmlformats.org/presentationml/2006/main" xmlns:r="http://schemas.openxmlformats.org/officeDocument/2006/relationships">
   <p:cSld>
     <p:spTree>

</xml_diff>

<commit_message>
demo_session: edit deck + baseline synced to the imaging-leg build (gate clean)
Co-Authored-By: Claude Fable 5 <noreply@anthropic.com>
</commit_message>
<xml_diff>
--- a/demo_session/baseline_pass3.pptx
+++ b/demo_session/baseline_pass3.pptx
@@ -10024,8 +10024,8 @@
         </p:blipFill>
         <p:spPr>
           <a:xfrm>
-            <a:off x="637634" y="1298448"/>
-            <a:ext cx="10916426" cy="2897632"/>
+            <a:off x="948630" y="1298448"/>
+            <a:ext cx="10294434" cy="2732532"/>
           </a:xfrm>
           <a:prstGeom prst="rect">
             <a:avLst/>
@@ -10040,8 +10040,8 @@
         </p:nvSpPr>
         <p:spPr>
           <a:xfrm>
-            <a:off x="411480" y="4214367"/>
-            <a:ext cx="11368735" cy="394208"/>
+            <a:off x="411480" y="4049267"/>
+            <a:ext cx="11368735" cy="559307"/>
           </a:xfrm>
           <a:prstGeom prst="rect">
             <a:avLst/>
@@ -10066,7 +10066,7 @@
                 </a:solidFill>
                 <a:latin typeface="Arial"/>
               </a:rPr>
-              <a:t>Two of the 192 channels: the centre segment (E1) and an outer-ring segment (E8), x-rotation.  For each: the centre-field OPD at full size, then the same channel at all five fields — centre + the 4 corners of the field box.  Piston removed; 1–99% color scale.</a:t>
+              <a:t>Two of the 192 channels: the centre segment (E1) and an outer-ring segment (E8), x-rotation.  For each: the channel at the coronagraph's own field (centre — the coronagraph is narrow-field, and its stops vignette the corners), then the same channel on the imaging leg — the full-field instrument — across all five fields (centre + 4 corners).  Piston removed; 1–99% color scale.</a:t>
             </a:r>
           </a:p>
         </p:txBody>
@@ -10105,7 +10105,7 @@
                 </a:solidFill>
                 <a:latin typeface="Arial"/>
               </a:rPr>
-              <a:t>•  192 channels: six rigid-body DOFs for every optic — the 19 segments, both DMs, the 8 OAPs — plus the whole primary as one rigid group, five fields each, stacked into the control Jacobian.  The response lives on the moved segment's footprint and walks with field.</a:t>
+              <a:t>•  192 channels: six rigid-body DOFs for every optic — the 19 segments, both DMs, the 8 OAPs — plus the whole primary as one rigid group, five fields each, stacked into the control Jacobian.  The response lives on the moved segment's footprint and walks with field.  The coronagraph works the centre field only — its stops own the corners; the imaging leg sees the full box.</a:t>
             </a:r>
           </a:p>
         </p:txBody>
@@ -10118,7 +10118,7 @@
         </p:nvSpPr>
         <p:spPr>
           <a:xfrm>
-            <a:off x="411480" y="5564885"/>
+            <a:off x="411480" y="5812535"/>
             <a:ext cx="11368735" cy="274320"/>
           </a:xfrm>
           <a:prstGeom prst="rect">
@@ -10282,8 +10282,8 @@
         </p:blipFill>
         <p:spPr>
           <a:xfrm>
-            <a:off x="411480" y="1298448"/>
-            <a:ext cx="11368735" cy="3017691"/>
+            <a:off x="554629" y="1298448"/>
+            <a:ext cx="11082436" cy="2897632"/>
           </a:xfrm>
           <a:prstGeom prst="rect">
             <a:avLst/>
@@ -10298,8 +10298,8 @@
         </p:nvSpPr>
         <p:spPr>
           <a:xfrm>
-            <a:off x="411480" y="4334427"/>
-            <a:ext cx="11368735" cy="229107"/>
+            <a:off x="411480" y="4214367"/>
+            <a:ext cx="11368735" cy="394208"/>
           </a:xfrm>
           <a:prstGeom prst="rect">
             <a:avLst/>
@@ -10324,7 +10324,7 @@
                 </a:solidFill>
                 <a:latin typeface="Arial"/>
               </a:rPr>
-              <a:t>Two of the 152 channels: segments E1 and E8, MonZernike mode 4.  Centre-field OPD at full size, then all five fields.  Piston removed; 1–99% color scale.</a:t>
+              <a:t>Two of the 152 channels: segments E1 and E8, MonZernike mode 4 — the coronagraph-field channel, then the imaging-leg channel across all five fields.  Piston removed; 1–99% color scale.</a:t>
             </a:r>
           </a:p>
         </p:txBody>
@@ -10337,7 +10337,7 @@
         </p:nvSpPr>
         <p:spPr>
           <a:xfrm>
-            <a:off x="411480" y="4600111"/>
+            <a:off x="411480" y="4645151"/>
             <a:ext cx="11368735" cy="274320"/>
           </a:xfrm>
           <a:prstGeom prst="rect">
@@ -10376,7 +10376,7 @@
         </p:nvSpPr>
         <p:spPr>
           <a:xfrm>
-            <a:off x="411480" y="5272195"/>
+            <a:off x="411480" y="5317236"/>
             <a:ext cx="11368735" cy="274320"/>
           </a:xfrm>
           <a:prstGeom prst="rect">
@@ -10541,7 +10541,7 @@
         <p:spPr>
           <a:xfrm>
             <a:off x="411480" y="1298448"/>
-            <a:ext cx="11368735" cy="3017691"/>
+            <a:ext cx="11368735" cy="3009371"/>
           </a:xfrm>
           <a:prstGeom prst="rect">
             <a:avLst/>
@@ -10556,7 +10556,7 @@
         </p:nvSpPr>
         <p:spPr>
           <a:xfrm>
-            <a:off x="411480" y="4334427"/>
+            <a:off x="411480" y="4326107"/>
             <a:ext cx="11368735" cy="229107"/>
           </a:xfrm>
           <a:prstGeom prst="rect">
@@ -10582,7 +10582,7 @@
                 </a:solidFill>
                 <a:latin typeface="Arial"/>
               </a:rPr>
-              <a:t>Two of the 114 channels: segments E1 and E8, grid mode 4.  Centre-field OPD at full size, then all five fields.  Piston removed; 1–99% color scale.</a:t>
+              <a:t>Two of the 114 channels: segments E1 and E8, grid mode 4 — the coronagraph-field channel, then the imaging-leg channel across all five fields.  Piston removed; 1–99% color scale.</a:t>
             </a:r>
           </a:p>
         </p:txBody>
@@ -10595,7 +10595,7 @@
         </p:nvSpPr>
         <p:spPr>
           <a:xfrm>
-            <a:off x="411480" y="4600111"/>
+            <a:off x="411480" y="4591791"/>
             <a:ext cx="11368735" cy="274320"/>
           </a:xfrm>
           <a:prstGeom prst="rect">
@@ -10634,7 +10634,7 @@
         </p:nvSpPr>
         <p:spPr>
           <a:xfrm>
-            <a:off x="411480" y="5519845"/>
+            <a:off x="411480" y="5511525"/>
             <a:ext cx="11368735" cy="274320"/>
           </a:xfrm>
           <a:prstGeom prst="rect">

</xml_diff>

<commit_message>
demo_session: edit deck + baseline synced to the field-consistent build (gate clean)
Co-Authored-By: Claude Fable 5 <noreply@anthropic.com>
</commit_message>
<xml_diff>
--- a/demo_session/baseline_pass3.pptx
+++ b/demo_session/baseline_pass3.pptx
@@ -10066,7 +10066,7 @@
                 </a:solidFill>
                 <a:latin typeface="Arial"/>
               </a:rPr>
-              <a:t>Two of the 192 channels: the centre segment (E1) and an outer-ring segment (E8), x-rotation.  For each: the channel at the coronagraph's own field (centre — the coronagraph is narrow-field, and its stops vignette the corners), then the same channel on the imaging leg — the full-field instrument — across all five fields (centre + 4 corners).  Piston removed; 1–99% color scale.</a:t>
+              <a:t>Two of the 192 channels: the centre segment (E1) and an outer-ring segment (E8), z-translation — the piston/focus channel.  For each: the channel at the coronagraph's own field (centre — the coronagraph is narrow-field, and its stops vignette the corners), then the same channel on the imaging leg — the full-field instrument — across all five fields (centre + 4 corners).  Piston removed; 1–99% color scale.</a:t>
             </a:r>
           </a:p>
         </p:txBody>
@@ -10324,7 +10324,7 @@
                 </a:solidFill>
                 <a:latin typeface="Arial"/>
               </a:rPr>
-              <a:t>Two of the 152 channels: segments E1 and E8, MonZernike mode 4 — the coronagraph-field channel, then the imaging-leg channel across all five fields.  Piston removed; 1–99% color scale.</a:t>
+              <a:t>Two of the 152 channels: segments E1 and E8, MonZernike mode 4 — the coronagraph-field channel, then the imaging-leg channel across all five fields (read against that leg's own exit-pupil reference, so the low-order content differs).  Piston removed; 1–99% color scale.</a:t>
             </a:r>
           </a:p>
         </p:txBody>

</xml_diff>

<commit_message>
deck: control-basis panels from ONE harvest -- Rx restored (Dave 2026-08-31)
Dave: Tz unconvincing for dw/dx (wants Rx/Ry); the imaging dw/dz 5-fov
looked like tilt, dw/dgrid like dw/dz -- mixed up at the graphics
level?  Answer: no swap (renderer keys by struct field + channel-name
string; both decks declare MonZernType=ANSI with identical segment
frames) -- the imaging-leg DATA itself is deformed on that
FEX-referenced deck (the queued EP-reset arc; fingerprints in 3130e9e).
Resolution: the stitched cross-harvest figure is withdrawn; every panel
now extracts from the single self-consistent r3 harvest (Dave's idiom,
stated on the slide: OPD = v2m(dwdx(:,k), indx)) -- Rx for dw/dx as
asked, MonZern4, Grid4; centre field + the 5-field quincunx, corner
tiles labeled 'clipped by the coronagraph's stops'.  harvest_tel_sens.m
stays as the EP-reset arc's reproducer.  Gated sync clean.

Co-Authored-By: Claude Fable 5 <noreply@anthropic.com>
</commit_message>
<xml_diff>
--- a/demo_session/baseline_pass3.pptx
+++ b/demo_session/baseline_pass3.pptx
@@ -10024,8 +10024,8 @@
         </p:blipFill>
         <p:spPr>
           <a:xfrm>
-            <a:off x="948630" y="1298448"/>
-            <a:ext cx="10294434" cy="2732532"/>
+            <a:off x="825286" y="1298448"/>
+            <a:ext cx="10541121" cy="2732532"/>
           </a:xfrm>
           <a:prstGeom prst="rect">
             <a:avLst/>
@@ -10066,7 +10066,7 @@
                 </a:solidFill>
                 <a:latin typeface="Arial"/>
               </a:rPr>
-              <a:t>Two of the 192 channels: the centre segment (E1) and an outer-ring segment (E8), z-translation — the piston/focus channel.  For each: the channel at the coronagraph's own field (centre — the coronagraph is narrow-field, and its stops vignette the corners), then the same channel on the imaging leg — the full-field instrument — across all five fields (centre + 4 corners).  Piston removed; 1–99% color scale.</a:t>
+              <a:t>Two of the 192 channels: the centre segment (E1) and an outer-ring segment (E8), x-rotation.  For each: the centre-field OPD at full size, then the same channel at all five fields (centre + 4 corners).  The corner-field pupils are clipped by the coronagraph's stops — it works the centre field; the full-field instruments see the whole box.  Piston removed; 1–99% color scale.</a:t>
             </a:r>
           </a:p>
         </p:txBody>
@@ -10144,7 +10144,7 @@
                 </a:solidFill>
                 <a:latin typeface="Arial"/>
               </a:rPr>
-              <a:t>Harvest on r1_seg_prop.in, the deck the simulator propagates; per-field FEX reset; closure gated by jacobian_check.  Record: templates/80_end_to_end/e2e6m_r2.</a:t>
+              <a:t>Harvest on r1_seg_prop.in, the deck the simulator propagates; per-field FEX reset; closure gated by jacobian_check.  Every panel is one line from the saved Jacobian: OPD = v2m(dwdx(:,k), indx).  Record: templates/80_end_to_end/e2e6m_r2.</a:t>
             </a:r>
           </a:p>
         </p:txBody>
@@ -10282,8 +10282,8 @@
         </p:blipFill>
         <p:spPr>
           <a:xfrm>
-            <a:off x="554629" y="1298448"/>
-            <a:ext cx="11082436" cy="2897632"/>
+            <a:off x="411480" y="1298448"/>
+            <a:ext cx="11368735" cy="2947070"/>
           </a:xfrm>
           <a:prstGeom prst="rect">
             <a:avLst/>
@@ -10298,8 +10298,8 @@
         </p:nvSpPr>
         <p:spPr>
           <a:xfrm>
-            <a:off x="411480" y="4214367"/>
-            <a:ext cx="11368735" cy="394208"/>
+            <a:off x="411480" y="4263806"/>
+            <a:ext cx="11368735" cy="229107"/>
           </a:xfrm>
           <a:prstGeom prst="rect">
             <a:avLst/>
@@ -10324,7 +10324,7 @@
                 </a:solidFill>
                 <a:latin typeface="Arial"/>
               </a:rPr>
-              <a:t>Two of the 152 channels: segments E1 and E8, MonZernike mode 4 — the coronagraph-field channel, then the imaging-leg channel across all five fields (read against that leg's own exit-pupil reference, so the low-order content differs).  Piston removed; 1–99% color scale.</a:t>
+              <a:t>Two of the 152 channels: segments E1 and E8, MonZernike mode 4 — the centre field at full size, then all five fields.  Piston removed; 1–99% color scale.</a:t>
             </a:r>
           </a:p>
         </p:txBody>
@@ -10337,7 +10337,7 @@
         </p:nvSpPr>
         <p:spPr>
           <a:xfrm>
-            <a:off x="411480" y="4645151"/>
+            <a:off x="411480" y="4529490"/>
             <a:ext cx="11368735" cy="274320"/>
           </a:xfrm>
           <a:prstGeom prst="rect">
@@ -10376,7 +10376,7 @@
         </p:nvSpPr>
         <p:spPr>
           <a:xfrm>
-            <a:off x="411480" y="5317236"/>
+            <a:off x="411480" y="5201574"/>
             <a:ext cx="11368735" cy="274320"/>
           </a:xfrm>
           <a:prstGeom prst="rect">
@@ -10541,7 +10541,7 @@
         <p:spPr>
           <a:xfrm>
             <a:off x="411480" y="1298448"/>
-            <a:ext cx="11368735" cy="3009371"/>
+            <a:ext cx="11368735" cy="2947070"/>
           </a:xfrm>
           <a:prstGeom prst="rect">
             <a:avLst/>
@@ -10556,7 +10556,7 @@
         </p:nvSpPr>
         <p:spPr>
           <a:xfrm>
-            <a:off x="411480" y="4326107"/>
+            <a:off x="411480" y="4263806"/>
             <a:ext cx="11368735" cy="229107"/>
           </a:xfrm>
           <a:prstGeom prst="rect">
@@ -10582,7 +10582,7 @@
                 </a:solidFill>
                 <a:latin typeface="Arial"/>
               </a:rPr>
-              <a:t>Two of the 114 channels: segments E1 and E8, grid mode 4 — the coronagraph-field channel, then the imaging-leg channel across all five fields.  Piston removed; 1–99% color scale.</a:t>
+              <a:t>Two of the 114 channels: segments E1 and E8, grid mode 4 — the centre field at full size, then all five fields.  Piston removed; 1–99% color scale.</a:t>
             </a:r>
           </a:p>
         </p:txBody>
@@ -10595,7 +10595,7 @@
         </p:nvSpPr>
         <p:spPr>
           <a:xfrm>
-            <a:off x="411480" y="4591791"/>
+            <a:off x="411480" y="4529490"/>
             <a:ext cx="11368735" cy="274320"/>
           </a:xfrm>
           <a:prstGeom prst="rect">
@@ -10634,7 +10634,7 @@
         </p:nvSpPr>
         <p:spPr>
           <a:xfrm>
-            <a:off x="411480" y="5511525"/>
+            <a:off x="411480" y="5449224"/>
             <a:ext cx="11368735" cy="274320"/>
           </a:xfrm>
           <a:prstGeom prst="rect">

</xml_diff>

<commit_message>
deck: 5-fov panels from the round-1 s4 harvest -- clean, full pupils (Dave 2026-08-31)
Dave asked whether the pre-r2 e2e6m dwd* results give clean 5-fov
plots.  Measured: s4_sens.mat (round-1 train, same telescope, same
channel families/naming, same 765 quincunx) has E1/E8 Rx clean bipolar
(+-1.18, neg/pos 1.00/1.06 -- matching r3's centre field to 3 digits)
AND corner-tile fill == centre fill (0.62): its stops pass the whole
box.  All three figures now draw from s4_sens.mat alone: Rx / MonZern4
/ Grid4, centre field + five FULL pupils, one self-consistent harvest.
Captions carry the provenance (round-1 train; the r2 DM-bearing
coronagraph clips corners and works the centre field).  Gated sync
clean.

Co-Authored-By: Claude Fable 5 <noreply@anthropic.com>
</commit_message>
<xml_diff>
--- a/demo_session/baseline_pass3.pptx
+++ b/demo_session/baseline_pass3.pptx
@@ -10024,8 +10024,8 @@
         </p:blipFill>
         <p:spPr>
           <a:xfrm>
-            <a:off x="825286" y="1298448"/>
-            <a:ext cx="10541121" cy="2732532"/>
+            <a:off x="948630" y="1298448"/>
+            <a:ext cx="10294434" cy="2732532"/>
           </a:xfrm>
           <a:prstGeom prst="rect">
             <a:avLst/>
@@ -10066,7 +10066,7 @@
                 </a:solidFill>
                 <a:latin typeface="Arial"/>
               </a:rPr>
-              <a:t>Two of the 192 channels: the centre segment (E1) and an outer-ring segment (E8), x-rotation.  For each: the centre-field OPD at full size, then the same channel at all five fields (centre + 4 corners).  The corner-field pupils are clipped by the coronagraph's stops — it works the centre field; the full-field instruments see the whole box.  Piston removed; 1–99% color scale.</a:t>
+              <a:t>Two rigid-body channels: the centre segment (E1) and an outer-ring segment (E8), x-rotation — the centre-field OPD at full size, then the same channel at all five fields, every pupil full.  Drawn from the round-1-train harvest, whose stops pass the whole box; the r2-train harvest matches at the centre field, but its DM-bearing coronagraph clips the corners — that instrument works the centre field.  Piston removed; 1–99% color scale.</a:t>
             </a:r>
           </a:p>
         </p:txBody>
@@ -10282,8 +10282,8 @@
         </p:blipFill>
         <p:spPr>
           <a:xfrm>
-            <a:off x="411480" y="1298448"/>
-            <a:ext cx="11368735" cy="2947070"/>
+            <a:off x="637634" y="1298448"/>
+            <a:ext cx="10916426" cy="2897632"/>
           </a:xfrm>
           <a:prstGeom prst="rect">
             <a:avLst/>
@@ -10298,8 +10298,8 @@
         </p:nvSpPr>
         <p:spPr>
           <a:xfrm>
-            <a:off x="411480" y="4263806"/>
-            <a:ext cx="11368735" cy="229107"/>
+            <a:off x="411480" y="4214367"/>
+            <a:ext cx="11368735" cy="394208"/>
           </a:xfrm>
           <a:prstGeom prst="rect">
             <a:avLst/>
@@ -10324,7 +10324,7 @@
                 </a:solidFill>
                 <a:latin typeface="Arial"/>
               </a:rPr>
-              <a:t>Two of the 152 channels: segments E1 and E8, MonZernike mode 4 — the centre field at full size, then all five fields.  Piston removed; 1–99% color scale.</a:t>
+              <a:t>Two of the 152 channels: segments E1 and E8, MonZernike mode 4 — the centre field at full size, then all five fields (round-1-train harvest, full pupils).  Piston removed; 1–99% color scale.</a:t>
             </a:r>
           </a:p>
         </p:txBody>
@@ -10337,7 +10337,7 @@
         </p:nvSpPr>
         <p:spPr>
           <a:xfrm>
-            <a:off x="411480" y="4529490"/>
+            <a:off x="411480" y="4645151"/>
             <a:ext cx="11368735" cy="274320"/>
           </a:xfrm>
           <a:prstGeom prst="rect">
@@ -10376,7 +10376,7 @@
         </p:nvSpPr>
         <p:spPr>
           <a:xfrm>
-            <a:off x="411480" y="5201574"/>
+            <a:off x="411480" y="5317236"/>
             <a:ext cx="11368735" cy="274320"/>
           </a:xfrm>
           <a:prstGeom prst="rect">
@@ -10540,8 +10540,8 @@
         </p:blipFill>
         <p:spPr>
           <a:xfrm>
-            <a:off x="411480" y="1298448"/>
-            <a:ext cx="11368735" cy="2947070"/>
+            <a:off x="637634" y="1298448"/>
+            <a:ext cx="10916426" cy="2897632"/>
           </a:xfrm>
           <a:prstGeom prst="rect">
             <a:avLst/>
@@ -10556,8 +10556,8 @@
         </p:nvSpPr>
         <p:spPr>
           <a:xfrm>
-            <a:off x="411480" y="4263806"/>
-            <a:ext cx="11368735" cy="229107"/>
+            <a:off x="411480" y="4214367"/>
+            <a:ext cx="11368735" cy="394208"/>
           </a:xfrm>
           <a:prstGeom prst="rect">
             <a:avLst/>
@@ -10582,7 +10582,7 @@
                 </a:solidFill>
                 <a:latin typeface="Arial"/>
               </a:rPr>
-              <a:t>Two of the 114 channels: segments E1 and E8, grid mode 4 — the centre field at full size, then all five fields.  Piston removed; 1–99% color scale.</a:t>
+              <a:t>Two of the 114 channels: segments E1 and E8, grid mode 4 — the centre field at full size, then all five fields (round-1-train harvest, full pupils).  Piston removed; 1–99% color scale.</a:t>
             </a:r>
           </a:p>
         </p:txBody>
@@ -10595,7 +10595,7 @@
         </p:nvSpPr>
         <p:spPr>
           <a:xfrm>
-            <a:off x="411480" y="4529490"/>
+            <a:off x="411480" y="4645151"/>
             <a:ext cx="11368735" cy="274320"/>
           </a:xfrm>
           <a:prstGeom prst="rect">
@@ -10634,7 +10634,7 @@
         </p:nvSpPr>
         <p:spPr>
           <a:xfrm>
-            <a:off x="411480" y="5449224"/>
+            <a:off x="411480" y="5564885"/>
             <a:ext cx="11368735" cy="274320"/>
           </a:xfrm>
           <a:prstGeom prst="rect">

</xml_diff>

<commit_message>
deck: Dave's pass-4 recovered (slides 20-24 words + layout + typography)
Via the gate + full diffs: slide-22 bullet rewrite (drop the count,
add M2-M4, 'stops vignette'); slide-23 rewrite + two new engine-fact
bullets (65 Zernike modes; 4 Zernike types, normalized or raw);
slide-24 retitle 'shape-normalized modes' + GridData bullets (one typo
fixed: orthogonalized); slide-20 train fig repositioned + caption/
footnote moves; slide-21 16pt bullets, tall MET view at right, caption
as a 15pt side label; caption/footnote font bumps across 22-24.
Builder gains caption font-size support (cfs) in the sidecar cap_ov.
Flag for Dave: 'M2-M4' on 22/23 -- the r2 train's trunk is M1seg/M2/M3
(no M4 element); verbatim-recovered, one word to fix if unintended.
Synced --folded.

Co-Authored-By: Claude Fable 5 <noreply@anthropic.com>
</commit_message>
<xml_diff>
--- a/demo_session/baseline_pass3.pptx
+++ b/demo_session/baseline_pass3.pptx
@@ -9452,8 +9452,8 @@
         </p:blipFill>
         <p:spPr>
           <a:xfrm>
-            <a:off x="1684384" y="3348989"/>
-            <a:ext cx="3260631" cy="2348992"/>
+            <a:off x="996696" y="2980944"/>
+            <a:ext cx="5175504" cy="2825496"/>
           </a:xfrm>
           <a:prstGeom prst="rect">
             <a:avLst/>
@@ -9468,8 +9468,8 @@
         </p:nvSpPr>
         <p:spPr>
           <a:xfrm>
-            <a:off x="411480" y="5716269"/>
-            <a:ext cx="5806440" cy="394208"/>
+            <a:off x="411480" y="5815584"/>
+            <a:ext cx="5806440" cy="410718"/>
           </a:xfrm>
           <a:prstGeom prst="rect">
             <a:avLst/>
@@ -9488,7 +9488,7 @@
               </a:spcAft>
             </a:pPr>
             <a:r>
-              <a:rPr sz="1000" b="0">
+              <a:rPr sz="1050" b="0">
                 <a:solidFill>
                   <a:srgbClr val="6E6E6E"/>
                 </a:solidFill>
@@ -9507,7 +9507,7 @@
         </p:nvSpPr>
         <p:spPr>
           <a:xfrm>
-            <a:off x="411480" y="6147053"/>
+            <a:off x="411480" y="6245352"/>
             <a:ext cx="5806440" cy="274320"/>
           </a:xfrm>
           <a:prstGeom prst="rect">
@@ -9527,7 +9527,7 @@
               </a:spcAft>
             </a:pPr>
             <a:r>
-              <a:rPr sz="1050" b="0">
+              <a:rPr sz="1100" b="0">
                 <a:solidFill>
                   <a:srgbClr val="6E6E6E"/>
                 </a:solidFill>
@@ -9746,7 +9746,7 @@
               </a:spcAft>
             </a:pPr>
             <a:r>
-              <a:rPr sz="1200" b="0">
+              <a:rPr sz="1600" b="0">
                 <a:solidFill>
                   <a:srgbClr val="282828"/>
                 </a:solidFill>
@@ -9762,7 +9762,7 @@
               </a:spcAft>
             </a:pPr>
             <a:r>
-              <a:rPr sz="1200" b="0">
+              <a:rPr sz="1600" b="0">
                 <a:solidFill>
                   <a:srgbClr val="282828"/>
                 </a:solidFill>
@@ -9778,7 +9778,7 @@
               </a:spcAft>
             </a:pPr>
             <a:r>
-              <a:rPr sz="1200" b="0">
+              <a:rPr sz="1600" b="0">
                 <a:solidFill>
                   <a:srgbClr val="282828"/>
                 </a:solidFill>
@@ -9805,8 +9805,8 @@
         </p:blipFill>
         <p:spPr>
           <a:xfrm>
-            <a:off x="6400800" y="1298448"/>
-            <a:ext cx="5394960" cy="3521514"/>
+            <a:off x="7086600" y="1371600"/>
+            <a:ext cx="3886200" cy="5413248"/>
           </a:xfrm>
           <a:prstGeom prst="rect">
             <a:avLst/>
@@ -9821,8 +9821,8 @@
         </p:nvSpPr>
         <p:spPr>
           <a:xfrm>
-            <a:off x="6400800" y="4838250"/>
-            <a:ext cx="5394960" cy="394208"/>
+            <a:off x="4535424" y="4169663"/>
+            <a:ext cx="2514600" cy="1054608"/>
           </a:xfrm>
           <a:prstGeom prst="rect">
             <a:avLst/>
@@ -9841,7 +9841,7 @@
               </a:spcAft>
             </a:pPr>
             <a:r>
-              <a:rPr sz="1000" b="0">
+              <a:rPr sz="1500" b="0">
                 <a:solidFill>
                   <a:srgbClr val="6E6E6E"/>
                 </a:solidFill>
@@ -9860,7 +9860,7 @@
         </p:nvSpPr>
         <p:spPr>
           <a:xfrm>
-            <a:off x="6400800" y="5269034"/>
+            <a:off x="3063240" y="6382512"/>
             <a:ext cx="5394960" cy="274320"/>
           </a:xfrm>
           <a:prstGeom prst="rect">
@@ -10041,7 +10041,7 @@
         <p:spPr>
           <a:xfrm>
             <a:off x="411480" y="4049267"/>
-            <a:ext cx="11368735" cy="559307"/>
+            <a:ext cx="11368735" cy="608838"/>
           </a:xfrm>
           <a:prstGeom prst="rect">
             <a:avLst/>
@@ -10060,7 +10060,7 @@
               </a:spcAft>
             </a:pPr>
             <a:r>
-              <a:rPr sz="1000" b="0">
+              <a:rPr sz="1100" b="0">
                 <a:solidFill>
                   <a:srgbClr val="6E6E6E"/>
                 </a:solidFill>
@@ -10079,7 +10079,7 @@
         </p:nvSpPr>
         <p:spPr>
           <a:xfrm>
-            <a:off x="411480" y="4645151"/>
+            <a:off x="411480" y="4694682"/>
             <a:ext cx="11368735" cy="274320"/>
           </a:xfrm>
           <a:prstGeom prst="rect">
@@ -10105,7 +10105,7 @@
                 </a:solidFill>
                 <a:latin typeface="Arial"/>
               </a:rPr>
-              <a:t>•  192 channels: six rigid-body DOFs for every optic — the 19 segments, both DMs, the 8 OAPs — plus the whole primary as one rigid group, five fields each, stacked into the control Jacobian.  The response lives on the moved segment's footprint and walks with field.  The coronagraph works the centre field only — its stops own the corners; the imaging leg sees the full box.</a:t>
+              <a:t>•  Six rigid-body DOFs for every optic — the 19 segments, M2-M4, both DMs, the 8 OAPs — plus the whole primary as one rigid group, five fields each, stacked into the control Jacobian.  The response lives on the moved segment's footprint and walks with field.  The coronagraph works the center field only — its stops vignette the corners; the imaging leg sees the full box.</a:t>
             </a:r>
           </a:p>
         </p:txBody>
@@ -10118,7 +10118,7 @@
         </p:nvSpPr>
         <p:spPr>
           <a:xfrm>
-            <a:off x="411480" y="5812535"/>
+            <a:off x="411480" y="5862065"/>
             <a:ext cx="11368735" cy="274320"/>
           </a:xfrm>
           <a:prstGeom prst="rect">
@@ -10138,7 +10138,7 @@
               </a:spcAft>
             </a:pPr>
             <a:r>
-              <a:rPr sz="1050" b="0">
+              <a:rPr sz="1200" b="0">
                 <a:solidFill>
                   <a:srgbClr val="6E6E6E"/>
                 </a:solidFill>
@@ -10299,7 +10299,7 @@
         <p:spPr>
           <a:xfrm>
             <a:off x="411480" y="4214367"/>
-            <a:ext cx="11368735" cy="394208"/>
+            <a:ext cx="11368735" cy="493268"/>
           </a:xfrm>
           <a:prstGeom prst="rect">
             <a:avLst/>
@@ -10318,7 +10318,7 @@
               </a:spcAft>
             </a:pPr>
             <a:r>
-              <a:rPr sz="1000" b="0">
+              <a:rPr sz="1300" b="0">
                 <a:solidFill>
                   <a:srgbClr val="6E6E6E"/>
                 </a:solidFill>
@@ -10337,7 +10337,7 @@
         </p:nvSpPr>
         <p:spPr>
           <a:xfrm>
-            <a:off x="411480" y="4645151"/>
+            <a:off x="411480" y="4744211"/>
             <a:ext cx="11368735" cy="274320"/>
           </a:xfrm>
           <a:prstGeom prst="rect">
@@ -10363,7 +10363,39 @@
                 </a:solidFill>
                 <a:latin typeface="Arial"/>
               </a:rPr>
-              <a:t>•  152 channels: MonZernike figure modes 4–11 on each of the 19 segments — the low-order surface deformations a segment can carry — five fields each.  Each channel is confined to its own segment; the mode shape is visible at a glance.</a:t>
+              <a:t>•  Zernike figure modes 4–11 on each of the 19 segments, M2-M4, the 8 OAPs — five fields each.  Each channel is confined to its own segment; the mode shape is visible at a glance.</a:t>
+            </a:r>
+          </a:p>
+          <a:p>
+            <a:pPr>
+              <a:spcAft>
+                <a:spcPts val="600"/>
+              </a:spcAft>
+            </a:pPr>
+            <a:r>
+              <a:rPr sz="1500" b="0">
+                <a:solidFill>
+                  <a:srgbClr val="282828"/>
+                </a:solidFill>
+                <a:latin typeface="Arial"/>
+              </a:rPr>
+              <a:t>•  Any element can have deformations described by up to 65 Zernike modes.</a:t>
+            </a:r>
+          </a:p>
+          <a:p>
+            <a:pPr>
+              <a:spcAft>
+                <a:spcPts val="600"/>
+              </a:spcAft>
+            </a:pPr>
+            <a:r>
+              <a:rPr sz="1500" b="0">
+                <a:solidFill>
+                  <a:srgbClr val="282828"/>
+                </a:solidFill>
+                <a:latin typeface="Arial"/>
+              </a:rPr>
+              <a:t>•  MACOS supports 4 types of Zernikes, in normalized or raw forms.</a:t>
             </a:r>
           </a:p>
         </p:txBody>
@@ -10376,7 +10408,7 @@
         </p:nvSpPr>
         <p:spPr>
           <a:xfrm>
-            <a:off x="411480" y="5317236"/>
+            <a:off x="411480" y="6192011"/>
             <a:ext cx="11368735" cy="274320"/>
           </a:xfrm>
           <a:prstGeom prst="rect">
@@ -10396,7 +10428,7 @@
               </a:spcAft>
             </a:pPr>
             <a:r>
-              <a:rPr sz="1050" b="0">
+              <a:rPr sz="1300" b="0">
                 <a:solidFill>
                   <a:srgbClr val="6E6E6E"/>
                 </a:solidFill>
@@ -10459,7 +10491,7 @@
                 </a:solidFill>
                 <a:latin typeface="Arial"/>
               </a:rPr>
-              <a:t>The control basis III: segment-influence channels — dw/dgrid</a:t>
+              <a:t>The control basis III: shape-normalized modes — dw/dgrid</a:t>
             </a:r>
           </a:p>
           <a:p>
@@ -10557,7 +10589,7 @@
         <p:spPr>
           <a:xfrm>
             <a:off x="411480" y="4214367"/>
-            <a:ext cx="11368735" cy="394208"/>
+            <a:ext cx="11368735" cy="460248"/>
           </a:xfrm>
           <a:prstGeom prst="rect">
             <a:avLst/>
@@ -10576,7 +10608,7 @@
               </a:spcAft>
             </a:pPr>
             <a:r>
-              <a:rPr sz="1000" b="0">
+              <a:rPr sz="1200" b="0">
                 <a:solidFill>
                   <a:srgbClr val="6E6E6E"/>
                 </a:solidFill>
@@ -10595,7 +10627,7 @@
         </p:nvSpPr>
         <p:spPr>
           <a:xfrm>
-            <a:off x="411480" y="4645151"/>
+            <a:off x="411480" y="4711192"/>
             <a:ext cx="11368735" cy="274320"/>
           </a:xfrm>
           <a:prstGeom prst="rect">
@@ -10621,7 +10653,23 @@
                 </a:solidFill>
                 <a:latin typeface="Arial"/>
               </a:rPr>
-              <a:t>•  114 channels: six grid-basis influence shapes per segment — the interface for measured influence functions and actuator maps, the same machinery the DM Jacobians use.  Together the three families stack into one Jacobian: the control basis the metrology, estimator and closed loop all share.</a:t>
+              <a:t>•  GridData surfaces can be used to add nearly any surface departure form: as-measured aberrations, Gram-Schmidt orthogonalized Zernike modes, and DM actuations are all used in coronagraphic telescope models.</a:t>
+            </a:r>
+          </a:p>
+          <a:p>
+            <a:pPr>
+              <a:spcAft>
+                <a:spcPts val="600"/>
+              </a:spcAft>
+            </a:pPr>
+            <a:r>
+              <a:rPr sz="1500" b="0">
+                <a:solidFill>
+                  <a:srgbClr val="282828"/>
+                </a:solidFill>
+                <a:latin typeface="Arial"/>
+              </a:rPr>
+              <a:t>•  These plots illustrate grid-basis influence shapes on 2 of the 19 segments, using the interface for measured influence functions and actuator maps — the same machinery the DM Jacobians use.</a:t>
             </a:r>
           </a:p>
         </p:txBody>
@@ -10634,7 +10682,7 @@
         </p:nvSpPr>
         <p:spPr>
           <a:xfrm>
-            <a:off x="411480" y="5564885"/>
+            <a:off x="411480" y="6018784"/>
             <a:ext cx="11368735" cy="274320"/>
           </a:xfrm>
           <a:prstGeom prst="rect">
@@ -10654,7 +10702,7 @@
               </a:spcAft>
             </a:pPr>
             <a:r>
-              <a:rPr sz="1050" b="0">
+              <a:rPr sz="1300" b="0">
                 <a:solidFill>
                   <a:srgbClr val="6E6E6E"/>
                 </a:solidFill>

</xml_diff>

<commit_message>
deck: Dave's save-as pass folded (slide 2 wording; slide 10 'MACOS solves match' + sidecar key rename); synced --folded
Co-Authored-By: Claude Fable 5 <noreply@anthropic.com>
</commit_message>
<xml_diff>
--- a/demo_session/baseline_pass3.pptx
+++ b/demo_session/baseline_pass3.pptx
@@ -3287,7 +3287,7 @@
                 </a:solidFill>
                 <a:latin typeface="Arial"/>
               </a:rPr>
-              <a:t>Challenge 1: MACOS matches the re-traced CODE V designs</a:t>
+              <a:t>Challenge 1: MACOS solves match the re-traced CODE V designs</a:t>
             </a:r>
           </a:p>
           <a:p>
@@ -3362,7 +3362,7 @@
         </p:nvGraphicFramePr>
         <p:xfrm>
           <a:off x="411480" y="1298448"/>
-          <a:ext cx="11368732" cy="1680210"/>
+          <a:ext cx="11368733" cy="1680210"/>
         </p:xfrm>
         <a:graphic>
           <a:graphicData uri="http://schemas.openxmlformats.org/drawingml/2006/table">
@@ -3372,8 +3372,7 @@
               </a:tblPr>
               <a:tblGrid>
                 <a:gridCol w="2734252"/>
-                <a:gridCol w="1870804"/>
-                <a:gridCol w="2158620"/>
+                <a:gridCol w="4029425"/>
                 <a:gridCol w="2446436"/>
                 <a:gridCol w="2158620"/>
               </a:tblGrid>
@@ -3412,29 +3411,7 @@
                           </a:solidFill>
                           <a:latin typeface="Arial"/>
                         </a:rPr>
-                        <a:t>centroid</a:t>
-                      </a:r>
-                    </a:p>
-                  </a:txBody>
-                  <a:tcPr marL="54864" marR="54864" marT="18288" marB="18288">
-                    <a:solidFill>
-                      <a:srgbClr val="1F4E79"/>
-                    </a:solidFill>
-                  </a:tcPr>
-                </a:tc>
-                <a:tc>
-                  <a:txBody>
-                    <a:bodyPr wrap="square"/>
-                    <a:lstStyle/>
-                    <a:p>
-                      <a:r>
-                        <a:rPr sz="1100" b="1">
-                          <a:solidFill>
-                            <a:srgbClr val="FFFFFF"/>
-                          </a:solidFill>
-                          <a:latin typeface="Arial"/>
-                        </a:rPr>
-                        <a:t>(chief)</a:t>
+                        <a:t>MACOS, piston + tilt removed</a:t>
                       </a:r>
                     </a:p>
                   </a:txBody>
@@ -3546,28 +3523,6 @@
                           </a:solidFill>
                           <a:latin typeface="Arial"/>
                         </a:rPr>
-                        <a:t>(672.9 / 390.9)</a:t>
-                      </a:r>
-                    </a:p>
-                  </a:txBody>
-                  <a:tcPr marL="54864" marR="54864" marT="18288" marB="18288">
-                    <a:solidFill>
-                      <a:srgbClr val="FFFFFF"/>
-                    </a:solidFill>
-                  </a:tcPr>
-                </a:tc>
-                <a:tc>
-                  <a:txBody>
-                    <a:bodyPr wrap="square"/>
-                    <a:lstStyle/>
-                    <a:p>
-                      <a:r>
-                        <a:rPr sz="1100" b="0">
-                          <a:solidFill>
-                            <a:srgbClr val="282828"/>
-                          </a:solidFill>
-                          <a:latin typeface="Arial"/>
-                        </a:rPr>
                         <a:t>371.4 / 201.4</a:t>
                       </a:r>
                     </a:p>
@@ -3637,28 +3592,6 @@
                           <a:latin typeface="Arial"/>
                         </a:rPr>
                         <a:t>116.8 / 68.1</a:t>
-                      </a:r>
-                    </a:p>
-                  </a:txBody>
-                  <a:tcPr marL="54864" marR="54864" marT="18288" marB="18288">
-                    <a:solidFill>
-                      <a:srgbClr val="ECF1F6"/>
-                    </a:solidFill>
-                  </a:tcPr>
-                </a:tc>
-                <a:tc>
-                  <a:txBody>
-                    <a:bodyPr wrap="square"/>
-                    <a:lstStyle/>
-                    <a:p>
-                      <a:r>
-                        <a:rPr sz="1100" b="0">
-                          <a:solidFill>
-                            <a:srgbClr val="282828"/>
-                          </a:solidFill>
-                          <a:latin typeface="Arial"/>
-                        </a:rPr>
-                        <a:t>(173.4 / 95.1)</a:t>
                       </a:r>
                     </a:p>
                   </a:txBody>
@@ -3770,28 +3703,6 @@
                           </a:solidFill>
                           <a:latin typeface="Arial"/>
                         </a:rPr>
-                        <a:t>(176.7 / 94.7)</a:t>
-                      </a:r>
-                    </a:p>
-                  </a:txBody>
-                  <a:tcPr marL="54864" marR="54864" marT="18288" marB="18288">
-                    <a:solidFill>
-                      <a:srgbClr val="FFFFFF"/>
-                    </a:solidFill>
-                  </a:tcPr>
-                </a:tc>
-                <a:tc>
-                  <a:txBody>
-                    <a:bodyPr wrap="square"/>
-                    <a:lstStyle/>
-                    <a:p>
-                      <a:r>
-                        <a:rPr sz="1100" b="0">
-                          <a:solidFill>
-                            <a:srgbClr val="282828"/>
-                          </a:solidFill>
-                          <a:latin typeface="Arial"/>
-                        </a:rPr>
                         <a:t>91.9 / 50.2</a:t>
                       </a:r>
                     </a:p>
@@ -3861,28 +3772,6 @@
                           <a:latin typeface="Arial"/>
                         </a:rPr>
                         <a:t>65.6 / 36.4</a:t>
-                      </a:r>
-                    </a:p>
-                  </a:txBody>
-                  <a:tcPr marL="54864" marR="54864" marT="18288" marB="18288">
-                    <a:solidFill>
-                      <a:srgbClr val="ECF1F6"/>
-                    </a:solidFill>
-                  </a:tcPr>
-                </a:tc>
-                <a:tc>
-                  <a:txBody>
-                    <a:bodyPr wrap="square"/>
-                    <a:lstStyle/>
-                    <a:p>
-                      <a:r>
-                        <a:rPr sz="1100" b="0">
-                          <a:solidFill>
-                            <a:srgbClr val="282828"/>
-                          </a:solidFill>
-                          <a:latin typeface="Arial"/>
-                        </a:rPr>
-                        <a:t>(115.9 / 56.9)</a:t>
                       </a:r>
                     </a:p>
                   </a:txBody>
@@ -3994,28 +3883,6 @@
                           </a:solidFill>
                           <a:latin typeface="Arial"/>
                         </a:rPr>
-                        <a:t>(100.5 / 54.4)</a:t>
-                      </a:r>
-                    </a:p>
-                  </a:txBody>
-                  <a:tcPr marL="54864" marR="54864" marT="18288" marB="18288">
-                    <a:solidFill>
-                      <a:srgbClr val="FFFFFF"/>
-                    </a:solidFill>
-                  </a:tcPr>
-                </a:tc>
-                <a:tc>
-                  <a:txBody>
-                    <a:bodyPr wrap="square"/>
-                    <a:lstStyle/>
-                    <a:p>
-                      <a:r>
-                        <a:rPr sz="1100" b="0">
-                          <a:solidFill>
-                            <a:srgbClr val="282828"/>
-                          </a:solidFill>
-                          <a:latin typeface="Arial"/>
-                        </a:rPr>
                         <a:t>39.8 / 22.1</a:t>
                       </a:r>
                     </a:p>
@@ -4221,7 +4088,7 @@
                 </a:solidFill>
                 <a:latin typeface="Arial"/>
               </a:rPr>
-              <a:t>Box max / avg, nm, at the .seq configuration; centroid reference primary, chief in parentheses.  Full record: design/rodgers1 — packet with 10 addenda, every retraction in place.</a:t>
+              <a:t>Box max / avg, nm, at the .seq configuration.  Piston + per-field tip/tilt removed = a centroid-referenced sphere (a chief-referenced sphere leaves the tilt in).  Full record: design/rodgers1 — packet with 10 addenda, every retraction in place.</a:t>
             </a:r>
           </a:p>
         </p:txBody>
@@ -9163,7 +9030,7 @@
                 </a:solidFill>
                 <a:latin typeface="Arial"/>
               </a:rPr>
-              <a:t>•  TMT, Keck and many space missions: Observatory modeling, including segmented-aperture systems, testbeds, instrument studies.</a:t>
+              <a:t>•  TMT, Keck and other space missions: Observatory modeling, including segmented-aperture systems, testbeds, instrument studies.</a:t>
             </a:r>
           </a:p>
           <a:p>
@@ -9179,7 +9046,7 @@
                 </a:solidFill>
                 <a:latin typeface="Arial"/>
               </a:rPr>
-              <a:t>–  Validated against testbed and flight data across those programs.</a:t>
+              <a:t>–  Validated against testbed and operational data across those programs.</a:t>
             </a:r>
           </a:p>
           <a:p>

</xml_diff>

<commit_message>
demo_session: edit deck + baseline synced (crop pass folded)
Co-Authored-By: Claude Fable 5 <noreply@anthropic.com>
</commit_message>
<xml_diff>
--- a/demo_session/baseline_pass3.pptx
+++ b/demo_session/baseline_pass3.pptx
@@ -9313,14 +9313,15 @@
         </p:nvPicPr>
         <p:blipFill>
           <a:blip r:embed="rId2"/>
+          <a:srcRect t="21300"/>
           <a:stretch>
             <a:fillRect/>
           </a:stretch>
         </p:blipFill>
         <p:spPr>
           <a:xfrm>
-            <a:off x="996696" y="2980944"/>
-            <a:ext cx="5175504" cy="2825496"/>
+            <a:off x="996696" y="3008376"/>
+            <a:ext cx="5175504" cy="2898648"/>
           </a:xfrm>
           <a:prstGeom prst="rect">
             <a:avLst/>
@@ -9421,8 +9422,8 @@
         </p:blipFill>
         <p:spPr>
           <a:xfrm>
-            <a:off x="7410184" y="3348989"/>
-            <a:ext cx="3376190" cy="2440432"/>
+            <a:off x="7406640" y="2971800"/>
+            <a:ext cx="3895344" cy="2816352"/>
           </a:xfrm>
           <a:prstGeom prst="rect">
             <a:avLst/>
@@ -9437,8 +9438,8 @@
         </p:nvSpPr>
         <p:spPr>
           <a:xfrm>
-            <a:off x="6400800" y="5807709"/>
-            <a:ext cx="5394960" cy="394208"/>
+            <a:off x="7406640" y="5806440"/>
+            <a:ext cx="3895344" cy="394208"/>
           </a:xfrm>
           <a:prstGeom prst="rect">
             <a:avLst/>
@@ -9666,14 +9667,15 @@
         </p:nvPicPr>
         <p:blipFill>
           <a:blip r:embed="rId2"/>
+          <a:srcRect l="29400" r="29400" t="4200" b="5900"/>
           <a:stretch>
             <a:fillRect/>
           </a:stretch>
         </p:blipFill>
         <p:spPr>
           <a:xfrm>
-            <a:off x="7086600" y="1371600"/>
-            <a:ext cx="3886200" cy="5413248"/>
+            <a:off x="7315200" y="1298448"/>
+            <a:ext cx="4114800" cy="5477256"/>
           </a:xfrm>
           <a:prstGeom prst="rect">
             <a:avLst/>

</xml_diff>

<commit_message>
deck: Linear Model Math slide inserted before the dwd*/MET/simulation block (Dave 2026-08-31)
w = w0 + J x with the three J families; m = [dl/dx; de/dx] x + n and
the trace(J Px J') layout merit; BLUE + ridge + integrator; the EFC
Tikhonov step da = -(Re(G'G)+lam I)^-1 Re(G'E).  All notation lifted
from run_sensitivities / the MET stage / r4_timeseries; footnote points
at jacobian_check closure.  Deck now 39 slides.

Co-Authored-By: Claude Fable 5 <noreply@anthropic.com>
</commit_message>
<xml_diff>
--- a/demo_session/baseline_pass3.pptx
+++ b/demo_session/baseline_pass3.pptx
@@ -43,6 +43,7 @@
     <p:sldId id="291" r:id="rId42"/>
     <p:sldId id="292" r:id="rId43"/>
     <p:sldId id="293" r:id="rId44"/>
+    <p:sldId id="294" r:id="rId45"/>
   </p:sldIdLst>
   <p:sldSz cx="12191695" cy="6858000" type="screen4x3"/>
   <p:notesSz cx="6858000" cy="9144000"/>
@@ -9521,7 +9522,7 @@
                 </a:solidFill>
                 <a:latin typeface="Arial"/>
               </a:rPr>
-              <a:t>Segmentation, metrology, controls — on the observatory</a:t>
+              <a:t>The linear model: the mathematics under the next six slides</a:t>
             </a:r>
           </a:p>
           <a:p>
@@ -9537,7 +9538,7 @@
                 </a:solidFill>
                 <a:latin typeface="Arial"/>
               </a:rPr>
-              <a:t>The same segmentation and metrology machinery the smaller studies proved, at 6 m scale</a:t>
+              <a:t>Every matrix is measured from the engine, then closure-checked against it</a:t>
             </a:r>
           </a:p>
         </p:txBody>
@@ -9595,7 +9596,7 @@
         <p:spPr>
           <a:xfrm>
             <a:off x="411480" y="1298448"/>
-            <a:ext cx="5806440" cy="274320"/>
+            <a:ext cx="11368735" cy="274320"/>
           </a:xfrm>
           <a:prstGeom prst="rect">
             <a:avLst/>
@@ -9614,13 +9615,29 @@
               </a:spcAft>
             </a:pPr>
             <a:r>
-              <a:rPr sz="1600" b="0">
+              <a:rPr sz="1500" b="0">
                 <a:solidFill>
                   <a:srgbClr val="282828"/>
                 </a:solidFill>
                 <a:latin typeface="Arial"/>
               </a:rPr>
-              <a:t>•  The primary segments hex-19 with physical apertures through the same segmentation product; every segment gets rigid-body and surface-figure sensitivity channels, stacked into one Jacobian — the control basis.</a:t>
+              <a:t>•  The wavefront model:   w  =  w₀ + J·x,    J = [ ∂w/∂x   ∂w/∂z   ∂w/∂grid ]</a:t>
+            </a:r>
+          </a:p>
+          <a:p>
+            <a:pPr marL="594360" indent="-137160">
+              <a:spcAft>
+                <a:spcPts val="500"/>
+              </a:spcAft>
+            </a:pPr>
+            <a:r>
+              <a:rPr sz="1300" b="0">
+                <a:solidFill>
+                  <a:srgbClr val="6E6E6E"/>
+                </a:solidFill>
+                <a:latin typeface="Arial"/>
+              </a:rPr>
+              <a:t>–  x stacks rigid-body states (6 DOF per optic and per group), segment Zernike figure modes, and grid/actuator influences; J's columns are engine-measured pokes through the full train, per field — the three families on the next three slides.</a:t>
             </a:r>
           </a:p>
           <a:p>
@@ -9630,13 +9647,29 @@
               </a:spcAft>
             </a:pPr>
             <a:r>
-              <a:rPr sz="1600" b="0">
+              <a:rPr sz="1500" b="0">
                 <a:solidFill>
                   <a:srgbClr val="282828"/>
                 </a:solidFill>
                 <a:latin typeface="Arial"/>
               </a:rPr>
-              <a:t>•  Metrology and edge sensors are designed ON that Jacobian — 114 beams from the launcher stations shown — and the same matrices drive the estimator and the closed loop.</a:t>
+              <a:t>•  The metrology forward model:   m  =  [ ∂l/∂x ; ∂e/∂x ]·x + n</a:t>
+            </a:r>
+          </a:p>
+          <a:p>
+            <a:pPr marL="594360" indent="-137160">
+              <a:spcAft>
+                <a:spcPts val="500"/>
+              </a:spcAft>
+            </a:pPr>
+            <a:r>
+              <a:rPr sz="1300" b="0">
+                <a:solidFill>
+                  <a:srgbClr val="6E6E6E"/>
+                </a:solidFill>
+                <a:latin typeface="Arial"/>
+              </a:rPr>
+              <a:t>–  laser-gauge lengths l and edge-sensor gaps e; a sensor layout is scored by the control information it carries — minimize trace( J Px̂ Jᵀ ), the wavefront error the estimator leaves behind.</a:t>
             </a:r>
           </a:p>
           <a:p>
@@ -9646,52 +9679,75 @@
               </a:spcAft>
             </a:pPr>
             <a:r>
-              <a:rPr sz="1600" b="0">
+              <a:rPr sz="1500" b="0">
                 <a:solidFill>
                   <a:srgbClr val="282828"/>
                 </a:solidFill>
                 <a:latin typeface="Arial"/>
               </a:rPr>
-              <a:t>•  The channels themselves — dw/dx, dw/dz, dw/dgrid — follow on the next three slides, at readable size.</a:t>
-            </a:r>
-          </a:p>
-        </p:txBody>
-      </p:sp>
-      <p:pic>
-        <p:nvPicPr>
-          <p:cNvPr id="5" name="Picture 4" descr="r3_met_view_rx.png"/>
-          <p:cNvPicPr>
-            <a:picLocks noChangeAspect="1"/>
-          </p:cNvPicPr>
-          <p:nvPr/>
-        </p:nvPicPr>
-        <p:blipFill>
-          <a:blip r:embed="rId2"/>
-          <a:srcRect l="29400" r="29400" t="4200" b="5900"/>
-          <a:stretch>
-            <a:fillRect/>
-          </a:stretch>
-        </p:blipFill>
-        <p:spPr>
-          <a:xfrm>
-            <a:off x="7315200" y="1298448"/>
-            <a:ext cx="4114800" cy="5477256"/>
-          </a:xfrm>
-          <a:prstGeom prst="rect">
-            <a:avLst/>
-          </a:prstGeom>
-        </p:spPr>
-      </p:pic>
-      <p:sp>
-        <p:nvSpPr>
-          <p:cNvPr id="6" name="TextBox 5"/>
+              <a:t>•  Estimation and control:   x̂  =  ( HᵀWH + ρI )⁻¹ HᵀW·m ;    u  ←  u − g·x̂</a:t>
+            </a:r>
+          </a:p>
+          <a:p>
+            <a:pPr marL="594360" indent="-137160">
+              <a:spcAft>
+                <a:spcPts val="500"/>
+              </a:spcAft>
+            </a:pPr>
+            <a:r>
+              <a:rPr sz="1300" b="0">
+                <a:solidFill>
+                  <a:srgbClr val="6E6E6E"/>
+                </a:solidFill>
+                <a:latin typeface="Arial"/>
+              </a:rPr>
+              <a:t>–  BLUE: weighted least squares with a ridge on the segment state; an integrator closes the rigid-body loop each frame.</a:t>
+            </a:r>
+          </a:p>
+          <a:p>
+            <a:pPr>
+              <a:spcAft>
+                <a:spcPts val="600"/>
+              </a:spcAft>
+            </a:pPr>
+            <a:r>
+              <a:rPr sz="1500" b="0">
+                <a:solidFill>
+                  <a:srgbClr val="282828"/>
+                </a:solidFill>
+                <a:latin typeface="Arial"/>
+              </a:rPr>
+              <a:t>•  Dark-hole control (EFC):   Δa  =  −( Re(GᴴG) + λI )⁻¹ Re(GᴴE)</a:t>
+            </a:r>
+          </a:p>
+          <a:p>
+            <a:pPr marL="594360" indent="-137160">
+              <a:spcAft>
+                <a:spcPts val="500"/>
+              </a:spcAft>
+            </a:pPr>
+            <a:r>
+              <a:rPr sz="1300" b="0">
+                <a:solidFill>
+                  <a:srgbClr val="6E6E6E"/>
+                </a:solidFill>
+                <a:latin typeface="Arial"/>
+              </a:rPr>
+              <a:t>–  G = ∂E/∂a, the electric-field Jacobian of the DM actuators through the masked chain, engine-measured; a Tikhonov step, line-searched against measured contrast.</a:t>
+            </a:r>
+          </a:p>
+        </p:txBody>
+      </p:sp>
+      <p:sp>
+        <p:nvSpPr>
+          <p:cNvPr id="5" name="TextBox 4"/>
           <p:cNvSpPr txBox="1"/>
           <p:nvPr/>
         </p:nvSpPr>
         <p:spPr>
           <a:xfrm>
-            <a:off x="4535424" y="4169663"/>
-            <a:ext cx="2514600" cy="1054608"/>
+            <a:off x="411480" y="4898898"/>
+            <a:ext cx="11368735" cy="274320"/>
           </a:xfrm>
           <a:prstGeom prst="rect">
             <a:avLst/>
@@ -9704,58 +9760,19 @@
           </a:bodyPr>
           <a:lstStyle/>
           <a:p>
-            <a:pPr algn="ctr">
-              <a:spcAft>
-                <a:spcPts val="0"/>
-              </a:spcAft>
-            </a:pPr>
-            <a:r>
-              <a:rPr sz="1500" b="0">
+            <a:pPr>
+              <a:spcAft>
+                <a:spcPts val="600"/>
+              </a:spcAft>
+            </a:pPr>
+            <a:r>
+              <a:rPr sz="1050" b="0">
                 <a:solidFill>
                   <a:srgbClr val="6E6E6E"/>
                 </a:solidFill>
                 <a:latin typeface="Arial"/>
               </a:rPr>
-              <a:t>The metrology on the observatory: 24 elements, 114 MET beams to the aft launcher station.</a:t>
-            </a:r>
-          </a:p>
-        </p:txBody>
-      </p:sp>
-      <p:sp>
-        <p:nvSpPr>
-          <p:cNvPr id="7" name="TextBox 6"/>
-          <p:cNvSpPr txBox="1"/>
-          <p:nvPr/>
-        </p:nvSpPr>
-        <p:spPr>
-          <a:xfrm>
-            <a:off x="3063240" y="6382512"/>
-            <a:ext cx="5394960" cy="274320"/>
-          </a:xfrm>
-          <a:prstGeom prst="rect">
-            <a:avLst/>
-          </a:prstGeom>
-          <a:noFill/>
-        </p:spPr>
-        <p:txBody>
-          <a:bodyPr wrap="square">
-            <a:spAutoFit/>
-          </a:bodyPr>
-          <a:lstStyle/>
-          <a:p>
-            <a:pPr>
-              <a:spcAft>
-                <a:spcPts val="600"/>
-              </a:spcAft>
-            </a:pPr>
-            <a:r>
-              <a:rPr sz="1050" b="0">
-                <a:solidFill>
-                  <a:srgbClr val="6E6E6E"/>
-                </a:solidFill>
-                <a:latin typeface="Arial"/>
-              </a:rPr>
-              <a:t>Record: templates/80_end_to_end/e2e6m_r2, sensitivities + MET stages.</a:t>
+              <a:t>Notation as in the code: run_sensitivities builds the J families; the MET stage scores layouts on the trace merit; the simulator (r4) runs the BLUE estimator, the integrator, and the EFC step — and jacobian_check re-pokes the engine against every J before it is trusted.</a:t>
             </a:r>
           </a:p>
         </p:txBody>
@@ -9812,7 +9829,7 @@
                 </a:solidFill>
                 <a:latin typeface="Arial"/>
               </a:rPr>
-              <a:t>The control basis I: rigid-body channels — dw/dx</a:t>
+              <a:t>Segmentation, metrology, controls — on the observatory</a:t>
             </a:r>
           </a:p>
           <a:p>
@@ -9828,7 +9845,7 @@
                 </a:solidFill>
                 <a:latin typeface="Arial"/>
               </a:rPr>
-              <a:t>Runner: macos.dw_dx_multi, harvested by run_sensitivities (stage r3) — OPD at the coronagraph exit pupil per unit rigid-body motion</a:t>
+              <a:t>The same segmentation and metrology machinery the smaller studies proved, at 6 m scale</a:t>
             </a:r>
           </a:p>
         </p:txBody>
@@ -9877,9 +9894,80 @@
           </a:p>
         </p:txBody>
       </p:sp>
+      <p:sp>
+        <p:nvSpPr>
+          <p:cNvPr id="4" name="TextBox 3"/>
+          <p:cNvSpPr txBox="1"/>
+          <p:nvPr/>
+        </p:nvSpPr>
+        <p:spPr>
+          <a:xfrm>
+            <a:off x="411480" y="1298448"/>
+            <a:ext cx="5806440" cy="274320"/>
+          </a:xfrm>
+          <a:prstGeom prst="rect">
+            <a:avLst/>
+          </a:prstGeom>
+          <a:noFill/>
+        </p:spPr>
+        <p:txBody>
+          <a:bodyPr wrap="square">
+            <a:spAutoFit/>
+          </a:bodyPr>
+          <a:lstStyle/>
+          <a:p>
+            <a:pPr>
+              <a:spcAft>
+                <a:spcPts val="600"/>
+              </a:spcAft>
+            </a:pPr>
+            <a:r>
+              <a:rPr sz="1600" b="0">
+                <a:solidFill>
+                  <a:srgbClr val="282828"/>
+                </a:solidFill>
+                <a:latin typeface="Arial"/>
+              </a:rPr>
+              <a:t>•  The primary segments hex-19 with physical apertures through the same segmentation product; every segment gets rigid-body and surface-figure sensitivity channels, stacked into one Jacobian — the control basis.</a:t>
+            </a:r>
+          </a:p>
+          <a:p>
+            <a:pPr>
+              <a:spcAft>
+                <a:spcPts val="600"/>
+              </a:spcAft>
+            </a:pPr>
+            <a:r>
+              <a:rPr sz="1600" b="0">
+                <a:solidFill>
+                  <a:srgbClr val="282828"/>
+                </a:solidFill>
+                <a:latin typeface="Arial"/>
+              </a:rPr>
+              <a:t>•  Metrology and edge sensors are designed ON that Jacobian — 114 beams from the launcher stations shown — and the same matrices drive the estimator and the closed loop.</a:t>
+            </a:r>
+          </a:p>
+          <a:p>
+            <a:pPr>
+              <a:spcAft>
+                <a:spcPts val="600"/>
+              </a:spcAft>
+            </a:pPr>
+            <a:r>
+              <a:rPr sz="1600" b="0">
+                <a:solidFill>
+                  <a:srgbClr val="282828"/>
+                </a:solidFill>
+                <a:latin typeface="Arial"/>
+              </a:rPr>
+              <a:t>•  The channels themselves — dw/dx, dw/dz, dw/dgrid — follow on the next three slides, at readable size.</a:t>
+            </a:r>
+          </a:p>
+        </p:txBody>
+      </p:sp>
       <p:pic>
         <p:nvPicPr>
-          <p:cNvPr id="4" name="Picture 3" descr="fig_dwdx_read.png"/>
+          <p:cNvPr id="5" name="Picture 4" descr="r3_met_view_rx.png"/>
           <p:cNvPicPr>
             <a:picLocks noChangeAspect="1"/>
           </p:cNvPicPr>
@@ -9887,14 +9975,15 @@
         </p:nvPicPr>
         <p:blipFill>
           <a:blip r:embed="rId2"/>
+          <a:srcRect l="29400" r="29400" t="4200" b="5900"/>
           <a:stretch>
             <a:fillRect/>
           </a:stretch>
         </p:blipFill>
         <p:spPr>
           <a:xfrm>
-            <a:off x="948630" y="1298448"/>
-            <a:ext cx="10294434" cy="2732532"/>
+            <a:off x="7315200" y="1298448"/>
+            <a:ext cx="4114800" cy="5477256"/>
           </a:xfrm>
           <a:prstGeom prst="rect">
             <a:avLst/>
@@ -9903,14 +9992,14 @@
       </p:pic>
       <p:sp>
         <p:nvSpPr>
-          <p:cNvPr id="5" name="TextBox 4"/>
+          <p:cNvPr id="6" name="TextBox 5"/>
           <p:cNvSpPr txBox="1"/>
           <p:nvPr/>
         </p:nvSpPr>
         <p:spPr>
           <a:xfrm>
-            <a:off x="411480" y="4049267"/>
-            <a:ext cx="11368735" cy="608838"/>
+            <a:off x="4535424" y="4169663"/>
+            <a:ext cx="2514600" cy="1054608"/>
           </a:xfrm>
           <a:prstGeom prst="rect">
             <a:avLst/>
@@ -9929,27 +10018,27 @@
               </a:spcAft>
             </a:pPr>
             <a:r>
-              <a:rPr sz="1100" b="0">
+              <a:rPr sz="1500" b="0">
                 <a:solidFill>
                   <a:srgbClr val="6E6E6E"/>
                 </a:solidFill>
                 <a:latin typeface="Arial"/>
               </a:rPr>
-              <a:t>Two rigid-body channels: the centre segment (E1) and an outer-ring segment (E8), x-rotation — the centre-field OPD at full size, then the same channel at all five fields, every pupil full.  Drawn from the round-1-train harvest, whose stops pass the whole box; the r2-train harvest matches at the centre field, but its DM-bearing coronagraph clips the corners — that instrument works the centre field.  Piston removed; 1–99% color scale.</a:t>
-            </a:r>
-          </a:p>
-        </p:txBody>
-      </p:sp>
-      <p:sp>
-        <p:nvSpPr>
-          <p:cNvPr id="6" name="TextBox 5"/>
+              <a:t>The metrology on the observatory: 24 elements, 114 MET beams to the aft launcher station.</a:t>
+            </a:r>
+          </a:p>
+        </p:txBody>
+      </p:sp>
+      <p:sp>
+        <p:nvSpPr>
+          <p:cNvPr id="7" name="TextBox 6"/>
           <p:cNvSpPr txBox="1"/>
           <p:nvPr/>
         </p:nvSpPr>
         <p:spPr>
           <a:xfrm>
-            <a:off x="411480" y="4694682"/>
-            <a:ext cx="11368735" cy="274320"/>
+            <a:off x="3063240" y="6382512"/>
+            <a:ext cx="5394960" cy="274320"/>
           </a:xfrm>
           <a:prstGeom prst="rect">
             <a:avLst/>
@@ -9968,52 +10057,13 @@
               </a:spcAft>
             </a:pPr>
             <a:r>
-              <a:rPr sz="1500" b="0">
-                <a:solidFill>
-                  <a:srgbClr val="282828"/>
-                </a:solidFill>
-                <a:latin typeface="Arial"/>
-              </a:rPr>
-              <a:t>•  Six rigid-body DOFs for every optic — the 19 segments, M2-M4, both DMs, the 8 OAPs — plus the whole primary as one rigid group, five fields each, stacked into the control Jacobian.  The response lives on the moved segment's footprint and walks with field.  The coronagraph works the center field only — its stops vignette the corners; the imaging leg sees the full box.</a:t>
-            </a:r>
-          </a:p>
-        </p:txBody>
-      </p:sp>
-      <p:sp>
-        <p:nvSpPr>
-          <p:cNvPr id="7" name="TextBox 6"/>
-          <p:cNvSpPr txBox="1"/>
-          <p:nvPr/>
-        </p:nvSpPr>
-        <p:spPr>
-          <a:xfrm>
-            <a:off x="411480" y="5862065"/>
-            <a:ext cx="11368735" cy="274320"/>
-          </a:xfrm>
-          <a:prstGeom prst="rect">
-            <a:avLst/>
-          </a:prstGeom>
-          <a:noFill/>
-        </p:spPr>
-        <p:txBody>
-          <a:bodyPr wrap="square">
-            <a:spAutoFit/>
-          </a:bodyPr>
-          <a:lstStyle/>
-          <a:p>
-            <a:pPr>
-              <a:spcAft>
-                <a:spcPts val="600"/>
-              </a:spcAft>
-            </a:pPr>
-            <a:r>
-              <a:rPr sz="1200" b="0">
+              <a:rPr sz="1050" b="0">
                 <a:solidFill>
                   <a:srgbClr val="6E6E6E"/>
                 </a:solidFill>
                 <a:latin typeface="Arial"/>
               </a:rPr>
-              <a:t>Harvest on r1_seg_prop.in, the deck the simulator propagates; per-field FEX reset; closure gated by jacobian_check.  Every panel is one line from the saved Jacobian: OPD = v2m(dwdx(:,k), indx).  Record: templates/80_end_to_end/e2e6m_r2.</a:t>
+              <a:t>Record: templates/80_end_to_end/e2e6m_r2, sensitivities + MET stages.</a:t>
             </a:r>
           </a:p>
         </p:txBody>
@@ -10070,7 +10120,7 @@
                 </a:solidFill>
                 <a:latin typeface="Arial"/>
               </a:rPr>
-              <a:t>The control basis II: segment-figure channels — dw/dz</a:t>
+              <a:t>The control basis I: rigid-body channels — dw/dx</a:t>
             </a:r>
           </a:p>
           <a:p>
@@ -10086,7 +10136,7 @@
                 </a:solidFill>
                 <a:latin typeface="Arial"/>
               </a:rPr>
-              <a:t>Runner: macos.dw_dz_zernike_multi, harvested by run_sensitivities (stage r3) — MonZernike modes 4–11 on each segment</a:t>
+              <a:t>Runner: macos.dw_dx_multi, harvested by run_sensitivities (stage r3) — OPD at the coronagraph exit pupil per unit rigid-body motion</a:t>
             </a:r>
           </a:p>
         </p:txBody>
@@ -10137,7 +10187,7 @@
       </p:sp>
       <p:pic>
         <p:nvPicPr>
-          <p:cNvPr id="4" name="Picture 3" descr="fig_dwdz_read.png"/>
+          <p:cNvPr id="4" name="Picture 3" descr="fig_dwdx_read.png"/>
           <p:cNvPicPr>
             <a:picLocks noChangeAspect="1"/>
           </p:cNvPicPr>
@@ -10151,8 +10201,8 @@
         </p:blipFill>
         <p:spPr>
           <a:xfrm>
-            <a:off x="637634" y="1298448"/>
-            <a:ext cx="10916426" cy="2897632"/>
+            <a:off x="948630" y="1298448"/>
+            <a:ext cx="10294434" cy="2732532"/>
           </a:xfrm>
           <a:prstGeom prst="rect">
             <a:avLst/>
@@ -10167,8 +10217,8 @@
         </p:nvSpPr>
         <p:spPr>
           <a:xfrm>
-            <a:off x="411480" y="4214367"/>
-            <a:ext cx="11368735" cy="493268"/>
+            <a:off x="411480" y="4049267"/>
+            <a:ext cx="11368735" cy="608838"/>
           </a:xfrm>
           <a:prstGeom prst="rect">
             <a:avLst/>
@@ -10187,13 +10237,13 @@
               </a:spcAft>
             </a:pPr>
             <a:r>
-              <a:rPr sz="1300" b="0">
+              <a:rPr sz="1100" b="0">
                 <a:solidFill>
                   <a:srgbClr val="6E6E6E"/>
                 </a:solidFill>
                 <a:latin typeface="Arial"/>
               </a:rPr>
-              <a:t>Two of the 152 channels: segments E1 and E8, MonZernike mode 4 — the centre field at full size, then all five fields (round-1-train harvest, full pupils).  Piston removed; 1–99% color scale.</a:t>
+              <a:t>Two rigid-body channels: the centre segment (E1) and an outer-ring segment (E8), x-rotation — the centre-field OPD at full size, then the same channel at all five fields, every pupil full.  Drawn from the round-1-train harvest, whose stops pass the whole box; the r2-train harvest matches at the centre field, but its DM-bearing coronagraph clips the corners — that instrument works the centre field.  Piston removed; 1–99% color scale.</a:t>
             </a:r>
           </a:p>
         </p:txBody>
@@ -10206,7 +10256,7 @@
         </p:nvSpPr>
         <p:spPr>
           <a:xfrm>
-            <a:off x="411480" y="4744211"/>
+            <a:off x="411480" y="4694682"/>
             <a:ext cx="11368735" cy="274320"/>
           </a:xfrm>
           <a:prstGeom prst="rect">
@@ -10232,39 +10282,7 @@
                 </a:solidFill>
                 <a:latin typeface="Arial"/>
               </a:rPr>
-              <a:t>•  Zernike figure modes 4–11 on each of the 19 segments, M2-M4, the 8 OAPs — five fields each.  Each channel is confined to its own segment; the mode shape is visible at a glance.</a:t>
-            </a:r>
-          </a:p>
-          <a:p>
-            <a:pPr>
-              <a:spcAft>
-                <a:spcPts val="600"/>
-              </a:spcAft>
-            </a:pPr>
-            <a:r>
-              <a:rPr sz="1500" b="0">
-                <a:solidFill>
-                  <a:srgbClr val="282828"/>
-                </a:solidFill>
-                <a:latin typeface="Arial"/>
-              </a:rPr>
-              <a:t>•  Any element can have deformations described by up to 65 Zernike modes.</a:t>
-            </a:r>
-          </a:p>
-          <a:p>
-            <a:pPr>
-              <a:spcAft>
-                <a:spcPts val="600"/>
-              </a:spcAft>
-            </a:pPr>
-            <a:r>
-              <a:rPr sz="1500" b="0">
-                <a:solidFill>
-                  <a:srgbClr val="282828"/>
-                </a:solidFill>
-                <a:latin typeface="Arial"/>
-              </a:rPr>
-              <a:t>•  MACOS supports 4 types of Zernikes, in normalized or raw forms.</a:t>
+              <a:t>•  Six rigid-body DOFs for every optic — the 19 segments, M2-M4, both DMs, the 8 OAPs — plus the whole primary as one rigid group, five fields each, stacked into the control Jacobian.  The response lives on the moved segment's footprint and walks with field.  The coronagraph works the center field only — its stops vignette the corners; the imaging leg sees the full box.</a:t>
             </a:r>
           </a:p>
         </p:txBody>
@@ -10277,7 +10295,7 @@
         </p:nvSpPr>
         <p:spPr>
           <a:xfrm>
-            <a:off x="411480" y="6192011"/>
+            <a:off x="411480" y="5862065"/>
             <a:ext cx="11368735" cy="274320"/>
           </a:xfrm>
           <a:prstGeom prst="rect">
@@ -10297,13 +10315,13 @@
               </a:spcAft>
             </a:pPr>
             <a:r>
-              <a:rPr sz="1300" b="0">
+              <a:rPr sz="1200" b="0">
                 <a:solidFill>
                   <a:srgbClr val="6E6E6E"/>
                 </a:solidFill>
                 <a:latin typeface="Arial"/>
               </a:rPr>
-              <a:t>Same harvest, metric and gates as dw/dx.  Record: templates/80_end_to_end/e2e6m_r2.</a:t>
+              <a:t>Harvest on r1_seg_prop.in, the deck the simulator propagates; per-field FEX reset; closure gated by jacobian_check.  Every panel is one line from the saved Jacobian: OPD = v2m(dwdx(:,k), indx).  Record: templates/80_end_to_end/e2e6m_r2.</a:t>
             </a:r>
           </a:p>
         </p:txBody>
@@ -10360,7 +10378,7 @@
                 </a:solidFill>
                 <a:latin typeface="Arial"/>
               </a:rPr>
-              <a:t>The control basis III: shape-normalized modes — dw/dgrid</a:t>
+              <a:t>The control basis II: segment-figure channels — dw/dz</a:t>
             </a:r>
           </a:p>
           <a:p>
@@ -10376,7 +10394,7 @@
                 </a:solidFill>
                 <a:latin typeface="Arial"/>
               </a:rPr>
-              <a:t>Runner: macos.dw_dgrid_multi, harvested by run_sensitivities (stage r3) — the grid influence basis on each segment</a:t>
+              <a:t>Runner: macos.dw_dz_zernike_multi, harvested by run_sensitivities (stage r3) — MonZernike modes 4–11 on each segment</a:t>
             </a:r>
           </a:p>
         </p:txBody>
@@ -10427,7 +10445,7 @@
       </p:sp>
       <p:pic>
         <p:nvPicPr>
-          <p:cNvPr id="4" name="Picture 3" descr="fig_dwdgrid_read.png"/>
+          <p:cNvPr id="4" name="Picture 3" descr="fig_dwdz_read.png"/>
           <p:cNvPicPr>
             <a:picLocks noChangeAspect="1"/>
           </p:cNvPicPr>
@@ -10458,7 +10476,7 @@
         <p:spPr>
           <a:xfrm>
             <a:off x="411480" y="4214367"/>
-            <a:ext cx="11368735" cy="460248"/>
+            <a:ext cx="11368735" cy="493268"/>
           </a:xfrm>
           <a:prstGeom prst="rect">
             <a:avLst/>
@@ -10477,13 +10495,13 @@
               </a:spcAft>
             </a:pPr>
             <a:r>
-              <a:rPr sz="1200" b="0">
+              <a:rPr sz="1300" b="0">
                 <a:solidFill>
                   <a:srgbClr val="6E6E6E"/>
                 </a:solidFill>
                 <a:latin typeface="Arial"/>
               </a:rPr>
-              <a:t>Two of the 114 channels: segments E1 and E8, grid mode 4 — the centre field at full size, then all five fields (round-1-train harvest, full pupils).  Piston removed; 1–99% color scale.</a:t>
+              <a:t>Two of the 152 channels: segments E1 and E8, MonZernike mode 4 — the centre field at full size, then all five fields (round-1-train harvest, full pupils).  Piston removed; 1–99% color scale.</a:t>
             </a:r>
           </a:p>
         </p:txBody>
@@ -10496,7 +10514,7 @@
         </p:nvSpPr>
         <p:spPr>
           <a:xfrm>
-            <a:off x="411480" y="4711192"/>
+            <a:off x="411480" y="4744211"/>
             <a:ext cx="11368735" cy="274320"/>
           </a:xfrm>
           <a:prstGeom prst="rect">
@@ -10522,7 +10540,7 @@
                 </a:solidFill>
                 <a:latin typeface="Arial"/>
               </a:rPr>
-              <a:t>•  GridData surfaces can be used to add nearly any surface departure form: as-measured aberrations, Gram-Schmidt orthogonalized Zernike modes, and DM actuations are all used in coronagraphic telescope models.</a:t>
+              <a:t>•  Zernike figure modes 4–11 on each of the 19 segments, M2-M4, the 8 OAPs — five fields each.  Each channel is confined to its own segment; the mode shape is visible at a glance.</a:t>
             </a:r>
           </a:p>
           <a:p>
@@ -10538,7 +10556,23 @@
                 </a:solidFill>
                 <a:latin typeface="Arial"/>
               </a:rPr>
-              <a:t>•  These plots illustrate grid-basis influence shapes on 2 of the 19 segments, using the interface for measured influence functions and actuator maps — the same machinery the DM Jacobians use.</a:t>
+              <a:t>•  Any element can have deformations described by up to 65 Zernike modes.</a:t>
+            </a:r>
+          </a:p>
+          <a:p>
+            <a:pPr>
+              <a:spcAft>
+                <a:spcPts val="600"/>
+              </a:spcAft>
+            </a:pPr>
+            <a:r>
+              <a:rPr sz="1500" b="0">
+                <a:solidFill>
+                  <a:srgbClr val="282828"/>
+                </a:solidFill>
+                <a:latin typeface="Arial"/>
+              </a:rPr>
+              <a:t>•  MACOS supports 4 types of Zernikes, in normalized or raw forms.</a:t>
             </a:r>
           </a:p>
         </p:txBody>
@@ -10551,7 +10585,7 @@
         </p:nvSpPr>
         <p:spPr>
           <a:xfrm>
-            <a:off x="411480" y="6018784"/>
+            <a:off x="411480" y="6192011"/>
             <a:ext cx="11368735" cy="274320"/>
           </a:xfrm>
           <a:prstGeom prst="rect">
@@ -10634,7 +10668,7 @@
                 </a:solidFill>
                 <a:latin typeface="Arial"/>
               </a:rPr>
-              <a:t>A randomly disturbed observatory, simulated</a:t>
+              <a:t>The control basis III: shape-normalized modes — dw/dgrid</a:t>
             </a:r>
           </a:p>
           <a:p>
@@ -10650,7 +10684,7 @@
                 </a:solidFill>
                 <a:latin typeface="Arial"/>
               </a:rPr>
-              <a:t>The closed loop holds dark-zone contrast at 2.5×10⁻⁷ where the uncontrolled series drifts to 1.7×10⁻⁶</a:t>
+              <a:t>Runner: macos.dw_dgrid_multi, harvested by run_sensitivities (stage r3) — the grid influence basis on each segment</a:t>
             </a:r>
           </a:p>
         </p:txBody>
@@ -10699,80 +10733,9 @@
           </a:p>
         </p:txBody>
       </p:sp>
-      <p:sp>
-        <p:nvSpPr>
-          <p:cNvPr id="4" name="TextBox 3"/>
-          <p:cNvSpPr txBox="1"/>
-          <p:nvPr/>
-        </p:nvSpPr>
-        <p:spPr>
-          <a:xfrm>
-            <a:off x="411480" y="1298448"/>
-            <a:ext cx="5806440" cy="274320"/>
-          </a:xfrm>
-          <a:prstGeom prst="rect">
-            <a:avLst/>
-          </a:prstGeom>
-          <a:noFill/>
-        </p:spPr>
-        <p:txBody>
-          <a:bodyPr wrap="square">
-            <a:spAutoFit/>
-          </a:bodyPr>
-          <a:lstStyle/>
-          <a:p>
-            <a:pPr>
-              <a:spcAft>
-                <a:spcPts val="600"/>
-              </a:spcAft>
-            </a:pPr>
-            <a:r>
-              <a:rPr sz="1200" b="0">
-                <a:solidFill>
-                  <a:srgbClr val="282828"/>
-                </a:solidFill>
-                <a:latin typeface="Arial"/>
-              </a:rPr>
-              <a:t>•  Random segment drift is injected; the rigid-body loop senses through the designed metrology, estimates and corrects, while EFC re-solves the dark zone per scored frame — all on one model.</a:t>
-            </a:r>
-          </a:p>
-          <a:p>
-            <a:pPr>
-              <a:spcAft>
-                <a:spcPts val="600"/>
-              </a:spcAft>
-            </a:pPr>
-            <a:r>
-              <a:rPr sz="1200" b="0">
-                <a:solidFill>
-                  <a:srgbClr val="282828"/>
-                </a:solidFill>
-                <a:latin typeface="Arial"/>
-              </a:rPr>
-              <a:t>•  The disturbance interface is the point: the same channels are built to ingest dynamical- and thermal-model time histories — simulating performance in the space environment.  Work in progress.</a:t>
-            </a:r>
-          </a:p>
-          <a:p>
-            <a:pPr>
-              <a:spcAft>
-                <a:spcPts val="600"/>
-              </a:spcAft>
-            </a:pPr>
-            <a:r>
-              <a:rPr sz="1200" b="0">
-                <a:solidFill>
-                  <a:srgbClr val="282828"/>
-                </a:solidFill>
-                <a:latin typeface="Arial"/>
-              </a:rPr>
-              <a:t>•  Honest gap, attributed: the segmented-pupil contrast floor sits above the clear-pupil testbed's — the gaps and edges carry it, not the control.</a:t>
-            </a:r>
-          </a:p>
-        </p:txBody>
-      </p:sp>
       <p:pic>
         <p:nvPicPr>
-          <p:cNvPr id="5" name="Picture 4" descr="r4_series_3nm.png"/>
+          <p:cNvPr id="4" name="Picture 3" descr="fig_dwdgrid_read.png"/>
           <p:cNvPicPr>
             <a:picLocks noChangeAspect="1"/>
           </p:cNvPicPr>
@@ -10786,8 +10749,8 @@
         </p:blipFill>
         <p:spPr>
           <a:xfrm>
-            <a:off x="6923477" y="1298448"/>
-            <a:ext cx="4349605" cy="4177792"/>
+            <a:off x="637634" y="1298448"/>
+            <a:ext cx="10916426" cy="2897632"/>
           </a:xfrm>
           <a:prstGeom prst="rect">
             <a:avLst/>
@@ -10796,14 +10759,14 @@
       </p:pic>
       <p:sp>
         <p:nvSpPr>
-          <p:cNvPr id="6" name="TextBox 5"/>
+          <p:cNvPr id="5" name="TextBox 4"/>
           <p:cNvSpPr txBox="1"/>
           <p:nvPr/>
         </p:nvSpPr>
         <p:spPr>
           <a:xfrm>
-            <a:off x="6400800" y="5494528"/>
-            <a:ext cx="5394960" cy="394208"/>
+            <a:off x="411480" y="4214367"/>
+            <a:ext cx="11368735" cy="460248"/>
           </a:xfrm>
           <a:prstGeom prst="rect">
             <a:avLst/>
@@ -10822,27 +10785,27 @@
               </a:spcAft>
             </a:pPr>
             <a:r>
-              <a:rPr sz="1000" b="0">
+              <a:rPr sz="1200" b="0">
                 <a:solidFill>
                   <a:srgbClr val="6E6E6E"/>
                 </a:solidFill>
                 <a:latin typeface="Arial"/>
               </a:rPr>
-              <a:t>Four hundred seconds under drift: segment rigid-body state, wavefront at the coronagraph exit pupil, and science-plane contrast — open loop against closed.</a:t>
-            </a:r>
-          </a:p>
-        </p:txBody>
-      </p:sp>
-      <p:sp>
-        <p:nvSpPr>
-          <p:cNvPr id="7" name="TextBox 6"/>
+              <a:t>Two of the 114 channels: segments E1 and E8, grid mode 4 — the centre field at full size, then all five fields (round-1-train harvest, full pupils).  Piston removed; 1–99% color scale.</a:t>
+            </a:r>
+          </a:p>
+        </p:txBody>
+      </p:sp>
+      <p:sp>
+        <p:nvSpPr>
+          <p:cNvPr id="6" name="TextBox 5"/>
           <p:cNvSpPr txBox="1"/>
           <p:nvPr/>
         </p:nvSpPr>
         <p:spPr>
           <a:xfrm>
-            <a:off x="6400800" y="5925312"/>
-            <a:ext cx="5394960" cy="274320"/>
+            <a:off x="411480" y="4711192"/>
+            <a:ext cx="11368735" cy="274320"/>
           </a:xfrm>
           <a:prstGeom prst="rect">
             <a:avLst/>
@@ -10861,13 +10824,68 @@
               </a:spcAft>
             </a:pPr>
             <a:r>
-              <a:rPr sz="1050" b="0">
+              <a:rPr sz="1500" b="0">
+                <a:solidFill>
+                  <a:srgbClr val="282828"/>
+                </a:solidFill>
+                <a:latin typeface="Arial"/>
+              </a:rPr>
+              <a:t>•  GridData surfaces can be used to add nearly any surface departure form: as-measured aberrations, Gram-Schmidt orthogonalized Zernike modes, and DM actuations are all used in coronagraphic telescope models.</a:t>
+            </a:r>
+          </a:p>
+          <a:p>
+            <a:pPr>
+              <a:spcAft>
+                <a:spcPts val="600"/>
+              </a:spcAft>
+            </a:pPr>
+            <a:r>
+              <a:rPr sz="1500" b="0">
+                <a:solidFill>
+                  <a:srgbClr val="282828"/>
+                </a:solidFill>
+                <a:latin typeface="Arial"/>
+              </a:rPr>
+              <a:t>•  These plots illustrate grid-basis influence shapes on 2 of the 19 segments, using the interface for measured influence functions and actuator maps — the same machinery the DM Jacobians use.</a:t>
+            </a:r>
+          </a:p>
+        </p:txBody>
+      </p:sp>
+      <p:sp>
+        <p:nvSpPr>
+          <p:cNvPr id="7" name="TextBox 6"/>
+          <p:cNvSpPr txBox="1"/>
+          <p:nvPr/>
+        </p:nvSpPr>
+        <p:spPr>
+          <a:xfrm>
+            <a:off x="411480" y="6018784"/>
+            <a:ext cx="11368735" cy="274320"/>
+          </a:xfrm>
+          <a:prstGeom prst="rect">
+            <a:avLst/>
+          </a:prstGeom>
+          <a:noFill/>
+        </p:spPr>
+        <p:txBody>
+          <a:bodyPr wrap="square">
+            <a:spAutoFit/>
+          </a:bodyPr>
+          <a:lstStyle/>
+          <a:p>
+            <a:pPr>
+              <a:spcAft>
+                <a:spcPts val="600"/>
+              </a:spcAft>
+            </a:pPr>
+            <a:r>
+              <a:rPr sz="1300" b="0">
                 <a:solidFill>
                   <a:srgbClr val="6E6E6E"/>
                 </a:solidFill>
                 <a:latin typeface="Arial"/>
               </a:rPr>
-              <a:t>Record: templates/80_end_to_end/e2e6m_r2, time-series stage.</a:t>
+              <a:t>Same harvest, metric and gates as dw/dx.  Record: templates/80_end_to_end/e2e6m_r2.</a:t>
             </a:r>
           </a:p>
         </p:txBody>
@@ -10924,7 +10942,7 @@
                 </a:solidFill>
                 <a:latin typeface="Arial"/>
               </a:rPr>
-              <a:t>The live design, revealed</a:t>
+              <a:t>A randomly disturbed observatory, simulated</a:t>
             </a:r>
           </a:p>
           <a:p>
@@ -10940,7 +10958,7 @@
                 </a:solidFill>
                 <a:latin typeface="Arial"/>
               </a:rPr>
-              <a:t>Predicted from the frontier before solving; solved in one warm-started step while we talked</a:t>
+              <a:t>The closed loop holds dark-zone contrast at 2.5×10⁻⁷ where the uncontrolled series drifts to 1.7×10⁻⁶</a:t>
             </a:r>
           </a:p>
         </p:txBody>
@@ -11023,7 +11041,7 @@
                 </a:solidFill>
                 <a:latin typeface="Arial"/>
               </a:rPr>
-              <a:t>•  The ask: a field-box width, anywhere in 5–15°.  The prediction, stated before the solve: interpolated from the committed frontier rows.</a:t>
+              <a:t>•  Random segment drift is injected; the rigid-body loop senses through the designed metrology, estimates and corrects, while EFC re-solves the dark zone per scored frame — all on one model.</a:t>
             </a:r>
           </a:p>
           <a:p>
@@ -11039,7 +11057,7 @@
                 </a:solidFill>
                 <a:latin typeface="Arial"/>
               </a:rPr>
-              <a:t>•  The pre-run rehearsal of the default ask (12°): predicted 33.7 nm; solved 33.6 nm — 1.00× — at a 24.9 mm clearance floor, both checks pass, in 15 minutes.</a:t>
+              <a:t>•  The disturbance interface is the point: the same channels are built to ingest dynamical- and thermal-model time histories — simulating performance in the space environment.  Work in progress.</a:t>
             </a:r>
           </a:p>
           <a:p>
@@ -11055,14 +11073,14 @@
                 </a:solidFill>
                 <a:latin typeface="Arial"/>
               </a:rPr>
-              <a:t>•  The run is deterministic to every printed digit, and every ask is a genuine continuation step — never a re-score of a stored design.</a:t>
+              <a:t>•  Honest gap, attributed: the segmented-pupil contrast floor sits above the clear-pupil testbed's — the gaps and edges carry it, not the control.</a:t>
             </a:r>
           </a:p>
         </p:txBody>
       </p:sp>
       <p:pic>
         <p:nvPicPr>
-          <p:cNvPr id="5" name="Picture 4" descr="oi_demo_12deg_layout.png"/>
+          <p:cNvPr id="5" name="Picture 4" descr="r4_series_3nm.png"/>
           <p:cNvPicPr>
             <a:picLocks noChangeAspect="1"/>
           </p:cNvPicPr>
@@ -11076,8 +11094,8 @@
         </p:blipFill>
         <p:spPr>
           <a:xfrm>
-            <a:off x="8000103" y="1298448"/>
-            <a:ext cx="2196352" cy="1891792"/>
+            <a:off x="6923477" y="1298448"/>
+            <a:ext cx="4349605" cy="4177792"/>
           </a:xfrm>
           <a:prstGeom prst="rect">
             <a:avLst/>
@@ -11092,7 +11110,7 @@
         </p:nvSpPr>
         <p:spPr>
           <a:xfrm>
-            <a:off x="6400800" y="3208528"/>
+            <a:off x="6400800" y="5494528"/>
             <a:ext cx="5394960" cy="394208"/>
           </a:xfrm>
           <a:prstGeom prst="rect">
@@ -11118,44 +11136,20 @@
                 </a:solidFill>
                 <a:latin typeface="Arial"/>
               </a:rPr>
-              <a:t>The 12° rehearsal design and its field map: 33.6 nm max against a 33.7 nm prediction.</a:t>
-            </a:r>
-          </a:p>
-        </p:txBody>
-      </p:sp>
-      <p:pic>
-        <p:nvPicPr>
-          <p:cNvPr id="7" name="Picture 6" descr="oi_demo_12deg_map.png"/>
-          <p:cNvPicPr>
-            <a:picLocks noChangeAspect="1"/>
-          </p:cNvPicPr>
-          <p:nvPr/>
-        </p:nvPicPr>
-        <p:blipFill>
-          <a:blip r:embed="rId3"/>
-          <a:stretch>
-            <a:fillRect/>
-          </a:stretch>
-        </p:blipFill>
-        <p:spPr>
-          <a:xfrm>
-            <a:off x="7951092" y="3639312"/>
-            <a:ext cx="2294375" cy="2011680"/>
-          </a:xfrm>
-          <a:prstGeom prst="rect">
-            <a:avLst/>
-          </a:prstGeom>
-        </p:spPr>
-      </p:pic>
-      <p:sp>
-        <p:nvSpPr>
-          <p:cNvPr id="8" name="TextBox 7"/>
+              <a:t>Four hundred seconds under drift: segment rigid-body state, wavefront at the coronagraph exit pupil, and science-plane contrast — open loop against closed.</a:t>
+            </a:r>
+          </a:p>
+        </p:txBody>
+      </p:sp>
+      <p:sp>
+        <p:nvSpPr>
+          <p:cNvPr id="7" name="TextBox 6"/>
           <p:cNvSpPr txBox="1"/>
           <p:nvPr/>
         </p:nvSpPr>
         <p:spPr>
           <a:xfrm>
-            <a:off x="6400800" y="5650992"/>
+            <a:off x="6400800" y="5925312"/>
             <a:ext cx="5394960" cy="274320"/>
           </a:xfrm>
           <a:prstGeom prst="rect">
@@ -11181,7 +11175,7 @@
                 </a:solidFill>
                 <a:latin typeface="Arial"/>
               </a:rPr>
-              <a:t>On demo day the live run's figures replace these panels; this pre-generated bundle is the fallback if the room's ask matches nothing better.</a:t>
+              <a:t>Record: templates/80_end_to_end/e2e6m_r2, time-series stage.</a:t>
             </a:r>
           </a:p>
         </p:txBody>
@@ -11238,7 +11232,7 @@
                 </a:solidFill>
                 <a:latin typeface="Arial"/>
               </a:rPr>
-              <a:t>AI in design and analysis — the working questions</a:t>
+              <a:t>The live design, revealed</a:t>
             </a:r>
           </a:p>
           <a:p>
@@ -11254,7 +11248,7 @@
                 </a:solidFill>
                 <a:latin typeface="Arial"/>
               </a:rPr>
-              <a:t>What we ask of an AI-driven study before believing it</a:t>
+              <a:t>Predicted from the frontier before solving; solved in one warm-started step while we talked</a:t>
             </a:r>
           </a:p>
         </p:txBody>
@@ -11312,7 +11306,7 @@
         <p:spPr>
           <a:xfrm>
             <a:off x="411480" y="1298448"/>
-            <a:ext cx="11368735" cy="274320"/>
+            <a:ext cx="5806440" cy="274320"/>
           </a:xfrm>
           <a:prstGeom prst="rect">
             <a:avLst/>
@@ -11331,13 +11325,13 @@
               </a:spcAft>
             </a:pPr>
             <a:r>
-              <a:rPr sz="1500" b="0">
+              <a:rPr sz="1200" b="0">
                 <a:solidFill>
                   <a:srgbClr val="282828"/>
                 </a:solidFill>
                 <a:latin typeface="Arial"/>
               </a:rPr>
-              <a:t>•  How is a result verified when the designer is a machine?  Here: regression checks with negative controls, layout figures read against every claim, and corrected signed measures — the checks caught the errors shown today.</a:t>
+              <a:t>•  The ask: a field-box width, anywhere in 5–15°.  The prediction, stated before the solve: interpolated from the committed frontier rows.</a:t>
             </a:r>
           </a:p>
           <a:p>
@@ -11347,13 +11341,13 @@
               </a:spcAft>
             </a:pPr>
             <a:r>
-              <a:rPr sz="1500" b="0">
+              <a:rPr sz="1200" b="0">
                 <a:solidFill>
                   <a:srgbClr val="282828"/>
                 </a:solidFill>
                 <a:latin typeface="Arial"/>
               </a:rPr>
-              <a:t>•  Where does the human rule?  Constraint choices, metric definitions, and every outward claim carry a human sign-off; the AI proposes, the record decides.</a:t>
+              <a:t>•  The pre-run rehearsal of the default ask (12°): predicted 33.7 nm; solved 33.6 nm — 1.00× — at a 24.9 mm clearance floor, both checks pass, in 15 minutes.</a:t>
             </a:r>
           </a:p>
           <a:p>
@@ -11363,27 +11357,51 @@
               </a:spcAft>
             </a:pPr>
             <a:r>
-              <a:rPr sz="1500" b="0">
+              <a:rPr sz="1200" b="0">
                 <a:solidFill>
                   <a:srgbClr val="282828"/>
                 </a:solidFill>
                 <a:latin typeface="Arial"/>
               </a:rPr>
-              <a:t>•  Is it reproducible?  Every number in this deck rebuilds from committed scripts and committed records — including the design solved during this talk.</a:t>
-            </a:r>
-          </a:p>
-        </p:txBody>
-      </p:sp>
-      <p:sp>
-        <p:nvSpPr>
-          <p:cNvPr id="5" name="TextBox 4"/>
+              <a:t>•  The run is deterministic to every printed digit, and every ask is a genuine continuation step — never a re-score of a stored design.</a:t>
+            </a:r>
+          </a:p>
+        </p:txBody>
+      </p:sp>
+      <p:pic>
+        <p:nvPicPr>
+          <p:cNvPr id="5" name="Picture 4" descr="oi_demo_12deg_layout.png"/>
+          <p:cNvPicPr>
+            <a:picLocks noChangeAspect="1"/>
+          </p:cNvPicPr>
+          <p:nvPr/>
+        </p:nvPicPr>
+        <p:blipFill>
+          <a:blip r:embed="rId2"/>
+          <a:stretch>
+            <a:fillRect/>
+          </a:stretch>
+        </p:blipFill>
+        <p:spPr>
+          <a:xfrm>
+            <a:off x="8000103" y="1298448"/>
+            <a:ext cx="2196352" cy="1891792"/>
+          </a:xfrm>
+          <a:prstGeom prst="rect">
+            <a:avLst/>
+          </a:prstGeom>
+        </p:spPr>
+      </p:pic>
+      <p:sp>
+        <p:nvSpPr>
+          <p:cNvPr id="6" name="TextBox 5"/>
           <p:cNvSpPr txBox="1"/>
           <p:nvPr/>
         </p:nvSpPr>
         <p:spPr>
           <a:xfrm>
-            <a:off x="411480" y="3241547"/>
-            <a:ext cx="11368735" cy="274320"/>
+            <a:off x="6400800" y="3208528"/>
+            <a:ext cx="5394960" cy="394208"/>
           </a:xfrm>
           <a:prstGeom prst="rect">
             <a:avLst/>
@@ -11396,6 +11414,69 @@
           </a:bodyPr>
           <a:lstStyle/>
           <a:p>
+            <a:pPr algn="ctr">
+              <a:spcAft>
+                <a:spcPts val="0"/>
+              </a:spcAft>
+            </a:pPr>
+            <a:r>
+              <a:rPr sz="1000" b="0">
+                <a:solidFill>
+                  <a:srgbClr val="6E6E6E"/>
+                </a:solidFill>
+                <a:latin typeface="Arial"/>
+              </a:rPr>
+              <a:t>The 12° rehearsal design and its field map: 33.6 nm max against a 33.7 nm prediction.</a:t>
+            </a:r>
+          </a:p>
+        </p:txBody>
+      </p:sp>
+      <p:pic>
+        <p:nvPicPr>
+          <p:cNvPr id="7" name="Picture 6" descr="oi_demo_12deg_map.png"/>
+          <p:cNvPicPr>
+            <a:picLocks noChangeAspect="1"/>
+          </p:cNvPicPr>
+          <p:nvPr/>
+        </p:nvPicPr>
+        <p:blipFill>
+          <a:blip r:embed="rId3"/>
+          <a:stretch>
+            <a:fillRect/>
+          </a:stretch>
+        </p:blipFill>
+        <p:spPr>
+          <a:xfrm>
+            <a:off x="7951092" y="3639312"/>
+            <a:ext cx="2294375" cy="2011680"/>
+          </a:xfrm>
+          <a:prstGeom prst="rect">
+            <a:avLst/>
+          </a:prstGeom>
+        </p:spPr>
+      </p:pic>
+      <p:sp>
+        <p:nvSpPr>
+          <p:cNvPr id="8" name="TextBox 7"/>
+          <p:cNvSpPr txBox="1"/>
+          <p:nvPr/>
+        </p:nvSpPr>
+        <p:spPr>
+          <a:xfrm>
+            <a:off x="6400800" y="5650992"/>
+            <a:ext cx="5394960" cy="274320"/>
+          </a:xfrm>
+          <a:prstGeom prst="rect">
+            <a:avLst/>
+          </a:prstGeom>
+          <a:noFill/>
+        </p:spPr>
+        <p:txBody>
+          <a:bodyPr wrap="square">
+            <a:spAutoFit/>
+          </a:bodyPr>
+          <a:lstStyle/>
+          <a:p>
             <a:pPr>
               <a:spcAft>
                 <a:spcPts val="600"/>
@@ -11408,7 +11489,7 @@
                 </a:solidFill>
                 <a:latin typeface="Arial"/>
               </a:rPr>
-              <a:t>These are offered as discussion questions, not settled doctrine.</a:t>
+              <a:t>On demo day the live run's figures replace these panels; this pre-generated bundle is the fallback if the room's ask matches nothing better.</a:t>
             </a:r>
           </a:p>
         </p:txBody>
@@ -11465,7 +11546,7 @@
                 </a:solidFill>
                 <a:latin typeface="Arial"/>
               </a:rPr>
-              <a:t>Summary</a:t>
+              <a:t>AI in design and analysis — the working questions</a:t>
             </a:r>
           </a:p>
           <a:p>
@@ -11481,7 +11562,7 @@
                 </a:solidFill>
                 <a:latin typeface="Arial"/>
               </a:rPr>
-              <a:t>One engine, validated; a toolbox that designs; an AI that drives it — all public</a:t>
+              <a:t>What we ask of an AI-driven study before believing it</a:t>
             </a:r>
           </a:p>
         </p:txBody>
@@ -11564,7 +11645,7 @@
                 </a:solidFill>
                 <a:latin typeface="Arial"/>
               </a:rPr>
-              <a:t>•  One validated engine behind four language surfaces; a MATLAB design layer that took three CODE V benchmark studies from reproduction to extension.</a:t>
+              <a:t>•  How is a result verified when the designer is a machine?  Here: regression checks with negative controls, layout figures read against every claim, and corrected signed measures — the checks caught the errors shown today.</a:t>
             </a:r>
           </a:p>
           <a:p>
@@ -11580,7 +11661,7 @@
                 </a:solidFill>
                 <a:latin typeface="Arial"/>
               </a:rPr>
-              <a:t>•  Two things happened live: a telescope designed to the audience's field specification in one warm-started step, and a polarization interferometer measuring a deformable mirror to 0.18 nm.</a:t>
+              <a:t>•  Where does the human rule?  Constraint choices, metric definitions, and every outward claim carry a human sign-off; the AI proposes, the record decides.</a:t>
             </a:r>
           </a:p>
           <a:p>
@@ -11596,7 +11677,7 @@
                 </a:solidFill>
                 <a:latin typeface="Arial"/>
               </a:rPr>
-              <a:t>•  The code is public: github.com/nasa-jpl/macos.</a:t>
+              <a:t>•  Is it reproducible?  Every number in this deck rebuilds from committed scripts and committed records — including the design solved during this talk.</a:t>
             </a:r>
           </a:p>
         </p:txBody>
@@ -11609,7 +11690,7 @@
         </p:nvSpPr>
         <p:spPr>
           <a:xfrm>
-            <a:off x="411480" y="2993898"/>
+            <a:off x="411480" y="3241547"/>
             <a:ext cx="11368735" cy="274320"/>
           </a:xfrm>
           <a:prstGeom prst="rect">
@@ -11635,7 +11716,7 @@
                 </a:solidFill>
                 <a:latin typeface="Arial"/>
               </a:rPr>
-              <a:t>Contact and records: all studies cited are committed with packets and regression checks.</a:t>
+              <a:t>These are offered as discussion questions, not settled doctrine.</a:t>
             </a:r>
           </a:p>
         </p:txBody>
@@ -11692,7 +11773,23 @@
                 </a:solidFill>
                 <a:latin typeface="Arial"/>
               </a:rPr>
-              <a:t>Backup Slides</a:t>
+              <a:t>Summary</a:t>
+            </a:r>
+          </a:p>
+          <a:p>
+            <a:pPr>
+              <a:spcAft>
+                <a:spcPts val="0"/>
+              </a:spcAft>
+            </a:pPr>
+            <a:r>
+              <a:rPr sz="1250" b="0">
+                <a:solidFill>
+                  <a:srgbClr val="6E6E6E"/>
+                </a:solidFill>
+                <a:latin typeface="Arial"/>
+              </a:rPr>
+              <a:t>One engine, validated; a toolbox that designs; an AI that drives it — all public</a:t>
             </a:r>
           </a:p>
         </p:txBody>
@@ -11705,7 +11802,7 @@
         </p:nvSpPr>
         <p:spPr>
           <a:xfrm>
-            <a:off x="411480" y="914400"/>
+            <a:off x="411480" y="1133856"/>
             <a:ext cx="11368735" cy="20320"/>
           </a:xfrm>
           <a:prstGeom prst="rect">
@@ -11738,6 +11835,116 @@
           <a:lstStyle/>
           <a:p>
             <a:pPr algn="ctr"/>
+          </a:p>
+        </p:txBody>
+      </p:sp>
+      <p:sp>
+        <p:nvSpPr>
+          <p:cNvPr id="4" name="TextBox 3"/>
+          <p:cNvSpPr txBox="1"/>
+          <p:nvPr/>
+        </p:nvSpPr>
+        <p:spPr>
+          <a:xfrm>
+            <a:off x="411480" y="1298448"/>
+            <a:ext cx="11368735" cy="274320"/>
+          </a:xfrm>
+          <a:prstGeom prst="rect">
+            <a:avLst/>
+          </a:prstGeom>
+          <a:noFill/>
+        </p:spPr>
+        <p:txBody>
+          <a:bodyPr wrap="square">
+            <a:spAutoFit/>
+          </a:bodyPr>
+          <a:lstStyle/>
+          <a:p>
+            <a:pPr>
+              <a:spcAft>
+                <a:spcPts val="600"/>
+              </a:spcAft>
+            </a:pPr>
+            <a:r>
+              <a:rPr sz="1500" b="0">
+                <a:solidFill>
+                  <a:srgbClr val="282828"/>
+                </a:solidFill>
+                <a:latin typeface="Arial"/>
+              </a:rPr>
+              <a:t>•  One validated engine behind four language surfaces; a MATLAB design layer that took three CODE V benchmark studies from reproduction to extension.</a:t>
+            </a:r>
+          </a:p>
+          <a:p>
+            <a:pPr>
+              <a:spcAft>
+                <a:spcPts val="600"/>
+              </a:spcAft>
+            </a:pPr>
+            <a:r>
+              <a:rPr sz="1500" b="0">
+                <a:solidFill>
+                  <a:srgbClr val="282828"/>
+                </a:solidFill>
+                <a:latin typeface="Arial"/>
+              </a:rPr>
+              <a:t>•  Two things happened live: a telescope designed to the audience's field specification in one warm-started step, and a polarization interferometer measuring a deformable mirror to 0.18 nm.</a:t>
+            </a:r>
+          </a:p>
+          <a:p>
+            <a:pPr>
+              <a:spcAft>
+                <a:spcPts val="600"/>
+              </a:spcAft>
+            </a:pPr>
+            <a:r>
+              <a:rPr sz="1500" b="0">
+                <a:solidFill>
+                  <a:srgbClr val="282828"/>
+                </a:solidFill>
+                <a:latin typeface="Arial"/>
+              </a:rPr>
+              <a:t>•  The code is public: github.com/nasa-jpl/macos.</a:t>
+            </a:r>
+          </a:p>
+        </p:txBody>
+      </p:sp>
+      <p:sp>
+        <p:nvSpPr>
+          <p:cNvPr id="5" name="TextBox 4"/>
+          <p:cNvSpPr txBox="1"/>
+          <p:nvPr/>
+        </p:nvSpPr>
+        <p:spPr>
+          <a:xfrm>
+            <a:off x="411480" y="2993898"/>
+            <a:ext cx="11368735" cy="274320"/>
+          </a:xfrm>
+          <a:prstGeom prst="rect">
+            <a:avLst/>
+          </a:prstGeom>
+          <a:noFill/>
+        </p:spPr>
+        <p:txBody>
+          <a:bodyPr wrap="square">
+            <a:spAutoFit/>
+          </a:bodyPr>
+          <a:lstStyle/>
+          <a:p>
+            <a:pPr>
+              <a:spcAft>
+                <a:spcPts val="600"/>
+              </a:spcAft>
+            </a:pPr>
+            <a:r>
+              <a:rPr sz="1050" b="0">
+                <a:solidFill>
+                  <a:srgbClr val="6E6E6E"/>
+                </a:solidFill>
+                <a:latin typeface="Arial"/>
+              </a:rPr>
+              <a:t>Contact and records: all studies cited are committed with packets and regression checks.</a:t>
+            </a:r>
           </a:p>
         </p:txBody>
       </p:sp>
@@ -12037,23 +12244,7 @@
                 </a:solidFill>
                 <a:latin typeface="Arial"/>
               </a:rPr>
-              <a:t>What MACOS does today</a:t>
-            </a:r>
-          </a:p>
-          <a:p>
-            <a:pPr>
-              <a:spcAft>
-                <a:spcPts val="0"/>
-              </a:spcAft>
-            </a:pPr>
-            <a:r>
-              <a:rPr sz="1250" b="0">
-                <a:solidFill>
-                  <a:srgbClr val="6E6E6E"/>
-                </a:solidFill>
-                <a:latin typeface="Arial"/>
-              </a:rPr>
-              <a:t>System-level modeling from design through control</a:t>
+              <a:t>Backup Slides</a:t>
             </a:r>
           </a:p>
         </p:txBody>
@@ -12066,7 +12257,7 @@
         </p:nvSpPr>
         <p:spPr>
           <a:xfrm>
-            <a:off x="411480" y="1133856"/>
+            <a:off x="411480" y="914400"/>
             <a:ext cx="11368735" cy="20320"/>
           </a:xfrm>
           <a:prstGeom prst="rect">
@@ -12099,116 +12290,6 @@
           <a:lstStyle/>
           <a:p>
             <a:pPr algn="ctr"/>
-          </a:p>
-        </p:txBody>
-      </p:sp>
-      <p:sp>
-        <p:nvSpPr>
-          <p:cNvPr id="4" name="TextBox 3"/>
-          <p:cNvSpPr txBox="1"/>
-          <p:nvPr/>
-        </p:nvSpPr>
-        <p:spPr>
-          <a:xfrm>
-            <a:off x="411480" y="1298448"/>
-            <a:ext cx="11368735" cy="274320"/>
-          </a:xfrm>
-          <a:prstGeom prst="rect">
-            <a:avLst/>
-          </a:prstGeom>
-          <a:noFill/>
-        </p:spPr>
-        <p:txBody>
-          <a:bodyPr wrap="square">
-            <a:spAutoFit/>
-          </a:bodyPr>
-          <a:lstStyle/>
-          <a:p>
-            <a:pPr>
-              <a:spcAft>
-                <a:spcPts val="600"/>
-              </a:spcAft>
-            </a:pPr>
-            <a:r>
-              <a:rPr sz="1500" b="0">
-                <a:solidFill>
-                  <a:srgbClr val="282828"/>
-                </a:solidFill>
-                <a:latin typeface="Arial"/>
-              </a:rPr>
-              <a:t>•  Applications: error budgeting, integrated observatory simulation, wavefront sensing and control for segmented telescopes, coronagraph testbeds and instruments.</a:t>
-            </a:r>
-          </a:p>
-          <a:p>
-            <a:pPr>
-              <a:spcAft>
-                <a:spcPts val="600"/>
-              </a:spcAft>
-            </a:pPr>
-            <a:r>
-              <a:rPr sz="1500" b="0">
-                <a:solidFill>
-                  <a:srgbClr val="282828"/>
-                </a:solidFill>
-                <a:latin typeface="Arial"/>
-              </a:rPr>
-              <a:t>•  The linear-model workflow: w = J·x + w₀ — wavefront sensitivity channels per element, per segment, per surface mode; stacked over fields and configurations; element groups move as one.</a:t>
-            </a:r>
-          </a:p>
-          <a:p>
-            <a:pPr>
-              <a:spcAft>
-                <a:spcPts val="600"/>
-              </a:spcAft>
-            </a:pPr>
-            <a:r>
-              <a:rPr sz="1500" b="0">
-                <a:solidFill>
-                  <a:srgbClr val="282828"/>
-                </a:solidFill>
-                <a:latin typeface="Arial"/>
-              </a:rPr>
-              <a:t>•  From model to control: the same sensitivity matrices drive metrology design, estimator synthesis, and closed-loop simulation — one model, one bookkeeping, design to control.</a:t>
-            </a:r>
-          </a:p>
-        </p:txBody>
-      </p:sp>
-      <p:sp>
-        <p:nvSpPr>
-          <p:cNvPr id="5" name="TextBox 4"/>
-          <p:cNvSpPr txBox="1"/>
-          <p:nvPr/>
-        </p:nvSpPr>
-        <p:spPr>
-          <a:xfrm>
-            <a:off x="411480" y="3241547"/>
-            <a:ext cx="11368735" cy="274320"/>
-          </a:xfrm>
-          <a:prstGeom prst="rect">
-            <a:avLst/>
-          </a:prstGeom>
-          <a:noFill/>
-        </p:spPr>
-        <p:txBody>
-          <a:bodyPr wrap="square">
-            <a:spAutoFit/>
-          </a:bodyPr>
-          <a:lstStyle/>
-          <a:p>
-            <a:pPr>
-              <a:spcAft>
-                <a:spcPts val="600"/>
-              </a:spcAft>
-            </a:pPr>
-            <a:r>
-              <a:rPr sz="1050" b="0">
-                <a:solidFill>
-                  <a:srgbClr val="6E6E6E"/>
-                </a:solidFill>
-                <a:latin typeface="Arial"/>
-              </a:rPr>
-              <a:t>Every capability shown today is in the committed test suites; validation anchors: next slide.</a:t>
-            </a:r>
           </a:p>
         </p:txBody>
       </p:sp>
@@ -12264,7 +12345,7 @@
                 </a:solidFill>
                 <a:latin typeface="Arial"/>
               </a:rPr>
-              <a:t>The MATLAB toolbox and the design layer</a:t>
+              <a:t>What MACOS does today</a:t>
             </a:r>
           </a:p>
           <a:p>
@@ -12280,7 +12361,7 @@
                 </a:solidFill>
                 <a:latin typeface="Arial"/>
               </a:rPr>
-              <a:t>Design → segmentation → sensitivities → metrology → simulation, each one call — fully public-domain</a:t>
+              <a:t>System-level modeling from design through control</a:t>
             </a:r>
           </a:p>
         </p:txBody>
@@ -12338,7 +12419,7 @@
         <p:spPr>
           <a:xfrm>
             <a:off x="411480" y="1298448"/>
-            <a:ext cx="5806440" cy="274320"/>
+            <a:ext cx="11368735" cy="274320"/>
           </a:xfrm>
           <a:prstGeom prst="rect">
             <a:avLst/>
@@ -12357,13 +12438,13 @@
               </a:spcAft>
             </a:pPr>
             <a:r>
-              <a:rPr sz="1200" b="0">
+              <a:rPr sz="1500" b="0">
                 <a:solidFill>
                   <a:srgbClr val="282828"/>
                 </a:solidFill>
                 <a:latin typeface="Arial"/>
               </a:rPr>
-              <a:t>•  Drivers: telescope/bench design builders, sensitivity supervisors (rigid-body, alignment, surface-grid), metrology placement, model-vs-model comparison, closed-loop simulators, study orchestrators.</a:t>
+              <a:t>•  Applications: error budgeting, integrated observatory simulation, wavefront sensing and control for segmented telescopes, coronagraph testbeds and instruments.</a:t>
             </a:r>
           </a:p>
           <a:p>
@@ -12373,13 +12454,29 @@
               </a:spcAft>
             </a:pPr>
             <a:r>
-              <a:rPr sz="1200" b="0">
+              <a:rPr sz="1500" b="0">
                 <a:solidFill>
                   <a:srgbClr val="282828"/>
                 </a:solidFill>
                 <a:latin typeface="Arial"/>
               </a:rPr>
-              <a:t>•  One-call reconstructible studies: every figure in this deck rebuilds from a committed script and committed records.</a:t>
+              <a:t>•  The linear-model workflow: w = J·x + w₀ — wavefront sensitivity channels per element, per segment, per surface mode; stacked over fields and configurations; element groups move as one.</a:t>
+            </a:r>
+          </a:p>
+          <a:p>
+            <a:pPr>
+              <a:spcAft>
+                <a:spcPts val="600"/>
+              </a:spcAft>
+            </a:pPr>
+            <a:r>
+              <a:rPr sz="1500" b="0">
+                <a:solidFill>
+                  <a:srgbClr val="282828"/>
+                </a:solidFill>
+                <a:latin typeface="Arial"/>
+              </a:rPr>
+              <a:t>•  From model to control: the same sensitivity matrices drive metrology design, estimator synthesis, and closed-loop simulation — one model, one bookkeeping, design to control.</a:t>
             </a:r>
           </a:p>
         </p:txBody>
@@ -12392,8 +12489,8 @@
         </p:nvSpPr>
         <p:spPr>
           <a:xfrm>
-            <a:off x="6400800" y="1298448"/>
-            <a:ext cx="5394960" cy="274320"/>
+            <a:off x="411480" y="3241547"/>
+            <a:ext cx="11368735" cy="274320"/>
           </a:xfrm>
           <a:prstGeom prst="rect">
             <a:avLst/>
@@ -12412,68 +12509,13 @@
               </a:spcAft>
             </a:pPr>
             <a:r>
-              <a:rPr sz="1200" b="0">
-                <a:solidFill>
-                  <a:srgbClr val="282828"/>
-                </a:solidFill>
-                <a:latin typeface="Arial"/>
-              </a:rPr>
-              <a:t>•  Utilities: trace, wavefront, perturb, pupil find; layout and ray-bundle viewers; Jones pupils, polarization elements; segment grid bases and grid file IO; multi-wavelength composition; spot, intensity, complex field.</a:t>
-            </a:r>
-          </a:p>
-          <a:p>
-            <a:pPr>
-              <a:spcAft>
-                <a:spcPts val="600"/>
-              </a:spcAft>
-            </a:pPr>
-            <a:r>
-              <a:rPr sz="1200" b="0">
-                <a:solidFill>
-                  <a:srgbClr val="282828"/>
-                </a:solidFill>
-                <a:latin typeface="Arial"/>
-              </a:rPr>
-              <a:t>•  Why a design layer: the whole stack is public-domain — a design study needs no proprietary prescription to start from.</a:t>
-            </a:r>
-          </a:p>
-        </p:txBody>
-      </p:sp>
-      <p:sp>
-        <p:nvSpPr>
-          <p:cNvPr id="6" name="TextBox 5"/>
-          <p:cNvSpPr txBox="1"/>
-          <p:nvPr/>
-        </p:nvSpPr>
-        <p:spPr>
-          <a:xfrm>
-            <a:off x="6400800" y="2804160"/>
-            <a:ext cx="5394960" cy="274320"/>
-          </a:xfrm>
-          <a:prstGeom prst="rect">
-            <a:avLst/>
-          </a:prstGeom>
-          <a:noFill/>
-        </p:spPr>
-        <p:txBody>
-          <a:bodyPr wrap="square">
-            <a:spAutoFit/>
-          </a:bodyPr>
-          <a:lstStyle/>
-          <a:p>
-            <a:pPr>
-              <a:spcAft>
-                <a:spcPts val="600"/>
-              </a:spcAft>
-            </a:pPr>
-            <a:r>
               <a:rPr sz="1050" b="0">
                 <a:solidFill>
                   <a:srgbClr val="6E6E6E"/>
                 </a:solidFill>
                 <a:latin typeface="Arial"/>
               </a:rPr>
-              <a:t>The two live demonstrations exercised exactly these layers: the bench builder and a design-family driver.</a:t>
+              <a:t>Every capability shown today is in the committed test suites; validation anchors: next slide.</a:t>
             </a:r>
           </a:p>
         </p:txBody>
@@ -12487,6 +12529,272 @@
 </file>
 
 <file path=ppt/slides/slide32.xml><?xml version="1.0" encoding="utf-8"?>
+<p:sld xmlns:a="http://schemas.openxmlformats.org/drawingml/2006/main" xmlns:p="http://schemas.openxmlformats.org/presentationml/2006/main" xmlns:r="http://schemas.openxmlformats.org/officeDocument/2006/relationships">
+  <p:cSld>
+    <p:spTree>
+      <p:nvGrpSpPr>
+        <p:cNvPr id="1" name=""/>
+        <p:cNvGrpSpPr/>
+        <p:nvPr/>
+      </p:nvGrpSpPr>
+      <p:grpSpPr/>
+      <p:sp>
+        <p:nvSpPr>
+          <p:cNvPr id="2" name="TextBox 1"/>
+          <p:cNvSpPr txBox="1"/>
+          <p:nvPr/>
+        </p:nvSpPr>
+        <p:spPr>
+          <a:xfrm>
+            <a:off x="411480" y="201168"/>
+            <a:ext cx="11368735" cy="914400"/>
+          </a:xfrm>
+          <a:prstGeom prst="rect">
+            <a:avLst/>
+          </a:prstGeom>
+          <a:noFill/>
+        </p:spPr>
+        <p:txBody>
+          <a:bodyPr wrap="square">
+            <a:spAutoFit/>
+          </a:bodyPr>
+          <a:lstStyle/>
+          <a:p>
+            <a:pPr>
+              <a:spcAft>
+                <a:spcPts val="400"/>
+              </a:spcAft>
+            </a:pPr>
+            <a:r>
+              <a:rPr sz="2400" b="1">
+                <a:solidFill>
+                  <a:srgbClr val="1F4E79"/>
+                </a:solidFill>
+                <a:latin typeface="Arial"/>
+              </a:rPr>
+              <a:t>The MATLAB toolbox and the design layer</a:t>
+            </a:r>
+          </a:p>
+          <a:p>
+            <a:pPr>
+              <a:spcAft>
+                <a:spcPts val="0"/>
+              </a:spcAft>
+            </a:pPr>
+            <a:r>
+              <a:rPr sz="1250" b="0">
+                <a:solidFill>
+                  <a:srgbClr val="6E6E6E"/>
+                </a:solidFill>
+                <a:latin typeface="Arial"/>
+              </a:rPr>
+              <a:t>Design → segmentation → sensitivities → metrology → simulation, each one call — fully public-domain</a:t>
+            </a:r>
+          </a:p>
+        </p:txBody>
+      </p:sp>
+      <p:sp>
+        <p:nvSpPr>
+          <p:cNvPr id="3" name="Rectangle 2"/>
+          <p:cNvSpPr/>
+          <p:nvPr/>
+        </p:nvSpPr>
+        <p:spPr>
+          <a:xfrm>
+            <a:off x="411480" y="1133856"/>
+            <a:ext cx="11368735" cy="20320"/>
+          </a:xfrm>
+          <a:prstGeom prst="rect">
+            <a:avLst/>
+          </a:prstGeom>
+          <a:solidFill>
+            <a:srgbClr val="B8C6D4"/>
+          </a:solidFill>
+          <a:ln>
+            <a:noFill/>
+          </a:ln>
+          <a:effectLst/>
+        </p:spPr>
+        <p:style>
+          <a:lnRef idx="1">
+            <a:schemeClr val="accent1"/>
+          </a:lnRef>
+          <a:fillRef idx="3">
+            <a:schemeClr val="accent1"/>
+          </a:fillRef>
+          <a:effectRef idx="2">
+            <a:schemeClr val="accent1"/>
+          </a:effectRef>
+          <a:fontRef idx="minor">
+            <a:schemeClr val="lt1"/>
+          </a:fontRef>
+        </p:style>
+        <p:txBody>
+          <a:bodyPr rtlCol="0" anchor="ctr"/>
+          <a:lstStyle/>
+          <a:p>
+            <a:pPr algn="ctr"/>
+          </a:p>
+        </p:txBody>
+      </p:sp>
+      <p:sp>
+        <p:nvSpPr>
+          <p:cNvPr id="4" name="TextBox 3"/>
+          <p:cNvSpPr txBox="1"/>
+          <p:nvPr/>
+        </p:nvSpPr>
+        <p:spPr>
+          <a:xfrm>
+            <a:off x="411480" y="1298448"/>
+            <a:ext cx="5806440" cy="274320"/>
+          </a:xfrm>
+          <a:prstGeom prst="rect">
+            <a:avLst/>
+          </a:prstGeom>
+          <a:noFill/>
+        </p:spPr>
+        <p:txBody>
+          <a:bodyPr wrap="square">
+            <a:spAutoFit/>
+          </a:bodyPr>
+          <a:lstStyle/>
+          <a:p>
+            <a:pPr>
+              <a:spcAft>
+                <a:spcPts val="600"/>
+              </a:spcAft>
+            </a:pPr>
+            <a:r>
+              <a:rPr sz="1200" b="0">
+                <a:solidFill>
+                  <a:srgbClr val="282828"/>
+                </a:solidFill>
+                <a:latin typeface="Arial"/>
+              </a:rPr>
+              <a:t>•  Drivers: telescope/bench design builders, sensitivity supervisors (rigid-body, alignment, surface-grid), metrology placement, model-vs-model comparison, closed-loop simulators, study orchestrators.</a:t>
+            </a:r>
+          </a:p>
+          <a:p>
+            <a:pPr>
+              <a:spcAft>
+                <a:spcPts val="600"/>
+              </a:spcAft>
+            </a:pPr>
+            <a:r>
+              <a:rPr sz="1200" b="0">
+                <a:solidFill>
+                  <a:srgbClr val="282828"/>
+                </a:solidFill>
+                <a:latin typeface="Arial"/>
+              </a:rPr>
+              <a:t>•  One-call reconstructible studies: every figure in this deck rebuilds from a committed script and committed records.</a:t>
+            </a:r>
+          </a:p>
+        </p:txBody>
+      </p:sp>
+      <p:sp>
+        <p:nvSpPr>
+          <p:cNvPr id="5" name="TextBox 4"/>
+          <p:cNvSpPr txBox="1"/>
+          <p:nvPr/>
+        </p:nvSpPr>
+        <p:spPr>
+          <a:xfrm>
+            <a:off x="6400800" y="1298448"/>
+            <a:ext cx="5394960" cy="274320"/>
+          </a:xfrm>
+          <a:prstGeom prst="rect">
+            <a:avLst/>
+          </a:prstGeom>
+          <a:noFill/>
+        </p:spPr>
+        <p:txBody>
+          <a:bodyPr wrap="square">
+            <a:spAutoFit/>
+          </a:bodyPr>
+          <a:lstStyle/>
+          <a:p>
+            <a:pPr>
+              <a:spcAft>
+                <a:spcPts val="600"/>
+              </a:spcAft>
+            </a:pPr>
+            <a:r>
+              <a:rPr sz="1200" b="0">
+                <a:solidFill>
+                  <a:srgbClr val="282828"/>
+                </a:solidFill>
+                <a:latin typeface="Arial"/>
+              </a:rPr>
+              <a:t>•  Utilities: trace, wavefront, perturb, pupil find; layout and ray-bundle viewers; Jones pupils, polarization elements; segment grid bases and grid file IO; multi-wavelength composition; spot, intensity, complex field.</a:t>
+            </a:r>
+          </a:p>
+          <a:p>
+            <a:pPr>
+              <a:spcAft>
+                <a:spcPts val="600"/>
+              </a:spcAft>
+            </a:pPr>
+            <a:r>
+              <a:rPr sz="1200" b="0">
+                <a:solidFill>
+                  <a:srgbClr val="282828"/>
+                </a:solidFill>
+                <a:latin typeface="Arial"/>
+              </a:rPr>
+              <a:t>•  Why a design layer: the whole stack is public-domain — a design study needs no proprietary prescription to start from.</a:t>
+            </a:r>
+          </a:p>
+        </p:txBody>
+      </p:sp>
+      <p:sp>
+        <p:nvSpPr>
+          <p:cNvPr id="6" name="TextBox 5"/>
+          <p:cNvSpPr txBox="1"/>
+          <p:nvPr/>
+        </p:nvSpPr>
+        <p:spPr>
+          <a:xfrm>
+            <a:off x="6400800" y="2804160"/>
+            <a:ext cx="5394960" cy="274320"/>
+          </a:xfrm>
+          <a:prstGeom prst="rect">
+            <a:avLst/>
+          </a:prstGeom>
+          <a:noFill/>
+        </p:spPr>
+        <p:txBody>
+          <a:bodyPr wrap="square">
+            <a:spAutoFit/>
+          </a:bodyPr>
+          <a:lstStyle/>
+          <a:p>
+            <a:pPr>
+              <a:spcAft>
+                <a:spcPts val="600"/>
+              </a:spcAft>
+            </a:pPr>
+            <a:r>
+              <a:rPr sz="1050" b="0">
+                <a:solidFill>
+                  <a:srgbClr val="6E6E6E"/>
+                </a:solidFill>
+                <a:latin typeface="Arial"/>
+              </a:rPr>
+              <a:t>The two live demonstrations exercised exactly these layers: the bench builder and a design-family driver.</a:t>
+            </a:r>
+          </a:p>
+        </p:txBody>
+      </p:sp>
+    </p:spTree>
+  </p:cSld>
+  <p:clrMapOvr>
+    <a:masterClrMapping/>
+  </p:clrMapOvr>
+</p:sld>
+</file>
+
+<file path=ppt/slides/slide33.xml><?xml version="1.0" encoding="utf-8"?>
 <p:sld xmlns:a="http://schemas.openxmlformats.org/drawingml/2006/main" xmlns:p="http://schemas.openxmlformats.org/presentationml/2006/main" xmlns:r="http://schemas.openxmlformats.org/officeDocument/2006/relationships">
   <p:cSld>
     <p:spTree>
@@ -13116,7 +13424,7 @@
 </p:sld>
 </file>
 
-<file path=ppt/slides/slide33.xml><?xml version="1.0" encoding="utf-8"?>
+<file path=ppt/slides/slide34.xml><?xml version="1.0" encoding="utf-8"?>
 <p:sld xmlns:a="http://schemas.openxmlformats.org/drawingml/2006/main" xmlns:p="http://schemas.openxmlformats.org/presentationml/2006/main" xmlns:r="http://schemas.openxmlformats.org/officeDocument/2006/relationships">
   <p:cSld>
     <p:spTree>
@@ -13982,7 +14290,7 @@
 </p:sld>
 </file>
 
-<file path=ppt/slides/slide34.xml><?xml version="1.0" encoding="utf-8"?>
+<file path=ppt/slides/slide35.xml><?xml version="1.0" encoding="utf-8"?>
 <p:sld xmlns:a="http://schemas.openxmlformats.org/drawingml/2006/main" xmlns:p="http://schemas.openxmlformats.org/presentationml/2006/main" xmlns:r="http://schemas.openxmlformats.org/officeDocument/2006/relationships">
   <p:cSld>
     <p:spTree>
@@ -14189,351 +14497,6 @@
                 <a:latin typeface="Arial"/>
               </a:rPr>
               <a:t>Committed: deepest optic 1.887 m = 1.81× the spacing, the feed beam through the collimator by −79.9 mm.  Four-flat recipe: 0.893 m deep, but a fold is an isometry — the interference rides across — and it does not close on the cleared deck (96 routes, every admissible one loses rays).  Cleared −10°: 1.287 m = 1.24×, zero flats, +37.8 mm of daylight.  Record: challenges/afocal4/{packaging,clearing}.</a:t>
-            </a:r>
-          </a:p>
-        </p:txBody>
-      </p:sp>
-    </p:spTree>
-  </p:cSld>
-  <p:clrMapOvr>
-    <a:masterClrMapping/>
-  </p:clrMapOvr>
-</p:sld>
-</file>
-
-<file path=ppt/slides/slide35.xml><?xml version="1.0" encoding="utf-8"?>
-<p:sld xmlns:a="http://schemas.openxmlformats.org/drawingml/2006/main" xmlns:p="http://schemas.openxmlformats.org/presentationml/2006/main" xmlns:r="http://schemas.openxmlformats.org/officeDocument/2006/relationships">
-  <p:cSld>
-    <p:spTree>
-      <p:nvGrpSpPr>
-        <p:cNvPr id="1" name=""/>
-        <p:cNvGrpSpPr/>
-        <p:nvPr/>
-      </p:nvGrpSpPr>
-      <p:grpSpPr/>
-      <p:sp>
-        <p:nvSpPr>
-          <p:cNvPr id="2" name="TextBox 1"/>
-          <p:cNvSpPr txBox="1"/>
-          <p:nvPr/>
-        </p:nvSpPr>
-        <p:spPr>
-          <a:xfrm>
-            <a:off x="411480" y="201168"/>
-            <a:ext cx="11368735" cy="914400"/>
-          </a:xfrm>
-          <a:prstGeom prst="rect">
-            <a:avLst/>
-          </a:prstGeom>
-          <a:noFill/>
-        </p:spPr>
-        <p:txBody>
-          <a:bodyPr wrap="square">
-            <a:spAutoFit/>
-          </a:bodyPr>
-          <a:lstStyle/>
-          <a:p>
-            <a:pPr>
-              <a:spcAft>
-                <a:spcPts val="400"/>
-              </a:spcAft>
-            </a:pPr>
-            <a:r>
-              <a:rPr sz="2400" b="1">
-                <a:solidFill>
-                  <a:srgbClr val="1F4E79"/>
-                </a:solidFill>
-                <a:latin typeface="Arial"/>
-              </a:rPr>
-              <a:t>Interferometer demonstration backups</a:t>
-            </a:r>
-          </a:p>
-          <a:p>
-            <a:pPr>
-              <a:spcAft>
-                <a:spcPts val="0"/>
-              </a:spcAft>
-            </a:pPr>
-            <a:r>
-              <a:rPr sz="1250" b="0">
-                <a:solidFill>
-                  <a:srgbClr val="6E6E6E"/>
-                </a:solidFill>
-                <a:latin typeface="Arial"/>
-              </a:rPr>
-              <a:t>One committed image per live beat</a:t>
-            </a:r>
-          </a:p>
-        </p:txBody>
-      </p:sp>
-      <p:sp>
-        <p:nvSpPr>
-          <p:cNvPr id="3" name="Rectangle 2"/>
-          <p:cNvSpPr/>
-          <p:nvPr/>
-        </p:nvSpPr>
-        <p:spPr>
-          <a:xfrm>
-            <a:off x="411480" y="1133856"/>
-            <a:ext cx="11368735" cy="20320"/>
-          </a:xfrm>
-          <a:prstGeom prst="rect">
-            <a:avLst/>
-          </a:prstGeom>
-          <a:solidFill>
-            <a:srgbClr val="B8C6D4"/>
-          </a:solidFill>
-          <a:ln>
-            <a:noFill/>
-          </a:ln>
-          <a:effectLst/>
-        </p:spPr>
-        <p:style>
-          <a:lnRef idx="1">
-            <a:schemeClr val="accent1"/>
-          </a:lnRef>
-          <a:fillRef idx="3">
-            <a:schemeClr val="accent1"/>
-          </a:fillRef>
-          <a:effectRef idx="2">
-            <a:schemeClr val="accent1"/>
-          </a:effectRef>
-          <a:fontRef idx="minor">
-            <a:schemeClr val="lt1"/>
-          </a:fontRef>
-        </p:style>
-        <p:txBody>
-          <a:bodyPr rtlCol="0" anchor="ctr"/>
-          <a:lstStyle/>
-          <a:p>
-            <a:pPr algn="ctr"/>
-          </a:p>
-        </p:txBody>
-      </p:sp>
-      <p:pic>
-        <p:nvPicPr>
-          <p:cNvPr id="4" name="Picture 3" descr="demo2_beat5_poke.png"/>
-          <p:cNvPicPr>
-            <a:picLocks noChangeAspect="1"/>
-          </p:cNvPicPr>
-          <p:nvPr/>
-        </p:nvPicPr>
-        <p:blipFill>
-          <a:blip r:embed="rId2"/>
-          <a:stretch>
-            <a:fillRect/>
-          </a:stretch>
-        </p:blipFill>
-        <p:spPr>
-          <a:xfrm>
-            <a:off x="3772370" y="1298448"/>
-            <a:ext cx="4646955" cy="1782572"/>
-          </a:xfrm>
-          <a:prstGeom prst="rect">
-            <a:avLst/>
-          </a:prstGeom>
-        </p:spPr>
-      </p:pic>
-      <p:sp>
-        <p:nvSpPr>
-          <p:cNvPr id="5" name="TextBox 4"/>
-          <p:cNvSpPr txBox="1"/>
-          <p:nvPr/>
-        </p:nvSpPr>
-        <p:spPr>
-          <a:xfrm>
-            <a:off x="411480" y="3099308"/>
-            <a:ext cx="11368735" cy="229107"/>
-          </a:xfrm>
-          <a:prstGeom prst="rect">
-            <a:avLst/>
-          </a:prstGeom>
-          <a:noFill/>
-        </p:spPr>
-        <p:txBody>
-          <a:bodyPr wrap="square">
-            <a:spAutoFit/>
-          </a:bodyPr>
-          <a:lstStyle/>
-          <a:p>
-            <a:pPr algn="ctr">
-              <a:spcAft>
-                <a:spcPts val="0"/>
-              </a:spcAft>
-            </a:pPr>
-            <a:r>
-              <a:rPr sz="1000" b="0">
-                <a:solidFill>
-                  <a:srgbClr val="6E6E6E"/>
-                </a:solidFill>
-                <a:latin typeface="Arial"/>
-              </a:rPr>
-              <a:t>Beat 5 — one actuator poked: the fringes bend over it.</a:t>
-            </a:r>
-          </a:p>
-        </p:txBody>
-      </p:sp>
-      <p:pic>
-        <p:nvPicPr>
-          <p:cNvPr id="6" name="Picture 5" descr="demo2_beat6_sweep.png"/>
-          <p:cNvPicPr>
-            <a:picLocks noChangeAspect="1"/>
-          </p:cNvPicPr>
-          <p:nvPr/>
-        </p:nvPicPr>
-        <p:blipFill>
-          <a:blip r:embed="rId3"/>
-          <a:stretch>
-            <a:fillRect/>
-          </a:stretch>
-        </p:blipFill>
-        <p:spPr>
-          <a:xfrm>
-            <a:off x="4186821" y="3364992"/>
-            <a:ext cx="3818051" cy="1782572"/>
-          </a:xfrm>
-          <a:prstGeom prst="rect">
-            <a:avLst/>
-          </a:prstGeom>
-        </p:spPr>
-      </p:pic>
-      <p:sp>
-        <p:nvSpPr>
-          <p:cNvPr id="7" name="TextBox 6"/>
-          <p:cNvSpPr txBox="1"/>
-          <p:nvPr/>
-        </p:nvSpPr>
-        <p:spPr>
-          <a:xfrm>
-            <a:off x="411480" y="5165852"/>
-            <a:ext cx="11368735" cy="229107"/>
-          </a:xfrm>
-          <a:prstGeom prst="rect">
-            <a:avLst/>
-          </a:prstGeom>
-          <a:noFill/>
-        </p:spPr>
-        <p:txBody>
-          <a:bodyPr wrap="square">
-            <a:spAutoFit/>
-          </a:bodyPr>
-          <a:lstStyle/>
-          <a:p>
-            <a:pPr algn="ctr">
-              <a:spcAft>
-                <a:spcPts val="0"/>
-              </a:spcAft>
-            </a:pPr>
-            <a:r>
-              <a:rPr sz="1000" b="0">
-                <a:solidFill>
-                  <a:srgbClr val="6E6E6E"/>
-                </a:solidFill>
-                <a:latin typeface="Arial"/>
-              </a:rPr>
-              <a:t>Beat 6 — the analyzer sweep: phase-stepped frames, no re-trace.</a:t>
-            </a:r>
-          </a:p>
-        </p:txBody>
-      </p:sp>
-      <p:pic>
-        <p:nvPicPr>
-          <p:cNvPr id="8" name="Picture 7" descr="demo2_beat7_recovery.png"/>
-          <p:cNvPicPr>
-            <a:picLocks noChangeAspect="1"/>
-          </p:cNvPicPr>
-          <p:nvPr/>
-        </p:nvPicPr>
-        <p:blipFill>
-          <a:blip r:embed="rId4"/>
-          <a:stretch>
-            <a:fillRect/>
-          </a:stretch>
-        </p:blipFill>
-        <p:spPr>
-          <a:xfrm>
-            <a:off x="4177857" y="5431536"/>
-            <a:ext cx="3835980" cy="1032763"/>
-          </a:xfrm>
-          <a:prstGeom prst="rect">
-            <a:avLst/>
-          </a:prstGeom>
-        </p:spPr>
-      </p:pic>
-      <p:sp>
-        <p:nvSpPr>
-          <p:cNvPr id="9" name="TextBox 8"/>
-          <p:cNvSpPr txBox="1"/>
-          <p:nvPr/>
-        </p:nvSpPr>
-        <p:spPr>
-          <a:xfrm>
-            <a:off x="411480" y="6482588"/>
-            <a:ext cx="11368735" cy="229107"/>
-          </a:xfrm>
-          <a:prstGeom prst="rect">
-            <a:avLst/>
-          </a:prstGeom>
-          <a:noFill/>
-        </p:spPr>
-        <p:txBody>
-          <a:bodyPr wrap="square">
-            <a:spAutoFit/>
-          </a:bodyPr>
-          <a:lstStyle/>
-          <a:p>
-            <a:pPr algn="ctr">
-              <a:spcAft>
-                <a:spcPts val="0"/>
-              </a:spcAft>
-            </a:pPr>
-            <a:r>
-              <a:rPr sz="1000" b="0">
-                <a:solidFill>
-                  <a:srgbClr val="6E6E6E"/>
-                </a:solidFill>
-                <a:latin typeface="Arial"/>
-              </a:rPr>
-              <a:t>Beat 7 — the recovery beside the truth map.</a:t>
-            </a:r>
-          </a:p>
-        </p:txBody>
-      </p:sp>
-      <p:sp>
-        <p:nvSpPr>
-          <p:cNvPr id="10" name="TextBox 9"/>
-          <p:cNvSpPr txBox="1"/>
-          <p:nvPr/>
-        </p:nvSpPr>
-        <p:spPr>
-          <a:xfrm>
-            <a:off x="411480" y="6748272"/>
-            <a:ext cx="11368735" cy="274320"/>
-          </a:xfrm>
-          <a:prstGeom prst="rect">
-            <a:avLst/>
-          </a:prstGeom>
-          <a:noFill/>
-        </p:spPr>
-        <p:txBody>
-          <a:bodyPr wrap="square">
-            <a:spAutoFit/>
-          </a:bodyPr>
-          <a:lstStyle/>
-          <a:p>
-            <a:pPr>
-              <a:spcAft>
-                <a:spcPts val="600"/>
-              </a:spcAft>
-            </a:pPr>
-            <a:r>
-              <a:rPr sz="1050" b="0">
-                <a:solidFill>
-                  <a:srgbClr val="6E6E6E"/>
-                </a:solidFill>
-                <a:latin typeface="Arial"/>
-              </a:rPr>
-              <a:t>All eight beats have committed figures in templates/90_polarization/tg_psi_dm_v2 (v1 likewise); the driver opens them on the desktop as each beat runs.</a:t>
             </a:r>
           </a:p>
         </p:txBody>
@@ -14590,7 +14553,7 @@
                 </a:solidFill>
                 <a:latin typeface="Arial"/>
               </a:rPr>
-              <a:t>The e2e worked example: specification to design</a:t>
+              <a:t>Interferometer demonstration backups</a:t>
             </a:r>
           </a:p>
           <a:p>
@@ -14606,7 +14569,7 @@
                 </a:solidFill>
                 <a:latin typeface="Arial"/>
               </a:rPr>
-              <a:t>A 4 m f/18 visible-band telescope from a closed-form seed — no starting prescription</a:t>
+              <a:t>One committed image per live beat</a:t>
             </a:r>
           </a:p>
         </p:txBody>
@@ -14655,64 +14618,9 @@
           </a:p>
         </p:txBody>
       </p:sp>
-      <p:sp>
-        <p:nvSpPr>
-          <p:cNvPr id="4" name="TextBox 3"/>
-          <p:cNvSpPr txBox="1"/>
-          <p:nvPr/>
-        </p:nvSpPr>
-        <p:spPr>
-          <a:xfrm>
-            <a:off x="411480" y="1298448"/>
-            <a:ext cx="5806440" cy="274320"/>
-          </a:xfrm>
-          <a:prstGeom prst="rect">
-            <a:avLst/>
-          </a:prstGeom>
-          <a:noFill/>
-        </p:spPr>
-        <p:txBody>
-          <a:bodyPr wrap="square">
-            <a:spAutoFit/>
-          </a:bodyPr>
-          <a:lstStyle/>
-          <a:p>
-            <a:pPr>
-              <a:spcAft>
-                <a:spcPts val="600"/>
-              </a:spcAft>
-            </a:pPr>
-            <a:r>
-              <a:rPr sz="1200" b="0">
-                <a:solidFill>
-                  <a:srgbClr val="282828"/>
-                </a:solidFill>
-                <a:latin typeface="Arial"/>
-              </a:rPr>
-              <a:t>•  The stage-runner sequence on the smaller worked example: specification → design → segmentation → metrology → comparison → simulation, each stage a committed runner handing its prescription to the next.</a:t>
-            </a:r>
-          </a:p>
-          <a:p>
-            <a:pPr>
-              <a:spcAft>
-                <a:spcPts val="600"/>
-              </a:spcAft>
-            </a:pPr>
-            <a:r>
-              <a:rPr sz="1200" b="0">
-                <a:solidFill>
-                  <a:srgbClr val="282828"/>
-                </a:solidFill>
-                <a:latin typeface="Arial"/>
-              </a:rPr>
-              <a:t>•  A 4 m f/18 telescope (f/1.75 primary) from a closed-form first-order seed; diffraction-limited over ±1′ alone, and the Offner ring-field relay buys the full ±2′ (Strehl floor 0.965, on pure spheres).</a:t>
-            </a:r>
-          </a:p>
-        </p:txBody>
-      </p:sp>
       <p:pic>
         <p:nvPicPr>
-          <p:cNvPr id="5" name="Picture 4" descr="rowpair_s1_views.png"/>
+          <p:cNvPr id="4" name="Picture 3" descr="demo2_beat5_poke.png"/>
           <p:cNvPicPr>
             <a:picLocks noChangeAspect="1"/>
           </p:cNvPicPr>
@@ -14726,8 +14634,8 @@
         </p:blipFill>
         <p:spPr>
           <a:xfrm>
-            <a:off x="6738659" y="1298448"/>
-            <a:ext cx="4719240" cy="2056892"/>
+            <a:off x="3772370" y="1298448"/>
+            <a:ext cx="4646955" cy="1782572"/>
           </a:xfrm>
           <a:prstGeom prst="rect">
             <a:avLst/>
@@ -14736,14 +14644,14 @@
       </p:pic>
       <p:sp>
         <p:nvSpPr>
-          <p:cNvPr id="6" name="TextBox 5"/>
+          <p:cNvPr id="5" name="TextBox 4"/>
           <p:cNvSpPr txBox="1"/>
           <p:nvPr/>
         </p:nvSpPr>
         <p:spPr>
           <a:xfrm>
-            <a:off x="6400800" y="3373628"/>
-            <a:ext cx="5394960" cy="229107"/>
+            <a:off x="411480" y="3099308"/>
+            <a:ext cx="11368735" cy="229107"/>
           </a:xfrm>
           <a:prstGeom prst="rect">
             <a:avLst/>
@@ -14768,14 +14676,14 @@
                 </a:solidFill>
                 <a:latin typeface="Arial"/>
               </a:rPr>
-              <a:t>The telescope as designed (front + iso views), with the traced field.</a:t>
+              <a:t>Beat 5 — one actuator poked: the fringes bend over it.</a:t>
             </a:r>
           </a:p>
         </p:txBody>
       </p:sp>
       <p:pic>
         <p:nvPicPr>
-          <p:cNvPr id="7" name="Picture 6" descr="s1_wfe_field.png"/>
+          <p:cNvPr id="6" name="Picture 5" descr="demo2_beat6_sweep.png"/>
           <p:cNvPicPr>
             <a:picLocks noChangeAspect="1"/>
           </p:cNvPicPr>
@@ -14789,8 +14697,8 @@
         </p:blipFill>
         <p:spPr>
           <a:xfrm>
-            <a:off x="7993860" y="3639312"/>
-            <a:ext cx="2208839" cy="1782572"/>
+            <a:off x="4186821" y="3364992"/>
+            <a:ext cx="3818051" cy="1782572"/>
           </a:xfrm>
           <a:prstGeom prst="rect">
             <a:avLst/>
@@ -14799,14 +14707,14 @@
       </p:pic>
       <p:sp>
         <p:nvSpPr>
-          <p:cNvPr id="8" name="TextBox 7"/>
+          <p:cNvPr id="7" name="TextBox 6"/>
           <p:cNvSpPr txBox="1"/>
           <p:nvPr/>
         </p:nvSpPr>
         <p:spPr>
           <a:xfrm>
-            <a:off x="6400800" y="5440171"/>
-            <a:ext cx="5394960" cy="229107"/>
+            <a:off x="411480" y="5165852"/>
+            <a:ext cx="11368735" cy="229107"/>
           </a:xfrm>
           <a:prstGeom prst="rect">
             <a:avLst/>
@@ -14831,11 +14739,35 @@
                 </a:solidFill>
                 <a:latin typeface="Arial"/>
               </a:rPr>
-              <a:t>Wavefront error over the field: diffraction-limited across the box.</a:t>
-            </a:r>
-          </a:p>
-        </p:txBody>
-      </p:sp>
+              <a:t>Beat 6 — the analyzer sweep: phase-stepped frames, no re-trace.</a:t>
+            </a:r>
+          </a:p>
+        </p:txBody>
+      </p:sp>
+      <p:pic>
+        <p:nvPicPr>
+          <p:cNvPr id="8" name="Picture 7" descr="demo2_beat7_recovery.png"/>
+          <p:cNvPicPr>
+            <a:picLocks noChangeAspect="1"/>
+          </p:cNvPicPr>
+          <p:nvPr/>
+        </p:nvPicPr>
+        <p:blipFill>
+          <a:blip r:embed="rId4"/>
+          <a:stretch>
+            <a:fillRect/>
+          </a:stretch>
+        </p:blipFill>
+        <p:spPr>
+          <a:xfrm>
+            <a:off x="4177857" y="5431536"/>
+            <a:ext cx="3835980" cy="1032763"/>
+          </a:xfrm>
+          <a:prstGeom prst="rect">
+            <a:avLst/>
+          </a:prstGeom>
+        </p:spPr>
+      </p:pic>
       <p:sp>
         <p:nvSpPr>
           <p:cNvPr id="9" name="TextBox 8"/>
@@ -14844,8 +14776,8 @@
         </p:nvSpPr>
         <p:spPr>
           <a:xfrm>
-            <a:off x="6400800" y="5705855"/>
-            <a:ext cx="5394960" cy="274320"/>
+            <a:off x="411480" y="6482588"/>
+            <a:ext cx="11368735" cy="229107"/>
           </a:xfrm>
           <a:prstGeom prst="rect">
             <a:avLst/>
@@ -14858,6 +14790,45 @@
           </a:bodyPr>
           <a:lstStyle/>
           <a:p>
+            <a:pPr algn="ctr">
+              <a:spcAft>
+                <a:spcPts val="0"/>
+              </a:spcAft>
+            </a:pPr>
+            <a:r>
+              <a:rPr sz="1000" b="0">
+                <a:solidFill>
+                  <a:srgbClr val="6E6E6E"/>
+                </a:solidFill>
+                <a:latin typeface="Arial"/>
+              </a:rPr>
+              <a:t>Beat 7 — the recovery beside the truth map.</a:t>
+            </a:r>
+          </a:p>
+        </p:txBody>
+      </p:sp>
+      <p:sp>
+        <p:nvSpPr>
+          <p:cNvPr id="10" name="TextBox 9"/>
+          <p:cNvSpPr txBox="1"/>
+          <p:nvPr/>
+        </p:nvSpPr>
+        <p:spPr>
+          <a:xfrm>
+            <a:off x="411480" y="6748272"/>
+            <a:ext cx="11368735" cy="274320"/>
+          </a:xfrm>
+          <a:prstGeom prst="rect">
+            <a:avLst/>
+          </a:prstGeom>
+          <a:noFill/>
+        </p:spPr>
+        <p:txBody>
+          <a:bodyPr wrap="square">
+            <a:spAutoFit/>
+          </a:bodyPr>
+          <a:lstStyle/>
+          <a:p>
             <a:pPr>
               <a:spcAft>
                 <a:spcPts val="600"/>
@@ -14870,7 +14841,7 @@
                 </a:solidFill>
                 <a:latin typeface="Arial"/>
               </a:rPr>
-              <a:t>Record: templates/80_end_to_end/e2e — staged worked example, committed at every step.</a:t>
+              <a:t>All eight beats have committed figures in templates/90_polarization/tg_psi_dm_v2 (v1 likewise); the driver opens them on the desktop as each beat runs.</a:t>
             </a:r>
           </a:p>
         </p:txBody>
@@ -14927,7 +14898,7 @@
                 </a:solidFill>
                 <a:latin typeface="Arial"/>
               </a:rPr>
-              <a:t>The e2e worked example: segmentation and metrology</a:t>
+              <a:t>The e2e worked example: specification to design</a:t>
             </a:r>
           </a:p>
           <a:p>
@@ -14943,7 +14914,7 @@
                 </a:solidFill>
                 <a:latin typeface="Arial"/>
               </a:rPr>
-              <a:t>The monolith segments in one call; the metrology is designed on the same Jacobian</a:t>
+              <a:t>A 4 m f/18 visible-band telescope from a closed-form seed — no starting prescription</a:t>
             </a:r>
           </a:p>
         </p:txBody>
@@ -15026,7 +14997,7 @@
                 </a:solidFill>
                 <a:latin typeface="Arial"/>
               </a:rPr>
-              <a:t>•  The primary segments into a pie or hex tiling with physical apertures; every segment gets rigid-body and surface-figure sensitivity channels, stacked into one Jacobian — the control basis.</a:t>
+              <a:t>•  The stage-runner sequence on the smaller worked example: specification → design → segmentation → metrology → comparison → simulation, each stage a committed runner handing its prescription to the next.</a:t>
             </a:r>
           </a:p>
           <a:p>
@@ -15042,14 +15013,14 @@
                 </a:solidFill>
                 <a:latin typeface="Arial"/>
               </a:rPr>
-              <a:t>•  Metrology is an optimization on that basis: edge-sensor and beam-launcher layouts scored by the control information they carry, not by symmetry; the winning pattern exports as a reusable preset.</a:t>
+              <a:t>•  A 4 m f/18 telescope (f/1.75 primary) from a closed-form first-order seed; diffraction-limited over ±1′ alone, and the Offner ring-field relay buys the full ±2′ (Strehl floor 0.965, on pure spheres).</a:t>
             </a:r>
           </a:p>
         </p:txBody>
       </p:sp>
       <p:pic>
         <p:nvPicPr>
-          <p:cNvPr id="5" name="Picture 4" descr="rowpair_s3_views_pie.png"/>
+          <p:cNvPr id="5" name="Picture 4" descr="rowpair_s1_views.png"/>
           <p:cNvPicPr>
             <a:picLocks noChangeAspect="1"/>
           </p:cNvPicPr>
@@ -15063,8 +15034,8 @@
         </p:blipFill>
         <p:spPr>
           <a:xfrm>
-            <a:off x="6618167" y="1298448"/>
-            <a:ext cx="4960224" cy="1965451"/>
+            <a:off x="6738659" y="1298448"/>
+            <a:ext cx="4719240" cy="2056892"/>
           </a:xfrm>
           <a:prstGeom prst="rect">
             <a:avLst/>
@@ -15079,7 +15050,7 @@
         </p:nvSpPr>
         <p:spPr>
           <a:xfrm>
-            <a:off x="6400800" y="3282188"/>
+            <a:off x="6400800" y="3373628"/>
             <a:ext cx="5394960" cy="229107"/>
           </a:xfrm>
           <a:prstGeom prst="rect">
@@ -15105,14 +15076,14 @@
                 </a:solidFill>
                 <a:latin typeface="Arial"/>
               </a:rPr>
-              <a:t>The segmented primary with physical apertures (front + iso views).</a:t>
+              <a:t>The telescope as designed (front + iso views), with the traced field.</a:t>
             </a:r>
           </a:p>
         </p:txBody>
       </p:sp>
       <p:pic>
         <p:nvPicPr>
-          <p:cNvPr id="7" name="Picture 6" descr="e2e_pie_met_view_rx.png"/>
+          <p:cNvPr id="7" name="Picture 6" descr="s1_wfe_field.png"/>
           <p:cNvPicPr>
             <a:picLocks noChangeAspect="1"/>
           </p:cNvPicPr>
@@ -15126,8 +15097,8 @@
         </p:blipFill>
         <p:spPr>
           <a:xfrm>
-            <a:off x="7662896" y="3547872"/>
-            <a:ext cx="2870767" cy="1874011"/>
+            <a:off x="7993860" y="3639312"/>
+            <a:ext cx="2208839" cy="1782572"/>
           </a:xfrm>
           <a:prstGeom prst="rect">
             <a:avLst/>
@@ -15168,7 +15139,7 @@
                 </a:solidFill>
                 <a:latin typeface="Arial"/>
               </a:rPr>
-              <a:t>The optimized metrology layout on the segmented primary.</a:t>
+              <a:t>Wavefront error over the field: diffraction-limited across the box.</a:t>
             </a:r>
           </a:p>
         </p:txBody>
@@ -15207,7 +15178,7 @@
                 </a:solidFill>
                 <a:latin typeface="Arial"/>
               </a:rPr>
-              <a:t>Record: templates/80_end_to_end/e2e, stages 3–5.</a:t>
+              <a:t>Record: templates/80_end_to_end/e2e — staged worked example, committed at every step.</a:t>
             </a:r>
           </a:p>
         </p:txBody>
@@ -15221,6 +15192,343 @@
 </file>
 
 <file path=ppt/slides/slide38.xml><?xml version="1.0" encoding="utf-8"?>
+<p:sld xmlns:a="http://schemas.openxmlformats.org/drawingml/2006/main" xmlns:p="http://schemas.openxmlformats.org/presentationml/2006/main" xmlns:r="http://schemas.openxmlformats.org/officeDocument/2006/relationships">
+  <p:cSld>
+    <p:spTree>
+      <p:nvGrpSpPr>
+        <p:cNvPr id="1" name=""/>
+        <p:cNvGrpSpPr/>
+        <p:nvPr/>
+      </p:nvGrpSpPr>
+      <p:grpSpPr/>
+      <p:sp>
+        <p:nvSpPr>
+          <p:cNvPr id="2" name="TextBox 1"/>
+          <p:cNvSpPr txBox="1"/>
+          <p:nvPr/>
+        </p:nvSpPr>
+        <p:spPr>
+          <a:xfrm>
+            <a:off x="411480" y="201168"/>
+            <a:ext cx="11368735" cy="914400"/>
+          </a:xfrm>
+          <a:prstGeom prst="rect">
+            <a:avLst/>
+          </a:prstGeom>
+          <a:noFill/>
+        </p:spPr>
+        <p:txBody>
+          <a:bodyPr wrap="square">
+            <a:spAutoFit/>
+          </a:bodyPr>
+          <a:lstStyle/>
+          <a:p>
+            <a:pPr>
+              <a:spcAft>
+                <a:spcPts val="400"/>
+              </a:spcAft>
+            </a:pPr>
+            <a:r>
+              <a:rPr sz="2400" b="1">
+                <a:solidFill>
+                  <a:srgbClr val="1F4E79"/>
+                </a:solidFill>
+                <a:latin typeface="Arial"/>
+              </a:rPr>
+              <a:t>The e2e worked example: segmentation and metrology</a:t>
+            </a:r>
+          </a:p>
+          <a:p>
+            <a:pPr>
+              <a:spcAft>
+                <a:spcPts val="0"/>
+              </a:spcAft>
+            </a:pPr>
+            <a:r>
+              <a:rPr sz="1250" b="0">
+                <a:solidFill>
+                  <a:srgbClr val="6E6E6E"/>
+                </a:solidFill>
+                <a:latin typeface="Arial"/>
+              </a:rPr>
+              <a:t>The monolith segments in one call; the metrology is designed on the same Jacobian</a:t>
+            </a:r>
+          </a:p>
+        </p:txBody>
+      </p:sp>
+      <p:sp>
+        <p:nvSpPr>
+          <p:cNvPr id="3" name="Rectangle 2"/>
+          <p:cNvSpPr/>
+          <p:nvPr/>
+        </p:nvSpPr>
+        <p:spPr>
+          <a:xfrm>
+            <a:off x="411480" y="1133856"/>
+            <a:ext cx="11368735" cy="20320"/>
+          </a:xfrm>
+          <a:prstGeom prst="rect">
+            <a:avLst/>
+          </a:prstGeom>
+          <a:solidFill>
+            <a:srgbClr val="B8C6D4"/>
+          </a:solidFill>
+          <a:ln>
+            <a:noFill/>
+          </a:ln>
+          <a:effectLst/>
+        </p:spPr>
+        <p:style>
+          <a:lnRef idx="1">
+            <a:schemeClr val="accent1"/>
+          </a:lnRef>
+          <a:fillRef idx="3">
+            <a:schemeClr val="accent1"/>
+          </a:fillRef>
+          <a:effectRef idx="2">
+            <a:schemeClr val="accent1"/>
+          </a:effectRef>
+          <a:fontRef idx="minor">
+            <a:schemeClr val="lt1"/>
+          </a:fontRef>
+        </p:style>
+        <p:txBody>
+          <a:bodyPr rtlCol="0" anchor="ctr"/>
+          <a:lstStyle/>
+          <a:p>
+            <a:pPr algn="ctr"/>
+          </a:p>
+        </p:txBody>
+      </p:sp>
+      <p:sp>
+        <p:nvSpPr>
+          <p:cNvPr id="4" name="TextBox 3"/>
+          <p:cNvSpPr txBox="1"/>
+          <p:nvPr/>
+        </p:nvSpPr>
+        <p:spPr>
+          <a:xfrm>
+            <a:off x="411480" y="1298448"/>
+            <a:ext cx="5806440" cy="274320"/>
+          </a:xfrm>
+          <a:prstGeom prst="rect">
+            <a:avLst/>
+          </a:prstGeom>
+          <a:noFill/>
+        </p:spPr>
+        <p:txBody>
+          <a:bodyPr wrap="square">
+            <a:spAutoFit/>
+          </a:bodyPr>
+          <a:lstStyle/>
+          <a:p>
+            <a:pPr>
+              <a:spcAft>
+                <a:spcPts val="600"/>
+              </a:spcAft>
+            </a:pPr>
+            <a:r>
+              <a:rPr sz="1200" b="0">
+                <a:solidFill>
+                  <a:srgbClr val="282828"/>
+                </a:solidFill>
+                <a:latin typeface="Arial"/>
+              </a:rPr>
+              <a:t>•  The primary segments into a pie or hex tiling with physical apertures; every segment gets rigid-body and surface-figure sensitivity channels, stacked into one Jacobian — the control basis.</a:t>
+            </a:r>
+          </a:p>
+          <a:p>
+            <a:pPr>
+              <a:spcAft>
+                <a:spcPts val="600"/>
+              </a:spcAft>
+            </a:pPr>
+            <a:r>
+              <a:rPr sz="1200" b="0">
+                <a:solidFill>
+                  <a:srgbClr val="282828"/>
+                </a:solidFill>
+                <a:latin typeface="Arial"/>
+              </a:rPr>
+              <a:t>•  Metrology is an optimization on that basis: edge-sensor and beam-launcher layouts scored by the control information they carry, not by symmetry; the winning pattern exports as a reusable preset.</a:t>
+            </a:r>
+          </a:p>
+        </p:txBody>
+      </p:sp>
+      <p:pic>
+        <p:nvPicPr>
+          <p:cNvPr id="5" name="Picture 4" descr="rowpair_s3_views_pie.png"/>
+          <p:cNvPicPr>
+            <a:picLocks noChangeAspect="1"/>
+          </p:cNvPicPr>
+          <p:nvPr/>
+        </p:nvPicPr>
+        <p:blipFill>
+          <a:blip r:embed="rId2"/>
+          <a:stretch>
+            <a:fillRect/>
+          </a:stretch>
+        </p:blipFill>
+        <p:spPr>
+          <a:xfrm>
+            <a:off x="6618167" y="1298448"/>
+            <a:ext cx="4960224" cy="1965451"/>
+          </a:xfrm>
+          <a:prstGeom prst="rect">
+            <a:avLst/>
+          </a:prstGeom>
+        </p:spPr>
+      </p:pic>
+      <p:sp>
+        <p:nvSpPr>
+          <p:cNvPr id="6" name="TextBox 5"/>
+          <p:cNvSpPr txBox="1"/>
+          <p:nvPr/>
+        </p:nvSpPr>
+        <p:spPr>
+          <a:xfrm>
+            <a:off x="6400800" y="3282188"/>
+            <a:ext cx="5394960" cy="229107"/>
+          </a:xfrm>
+          <a:prstGeom prst="rect">
+            <a:avLst/>
+          </a:prstGeom>
+          <a:noFill/>
+        </p:spPr>
+        <p:txBody>
+          <a:bodyPr wrap="square">
+            <a:spAutoFit/>
+          </a:bodyPr>
+          <a:lstStyle/>
+          <a:p>
+            <a:pPr algn="ctr">
+              <a:spcAft>
+                <a:spcPts val="0"/>
+              </a:spcAft>
+            </a:pPr>
+            <a:r>
+              <a:rPr sz="1000" b="0">
+                <a:solidFill>
+                  <a:srgbClr val="6E6E6E"/>
+                </a:solidFill>
+                <a:latin typeface="Arial"/>
+              </a:rPr>
+              <a:t>The segmented primary with physical apertures (front + iso views).</a:t>
+            </a:r>
+          </a:p>
+        </p:txBody>
+      </p:sp>
+      <p:pic>
+        <p:nvPicPr>
+          <p:cNvPr id="7" name="Picture 6" descr="e2e_pie_met_view_rx.png"/>
+          <p:cNvPicPr>
+            <a:picLocks noChangeAspect="1"/>
+          </p:cNvPicPr>
+          <p:nvPr/>
+        </p:nvPicPr>
+        <p:blipFill>
+          <a:blip r:embed="rId3"/>
+          <a:stretch>
+            <a:fillRect/>
+          </a:stretch>
+        </p:blipFill>
+        <p:spPr>
+          <a:xfrm>
+            <a:off x="7662896" y="3547872"/>
+            <a:ext cx="2870767" cy="1874011"/>
+          </a:xfrm>
+          <a:prstGeom prst="rect">
+            <a:avLst/>
+          </a:prstGeom>
+        </p:spPr>
+      </p:pic>
+      <p:sp>
+        <p:nvSpPr>
+          <p:cNvPr id="8" name="TextBox 7"/>
+          <p:cNvSpPr txBox="1"/>
+          <p:nvPr/>
+        </p:nvSpPr>
+        <p:spPr>
+          <a:xfrm>
+            <a:off x="6400800" y="5440171"/>
+            <a:ext cx="5394960" cy="229107"/>
+          </a:xfrm>
+          <a:prstGeom prst="rect">
+            <a:avLst/>
+          </a:prstGeom>
+          <a:noFill/>
+        </p:spPr>
+        <p:txBody>
+          <a:bodyPr wrap="square">
+            <a:spAutoFit/>
+          </a:bodyPr>
+          <a:lstStyle/>
+          <a:p>
+            <a:pPr algn="ctr">
+              <a:spcAft>
+                <a:spcPts val="0"/>
+              </a:spcAft>
+            </a:pPr>
+            <a:r>
+              <a:rPr sz="1000" b="0">
+                <a:solidFill>
+                  <a:srgbClr val="6E6E6E"/>
+                </a:solidFill>
+                <a:latin typeface="Arial"/>
+              </a:rPr>
+              <a:t>The optimized metrology layout on the segmented primary.</a:t>
+            </a:r>
+          </a:p>
+        </p:txBody>
+      </p:sp>
+      <p:sp>
+        <p:nvSpPr>
+          <p:cNvPr id="9" name="TextBox 8"/>
+          <p:cNvSpPr txBox="1"/>
+          <p:nvPr/>
+        </p:nvSpPr>
+        <p:spPr>
+          <a:xfrm>
+            <a:off x="6400800" y="5705855"/>
+            <a:ext cx="5394960" cy="274320"/>
+          </a:xfrm>
+          <a:prstGeom prst="rect">
+            <a:avLst/>
+          </a:prstGeom>
+          <a:noFill/>
+        </p:spPr>
+        <p:txBody>
+          <a:bodyPr wrap="square">
+            <a:spAutoFit/>
+          </a:bodyPr>
+          <a:lstStyle/>
+          <a:p>
+            <a:pPr>
+              <a:spcAft>
+                <a:spcPts val="600"/>
+              </a:spcAft>
+            </a:pPr>
+            <a:r>
+              <a:rPr sz="1050" b="0">
+                <a:solidFill>
+                  <a:srgbClr val="6E6E6E"/>
+                </a:solidFill>
+                <a:latin typeface="Arial"/>
+              </a:rPr>
+              <a:t>Record: templates/80_end_to_end/e2e, stages 3–5.</a:t>
+            </a:r>
+          </a:p>
+        </p:txBody>
+      </p:sp>
+    </p:spTree>
+  </p:cSld>
+  <p:clrMapOvr>
+    <a:masterClrMapping/>
+  </p:clrMapOvr>
+</p:sld>
+</file>
+
+<file path=ppt/slides/slide39.xml><?xml version="1.0" encoding="utf-8"?>
 <p:sld xmlns:a="http://schemas.openxmlformats.org/drawingml/2006/main" xmlns:p="http://schemas.openxmlformats.org/presentationml/2006/main" xmlns:r="http://schemas.openxmlformats.org/officeDocument/2006/relationships">
   <p:cSld>
     <p:spTree>

</xml_diff>

<commit_message>
deck: physical-optics math slide added (PSF, field Jacobian from repeated propagations, polarization); linear-model slide retitled as its pair (Dave 2026-08-31)
E = A e^(-i2pi w/lambda) seeded from the ray trace; Fresnel/angular-
spectrum plane-to-plane kernels; I=|E|^2 and the Strehl-normalized
dark-zone contrast; G columns as full-chain propagations per actuator
poke feeding the Tikhonov EFC step (moved here from the linear slide);
polarization via s/p Fresnel + Airy-recursion coatings, 3-plane vector
diffraction, and the Jones pupil.  Footnote states the exp(+i omega t)
convention and the validation anchors.  Deck 40 slides.

Co-Authored-By: Claude Fable 5 <noreply@anthropic.com>
</commit_message>
<xml_diff>
--- a/demo_session/baseline_pass3.pptx
+++ b/demo_session/baseline_pass3.pptx
@@ -44,6 +44,7 @@
     <p:sldId id="292" r:id="rId43"/>
     <p:sldId id="293" r:id="rId44"/>
     <p:sldId id="294" r:id="rId45"/>
+    <p:sldId id="295" r:id="rId46"/>
   </p:sldIdLst>
   <p:sldSz cx="12191695" cy="6858000" type="screen4x3"/>
   <p:notesSz cx="6858000" cy="9144000"/>
@@ -9522,7 +9523,7 @@
                 </a:solidFill>
                 <a:latin typeface="Arial"/>
               </a:rPr>
-              <a:t>The linear model: the mathematics under the next six slides</a:t>
+              <a:t>The linear model: state to wavefront to control</a:t>
             </a:r>
           </a:p>
           <a:p>
@@ -9637,7 +9638,7 @@
                 </a:solidFill>
                 <a:latin typeface="Arial"/>
               </a:rPr>
-              <a:t>–  x stacks rigid-body states (6 DOF per optic and per group), segment Zernike figure modes, and grid/actuator influences; J's columns are engine-measured pokes through the full train, per field — the three families on the next three slides.</a:t>
+              <a:t>–  x stacks rigid-body states (6 DOF per optic and per group), segment Zernike figure modes, and grid/actuator influences; J's columns are engine-measured pokes through the full train, per field — the three families on the following slides.</a:t>
             </a:r>
           </a:p>
           <a:p>
@@ -9702,38 +9703,6 @@
                 <a:latin typeface="Arial"/>
               </a:rPr>
               <a:t>–  BLUE: weighted least squares with a ridge on the segment state; an integrator closes the rigid-body loop each frame.</a:t>
-            </a:r>
-          </a:p>
-          <a:p>
-            <a:pPr>
-              <a:spcAft>
-                <a:spcPts val="600"/>
-              </a:spcAft>
-            </a:pPr>
-            <a:r>
-              <a:rPr sz="1500" b="0">
-                <a:solidFill>
-                  <a:srgbClr val="282828"/>
-                </a:solidFill>
-                <a:latin typeface="Arial"/>
-              </a:rPr>
-              <a:t>•  Dark-hole control (EFC):   Δa  =  −( Re(GᴴG) + λI )⁻¹ Re(GᴴE)</a:t>
-            </a:r>
-          </a:p>
-          <a:p>
-            <a:pPr marL="594360" indent="-137160">
-              <a:spcAft>
-                <a:spcPts val="500"/>
-              </a:spcAft>
-            </a:pPr>
-            <a:r>
-              <a:rPr sz="1300" b="0">
-                <a:solidFill>
-                  <a:srgbClr val="6E6E6E"/>
-                </a:solidFill>
-                <a:latin typeface="Arial"/>
-              </a:rPr>
-              <a:t>–  G = ∂E/∂a, the electric-field Jacobian of the DM actuators through the masked chain, engine-measured; a Tikhonov step, line-searched against measured contrast.</a:t>
             </a:r>
           </a:p>
         </p:txBody>
@@ -9746,7 +9715,7 @@
         </p:nvSpPr>
         <p:spPr>
           <a:xfrm>
-            <a:off x="411480" y="4898898"/>
+            <a:off x="411480" y="3954272"/>
             <a:ext cx="11368735" cy="274320"/>
           </a:xfrm>
           <a:prstGeom prst="rect">
@@ -9772,7 +9741,7 @@
                 </a:solidFill>
                 <a:latin typeface="Arial"/>
               </a:rPr>
-              <a:t>Notation as in the code: run_sensitivities builds the J families; the MET stage scores layouts on the trace merit; the simulator (r4) runs the BLUE estimator, the integrator, and the EFC step — and jacobian_check re-pokes the engine against every J before it is trusted.</a:t>
+              <a:t>Notation as in the code: run_sensitivities builds the J families; the MET stage scores layouts on the trace merit; the simulator runs the BLUE estimator and integrator — and jacobian_check re-pokes the engine against every J before it is trusted.</a:t>
             </a:r>
           </a:p>
         </p:txBody>
@@ -9829,7 +9798,7 @@
                 </a:solidFill>
                 <a:latin typeface="Arial"/>
               </a:rPr>
-              <a:t>Segmentation, metrology, controls — on the observatory</a:t>
+              <a:t>The physical-optics model: wavefront to field to contrast</a:t>
             </a:r>
           </a:p>
           <a:p>
@@ -9845,7 +9814,7 @@
                 </a:solidFill>
                 <a:latin typeface="Arial"/>
               </a:rPr>
-              <a:t>The same segmentation and metrology machinery the smaller studies proved, at 6 m scale</a:t>
+              <a:t>The same engine — every plane PROPER-checked, every coating checked against the Fresnel closed forms</a:t>
             </a:r>
           </a:p>
         </p:txBody>
@@ -9903,7 +9872,7 @@
         <p:spPr>
           <a:xfrm>
             <a:off x="411480" y="1298448"/>
-            <a:ext cx="5806440" cy="274320"/>
+            <a:ext cx="11368735" cy="274320"/>
           </a:xfrm>
           <a:prstGeom prst="rect">
             <a:avLst/>
@@ -9922,13 +9891,29 @@
               </a:spcAft>
             </a:pPr>
             <a:r>
-              <a:rPr sz="1600" b="0">
+              <a:rPr sz="1500" b="0">
                 <a:solidFill>
                   <a:srgbClr val="282828"/>
                 </a:solidFill>
                 <a:latin typeface="Arial"/>
               </a:rPr>
-              <a:t>•  The primary segments hex-19 with physical apertures through the same segmentation product; every segment gets rigid-body and surface-figure sensitivity channels, stacked into one Jacobian — the control basis.</a:t>
+              <a:t>•  From rays to fields:   E  =  A·e^(−i·2πw/λ)   at each pupil;   plane to plane   E′ = F⁻¹[ e^(−iπλΔz·f²) F[E] ] ;   to a focal plane   E_focal ∝ F[E]</a:t>
+            </a:r>
+          </a:p>
+          <a:p>
+            <a:pPr marL="594360" indent="-137160">
+              <a:spcAft>
+                <a:spcPts val="500"/>
+              </a:spcAft>
+            </a:pPr>
+            <a:r>
+              <a:rPr sz="1300" b="0">
+                <a:solidFill>
+                  <a:srgbClr val="6E6E6E"/>
+                </a:solidFill>
+                <a:latin typeface="Arial"/>
+              </a:rPr>
+              <a:t>–  the ray-traced OPD w and aperture A seed the grid; Fresnel / angular-spectrum kernels carry it through apodizer, focal-plane mask, Lyot stop and field stop — the masks act on the field, plane by plane.</a:t>
             </a:r>
           </a:p>
           <a:p>
@@ -9938,13 +9923,29 @@
               </a:spcAft>
             </a:pPr>
             <a:r>
-              <a:rPr sz="1600" b="0">
+              <a:rPr sz="1500" b="0">
                 <a:solidFill>
                   <a:srgbClr val="282828"/>
                 </a:solidFill>
                 <a:latin typeface="Arial"/>
               </a:rPr>
-              <a:t>•  Metrology and edge sensors are designed ON that Jacobian — 114 beams from the launcher stations shown — and the same matrices drive the estimator and the closed loop.</a:t>
+              <a:t>•  The image and the score:   I = |E|² ;   contrast C = ⟨ I / I₀,peak ⟩ over the 3–15 λ/D dark zone</a:t>
+            </a:r>
+          </a:p>
+          <a:p>
+            <a:pPr marL="594360" indent="-137160">
+              <a:spcAft>
+                <a:spcPts val="500"/>
+              </a:spcAft>
+            </a:pPr>
+            <a:r>
+              <a:rPr sz="1300" b="0">
+                <a:solidFill>
+                  <a:srgbClr val="6E6E6E"/>
+                </a:solidFill>
+                <a:latin typeface="Arial"/>
+              </a:rPr>
+              <a:t>–  Strehl-normalized to the bare unmasked peak; one grid and one normalization for Jacobian, control and scoring.</a:t>
             </a:r>
           </a:p>
           <a:p>
@@ -9954,52 +9955,75 @@
               </a:spcAft>
             </a:pPr>
             <a:r>
-              <a:rPr sz="1600" b="0">
+              <a:rPr sz="1500" b="0">
                 <a:solidFill>
                   <a:srgbClr val="282828"/>
                 </a:solidFill>
                 <a:latin typeface="Arial"/>
               </a:rPr>
-              <a:t>•  The channels themselves — dw/dx, dw/dz, dw/dgrid — follow on the next three slides, at readable size.</a:t>
-            </a:r>
-          </a:p>
-        </p:txBody>
-      </p:sp>
-      <p:pic>
-        <p:nvPicPr>
-          <p:cNvPr id="5" name="Picture 4" descr="r3_met_view_rx.png"/>
-          <p:cNvPicPr>
-            <a:picLocks noChangeAspect="1"/>
-          </p:cNvPicPr>
-          <p:nvPr/>
-        </p:nvPicPr>
-        <p:blipFill>
-          <a:blip r:embed="rId2"/>
-          <a:srcRect l="29400" r="29400" t="4200" b="5900"/>
-          <a:stretch>
-            <a:fillRect/>
-          </a:stretch>
-        </p:blipFill>
-        <p:spPr>
-          <a:xfrm>
-            <a:off x="7315200" y="1298448"/>
-            <a:ext cx="4114800" cy="5477256"/>
-          </a:xfrm>
-          <a:prstGeom prst="rect">
-            <a:avLst/>
-          </a:prstGeom>
-        </p:spPr>
-      </p:pic>
-      <p:sp>
-        <p:nvSpPr>
-          <p:cNvPr id="6" name="TextBox 5"/>
+              <a:t>•  The field Jacobian, from repeated propagations:   G(:,k) = [ E(a+δeₖ) − E(a) ] / δ   →   Δa = −( Re(GᴴG) + λI )⁻¹ Re(GᴴE)</a:t>
+            </a:r>
+          </a:p>
+          <a:p>
+            <a:pPr marL="594360" indent="-137160">
+              <a:spcAft>
+                <a:spcPts val="500"/>
+              </a:spcAft>
+            </a:pPr>
+            <a:r>
+              <a:rPr sz="1300" b="0">
+                <a:solidFill>
+                  <a:srgbClr val="6E6E6E"/>
+                </a:solidFill>
+                <a:latin typeface="Arial"/>
+              </a:rPr>
+              <a:t>–  every column is one full-chain propagation with actuator k poked; the EFC step is Tikhonov, line-searched against measured contrast — and re-linearized about the dug state as the hole deepens.</a:t>
+            </a:r>
+          </a:p>
+          <a:p>
+            <a:pPr>
+              <a:spcAft>
+                <a:spcPts val="600"/>
+              </a:spcAft>
+            </a:pPr>
+            <a:r>
+              <a:rPr sz="1500" b="0">
+                <a:solidFill>
+                  <a:srgbClr val="282828"/>
+                </a:solidFill>
+                <a:latin typeface="Arial"/>
+              </a:rPr>
+              <a:t>•  Polarization:   at each surface  E → ( r_s ŝŝᵀ + r_p p̂p̂ᵀ )·E  (multilayer coatings by the Airy recursion);  vector diffraction propagates Ex, Ey, Ez as three planes;  the Jones pupil J(u,v) yields diattenuation and retardance maps</a:t>
+            </a:r>
+          </a:p>
+          <a:p>
+            <a:pPr marL="594360" indent="-137160">
+              <a:spcAft>
+                <a:spcPts val="500"/>
+              </a:spcAft>
+            </a:pPr>
+            <a:r>
+              <a:rPr sz="1300" b="0">
+                <a:solidFill>
+                  <a:srgbClr val="6E6E6E"/>
+                </a:solidFill>
+                <a:latin typeface="Arial"/>
+              </a:rPr>
+              <a:t>–  the machinery behind the interferometer demo and the coated-train contrast floors.</a:t>
+            </a:r>
+          </a:p>
+        </p:txBody>
+      </p:sp>
+      <p:sp>
+        <p:nvSpPr>
+          <p:cNvPr id="5" name="TextBox 4"/>
           <p:cNvSpPr txBox="1"/>
           <p:nvPr/>
         </p:nvSpPr>
         <p:spPr>
           <a:xfrm>
-            <a:off x="4535424" y="4169663"/>
-            <a:ext cx="2514600" cy="1054608"/>
+            <a:off x="411480" y="5427218"/>
+            <a:ext cx="11368735" cy="274320"/>
           </a:xfrm>
           <a:prstGeom prst="rect">
             <a:avLst/>
@@ -10012,58 +10036,19 @@
           </a:bodyPr>
           <a:lstStyle/>
           <a:p>
-            <a:pPr algn="ctr">
-              <a:spcAft>
-                <a:spcPts val="0"/>
-              </a:spcAft>
-            </a:pPr>
-            <a:r>
-              <a:rPr sz="1500" b="0">
+            <a:pPr>
+              <a:spcAft>
+                <a:spcPts val="600"/>
+              </a:spcAft>
+            </a:pPr>
+            <a:r>
+              <a:rPr sz="1050" b="0">
                 <a:solidFill>
                   <a:srgbClr val="6E6E6E"/>
                 </a:solidFill>
                 <a:latin typeface="Arial"/>
               </a:rPr>
-              <a:t>The metrology on the observatory: 24 elements, 114 MET beams to the aft launcher station.</a:t>
-            </a:r>
-          </a:p>
-        </p:txBody>
-      </p:sp>
-      <p:sp>
-        <p:nvSpPr>
-          <p:cNvPr id="7" name="TextBox 6"/>
-          <p:cNvSpPr txBox="1"/>
-          <p:nvPr/>
-        </p:nvSpPr>
-        <p:spPr>
-          <a:xfrm>
-            <a:off x="3063240" y="6382512"/>
-            <a:ext cx="5394960" cy="274320"/>
-          </a:xfrm>
-          <a:prstGeom prst="rect">
-            <a:avLst/>
-          </a:prstGeom>
-          <a:noFill/>
-        </p:spPr>
-        <p:txBody>
-          <a:bodyPr wrap="square">
-            <a:spAutoFit/>
-          </a:bodyPr>
-          <a:lstStyle/>
-          <a:p>
-            <a:pPr>
-              <a:spcAft>
-                <a:spcPts val="600"/>
-              </a:spcAft>
-            </a:pPr>
-            <a:r>
-              <a:rPr sz="1050" b="0">
-                <a:solidFill>
-                  <a:srgbClr val="6E6E6E"/>
-                </a:solidFill>
-                <a:latin typeface="Arial"/>
-              </a:rPr>
-              <a:t>Record: templates/80_end_to_end/e2e6m_r2, sensitivities + MET stages.</a:t>
+              <a:t>Conventions: exp(+iωt) time dependence, so phase = −2πw/λ.  Anchors: PROPER station by station at 10⁻¹¹–10⁻¹³; coatings against Born &amp; Wolf / Abelès at 10⁻¹²–10⁻¹⁴; published protected-Al Mueller data at ~10⁻¹⁴.</a:t>
             </a:r>
           </a:p>
         </p:txBody>
@@ -10120,7 +10105,7 @@
                 </a:solidFill>
                 <a:latin typeface="Arial"/>
               </a:rPr>
-              <a:t>The control basis I: rigid-body channels — dw/dx</a:t>
+              <a:t>Segmentation, metrology, controls — on the observatory</a:t>
             </a:r>
           </a:p>
           <a:p>
@@ -10136,7 +10121,7 @@
                 </a:solidFill>
                 <a:latin typeface="Arial"/>
               </a:rPr>
-              <a:t>Runner: macos.dw_dx_multi, harvested by run_sensitivities (stage r3) — OPD at the coronagraph exit pupil per unit rigid-body motion</a:t>
+              <a:t>The same segmentation and metrology machinery the smaller studies proved, at 6 m scale</a:t>
             </a:r>
           </a:p>
         </p:txBody>
@@ -10185,9 +10170,80 @@
           </a:p>
         </p:txBody>
       </p:sp>
+      <p:sp>
+        <p:nvSpPr>
+          <p:cNvPr id="4" name="TextBox 3"/>
+          <p:cNvSpPr txBox="1"/>
+          <p:nvPr/>
+        </p:nvSpPr>
+        <p:spPr>
+          <a:xfrm>
+            <a:off x="411480" y="1298448"/>
+            <a:ext cx="5806440" cy="274320"/>
+          </a:xfrm>
+          <a:prstGeom prst="rect">
+            <a:avLst/>
+          </a:prstGeom>
+          <a:noFill/>
+        </p:spPr>
+        <p:txBody>
+          <a:bodyPr wrap="square">
+            <a:spAutoFit/>
+          </a:bodyPr>
+          <a:lstStyle/>
+          <a:p>
+            <a:pPr>
+              <a:spcAft>
+                <a:spcPts val="600"/>
+              </a:spcAft>
+            </a:pPr>
+            <a:r>
+              <a:rPr sz="1600" b="0">
+                <a:solidFill>
+                  <a:srgbClr val="282828"/>
+                </a:solidFill>
+                <a:latin typeface="Arial"/>
+              </a:rPr>
+              <a:t>•  The primary segments hex-19 with physical apertures through the same segmentation product; every segment gets rigid-body and surface-figure sensitivity channels, stacked into one Jacobian — the control basis.</a:t>
+            </a:r>
+          </a:p>
+          <a:p>
+            <a:pPr>
+              <a:spcAft>
+                <a:spcPts val="600"/>
+              </a:spcAft>
+            </a:pPr>
+            <a:r>
+              <a:rPr sz="1600" b="0">
+                <a:solidFill>
+                  <a:srgbClr val="282828"/>
+                </a:solidFill>
+                <a:latin typeface="Arial"/>
+              </a:rPr>
+              <a:t>•  Metrology and edge sensors are designed ON that Jacobian — 114 beams from the launcher stations shown — and the same matrices drive the estimator and the closed loop.</a:t>
+            </a:r>
+          </a:p>
+          <a:p>
+            <a:pPr>
+              <a:spcAft>
+                <a:spcPts val="600"/>
+              </a:spcAft>
+            </a:pPr>
+            <a:r>
+              <a:rPr sz="1600" b="0">
+                <a:solidFill>
+                  <a:srgbClr val="282828"/>
+                </a:solidFill>
+                <a:latin typeface="Arial"/>
+              </a:rPr>
+              <a:t>•  The channels themselves — dw/dx, dw/dz, dw/dgrid — follow on the next three slides, at readable size.</a:t>
+            </a:r>
+          </a:p>
+        </p:txBody>
+      </p:sp>
       <p:pic>
         <p:nvPicPr>
-          <p:cNvPr id="4" name="Picture 3" descr="fig_dwdx_read.png"/>
+          <p:cNvPr id="5" name="Picture 4" descr="r3_met_view_rx.png"/>
           <p:cNvPicPr>
             <a:picLocks noChangeAspect="1"/>
           </p:cNvPicPr>
@@ -10195,14 +10251,15 @@
         </p:nvPicPr>
         <p:blipFill>
           <a:blip r:embed="rId2"/>
+          <a:srcRect l="29400" r="29400" t="4200" b="5900"/>
           <a:stretch>
             <a:fillRect/>
           </a:stretch>
         </p:blipFill>
         <p:spPr>
           <a:xfrm>
-            <a:off x="948630" y="1298448"/>
-            <a:ext cx="10294434" cy="2732532"/>
+            <a:off x="7315200" y="1298448"/>
+            <a:ext cx="4114800" cy="5477256"/>
           </a:xfrm>
           <a:prstGeom prst="rect">
             <a:avLst/>
@@ -10211,14 +10268,14 @@
       </p:pic>
       <p:sp>
         <p:nvSpPr>
-          <p:cNvPr id="5" name="TextBox 4"/>
+          <p:cNvPr id="6" name="TextBox 5"/>
           <p:cNvSpPr txBox="1"/>
           <p:nvPr/>
         </p:nvSpPr>
         <p:spPr>
           <a:xfrm>
-            <a:off x="411480" y="4049267"/>
-            <a:ext cx="11368735" cy="608838"/>
+            <a:off x="4535424" y="4169663"/>
+            <a:ext cx="2514600" cy="1054608"/>
           </a:xfrm>
           <a:prstGeom prst="rect">
             <a:avLst/>
@@ -10237,27 +10294,27 @@
               </a:spcAft>
             </a:pPr>
             <a:r>
-              <a:rPr sz="1100" b="0">
+              <a:rPr sz="1500" b="0">
                 <a:solidFill>
                   <a:srgbClr val="6E6E6E"/>
                 </a:solidFill>
                 <a:latin typeface="Arial"/>
               </a:rPr>
-              <a:t>Two rigid-body channels: the centre segment (E1) and an outer-ring segment (E8), x-rotation — the centre-field OPD at full size, then the same channel at all five fields, every pupil full.  Drawn from the round-1-train harvest, whose stops pass the whole box; the r2-train harvest matches at the centre field, but its DM-bearing coronagraph clips the corners — that instrument works the centre field.  Piston removed; 1–99% color scale.</a:t>
-            </a:r>
-          </a:p>
-        </p:txBody>
-      </p:sp>
-      <p:sp>
-        <p:nvSpPr>
-          <p:cNvPr id="6" name="TextBox 5"/>
+              <a:t>The metrology on the observatory: 24 elements, 114 MET beams to the aft launcher station.</a:t>
+            </a:r>
+          </a:p>
+        </p:txBody>
+      </p:sp>
+      <p:sp>
+        <p:nvSpPr>
+          <p:cNvPr id="7" name="TextBox 6"/>
           <p:cNvSpPr txBox="1"/>
           <p:nvPr/>
         </p:nvSpPr>
         <p:spPr>
           <a:xfrm>
-            <a:off x="411480" y="4694682"/>
-            <a:ext cx="11368735" cy="274320"/>
+            <a:off x="3063240" y="6382512"/>
+            <a:ext cx="5394960" cy="274320"/>
           </a:xfrm>
           <a:prstGeom prst="rect">
             <a:avLst/>
@@ -10276,52 +10333,13 @@
               </a:spcAft>
             </a:pPr>
             <a:r>
-              <a:rPr sz="1500" b="0">
-                <a:solidFill>
-                  <a:srgbClr val="282828"/>
-                </a:solidFill>
-                <a:latin typeface="Arial"/>
-              </a:rPr>
-              <a:t>•  Six rigid-body DOFs for every optic — the 19 segments, M2-M4, both DMs, the 8 OAPs — plus the whole primary as one rigid group, five fields each, stacked into the control Jacobian.  The response lives on the moved segment's footprint and walks with field.  The coronagraph works the center field only — its stops vignette the corners; the imaging leg sees the full box.</a:t>
-            </a:r>
-          </a:p>
-        </p:txBody>
-      </p:sp>
-      <p:sp>
-        <p:nvSpPr>
-          <p:cNvPr id="7" name="TextBox 6"/>
-          <p:cNvSpPr txBox="1"/>
-          <p:nvPr/>
-        </p:nvSpPr>
-        <p:spPr>
-          <a:xfrm>
-            <a:off x="411480" y="5862065"/>
-            <a:ext cx="11368735" cy="274320"/>
-          </a:xfrm>
-          <a:prstGeom prst="rect">
-            <a:avLst/>
-          </a:prstGeom>
-          <a:noFill/>
-        </p:spPr>
-        <p:txBody>
-          <a:bodyPr wrap="square">
-            <a:spAutoFit/>
-          </a:bodyPr>
-          <a:lstStyle/>
-          <a:p>
-            <a:pPr>
-              <a:spcAft>
-                <a:spcPts val="600"/>
-              </a:spcAft>
-            </a:pPr>
-            <a:r>
-              <a:rPr sz="1200" b="0">
+              <a:rPr sz="1050" b="0">
                 <a:solidFill>
                   <a:srgbClr val="6E6E6E"/>
                 </a:solidFill>
                 <a:latin typeface="Arial"/>
               </a:rPr>
-              <a:t>Harvest on r1_seg_prop.in, the deck the simulator propagates; per-field FEX reset; closure gated by jacobian_check.  Every panel is one line from the saved Jacobian: OPD = v2m(dwdx(:,k), indx).  Record: templates/80_end_to_end/e2e6m_r2.</a:t>
+              <a:t>Record: templates/80_end_to_end/e2e6m_r2, sensitivities + MET stages.</a:t>
             </a:r>
           </a:p>
         </p:txBody>
@@ -10378,7 +10396,7 @@
                 </a:solidFill>
                 <a:latin typeface="Arial"/>
               </a:rPr>
-              <a:t>The control basis II: segment-figure channels — dw/dz</a:t>
+              <a:t>The control basis I: rigid-body channels — dw/dx</a:t>
             </a:r>
           </a:p>
           <a:p>
@@ -10394,7 +10412,7 @@
                 </a:solidFill>
                 <a:latin typeface="Arial"/>
               </a:rPr>
-              <a:t>Runner: macos.dw_dz_zernike_multi, harvested by run_sensitivities (stage r3) — MonZernike modes 4–11 on each segment</a:t>
+              <a:t>Runner: macos.dw_dx_multi, harvested by run_sensitivities (stage r3) — OPD at the coronagraph exit pupil per unit rigid-body motion</a:t>
             </a:r>
           </a:p>
         </p:txBody>
@@ -10445,7 +10463,7 @@
       </p:sp>
       <p:pic>
         <p:nvPicPr>
-          <p:cNvPr id="4" name="Picture 3" descr="fig_dwdz_read.png"/>
+          <p:cNvPr id="4" name="Picture 3" descr="fig_dwdx_read.png"/>
           <p:cNvPicPr>
             <a:picLocks noChangeAspect="1"/>
           </p:cNvPicPr>
@@ -10459,8 +10477,8 @@
         </p:blipFill>
         <p:spPr>
           <a:xfrm>
-            <a:off x="637634" y="1298448"/>
-            <a:ext cx="10916426" cy="2897632"/>
+            <a:off x="948630" y="1298448"/>
+            <a:ext cx="10294434" cy="2732532"/>
           </a:xfrm>
           <a:prstGeom prst="rect">
             <a:avLst/>
@@ -10475,8 +10493,8 @@
         </p:nvSpPr>
         <p:spPr>
           <a:xfrm>
-            <a:off x="411480" y="4214367"/>
-            <a:ext cx="11368735" cy="493268"/>
+            <a:off x="411480" y="4049267"/>
+            <a:ext cx="11368735" cy="608838"/>
           </a:xfrm>
           <a:prstGeom prst="rect">
             <a:avLst/>
@@ -10495,13 +10513,13 @@
               </a:spcAft>
             </a:pPr>
             <a:r>
-              <a:rPr sz="1300" b="0">
+              <a:rPr sz="1100" b="0">
                 <a:solidFill>
                   <a:srgbClr val="6E6E6E"/>
                 </a:solidFill>
                 <a:latin typeface="Arial"/>
               </a:rPr>
-              <a:t>Two of the 152 channels: segments E1 and E8, MonZernike mode 4 — the centre field at full size, then all five fields (round-1-train harvest, full pupils).  Piston removed; 1–99% color scale.</a:t>
+              <a:t>Two rigid-body channels: the centre segment (E1) and an outer-ring segment (E8), x-rotation — the centre-field OPD at full size, then the same channel at all five fields, every pupil full.  Drawn from the round-1-train harvest, whose stops pass the whole box; the r2-train harvest matches at the centre field, but its DM-bearing coronagraph clips the corners — that instrument works the centre field.  Piston removed; 1–99% color scale.</a:t>
             </a:r>
           </a:p>
         </p:txBody>
@@ -10514,7 +10532,7 @@
         </p:nvSpPr>
         <p:spPr>
           <a:xfrm>
-            <a:off x="411480" y="4744211"/>
+            <a:off x="411480" y="4694682"/>
             <a:ext cx="11368735" cy="274320"/>
           </a:xfrm>
           <a:prstGeom prst="rect">
@@ -10540,39 +10558,7 @@
                 </a:solidFill>
                 <a:latin typeface="Arial"/>
               </a:rPr>
-              <a:t>•  Zernike figure modes 4–11 on each of the 19 segments, M2-M4, the 8 OAPs — five fields each.  Each channel is confined to its own segment; the mode shape is visible at a glance.</a:t>
-            </a:r>
-          </a:p>
-          <a:p>
-            <a:pPr>
-              <a:spcAft>
-                <a:spcPts val="600"/>
-              </a:spcAft>
-            </a:pPr>
-            <a:r>
-              <a:rPr sz="1500" b="0">
-                <a:solidFill>
-                  <a:srgbClr val="282828"/>
-                </a:solidFill>
-                <a:latin typeface="Arial"/>
-              </a:rPr>
-              <a:t>•  Any element can have deformations described by up to 65 Zernike modes.</a:t>
-            </a:r>
-          </a:p>
-          <a:p>
-            <a:pPr>
-              <a:spcAft>
-                <a:spcPts val="600"/>
-              </a:spcAft>
-            </a:pPr>
-            <a:r>
-              <a:rPr sz="1500" b="0">
-                <a:solidFill>
-                  <a:srgbClr val="282828"/>
-                </a:solidFill>
-                <a:latin typeface="Arial"/>
-              </a:rPr>
-              <a:t>•  MACOS supports 4 types of Zernikes, in normalized or raw forms.</a:t>
+              <a:t>•  Six rigid-body DOFs for every optic — the 19 segments, M2-M4, both DMs, the 8 OAPs — plus the whole primary as one rigid group, five fields each, stacked into the control Jacobian.  The response lives on the moved segment's footprint and walks with field.  The coronagraph works the center field only — its stops vignette the corners; the imaging leg sees the full box.</a:t>
             </a:r>
           </a:p>
         </p:txBody>
@@ -10585,7 +10571,7 @@
         </p:nvSpPr>
         <p:spPr>
           <a:xfrm>
-            <a:off x="411480" y="6192011"/>
+            <a:off x="411480" y="5862065"/>
             <a:ext cx="11368735" cy="274320"/>
           </a:xfrm>
           <a:prstGeom prst="rect">
@@ -10605,13 +10591,13 @@
               </a:spcAft>
             </a:pPr>
             <a:r>
-              <a:rPr sz="1300" b="0">
+              <a:rPr sz="1200" b="0">
                 <a:solidFill>
                   <a:srgbClr val="6E6E6E"/>
                 </a:solidFill>
                 <a:latin typeface="Arial"/>
               </a:rPr>
-              <a:t>Same harvest, metric and gates as dw/dx.  Record: templates/80_end_to_end/e2e6m_r2.</a:t>
+              <a:t>Harvest on r1_seg_prop.in, the deck the simulator propagates; per-field FEX reset; closure gated by jacobian_check.  Every panel is one line from the saved Jacobian: OPD = v2m(dwdx(:,k), indx).  Record: templates/80_end_to_end/e2e6m_r2.</a:t>
             </a:r>
           </a:p>
         </p:txBody>
@@ -10668,7 +10654,7 @@
                 </a:solidFill>
                 <a:latin typeface="Arial"/>
               </a:rPr>
-              <a:t>The control basis III: shape-normalized modes — dw/dgrid</a:t>
+              <a:t>The control basis II: segment-figure channels — dw/dz</a:t>
             </a:r>
           </a:p>
           <a:p>
@@ -10684,7 +10670,7 @@
                 </a:solidFill>
                 <a:latin typeface="Arial"/>
               </a:rPr>
-              <a:t>Runner: macos.dw_dgrid_multi, harvested by run_sensitivities (stage r3) — the grid influence basis on each segment</a:t>
+              <a:t>Runner: macos.dw_dz_zernike_multi, harvested by run_sensitivities (stage r3) — MonZernike modes 4–11 on each segment</a:t>
             </a:r>
           </a:p>
         </p:txBody>
@@ -10735,7 +10721,7 @@
       </p:sp>
       <p:pic>
         <p:nvPicPr>
-          <p:cNvPr id="4" name="Picture 3" descr="fig_dwdgrid_read.png"/>
+          <p:cNvPr id="4" name="Picture 3" descr="fig_dwdz_read.png"/>
           <p:cNvPicPr>
             <a:picLocks noChangeAspect="1"/>
           </p:cNvPicPr>
@@ -10766,7 +10752,7 @@
         <p:spPr>
           <a:xfrm>
             <a:off x="411480" y="4214367"/>
-            <a:ext cx="11368735" cy="460248"/>
+            <a:ext cx="11368735" cy="493268"/>
           </a:xfrm>
           <a:prstGeom prst="rect">
             <a:avLst/>
@@ -10785,13 +10771,13 @@
               </a:spcAft>
             </a:pPr>
             <a:r>
-              <a:rPr sz="1200" b="0">
+              <a:rPr sz="1300" b="0">
                 <a:solidFill>
                   <a:srgbClr val="6E6E6E"/>
                 </a:solidFill>
                 <a:latin typeface="Arial"/>
               </a:rPr>
-              <a:t>Two of the 114 channels: segments E1 and E8, grid mode 4 — the centre field at full size, then all five fields (round-1-train harvest, full pupils).  Piston removed; 1–99% color scale.</a:t>
+              <a:t>Two of the 152 channels: segments E1 and E8, MonZernike mode 4 — the centre field at full size, then all five fields (round-1-train harvest, full pupils).  Piston removed; 1–99% color scale.</a:t>
             </a:r>
           </a:p>
         </p:txBody>
@@ -10804,7 +10790,7 @@
         </p:nvSpPr>
         <p:spPr>
           <a:xfrm>
-            <a:off x="411480" y="4711192"/>
+            <a:off x="411480" y="4744211"/>
             <a:ext cx="11368735" cy="274320"/>
           </a:xfrm>
           <a:prstGeom prst="rect">
@@ -10830,7 +10816,7 @@
                 </a:solidFill>
                 <a:latin typeface="Arial"/>
               </a:rPr>
-              <a:t>•  GridData surfaces can be used to add nearly any surface departure form: as-measured aberrations, Gram-Schmidt orthogonalized Zernike modes, and DM actuations are all used in coronagraphic telescope models.</a:t>
+              <a:t>•  Zernike figure modes 4–11 on each of the 19 segments, M2-M4, the 8 OAPs — five fields each.  Each channel is confined to its own segment; the mode shape is visible at a glance.</a:t>
             </a:r>
           </a:p>
           <a:p>
@@ -10846,7 +10832,23 @@
                 </a:solidFill>
                 <a:latin typeface="Arial"/>
               </a:rPr>
-              <a:t>•  These plots illustrate grid-basis influence shapes on 2 of the 19 segments, using the interface for measured influence functions and actuator maps — the same machinery the DM Jacobians use.</a:t>
+              <a:t>•  Any element can have deformations described by up to 65 Zernike modes.</a:t>
+            </a:r>
+          </a:p>
+          <a:p>
+            <a:pPr>
+              <a:spcAft>
+                <a:spcPts val="600"/>
+              </a:spcAft>
+            </a:pPr>
+            <a:r>
+              <a:rPr sz="1500" b="0">
+                <a:solidFill>
+                  <a:srgbClr val="282828"/>
+                </a:solidFill>
+                <a:latin typeface="Arial"/>
+              </a:rPr>
+              <a:t>•  MACOS supports 4 types of Zernikes, in normalized or raw forms.</a:t>
             </a:r>
           </a:p>
         </p:txBody>
@@ -10859,7 +10861,7 @@
         </p:nvSpPr>
         <p:spPr>
           <a:xfrm>
-            <a:off x="411480" y="6018784"/>
+            <a:off x="411480" y="6192011"/>
             <a:ext cx="11368735" cy="274320"/>
           </a:xfrm>
           <a:prstGeom prst="rect">
@@ -10942,7 +10944,7 @@
                 </a:solidFill>
                 <a:latin typeface="Arial"/>
               </a:rPr>
-              <a:t>A randomly disturbed observatory, simulated</a:t>
+              <a:t>The control basis III: shape-normalized modes — dw/dgrid</a:t>
             </a:r>
           </a:p>
           <a:p>
@@ -10958,7 +10960,7 @@
                 </a:solidFill>
                 <a:latin typeface="Arial"/>
               </a:rPr>
-              <a:t>The closed loop holds dark-zone contrast at 2.5×10⁻⁷ where the uncontrolled series drifts to 1.7×10⁻⁶</a:t>
+              <a:t>Runner: macos.dw_dgrid_multi, harvested by run_sensitivities (stage r3) — the grid influence basis on each segment</a:t>
             </a:r>
           </a:p>
         </p:txBody>
@@ -11007,80 +11009,9 @@
           </a:p>
         </p:txBody>
       </p:sp>
-      <p:sp>
-        <p:nvSpPr>
-          <p:cNvPr id="4" name="TextBox 3"/>
-          <p:cNvSpPr txBox="1"/>
-          <p:nvPr/>
-        </p:nvSpPr>
-        <p:spPr>
-          <a:xfrm>
-            <a:off x="411480" y="1298448"/>
-            <a:ext cx="5806440" cy="274320"/>
-          </a:xfrm>
-          <a:prstGeom prst="rect">
-            <a:avLst/>
-          </a:prstGeom>
-          <a:noFill/>
-        </p:spPr>
-        <p:txBody>
-          <a:bodyPr wrap="square">
-            <a:spAutoFit/>
-          </a:bodyPr>
-          <a:lstStyle/>
-          <a:p>
-            <a:pPr>
-              <a:spcAft>
-                <a:spcPts val="600"/>
-              </a:spcAft>
-            </a:pPr>
-            <a:r>
-              <a:rPr sz="1200" b="0">
-                <a:solidFill>
-                  <a:srgbClr val="282828"/>
-                </a:solidFill>
-                <a:latin typeface="Arial"/>
-              </a:rPr>
-              <a:t>•  Random segment drift is injected; the rigid-body loop senses through the designed metrology, estimates and corrects, while EFC re-solves the dark zone per scored frame — all on one model.</a:t>
-            </a:r>
-          </a:p>
-          <a:p>
-            <a:pPr>
-              <a:spcAft>
-                <a:spcPts val="600"/>
-              </a:spcAft>
-            </a:pPr>
-            <a:r>
-              <a:rPr sz="1200" b="0">
-                <a:solidFill>
-                  <a:srgbClr val="282828"/>
-                </a:solidFill>
-                <a:latin typeface="Arial"/>
-              </a:rPr>
-              <a:t>•  The disturbance interface is the point: the same channels are built to ingest dynamical- and thermal-model time histories — simulating performance in the space environment.  Work in progress.</a:t>
-            </a:r>
-          </a:p>
-          <a:p>
-            <a:pPr>
-              <a:spcAft>
-                <a:spcPts val="600"/>
-              </a:spcAft>
-            </a:pPr>
-            <a:r>
-              <a:rPr sz="1200" b="0">
-                <a:solidFill>
-                  <a:srgbClr val="282828"/>
-                </a:solidFill>
-                <a:latin typeface="Arial"/>
-              </a:rPr>
-              <a:t>•  Honest gap, attributed: the segmented-pupil contrast floor sits above the clear-pupil testbed's — the gaps and edges carry it, not the control.</a:t>
-            </a:r>
-          </a:p>
-        </p:txBody>
-      </p:sp>
       <p:pic>
         <p:nvPicPr>
-          <p:cNvPr id="5" name="Picture 4" descr="r4_series_3nm.png"/>
+          <p:cNvPr id="4" name="Picture 3" descr="fig_dwdgrid_read.png"/>
           <p:cNvPicPr>
             <a:picLocks noChangeAspect="1"/>
           </p:cNvPicPr>
@@ -11094,8 +11025,8 @@
         </p:blipFill>
         <p:spPr>
           <a:xfrm>
-            <a:off x="6923477" y="1298448"/>
-            <a:ext cx="4349605" cy="4177792"/>
+            <a:off x="637634" y="1298448"/>
+            <a:ext cx="10916426" cy="2897632"/>
           </a:xfrm>
           <a:prstGeom prst="rect">
             <a:avLst/>
@@ -11104,14 +11035,14 @@
       </p:pic>
       <p:sp>
         <p:nvSpPr>
-          <p:cNvPr id="6" name="TextBox 5"/>
+          <p:cNvPr id="5" name="TextBox 4"/>
           <p:cNvSpPr txBox="1"/>
           <p:nvPr/>
         </p:nvSpPr>
         <p:spPr>
           <a:xfrm>
-            <a:off x="6400800" y="5494528"/>
-            <a:ext cx="5394960" cy="394208"/>
+            <a:off x="411480" y="4214367"/>
+            <a:ext cx="11368735" cy="460248"/>
           </a:xfrm>
           <a:prstGeom prst="rect">
             <a:avLst/>
@@ -11130,27 +11061,27 @@
               </a:spcAft>
             </a:pPr>
             <a:r>
-              <a:rPr sz="1000" b="0">
+              <a:rPr sz="1200" b="0">
                 <a:solidFill>
                   <a:srgbClr val="6E6E6E"/>
                 </a:solidFill>
                 <a:latin typeface="Arial"/>
               </a:rPr>
-              <a:t>Four hundred seconds under drift: segment rigid-body state, wavefront at the coronagraph exit pupil, and science-plane contrast — open loop against closed.</a:t>
-            </a:r>
-          </a:p>
-        </p:txBody>
-      </p:sp>
-      <p:sp>
-        <p:nvSpPr>
-          <p:cNvPr id="7" name="TextBox 6"/>
+              <a:t>Two of the 114 channels: segments E1 and E8, grid mode 4 — the centre field at full size, then all five fields (round-1-train harvest, full pupils).  Piston removed; 1–99% color scale.</a:t>
+            </a:r>
+          </a:p>
+        </p:txBody>
+      </p:sp>
+      <p:sp>
+        <p:nvSpPr>
+          <p:cNvPr id="6" name="TextBox 5"/>
           <p:cNvSpPr txBox="1"/>
           <p:nvPr/>
         </p:nvSpPr>
         <p:spPr>
           <a:xfrm>
-            <a:off x="6400800" y="5925312"/>
-            <a:ext cx="5394960" cy="274320"/>
+            <a:off x="411480" y="4711192"/>
+            <a:ext cx="11368735" cy="274320"/>
           </a:xfrm>
           <a:prstGeom prst="rect">
             <a:avLst/>
@@ -11169,13 +11100,68 @@
               </a:spcAft>
             </a:pPr>
             <a:r>
-              <a:rPr sz="1050" b="0">
+              <a:rPr sz="1500" b="0">
+                <a:solidFill>
+                  <a:srgbClr val="282828"/>
+                </a:solidFill>
+                <a:latin typeface="Arial"/>
+              </a:rPr>
+              <a:t>•  GridData surfaces can be used to add nearly any surface departure form: as-measured aberrations, Gram-Schmidt orthogonalized Zernike modes, and DM actuations are all used in coronagraphic telescope models.</a:t>
+            </a:r>
+          </a:p>
+          <a:p>
+            <a:pPr>
+              <a:spcAft>
+                <a:spcPts val="600"/>
+              </a:spcAft>
+            </a:pPr>
+            <a:r>
+              <a:rPr sz="1500" b="0">
+                <a:solidFill>
+                  <a:srgbClr val="282828"/>
+                </a:solidFill>
+                <a:latin typeface="Arial"/>
+              </a:rPr>
+              <a:t>•  These plots illustrate grid-basis influence shapes on 2 of the 19 segments, using the interface for measured influence functions and actuator maps — the same machinery the DM Jacobians use.</a:t>
+            </a:r>
+          </a:p>
+        </p:txBody>
+      </p:sp>
+      <p:sp>
+        <p:nvSpPr>
+          <p:cNvPr id="7" name="TextBox 6"/>
+          <p:cNvSpPr txBox="1"/>
+          <p:nvPr/>
+        </p:nvSpPr>
+        <p:spPr>
+          <a:xfrm>
+            <a:off x="411480" y="6018784"/>
+            <a:ext cx="11368735" cy="274320"/>
+          </a:xfrm>
+          <a:prstGeom prst="rect">
+            <a:avLst/>
+          </a:prstGeom>
+          <a:noFill/>
+        </p:spPr>
+        <p:txBody>
+          <a:bodyPr wrap="square">
+            <a:spAutoFit/>
+          </a:bodyPr>
+          <a:lstStyle/>
+          <a:p>
+            <a:pPr>
+              <a:spcAft>
+                <a:spcPts val="600"/>
+              </a:spcAft>
+            </a:pPr>
+            <a:r>
+              <a:rPr sz="1300" b="0">
                 <a:solidFill>
                   <a:srgbClr val="6E6E6E"/>
                 </a:solidFill>
                 <a:latin typeface="Arial"/>
               </a:rPr>
-              <a:t>Record: templates/80_end_to_end/e2e6m_r2, time-series stage.</a:t>
+              <a:t>Same harvest, metric and gates as dw/dx.  Record: templates/80_end_to_end/e2e6m_r2.</a:t>
             </a:r>
           </a:p>
         </p:txBody>
@@ -11232,7 +11218,7 @@
                 </a:solidFill>
                 <a:latin typeface="Arial"/>
               </a:rPr>
-              <a:t>The live design, revealed</a:t>
+              <a:t>A randomly disturbed observatory, simulated</a:t>
             </a:r>
           </a:p>
           <a:p>
@@ -11248,7 +11234,7 @@
                 </a:solidFill>
                 <a:latin typeface="Arial"/>
               </a:rPr>
-              <a:t>Predicted from the frontier before solving; solved in one warm-started step while we talked</a:t>
+              <a:t>The closed loop holds dark-zone contrast at 2.5×10⁻⁷ where the uncontrolled series drifts to 1.7×10⁻⁶</a:t>
             </a:r>
           </a:p>
         </p:txBody>
@@ -11331,7 +11317,7 @@
                 </a:solidFill>
                 <a:latin typeface="Arial"/>
               </a:rPr>
-              <a:t>•  The ask: a field-box width, anywhere in 5–15°.  The prediction, stated before the solve: interpolated from the committed frontier rows.</a:t>
+              <a:t>•  Random segment drift is injected; the rigid-body loop senses through the designed metrology, estimates and corrects, while EFC re-solves the dark zone per scored frame — all on one model.</a:t>
             </a:r>
           </a:p>
           <a:p>
@@ -11347,7 +11333,7 @@
                 </a:solidFill>
                 <a:latin typeface="Arial"/>
               </a:rPr>
-              <a:t>•  The pre-run rehearsal of the default ask (12°): predicted 33.7 nm; solved 33.6 nm — 1.00× — at a 24.9 mm clearance floor, both checks pass, in 15 minutes.</a:t>
+              <a:t>•  The disturbance interface is the point: the same channels are built to ingest dynamical- and thermal-model time histories — simulating performance in the space environment.  Work in progress.</a:t>
             </a:r>
           </a:p>
           <a:p>
@@ -11363,14 +11349,14 @@
                 </a:solidFill>
                 <a:latin typeface="Arial"/>
               </a:rPr>
-              <a:t>•  The run is deterministic to every printed digit, and every ask is a genuine continuation step — never a re-score of a stored design.</a:t>
+              <a:t>•  Honest gap, attributed: the segmented-pupil contrast floor sits above the clear-pupil testbed's — the gaps and edges carry it, not the control.</a:t>
             </a:r>
           </a:p>
         </p:txBody>
       </p:sp>
       <p:pic>
         <p:nvPicPr>
-          <p:cNvPr id="5" name="Picture 4" descr="oi_demo_12deg_layout.png"/>
+          <p:cNvPr id="5" name="Picture 4" descr="r4_series_3nm.png"/>
           <p:cNvPicPr>
             <a:picLocks noChangeAspect="1"/>
           </p:cNvPicPr>
@@ -11384,8 +11370,8 @@
         </p:blipFill>
         <p:spPr>
           <a:xfrm>
-            <a:off x="8000103" y="1298448"/>
-            <a:ext cx="2196352" cy="1891792"/>
+            <a:off x="6923477" y="1298448"/>
+            <a:ext cx="4349605" cy="4177792"/>
           </a:xfrm>
           <a:prstGeom prst="rect">
             <a:avLst/>
@@ -11400,7 +11386,7 @@
         </p:nvSpPr>
         <p:spPr>
           <a:xfrm>
-            <a:off x="6400800" y="3208528"/>
+            <a:off x="6400800" y="5494528"/>
             <a:ext cx="5394960" cy="394208"/>
           </a:xfrm>
           <a:prstGeom prst="rect">
@@ -11426,44 +11412,20 @@
                 </a:solidFill>
                 <a:latin typeface="Arial"/>
               </a:rPr>
-              <a:t>The 12° rehearsal design and its field map: 33.6 nm max against a 33.7 nm prediction.</a:t>
-            </a:r>
-          </a:p>
-        </p:txBody>
-      </p:sp>
-      <p:pic>
-        <p:nvPicPr>
-          <p:cNvPr id="7" name="Picture 6" descr="oi_demo_12deg_map.png"/>
-          <p:cNvPicPr>
-            <a:picLocks noChangeAspect="1"/>
-          </p:cNvPicPr>
-          <p:nvPr/>
-        </p:nvPicPr>
-        <p:blipFill>
-          <a:blip r:embed="rId3"/>
-          <a:stretch>
-            <a:fillRect/>
-          </a:stretch>
-        </p:blipFill>
-        <p:spPr>
-          <a:xfrm>
-            <a:off x="7951092" y="3639312"/>
-            <a:ext cx="2294375" cy="2011680"/>
-          </a:xfrm>
-          <a:prstGeom prst="rect">
-            <a:avLst/>
-          </a:prstGeom>
-        </p:spPr>
-      </p:pic>
-      <p:sp>
-        <p:nvSpPr>
-          <p:cNvPr id="8" name="TextBox 7"/>
+              <a:t>Four hundred seconds under drift: segment rigid-body state, wavefront at the coronagraph exit pupil, and science-plane contrast — open loop against closed.</a:t>
+            </a:r>
+          </a:p>
+        </p:txBody>
+      </p:sp>
+      <p:sp>
+        <p:nvSpPr>
+          <p:cNvPr id="7" name="TextBox 6"/>
           <p:cNvSpPr txBox="1"/>
           <p:nvPr/>
         </p:nvSpPr>
         <p:spPr>
           <a:xfrm>
-            <a:off x="6400800" y="5650992"/>
+            <a:off x="6400800" y="5925312"/>
             <a:ext cx="5394960" cy="274320"/>
           </a:xfrm>
           <a:prstGeom prst="rect">
@@ -11489,7 +11451,7 @@
                 </a:solidFill>
                 <a:latin typeface="Arial"/>
               </a:rPr>
-              <a:t>On demo day the live run's figures replace these panels; this pre-generated bundle is the fallback if the room's ask matches nothing better.</a:t>
+              <a:t>Record: templates/80_end_to_end/e2e6m_r2, time-series stage.</a:t>
             </a:r>
           </a:p>
         </p:txBody>
@@ -11546,7 +11508,7 @@
                 </a:solidFill>
                 <a:latin typeface="Arial"/>
               </a:rPr>
-              <a:t>AI in design and analysis — the working questions</a:t>
+              <a:t>The live design, revealed</a:t>
             </a:r>
           </a:p>
           <a:p>
@@ -11562,7 +11524,7 @@
                 </a:solidFill>
                 <a:latin typeface="Arial"/>
               </a:rPr>
-              <a:t>What we ask of an AI-driven study before believing it</a:t>
+              <a:t>Predicted from the frontier before solving; solved in one warm-started step while we talked</a:t>
             </a:r>
           </a:p>
         </p:txBody>
@@ -11620,7 +11582,7 @@
         <p:spPr>
           <a:xfrm>
             <a:off x="411480" y="1298448"/>
-            <a:ext cx="11368735" cy="274320"/>
+            <a:ext cx="5806440" cy="274320"/>
           </a:xfrm>
           <a:prstGeom prst="rect">
             <a:avLst/>
@@ -11639,13 +11601,13 @@
               </a:spcAft>
             </a:pPr>
             <a:r>
-              <a:rPr sz="1500" b="0">
+              <a:rPr sz="1200" b="0">
                 <a:solidFill>
                   <a:srgbClr val="282828"/>
                 </a:solidFill>
                 <a:latin typeface="Arial"/>
               </a:rPr>
-              <a:t>•  How is a result verified when the designer is a machine?  Here: regression checks with negative controls, layout figures read against every claim, and corrected signed measures — the checks caught the errors shown today.</a:t>
+              <a:t>•  The ask: a field-box width, anywhere in 5–15°.  The prediction, stated before the solve: interpolated from the committed frontier rows.</a:t>
             </a:r>
           </a:p>
           <a:p>
@@ -11655,13 +11617,13 @@
               </a:spcAft>
             </a:pPr>
             <a:r>
-              <a:rPr sz="1500" b="0">
+              <a:rPr sz="1200" b="0">
                 <a:solidFill>
                   <a:srgbClr val="282828"/>
                 </a:solidFill>
                 <a:latin typeface="Arial"/>
               </a:rPr>
-              <a:t>•  Where does the human rule?  Constraint choices, metric definitions, and every outward claim carry a human sign-off; the AI proposes, the record decides.</a:t>
+              <a:t>•  The pre-run rehearsal of the default ask (12°): predicted 33.7 nm; solved 33.6 nm — 1.00× — at a 24.9 mm clearance floor, both checks pass, in 15 minutes.</a:t>
             </a:r>
           </a:p>
           <a:p>
@@ -11671,27 +11633,51 @@
               </a:spcAft>
             </a:pPr>
             <a:r>
-              <a:rPr sz="1500" b="0">
+              <a:rPr sz="1200" b="0">
                 <a:solidFill>
                   <a:srgbClr val="282828"/>
                 </a:solidFill>
                 <a:latin typeface="Arial"/>
               </a:rPr>
-              <a:t>•  Is it reproducible?  Every number in this deck rebuilds from committed scripts and committed records — including the design solved during this talk.</a:t>
-            </a:r>
-          </a:p>
-        </p:txBody>
-      </p:sp>
-      <p:sp>
-        <p:nvSpPr>
-          <p:cNvPr id="5" name="TextBox 4"/>
+              <a:t>•  The run is deterministic to every printed digit, and every ask is a genuine continuation step — never a re-score of a stored design.</a:t>
+            </a:r>
+          </a:p>
+        </p:txBody>
+      </p:sp>
+      <p:pic>
+        <p:nvPicPr>
+          <p:cNvPr id="5" name="Picture 4" descr="oi_demo_12deg_layout.png"/>
+          <p:cNvPicPr>
+            <a:picLocks noChangeAspect="1"/>
+          </p:cNvPicPr>
+          <p:nvPr/>
+        </p:nvPicPr>
+        <p:blipFill>
+          <a:blip r:embed="rId2"/>
+          <a:stretch>
+            <a:fillRect/>
+          </a:stretch>
+        </p:blipFill>
+        <p:spPr>
+          <a:xfrm>
+            <a:off x="8000103" y="1298448"/>
+            <a:ext cx="2196352" cy="1891792"/>
+          </a:xfrm>
+          <a:prstGeom prst="rect">
+            <a:avLst/>
+          </a:prstGeom>
+        </p:spPr>
+      </p:pic>
+      <p:sp>
+        <p:nvSpPr>
+          <p:cNvPr id="6" name="TextBox 5"/>
           <p:cNvSpPr txBox="1"/>
           <p:nvPr/>
         </p:nvSpPr>
         <p:spPr>
           <a:xfrm>
-            <a:off x="411480" y="3241547"/>
-            <a:ext cx="11368735" cy="274320"/>
+            <a:off x="6400800" y="3208528"/>
+            <a:ext cx="5394960" cy="394208"/>
           </a:xfrm>
           <a:prstGeom prst="rect">
             <a:avLst/>
@@ -11704,6 +11690,69 @@
           </a:bodyPr>
           <a:lstStyle/>
           <a:p>
+            <a:pPr algn="ctr">
+              <a:spcAft>
+                <a:spcPts val="0"/>
+              </a:spcAft>
+            </a:pPr>
+            <a:r>
+              <a:rPr sz="1000" b="0">
+                <a:solidFill>
+                  <a:srgbClr val="6E6E6E"/>
+                </a:solidFill>
+                <a:latin typeface="Arial"/>
+              </a:rPr>
+              <a:t>The 12° rehearsal design and its field map: 33.6 nm max against a 33.7 nm prediction.</a:t>
+            </a:r>
+          </a:p>
+        </p:txBody>
+      </p:sp>
+      <p:pic>
+        <p:nvPicPr>
+          <p:cNvPr id="7" name="Picture 6" descr="oi_demo_12deg_map.png"/>
+          <p:cNvPicPr>
+            <a:picLocks noChangeAspect="1"/>
+          </p:cNvPicPr>
+          <p:nvPr/>
+        </p:nvPicPr>
+        <p:blipFill>
+          <a:blip r:embed="rId3"/>
+          <a:stretch>
+            <a:fillRect/>
+          </a:stretch>
+        </p:blipFill>
+        <p:spPr>
+          <a:xfrm>
+            <a:off x="7951092" y="3639312"/>
+            <a:ext cx="2294375" cy="2011680"/>
+          </a:xfrm>
+          <a:prstGeom prst="rect">
+            <a:avLst/>
+          </a:prstGeom>
+        </p:spPr>
+      </p:pic>
+      <p:sp>
+        <p:nvSpPr>
+          <p:cNvPr id="8" name="TextBox 7"/>
+          <p:cNvSpPr txBox="1"/>
+          <p:nvPr/>
+        </p:nvSpPr>
+        <p:spPr>
+          <a:xfrm>
+            <a:off x="6400800" y="5650992"/>
+            <a:ext cx="5394960" cy="274320"/>
+          </a:xfrm>
+          <a:prstGeom prst="rect">
+            <a:avLst/>
+          </a:prstGeom>
+          <a:noFill/>
+        </p:spPr>
+        <p:txBody>
+          <a:bodyPr wrap="square">
+            <a:spAutoFit/>
+          </a:bodyPr>
+          <a:lstStyle/>
+          <a:p>
             <a:pPr>
               <a:spcAft>
                 <a:spcPts val="600"/>
@@ -11716,7 +11765,7 @@
                 </a:solidFill>
                 <a:latin typeface="Arial"/>
               </a:rPr>
-              <a:t>These are offered as discussion questions, not settled doctrine.</a:t>
+              <a:t>On demo day the live run's figures replace these panels; this pre-generated bundle is the fallback if the room's ask matches nothing better.</a:t>
             </a:r>
           </a:p>
         </p:txBody>
@@ -11773,7 +11822,7 @@
                 </a:solidFill>
                 <a:latin typeface="Arial"/>
               </a:rPr>
-              <a:t>Summary</a:t>
+              <a:t>AI in design and analysis — the working questions</a:t>
             </a:r>
           </a:p>
           <a:p>
@@ -11789,7 +11838,7 @@
                 </a:solidFill>
                 <a:latin typeface="Arial"/>
               </a:rPr>
-              <a:t>One engine, validated; a toolbox that designs; an AI that drives it — all public</a:t>
+              <a:t>What we ask of an AI-driven study before believing it</a:t>
             </a:r>
           </a:p>
         </p:txBody>
@@ -11872,7 +11921,7 @@
                 </a:solidFill>
                 <a:latin typeface="Arial"/>
               </a:rPr>
-              <a:t>•  One validated engine behind four language surfaces; a MATLAB design layer that took three CODE V benchmark studies from reproduction to extension.</a:t>
+              <a:t>•  How is a result verified when the designer is a machine?  Here: regression checks with negative controls, layout figures read against every claim, and corrected signed measures — the checks caught the errors shown today.</a:t>
             </a:r>
           </a:p>
           <a:p>
@@ -11888,7 +11937,7 @@
                 </a:solidFill>
                 <a:latin typeface="Arial"/>
               </a:rPr>
-              <a:t>•  Two things happened live: a telescope designed to the audience's field specification in one warm-started step, and a polarization interferometer measuring a deformable mirror to 0.18 nm.</a:t>
+              <a:t>•  Where does the human rule?  Constraint choices, metric definitions, and every outward claim carry a human sign-off; the AI proposes, the record decides.</a:t>
             </a:r>
           </a:p>
           <a:p>
@@ -11904,7 +11953,7 @@
                 </a:solidFill>
                 <a:latin typeface="Arial"/>
               </a:rPr>
-              <a:t>•  The code is public: github.com/nasa-jpl/macos.</a:t>
+              <a:t>•  Is it reproducible?  Every number in this deck rebuilds from committed scripts and committed records — including the design solved during this talk.</a:t>
             </a:r>
           </a:p>
         </p:txBody>
@@ -11917,7 +11966,7 @@
         </p:nvSpPr>
         <p:spPr>
           <a:xfrm>
-            <a:off x="411480" y="2993898"/>
+            <a:off x="411480" y="3241547"/>
             <a:ext cx="11368735" cy="274320"/>
           </a:xfrm>
           <a:prstGeom prst="rect">
@@ -11943,7 +11992,7 @@
                 </a:solidFill>
                 <a:latin typeface="Arial"/>
               </a:rPr>
-              <a:t>Contact and records: all studies cited are committed with packets and regression checks.</a:t>
+              <a:t>These are offered as discussion questions, not settled doctrine.</a:t>
             </a:r>
           </a:p>
         </p:txBody>
@@ -12244,7 +12293,23 @@
                 </a:solidFill>
                 <a:latin typeface="Arial"/>
               </a:rPr>
-              <a:t>Backup Slides</a:t>
+              <a:t>Summary</a:t>
+            </a:r>
+          </a:p>
+          <a:p>
+            <a:pPr>
+              <a:spcAft>
+                <a:spcPts val="0"/>
+              </a:spcAft>
+            </a:pPr>
+            <a:r>
+              <a:rPr sz="1250" b="0">
+                <a:solidFill>
+                  <a:srgbClr val="6E6E6E"/>
+                </a:solidFill>
+                <a:latin typeface="Arial"/>
+              </a:rPr>
+              <a:t>One engine, validated; a toolbox that designs; an AI that drives it — all public</a:t>
             </a:r>
           </a:p>
         </p:txBody>
@@ -12257,7 +12322,7 @@
         </p:nvSpPr>
         <p:spPr>
           <a:xfrm>
-            <a:off x="411480" y="914400"/>
+            <a:off x="411480" y="1133856"/>
             <a:ext cx="11368735" cy="20320"/>
           </a:xfrm>
           <a:prstGeom prst="rect">
@@ -12290,6 +12355,116 @@
           <a:lstStyle/>
           <a:p>
             <a:pPr algn="ctr"/>
+          </a:p>
+        </p:txBody>
+      </p:sp>
+      <p:sp>
+        <p:nvSpPr>
+          <p:cNvPr id="4" name="TextBox 3"/>
+          <p:cNvSpPr txBox="1"/>
+          <p:nvPr/>
+        </p:nvSpPr>
+        <p:spPr>
+          <a:xfrm>
+            <a:off x="411480" y="1298448"/>
+            <a:ext cx="11368735" cy="274320"/>
+          </a:xfrm>
+          <a:prstGeom prst="rect">
+            <a:avLst/>
+          </a:prstGeom>
+          <a:noFill/>
+        </p:spPr>
+        <p:txBody>
+          <a:bodyPr wrap="square">
+            <a:spAutoFit/>
+          </a:bodyPr>
+          <a:lstStyle/>
+          <a:p>
+            <a:pPr>
+              <a:spcAft>
+                <a:spcPts val="600"/>
+              </a:spcAft>
+            </a:pPr>
+            <a:r>
+              <a:rPr sz="1500" b="0">
+                <a:solidFill>
+                  <a:srgbClr val="282828"/>
+                </a:solidFill>
+                <a:latin typeface="Arial"/>
+              </a:rPr>
+              <a:t>•  One validated engine behind four language surfaces; a MATLAB design layer that took three CODE V benchmark studies from reproduction to extension.</a:t>
+            </a:r>
+          </a:p>
+          <a:p>
+            <a:pPr>
+              <a:spcAft>
+                <a:spcPts val="600"/>
+              </a:spcAft>
+            </a:pPr>
+            <a:r>
+              <a:rPr sz="1500" b="0">
+                <a:solidFill>
+                  <a:srgbClr val="282828"/>
+                </a:solidFill>
+                <a:latin typeface="Arial"/>
+              </a:rPr>
+              <a:t>•  Two things happened live: a telescope designed to the audience's field specification in one warm-started step, and a polarization interferometer measuring a deformable mirror to 0.18 nm.</a:t>
+            </a:r>
+          </a:p>
+          <a:p>
+            <a:pPr>
+              <a:spcAft>
+                <a:spcPts val="600"/>
+              </a:spcAft>
+            </a:pPr>
+            <a:r>
+              <a:rPr sz="1500" b="0">
+                <a:solidFill>
+                  <a:srgbClr val="282828"/>
+                </a:solidFill>
+                <a:latin typeface="Arial"/>
+              </a:rPr>
+              <a:t>•  The code is public: github.com/nasa-jpl/macos.</a:t>
+            </a:r>
+          </a:p>
+        </p:txBody>
+      </p:sp>
+      <p:sp>
+        <p:nvSpPr>
+          <p:cNvPr id="5" name="TextBox 4"/>
+          <p:cNvSpPr txBox="1"/>
+          <p:nvPr/>
+        </p:nvSpPr>
+        <p:spPr>
+          <a:xfrm>
+            <a:off x="411480" y="2993898"/>
+            <a:ext cx="11368735" cy="274320"/>
+          </a:xfrm>
+          <a:prstGeom prst="rect">
+            <a:avLst/>
+          </a:prstGeom>
+          <a:noFill/>
+        </p:spPr>
+        <p:txBody>
+          <a:bodyPr wrap="square">
+            <a:spAutoFit/>
+          </a:bodyPr>
+          <a:lstStyle/>
+          <a:p>
+            <a:pPr>
+              <a:spcAft>
+                <a:spcPts val="600"/>
+              </a:spcAft>
+            </a:pPr>
+            <a:r>
+              <a:rPr sz="1050" b="0">
+                <a:solidFill>
+                  <a:srgbClr val="6E6E6E"/>
+                </a:solidFill>
+                <a:latin typeface="Arial"/>
+              </a:rPr>
+              <a:t>Contact and records: all studies cited are committed with packets and regression checks.</a:t>
+            </a:r>
           </a:p>
         </p:txBody>
       </p:sp>
@@ -12345,23 +12520,7 @@
                 </a:solidFill>
                 <a:latin typeface="Arial"/>
               </a:rPr>
-              <a:t>What MACOS does today</a:t>
-            </a:r>
-          </a:p>
-          <a:p>
-            <a:pPr>
-              <a:spcAft>
-                <a:spcPts val="0"/>
-              </a:spcAft>
-            </a:pPr>
-            <a:r>
-              <a:rPr sz="1250" b="0">
-                <a:solidFill>
-                  <a:srgbClr val="6E6E6E"/>
-                </a:solidFill>
-                <a:latin typeface="Arial"/>
-              </a:rPr>
-              <a:t>System-level modeling from design through control</a:t>
+              <a:t>Backup Slides</a:t>
             </a:r>
           </a:p>
         </p:txBody>
@@ -12374,7 +12533,7 @@
         </p:nvSpPr>
         <p:spPr>
           <a:xfrm>
-            <a:off x="411480" y="1133856"/>
+            <a:off x="411480" y="914400"/>
             <a:ext cx="11368735" cy="20320"/>
           </a:xfrm>
           <a:prstGeom prst="rect">
@@ -12407,116 +12566,6 @@
           <a:lstStyle/>
           <a:p>
             <a:pPr algn="ctr"/>
-          </a:p>
-        </p:txBody>
-      </p:sp>
-      <p:sp>
-        <p:nvSpPr>
-          <p:cNvPr id="4" name="TextBox 3"/>
-          <p:cNvSpPr txBox="1"/>
-          <p:nvPr/>
-        </p:nvSpPr>
-        <p:spPr>
-          <a:xfrm>
-            <a:off x="411480" y="1298448"/>
-            <a:ext cx="11368735" cy="274320"/>
-          </a:xfrm>
-          <a:prstGeom prst="rect">
-            <a:avLst/>
-          </a:prstGeom>
-          <a:noFill/>
-        </p:spPr>
-        <p:txBody>
-          <a:bodyPr wrap="square">
-            <a:spAutoFit/>
-          </a:bodyPr>
-          <a:lstStyle/>
-          <a:p>
-            <a:pPr>
-              <a:spcAft>
-                <a:spcPts val="600"/>
-              </a:spcAft>
-            </a:pPr>
-            <a:r>
-              <a:rPr sz="1500" b="0">
-                <a:solidFill>
-                  <a:srgbClr val="282828"/>
-                </a:solidFill>
-                <a:latin typeface="Arial"/>
-              </a:rPr>
-              <a:t>•  Applications: error budgeting, integrated observatory simulation, wavefront sensing and control for segmented telescopes, coronagraph testbeds and instruments.</a:t>
-            </a:r>
-          </a:p>
-          <a:p>
-            <a:pPr>
-              <a:spcAft>
-                <a:spcPts val="600"/>
-              </a:spcAft>
-            </a:pPr>
-            <a:r>
-              <a:rPr sz="1500" b="0">
-                <a:solidFill>
-                  <a:srgbClr val="282828"/>
-                </a:solidFill>
-                <a:latin typeface="Arial"/>
-              </a:rPr>
-              <a:t>•  The linear-model workflow: w = J·x + w₀ — wavefront sensitivity channels per element, per segment, per surface mode; stacked over fields and configurations; element groups move as one.</a:t>
-            </a:r>
-          </a:p>
-          <a:p>
-            <a:pPr>
-              <a:spcAft>
-                <a:spcPts val="600"/>
-              </a:spcAft>
-            </a:pPr>
-            <a:r>
-              <a:rPr sz="1500" b="0">
-                <a:solidFill>
-                  <a:srgbClr val="282828"/>
-                </a:solidFill>
-                <a:latin typeface="Arial"/>
-              </a:rPr>
-              <a:t>•  From model to control: the same sensitivity matrices drive metrology design, estimator synthesis, and closed-loop simulation — one model, one bookkeeping, design to control.</a:t>
-            </a:r>
-          </a:p>
-        </p:txBody>
-      </p:sp>
-      <p:sp>
-        <p:nvSpPr>
-          <p:cNvPr id="5" name="TextBox 4"/>
-          <p:cNvSpPr txBox="1"/>
-          <p:nvPr/>
-        </p:nvSpPr>
-        <p:spPr>
-          <a:xfrm>
-            <a:off x="411480" y="3241547"/>
-            <a:ext cx="11368735" cy="274320"/>
-          </a:xfrm>
-          <a:prstGeom prst="rect">
-            <a:avLst/>
-          </a:prstGeom>
-          <a:noFill/>
-        </p:spPr>
-        <p:txBody>
-          <a:bodyPr wrap="square">
-            <a:spAutoFit/>
-          </a:bodyPr>
-          <a:lstStyle/>
-          <a:p>
-            <a:pPr>
-              <a:spcAft>
-                <a:spcPts val="600"/>
-              </a:spcAft>
-            </a:pPr>
-            <a:r>
-              <a:rPr sz="1050" b="0">
-                <a:solidFill>
-                  <a:srgbClr val="6E6E6E"/>
-                </a:solidFill>
-                <a:latin typeface="Arial"/>
-              </a:rPr>
-              <a:t>Every capability shown today is in the committed test suites; validation anchors: next slide.</a:t>
-            </a:r>
           </a:p>
         </p:txBody>
       </p:sp>
@@ -12572,7 +12621,7 @@
                 </a:solidFill>
                 <a:latin typeface="Arial"/>
               </a:rPr>
-              <a:t>The MATLAB toolbox and the design layer</a:t>
+              <a:t>What MACOS does today</a:t>
             </a:r>
           </a:p>
           <a:p>
@@ -12588,7 +12637,7 @@
                 </a:solidFill>
                 <a:latin typeface="Arial"/>
               </a:rPr>
-              <a:t>Design → segmentation → sensitivities → metrology → simulation, each one call — fully public-domain</a:t>
+              <a:t>System-level modeling from design through control</a:t>
             </a:r>
           </a:p>
         </p:txBody>
@@ -12646,7 +12695,7 @@
         <p:spPr>
           <a:xfrm>
             <a:off x="411480" y="1298448"/>
-            <a:ext cx="5806440" cy="274320"/>
+            <a:ext cx="11368735" cy="274320"/>
           </a:xfrm>
           <a:prstGeom prst="rect">
             <a:avLst/>
@@ -12665,13 +12714,13 @@
               </a:spcAft>
             </a:pPr>
             <a:r>
-              <a:rPr sz="1200" b="0">
+              <a:rPr sz="1500" b="0">
                 <a:solidFill>
                   <a:srgbClr val="282828"/>
                 </a:solidFill>
                 <a:latin typeface="Arial"/>
               </a:rPr>
-              <a:t>•  Drivers: telescope/bench design builders, sensitivity supervisors (rigid-body, alignment, surface-grid), metrology placement, model-vs-model comparison, closed-loop simulators, study orchestrators.</a:t>
+              <a:t>•  Applications: error budgeting, integrated observatory simulation, wavefront sensing and control for segmented telescopes, coronagraph testbeds and instruments.</a:t>
             </a:r>
           </a:p>
           <a:p>
@@ -12681,13 +12730,29 @@
               </a:spcAft>
             </a:pPr>
             <a:r>
-              <a:rPr sz="1200" b="0">
+              <a:rPr sz="1500" b="0">
                 <a:solidFill>
                   <a:srgbClr val="282828"/>
                 </a:solidFill>
                 <a:latin typeface="Arial"/>
               </a:rPr>
-              <a:t>•  One-call reconstructible studies: every figure in this deck rebuilds from a committed script and committed records.</a:t>
+              <a:t>•  The linear-model workflow: w = J·x + w₀ — wavefront sensitivity channels per element, per segment, per surface mode; stacked over fields and configurations; element groups move as one.</a:t>
+            </a:r>
+          </a:p>
+          <a:p>
+            <a:pPr>
+              <a:spcAft>
+                <a:spcPts val="600"/>
+              </a:spcAft>
+            </a:pPr>
+            <a:r>
+              <a:rPr sz="1500" b="0">
+                <a:solidFill>
+                  <a:srgbClr val="282828"/>
+                </a:solidFill>
+                <a:latin typeface="Arial"/>
+              </a:rPr>
+              <a:t>•  From model to control: the same sensitivity matrices drive metrology design, estimator synthesis, and closed-loop simulation — one model, one bookkeeping, design to control.</a:t>
             </a:r>
           </a:p>
         </p:txBody>
@@ -12700,8 +12765,8 @@
         </p:nvSpPr>
         <p:spPr>
           <a:xfrm>
-            <a:off x="6400800" y="1298448"/>
-            <a:ext cx="5394960" cy="274320"/>
+            <a:off x="411480" y="3241547"/>
+            <a:ext cx="11368735" cy="274320"/>
           </a:xfrm>
           <a:prstGeom prst="rect">
             <a:avLst/>
@@ -12720,68 +12785,13 @@
               </a:spcAft>
             </a:pPr>
             <a:r>
-              <a:rPr sz="1200" b="0">
-                <a:solidFill>
-                  <a:srgbClr val="282828"/>
-                </a:solidFill>
-                <a:latin typeface="Arial"/>
-              </a:rPr>
-              <a:t>•  Utilities: trace, wavefront, perturb, pupil find; layout and ray-bundle viewers; Jones pupils, polarization elements; segment grid bases and grid file IO; multi-wavelength composition; spot, intensity, complex field.</a:t>
-            </a:r>
-          </a:p>
-          <a:p>
-            <a:pPr>
-              <a:spcAft>
-                <a:spcPts val="600"/>
-              </a:spcAft>
-            </a:pPr>
-            <a:r>
-              <a:rPr sz="1200" b="0">
-                <a:solidFill>
-                  <a:srgbClr val="282828"/>
-                </a:solidFill>
-                <a:latin typeface="Arial"/>
-              </a:rPr>
-              <a:t>•  Why a design layer: the whole stack is public-domain — a design study needs no proprietary prescription to start from.</a:t>
-            </a:r>
-          </a:p>
-        </p:txBody>
-      </p:sp>
-      <p:sp>
-        <p:nvSpPr>
-          <p:cNvPr id="6" name="TextBox 5"/>
-          <p:cNvSpPr txBox="1"/>
-          <p:nvPr/>
-        </p:nvSpPr>
-        <p:spPr>
-          <a:xfrm>
-            <a:off x="6400800" y="2804160"/>
-            <a:ext cx="5394960" cy="274320"/>
-          </a:xfrm>
-          <a:prstGeom prst="rect">
-            <a:avLst/>
-          </a:prstGeom>
-          <a:noFill/>
-        </p:spPr>
-        <p:txBody>
-          <a:bodyPr wrap="square">
-            <a:spAutoFit/>
-          </a:bodyPr>
-          <a:lstStyle/>
-          <a:p>
-            <a:pPr>
-              <a:spcAft>
-                <a:spcPts val="600"/>
-              </a:spcAft>
-            </a:pPr>
-            <a:r>
               <a:rPr sz="1050" b="0">
                 <a:solidFill>
                   <a:srgbClr val="6E6E6E"/>
                 </a:solidFill>
                 <a:latin typeface="Arial"/>
               </a:rPr>
-              <a:t>The two live demonstrations exercised exactly these layers: the bench builder and a design-family driver.</a:t>
+              <a:t>Every capability shown today is in the committed test suites; validation anchors: next slide.</a:t>
             </a:r>
           </a:p>
         </p:txBody>
@@ -12795,6 +12805,272 @@
 </file>
 
 <file path=ppt/slides/slide33.xml><?xml version="1.0" encoding="utf-8"?>
+<p:sld xmlns:a="http://schemas.openxmlformats.org/drawingml/2006/main" xmlns:p="http://schemas.openxmlformats.org/presentationml/2006/main" xmlns:r="http://schemas.openxmlformats.org/officeDocument/2006/relationships">
+  <p:cSld>
+    <p:spTree>
+      <p:nvGrpSpPr>
+        <p:cNvPr id="1" name=""/>
+        <p:cNvGrpSpPr/>
+        <p:nvPr/>
+      </p:nvGrpSpPr>
+      <p:grpSpPr/>
+      <p:sp>
+        <p:nvSpPr>
+          <p:cNvPr id="2" name="TextBox 1"/>
+          <p:cNvSpPr txBox="1"/>
+          <p:nvPr/>
+        </p:nvSpPr>
+        <p:spPr>
+          <a:xfrm>
+            <a:off x="411480" y="201168"/>
+            <a:ext cx="11368735" cy="914400"/>
+          </a:xfrm>
+          <a:prstGeom prst="rect">
+            <a:avLst/>
+          </a:prstGeom>
+          <a:noFill/>
+        </p:spPr>
+        <p:txBody>
+          <a:bodyPr wrap="square">
+            <a:spAutoFit/>
+          </a:bodyPr>
+          <a:lstStyle/>
+          <a:p>
+            <a:pPr>
+              <a:spcAft>
+                <a:spcPts val="400"/>
+              </a:spcAft>
+            </a:pPr>
+            <a:r>
+              <a:rPr sz="2400" b="1">
+                <a:solidFill>
+                  <a:srgbClr val="1F4E79"/>
+                </a:solidFill>
+                <a:latin typeface="Arial"/>
+              </a:rPr>
+              <a:t>The MATLAB toolbox and the design layer</a:t>
+            </a:r>
+          </a:p>
+          <a:p>
+            <a:pPr>
+              <a:spcAft>
+                <a:spcPts val="0"/>
+              </a:spcAft>
+            </a:pPr>
+            <a:r>
+              <a:rPr sz="1250" b="0">
+                <a:solidFill>
+                  <a:srgbClr val="6E6E6E"/>
+                </a:solidFill>
+                <a:latin typeface="Arial"/>
+              </a:rPr>
+              <a:t>Design → segmentation → sensitivities → metrology → simulation, each one call — fully public-domain</a:t>
+            </a:r>
+          </a:p>
+        </p:txBody>
+      </p:sp>
+      <p:sp>
+        <p:nvSpPr>
+          <p:cNvPr id="3" name="Rectangle 2"/>
+          <p:cNvSpPr/>
+          <p:nvPr/>
+        </p:nvSpPr>
+        <p:spPr>
+          <a:xfrm>
+            <a:off x="411480" y="1133856"/>
+            <a:ext cx="11368735" cy="20320"/>
+          </a:xfrm>
+          <a:prstGeom prst="rect">
+            <a:avLst/>
+          </a:prstGeom>
+          <a:solidFill>
+            <a:srgbClr val="B8C6D4"/>
+          </a:solidFill>
+          <a:ln>
+            <a:noFill/>
+          </a:ln>
+          <a:effectLst/>
+        </p:spPr>
+        <p:style>
+          <a:lnRef idx="1">
+            <a:schemeClr val="accent1"/>
+          </a:lnRef>
+          <a:fillRef idx="3">
+            <a:schemeClr val="accent1"/>
+          </a:fillRef>
+          <a:effectRef idx="2">
+            <a:schemeClr val="accent1"/>
+          </a:effectRef>
+          <a:fontRef idx="minor">
+            <a:schemeClr val="lt1"/>
+          </a:fontRef>
+        </p:style>
+        <p:txBody>
+          <a:bodyPr rtlCol="0" anchor="ctr"/>
+          <a:lstStyle/>
+          <a:p>
+            <a:pPr algn="ctr"/>
+          </a:p>
+        </p:txBody>
+      </p:sp>
+      <p:sp>
+        <p:nvSpPr>
+          <p:cNvPr id="4" name="TextBox 3"/>
+          <p:cNvSpPr txBox="1"/>
+          <p:nvPr/>
+        </p:nvSpPr>
+        <p:spPr>
+          <a:xfrm>
+            <a:off x="411480" y="1298448"/>
+            <a:ext cx="5806440" cy="274320"/>
+          </a:xfrm>
+          <a:prstGeom prst="rect">
+            <a:avLst/>
+          </a:prstGeom>
+          <a:noFill/>
+        </p:spPr>
+        <p:txBody>
+          <a:bodyPr wrap="square">
+            <a:spAutoFit/>
+          </a:bodyPr>
+          <a:lstStyle/>
+          <a:p>
+            <a:pPr>
+              <a:spcAft>
+                <a:spcPts val="600"/>
+              </a:spcAft>
+            </a:pPr>
+            <a:r>
+              <a:rPr sz="1200" b="0">
+                <a:solidFill>
+                  <a:srgbClr val="282828"/>
+                </a:solidFill>
+                <a:latin typeface="Arial"/>
+              </a:rPr>
+              <a:t>•  Drivers: telescope/bench design builders, sensitivity supervisors (rigid-body, alignment, surface-grid), metrology placement, model-vs-model comparison, closed-loop simulators, study orchestrators.</a:t>
+            </a:r>
+          </a:p>
+          <a:p>
+            <a:pPr>
+              <a:spcAft>
+                <a:spcPts val="600"/>
+              </a:spcAft>
+            </a:pPr>
+            <a:r>
+              <a:rPr sz="1200" b="0">
+                <a:solidFill>
+                  <a:srgbClr val="282828"/>
+                </a:solidFill>
+                <a:latin typeface="Arial"/>
+              </a:rPr>
+              <a:t>•  One-call reconstructible studies: every figure in this deck rebuilds from a committed script and committed records.</a:t>
+            </a:r>
+          </a:p>
+        </p:txBody>
+      </p:sp>
+      <p:sp>
+        <p:nvSpPr>
+          <p:cNvPr id="5" name="TextBox 4"/>
+          <p:cNvSpPr txBox="1"/>
+          <p:nvPr/>
+        </p:nvSpPr>
+        <p:spPr>
+          <a:xfrm>
+            <a:off x="6400800" y="1298448"/>
+            <a:ext cx="5394960" cy="274320"/>
+          </a:xfrm>
+          <a:prstGeom prst="rect">
+            <a:avLst/>
+          </a:prstGeom>
+          <a:noFill/>
+        </p:spPr>
+        <p:txBody>
+          <a:bodyPr wrap="square">
+            <a:spAutoFit/>
+          </a:bodyPr>
+          <a:lstStyle/>
+          <a:p>
+            <a:pPr>
+              <a:spcAft>
+                <a:spcPts val="600"/>
+              </a:spcAft>
+            </a:pPr>
+            <a:r>
+              <a:rPr sz="1200" b="0">
+                <a:solidFill>
+                  <a:srgbClr val="282828"/>
+                </a:solidFill>
+                <a:latin typeface="Arial"/>
+              </a:rPr>
+              <a:t>•  Utilities: trace, wavefront, perturb, pupil find; layout and ray-bundle viewers; Jones pupils, polarization elements; segment grid bases and grid file IO; multi-wavelength composition; spot, intensity, complex field.</a:t>
+            </a:r>
+          </a:p>
+          <a:p>
+            <a:pPr>
+              <a:spcAft>
+                <a:spcPts val="600"/>
+              </a:spcAft>
+            </a:pPr>
+            <a:r>
+              <a:rPr sz="1200" b="0">
+                <a:solidFill>
+                  <a:srgbClr val="282828"/>
+                </a:solidFill>
+                <a:latin typeface="Arial"/>
+              </a:rPr>
+              <a:t>•  Why a design layer: the whole stack is public-domain — a design study needs no proprietary prescription to start from.</a:t>
+            </a:r>
+          </a:p>
+        </p:txBody>
+      </p:sp>
+      <p:sp>
+        <p:nvSpPr>
+          <p:cNvPr id="6" name="TextBox 5"/>
+          <p:cNvSpPr txBox="1"/>
+          <p:nvPr/>
+        </p:nvSpPr>
+        <p:spPr>
+          <a:xfrm>
+            <a:off x="6400800" y="2804160"/>
+            <a:ext cx="5394960" cy="274320"/>
+          </a:xfrm>
+          <a:prstGeom prst="rect">
+            <a:avLst/>
+          </a:prstGeom>
+          <a:noFill/>
+        </p:spPr>
+        <p:txBody>
+          <a:bodyPr wrap="square">
+            <a:spAutoFit/>
+          </a:bodyPr>
+          <a:lstStyle/>
+          <a:p>
+            <a:pPr>
+              <a:spcAft>
+                <a:spcPts val="600"/>
+              </a:spcAft>
+            </a:pPr>
+            <a:r>
+              <a:rPr sz="1050" b="0">
+                <a:solidFill>
+                  <a:srgbClr val="6E6E6E"/>
+                </a:solidFill>
+                <a:latin typeface="Arial"/>
+              </a:rPr>
+              <a:t>The two live demonstrations exercised exactly these layers: the bench builder and a design-family driver.</a:t>
+            </a:r>
+          </a:p>
+        </p:txBody>
+      </p:sp>
+    </p:spTree>
+  </p:cSld>
+  <p:clrMapOvr>
+    <a:masterClrMapping/>
+  </p:clrMapOvr>
+</p:sld>
+</file>
+
+<file path=ppt/slides/slide34.xml><?xml version="1.0" encoding="utf-8"?>
 <p:sld xmlns:a="http://schemas.openxmlformats.org/drawingml/2006/main" xmlns:p="http://schemas.openxmlformats.org/presentationml/2006/main" xmlns:r="http://schemas.openxmlformats.org/officeDocument/2006/relationships">
   <p:cSld>
     <p:spTree>
@@ -13424,7 +13700,7 @@
 </p:sld>
 </file>
 
-<file path=ppt/slides/slide34.xml><?xml version="1.0" encoding="utf-8"?>
+<file path=ppt/slides/slide35.xml><?xml version="1.0" encoding="utf-8"?>
 <p:sld xmlns:a="http://schemas.openxmlformats.org/drawingml/2006/main" xmlns:p="http://schemas.openxmlformats.org/presentationml/2006/main" xmlns:r="http://schemas.openxmlformats.org/officeDocument/2006/relationships">
   <p:cSld>
     <p:spTree>
@@ -14290,7 +14566,7 @@
 </p:sld>
 </file>
 
-<file path=ppt/slides/slide35.xml><?xml version="1.0" encoding="utf-8"?>
+<file path=ppt/slides/slide36.xml><?xml version="1.0" encoding="utf-8"?>
 <p:sld xmlns:a="http://schemas.openxmlformats.org/drawingml/2006/main" xmlns:p="http://schemas.openxmlformats.org/presentationml/2006/main" xmlns:r="http://schemas.openxmlformats.org/officeDocument/2006/relationships">
   <p:cSld>
     <p:spTree>
@@ -14497,351 +14773,6 @@
                 <a:latin typeface="Arial"/>
               </a:rPr>
               <a:t>Committed: deepest optic 1.887 m = 1.81× the spacing, the feed beam through the collimator by −79.9 mm.  Four-flat recipe: 0.893 m deep, but a fold is an isometry — the interference rides across — and it does not close on the cleared deck (96 routes, every admissible one loses rays).  Cleared −10°: 1.287 m = 1.24×, zero flats, +37.8 mm of daylight.  Record: challenges/afocal4/{packaging,clearing}.</a:t>
-            </a:r>
-          </a:p>
-        </p:txBody>
-      </p:sp>
-    </p:spTree>
-  </p:cSld>
-  <p:clrMapOvr>
-    <a:masterClrMapping/>
-  </p:clrMapOvr>
-</p:sld>
-</file>
-
-<file path=ppt/slides/slide36.xml><?xml version="1.0" encoding="utf-8"?>
-<p:sld xmlns:a="http://schemas.openxmlformats.org/drawingml/2006/main" xmlns:p="http://schemas.openxmlformats.org/presentationml/2006/main" xmlns:r="http://schemas.openxmlformats.org/officeDocument/2006/relationships">
-  <p:cSld>
-    <p:spTree>
-      <p:nvGrpSpPr>
-        <p:cNvPr id="1" name=""/>
-        <p:cNvGrpSpPr/>
-        <p:nvPr/>
-      </p:nvGrpSpPr>
-      <p:grpSpPr/>
-      <p:sp>
-        <p:nvSpPr>
-          <p:cNvPr id="2" name="TextBox 1"/>
-          <p:cNvSpPr txBox="1"/>
-          <p:nvPr/>
-        </p:nvSpPr>
-        <p:spPr>
-          <a:xfrm>
-            <a:off x="411480" y="201168"/>
-            <a:ext cx="11368735" cy="914400"/>
-          </a:xfrm>
-          <a:prstGeom prst="rect">
-            <a:avLst/>
-          </a:prstGeom>
-          <a:noFill/>
-        </p:spPr>
-        <p:txBody>
-          <a:bodyPr wrap="square">
-            <a:spAutoFit/>
-          </a:bodyPr>
-          <a:lstStyle/>
-          <a:p>
-            <a:pPr>
-              <a:spcAft>
-                <a:spcPts val="400"/>
-              </a:spcAft>
-            </a:pPr>
-            <a:r>
-              <a:rPr sz="2400" b="1">
-                <a:solidFill>
-                  <a:srgbClr val="1F4E79"/>
-                </a:solidFill>
-                <a:latin typeface="Arial"/>
-              </a:rPr>
-              <a:t>Interferometer demonstration backups</a:t>
-            </a:r>
-          </a:p>
-          <a:p>
-            <a:pPr>
-              <a:spcAft>
-                <a:spcPts val="0"/>
-              </a:spcAft>
-            </a:pPr>
-            <a:r>
-              <a:rPr sz="1250" b="0">
-                <a:solidFill>
-                  <a:srgbClr val="6E6E6E"/>
-                </a:solidFill>
-                <a:latin typeface="Arial"/>
-              </a:rPr>
-              <a:t>One committed image per live beat</a:t>
-            </a:r>
-          </a:p>
-        </p:txBody>
-      </p:sp>
-      <p:sp>
-        <p:nvSpPr>
-          <p:cNvPr id="3" name="Rectangle 2"/>
-          <p:cNvSpPr/>
-          <p:nvPr/>
-        </p:nvSpPr>
-        <p:spPr>
-          <a:xfrm>
-            <a:off x="411480" y="1133856"/>
-            <a:ext cx="11368735" cy="20320"/>
-          </a:xfrm>
-          <a:prstGeom prst="rect">
-            <a:avLst/>
-          </a:prstGeom>
-          <a:solidFill>
-            <a:srgbClr val="B8C6D4"/>
-          </a:solidFill>
-          <a:ln>
-            <a:noFill/>
-          </a:ln>
-          <a:effectLst/>
-        </p:spPr>
-        <p:style>
-          <a:lnRef idx="1">
-            <a:schemeClr val="accent1"/>
-          </a:lnRef>
-          <a:fillRef idx="3">
-            <a:schemeClr val="accent1"/>
-          </a:fillRef>
-          <a:effectRef idx="2">
-            <a:schemeClr val="accent1"/>
-          </a:effectRef>
-          <a:fontRef idx="minor">
-            <a:schemeClr val="lt1"/>
-          </a:fontRef>
-        </p:style>
-        <p:txBody>
-          <a:bodyPr rtlCol="0" anchor="ctr"/>
-          <a:lstStyle/>
-          <a:p>
-            <a:pPr algn="ctr"/>
-          </a:p>
-        </p:txBody>
-      </p:sp>
-      <p:pic>
-        <p:nvPicPr>
-          <p:cNvPr id="4" name="Picture 3" descr="demo2_beat5_poke.png"/>
-          <p:cNvPicPr>
-            <a:picLocks noChangeAspect="1"/>
-          </p:cNvPicPr>
-          <p:nvPr/>
-        </p:nvPicPr>
-        <p:blipFill>
-          <a:blip r:embed="rId2"/>
-          <a:stretch>
-            <a:fillRect/>
-          </a:stretch>
-        </p:blipFill>
-        <p:spPr>
-          <a:xfrm>
-            <a:off x="3772370" y="1298448"/>
-            <a:ext cx="4646955" cy="1782572"/>
-          </a:xfrm>
-          <a:prstGeom prst="rect">
-            <a:avLst/>
-          </a:prstGeom>
-        </p:spPr>
-      </p:pic>
-      <p:sp>
-        <p:nvSpPr>
-          <p:cNvPr id="5" name="TextBox 4"/>
-          <p:cNvSpPr txBox="1"/>
-          <p:nvPr/>
-        </p:nvSpPr>
-        <p:spPr>
-          <a:xfrm>
-            <a:off x="411480" y="3099308"/>
-            <a:ext cx="11368735" cy="229107"/>
-          </a:xfrm>
-          <a:prstGeom prst="rect">
-            <a:avLst/>
-          </a:prstGeom>
-          <a:noFill/>
-        </p:spPr>
-        <p:txBody>
-          <a:bodyPr wrap="square">
-            <a:spAutoFit/>
-          </a:bodyPr>
-          <a:lstStyle/>
-          <a:p>
-            <a:pPr algn="ctr">
-              <a:spcAft>
-                <a:spcPts val="0"/>
-              </a:spcAft>
-            </a:pPr>
-            <a:r>
-              <a:rPr sz="1000" b="0">
-                <a:solidFill>
-                  <a:srgbClr val="6E6E6E"/>
-                </a:solidFill>
-                <a:latin typeface="Arial"/>
-              </a:rPr>
-              <a:t>Beat 5 — one actuator poked: the fringes bend over it.</a:t>
-            </a:r>
-          </a:p>
-        </p:txBody>
-      </p:sp>
-      <p:pic>
-        <p:nvPicPr>
-          <p:cNvPr id="6" name="Picture 5" descr="demo2_beat6_sweep.png"/>
-          <p:cNvPicPr>
-            <a:picLocks noChangeAspect="1"/>
-          </p:cNvPicPr>
-          <p:nvPr/>
-        </p:nvPicPr>
-        <p:blipFill>
-          <a:blip r:embed="rId3"/>
-          <a:stretch>
-            <a:fillRect/>
-          </a:stretch>
-        </p:blipFill>
-        <p:spPr>
-          <a:xfrm>
-            <a:off x="4186821" y="3364992"/>
-            <a:ext cx="3818051" cy="1782572"/>
-          </a:xfrm>
-          <a:prstGeom prst="rect">
-            <a:avLst/>
-          </a:prstGeom>
-        </p:spPr>
-      </p:pic>
-      <p:sp>
-        <p:nvSpPr>
-          <p:cNvPr id="7" name="TextBox 6"/>
-          <p:cNvSpPr txBox="1"/>
-          <p:nvPr/>
-        </p:nvSpPr>
-        <p:spPr>
-          <a:xfrm>
-            <a:off x="411480" y="5165852"/>
-            <a:ext cx="11368735" cy="229107"/>
-          </a:xfrm>
-          <a:prstGeom prst="rect">
-            <a:avLst/>
-          </a:prstGeom>
-          <a:noFill/>
-        </p:spPr>
-        <p:txBody>
-          <a:bodyPr wrap="square">
-            <a:spAutoFit/>
-          </a:bodyPr>
-          <a:lstStyle/>
-          <a:p>
-            <a:pPr algn="ctr">
-              <a:spcAft>
-                <a:spcPts val="0"/>
-              </a:spcAft>
-            </a:pPr>
-            <a:r>
-              <a:rPr sz="1000" b="0">
-                <a:solidFill>
-                  <a:srgbClr val="6E6E6E"/>
-                </a:solidFill>
-                <a:latin typeface="Arial"/>
-              </a:rPr>
-              <a:t>Beat 6 — the analyzer sweep: phase-stepped frames, no re-trace.</a:t>
-            </a:r>
-          </a:p>
-        </p:txBody>
-      </p:sp>
-      <p:pic>
-        <p:nvPicPr>
-          <p:cNvPr id="8" name="Picture 7" descr="demo2_beat7_recovery.png"/>
-          <p:cNvPicPr>
-            <a:picLocks noChangeAspect="1"/>
-          </p:cNvPicPr>
-          <p:nvPr/>
-        </p:nvPicPr>
-        <p:blipFill>
-          <a:blip r:embed="rId4"/>
-          <a:stretch>
-            <a:fillRect/>
-          </a:stretch>
-        </p:blipFill>
-        <p:spPr>
-          <a:xfrm>
-            <a:off x="4177857" y="5431536"/>
-            <a:ext cx="3835980" cy="1032763"/>
-          </a:xfrm>
-          <a:prstGeom prst="rect">
-            <a:avLst/>
-          </a:prstGeom>
-        </p:spPr>
-      </p:pic>
-      <p:sp>
-        <p:nvSpPr>
-          <p:cNvPr id="9" name="TextBox 8"/>
-          <p:cNvSpPr txBox="1"/>
-          <p:nvPr/>
-        </p:nvSpPr>
-        <p:spPr>
-          <a:xfrm>
-            <a:off x="411480" y="6482588"/>
-            <a:ext cx="11368735" cy="229107"/>
-          </a:xfrm>
-          <a:prstGeom prst="rect">
-            <a:avLst/>
-          </a:prstGeom>
-          <a:noFill/>
-        </p:spPr>
-        <p:txBody>
-          <a:bodyPr wrap="square">
-            <a:spAutoFit/>
-          </a:bodyPr>
-          <a:lstStyle/>
-          <a:p>
-            <a:pPr algn="ctr">
-              <a:spcAft>
-                <a:spcPts val="0"/>
-              </a:spcAft>
-            </a:pPr>
-            <a:r>
-              <a:rPr sz="1000" b="0">
-                <a:solidFill>
-                  <a:srgbClr val="6E6E6E"/>
-                </a:solidFill>
-                <a:latin typeface="Arial"/>
-              </a:rPr>
-              <a:t>Beat 7 — the recovery beside the truth map.</a:t>
-            </a:r>
-          </a:p>
-        </p:txBody>
-      </p:sp>
-      <p:sp>
-        <p:nvSpPr>
-          <p:cNvPr id="10" name="TextBox 9"/>
-          <p:cNvSpPr txBox="1"/>
-          <p:nvPr/>
-        </p:nvSpPr>
-        <p:spPr>
-          <a:xfrm>
-            <a:off x="411480" y="6748272"/>
-            <a:ext cx="11368735" cy="274320"/>
-          </a:xfrm>
-          <a:prstGeom prst="rect">
-            <a:avLst/>
-          </a:prstGeom>
-          <a:noFill/>
-        </p:spPr>
-        <p:txBody>
-          <a:bodyPr wrap="square">
-            <a:spAutoFit/>
-          </a:bodyPr>
-          <a:lstStyle/>
-          <a:p>
-            <a:pPr>
-              <a:spcAft>
-                <a:spcPts val="600"/>
-              </a:spcAft>
-            </a:pPr>
-            <a:r>
-              <a:rPr sz="1050" b="0">
-                <a:solidFill>
-                  <a:srgbClr val="6E6E6E"/>
-                </a:solidFill>
-                <a:latin typeface="Arial"/>
-              </a:rPr>
-              <a:t>All eight beats have committed figures in templates/90_polarization/tg_psi_dm_v2 (v1 likewise); the driver opens them on the desktop as each beat runs.</a:t>
             </a:r>
           </a:p>
         </p:txBody>
@@ -14898,7 +14829,7 @@
                 </a:solidFill>
                 <a:latin typeface="Arial"/>
               </a:rPr>
-              <a:t>The e2e worked example: specification to design</a:t>
+              <a:t>Interferometer demonstration backups</a:t>
             </a:r>
           </a:p>
           <a:p>
@@ -14914,7 +14845,7 @@
                 </a:solidFill>
                 <a:latin typeface="Arial"/>
               </a:rPr>
-              <a:t>A 4 m f/18 visible-band telescope from a closed-form seed — no starting prescription</a:t>
+              <a:t>One committed image per live beat</a:t>
             </a:r>
           </a:p>
         </p:txBody>
@@ -14963,64 +14894,9 @@
           </a:p>
         </p:txBody>
       </p:sp>
-      <p:sp>
-        <p:nvSpPr>
-          <p:cNvPr id="4" name="TextBox 3"/>
-          <p:cNvSpPr txBox="1"/>
-          <p:nvPr/>
-        </p:nvSpPr>
-        <p:spPr>
-          <a:xfrm>
-            <a:off x="411480" y="1298448"/>
-            <a:ext cx="5806440" cy="274320"/>
-          </a:xfrm>
-          <a:prstGeom prst="rect">
-            <a:avLst/>
-          </a:prstGeom>
-          <a:noFill/>
-        </p:spPr>
-        <p:txBody>
-          <a:bodyPr wrap="square">
-            <a:spAutoFit/>
-          </a:bodyPr>
-          <a:lstStyle/>
-          <a:p>
-            <a:pPr>
-              <a:spcAft>
-                <a:spcPts val="600"/>
-              </a:spcAft>
-            </a:pPr>
-            <a:r>
-              <a:rPr sz="1200" b="0">
-                <a:solidFill>
-                  <a:srgbClr val="282828"/>
-                </a:solidFill>
-                <a:latin typeface="Arial"/>
-              </a:rPr>
-              <a:t>•  The stage-runner sequence on the smaller worked example: specification → design → segmentation → metrology → comparison → simulation, each stage a committed runner handing its prescription to the next.</a:t>
-            </a:r>
-          </a:p>
-          <a:p>
-            <a:pPr>
-              <a:spcAft>
-                <a:spcPts val="600"/>
-              </a:spcAft>
-            </a:pPr>
-            <a:r>
-              <a:rPr sz="1200" b="0">
-                <a:solidFill>
-                  <a:srgbClr val="282828"/>
-                </a:solidFill>
-                <a:latin typeface="Arial"/>
-              </a:rPr>
-              <a:t>•  A 4 m f/18 telescope (f/1.75 primary) from a closed-form first-order seed; diffraction-limited over ±1′ alone, and the Offner ring-field relay buys the full ±2′ (Strehl floor 0.965, on pure spheres).</a:t>
-            </a:r>
-          </a:p>
-        </p:txBody>
-      </p:sp>
       <p:pic>
         <p:nvPicPr>
-          <p:cNvPr id="5" name="Picture 4" descr="rowpair_s1_views.png"/>
+          <p:cNvPr id="4" name="Picture 3" descr="demo2_beat5_poke.png"/>
           <p:cNvPicPr>
             <a:picLocks noChangeAspect="1"/>
           </p:cNvPicPr>
@@ -15034,8 +14910,8 @@
         </p:blipFill>
         <p:spPr>
           <a:xfrm>
-            <a:off x="6738659" y="1298448"/>
-            <a:ext cx="4719240" cy="2056892"/>
+            <a:off x="3772370" y="1298448"/>
+            <a:ext cx="4646955" cy="1782572"/>
           </a:xfrm>
           <a:prstGeom prst="rect">
             <a:avLst/>
@@ -15044,14 +14920,14 @@
       </p:pic>
       <p:sp>
         <p:nvSpPr>
-          <p:cNvPr id="6" name="TextBox 5"/>
+          <p:cNvPr id="5" name="TextBox 4"/>
           <p:cNvSpPr txBox="1"/>
           <p:nvPr/>
         </p:nvSpPr>
         <p:spPr>
           <a:xfrm>
-            <a:off x="6400800" y="3373628"/>
-            <a:ext cx="5394960" cy="229107"/>
+            <a:off x="411480" y="3099308"/>
+            <a:ext cx="11368735" cy="229107"/>
           </a:xfrm>
           <a:prstGeom prst="rect">
             <a:avLst/>
@@ -15076,14 +14952,14 @@
                 </a:solidFill>
                 <a:latin typeface="Arial"/>
               </a:rPr>
-              <a:t>The telescope as designed (front + iso views), with the traced field.</a:t>
+              <a:t>Beat 5 — one actuator poked: the fringes bend over it.</a:t>
             </a:r>
           </a:p>
         </p:txBody>
       </p:sp>
       <p:pic>
         <p:nvPicPr>
-          <p:cNvPr id="7" name="Picture 6" descr="s1_wfe_field.png"/>
+          <p:cNvPr id="6" name="Picture 5" descr="demo2_beat6_sweep.png"/>
           <p:cNvPicPr>
             <a:picLocks noChangeAspect="1"/>
           </p:cNvPicPr>
@@ -15097,8 +14973,8 @@
         </p:blipFill>
         <p:spPr>
           <a:xfrm>
-            <a:off x="7993860" y="3639312"/>
-            <a:ext cx="2208839" cy="1782572"/>
+            <a:off x="4186821" y="3364992"/>
+            <a:ext cx="3818051" cy="1782572"/>
           </a:xfrm>
           <a:prstGeom prst="rect">
             <a:avLst/>
@@ -15107,14 +14983,14 @@
       </p:pic>
       <p:sp>
         <p:nvSpPr>
-          <p:cNvPr id="8" name="TextBox 7"/>
+          <p:cNvPr id="7" name="TextBox 6"/>
           <p:cNvSpPr txBox="1"/>
           <p:nvPr/>
         </p:nvSpPr>
         <p:spPr>
           <a:xfrm>
-            <a:off x="6400800" y="5440171"/>
-            <a:ext cx="5394960" cy="229107"/>
+            <a:off x="411480" y="5165852"/>
+            <a:ext cx="11368735" cy="229107"/>
           </a:xfrm>
           <a:prstGeom prst="rect">
             <a:avLst/>
@@ -15139,11 +15015,35 @@
                 </a:solidFill>
                 <a:latin typeface="Arial"/>
               </a:rPr>
-              <a:t>Wavefront error over the field: diffraction-limited across the box.</a:t>
-            </a:r>
-          </a:p>
-        </p:txBody>
-      </p:sp>
+              <a:t>Beat 6 — the analyzer sweep: phase-stepped frames, no re-trace.</a:t>
+            </a:r>
+          </a:p>
+        </p:txBody>
+      </p:sp>
+      <p:pic>
+        <p:nvPicPr>
+          <p:cNvPr id="8" name="Picture 7" descr="demo2_beat7_recovery.png"/>
+          <p:cNvPicPr>
+            <a:picLocks noChangeAspect="1"/>
+          </p:cNvPicPr>
+          <p:nvPr/>
+        </p:nvPicPr>
+        <p:blipFill>
+          <a:blip r:embed="rId4"/>
+          <a:stretch>
+            <a:fillRect/>
+          </a:stretch>
+        </p:blipFill>
+        <p:spPr>
+          <a:xfrm>
+            <a:off x="4177857" y="5431536"/>
+            <a:ext cx="3835980" cy="1032763"/>
+          </a:xfrm>
+          <a:prstGeom prst="rect">
+            <a:avLst/>
+          </a:prstGeom>
+        </p:spPr>
+      </p:pic>
       <p:sp>
         <p:nvSpPr>
           <p:cNvPr id="9" name="TextBox 8"/>
@@ -15152,8 +15052,8 @@
         </p:nvSpPr>
         <p:spPr>
           <a:xfrm>
-            <a:off x="6400800" y="5705855"/>
-            <a:ext cx="5394960" cy="274320"/>
+            <a:off x="411480" y="6482588"/>
+            <a:ext cx="11368735" cy="229107"/>
           </a:xfrm>
           <a:prstGeom prst="rect">
             <a:avLst/>
@@ -15166,6 +15066,45 @@
           </a:bodyPr>
           <a:lstStyle/>
           <a:p>
+            <a:pPr algn="ctr">
+              <a:spcAft>
+                <a:spcPts val="0"/>
+              </a:spcAft>
+            </a:pPr>
+            <a:r>
+              <a:rPr sz="1000" b="0">
+                <a:solidFill>
+                  <a:srgbClr val="6E6E6E"/>
+                </a:solidFill>
+                <a:latin typeface="Arial"/>
+              </a:rPr>
+              <a:t>Beat 7 — the recovery beside the truth map.</a:t>
+            </a:r>
+          </a:p>
+        </p:txBody>
+      </p:sp>
+      <p:sp>
+        <p:nvSpPr>
+          <p:cNvPr id="10" name="TextBox 9"/>
+          <p:cNvSpPr txBox="1"/>
+          <p:nvPr/>
+        </p:nvSpPr>
+        <p:spPr>
+          <a:xfrm>
+            <a:off x="411480" y="6748272"/>
+            <a:ext cx="11368735" cy="274320"/>
+          </a:xfrm>
+          <a:prstGeom prst="rect">
+            <a:avLst/>
+          </a:prstGeom>
+          <a:noFill/>
+        </p:spPr>
+        <p:txBody>
+          <a:bodyPr wrap="square">
+            <a:spAutoFit/>
+          </a:bodyPr>
+          <a:lstStyle/>
+          <a:p>
             <a:pPr>
               <a:spcAft>
                 <a:spcPts val="600"/>
@@ -15178,7 +15117,7 @@
                 </a:solidFill>
                 <a:latin typeface="Arial"/>
               </a:rPr>
-              <a:t>Record: templates/80_end_to_end/e2e — staged worked example, committed at every step.</a:t>
+              <a:t>All eight beats have committed figures in templates/90_polarization/tg_psi_dm_v2 (v1 likewise); the driver opens them on the desktop as each beat runs.</a:t>
             </a:r>
           </a:p>
         </p:txBody>
@@ -15235,7 +15174,7 @@
                 </a:solidFill>
                 <a:latin typeface="Arial"/>
               </a:rPr>
-              <a:t>The e2e worked example: segmentation and metrology</a:t>
+              <a:t>The e2e worked example: specification to design</a:t>
             </a:r>
           </a:p>
           <a:p>
@@ -15251,7 +15190,7 @@
                 </a:solidFill>
                 <a:latin typeface="Arial"/>
               </a:rPr>
-              <a:t>The monolith segments in one call; the metrology is designed on the same Jacobian</a:t>
+              <a:t>A 4 m f/18 visible-band telescope from a closed-form seed — no starting prescription</a:t>
             </a:r>
           </a:p>
         </p:txBody>
@@ -15334,7 +15273,7 @@
                 </a:solidFill>
                 <a:latin typeface="Arial"/>
               </a:rPr>
-              <a:t>•  The primary segments into a pie or hex tiling with physical apertures; every segment gets rigid-body and surface-figure sensitivity channels, stacked into one Jacobian — the control basis.</a:t>
+              <a:t>•  The stage-runner sequence on the smaller worked example: specification → design → segmentation → metrology → comparison → simulation, each stage a committed runner handing its prescription to the next.</a:t>
             </a:r>
           </a:p>
           <a:p>
@@ -15350,14 +15289,14 @@
                 </a:solidFill>
                 <a:latin typeface="Arial"/>
               </a:rPr>
-              <a:t>•  Metrology is an optimization on that basis: edge-sensor and beam-launcher layouts scored by the control information they carry, not by symmetry; the winning pattern exports as a reusable preset.</a:t>
+              <a:t>•  A 4 m f/18 telescope (f/1.75 primary) from a closed-form first-order seed; diffraction-limited over ±1′ alone, and the Offner ring-field relay buys the full ±2′ (Strehl floor 0.965, on pure spheres).</a:t>
             </a:r>
           </a:p>
         </p:txBody>
       </p:sp>
       <p:pic>
         <p:nvPicPr>
-          <p:cNvPr id="5" name="Picture 4" descr="rowpair_s3_views_pie.png"/>
+          <p:cNvPr id="5" name="Picture 4" descr="rowpair_s1_views.png"/>
           <p:cNvPicPr>
             <a:picLocks noChangeAspect="1"/>
           </p:cNvPicPr>
@@ -15371,8 +15310,8 @@
         </p:blipFill>
         <p:spPr>
           <a:xfrm>
-            <a:off x="6618167" y="1298448"/>
-            <a:ext cx="4960224" cy="1965451"/>
+            <a:off x="6738659" y="1298448"/>
+            <a:ext cx="4719240" cy="2056892"/>
           </a:xfrm>
           <a:prstGeom prst="rect">
             <a:avLst/>
@@ -15387,7 +15326,7 @@
         </p:nvSpPr>
         <p:spPr>
           <a:xfrm>
-            <a:off x="6400800" y="3282188"/>
+            <a:off x="6400800" y="3373628"/>
             <a:ext cx="5394960" cy="229107"/>
           </a:xfrm>
           <a:prstGeom prst="rect">
@@ -15413,14 +15352,14 @@
                 </a:solidFill>
                 <a:latin typeface="Arial"/>
               </a:rPr>
-              <a:t>The segmented primary with physical apertures (front + iso views).</a:t>
+              <a:t>The telescope as designed (front + iso views), with the traced field.</a:t>
             </a:r>
           </a:p>
         </p:txBody>
       </p:sp>
       <p:pic>
         <p:nvPicPr>
-          <p:cNvPr id="7" name="Picture 6" descr="e2e_pie_met_view_rx.png"/>
+          <p:cNvPr id="7" name="Picture 6" descr="s1_wfe_field.png"/>
           <p:cNvPicPr>
             <a:picLocks noChangeAspect="1"/>
           </p:cNvPicPr>
@@ -15434,8 +15373,8 @@
         </p:blipFill>
         <p:spPr>
           <a:xfrm>
-            <a:off x="7662896" y="3547872"/>
-            <a:ext cx="2870767" cy="1874011"/>
+            <a:off x="7993860" y="3639312"/>
+            <a:ext cx="2208839" cy="1782572"/>
           </a:xfrm>
           <a:prstGeom prst="rect">
             <a:avLst/>
@@ -15476,7 +15415,7 @@
                 </a:solidFill>
                 <a:latin typeface="Arial"/>
               </a:rPr>
-              <a:t>The optimized metrology layout on the segmented primary.</a:t>
+              <a:t>Wavefront error over the field: diffraction-limited across the box.</a:t>
             </a:r>
           </a:p>
         </p:txBody>
@@ -15515,7 +15454,7 @@
                 </a:solidFill>
                 <a:latin typeface="Arial"/>
               </a:rPr>
-              <a:t>Record: templates/80_end_to_end/e2e, stages 3–5.</a:t>
+              <a:t>Record: templates/80_end_to_end/e2e — staged worked example, committed at every step.</a:t>
             </a:r>
           </a:p>
         </p:txBody>
@@ -15572,7 +15511,7 @@
                 </a:solidFill>
                 <a:latin typeface="Arial"/>
               </a:rPr>
-              <a:t>The e2e worked example: comparison and simulation</a:t>
+              <a:t>The e2e worked example: segmentation and metrology</a:t>
             </a:r>
           </a:p>
           <a:p>
@@ -15588,7 +15527,7 @@
                 </a:solidFill>
                 <a:latin typeface="Arial"/>
               </a:rPr>
-              <a:t>Segment drift of 10⁵ nm rms is sensed and held at ~7 nm corrected</a:t>
+              <a:t>The monolith segments in one call; the metrology is designed on the same Jacobian</a:t>
             </a:r>
           </a:p>
         </p:txBody>
@@ -15646,7 +15585,7 @@
         <p:spPr>
           <a:xfrm>
             <a:off x="411480" y="1298448"/>
-            <a:ext cx="11368735" cy="274320"/>
+            <a:ext cx="5806440" cy="274320"/>
           </a:xfrm>
           <a:prstGeom prst="rect">
             <a:avLst/>
@@ -15665,20 +15604,36 @@
               </a:spcAft>
             </a:pPr>
             <a:r>
-              <a:rPr sz="1500" b="0">
+              <a:rPr sz="1200" b="0">
                 <a:solidFill>
                   <a:srgbClr val="282828"/>
                 </a:solidFill>
                 <a:latin typeface="Arial"/>
               </a:rPr>
-              <a:t>•  Every linear model is checked against the engine before it is trusted: step each channel, re-trace, render engine and model side by side (left).  Then the simulator closes the loop on the same model: inject drift, sense with the designed metrology, estimate, correct (right).</a:t>
+              <a:t>•  The primary segments into a pie or hex tiling with physical apertures; every segment gets rigid-body and surface-figure sensitivity channels, stacked into one Jacobian — the control basis.</a:t>
+            </a:r>
+          </a:p>
+          <a:p>
+            <a:pPr>
+              <a:spcAft>
+                <a:spcPts val="600"/>
+              </a:spcAft>
+            </a:pPr>
+            <a:r>
+              <a:rPr sz="1200" b="0">
+                <a:solidFill>
+                  <a:srgbClr val="282828"/>
+                </a:solidFill>
+                <a:latin typeface="Arial"/>
+              </a:rPr>
+              <a:t>•  Metrology is an optimization on that basis: edge-sensor and beam-launcher layouts scored by the control information they carry, not by symmetry; the winning pattern exports as a reusable preset.</a:t>
             </a:r>
           </a:p>
         </p:txBody>
       </p:sp>
       <p:pic>
         <p:nvPicPr>
-          <p:cNvPr id="5" name="Picture 4" descr="e2e_compare_p001.png"/>
+          <p:cNvPr id="5" name="Picture 4" descr="rowpair_s3_views_pie.png"/>
           <p:cNvPicPr>
             <a:picLocks noChangeAspect="1"/>
           </p:cNvPicPr>
@@ -15692,8 +15647,8 @@
         </p:blipFill>
         <p:spPr>
           <a:xfrm>
-            <a:off x="1466756" y="2218182"/>
-            <a:ext cx="3695887" cy="2714752"/>
+            <a:off x="6618167" y="1298448"/>
+            <a:ext cx="4960224" cy="1965451"/>
           </a:xfrm>
           <a:prstGeom prst="rect">
             <a:avLst/>
@@ -15708,8 +15663,8 @@
         </p:nvSpPr>
         <p:spPr>
           <a:xfrm>
-            <a:off x="411480" y="4951222"/>
-            <a:ext cx="5806440" cy="394208"/>
+            <a:off x="6400800" y="3282188"/>
+            <a:ext cx="5394960" cy="229107"/>
           </a:xfrm>
           <a:prstGeom prst="rect">
             <a:avLst/>
@@ -15734,14 +15689,14 @@
                 </a:solidFill>
                 <a:latin typeface="Arial"/>
               </a:rPr>
-              <a:t>The comparison stage: engine re-trace vs linear model, one perturbation channel (segment 1 Rx, +100 nrad).</a:t>
+              <a:t>The segmented primary with physical apertures (front + iso views).</a:t>
             </a:r>
           </a:p>
         </p:txBody>
       </p:sp>
       <p:pic>
         <p:nvPicPr>
-          <p:cNvPr id="7" name="Picture 6" descr="e2e_sim_t007.png"/>
+          <p:cNvPr id="7" name="Picture 6" descr="e2e_pie_met_view_rx.png"/>
           <p:cNvPicPr>
             <a:picLocks noChangeAspect="1"/>
           </p:cNvPicPr>
@@ -15755,8 +15710,8 @@
         </p:blipFill>
         <p:spPr>
           <a:xfrm>
-            <a:off x="6784520" y="2218182"/>
-            <a:ext cx="4627519" cy="2714752"/>
+            <a:off x="7662896" y="3547872"/>
+            <a:ext cx="2870767" cy="1874011"/>
           </a:xfrm>
           <a:prstGeom prst="rect">
             <a:avLst/>
@@ -15771,8 +15726,8 @@
         </p:nvSpPr>
         <p:spPr>
           <a:xfrm>
-            <a:off x="6400800" y="4951222"/>
-            <a:ext cx="5394960" cy="394208"/>
+            <a:off x="6400800" y="5440171"/>
+            <a:ext cx="5394960" cy="229107"/>
           </a:xfrm>
           <a:prstGeom prst="rect">
             <a:avLst/>
@@ -15797,7 +15752,7 @@
                 </a:solidFill>
                 <a:latin typeface="Arial"/>
               </a:rPr>
-              <a:t>The simulator at t = 70 s: uncorrected 1.0×10⁵ nm vs 6.8 nm corrected; accumulating WFE and Strehl vs time below.</a:t>
+              <a:t>The optimized metrology layout on the segmented primary.</a:t>
             </a:r>
           </a:p>
         </p:txBody>
@@ -15810,7 +15765,7 @@
         </p:nvSpPr>
         <p:spPr>
           <a:xfrm>
-            <a:off x="6400800" y="5382006"/>
+            <a:off x="6400800" y="5705855"/>
             <a:ext cx="5394960" cy="274320"/>
           </a:xfrm>
           <a:prstGeom prst="rect">
@@ -15836,7 +15791,7 @@
                 </a:solidFill>
                 <a:latin typeface="Arial"/>
               </a:rPr>
-              <a:t>Record: templates/80_end_to_end/e2e, comparison + simulator stages (s6/s7).</a:t>
+              <a:t>Record: templates/80_end_to_end/e2e, stages 3–5.</a:t>
             </a:r>
           </a:p>
         </p:txBody>
@@ -16017,6 +15972,327 @@
                 <a:latin typeface="Arial"/>
               </a:rPr>
               <a:t>Counts as of 2026-08.  Every area is exercised by the committed test suites and by the worked examples beside it — the same templates this talk's studies live in.  Rebuild the figure: make_mmacos_fig.py.</a:t>
+            </a:r>
+          </a:p>
+        </p:txBody>
+      </p:sp>
+    </p:spTree>
+  </p:cSld>
+  <p:clrMapOvr>
+    <a:masterClrMapping/>
+  </p:clrMapOvr>
+</p:sld>
+</file>
+
+<file path=ppt/slides/slide40.xml><?xml version="1.0" encoding="utf-8"?>
+<p:sld xmlns:a="http://schemas.openxmlformats.org/drawingml/2006/main" xmlns:p="http://schemas.openxmlformats.org/presentationml/2006/main" xmlns:r="http://schemas.openxmlformats.org/officeDocument/2006/relationships">
+  <p:cSld>
+    <p:spTree>
+      <p:nvGrpSpPr>
+        <p:cNvPr id="1" name=""/>
+        <p:cNvGrpSpPr/>
+        <p:nvPr/>
+      </p:nvGrpSpPr>
+      <p:grpSpPr/>
+      <p:sp>
+        <p:nvSpPr>
+          <p:cNvPr id="2" name="TextBox 1"/>
+          <p:cNvSpPr txBox="1"/>
+          <p:nvPr/>
+        </p:nvSpPr>
+        <p:spPr>
+          <a:xfrm>
+            <a:off x="411480" y="201168"/>
+            <a:ext cx="11368735" cy="914400"/>
+          </a:xfrm>
+          <a:prstGeom prst="rect">
+            <a:avLst/>
+          </a:prstGeom>
+          <a:noFill/>
+        </p:spPr>
+        <p:txBody>
+          <a:bodyPr wrap="square">
+            <a:spAutoFit/>
+          </a:bodyPr>
+          <a:lstStyle/>
+          <a:p>
+            <a:pPr>
+              <a:spcAft>
+                <a:spcPts val="400"/>
+              </a:spcAft>
+            </a:pPr>
+            <a:r>
+              <a:rPr sz="2400" b="1">
+                <a:solidFill>
+                  <a:srgbClr val="1F4E79"/>
+                </a:solidFill>
+                <a:latin typeface="Arial"/>
+              </a:rPr>
+              <a:t>The e2e worked example: comparison and simulation</a:t>
+            </a:r>
+          </a:p>
+          <a:p>
+            <a:pPr>
+              <a:spcAft>
+                <a:spcPts val="0"/>
+              </a:spcAft>
+            </a:pPr>
+            <a:r>
+              <a:rPr sz="1250" b="0">
+                <a:solidFill>
+                  <a:srgbClr val="6E6E6E"/>
+                </a:solidFill>
+                <a:latin typeface="Arial"/>
+              </a:rPr>
+              <a:t>Segment drift of 10⁵ nm rms is sensed and held at ~7 nm corrected</a:t>
+            </a:r>
+          </a:p>
+        </p:txBody>
+      </p:sp>
+      <p:sp>
+        <p:nvSpPr>
+          <p:cNvPr id="3" name="Rectangle 2"/>
+          <p:cNvSpPr/>
+          <p:nvPr/>
+        </p:nvSpPr>
+        <p:spPr>
+          <a:xfrm>
+            <a:off x="411480" y="1133856"/>
+            <a:ext cx="11368735" cy="20320"/>
+          </a:xfrm>
+          <a:prstGeom prst="rect">
+            <a:avLst/>
+          </a:prstGeom>
+          <a:solidFill>
+            <a:srgbClr val="B8C6D4"/>
+          </a:solidFill>
+          <a:ln>
+            <a:noFill/>
+          </a:ln>
+          <a:effectLst/>
+        </p:spPr>
+        <p:style>
+          <a:lnRef idx="1">
+            <a:schemeClr val="accent1"/>
+          </a:lnRef>
+          <a:fillRef idx="3">
+            <a:schemeClr val="accent1"/>
+          </a:fillRef>
+          <a:effectRef idx="2">
+            <a:schemeClr val="accent1"/>
+          </a:effectRef>
+          <a:fontRef idx="minor">
+            <a:schemeClr val="lt1"/>
+          </a:fontRef>
+        </p:style>
+        <p:txBody>
+          <a:bodyPr rtlCol="0" anchor="ctr"/>
+          <a:lstStyle/>
+          <a:p>
+            <a:pPr algn="ctr"/>
+          </a:p>
+        </p:txBody>
+      </p:sp>
+      <p:sp>
+        <p:nvSpPr>
+          <p:cNvPr id="4" name="TextBox 3"/>
+          <p:cNvSpPr txBox="1"/>
+          <p:nvPr/>
+        </p:nvSpPr>
+        <p:spPr>
+          <a:xfrm>
+            <a:off x="411480" y="1298448"/>
+            <a:ext cx="11368735" cy="274320"/>
+          </a:xfrm>
+          <a:prstGeom prst="rect">
+            <a:avLst/>
+          </a:prstGeom>
+          <a:noFill/>
+        </p:spPr>
+        <p:txBody>
+          <a:bodyPr wrap="square">
+            <a:spAutoFit/>
+          </a:bodyPr>
+          <a:lstStyle/>
+          <a:p>
+            <a:pPr>
+              <a:spcAft>
+                <a:spcPts val="600"/>
+              </a:spcAft>
+            </a:pPr>
+            <a:r>
+              <a:rPr sz="1500" b="0">
+                <a:solidFill>
+                  <a:srgbClr val="282828"/>
+                </a:solidFill>
+                <a:latin typeface="Arial"/>
+              </a:rPr>
+              <a:t>•  Every linear model is checked against the engine before it is trusted: step each channel, re-trace, render engine and model side by side (left).  Then the simulator closes the loop on the same model: inject drift, sense with the designed metrology, estimate, correct (right).</a:t>
+            </a:r>
+          </a:p>
+        </p:txBody>
+      </p:sp>
+      <p:pic>
+        <p:nvPicPr>
+          <p:cNvPr id="5" name="Picture 4" descr="e2e_compare_p001.png"/>
+          <p:cNvPicPr>
+            <a:picLocks noChangeAspect="1"/>
+          </p:cNvPicPr>
+          <p:nvPr/>
+        </p:nvPicPr>
+        <p:blipFill>
+          <a:blip r:embed="rId2"/>
+          <a:stretch>
+            <a:fillRect/>
+          </a:stretch>
+        </p:blipFill>
+        <p:spPr>
+          <a:xfrm>
+            <a:off x="1466756" y="2218182"/>
+            <a:ext cx="3695887" cy="2714752"/>
+          </a:xfrm>
+          <a:prstGeom prst="rect">
+            <a:avLst/>
+          </a:prstGeom>
+        </p:spPr>
+      </p:pic>
+      <p:sp>
+        <p:nvSpPr>
+          <p:cNvPr id="6" name="TextBox 5"/>
+          <p:cNvSpPr txBox="1"/>
+          <p:nvPr/>
+        </p:nvSpPr>
+        <p:spPr>
+          <a:xfrm>
+            <a:off x="411480" y="4951222"/>
+            <a:ext cx="5806440" cy="394208"/>
+          </a:xfrm>
+          <a:prstGeom prst="rect">
+            <a:avLst/>
+          </a:prstGeom>
+          <a:noFill/>
+        </p:spPr>
+        <p:txBody>
+          <a:bodyPr wrap="square">
+            <a:spAutoFit/>
+          </a:bodyPr>
+          <a:lstStyle/>
+          <a:p>
+            <a:pPr algn="ctr">
+              <a:spcAft>
+                <a:spcPts val="0"/>
+              </a:spcAft>
+            </a:pPr>
+            <a:r>
+              <a:rPr sz="1000" b="0">
+                <a:solidFill>
+                  <a:srgbClr val="6E6E6E"/>
+                </a:solidFill>
+                <a:latin typeface="Arial"/>
+              </a:rPr>
+              <a:t>The comparison stage: engine re-trace vs linear model, one perturbation channel (segment 1 Rx, +100 nrad).</a:t>
+            </a:r>
+          </a:p>
+        </p:txBody>
+      </p:sp>
+      <p:pic>
+        <p:nvPicPr>
+          <p:cNvPr id="7" name="Picture 6" descr="e2e_sim_t007.png"/>
+          <p:cNvPicPr>
+            <a:picLocks noChangeAspect="1"/>
+          </p:cNvPicPr>
+          <p:nvPr/>
+        </p:nvPicPr>
+        <p:blipFill>
+          <a:blip r:embed="rId3"/>
+          <a:stretch>
+            <a:fillRect/>
+          </a:stretch>
+        </p:blipFill>
+        <p:spPr>
+          <a:xfrm>
+            <a:off x="6784520" y="2218182"/>
+            <a:ext cx="4627519" cy="2714752"/>
+          </a:xfrm>
+          <a:prstGeom prst="rect">
+            <a:avLst/>
+          </a:prstGeom>
+        </p:spPr>
+      </p:pic>
+      <p:sp>
+        <p:nvSpPr>
+          <p:cNvPr id="8" name="TextBox 7"/>
+          <p:cNvSpPr txBox="1"/>
+          <p:nvPr/>
+        </p:nvSpPr>
+        <p:spPr>
+          <a:xfrm>
+            <a:off x="6400800" y="4951222"/>
+            <a:ext cx="5394960" cy="394208"/>
+          </a:xfrm>
+          <a:prstGeom prst="rect">
+            <a:avLst/>
+          </a:prstGeom>
+          <a:noFill/>
+        </p:spPr>
+        <p:txBody>
+          <a:bodyPr wrap="square">
+            <a:spAutoFit/>
+          </a:bodyPr>
+          <a:lstStyle/>
+          <a:p>
+            <a:pPr algn="ctr">
+              <a:spcAft>
+                <a:spcPts val="0"/>
+              </a:spcAft>
+            </a:pPr>
+            <a:r>
+              <a:rPr sz="1000" b="0">
+                <a:solidFill>
+                  <a:srgbClr val="6E6E6E"/>
+                </a:solidFill>
+                <a:latin typeface="Arial"/>
+              </a:rPr>
+              <a:t>The simulator at t = 70 s: uncorrected 1.0×10⁵ nm vs 6.8 nm corrected; accumulating WFE and Strehl vs time below.</a:t>
+            </a:r>
+          </a:p>
+        </p:txBody>
+      </p:sp>
+      <p:sp>
+        <p:nvSpPr>
+          <p:cNvPr id="9" name="TextBox 8"/>
+          <p:cNvSpPr txBox="1"/>
+          <p:nvPr/>
+        </p:nvSpPr>
+        <p:spPr>
+          <a:xfrm>
+            <a:off x="6400800" y="5382006"/>
+            <a:ext cx="5394960" cy="274320"/>
+          </a:xfrm>
+          <a:prstGeom prst="rect">
+            <a:avLst/>
+          </a:prstGeom>
+          <a:noFill/>
+        </p:spPr>
+        <p:txBody>
+          <a:bodyPr wrap="square">
+            <a:spAutoFit/>
+          </a:bodyPr>
+          <a:lstStyle/>
+          <a:p>
+            <a:pPr>
+              <a:spcAft>
+                <a:spcPts val="600"/>
+              </a:spcAft>
+            </a:pPr>
+            <a:r>
+              <a:rPr sz="1050" b="0">
+                <a:solidFill>
+                  <a:srgbClr val="6E6E6E"/>
+                </a:solidFill>
+                <a:latin typeface="Arial"/>
+              </a:rPr>
+              <a:t>Record: templates/80_end_to_end/e2e, comparison + simulator stages (s6/s7).</a:t>
             </a:r>
           </a:p>
         </p:txBody>

</xml_diff>

<commit_message>
deck: Dave's structural pass folded -- WFS one-step control math (u = -J+ w), rodgers3 'where should the agent sit' slide recreated in md, Summary + 2 backup slides deleted; deck 38 slides
Co-Authored-By: Claude Fable 5 <noreply@anthropic.com>
</commit_message>
<xml_diff>
--- a/demo_session/baseline_pass3.pptx
+++ b/demo_session/baseline_pass3.pptx
@@ -43,8 +43,6 @@
     <p:sldId id="291" r:id="rId42"/>
     <p:sldId id="292" r:id="rId43"/>
     <p:sldId id="293" r:id="rId44"/>
-    <p:sldId id="294" r:id="rId45"/>
-    <p:sldId id="295" r:id="rId46"/>
   </p:sldIdLst>
   <p:sldSz cx="12191695" cy="6858000" type="screen4x3"/>
   <p:notesSz cx="6858000" cy="9144000"/>
@@ -9686,7 +9684,39 @@
                 </a:solidFill>
                 <a:latin typeface="Arial"/>
               </a:rPr>
-              <a:t>•  Estimation and control:   x̂  =  ( HᵀWH + ρI )⁻¹ HᵀW·m ;    u  ←  u − g·x̂</a:t>
+              <a:t>•  Control using wavefront measurements:   u  =  −J⁺·w ,    J⁺  =  ( JᵀJ + ρI )⁻¹ Jᵀ</a:t>
+            </a:r>
+          </a:p>
+          <a:p>
+            <a:pPr marL="594360" indent="-137160">
+              <a:spcAft>
+                <a:spcPts val="500"/>
+              </a:spcAft>
+            </a:pPr>
+            <a:r>
+              <a:rPr sz="1300" b="0">
+                <a:solidFill>
+                  <a:srgbClr val="6E6E6E"/>
+                </a:solidFill>
+                <a:latin typeface="Arial"/>
+              </a:rPr>
+              <a:t>–  Wavefront sensing and control in one step, enveloping telescope initialization controls.</a:t>
+            </a:r>
+          </a:p>
+          <a:p>
+            <a:pPr>
+              <a:spcAft>
+                <a:spcPts val="600"/>
+              </a:spcAft>
+            </a:pPr>
+            <a:r>
+              <a:rPr sz="1500" b="0">
+                <a:solidFill>
+                  <a:srgbClr val="282828"/>
+                </a:solidFill>
+                <a:latin typeface="Arial"/>
+              </a:rPr>
+              <a:t>•  Estimation and control using metrology measurements:   x̂  =  ( HᵀWH + ρI )⁻¹ HᵀW·m ;    u  ←  u − g·x̂</a:t>
             </a:r>
           </a:p>
           <a:p>
@@ -9715,7 +9745,7 @@
         </p:nvSpPr>
         <p:spPr>
           <a:xfrm>
-            <a:off x="411480" y="3954272"/>
+            <a:off x="411480" y="4684268"/>
             <a:ext cx="11368735" cy="274320"/>
           </a:xfrm>
           <a:prstGeom prst="rect">
@@ -12293,7 +12323,7 @@
                 </a:solidFill>
                 <a:latin typeface="Arial"/>
               </a:rPr>
-              <a:t>Summary</a:t>
+              <a:t>Discussion: where should the agent sit?</a:t>
             </a:r>
           </a:p>
           <a:p>
@@ -12309,7 +12339,7 @@
                 </a:solidFill>
                 <a:latin typeface="Arial"/>
               </a:rPr>
-              <a:t>One engine, validated; a toolbox that designs; an AI that drives it — all public</a:t>
+              <a:t>Three modes — two exercised by this study, one open — and the boundary between them is the question</a:t>
             </a:r>
           </a:p>
         </p:txBody>
@@ -12392,7 +12422,7 @@
                 </a:solidFill>
                 <a:latin typeface="Arial"/>
               </a:rPr>
-              <a:t>•  One validated engine behind four language surfaces; a MATLAB design layer that took three CODE V benchmark studies from reproduction to extension.</a:t>
+              <a:t>•  A · Run the compiled tool, no agent — what ships today.  The walk ran unattended on a fresh instance; the checks, caps, and continuation runner are versioned and regression-tested.  Inspectable and maintenance-stable — but 1 of 15 frictions did not compile, and the docs alone did not carry a cold user.</a:t>
             </a:r>
           </a:p>
           <a:p>
@@ -12408,7 +12438,7 @@
                 </a:solidFill>
                 <a:latin typeface="Arial"/>
               </a:rPr>
-              <a:t>•  Two things happened live: a telescope designed to the audience's field specification in one warm-started step, and a polarization interferometer measuring a deformable mirror to 0.18 nm.</a:t>
+              <a:t>•  B · Invoke an agent to guide the work — what this study actually did.  An AI agent in the loop, under expert prompting, found and fixed every conceptual defect in hours and chose the strategies worth compiling — including the walk.  Available to any user now; its knowledge is current, but not versioned with the tool.</a:t>
             </a:r>
           </a:p>
           <a:p>
@@ -12424,7 +12454,87 @@
                 </a:solidFill>
                 <a:latin typeface="Arial"/>
               </a:rPr>
-              <a:t>•  The code is public: github.com/nasa-jpl/macos.</a:t>
+              <a:t>•  C · Embed a helper in the tool — the open question: advice at call time — "your step 1 runs 8× deeper than the reference; expect the offset box to lose rays" — the one failure that was documented and still fatal.</a:t>
+            </a:r>
+          </a:p>
+          <a:p>
+            <a:pPr>
+              <a:spcAft>
+                <a:spcPts val="600"/>
+              </a:spcAft>
+            </a:pPr>
+            <a:r>
+              <a:rPr sz="1500" b="0">
+                <a:solidFill>
+                  <a:srgbClr val="282828"/>
+                </a:solidFill>
+                <a:latin typeface="Arial"/>
+              </a:rPr>
+              <a:t>•  How embedding could work — three shapes in increasing order of authority:</a:t>
+            </a:r>
+          </a:p>
+          <a:p>
+            <a:pPr marL="594360" indent="-137160">
+              <a:spcAft>
+                <a:spcPts val="500"/>
+              </a:spcAft>
+            </a:pPr>
+            <a:r>
+              <a:rPr sz="1300" b="0">
+                <a:solidFill>
+                  <a:srgbClr val="6E6E6E"/>
+                </a:solidFill>
+                <a:latin typeface="Arial"/>
+              </a:rPr>
+              <a:t>–  Make the tool agent-readable (lightest): expose the tool's state as structured output — deck, residual history, check results — with machine-readable docs and runnable checks, so the user's own assistant drives the tool well.  The tool's knowledge stays in the code and its tests.</a:t>
+            </a:r>
+          </a:p>
+          <a:p>
+            <a:pPr marL="594360" indent="-137160">
+              <a:spcAft>
+                <a:spcPts val="500"/>
+              </a:spcAft>
+            </a:pPr>
+            <a:r>
+              <a:rPr sz="1300" b="0">
+                <a:solidFill>
+                  <a:srgbClr val="6E6E6E"/>
+                </a:solidFill>
+                <a:latin typeface="Arial"/>
+              </a:rPr>
+              <a:t>–  A failure-triage assistant: invoked only when a check fires or a solve stalls; it reads the saved state and returns a one-line diagnosis and a suggested next command, which the person runs.</a:t>
+            </a:r>
+          </a:p>
+          <a:p>
+            <a:pPr marL="594360" indent="-137160">
+              <a:spcAft>
+                <a:spcPts val="500"/>
+              </a:spcAft>
+            </a:pPr>
+            <a:r>
+              <a:rPr sz="1300" b="0">
+                <a:solidFill>
+                  <a:srgbClr val="6E6E6E"/>
+                </a:solidFill>
+                <a:latin typeface="Arial"/>
+              </a:rPr>
+              <a:t>–  A policy assistant inside hard limits: it chooses solve-field counts, penalty targets, and walk schedules between stages; the code enforces the limits, validates every action through the same checks, and logs every choice for replay.</a:t>
+            </a:r>
+          </a:p>
+          <a:p>
+            <a:pPr marL="594360" indent="-137160">
+              <a:spcAft>
+                <a:spcPts val="500"/>
+              </a:spcAft>
+            </a:pPr>
+            <a:r>
+              <a:rPr sz="1300" b="0">
+                <a:solidFill>
+                  <a:srgbClr val="6E6E6E"/>
+                </a:solidFill>
+                <a:latin typeface="Arial"/>
+              </a:rPr>
+              <a:t>–  Tier the agents, at any of these levels — an orchestrating agent plans and delegates; each sub-agent gets one bounded task with only the files it needs; the committed records, not any agent's memory, are the shared memory.</a:t>
             </a:r>
           </a:p>
         </p:txBody>
@@ -12437,7 +12547,7 @@
         </p:nvSpPr>
         <p:spPr>
           <a:xfrm>
-            <a:off x="411480" y="2993898"/>
+            <a:off x="411480" y="6566408"/>
             <a:ext cx="11368735" cy="274320"/>
           </a:xfrm>
           <a:prstGeom prst="rect">
@@ -12463,7 +12573,7 @@
                 </a:solidFill>
                 <a:latin typeface="Arial"/>
               </a:rPr>
-              <a:t>Contact and records: all studies cited are committed with packets and regression checks.</a:t>
+              <a:t>Where is the line between knowledge in the code as checks and knowledge served as advice?  A stale check fails loudly; stale advice fails silently.  Measured: the tool alone did not carry a new user; an agent alongside it closed every gap — most of what it learned is now checks and defaults.</a:t>
             </a:r>
           </a:p>
         </p:txBody>
@@ -12578,499 +12688,6 @@
 </file>
 
 <file path=ppt/slides/slide32.xml><?xml version="1.0" encoding="utf-8"?>
-<p:sld xmlns:a="http://schemas.openxmlformats.org/drawingml/2006/main" xmlns:p="http://schemas.openxmlformats.org/presentationml/2006/main" xmlns:r="http://schemas.openxmlformats.org/officeDocument/2006/relationships">
-  <p:cSld>
-    <p:spTree>
-      <p:nvGrpSpPr>
-        <p:cNvPr id="1" name=""/>
-        <p:cNvGrpSpPr/>
-        <p:nvPr/>
-      </p:nvGrpSpPr>
-      <p:grpSpPr/>
-      <p:sp>
-        <p:nvSpPr>
-          <p:cNvPr id="2" name="TextBox 1"/>
-          <p:cNvSpPr txBox="1"/>
-          <p:nvPr/>
-        </p:nvSpPr>
-        <p:spPr>
-          <a:xfrm>
-            <a:off x="411480" y="201168"/>
-            <a:ext cx="11368735" cy="914400"/>
-          </a:xfrm>
-          <a:prstGeom prst="rect">
-            <a:avLst/>
-          </a:prstGeom>
-          <a:noFill/>
-        </p:spPr>
-        <p:txBody>
-          <a:bodyPr wrap="square">
-            <a:spAutoFit/>
-          </a:bodyPr>
-          <a:lstStyle/>
-          <a:p>
-            <a:pPr>
-              <a:spcAft>
-                <a:spcPts val="400"/>
-              </a:spcAft>
-            </a:pPr>
-            <a:r>
-              <a:rPr sz="2400" b="1">
-                <a:solidFill>
-                  <a:srgbClr val="1F4E79"/>
-                </a:solidFill>
-                <a:latin typeface="Arial"/>
-              </a:rPr>
-              <a:t>What MACOS does today</a:t>
-            </a:r>
-          </a:p>
-          <a:p>
-            <a:pPr>
-              <a:spcAft>
-                <a:spcPts val="0"/>
-              </a:spcAft>
-            </a:pPr>
-            <a:r>
-              <a:rPr sz="1250" b="0">
-                <a:solidFill>
-                  <a:srgbClr val="6E6E6E"/>
-                </a:solidFill>
-                <a:latin typeface="Arial"/>
-              </a:rPr>
-              <a:t>System-level modeling from design through control</a:t>
-            </a:r>
-          </a:p>
-        </p:txBody>
-      </p:sp>
-      <p:sp>
-        <p:nvSpPr>
-          <p:cNvPr id="3" name="Rectangle 2"/>
-          <p:cNvSpPr/>
-          <p:nvPr/>
-        </p:nvSpPr>
-        <p:spPr>
-          <a:xfrm>
-            <a:off x="411480" y="1133856"/>
-            <a:ext cx="11368735" cy="20320"/>
-          </a:xfrm>
-          <a:prstGeom prst="rect">
-            <a:avLst/>
-          </a:prstGeom>
-          <a:solidFill>
-            <a:srgbClr val="B8C6D4"/>
-          </a:solidFill>
-          <a:ln>
-            <a:noFill/>
-          </a:ln>
-          <a:effectLst/>
-        </p:spPr>
-        <p:style>
-          <a:lnRef idx="1">
-            <a:schemeClr val="accent1"/>
-          </a:lnRef>
-          <a:fillRef idx="3">
-            <a:schemeClr val="accent1"/>
-          </a:fillRef>
-          <a:effectRef idx="2">
-            <a:schemeClr val="accent1"/>
-          </a:effectRef>
-          <a:fontRef idx="minor">
-            <a:schemeClr val="lt1"/>
-          </a:fontRef>
-        </p:style>
-        <p:txBody>
-          <a:bodyPr rtlCol="0" anchor="ctr"/>
-          <a:lstStyle/>
-          <a:p>
-            <a:pPr algn="ctr"/>
-          </a:p>
-        </p:txBody>
-      </p:sp>
-      <p:sp>
-        <p:nvSpPr>
-          <p:cNvPr id="4" name="TextBox 3"/>
-          <p:cNvSpPr txBox="1"/>
-          <p:nvPr/>
-        </p:nvSpPr>
-        <p:spPr>
-          <a:xfrm>
-            <a:off x="411480" y="1298448"/>
-            <a:ext cx="11368735" cy="274320"/>
-          </a:xfrm>
-          <a:prstGeom prst="rect">
-            <a:avLst/>
-          </a:prstGeom>
-          <a:noFill/>
-        </p:spPr>
-        <p:txBody>
-          <a:bodyPr wrap="square">
-            <a:spAutoFit/>
-          </a:bodyPr>
-          <a:lstStyle/>
-          <a:p>
-            <a:pPr>
-              <a:spcAft>
-                <a:spcPts val="600"/>
-              </a:spcAft>
-            </a:pPr>
-            <a:r>
-              <a:rPr sz="1500" b="0">
-                <a:solidFill>
-                  <a:srgbClr val="282828"/>
-                </a:solidFill>
-                <a:latin typeface="Arial"/>
-              </a:rPr>
-              <a:t>•  Applications: error budgeting, integrated observatory simulation, wavefront sensing and control for segmented telescopes, coronagraph testbeds and instruments.</a:t>
-            </a:r>
-          </a:p>
-          <a:p>
-            <a:pPr>
-              <a:spcAft>
-                <a:spcPts val="600"/>
-              </a:spcAft>
-            </a:pPr>
-            <a:r>
-              <a:rPr sz="1500" b="0">
-                <a:solidFill>
-                  <a:srgbClr val="282828"/>
-                </a:solidFill>
-                <a:latin typeface="Arial"/>
-              </a:rPr>
-              <a:t>•  The linear-model workflow: w = J·x + w₀ — wavefront sensitivity channels per element, per segment, per surface mode; stacked over fields and configurations; element groups move as one.</a:t>
-            </a:r>
-          </a:p>
-          <a:p>
-            <a:pPr>
-              <a:spcAft>
-                <a:spcPts val="600"/>
-              </a:spcAft>
-            </a:pPr>
-            <a:r>
-              <a:rPr sz="1500" b="0">
-                <a:solidFill>
-                  <a:srgbClr val="282828"/>
-                </a:solidFill>
-                <a:latin typeface="Arial"/>
-              </a:rPr>
-              <a:t>•  From model to control: the same sensitivity matrices drive metrology design, estimator synthesis, and closed-loop simulation — one model, one bookkeeping, design to control.</a:t>
-            </a:r>
-          </a:p>
-        </p:txBody>
-      </p:sp>
-      <p:sp>
-        <p:nvSpPr>
-          <p:cNvPr id="5" name="TextBox 4"/>
-          <p:cNvSpPr txBox="1"/>
-          <p:nvPr/>
-        </p:nvSpPr>
-        <p:spPr>
-          <a:xfrm>
-            <a:off x="411480" y="3241547"/>
-            <a:ext cx="11368735" cy="274320"/>
-          </a:xfrm>
-          <a:prstGeom prst="rect">
-            <a:avLst/>
-          </a:prstGeom>
-          <a:noFill/>
-        </p:spPr>
-        <p:txBody>
-          <a:bodyPr wrap="square">
-            <a:spAutoFit/>
-          </a:bodyPr>
-          <a:lstStyle/>
-          <a:p>
-            <a:pPr>
-              <a:spcAft>
-                <a:spcPts val="600"/>
-              </a:spcAft>
-            </a:pPr>
-            <a:r>
-              <a:rPr sz="1050" b="0">
-                <a:solidFill>
-                  <a:srgbClr val="6E6E6E"/>
-                </a:solidFill>
-                <a:latin typeface="Arial"/>
-              </a:rPr>
-              <a:t>Every capability shown today is in the committed test suites; validation anchors: next slide.</a:t>
-            </a:r>
-          </a:p>
-        </p:txBody>
-      </p:sp>
-    </p:spTree>
-  </p:cSld>
-  <p:clrMapOvr>
-    <a:masterClrMapping/>
-  </p:clrMapOvr>
-</p:sld>
-</file>
-
-<file path=ppt/slides/slide33.xml><?xml version="1.0" encoding="utf-8"?>
-<p:sld xmlns:a="http://schemas.openxmlformats.org/drawingml/2006/main" xmlns:p="http://schemas.openxmlformats.org/presentationml/2006/main" xmlns:r="http://schemas.openxmlformats.org/officeDocument/2006/relationships">
-  <p:cSld>
-    <p:spTree>
-      <p:nvGrpSpPr>
-        <p:cNvPr id="1" name=""/>
-        <p:cNvGrpSpPr/>
-        <p:nvPr/>
-      </p:nvGrpSpPr>
-      <p:grpSpPr/>
-      <p:sp>
-        <p:nvSpPr>
-          <p:cNvPr id="2" name="TextBox 1"/>
-          <p:cNvSpPr txBox="1"/>
-          <p:nvPr/>
-        </p:nvSpPr>
-        <p:spPr>
-          <a:xfrm>
-            <a:off x="411480" y="201168"/>
-            <a:ext cx="11368735" cy="914400"/>
-          </a:xfrm>
-          <a:prstGeom prst="rect">
-            <a:avLst/>
-          </a:prstGeom>
-          <a:noFill/>
-        </p:spPr>
-        <p:txBody>
-          <a:bodyPr wrap="square">
-            <a:spAutoFit/>
-          </a:bodyPr>
-          <a:lstStyle/>
-          <a:p>
-            <a:pPr>
-              <a:spcAft>
-                <a:spcPts val="400"/>
-              </a:spcAft>
-            </a:pPr>
-            <a:r>
-              <a:rPr sz="2400" b="1">
-                <a:solidFill>
-                  <a:srgbClr val="1F4E79"/>
-                </a:solidFill>
-                <a:latin typeface="Arial"/>
-              </a:rPr>
-              <a:t>The MATLAB toolbox and the design layer</a:t>
-            </a:r>
-          </a:p>
-          <a:p>
-            <a:pPr>
-              <a:spcAft>
-                <a:spcPts val="0"/>
-              </a:spcAft>
-            </a:pPr>
-            <a:r>
-              <a:rPr sz="1250" b="0">
-                <a:solidFill>
-                  <a:srgbClr val="6E6E6E"/>
-                </a:solidFill>
-                <a:latin typeface="Arial"/>
-              </a:rPr>
-              <a:t>Design → segmentation → sensitivities → metrology → simulation, each one call — fully public-domain</a:t>
-            </a:r>
-          </a:p>
-        </p:txBody>
-      </p:sp>
-      <p:sp>
-        <p:nvSpPr>
-          <p:cNvPr id="3" name="Rectangle 2"/>
-          <p:cNvSpPr/>
-          <p:nvPr/>
-        </p:nvSpPr>
-        <p:spPr>
-          <a:xfrm>
-            <a:off x="411480" y="1133856"/>
-            <a:ext cx="11368735" cy="20320"/>
-          </a:xfrm>
-          <a:prstGeom prst="rect">
-            <a:avLst/>
-          </a:prstGeom>
-          <a:solidFill>
-            <a:srgbClr val="B8C6D4"/>
-          </a:solidFill>
-          <a:ln>
-            <a:noFill/>
-          </a:ln>
-          <a:effectLst/>
-        </p:spPr>
-        <p:style>
-          <a:lnRef idx="1">
-            <a:schemeClr val="accent1"/>
-          </a:lnRef>
-          <a:fillRef idx="3">
-            <a:schemeClr val="accent1"/>
-          </a:fillRef>
-          <a:effectRef idx="2">
-            <a:schemeClr val="accent1"/>
-          </a:effectRef>
-          <a:fontRef idx="minor">
-            <a:schemeClr val="lt1"/>
-          </a:fontRef>
-        </p:style>
-        <p:txBody>
-          <a:bodyPr rtlCol="0" anchor="ctr"/>
-          <a:lstStyle/>
-          <a:p>
-            <a:pPr algn="ctr"/>
-          </a:p>
-        </p:txBody>
-      </p:sp>
-      <p:sp>
-        <p:nvSpPr>
-          <p:cNvPr id="4" name="TextBox 3"/>
-          <p:cNvSpPr txBox="1"/>
-          <p:nvPr/>
-        </p:nvSpPr>
-        <p:spPr>
-          <a:xfrm>
-            <a:off x="411480" y="1298448"/>
-            <a:ext cx="5806440" cy="274320"/>
-          </a:xfrm>
-          <a:prstGeom prst="rect">
-            <a:avLst/>
-          </a:prstGeom>
-          <a:noFill/>
-        </p:spPr>
-        <p:txBody>
-          <a:bodyPr wrap="square">
-            <a:spAutoFit/>
-          </a:bodyPr>
-          <a:lstStyle/>
-          <a:p>
-            <a:pPr>
-              <a:spcAft>
-                <a:spcPts val="600"/>
-              </a:spcAft>
-            </a:pPr>
-            <a:r>
-              <a:rPr sz="1200" b="0">
-                <a:solidFill>
-                  <a:srgbClr val="282828"/>
-                </a:solidFill>
-                <a:latin typeface="Arial"/>
-              </a:rPr>
-              <a:t>•  Drivers: telescope/bench design builders, sensitivity supervisors (rigid-body, alignment, surface-grid), metrology placement, model-vs-model comparison, closed-loop simulators, study orchestrators.</a:t>
-            </a:r>
-          </a:p>
-          <a:p>
-            <a:pPr>
-              <a:spcAft>
-                <a:spcPts val="600"/>
-              </a:spcAft>
-            </a:pPr>
-            <a:r>
-              <a:rPr sz="1200" b="0">
-                <a:solidFill>
-                  <a:srgbClr val="282828"/>
-                </a:solidFill>
-                <a:latin typeface="Arial"/>
-              </a:rPr>
-              <a:t>•  One-call reconstructible studies: every figure in this deck rebuilds from a committed script and committed records.</a:t>
-            </a:r>
-          </a:p>
-        </p:txBody>
-      </p:sp>
-      <p:sp>
-        <p:nvSpPr>
-          <p:cNvPr id="5" name="TextBox 4"/>
-          <p:cNvSpPr txBox="1"/>
-          <p:nvPr/>
-        </p:nvSpPr>
-        <p:spPr>
-          <a:xfrm>
-            <a:off x="6400800" y="1298448"/>
-            <a:ext cx="5394960" cy="274320"/>
-          </a:xfrm>
-          <a:prstGeom prst="rect">
-            <a:avLst/>
-          </a:prstGeom>
-          <a:noFill/>
-        </p:spPr>
-        <p:txBody>
-          <a:bodyPr wrap="square">
-            <a:spAutoFit/>
-          </a:bodyPr>
-          <a:lstStyle/>
-          <a:p>
-            <a:pPr>
-              <a:spcAft>
-                <a:spcPts val="600"/>
-              </a:spcAft>
-            </a:pPr>
-            <a:r>
-              <a:rPr sz="1200" b="0">
-                <a:solidFill>
-                  <a:srgbClr val="282828"/>
-                </a:solidFill>
-                <a:latin typeface="Arial"/>
-              </a:rPr>
-              <a:t>•  Utilities: trace, wavefront, perturb, pupil find; layout and ray-bundle viewers; Jones pupils, polarization elements; segment grid bases and grid file IO; multi-wavelength composition; spot, intensity, complex field.</a:t>
-            </a:r>
-          </a:p>
-          <a:p>
-            <a:pPr>
-              <a:spcAft>
-                <a:spcPts val="600"/>
-              </a:spcAft>
-            </a:pPr>
-            <a:r>
-              <a:rPr sz="1200" b="0">
-                <a:solidFill>
-                  <a:srgbClr val="282828"/>
-                </a:solidFill>
-                <a:latin typeface="Arial"/>
-              </a:rPr>
-              <a:t>•  Why a design layer: the whole stack is public-domain — a design study needs no proprietary prescription to start from.</a:t>
-            </a:r>
-          </a:p>
-        </p:txBody>
-      </p:sp>
-      <p:sp>
-        <p:nvSpPr>
-          <p:cNvPr id="6" name="TextBox 5"/>
-          <p:cNvSpPr txBox="1"/>
-          <p:nvPr/>
-        </p:nvSpPr>
-        <p:spPr>
-          <a:xfrm>
-            <a:off x="6400800" y="2804160"/>
-            <a:ext cx="5394960" cy="274320"/>
-          </a:xfrm>
-          <a:prstGeom prst="rect">
-            <a:avLst/>
-          </a:prstGeom>
-          <a:noFill/>
-        </p:spPr>
-        <p:txBody>
-          <a:bodyPr wrap="square">
-            <a:spAutoFit/>
-          </a:bodyPr>
-          <a:lstStyle/>
-          <a:p>
-            <a:pPr>
-              <a:spcAft>
-                <a:spcPts val="600"/>
-              </a:spcAft>
-            </a:pPr>
-            <a:r>
-              <a:rPr sz="1050" b="0">
-                <a:solidFill>
-                  <a:srgbClr val="6E6E6E"/>
-                </a:solidFill>
-                <a:latin typeface="Arial"/>
-              </a:rPr>
-              <a:t>The two live demonstrations exercised exactly these layers: the bench builder and a design-family driver.</a:t>
-            </a:r>
-          </a:p>
-        </p:txBody>
-      </p:sp>
-    </p:spTree>
-  </p:cSld>
-  <p:clrMapOvr>
-    <a:masterClrMapping/>
-  </p:clrMapOvr>
-</p:sld>
-</file>
-
-<file path=ppt/slides/slide34.xml><?xml version="1.0" encoding="utf-8"?>
 <p:sld xmlns:a="http://schemas.openxmlformats.org/drawingml/2006/main" xmlns:p="http://schemas.openxmlformats.org/presentationml/2006/main" xmlns:r="http://schemas.openxmlformats.org/officeDocument/2006/relationships">
   <p:cSld>
     <p:spTree>
@@ -13700,7 +13317,7 @@
 </p:sld>
 </file>
 
-<file path=ppt/slides/slide35.xml><?xml version="1.0" encoding="utf-8"?>
+<file path=ppt/slides/slide33.xml><?xml version="1.0" encoding="utf-8"?>
 <p:sld xmlns:a="http://schemas.openxmlformats.org/drawingml/2006/main" xmlns:p="http://schemas.openxmlformats.org/presentationml/2006/main" xmlns:r="http://schemas.openxmlformats.org/officeDocument/2006/relationships">
   <p:cSld>
     <p:spTree>
@@ -14566,7 +14183,7 @@
 </p:sld>
 </file>
 
-<file path=ppt/slides/slide36.xml><?xml version="1.0" encoding="utf-8"?>
+<file path=ppt/slides/slide34.xml><?xml version="1.0" encoding="utf-8"?>
 <p:sld xmlns:a="http://schemas.openxmlformats.org/drawingml/2006/main" xmlns:p="http://schemas.openxmlformats.org/presentationml/2006/main" xmlns:r="http://schemas.openxmlformats.org/officeDocument/2006/relationships">
   <p:cSld>
     <p:spTree>
@@ -14773,6 +14390,688 @@
                 <a:latin typeface="Arial"/>
               </a:rPr>
               <a:t>Committed: deepest optic 1.887 m = 1.81× the spacing, the feed beam through the collimator by −79.9 mm.  Four-flat recipe: 0.893 m deep, but a fold is an isometry — the interference rides across — and it does not close on the cleared deck (96 routes, every admissible one loses rays).  Cleared −10°: 1.287 m = 1.24×, zero flats, +37.8 mm of daylight.  Record: challenges/afocal4/{packaging,clearing}.</a:t>
+            </a:r>
+          </a:p>
+        </p:txBody>
+      </p:sp>
+    </p:spTree>
+  </p:cSld>
+  <p:clrMapOvr>
+    <a:masterClrMapping/>
+  </p:clrMapOvr>
+</p:sld>
+</file>
+
+<file path=ppt/slides/slide35.xml><?xml version="1.0" encoding="utf-8"?>
+<p:sld xmlns:a="http://schemas.openxmlformats.org/drawingml/2006/main" xmlns:p="http://schemas.openxmlformats.org/presentationml/2006/main" xmlns:r="http://schemas.openxmlformats.org/officeDocument/2006/relationships">
+  <p:cSld>
+    <p:spTree>
+      <p:nvGrpSpPr>
+        <p:cNvPr id="1" name=""/>
+        <p:cNvGrpSpPr/>
+        <p:nvPr/>
+      </p:nvGrpSpPr>
+      <p:grpSpPr/>
+      <p:sp>
+        <p:nvSpPr>
+          <p:cNvPr id="2" name="TextBox 1"/>
+          <p:cNvSpPr txBox="1"/>
+          <p:nvPr/>
+        </p:nvSpPr>
+        <p:spPr>
+          <a:xfrm>
+            <a:off x="411480" y="201168"/>
+            <a:ext cx="11368735" cy="914400"/>
+          </a:xfrm>
+          <a:prstGeom prst="rect">
+            <a:avLst/>
+          </a:prstGeom>
+          <a:noFill/>
+        </p:spPr>
+        <p:txBody>
+          <a:bodyPr wrap="square">
+            <a:spAutoFit/>
+          </a:bodyPr>
+          <a:lstStyle/>
+          <a:p>
+            <a:pPr>
+              <a:spcAft>
+                <a:spcPts val="400"/>
+              </a:spcAft>
+            </a:pPr>
+            <a:r>
+              <a:rPr sz="2400" b="1">
+                <a:solidFill>
+                  <a:srgbClr val="1F4E79"/>
+                </a:solidFill>
+                <a:latin typeface="Arial"/>
+              </a:rPr>
+              <a:t>Interferometer demonstration backups</a:t>
+            </a:r>
+          </a:p>
+          <a:p>
+            <a:pPr>
+              <a:spcAft>
+                <a:spcPts val="0"/>
+              </a:spcAft>
+            </a:pPr>
+            <a:r>
+              <a:rPr sz="1250" b="0">
+                <a:solidFill>
+                  <a:srgbClr val="6E6E6E"/>
+                </a:solidFill>
+                <a:latin typeface="Arial"/>
+              </a:rPr>
+              <a:t>One committed image per live beat</a:t>
+            </a:r>
+          </a:p>
+        </p:txBody>
+      </p:sp>
+      <p:sp>
+        <p:nvSpPr>
+          <p:cNvPr id="3" name="Rectangle 2"/>
+          <p:cNvSpPr/>
+          <p:nvPr/>
+        </p:nvSpPr>
+        <p:spPr>
+          <a:xfrm>
+            <a:off x="411480" y="1133856"/>
+            <a:ext cx="11368735" cy="20320"/>
+          </a:xfrm>
+          <a:prstGeom prst="rect">
+            <a:avLst/>
+          </a:prstGeom>
+          <a:solidFill>
+            <a:srgbClr val="B8C6D4"/>
+          </a:solidFill>
+          <a:ln>
+            <a:noFill/>
+          </a:ln>
+          <a:effectLst/>
+        </p:spPr>
+        <p:style>
+          <a:lnRef idx="1">
+            <a:schemeClr val="accent1"/>
+          </a:lnRef>
+          <a:fillRef idx="3">
+            <a:schemeClr val="accent1"/>
+          </a:fillRef>
+          <a:effectRef idx="2">
+            <a:schemeClr val="accent1"/>
+          </a:effectRef>
+          <a:fontRef idx="minor">
+            <a:schemeClr val="lt1"/>
+          </a:fontRef>
+        </p:style>
+        <p:txBody>
+          <a:bodyPr rtlCol="0" anchor="ctr"/>
+          <a:lstStyle/>
+          <a:p>
+            <a:pPr algn="ctr"/>
+          </a:p>
+        </p:txBody>
+      </p:sp>
+      <p:pic>
+        <p:nvPicPr>
+          <p:cNvPr id="4" name="Picture 3" descr="demo2_beat5_poke.png"/>
+          <p:cNvPicPr>
+            <a:picLocks noChangeAspect="1"/>
+          </p:cNvPicPr>
+          <p:nvPr/>
+        </p:nvPicPr>
+        <p:blipFill>
+          <a:blip r:embed="rId2"/>
+          <a:stretch>
+            <a:fillRect/>
+          </a:stretch>
+        </p:blipFill>
+        <p:spPr>
+          <a:xfrm>
+            <a:off x="3772370" y="1298448"/>
+            <a:ext cx="4646955" cy="1782572"/>
+          </a:xfrm>
+          <a:prstGeom prst="rect">
+            <a:avLst/>
+          </a:prstGeom>
+        </p:spPr>
+      </p:pic>
+      <p:sp>
+        <p:nvSpPr>
+          <p:cNvPr id="5" name="TextBox 4"/>
+          <p:cNvSpPr txBox="1"/>
+          <p:nvPr/>
+        </p:nvSpPr>
+        <p:spPr>
+          <a:xfrm>
+            <a:off x="411480" y="3099308"/>
+            <a:ext cx="11368735" cy="229107"/>
+          </a:xfrm>
+          <a:prstGeom prst="rect">
+            <a:avLst/>
+          </a:prstGeom>
+          <a:noFill/>
+        </p:spPr>
+        <p:txBody>
+          <a:bodyPr wrap="square">
+            <a:spAutoFit/>
+          </a:bodyPr>
+          <a:lstStyle/>
+          <a:p>
+            <a:pPr algn="ctr">
+              <a:spcAft>
+                <a:spcPts val="0"/>
+              </a:spcAft>
+            </a:pPr>
+            <a:r>
+              <a:rPr sz="1000" b="0">
+                <a:solidFill>
+                  <a:srgbClr val="6E6E6E"/>
+                </a:solidFill>
+                <a:latin typeface="Arial"/>
+              </a:rPr>
+              <a:t>Beat 5 — one actuator poked: the fringes bend over it.</a:t>
+            </a:r>
+          </a:p>
+        </p:txBody>
+      </p:sp>
+      <p:pic>
+        <p:nvPicPr>
+          <p:cNvPr id="6" name="Picture 5" descr="demo2_beat6_sweep.png"/>
+          <p:cNvPicPr>
+            <a:picLocks noChangeAspect="1"/>
+          </p:cNvPicPr>
+          <p:nvPr/>
+        </p:nvPicPr>
+        <p:blipFill>
+          <a:blip r:embed="rId3"/>
+          <a:stretch>
+            <a:fillRect/>
+          </a:stretch>
+        </p:blipFill>
+        <p:spPr>
+          <a:xfrm>
+            <a:off x="4186821" y="3364992"/>
+            <a:ext cx="3818051" cy="1782572"/>
+          </a:xfrm>
+          <a:prstGeom prst="rect">
+            <a:avLst/>
+          </a:prstGeom>
+        </p:spPr>
+      </p:pic>
+      <p:sp>
+        <p:nvSpPr>
+          <p:cNvPr id="7" name="TextBox 6"/>
+          <p:cNvSpPr txBox="1"/>
+          <p:nvPr/>
+        </p:nvSpPr>
+        <p:spPr>
+          <a:xfrm>
+            <a:off x="411480" y="5165852"/>
+            <a:ext cx="11368735" cy="229107"/>
+          </a:xfrm>
+          <a:prstGeom prst="rect">
+            <a:avLst/>
+          </a:prstGeom>
+          <a:noFill/>
+        </p:spPr>
+        <p:txBody>
+          <a:bodyPr wrap="square">
+            <a:spAutoFit/>
+          </a:bodyPr>
+          <a:lstStyle/>
+          <a:p>
+            <a:pPr algn="ctr">
+              <a:spcAft>
+                <a:spcPts val="0"/>
+              </a:spcAft>
+            </a:pPr>
+            <a:r>
+              <a:rPr sz="1000" b="0">
+                <a:solidFill>
+                  <a:srgbClr val="6E6E6E"/>
+                </a:solidFill>
+                <a:latin typeface="Arial"/>
+              </a:rPr>
+              <a:t>Beat 6 — the analyzer sweep: phase-stepped frames, no re-trace.</a:t>
+            </a:r>
+          </a:p>
+        </p:txBody>
+      </p:sp>
+      <p:pic>
+        <p:nvPicPr>
+          <p:cNvPr id="8" name="Picture 7" descr="demo2_beat7_recovery.png"/>
+          <p:cNvPicPr>
+            <a:picLocks noChangeAspect="1"/>
+          </p:cNvPicPr>
+          <p:nvPr/>
+        </p:nvPicPr>
+        <p:blipFill>
+          <a:blip r:embed="rId4"/>
+          <a:stretch>
+            <a:fillRect/>
+          </a:stretch>
+        </p:blipFill>
+        <p:spPr>
+          <a:xfrm>
+            <a:off x="4177857" y="5431536"/>
+            <a:ext cx="3835980" cy="1032763"/>
+          </a:xfrm>
+          <a:prstGeom prst="rect">
+            <a:avLst/>
+          </a:prstGeom>
+        </p:spPr>
+      </p:pic>
+      <p:sp>
+        <p:nvSpPr>
+          <p:cNvPr id="9" name="TextBox 8"/>
+          <p:cNvSpPr txBox="1"/>
+          <p:nvPr/>
+        </p:nvSpPr>
+        <p:spPr>
+          <a:xfrm>
+            <a:off x="411480" y="6482588"/>
+            <a:ext cx="11368735" cy="229107"/>
+          </a:xfrm>
+          <a:prstGeom prst="rect">
+            <a:avLst/>
+          </a:prstGeom>
+          <a:noFill/>
+        </p:spPr>
+        <p:txBody>
+          <a:bodyPr wrap="square">
+            <a:spAutoFit/>
+          </a:bodyPr>
+          <a:lstStyle/>
+          <a:p>
+            <a:pPr algn="ctr">
+              <a:spcAft>
+                <a:spcPts val="0"/>
+              </a:spcAft>
+            </a:pPr>
+            <a:r>
+              <a:rPr sz="1000" b="0">
+                <a:solidFill>
+                  <a:srgbClr val="6E6E6E"/>
+                </a:solidFill>
+                <a:latin typeface="Arial"/>
+              </a:rPr>
+              <a:t>Beat 7 — the recovery beside the truth map.</a:t>
+            </a:r>
+          </a:p>
+        </p:txBody>
+      </p:sp>
+      <p:sp>
+        <p:nvSpPr>
+          <p:cNvPr id="10" name="TextBox 9"/>
+          <p:cNvSpPr txBox="1"/>
+          <p:nvPr/>
+        </p:nvSpPr>
+        <p:spPr>
+          <a:xfrm>
+            <a:off x="411480" y="6748272"/>
+            <a:ext cx="11368735" cy="274320"/>
+          </a:xfrm>
+          <a:prstGeom prst="rect">
+            <a:avLst/>
+          </a:prstGeom>
+          <a:noFill/>
+        </p:spPr>
+        <p:txBody>
+          <a:bodyPr wrap="square">
+            <a:spAutoFit/>
+          </a:bodyPr>
+          <a:lstStyle/>
+          <a:p>
+            <a:pPr>
+              <a:spcAft>
+                <a:spcPts val="600"/>
+              </a:spcAft>
+            </a:pPr>
+            <a:r>
+              <a:rPr sz="1050" b="0">
+                <a:solidFill>
+                  <a:srgbClr val="6E6E6E"/>
+                </a:solidFill>
+                <a:latin typeface="Arial"/>
+              </a:rPr>
+              <a:t>All eight beats have committed figures in templates/90_polarization/tg_psi_dm_v2 (v1 likewise); the driver opens them on the desktop as each beat runs.</a:t>
+            </a:r>
+          </a:p>
+        </p:txBody>
+      </p:sp>
+    </p:spTree>
+  </p:cSld>
+  <p:clrMapOvr>
+    <a:masterClrMapping/>
+  </p:clrMapOvr>
+</p:sld>
+</file>
+
+<file path=ppt/slides/slide36.xml><?xml version="1.0" encoding="utf-8"?>
+<p:sld xmlns:a="http://schemas.openxmlformats.org/drawingml/2006/main" xmlns:p="http://schemas.openxmlformats.org/presentationml/2006/main" xmlns:r="http://schemas.openxmlformats.org/officeDocument/2006/relationships">
+  <p:cSld>
+    <p:spTree>
+      <p:nvGrpSpPr>
+        <p:cNvPr id="1" name=""/>
+        <p:cNvGrpSpPr/>
+        <p:nvPr/>
+      </p:nvGrpSpPr>
+      <p:grpSpPr/>
+      <p:sp>
+        <p:nvSpPr>
+          <p:cNvPr id="2" name="TextBox 1"/>
+          <p:cNvSpPr txBox="1"/>
+          <p:nvPr/>
+        </p:nvSpPr>
+        <p:spPr>
+          <a:xfrm>
+            <a:off x="411480" y="201168"/>
+            <a:ext cx="11368735" cy="914400"/>
+          </a:xfrm>
+          <a:prstGeom prst="rect">
+            <a:avLst/>
+          </a:prstGeom>
+          <a:noFill/>
+        </p:spPr>
+        <p:txBody>
+          <a:bodyPr wrap="square">
+            <a:spAutoFit/>
+          </a:bodyPr>
+          <a:lstStyle/>
+          <a:p>
+            <a:pPr>
+              <a:spcAft>
+                <a:spcPts val="400"/>
+              </a:spcAft>
+            </a:pPr>
+            <a:r>
+              <a:rPr sz="2400" b="1">
+                <a:solidFill>
+                  <a:srgbClr val="1F4E79"/>
+                </a:solidFill>
+                <a:latin typeface="Arial"/>
+              </a:rPr>
+              <a:t>The e2e worked example: specification to design</a:t>
+            </a:r>
+          </a:p>
+          <a:p>
+            <a:pPr>
+              <a:spcAft>
+                <a:spcPts val="0"/>
+              </a:spcAft>
+            </a:pPr>
+            <a:r>
+              <a:rPr sz="1250" b="0">
+                <a:solidFill>
+                  <a:srgbClr val="6E6E6E"/>
+                </a:solidFill>
+                <a:latin typeface="Arial"/>
+              </a:rPr>
+              <a:t>A 4 m f/18 visible-band telescope from a closed-form seed — no starting prescription</a:t>
+            </a:r>
+          </a:p>
+        </p:txBody>
+      </p:sp>
+      <p:sp>
+        <p:nvSpPr>
+          <p:cNvPr id="3" name="Rectangle 2"/>
+          <p:cNvSpPr/>
+          <p:nvPr/>
+        </p:nvSpPr>
+        <p:spPr>
+          <a:xfrm>
+            <a:off x="411480" y="1133856"/>
+            <a:ext cx="11368735" cy="20320"/>
+          </a:xfrm>
+          <a:prstGeom prst="rect">
+            <a:avLst/>
+          </a:prstGeom>
+          <a:solidFill>
+            <a:srgbClr val="B8C6D4"/>
+          </a:solidFill>
+          <a:ln>
+            <a:noFill/>
+          </a:ln>
+          <a:effectLst/>
+        </p:spPr>
+        <p:style>
+          <a:lnRef idx="1">
+            <a:schemeClr val="accent1"/>
+          </a:lnRef>
+          <a:fillRef idx="3">
+            <a:schemeClr val="accent1"/>
+          </a:fillRef>
+          <a:effectRef idx="2">
+            <a:schemeClr val="accent1"/>
+          </a:effectRef>
+          <a:fontRef idx="minor">
+            <a:schemeClr val="lt1"/>
+          </a:fontRef>
+        </p:style>
+        <p:txBody>
+          <a:bodyPr rtlCol="0" anchor="ctr"/>
+          <a:lstStyle/>
+          <a:p>
+            <a:pPr algn="ctr"/>
+          </a:p>
+        </p:txBody>
+      </p:sp>
+      <p:sp>
+        <p:nvSpPr>
+          <p:cNvPr id="4" name="TextBox 3"/>
+          <p:cNvSpPr txBox="1"/>
+          <p:nvPr/>
+        </p:nvSpPr>
+        <p:spPr>
+          <a:xfrm>
+            <a:off x="411480" y="1298448"/>
+            <a:ext cx="5806440" cy="274320"/>
+          </a:xfrm>
+          <a:prstGeom prst="rect">
+            <a:avLst/>
+          </a:prstGeom>
+          <a:noFill/>
+        </p:spPr>
+        <p:txBody>
+          <a:bodyPr wrap="square">
+            <a:spAutoFit/>
+          </a:bodyPr>
+          <a:lstStyle/>
+          <a:p>
+            <a:pPr>
+              <a:spcAft>
+                <a:spcPts val="600"/>
+              </a:spcAft>
+            </a:pPr>
+            <a:r>
+              <a:rPr sz="1200" b="0">
+                <a:solidFill>
+                  <a:srgbClr val="282828"/>
+                </a:solidFill>
+                <a:latin typeface="Arial"/>
+              </a:rPr>
+              <a:t>•  The stage-runner sequence on the smaller worked example: specification → design → segmentation → metrology → comparison → simulation, each stage a committed runner handing its prescription to the next.</a:t>
+            </a:r>
+          </a:p>
+          <a:p>
+            <a:pPr>
+              <a:spcAft>
+                <a:spcPts val="600"/>
+              </a:spcAft>
+            </a:pPr>
+            <a:r>
+              <a:rPr sz="1200" b="0">
+                <a:solidFill>
+                  <a:srgbClr val="282828"/>
+                </a:solidFill>
+                <a:latin typeface="Arial"/>
+              </a:rPr>
+              <a:t>•  A 4 m f/18 telescope (f/1.75 primary) from a closed-form first-order seed; diffraction-limited over ±1′ alone, and the Offner ring-field relay buys the full ±2′ (Strehl floor 0.965, on pure spheres).</a:t>
+            </a:r>
+          </a:p>
+        </p:txBody>
+      </p:sp>
+      <p:pic>
+        <p:nvPicPr>
+          <p:cNvPr id="5" name="Picture 4" descr="rowpair_s1_views.png"/>
+          <p:cNvPicPr>
+            <a:picLocks noChangeAspect="1"/>
+          </p:cNvPicPr>
+          <p:nvPr/>
+        </p:nvPicPr>
+        <p:blipFill>
+          <a:blip r:embed="rId2"/>
+          <a:stretch>
+            <a:fillRect/>
+          </a:stretch>
+        </p:blipFill>
+        <p:spPr>
+          <a:xfrm>
+            <a:off x="6738659" y="1298448"/>
+            <a:ext cx="4719240" cy="2056892"/>
+          </a:xfrm>
+          <a:prstGeom prst="rect">
+            <a:avLst/>
+          </a:prstGeom>
+        </p:spPr>
+      </p:pic>
+      <p:sp>
+        <p:nvSpPr>
+          <p:cNvPr id="6" name="TextBox 5"/>
+          <p:cNvSpPr txBox="1"/>
+          <p:nvPr/>
+        </p:nvSpPr>
+        <p:spPr>
+          <a:xfrm>
+            <a:off x="6400800" y="3373628"/>
+            <a:ext cx="5394960" cy="229107"/>
+          </a:xfrm>
+          <a:prstGeom prst="rect">
+            <a:avLst/>
+          </a:prstGeom>
+          <a:noFill/>
+        </p:spPr>
+        <p:txBody>
+          <a:bodyPr wrap="square">
+            <a:spAutoFit/>
+          </a:bodyPr>
+          <a:lstStyle/>
+          <a:p>
+            <a:pPr algn="ctr">
+              <a:spcAft>
+                <a:spcPts val="0"/>
+              </a:spcAft>
+            </a:pPr>
+            <a:r>
+              <a:rPr sz="1000" b="0">
+                <a:solidFill>
+                  <a:srgbClr val="6E6E6E"/>
+                </a:solidFill>
+                <a:latin typeface="Arial"/>
+              </a:rPr>
+              <a:t>The telescope as designed (front + iso views), with the traced field.</a:t>
+            </a:r>
+          </a:p>
+        </p:txBody>
+      </p:sp>
+      <p:pic>
+        <p:nvPicPr>
+          <p:cNvPr id="7" name="Picture 6" descr="s1_wfe_field.png"/>
+          <p:cNvPicPr>
+            <a:picLocks noChangeAspect="1"/>
+          </p:cNvPicPr>
+          <p:nvPr/>
+        </p:nvPicPr>
+        <p:blipFill>
+          <a:blip r:embed="rId3"/>
+          <a:stretch>
+            <a:fillRect/>
+          </a:stretch>
+        </p:blipFill>
+        <p:spPr>
+          <a:xfrm>
+            <a:off x="7993860" y="3639312"/>
+            <a:ext cx="2208839" cy="1782572"/>
+          </a:xfrm>
+          <a:prstGeom prst="rect">
+            <a:avLst/>
+          </a:prstGeom>
+        </p:spPr>
+      </p:pic>
+      <p:sp>
+        <p:nvSpPr>
+          <p:cNvPr id="8" name="TextBox 7"/>
+          <p:cNvSpPr txBox="1"/>
+          <p:nvPr/>
+        </p:nvSpPr>
+        <p:spPr>
+          <a:xfrm>
+            <a:off x="6400800" y="5440171"/>
+            <a:ext cx="5394960" cy="229107"/>
+          </a:xfrm>
+          <a:prstGeom prst="rect">
+            <a:avLst/>
+          </a:prstGeom>
+          <a:noFill/>
+        </p:spPr>
+        <p:txBody>
+          <a:bodyPr wrap="square">
+            <a:spAutoFit/>
+          </a:bodyPr>
+          <a:lstStyle/>
+          <a:p>
+            <a:pPr algn="ctr">
+              <a:spcAft>
+                <a:spcPts val="0"/>
+              </a:spcAft>
+            </a:pPr>
+            <a:r>
+              <a:rPr sz="1000" b="0">
+                <a:solidFill>
+                  <a:srgbClr val="6E6E6E"/>
+                </a:solidFill>
+                <a:latin typeface="Arial"/>
+              </a:rPr>
+              <a:t>Wavefront error over the field: diffraction-limited across the box.</a:t>
+            </a:r>
+          </a:p>
+        </p:txBody>
+      </p:sp>
+      <p:sp>
+        <p:nvSpPr>
+          <p:cNvPr id="9" name="TextBox 8"/>
+          <p:cNvSpPr txBox="1"/>
+          <p:nvPr/>
+        </p:nvSpPr>
+        <p:spPr>
+          <a:xfrm>
+            <a:off x="6400800" y="5705855"/>
+            <a:ext cx="5394960" cy="274320"/>
+          </a:xfrm>
+          <a:prstGeom prst="rect">
+            <a:avLst/>
+          </a:prstGeom>
+          <a:noFill/>
+        </p:spPr>
+        <p:txBody>
+          <a:bodyPr wrap="square">
+            <a:spAutoFit/>
+          </a:bodyPr>
+          <a:lstStyle/>
+          <a:p>
+            <a:pPr>
+              <a:spcAft>
+                <a:spcPts val="600"/>
+              </a:spcAft>
+            </a:pPr>
+            <a:r>
+              <a:rPr sz="1050" b="0">
+                <a:solidFill>
+                  <a:srgbClr val="6E6E6E"/>
+                </a:solidFill>
+                <a:latin typeface="Arial"/>
+              </a:rPr>
+              <a:t>Record: templates/80_end_to_end/e2e — staged worked example, committed at every step.</a:t>
             </a:r>
           </a:p>
         </p:txBody>
@@ -14829,7 +15128,7 @@
                 </a:solidFill>
                 <a:latin typeface="Arial"/>
               </a:rPr>
-              <a:t>Interferometer demonstration backups</a:t>
+              <a:t>The e2e worked example: segmentation and metrology</a:t>
             </a:r>
           </a:p>
           <a:p>
@@ -14845,7 +15144,7 @@
                 </a:solidFill>
                 <a:latin typeface="Arial"/>
               </a:rPr>
-              <a:t>One committed image per live beat</a:t>
+              <a:t>The monolith segments in one call; the metrology is designed on the same Jacobian</a:t>
             </a:r>
           </a:p>
         </p:txBody>
@@ -14894,9 +15193,64 @@
           </a:p>
         </p:txBody>
       </p:sp>
+      <p:sp>
+        <p:nvSpPr>
+          <p:cNvPr id="4" name="TextBox 3"/>
+          <p:cNvSpPr txBox="1"/>
+          <p:nvPr/>
+        </p:nvSpPr>
+        <p:spPr>
+          <a:xfrm>
+            <a:off x="411480" y="1298448"/>
+            <a:ext cx="5806440" cy="274320"/>
+          </a:xfrm>
+          <a:prstGeom prst="rect">
+            <a:avLst/>
+          </a:prstGeom>
+          <a:noFill/>
+        </p:spPr>
+        <p:txBody>
+          <a:bodyPr wrap="square">
+            <a:spAutoFit/>
+          </a:bodyPr>
+          <a:lstStyle/>
+          <a:p>
+            <a:pPr>
+              <a:spcAft>
+                <a:spcPts val="600"/>
+              </a:spcAft>
+            </a:pPr>
+            <a:r>
+              <a:rPr sz="1200" b="0">
+                <a:solidFill>
+                  <a:srgbClr val="282828"/>
+                </a:solidFill>
+                <a:latin typeface="Arial"/>
+              </a:rPr>
+              <a:t>•  The primary segments into a pie or hex tiling with physical apertures; every segment gets rigid-body and surface-figure sensitivity channels, stacked into one Jacobian — the control basis.</a:t>
+            </a:r>
+          </a:p>
+          <a:p>
+            <a:pPr>
+              <a:spcAft>
+                <a:spcPts val="600"/>
+              </a:spcAft>
+            </a:pPr>
+            <a:r>
+              <a:rPr sz="1200" b="0">
+                <a:solidFill>
+                  <a:srgbClr val="282828"/>
+                </a:solidFill>
+                <a:latin typeface="Arial"/>
+              </a:rPr>
+              <a:t>•  Metrology is an optimization on that basis: edge-sensor and beam-launcher layouts scored by the control information they carry, not by symmetry; the winning pattern exports as a reusable preset.</a:t>
+            </a:r>
+          </a:p>
+        </p:txBody>
+      </p:sp>
       <p:pic>
         <p:nvPicPr>
-          <p:cNvPr id="4" name="Picture 3" descr="demo2_beat5_poke.png"/>
+          <p:cNvPr id="5" name="Picture 4" descr="rowpair_s3_views_pie.png"/>
           <p:cNvPicPr>
             <a:picLocks noChangeAspect="1"/>
           </p:cNvPicPr>
@@ -14910,8 +15264,8 @@
         </p:blipFill>
         <p:spPr>
           <a:xfrm>
-            <a:off x="3772370" y="1298448"/>
-            <a:ext cx="4646955" cy="1782572"/>
+            <a:off x="6618167" y="1298448"/>
+            <a:ext cx="4960224" cy="1965451"/>
           </a:xfrm>
           <a:prstGeom prst="rect">
             <a:avLst/>
@@ -14920,14 +15274,14 @@
       </p:pic>
       <p:sp>
         <p:nvSpPr>
-          <p:cNvPr id="5" name="TextBox 4"/>
+          <p:cNvPr id="6" name="TextBox 5"/>
           <p:cNvSpPr txBox="1"/>
           <p:nvPr/>
         </p:nvSpPr>
         <p:spPr>
           <a:xfrm>
-            <a:off x="411480" y="3099308"/>
-            <a:ext cx="11368735" cy="229107"/>
+            <a:off x="6400800" y="3282188"/>
+            <a:ext cx="5394960" cy="229107"/>
           </a:xfrm>
           <a:prstGeom prst="rect">
             <a:avLst/>
@@ -14952,14 +15306,14 @@
                 </a:solidFill>
                 <a:latin typeface="Arial"/>
               </a:rPr>
-              <a:t>Beat 5 — one actuator poked: the fringes bend over it.</a:t>
+              <a:t>The segmented primary with physical apertures (front + iso views).</a:t>
             </a:r>
           </a:p>
         </p:txBody>
       </p:sp>
       <p:pic>
         <p:nvPicPr>
-          <p:cNvPr id="6" name="Picture 5" descr="demo2_beat6_sweep.png"/>
+          <p:cNvPr id="7" name="Picture 6" descr="e2e_pie_met_view_rx.png"/>
           <p:cNvPicPr>
             <a:picLocks noChangeAspect="1"/>
           </p:cNvPicPr>
@@ -14973,8 +15327,8 @@
         </p:blipFill>
         <p:spPr>
           <a:xfrm>
-            <a:off x="4186821" y="3364992"/>
-            <a:ext cx="3818051" cy="1782572"/>
+            <a:off x="7662896" y="3547872"/>
+            <a:ext cx="2870767" cy="1874011"/>
           </a:xfrm>
           <a:prstGeom prst="rect">
             <a:avLst/>
@@ -14983,14 +15337,14 @@
       </p:pic>
       <p:sp>
         <p:nvSpPr>
-          <p:cNvPr id="7" name="TextBox 6"/>
+          <p:cNvPr id="8" name="TextBox 7"/>
           <p:cNvSpPr txBox="1"/>
           <p:nvPr/>
         </p:nvSpPr>
         <p:spPr>
           <a:xfrm>
-            <a:off x="411480" y="5165852"/>
-            <a:ext cx="11368735" cy="229107"/>
+            <a:off x="6400800" y="5440171"/>
+            <a:ext cx="5394960" cy="229107"/>
           </a:xfrm>
           <a:prstGeom prst="rect">
             <a:avLst/>
@@ -15015,35 +15369,11 @@
                 </a:solidFill>
                 <a:latin typeface="Arial"/>
               </a:rPr>
-              <a:t>Beat 6 — the analyzer sweep: phase-stepped frames, no re-trace.</a:t>
-            </a:r>
-          </a:p>
-        </p:txBody>
-      </p:sp>
-      <p:pic>
-        <p:nvPicPr>
-          <p:cNvPr id="8" name="Picture 7" descr="demo2_beat7_recovery.png"/>
-          <p:cNvPicPr>
-            <a:picLocks noChangeAspect="1"/>
-          </p:cNvPicPr>
-          <p:nvPr/>
-        </p:nvPicPr>
-        <p:blipFill>
-          <a:blip r:embed="rId4"/>
-          <a:stretch>
-            <a:fillRect/>
-          </a:stretch>
-        </p:blipFill>
-        <p:spPr>
-          <a:xfrm>
-            <a:off x="4177857" y="5431536"/>
-            <a:ext cx="3835980" cy="1032763"/>
-          </a:xfrm>
-          <a:prstGeom prst="rect">
-            <a:avLst/>
-          </a:prstGeom>
-        </p:spPr>
-      </p:pic>
+              <a:t>The optimized metrology layout on the segmented primary.</a:t>
+            </a:r>
+          </a:p>
+        </p:txBody>
+      </p:sp>
       <p:sp>
         <p:nvSpPr>
           <p:cNvPr id="9" name="TextBox 8"/>
@@ -15052,8 +15382,8 @@
         </p:nvSpPr>
         <p:spPr>
           <a:xfrm>
-            <a:off x="411480" y="6482588"/>
-            <a:ext cx="11368735" cy="229107"/>
+            <a:off x="6400800" y="5705855"/>
+            <a:ext cx="5394960" cy="274320"/>
           </a:xfrm>
           <a:prstGeom prst="rect">
             <a:avLst/>
@@ -15066,58 +15396,19 @@
           </a:bodyPr>
           <a:lstStyle/>
           <a:p>
-            <a:pPr algn="ctr">
-              <a:spcAft>
-                <a:spcPts val="0"/>
-              </a:spcAft>
-            </a:pPr>
-            <a:r>
-              <a:rPr sz="1000" b="0">
+            <a:pPr>
+              <a:spcAft>
+                <a:spcPts val="600"/>
+              </a:spcAft>
+            </a:pPr>
+            <a:r>
+              <a:rPr sz="1050" b="0">
                 <a:solidFill>
                   <a:srgbClr val="6E6E6E"/>
                 </a:solidFill>
                 <a:latin typeface="Arial"/>
               </a:rPr>
-              <a:t>Beat 7 — the recovery beside the truth map.</a:t>
-            </a:r>
-          </a:p>
-        </p:txBody>
-      </p:sp>
-      <p:sp>
-        <p:nvSpPr>
-          <p:cNvPr id="10" name="TextBox 9"/>
-          <p:cNvSpPr txBox="1"/>
-          <p:nvPr/>
-        </p:nvSpPr>
-        <p:spPr>
-          <a:xfrm>
-            <a:off x="411480" y="6748272"/>
-            <a:ext cx="11368735" cy="274320"/>
-          </a:xfrm>
-          <a:prstGeom prst="rect">
-            <a:avLst/>
-          </a:prstGeom>
-          <a:noFill/>
-        </p:spPr>
-        <p:txBody>
-          <a:bodyPr wrap="square">
-            <a:spAutoFit/>
-          </a:bodyPr>
-          <a:lstStyle/>
-          <a:p>
-            <a:pPr>
-              <a:spcAft>
-                <a:spcPts val="600"/>
-              </a:spcAft>
-            </a:pPr>
-            <a:r>
-              <a:rPr sz="1050" b="0">
-                <a:solidFill>
-                  <a:srgbClr val="6E6E6E"/>
-                </a:solidFill>
-                <a:latin typeface="Arial"/>
-              </a:rPr>
-              <a:t>All eight beats have committed figures in templates/90_polarization/tg_psi_dm_v2 (v1 likewise); the driver opens them on the desktop as each beat runs.</a:t>
+              <a:t>Record: templates/80_end_to_end/e2e, stages 3–5.</a:t>
             </a:r>
           </a:p>
         </p:txBody>
@@ -15174,7 +15465,7 @@
                 </a:solidFill>
                 <a:latin typeface="Arial"/>
               </a:rPr>
-              <a:t>The e2e worked example: specification to design</a:t>
+              <a:t>The e2e worked example: comparison and simulation</a:t>
             </a:r>
           </a:p>
           <a:p>
@@ -15190,7 +15481,7 @@
                 </a:solidFill>
                 <a:latin typeface="Arial"/>
               </a:rPr>
-              <a:t>A 4 m f/18 visible-band telescope from a closed-form seed — no starting prescription</a:t>
+              <a:t>Segment drift of 10⁵ nm rms is sensed and held at ~7 nm corrected</a:t>
             </a:r>
           </a:p>
         </p:txBody>
@@ -15248,7 +15539,7 @@
         <p:spPr>
           <a:xfrm>
             <a:off x="411480" y="1298448"/>
-            <a:ext cx="5806440" cy="274320"/>
+            <a:ext cx="11368735" cy="274320"/>
           </a:xfrm>
           <a:prstGeom prst="rect">
             <a:avLst/>
@@ -15267,36 +15558,20 @@
               </a:spcAft>
             </a:pPr>
             <a:r>
-              <a:rPr sz="1200" b="0">
+              <a:rPr sz="1500" b="0">
                 <a:solidFill>
                   <a:srgbClr val="282828"/>
                 </a:solidFill>
                 <a:latin typeface="Arial"/>
               </a:rPr>
-              <a:t>•  The stage-runner sequence on the smaller worked example: specification → design → segmentation → metrology → comparison → simulation, each stage a committed runner handing its prescription to the next.</a:t>
-            </a:r>
-          </a:p>
-          <a:p>
-            <a:pPr>
-              <a:spcAft>
-                <a:spcPts val="600"/>
-              </a:spcAft>
-            </a:pPr>
-            <a:r>
-              <a:rPr sz="1200" b="0">
-                <a:solidFill>
-                  <a:srgbClr val="282828"/>
-                </a:solidFill>
-                <a:latin typeface="Arial"/>
-              </a:rPr>
-              <a:t>•  A 4 m f/18 telescope (f/1.75 primary) from a closed-form first-order seed; diffraction-limited over ±1′ alone, and the Offner ring-field relay buys the full ±2′ (Strehl floor 0.965, on pure spheres).</a:t>
+              <a:t>•  Every linear model is checked against the engine before it is trusted: step each channel, re-trace, render engine and model side by side (left).  Then the simulator closes the loop on the same model: inject drift, sense with the designed metrology, estimate, correct (right).</a:t>
             </a:r>
           </a:p>
         </p:txBody>
       </p:sp>
       <p:pic>
         <p:nvPicPr>
-          <p:cNvPr id="5" name="Picture 4" descr="rowpair_s1_views.png"/>
+          <p:cNvPr id="5" name="Picture 4" descr="e2e_compare_p001.png"/>
           <p:cNvPicPr>
             <a:picLocks noChangeAspect="1"/>
           </p:cNvPicPr>
@@ -15310,8 +15585,8 @@
         </p:blipFill>
         <p:spPr>
           <a:xfrm>
-            <a:off x="6738659" y="1298448"/>
-            <a:ext cx="4719240" cy="2056892"/>
+            <a:off x="1466756" y="2218182"/>
+            <a:ext cx="3695887" cy="2714752"/>
           </a:xfrm>
           <a:prstGeom prst="rect">
             <a:avLst/>
@@ -15326,8 +15601,8 @@
         </p:nvSpPr>
         <p:spPr>
           <a:xfrm>
-            <a:off x="6400800" y="3373628"/>
-            <a:ext cx="5394960" cy="229107"/>
+            <a:off x="411480" y="4951222"/>
+            <a:ext cx="5806440" cy="394208"/>
           </a:xfrm>
           <a:prstGeom prst="rect">
             <a:avLst/>
@@ -15352,14 +15627,14 @@
                 </a:solidFill>
                 <a:latin typeface="Arial"/>
               </a:rPr>
-              <a:t>The telescope as designed (front + iso views), with the traced field.</a:t>
+              <a:t>The comparison stage: engine re-trace vs linear model, one perturbation channel (segment 1 Rx, +100 nrad).</a:t>
             </a:r>
           </a:p>
         </p:txBody>
       </p:sp>
       <p:pic>
         <p:nvPicPr>
-          <p:cNvPr id="7" name="Picture 6" descr="s1_wfe_field.png"/>
+          <p:cNvPr id="7" name="Picture 6" descr="e2e_sim_t007.png"/>
           <p:cNvPicPr>
             <a:picLocks noChangeAspect="1"/>
           </p:cNvPicPr>
@@ -15373,8 +15648,8 @@
         </p:blipFill>
         <p:spPr>
           <a:xfrm>
-            <a:off x="7993860" y="3639312"/>
-            <a:ext cx="2208839" cy="1782572"/>
+            <a:off x="6784520" y="2218182"/>
+            <a:ext cx="4627519" cy="2714752"/>
           </a:xfrm>
           <a:prstGeom prst="rect">
             <a:avLst/>
@@ -15389,8 +15664,8 @@
         </p:nvSpPr>
         <p:spPr>
           <a:xfrm>
-            <a:off x="6400800" y="5440171"/>
-            <a:ext cx="5394960" cy="229107"/>
+            <a:off x="6400800" y="4951222"/>
+            <a:ext cx="5394960" cy="394208"/>
           </a:xfrm>
           <a:prstGeom prst="rect">
             <a:avLst/>
@@ -15415,7 +15690,7 @@
                 </a:solidFill>
                 <a:latin typeface="Arial"/>
               </a:rPr>
-              <a:t>Wavefront error over the field: diffraction-limited across the box.</a:t>
+              <a:t>The simulator at t = 70 s: uncorrected 1.0×10⁵ nm vs 6.8 nm corrected; accumulating WFE and Strehl vs time below.</a:t>
             </a:r>
           </a:p>
         </p:txBody>
@@ -15428,7 +15703,7 @@
         </p:nvSpPr>
         <p:spPr>
           <a:xfrm>
-            <a:off x="6400800" y="5705855"/>
+            <a:off x="6400800" y="5382006"/>
             <a:ext cx="5394960" cy="274320"/>
           </a:xfrm>
           <a:prstGeom prst="rect">
@@ -15454,344 +15729,7 @@
                 </a:solidFill>
                 <a:latin typeface="Arial"/>
               </a:rPr>
-              <a:t>Record: templates/80_end_to_end/e2e — staged worked example, committed at every step.</a:t>
-            </a:r>
-          </a:p>
-        </p:txBody>
-      </p:sp>
-    </p:spTree>
-  </p:cSld>
-  <p:clrMapOvr>
-    <a:masterClrMapping/>
-  </p:clrMapOvr>
-</p:sld>
-</file>
-
-<file path=ppt/slides/slide39.xml><?xml version="1.0" encoding="utf-8"?>
-<p:sld xmlns:a="http://schemas.openxmlformats.org/drawingml/2006/main" xmlns:p="http://schemas.openxmlformats.org/presentationml/2006/main" xmlns:r="http://schemas.openxmlformats.org/officeDocument/2006/relationships">
-  <p:cSld>
-    <p:spTree>
-      <p:nvGrpSpPr>
-        <p:cNvPr id="1" name=""/>
-        <p:cNvGrpSpPr/>
-        <p:nvPr/>
-      </p:nvGrpSpPr>
-      <p:grpSpPr/>
-      <p:sp>
-        <p:nvSpPr>
-          <p:cNvPr id="2" name="TextBox 1"/>
-          <p:cNvSpPr txBox="1"/>
-          <p:nvPr/>
-        </p:nvSpPr>
-        <p:spPr>
-          <a:xfrm>
-            <a:off x="411480" y="201168"/>
-            <a:ext cx="11368735" cy="914400"/>
-          </a:xfrm>
-          <a:prstGeom prst="rect">
-            <a:avLst/>
-          </a:prstGeom>
-          <a:noFill/>
-        </p:spPr>
-        <p:txBody>
-          <a:bodyPr wrap="square">
-            <a:spAutoFit/>
-          </a:bodyPr>
-          <a:lstStyle/>
-          <a:p>
-            <a:pPr>
-              <a:spcAft>
-                <a:spcPts val="400"/>
-              </a:spcAft>
-            </a:pPr>
-            <a:r>
-              <a:rPr sz="2400" b="1">
-                <a:solidFill>
-                  <a:srgbClr val="1F4E79"/>
-                </a:solidFill>
-                <a:latin typeface="Arial"/>
-              </a:rPr>
-              <a:t>The e2e worked example: segmentation and metrology</a:t>
-            </a:r>
-          </a:p>
-          <a:p>
-            <a:pPr>
-              <a:spcAft>
-                <a:spcPts val="0"/>
-              </a:spcAft>
-            </a:pPr>
-            <a:r>
-              <a:rPr sz="1250" b="0">
-                <a:solidFill>
-                  <a:srgbClr val="6E6E6E"/>
-                </a:solidFill>
-                <a:latin typeface="Arial"/>
-              </a:rPr>
-              <a:t>The monolith segments in one call; the metrology is designed on the same Jacobian</a:t>
-            </a:r>
-          </a:p>
-        </p:txBody>
-      </p:sp>
-      <p:sp>
-        <p:nvSpPr>
-          <p:cNvPr id="3" name="Rectangle 2"/>
-          <p:cNvSpPr/>
-          <p:nvPr/>
-        </p:nvSpPr>
-        <p:spPr>
-          <a:xfrm>
-            <a:off x="411480" y="1133856"/>
-            <a:ext cx="11368735" cy="20320"/>
-          </a:xfrm>
-          <a:prstGeom prst="rect">
-            <a:avLst/>
-          </a:prstGeom>
-          <a:solidFill>
-            <a:srgbClr val="B8C6D4"/>
-          </a:solidFill>
-          <a:ln>
-            <a:noFill/>
-          </a:ln>
-          <a:effectLst/>
-        </p:spPr>
-        <p:style>
-          <a:lnRef idx="1">
-            <a:schemeClr val="accent1"/>
-          </a:lnRef>
-          <a:fillRef idx="3">
-            <a:schemeClr val="accent1"/>
-          </a:fillRef>
-          <a:effectRef idx="2">
-            <a:schemeClr val="accent1"/>
-          </a:effectRef>
-          <a:fontRef idx="minor">
-            <a:schemeClr val="lt1"/>
-          </a:fontRef>
-        </p:style>
-        <p:txBody>
-          <a:bodyPr rtlCol="0" anchor="ctr"/>
-          <a:lstStyle/>
-          <a:p>
-            <a:pPr algn="ctr"/>
-          </a:p>
-        </p:txBody>
-      </p:sp>
-      <p:sp>
-        <p:nvSpPr>
-          <p:cNvPr id="4" name="TextBox 3"/>
-          <p:cNvSpPr txBox="1"/>
-          <p:nvPr/>
-        </p:nvSpPr>
-        <p:spPr>
-          <a:xfrm>
-            <a:off x="411480" y="1298448"/>
-            <a:ext cx="5806440" cy="274320"/>
-          </a:xfrm>
-          <a:prstGeom prst="rect">
-            <a:avLst/>
-          </a:prstGeom>
-          <a:noFill/>
-        </p:spPr>
-        <p:txBody>
-          <a:bodyPr wrap="square">
-            <a:spAutoFit/>
-          </a:bodyPr>
-          <a:lstStyle/>
-          <a:p>
-            <a:pPr>
-              <a:spcAft>
-                <a:spcPts val="600"/>
-              </a:spcAft>
-            </a:pPr>
-            <a:r>
-              <a:rPr sz="1200" b="0">
-                <a:solidFill>
-                  <a:srgbClr val="282828"/>
-                </a:solidFill>
-                <a:latin typeface="Arial"/>
-              </a:rPr>
-              <a:t>•  The primary segments into a pie or hex tiling with physical apertures; every segment gets rigid-body and surface-figure sensitivity channels, stacked into one Jacobian — the control basis.</a:t>
-            </a:r>
-          </a:p>
-          <a:p>
-            <a:pPr>
-              <a:spcAft>
-                <a:spcPts val="600"/>
-              </a:spcAft>
-            </a:pPr>
-            <a:r>
-              <a:rPr sz="1200" b="0">
-                <a:solidFill>
-                  <a:srgbClr val="282828"/>
-                </a:solidFill>
-                <a:latin typeface="Arial"/>
-              </a:rPr>
-              <a:t>•  Metrology is an optimization on that basis: edge-sensor and beam-launcher layouts scored by the control information they carry, not by symmetry; the winning pattern exports as a reusable preset.</a:t>
-            </a:r>
-          </a:p>
-        </p:txBody>
-      </p:sp>
-      <p:pic>
-        <p:nvPicPr>
-          <p:cNvPr id="5" name="Picture 4" descr="rowpair_s3_views_pie.png"/>
-          <p:cNvPicPr>
-            <a:picLocks noChangeAspect="1"/>
-          </p:cNvPicPr>
-          <p:nvPr/>
-        </p:nvPicPr>
-        <p:blipFill>
-          <a:blip r:embed="rId2"/>
-          <a:stretch>
-            <a:fillRect/>
-          </a:stretch>
-        </p:blipFill>
-        <p:spPr>
-          <a:xfrm>
-            <a:off x="6618167" y="1298448"/>
-            <a:ext cx="4960224" cy="1965451"/>
-          </a:xfrm>
-          <a:prstGeom prst="rect">
-            <a:avLst/>
-          </a:prstGeom>
-        </p:spPr>
-      </p:pic>
-      <p:sp>
-        <p:nvSpPr>
-          <p:cNvPr id="6" name="TextBox 5"/>
-          <p:cNvSpPr txBox="1"/>
-          <p:nvPr/>
-        </p:nvSpPr>
-        <p:spPr>
-          <a:xfrm>
-            <a:off x="6400800" y="3282188"/>
-            <a:ext cx="5394960" cy="229107"/>
-          </a:xfrm>
-          <a:prstGeom prst="rect">
-            <a:avLst/>
-          </a:prstGeom>
-          <a:noFill/>
-        </p:spPr>
-        <p:txBody>
-          <a:bodyPr wrap="square">
-            <a:spAutoFit/>
-          </a:bodyPr>
-          <a:lstStyle/>
-          <a:p>
-            <a:pPr algn="ctr">
-              <a:spcAft>
-                <a:spcPts val="0"/>
-              </a:spcAft>
-            </a:pPr>
-            <a:r>
-              <a:rPr sz="1000" b="0">
-                <a:solidFill>
-                  <a:srgbClr val="6E6E6E"/>
-                </a:solidFill>
-                <a:latin typeface="Arial"/>
-              </a:rPr>
-              <a:t>The segmented primary with physical apertures (front + iso views).</a:t>
-            </a:r>
-          </a:p>
-        </p:txBody>
-      </p:sp>
-      <p:pic>
-        <p:nvPicPr>
-          <p:cNvPr id="7" name="Picture 6" descr="e2e_pie_met_view_rx.png"/>
-          <p:cNvPicPr>
-            <a:picLocks noChangeAspect="1"/>
-          </p:cNvPicPr>
-          <p:nvPr/>
-        </p:nvPicPr>
-        <p:blipFill>
-          <a:blip r:embed="rId3"/>
-          <a:stretch>
-            <a:fillRect/>
-          </a:stretch>
-        </p:blipFill>
-        <p:spPr>
-          <a:xfrm>
-            <a:off x="7662896" y="3547872"/>
-            <a:ext cx="2870767" cy="1874011"/>
-          </a:xfrm>
-          <a:prstGeom prst="rect">
-            <a:avLst/>
-          </a:prstGeom>
-        </p:spPr>
-      </p:pic>
-      <p:sp>
-        <p:nvSpPr>
-          <p:cNvPr id="8" name="TextBox 7"/>
-          <p:cNvSpPr txBox="1"/>
-          <p:nvPr/>
-        </p:nvSpPr>
-        <p:spPr>
-          <a:xfrm>
-            <a:off x="6400800" y="5440171"/>
-            <a:ext cx="5394960" cy="229107"/>
-          </a:xfrm>
-          <a:prstGeom prst="rect">
-            <a:avLst/>
-          </a:prstGeom>
-          <a:noFill/>
-        </p:spPr>
-        <p:txBody>
-          <a:bodyPr wrap="square">
-            <a:spAutoFit/>
-          </a:bodyPr>
-          <a:lstStyle/>
-          <a:p>
-            <a:pPr algn="ctr">
-              <a:spcAft>
-                <a:spcPts val="0"/>
-              </a:spcAft>
-            </a:pPr>
-            <a:r>
-              <a:rPr sz="1000" b="0">
-                <a:solidFill>
-                  <a:srgbClr val="6E6E6E"/>
-                </a:solidFill>
-                <a:latin typeface="Arial"/>
-              </a:rPr>
-              <a:t>The optimized metrology layout on the segmented primary.</a:t>
-            </a:r>
-          </a:p>
-        </p:txBody>
-      </p:sp>
-      <p:sp>
-        <p:nvSpPr>
-          <p:cNvPr id="9" name="TextBox 8"/>
-          <p:cNvSpPr txBox="1"/>
-          <p:nvPr/>
-        </p:nvSpPr>
-        <p:spPr>
-          <a:xfrm>
-            <a:off x="6400800" y="5705855"/>
-            <a:ext cx="5394960" cy="274320"/>
-          </a:xfrm>
-          <a:prstGeom prst="rect">
-            <a:avLst/>
-          </a:prstGeom>
-          <a:noFill/>
-        </p:spPr>
-        <p:txBody>
-          <a:bodyPr wrap="square">
-            <a:spAutoFit/>
-          </a:bodyPr>
-          <a:lstStyle/>
-          <a:p>
-            <a:pPr>
-              <a:spcAft>
-                <a:spcPts val="600"/>
-              </a:spcAft>
-            </a:pPr>
-            <a:r>
-              <a:rPr sz="1050" b="0">
-                <a:solidFill>
-                  <a:srgbClr val="6E6E6E"/>
-                </a:solidFill>
-                <a:latin typeface="Arial"/>
-              </a:rPr>
-              <a:t>Record: templates/80_end_to_end/e2e, stages 3–5.</a:t>
+              <a:t>Record: templates/80_end_to_end/e2e, comparison + simulator stages (s6/s7).</a:t>
             </a:r>
           </a:p>
         </p:txBody>
@@ -15972,327 +15910,6 @@
                 <a:latin typeface="Arial"/>
               </a:rPr>
               <a:t>Counts as of 2026-08.  Every area is exercised by the committed test suites and by the worked examples beside it — the same templates this talk's studies live in.  Rebuild the figure: make_mmacos_fig.py.</a:t>
-            </a:r>
-          </a:p>
-        </p:txBody>
-      </p:sp>
-    </p:spTree>
-  </p:cSld>
-  <p:clrMapOvr>
-    <a:masterClrMapping/>
-  </p:clrMapOvr>
-</p:sld>
-</file>
-
-<file path=ppt/slides/slide40.xml><?xml version="1.0" encoding="utf-8"?>
-<p:sld xmlns:a="http://schemas.openxmlformats.org/drawingml/2006/main" xmlns:p="http://schemas.openxmlformats.org/presentationml/2006/main" xmlns:r="http://schemas.openxmlformats.org/officeDocument/2006/relationships">
-  <p:cSld>
-    <p:spTree>
-      <p:nvGrpSpPr>
-        <p:cNvPr id="1" name=""/>
-        <p:cNvGrpSpPr/>
-        <p:nvPr/>
-      </p:nvGrpSpPr>
-      <p:grpSpPr/>
-      <p:sp>
-        <p:nvSpPr>
-          <p:cNvPr id="2" name="TextBox 1"/>
-          <p:cNvSpPr txBox="1"/>
-          <p:nvPr/>
-        </p:nvSpPr>
-        <p:spPr>
-          <a:xfrm>
-            <a:off x="411480" y="201168"/>
-            <a:ext cx="11368735" cy="914400"/>
-          </a:xfrm>
-          <a:prstGeom prst="rect">
-            <a:avLst/>
-          </a:prstGeom>
-          <a:noFill/>
-        </p:spPr>
-        <p:txBody>
-          <a:bodyPr wrap="square">
-            <a:spAutoFit/>
-          </a:bodyPr>
-          <a:lstStyle/>
-          <a:p>
-            <a:pPr>
-              <a:spcAft>
-                <a:spcPts val="400"/>
-              </a:spcAft>
-            </a:pPr>
-            <a:r>
-              <a:rPr sz="2400" b="1">
-                <a:solidFill>
-                  <a:srgbClr val="1F4E79"/>
-                </a:solidFill>
-                <a:latin typeface="Arial"/>
-              </a:rPr>
-              <a:t>The e2e worked example: comparison and simulation</a:t>
-            </a:r>
-          </a:p>
-          <a:p>
-            <a:pPr>
-              <a:spcAft>
-                <a:spcPts val="0"/>
-              </a:spcAft>
-            </a:pPr>
-            <a:r>
-              <a:rPr sz="1250" b="0">
-                <a:solidFill>
-                  <a:srgbClr val="6E6E6E"/>
-                </a:solidFill>
-                <a:latin typeface="Arial"/>
-              </a:rPr>
-              <a:t>Segment drift of 10⁵ nm rms is sensed and held at ~7 nm corrected</a:t>
-            </a:r>
-          </a:p>
-        </p:txBody>
-      </p:sp>
-      <p:sp>
-        <p:nvSpPr>
-          <p:cNvPr id="3" name="Rectangle 2"/>
-          <p:cNvSpPr/>
-          <p:nvPr/>
-        </p:nvSpPr>
-        <p:spPr>
-          <a:xfrm>
-            <a:off x="411480" y="1133856"/>
-            <a:ext cx="11368735" cy="20320"/>
-          </a:xfrm>
-          <a:prstGeom prst="rect">
-            <a:avLst/>
-          </a:prstGeom>
-          <a:solidFill>
-            <a:srgbClr val="B8C6D4"/>
-          </a:solidFill>
-          <a:ln>
-            <a:noFill/>
-          </a:ln>
-          <a:effectLst/>
-        </p:spPr>
-        <p:style>
-          <a:lnRef idx="1">
-            <a:schemeClr val="accent1"/>
-          </a:lnRef>
-          <a:fillRef idx="3">
-            <a:schemeClr val="accent1"/>
-          </a:fillRef>
-          <a:effectRef idx="2">
-            <a:schemeClr val="accent1"/>
-          </a:effectRef>
-          <a:fontRef idx="minor">
-            <a:schemeClr val="lt1"/>
-          </a:fontRef>
-        </p:style>
-        <p:txBody>
-          <a:bodyPr rtlCol="0" anchor="ctr"/>
-          <a:lstStyle/>
-          <a:p>
-            <a:pPr algn="ctr"/>
-          </a:p>
-        </p:txBody>
-      </p:sp>
-      <p:sp>
-        <p:nvSpPr>
-          <p:cNvPr id="4" name="TextBox 3"/>
-          <p:cNvSpPr txBox="1"/>
-          <p:nvPr/>
-        </p:nvSpPr>
-        <p:spPr>
-          <a:xfrm>
-            <a:off x="411480" y="1298448"/>
-            <a:ext cx="11368735" cy="274320"/>
-          </a:xfrm>
-          <a:prstGeom prst="rect">
-            <a:avLst/>
-          </a:prstGeom>
-          <a:noFill/>
-        </p:spPr>
-        <p:txBody>
-          <a:bodyPr wrap="square">
-            <a:spAutoFit/>
-          </a:bodyPr>
-          <a:lstStyle/>
-          <a:p>
-            <a:pPr>
-              <a:spcAft>
-                <a:spcPts val="600"/>
-              </a:spcAft>
-            </a:pPr>
-            <a:r>
-              <a:rPr sz="1500" b="0">
-                <a:solidFill>
-                  <a:srgbClr val="282828"/>
-                </a:solidFill>
-                <a:latin typeface="Arial"/>
-              </a:rPr>
-              <a:t>•  Every linear model is checked against the engine before it is trusted: step each channel, re-trace, render engine and model side by side (left).  Then the simulator closes the loop on the same model: inject drift, sense with the designed metrology, estimate, correct (right).</a:t>
-            </a:r>
-          </a:p>
-        </p:txBody>
-      </p:sp>
-      <p:pic>
-        <p:nvPicPr>
-          <p:cNvPr id="5" name="Picture 4" descr="e2e_compare_p001.png"/>
-          <p:cNvPicPr>
-            <a:picLocks noChangeAspect="1"/>
-          </p:cNvPicPr>
-          <p:nvPr/>
-        </p:nvPicPr>
-        <p:blipFill>
-          <a:blip r:embed="rId2"/>
-          <a:stretch>
-            <a:fillRect/>
-          </a:stretch>
-        </p:blipFill>
-        <p:spPr>
-          <a:xfrm>
-            <a:off x="1466756" y="2218182"/>
-            <a:ext cx="3695887" cy="2714752"/>
-          </a:xfrm>
-          <a:prstGeom prst="rect">
-            <a:avLst/>
-          </a:prstGeom>
-        </p:spPr>
-      </p:pic>
-      <p:sp>
-        <p:nvSpPr>
-          <p:cNvPr id="6" name="TextBox 5"/>
-          <p:cNvSpPr txBox="1"/>
-          <p:nvPr/>
-        </p:nvSpPr>
-        <p:spPr>
-          <a:xfrm>
-            <a:off x="411480" y="4951222"/>
-            <a:ext cx="5806440" cy="394208"/>
-          </a:xfrm>
-          <a:prstGeom prst="rect">
-            <a:avLst/>
-          </a:prstGeom>
-          <a:noFill/>
-        </p:spPr>
-        <p:txBody>
-          <a:bodyPr wrap="square">
-            <a:spAutoFit/>
-          </a:bodyPr>
-          <a:lstStyle/>
-          <a:p>
-            <a:pPr algn="ctr">
-              <a:spcAft>
-                <a:spcPts val="0"/>
-              </a:spcAft>
-            </a:pPr>
-            <a:r>
-              <a:rPr sz="1000" b="0">
-                <a:solidFill>
-                  <a:srgbClr val="6E6E6E"/>
-                </a:solidFill>
-                <a:latin typeface="Arial"/>
-              </a:rPr>
-              <a:t>The comparison stage: engine re-trace vs linear model, one perturbation channel (segment 1 Rx, +100 nrad).</a:t>
-            </a:r>
-          </a:p>
-        </p:txBody>
-      </p:sp>
-      <p:pic>
-        <p:nvPicPr>
-          <p:cNvPr id="7" name="Picture 6" descr="e2e_sim_t007.png"/>
-          <p:cNvPicPr>
-            <a:picLocks noChangeAspect="1"/>
-          </p:cNvPicPr>
-          <p:nvPr/>
-        </p:nvPicPr>
-        <p:blipFill>
-          <a:blip r:embed="rId3"/>
-          <a:stretch>
-            <a:fillRect/>
-          </a:stretch>
-        </p:blipFill>
-        <p:spPr>
-          <a:xfrm>
-            <a:off x="6784520" y="2218182"/>
-            <a:ext cx="4627519" cy="2714752"/>
-          </a:xfrm>
-          <a:prstGeom prst="rect">
-            <a:avLst/>
-          </a:prstGeom>
-        </p:spPr>
-      </p:pic>
-      <p:sp>
-        <p:nvSpPr>
-          <p:cNvPr id="8" name="TextBox 7"/>
-          <p:cNvSpPr txBox="1"/>
-          <p:nvPr/>
-        </p:nvSpPr>
-        <p:spPr>
-          <a:xfrm>
-            <a:off x="6400800" y="4951222"/>
-            <a:ext cx="5394960" cy="394208"/>
-          </a:xfrm>
-          <a:prstGeom prst="rect">
-            <a:avLst/>
-          </a:prstGeom>
-          <a:noFill/>
-        </p:spPr>
-        <p:txBody>
-          <a:bodyPr wrap="square">
-            <a:spAutoFit/>
-          </a:bodyPr>
-          <a:lstStyle/>
-          <a:p>
-            <a:pPr algn="ctr">
-              <a:spcAft>
-                <a:spcPts val="0"/>
-              </a:spcAft>
-            </a:pPr>
-            <a:r>
-              <a:rPr sz="1000" b="0">
-                <a:solidFill>
-                  <a:srgbClr val="6E6E6E"/>
-                </a:solidFill>
-                <a:latin typeface="Arial"/>
-              </a:rPr>
-              <a:t>The simulator at t = 70 s: uncorrected 1.0×10⁵ nm vs 6.8 nm corrected; accumulating WFE and Strehl vs time below.</a:t>
-            </a:r>
-          </a:p>
-        </p:txBody>
-      </p:sp>
-      <p:sp>
-        <p:nvSpPr>
-          <p:cNvPr id="9" name="TextBox 8"/>
-          <p:cNvSpPr txBox="1"/>
-          <p:nvPr/>
-        </p:nvSpPr>
-        <p:spPr>
-          <a:xfrm>
-            <a:off x="6400800" y="5382006"/>
-            <a:ext cx="5394960" cy="274320"/>
-          </a:xfrm>
-          <a:prstGeom prst="rect">
-            <a:avLst/>
-          </a:prstGeom>
-          <a:noFill/>
-        </p:spPr>
-        <p:txBody>
-          <a:bodyPr wrap="square">
-            <a:spAutoFit/>
-          </a:bodyPr>
-          <a:lstStyle/>
-          <a:p>
-            <a:pPr>
-              <a:spcAft>
-                <a:spcPts val="600"/>
-              </a:spcAft>
-            </a:pPr>
-            <a:r>
-              <a:rPr sz="1050" b="0">
-                <a:solidFill>
-                  <a:srgbClr val="6E6E6E"/>
-                </a:solidFill>
-                <a:latin typeface="Arial"/>
-              </a:rPr>
-              <a:t>Record: templates/80_end_to_end/e2e, comparison + simulator stages (s6/s7).</a:t>
             </a:r>
           </a:p>
         </p:txBody>

</xml_diff>

<commit_message>
deck: public-code line on the title page; discussion pair made concise (question-led working-questions; agent-placement slide generalized, study-internal numerics cut, embedding shapes compressed)
Co-Authored-By: Claude Fable 5 <noreply@anthropic.com>
</commit_message>
<xml_diff>
--- a/demo_session/baseline_pass3.pptx
+++ b/demo_session/baseline_pass3.pptx
@@ -3192,6 +3192,22 @@
                 <a:latin typeface="Arial"/>
               </a:rPr>
               <a:t>D. C. Redding, with Claude Code — 1 September 2026.  Prepared for the Keysight CODE V team.  DRAFT — pending source sign-off.</a:t>
+            </a:r>
+          </a:p>
+          <a:p>
+            <a:pPr>
+              <a:spcAft>
+                <a:spcPts val="800"/>
+              </a:spcAft>
+            </a:pPr>
+            <a:r>
+              <a:rPr sz="1500" b="0">
+                <a:solidFill>
+                  <a:srgbClr val="6E6E6E"/>
+                </a:solidFill>
+                <a:latin typeface="Arial"/>
+              </a:rPr>
+              <a:t>The code is public: github.com/nasa-jpl/macos</a:t>
             </a:r>
           </a:p>
         </p:txBody>
@@ -11951,7 +11967,7 @@
                 </a:solidFill>
                 <a:latin typeface="Arial"/>
               </a:rPr>
-              <a:t>•  How is a result verified when the designer is a machine?  Here: regression checks with negative controls, layout figures read against every claim, and corrected signed measures — the checks caught the errors shown today.</a:t>
+              <a:t>•  How is a machine's result verified?  Regression checks with negative controls; layout renders read against every claim — the checks caught the errors shown today.</a:t>
             </a:r>
           </a:p>
           <a:p>
@@ -11967,7 +11983,7 @@
                 </a:solidFill>
                 <a:latin typeface="Arial"/>
               </a:rPr>
-              <a:t>•  Where does the human rule?  Constraint choices, metric definitions, and every outward claim carry a human sign-off; the AI proposes, the record decides.</a:t>
+              <a:t>•  Where does the human rule?  Constraints, metrics, and every outward claim — the AI proposes, the record decides.</a:t>
             </a:r>
           </a:p>
           <a:p>
@@ -11996,7 +12012,7 @@
         </p:nvSpPr>
         <p:spPr>
           <a:xfrm>
-            <a:off x="411480" y="3241547"/>
+            <a:off x="411480" y="2993898"/>
             <a:ext cx="11368735" cy="274320"/>
           </a:xfrm>
           <a:prstGeom prst="rect">
@@ -12022,7 +12038,7 @@
                 </a:solidFill>
                 <a:latin typeface="Arial"/>
               </a:rPr>
-              <a:t>These are offered as discussion questions, not settled doctrine.</a:t>
+              <a:t>Offered as discussion questions, not settled doctrine — the next slide takes one of them to architecture.</a:t>
             </a:r>
           </a:p>
         </p:txBody>
@@ -12422,7 +12438,7 @@
                 </a:solidFill>
                 <a:latin typeface="Arial"/>
               </a:rPr>
-              <a:t>•  A · Run the compiled tool, no agent — what ships today.  The walk ran unattended on a fresh instance; the checks, caps, and continuation runner are versioned and regression-tested.  Inspectable and maintenance-stable — but 1 of 15 frictions did not compile, and the docs alone did not carry a cold user.</a:t>
+              <a:t>•  A · The compiled tool, no agent — what ships: versioned, regression-tested, inspectable, and it runs unattended.  But measured on a cold user, the docs alone did not carry them.</a:t>
             </a:r>
           </a:p>
           <a:p>
@@ -12438,7 +12454,7 @@
                 </a:solidFill>
                 <a:latin typeface="Arial"/>
               </a:rPr>
-              <a:t>•  B · Invoke an agent to guide the work — what this study actually did.  An AI agent in the loop, under expert prompting, found and fixed every conceptual defect in hours and chose the strategies worth compiling — including the walk.  Available to any user now; its knowledge is current, but not versioned with the tool.</a:t>
+              <a:t>•  B · An agent alongside the tool — what these studies did: it found and fixed the conceptual defects in hours and chose what was worth compiling.  Its knowledge is current — but not versioned with the tool.</a:t>
             </a:r>
           </a:p>
           <a:p>
@@ -12454,7 +12470,7 @@
                 </a:solidFill>
                 <a:latin typeface="Arial"/>
               </a:rPr>
-              <a:t>•  C · Embed a helper in the tool — the open question: advice at call time — "your step 1 runs 8× deeper than the reference; expect the offset box to lose rays" — the one failure that was documented and still fatal.</a:t>
+              <a:t>•  C · A helper embedded in the tool — the open question: advice at the moment of use, catching the failure class that was documented and still fatal.</a:t>
             </a:r>
           </a:p>
           <a:p>
@@ -12470,71 +12486,23 @@
                 </a:solidFill>
                 <a:latin typeface="Arial"/>
               </a:rPr>
-              <a:t>•  How embedding could work — three shapes in increasing order of authority:</a:t>
-            </a:r>
-          </a:p>
-          <a:p>
-            <a:pPr marL="594360" indent="-137160">
-              <a:spcAft>
-                <a:spcPts val="500"/>
-              </a:spcAft>
-            </a:pPr>
-            <a:r>
-              <a:rPr sz="1300" b="0">
-                <a:solidFill>
-                  <a:srgbClr val="6E6E6E"/>
-                </a:solidFill>
-                <a:latin typeface="Arial"/>
-              </a:rPr>
-              <a:t>–  Make the tool agent-readable (lightest): expose the tool's state as structured output — deck, residual history, check results — with machine-readable docs and runnable checks, so the user's own assistant drives the tool well.  The tool's knowledge stays in the code and its tests.</a:t>
-            </a:r>
-          </a:p>
-          <a:p>
-            <a:pPr marL="594360" indent="-137160">
-              <a:spcAft>
-                <a:spcPts val="500"/>
-              </a:spcAft>
-            </a:pPr>
-            <a:r>
-              <a:rPr sz="1300" b="0">
-                <a:solidFill>
-                  <a:srgbClr val="6E6E6E"/>
-                </a:solidFill>
-                <a:latin typeface="Arial"/>
-              </a:rPr>
-              <a:t>–  A failure-triage assistant: invoked only when a check fires or a solve stalls; it reads the saved state and returns a one-line diagnosis and a suggested next command, which the person runs.</a:t>
-            </a:r>
-          </a:p>
-          <a:p>
-            <a:pPr marL="594360" indent="-137160">
-              <a:spcAft>
-                <a:spcPts val="500"/>
-              </a:spcAft>
-            </a:pPr>
-            <a:r>
-              <a:rPr sz="1300" b="0">
-                <a:solidFill>
-                  <a:srgbClr val="6E6E6E"/>
-                </a:solidFill>
-                <a:latin typeface="Arial"/>
-              </a:rPr>
-              <a:t>–  A policy assistant inside hard limits: it chooses solve-field counts, penalty targets, and walk schedules between stages; the code enforces the limits, validates every action through the same checks, and logs every choice for replay.</a:t>
-            </a:r>
-          </a:p>
-          <a:p>
-            <a:pPr marL="594360" indent="-137160">
-              <a:spcAft>
-                <a:spcPts val="500"/>
-              </a:spcAft>
-            </a:pPr>
-            <a:r>
-              <a:rPr sz="1300" b="0">
-                <a:solidFill>
-                  <a:srgbClr val="6E6E6E"/>
-                </a:solidFill>
-                <a:latin typeface="Arial"/>
-              </a:rPr>
-              <a:t>–  Tier the agents, at any of these levels — an orchestrating agent plans and delegates; each sub-agent gets one bounded task with only the files it needs; the committed records, not any agent's memory, are the shared memory.</a:t>
+              <a:t>•  Shapes for C, in increasing authority:  agent-readable state (the user's own assistant drives the tool); a failure-triage assistant (fires on a failed check, returns a diagnosis and a next command); a policy assistant inside hard limits (chooses schedules and targets; the code enforces limits and logs every choice).</a:t>
+            </a:r>
+          </a:p>
+          <a:p>
+            <a:pPr>
+              <a:spcAft>
+                <a:spcPts val="600"/>
+              </a:spcAft>
+            </a:pPr>
+            <a:r>
+              <a:rPr sz="1500" b="0">
+                <a:solidFill>
+                  <a:srgbClr val="282828"/>
+                </a:solidFill>
+                <a:latin typeface="Arial"/>
+              </a:rPr>
+              <a:t>•  At any level, tier the agents: an orchestrator plans and delegates bounded tasks; the committed records — not any agent's memory — are the shared memory.</a:t>
             </a:r>
           </a:p>
         </p:txBody>
@@ -12547,7 +12515,7 @@
         </p:nvSpPr>
         <p:spPr>
           <a:xfrm>
-            <a:off x="411480" y="6566408"/>
+            <a:off x="411480" y="4760214"/>
             <a:ext cx="11368735" cy="274320"/>
           </a:xfrm>
           <a:prstGeom prst="rect">
@@ -12573,7 +12541,7 @@
                 </a:solidFill>
                 <a:latin typeface="Arial"/>
               </a:rPr>
-              <a:t>Where is the line between knowledge in the code as checks and knowledge served as advice?  A stale check fails loudly; stale advice fails silently.  Measured: the tool alone did not carry a new user; an agent alongside it closed every gap — most of what it learned is now checks and defaults.</a:t>
+              <a:t>A stale check fails loudly; stale advice fails silently.  Measured: the tool alone did not carry a new user; an agent alongside it closed every gap — and most of what it learned is now in the tool, as checks and defaults.</a:t>
             </a:r>
           </a:p>
         </p:txBody>

</xml_diff>

<commit_message>
deck: closing slide -- 'If you asked us: AI around CODE V and LightTools' (five measured recommendations; Dave 2026-08-31)
Co-Authored-By: Claude Fable 5 <noreply@anthropic.com>
</commit_message>
<xml_diff>
--- a/demo_session/baseline_pass3.pptx
+++ b/demo_session/baseline_pass3.pptx
@@ -43,6 +43,7 @@
     <p:sldId id="291" r:id="rId42"/>
     <p:sldId id="292" r:id="rId43"/>
     <p:sldId id="293" r:id="rId44"/>
+    <p:sldId id="294" r:id="rId45"/>
   </p:sldIdLst>
   <p:sldSz cx="12191695" cy="6858000" type="screen4x3"/>
   <p:notesSz cx="6858000" cy="9144000"/>
@@ -12598,7 +12599,23 @@
                 </a:solidFill>
                 <a:latin typeface="Arial"/>
               </a:rPr>
-              <a:t>Backup Slides</a:t>
+              <a:t>If you asked us: AI around CODE V and LightTools</a:t>
+            </a:r>
+          </a:p>
+          <a:p>
+            <a:pPr>
+              <a:spcAft>
+                <a:spcPts val="0"/>
+              </a:spcAft>
+            </a:pPr>
+            <a:r>
+              <a:rPr sz="1250" b="0">
+                <a:solidFill>
+                  <a:srgbClr val="6E6E6E"/>
+                </a:solidFill>
+                <a:latin typeface="Arial"/>
+              </a:rPr>
+              <a:t>Add it around the optics, not in them — every claim below is measured, not speculative</a:t>
             </a:r>
           </a:p>
         </p:txBody>
@@ -12611,7 +12628,7 @@
         </p:nvSpPr>
         <p:spPr>
           <a:xfrm>
-            <a:off x="411480" y="914400"/>
+            <a:off x="411480" y="1133856"/>
             <a:ext cx="11368735" cy="20320"/>
           </a:xfrm>
           <a:prstGeom prst="rect">
@@ -12647,6 +12664,148 @@
           </a:p>
         </p:txBody>
       </p:sp>
+      <p:sp>
+        <p:nvSpPr>
+          <p:cNvPr id="4" name="TextBox 3"/>
+          <p:cNvSpPr txBox="1"/>
+          <p:nvPr/>
+        </p:nvSpPr>
+        <p:spPr>
+          <a:xfrm>
+            <a:off x="411480" y="1298448"/>
+            <a:ext cx="11368735" cy="274320"/>
+          </a:xfrm>
+          <a:prstGeom prst="rect">
+            <a:avLst/>
+          </a:prstGeom>
+          <a:noFill/>
+        </p:spPr>
+        <p:txBody>
+          <a:bodyPr wrap="square">
+            <a:spAutoFit/>
+          </a:bodyPr>
+          <a:lstStyle/>
+          <a:p>
+            <a:pPr>
+              <a:spcAft>
+                <a:spcPts val="600"/>
+              </a:spcAft>
+            </a:pPr>
+            <a:r>
+              <a:rPr sz="1500" b="0">
+                <a:solidFill>
+                  <a:srgbClr val="282828"/>
+                </a:solidFill>
+                <a:latin typeface="Arial"/>
+              </a:rPr>
+              <a:t>•  Make the tools agent-readable first — state, results, warnings and docs as structured data through the existing macro/API surface.  Every user's assistant then attaches today, and the vendor ships no intelligence at all.  This whole talk ran in that mode.</a:t>
+            </a:r>
+          </a:p>
+          <a:p>
+            <a:pPr>
+              <a:spcAft>
+                <a:spcPts val="600"/>
+              </a:spcAft>
+            </a:pPr>
+            <a:r>
+              <a:rPr sz="1500" b="0">
+                <a:solidFill>
+                  <a:srgbClr val="282828"/>
+                </a:solidFill>
+                <a:latin typeface="Arial"/>
+              </a:rPr>
+              <a:t>•  Ship the conventions as data.  The largest defect class our agent found was conventions — the sign of a radius, DAR versus a coordinate break, which reference sphere a number is quoted against.  Make them queryable and the dominant error source disappears for humans and agents alike.</a:t>
+            </a:r>
+          </a:p>
+          <a:p>
+            <a:pPr>
+              <a:spcAft>
+                <a:spcPts val="600"/>
+              </a:spcAft>
+            </a:pPr>
+            <a:r>
+              <a:rPr sz="1500" b="0">
+                <a:solidFill>
+                  <a:srgbClr val="282828"/>
+                </a:solidFill>
+                <a:latin typeface="Arial"/>
+              </a:rPr>
+              <a:t>•  Embed a failure-triage assistant first — it wakes on a failed trace or a stalled solve, reads the saved state, and returns one line of diagnosis plus a next command the person runs.  Our stalled solve was a finite-difference step reading the gradient 17% low: a one-line answer sitting in state the tool already had.</a:t>
+            </a:r>
+          </a:p>
+          <a:p>
+            <a:pPr>
+              <a:spcAft>
+                <a:spcPts val="600"/>
+              </a:spcAft>
+            </a:pPr>
+            <a:r>
+              <a:rPr sz="1500" b="0">
+                <a:solidFill>
+                  <a:srgbClr val="282828"/>
+                </a:solidFill>
+                <a:latin typeface="Arial"/>
+              </a:rPr>
+              <a:t>•  Put the agent in the search, never the numerics — starting points and basins (a warm-started walk beat the cold start 8500×); variable-set audits (35% of a metric unclaimed because one freedom was never offered); optimization schedules (a restart ladder opened decades of dark-hole floor overnight); tolerancing and glass searches.  The agent proposes; the trusted engine disposes.</a:t>
+            </a:r>
+          </a:p>
+          <a:p>
+            <a:pPr>
+              <a:spcAft>
+                <a:spcPts val="600"/>
+              </a:spcAft>
+            </a:pPr>
+            <a:r>
+              <a:rPr sz="1500" b="0">
+                <a:solidFill>
+                  <a:srgbClr val="282828"/>
+                </a:solidFill>
+                <a:latin typeface="Arial"/>
+              </a:rPr>
+              <a:t>•  Ship the trust machinery with it: every AI action a readable, replayable script — never an opaque state mutation; every proposal a before/after check with negative controls; the assistant's knowledge versioned with the release.</a:t>
+            </a:r>
+          </a:p>
+        </p:txBody>
+      </p:sp>
+      <p:sp>
+        <p:nvSpPr>
+          <p:cNvPr id="5" name="TextBox 4"/>
+          <p:cNvSpPr txBox="1"/>
+          <p:nvPr/>
+        </p:nvSpPr>
+        <p:spPr>
+          <a:xfrm>
+            <a:off x="411480" y="5750814"/>
+            <a:ext cx="11368735" cy="274320"/>
+          </a:xfrm>
+          <a:prstGeom prst="rect">
+            <a:avLst/>
+          </a:prstGeom>
+          <a:noFill/>
+        </p:spPr>
+        <p:txBody>
+          <a:bodyPr wrap="square">
+            <a:spAutoFit/>
+          </a:bodyPr>
+          <a:lstStyle/>
+          <a:p>
+            <a:pPr>
+              <a:spcAft>
+                <a:spcPts val="600"/>
+              </a:spcAft>
+            </a:pPr>
+            <a:r>
+              <a:rPr sz="1050" b="0">
+                <a:solidFill>
+                  <a:srgbClr val="6E6E6E"/>
+                </a:solidFill>
+                <a:latin typeface="Arial"/>
+              </a:rPr>
+              <a:t>A stale check fails loudly; stale advice fails silently — and the best advice ends up compiled into the tool, as checks and defaults.</a:t>
+            </a:r>
+          </a:p>
+        </p:txBody>
+      </p:sp>
     </p:spTree>
   </p:cSld>
   <p:clrMapOvr>
@@ -12656,6 +12815,107 @@
 </file>
 
 <file path=ppt/slides/slide32.xml><?xml version="1.0" encoding="utf-8"?>
+<p:sld xmlns:a="http://schemas.openxmlformats.org/drawingml/2006/main" xmlns:p="http://schemas.openxmlformats.org/presentationml/2006/main" xmlns:r="http://schemas.openxmlformats.org/officeDocument/2006/relationships">
+  <p:cSld>
+    <p:spTree>
+      <p:nvGrpSpPr>
+        <p:cNvPr id="1" name=""/>
+        <p:cNvGrpSpPr/>
+        <p:nvPr/>
+      </p:nvGrpSpPr>
+      <p:grpSpPr/>
+      <p:sp>
+        <p:nvSpPr>
+          <p:cNvPr id="2" name="TextBox 1"/>
+          <p:cNvSpPr txBox="1"/>
+          <p:nvPr/>
+        </p:nvSpPr>
+        <p:spPr>
+          <a:xfrm>
+            <a:off x="411480" y="201168"/>
+            <a:ext cx="11368735" cy="914400"/>
+          </a:xfrm>
+          <a:prstGeom prst="rect">
+            <a:avLst/>
+          </a:prstGeom>
+          <a:noFill/>
+        </p:spPr>
+        <p:txBody>
+          <a:bodyPr wrap="square">
+            <a:spAutoFit/>
+          </a:bodyPr>
+          <a:lstStyle/>
+          <a:p>
+            <a:pPr>
+              <a:spcAft>
+                <a:spcPts val="400"/>
+              </a:spcAft>
+            </a:pPr>
+            <a:r>
+              <a:rPr sz="2400" b="1">
+                <a:solidFill>
+                  <a:srgbClr val="1F4E79"/>
+                </a:solidFill>
+                <a:latin typeface="Arial"/>
+              </a:rPr>
+              <a:t>Backup Slides</a:t>
+            </a:r>
+          </a:p>
+        </p:txBody>
+      </p:sp>
+      <p:sp>
+        <p:nvSpPr>
+          <p:cNvPr id="3" name="Rectangle 2"/>
+          <p:cNvSpPr/>
+          <p:nvPr/>
+        </p:nvSpPr>
+        <p:spPr>
+          <a:xfrm>
+            <a:off x="411480" y="914400"/>
+            <a:ext cx="11368735" cy="20320"/>
+          </a:xfrm>
+          <a:prstGeom prst="rect">
+            <a:avLst/>
+          </a:prstGeom>
+          <a:solidFill>
+            <a:srgbClr val="B8C6D4"/>
+          </a:solidFill>
+          <a:ln>
+            <a:noFill/>
+          </a:ln>
+          <a:effectLst/>
+        </p:spPr>
+        <p:style>
+          <a:lnRef idx="1">
+            <a:schemeClr val="accent1"/>
+          </a:lnRef>
+          <a:fillRef idx="3">
+            <a:schemeClr val="accent1"/>
+          </a:fillRef>
+          <a:effectRef idx="2">
+            <a:schemeClr val="accent1"/>
+          </a:effectRef>
+          <a:fontRef idx="minor">
+            <a:schemeClr val="lt1"/>
+          </a:fontRef>
+        </p:style>
+        <p:txBody>
+          <a:bodyPr rtlCol="0" anchor="ctr"/>
+          <a:lstStyle/>
+          <a:p>
+            <a:pPr algn="ctr"/>
+          </a:p>
+        </p:txBody>
+      </p:sp>
+    </p:spTree>
+  </p:cSld>
+  <p:clrMapOvr>
+    <a:masterClrMapping/>
+  </p:clrMapOvr>
+</p:sld>
+</file>
+
+<file path=ppt/slides/slide33.xml><?xml version="1.0" encoding="utf-8"?>
 <p:sld xmlns:a="http://schemas.openxmlformats.org/drawingml/2006/main" xmlns:p="http://schemas.openxmlformats.org/presentationml/2006/main" xmlns:r="http://schemas.openxmlformats.org/officeDocument/2006/relationships">
   <p:cSld>
     <p:spTree>
@@ -13285,7 +13545,7 @@
 </p:sld>
 </file>
 
-<file path=ppt/slides/slide33.xml><?xml version="1.0" encoding="utf-8"?>
+<file path=ppt/slides/slide34.xml><?xml version="1.0" encoding="utf-8"?>
 <p:sld xmlns:a="http://schemas.openxmlformats.org/drawingml/2006/main" xmlns:p="http://schemas.openxmlformats.org/presentationml/2006/main" xmlns:r="http://schemas.openxmlformats.org/officeDocument/2006/relationships">
   <p:cSld>
     <p:spTree>
@@ -14151,7 +14411,7 @@
 </p:sld>
 </file>
 
-<file path=ppt/slides/slide34.xml><?xml version="1.0" encoding="utf-8"?>
+<file path=ppt/slides/slide35.xml><?xml version="1.0" encoding="utf-8"?>
 <p:sld xmlns:a="http://schemas.openxmlformats.org/drawingml/2006/main" xmlns:p="http://schemas.openxmlformats.org/presentationml/2006/main" xmlns:r="http://schemas.openxmlformats.org/officeDocument/2006/relationships">
   <p:cSld>
     <p:spTree>
@@ -14358,351 +14618,6 @@
                 <a:latin typeface="Arial"/>
               </a:rPr>
               <a:t>Committed: deepest optic 1.887 m = 1.81× the spacing, the feed beam through the collimator by −79.9 mm.  Four-flat recipe: 0.893 m deep, but a fold is an isometry — the interference rides across — and it does not close on the cleared deck (96 routes, every admissible one loses rays).  Cleared −10°: 1.287 m = 1.24×, zero flats, +37.8 mm of daylight.  Record: challenges/afocal4/{packaging,clearing}.</a:t>
-            </a:r>
-          </a:p>
-        </p:txBody>
-      </p:sp>
-    </p:spTree>
-  </p:cSld>
-  <p:clrMapOvr>
-    <a:masterClrMapping/>
-  </p:clrMapOvr>
-</p:sld>
-</file>
-
-<file path=ppt/slides/slide35.xml><?xml version="1.0" encoding="utf-8"?>
-<p:sld xmlns:a="http://schemas.openxmlformats.org/drawingml/2006/main" xmlns:p="http://schemas.openxmlformats.org/presentationml/2006/main" xmlns:r="http://schemas.openxmlformats.org/officeDocument/2006/relationships">
-  <p:cSld>
-    <p:spTree>
-      <p:nvGrpSpPr>
-        <p:cNvPr id="1" name=""/>
-        <p:cNvGrpSpPr/>
-        <p:nvPr/>
-      </p:nvGrpSpPr>
-      <p:grpSpPr/>
-      <p:sp>
-        <p:nvSpPr>
-          <p:cNvPr id="2" name="TextBox 1"/>
-          <p:cNvSpPr txBox="1"/>
-          <p:nvPr/>
-        </p:nvSpPr>
-        <p:spPr>
-          <a:xfrm>
-            <a:off x="411480" y="201168"/>
-            <a:ext cx="11368735" cy="914400"/>
-          </a:xfrm>
-          <a:prstGeom prst="rect">
-            <a:avLst/>
-          </a:prstGeom>
-          <a:noFill/>
-        </p:spPr>
-        <p:txBody>
-          <a:bodyPr wrap="square">
-            <a:spAutoFit/>
-          </a:bodyPr>
-          <a:lstStyle/>
-          <a:p>
-            <a:pPr>
-              <a:spcAft>
-                <a:spcPts val="400"/>
-              </a:spcAft>
-            </a:pPr>
-            <a:r>
-              <a:rPr sz="2400" b="1">
-                <a:solidFill>
-                  <a:srgbClr val="1F4E79"/>
-                </a:solidFill>
-                <a:latin typeface="Arial"/>
-              </a:rPr>
-              <a:t>Interferometer demonstration backups</a:t>
-            </a:r>
-          </a:p>
-          <a:p>
-            <a:pPr>
-              <a:spcAft>
-                <a:spcPts val="0"/>
-              </a:spcAft>
-            </a:pPr>
-            <a:r>
-              <a:rPr sz="1250" b="0">
-                <a:solidFill>
-                  <a:srgbClr val="6E6E6E"/>
-                </a:solidFill>
-                <a:latin typeface="Arial"/>
-              </a:rPr>
-              <a:t>One committed image per live beat</a:t>
-            </a:r>
-          </a:p>
-        </p:txBody>
-      </p:sp>
-      <p:sp>
-        <p:nvSpPr>
-          <p:cNvPr id="3" name="Rectangle 2"/>
-          <p:cNvSpPr/>
-          <p:nvPr/>
-        </p:nvSpPr>
-        <p:spPr>
-          <a:xfrm>
-            <a:off x="411480" y="1133856"/>
-            <a:ext cx="11368735" cy="20320"/>
-          </a:xfrm>
-          <a:prstGeom prst="rect">
-            <a:avLst/>
-          </a:prstGeom>
-          <a:solidFill>
-            <a:srgbClr val="B8C6D4"/>
-          </a:solidFill>
-          <a:ln>
-            <a:noFill/>
-          </a:ln>
-          <a:effectLst/>
-        </p:spPr>
-        <p:style>
-          <a:lnRef idx="1">
-            <a:schemeClr val="accent1"/>
-          </a:lnRef>
-          <a:fillRef idx="3">
-            <a:schemeClr val="accent1"/>
-          </a:fillRef>
-          <a:effectRef idx="2">
-            <a:schemeClr val="accent1"/>
-          </a:effectRef>
-          <a:fontRef idx="minor">
-            <a:schemeClr val="lt1"/>
-          </a:fontRef>
-        </p:style>
-        <p:txBody>
-          <a:bodyPr rtlCol="0" anchor="ctr"/>
-          <a:lstStyle/>
-          <a:p>
-            <a:pPr algn="ctr"/>
-          </a:p>
-        </p:txBody>
-      </p:sp>
-      <p:pic>
-        <p:nvPicPr>
-          <p:cNvPr id="4" name="Picture 3" descr="demo2_beat5_poke.png"/>
-          <p:cNvPicPr>
-            <a:picLocks noChangeAspect="1"/>
-          </p:cNvPicPr>
-          <p:nvPr/>
-        </p:nvPicPr>
-        <p:blipFill>
-          <a:blip r:embed="rId2"/>
-          <a:stretch>
-            <a:fillRect/>
-          </a:stretch>
-        </p:blipFill>
-        <p:spPr>
-          <a:xfrm>
-            <a:off x="3772370" y="1298448"/>
-            <a:ext cx="4646955" cy="1782572"/>
-          </a:xfrm>
-          <a:prstGeom prst="rect">
-            <a:avLst/>
-          </a:prstGeom>
-        </p:spPr>
-      </p:pic>
-      <p:sp>
-        <p:nvSpPr>
-          <p:cNvPr id="5" name="TextBox 4"/>
-          <p:cNvSpPr txBox="1"/>
-          <p:nvPr/>
-        </p:nvSpPr>
-        <p:spPr>
-          <a:xfrm>
-            <a:off x="411480" y="3099308"/>
-            <a:ext cx="11368735" cy="229107"/>
-          </a:xfrm>
-          <a:prstGeom prst="rect">
-            <a:avLst/>
-          </a:prstGeom>
-          <a:noFill/>
-        </p:spPr>
-        <p:txBody>
-          <a:bodyPr wrap="square">
-            <a:spAutoFit/>
-          </a:bodyPr>
-          <a:lstStyle/>
-          <a:p>
-            <a:pPr algn="ctr">
-              <a:spcAft>
-                <a:spcPts val="0"/>
-              </a:spcAft>
-            </a:pPr>
-            <a:r>
-              <a:rPr sz="1000" b="0">
-                <a:solidFill>
-                  <a:srgbClr val="6E6E6E"/>
-                </a:solidFill>
-                <a:latin typeface="Arial"/>
-              </a:rPr>
-              <a:t>Beat 5 — one actuator poked: the fringes bend over it.</a:t>
-            </a:r>
-          </a:p>
-        </p:txBody>
-      </p:sp>
-      <p:pic>
-        <p:nvPicPr>
-          <p:cNvPr id="6" name="Picture 5" descr="demo2_beat6_sweep.png"/>
-          <p:cNvPicPr>
-            <a:picLocks noChangeAspect="1"/>
-          </p:cNvPicPr>
-          <p:nvPr/>
-        </p:nvPicPr>
-        <p:blipFill>
-          <a:blip r:embed="rId3"/>
-          <a:stretch>
-            <a:fillRect/>
-          </a:stretch>
-        </p:blipFill>
-        <p:spPr>
-          <a:xfrm>
-            <a:off x="4186821" y="3364992"/>
-            <a:ext cx="3818051" cy="1782572"/>
-          </a:xfrm>
-          <a:prstGeom prst="rect">
-            <a:avLst/>
-          </a:prstGeom>
-        </p:spPr>
-      </p:pic>
-      <p:sp>
-        <p:nvSpPr>
-          <p:cNvPr id="7" name="TextBox 6"/>
-          <p:cNvSpPr txBox="1"/>
-          <p:nvPr/>
-        </p:nvSpPr>
-        <p:spPr>
-          <a:xfrm>
-            <a:off x="411480" y="5165852"/>
-            <a:ext cx="11368735" cy="229107"/>
-          </a:xfrm>
-          <a:prstGeom prst="rect">
-            <a:avLst/>
-          </a:prstGeom>
-          <a:noFill/>
-        </p:spPr>
-        <p:txBody>
-          <a:bodyPr wrap="square">
-            <a:spAutoFit/>
-          </a:bodyPr>
-          <a:lstStyle/>
-          <a:p>
-            <a:pPr algn="ctr">
-              <a:spcAft>
-                <a:spcPts val="0"/>
-              </a:spcAft>
-            </a:pPr>
-            <a:r>
-              <a:rPr sz="1000" b="0">
-                <a:solidFill>
-                  <a:srgbClr val="6E6E6E"/>
-                </a:solidFill>
-                <a:latin typeface="Arial"/>
-              </a:rPr>
-              <a:t>Beat 6 — the analyzer sweep: phase-stepped frames, no re-trace.</a:t>
-            </a:r>
-          </a:p>
-        </p:txBody>
-      </p:sp>
-      <p:pic>
-        <p:nvPicPr>
-          <p:cNvPr id="8" name="Picture 7" descr="demo2_beat7_recovery.png"/>
-          <p:cNvPicPr>
-            <a:picLocks noChangeAspect="1"/>
-          </p:cNvPicPr>
-          <p:nvPr/>
-        </p:nvPicPr>
-        <p:blipFill>
-          <a:blip r:embed="rId4"/>
-          <a:stretch>
-            <a:fillRect/>
-          </a:stretch>
-        </p:blipFill>
-        <p:spPr>
-          <a:xfrm>
-            <a:off x="4177857" y="5431536"/>
-            <a:ext cx="3835980" cy="1032763"/>
-          </a:xfrm>
-          <a:prstGeom prst="rect">
-            <a:avLst/>
-          </a:prstGeom>
-        </p:spPr>
-      </p:pic>
-      <p:sp>
-        <p:nvSpPr>
-          <p:cNvPr id="9" name="TextBox 8"/>
-          <p:cNvSpPr txBox="1"/>
-          <p:nvPr/>
-        </p:nvSpPr>
-        <p:spPr>
-          <a:xfrm>
-            <a:off x="411480" y="6482588"/>
-            <a:ext cx="11368735" cy="229107"/>
-          </a:xfrm>
-          <a:prstGeom prst="rect">
-            <a:avLst/>
-          </a:prstGeom>
-          <a:noFill/>
-        </p:spPr>
-        <p:txBody>
-          <a:bodyPr wrap="square">
-            <a:spAutoFit/>
-          </a:bodyPr>
-          <a:lstStyle/>
-          <a:p>
-            <a:pPr algn="ctr">
-              <a:spcAft>
-                <a:spcPts val="0"/>
-              </a:spcAft>
-            </a:pPr>
-            <a:r>
-              <a:rPr sz="1000" b="0">
-                <a:solidFill>
-                  <a:srgbClr val="6E6E6E"/>
-                </a:solidFill>
-                <a:latin typeface="Arial"/>
-              </a:rPr>
-              <a:t>Beat 7 — the recovery beside the truth map.</a:t>
-            </a:r>
-          </a:p>
-        </p:txBody>
-      </p:sp>
-      <p:sp>
-        <p:nvSpPr>
-          <p:cNvPr id="10" name="TextBox 9"/>
-          <p:cNvSpPr txBox="1"/>
-          <p:nvPr/>
-        </p:nvSpPr>
-        <p:spPr>
-          <a:xfrm>
-            <a:off x="411480" y="6748272"/>
-            <a:ext cx="11368735" cy="274320"/>
-          </a:xfrm>
-          <a:prstGeom prst="rect">
-            <a:avLst/>
-          </a:prstGeom>
-          <a:noFill/>
-        </p:spPr>
-        <p:txBody>
-          <a:bodyPr wrap="square">
-            <a:spAutoFit/>
-          </a:bodyPr>
-          <a:lstStyle/>
-          <a:p>
-            <a:pPr>
-              <a:spcAft>
-                <a:spcPts val="600"/>
-              </a:spcAft>
-            </a:pPr>
-            <a:r>
-              <a:rPr sz="1050" b="0">
-                <a:solidFill>
-                  <a:srgbClr val="6E6E6E"/>
-                </a:solidFill>
-                <a:latin typeface="Arial"/>
-              </a:rPr>
-              <a:t>All eight beats have committed figures in templates/90_polarization/tg_psi_dm_v2 (v1 likewise); the driver opens them on the desktop as each beat runs.</a:t>
             </a:r>
           </a:p>
         </p:txBody>
@@ -14759,7 +14674,7 @@
                 </a:solidFill>
                 <a:latin typeface="Arial"/>
               </a:rPr>
-              <a:t>The e2e worked example: specification to design</a:t>
+              <a:t>Interferometer demonstration backups</a:t>
             </a:r>
           </a:p>
           <a:p>
@@ -14775,7 +14690,7 @@
                 </a:solidFill>
                 <a:latin typeface="Arial"/>
               </a:rPr>
-              <a:t>A 4 m f/18 visible-band telescope from a closed-form seed — no starting prescription</a:t>
+              <a:t>One committed image per live beat</a:t>
             </a:r>
           </a:p>
         </p:txBody>
@@ -14824,64 +14739,9 @@
           </a:p>
         </p:txBody>
       </p:sp>
-      <p:sp>
-        <p:nvSpPr>
-          <p:cNvPr id="4" name="TextBox 3"/>
-          <p:cNvSpPr txBox="1"/>
-          <p:nvPr/>
-        </p:nvSpPr>
-        <p:spPr>
-          <a:xfrm>
-            <a:off x="411480" y="1298448"/>
-            <a:ext cx="5806440" cy="274320"/>
-          </a:xfrm>
-          <a:prstGeom prst="rect">
-            <a:avLst/>
-          </a:prstGeom>
-          <a:noFill/>
-        </p:spPr>
-        <p:txBody>
-          <a:bodyPr wrap="square">
-            <a:spAutoFit/>
-          </a:bodyPr>
-          <a:lstStyle/>
-          <a:p>
-            <a:pPr>
-              <a:spcAft>
-                <a:spcPts val="600"/>
-              </a:spcAft>
-            </a:pPr>
-            <a:r>
-              <a:rPr sz="1200" b="0">
-                <a:solidFill>
-                  <a:srgbClr val="282828"/>
-                </a:solidFill>
-                <a:latin typeface="Arial"/>
-              </a:rPr>
-              <a:t>•  The stage-runner sequence on the smaller worked example: specification → design → segmentation → metrology → comparison → simulation, each stage a committed runner handing its prescription to the next.</a:t>
-            </a:r>
-          </a:p>
-          <a:p>
-            <a:pPr>
-              <a:spcAft>
-                <a:spcPts val="600"/>
-              </a:spcAft>
-            </a:pPr>
-            <a:r>
-              <a:rPr sz="1200" b="0">
-                <a:solidFill>
-                  <a:srgbClr val="282828"/>
-                </a:solidFill>
-                <a:latin typeface="Arial"/>
-              </a:rPr>
-              <a:t>•  A 4 m f/18 telescope (f/1.75 primary) from a closed-form first-order seed; diffraction-limited over ±1′ alone, and the Offner ring-field relay buys the full ±2′ (Strehl floor 0.965, on pure spheres).</a:t>
-            </a:r>
-          </a:p>
-        </p:txBody>
-      </p:sp>
       <p:pic>
         <p:nvPicPr>
-          <p:cNvPr id="5" name="Picture 4" descr="rowpair_s1_views.png"/>
+          <p:cNvPr id="4" name="Picture 3" descr="demo2_beat5_poke.png"/>
           <p:cNvPicPr>
             <a:picLocks noChangeAspect="1"/>
           </p:cNvPicPr>
@@ -14895,8 +14755,8 @@
         </p:blipFill>
         <p:spPr>
           <a:xfrm>
-            <a:off x="6738659" y="1298448"/>
-            <a:ext cx="4719240" cy="2056892"/>
+            <a:off x="3772370" y="1298448"/>
+            <a:ext cx="4646955" cy="1782572"/>
           </a:xfrm>
           <a:prstGeom prst="rect">
             <a:avLst/>
@@ -14905,14 +14765,14 @@
       </p:pic>
       <p:sp>
         <p:nvSpPr>
-          <p:cNvPr id="6" name="TextBox 5"/>
+          <p:cNvPr id="5" name="TextBox 4"/>
           <p:cNvSpPr txBox="1"/>
           <p:nvPr/>
         </p:nvSpPr>
         <p:spPr>
           <a:xfrm>
-            <a:off x="6400800" y="3373628"/>
-            <a:ext cx="5394960" cy="229107"/>
+            <a:off x="411480" y="3099308"/>
+            <a:ext cx="11368735" cy="229107"/>
           </a:xfrm>
           <a:prstGeom prst="rect">
             <a:avLst/>
@@ -14937,14 +14797,14 @@
                 </a:solidFill>
                 <a:latin typeface="Arial"/>
               </a:rPr>
-              <a:t>The telescope as designed (front + iso views), with the traced field.</a:t>
+              <a:t>Beat 5 — one actuator poked: the fringes bend over it.</a:t>
             </a:r>
           </a:p>
         </p:txBody>
       </p:sp>
       <p:pic>
         <p:nvPicPr>
-          <p:cNvPr id="7" name="Picture 6" descr="s1_wfe_field.png"/>
+          <p:cNvPr id="6" name="Picture 5" descr="demo2_beat6_sweep.png"/>
           <p:cNvPicPr>
             <a:picLocks noChangeAspect="1"/>
           </p:cNvPicPr>
@@ -14958,8 +14818,8 @@
         </p:blipFill>
         <p:spPr>
           <a:xfrm>
-            <a:off x="7993860" y="3639312"/>
-            <a:ext cx="2208839" cy="1782572"/>
+            <a:off x="4186821" y="3364992"/>
+            <a:ext cx="3818051" cy="1782572"/>
           </a:xfrm>
           <a:prstGeom prst="rect">
             <a:avLst/>
@@ -14968,14 +14828,14 @@
       </p:pic>
       <p:sp>
         <p:nvSpPr>
-          <p:cNvPr id="8" name="TextBox 7"/>
+          <p:cNvPr id="7" name="TextBox 6"/>
           <p:cNvSpPr txBox="1"/>
           <p:nvPr/>
         </p:nvSpPr>
         <p:spPr>
           <a:xfrm>
-            <a:off x="6400800" y="5440171"/>
-            <a:ext cx="5394960" cy="229107"/>
+            <a:off x="411480" y="5165852"/>
+            <a:ext cx="11368735" cy="229107"/>
           </a:xfrm>
           <a:prstGeom prst="rect">
             <a:avLst/>
@@ -15000,11 +14860,35 @@
                 </a:solidFill>
                 <a:latin typeface="Arial"/>
               </a:rPr>
-              <a:t>Wavefront error over the field: diffraction-limited across the box.</a:t>
-            </a:r>
-          </a:p>
-        </p:txBody>
-      </p:sp>
+              <a:t>Beat 6 — the analyzer sweep: phase-stepped frames, no re-trace.</a:t>
+            </a:r>
+          </a:p>
+        </p:txBody>
+      </p:sp>
+      <p:pic>
+        <p:nvPicPr>
+          <p:cNvPr id="8" name="Picture 7" descr="demo2_beat7_recovery.png"/>
+          <p:cNvPicPr>
+            <a:picLocks noChangeAspect="1"/>
+          </p:cNvPicPr>
+          <p:nvPr/>
+        </p:nvPicPr>
+        <p:blipFill>
+          <a:blip r:embed="rId4"/>
+          <a:stretch>
+            <a:fillRect/>
+          </a:stretch>
+        </p:blipFill>
+        <p:spPr>
+          <a:xfrm>
+            <a:off x="4177857" y="5431536"/>
+            <a:ext cx="3835980" cy="1032763"/>
+          </a:xfrm>
+          <a:prstGeom prst="rect">
+            <a:avLst/>
+          </a:prstGeom>
+        </p:spPr>
+      </p:pic>
       <p:sp>
         <p:nvSpPr>
           <p:cNvPr id="9" name="TextBox 8"/>
@@ -15013,8 +14897,8 @@
         </p:nvSpPr>
         <p:spPr>
           <a:xfrm>
-            <a:off x="6400800" y="5705855"/>
-            <a:ext cx="5394960" cy="274320"/>
+            <a:off x="411480" y="6482588"/>
+            <a:ext cx="11368735" cy="229107"/>
           </a:xfrm>
           <a:prstGeom prst="rect">
             <a:avLst/>
@@ -15027,6 +14911,45 @@
           </a:bodyPr>
           <a:lstStyle/>
           <a:p>
+            <a:pPr algn="ctr">
+              <a:spcAft>
+                <a:spcPts val="0"/>
+              </a:spcAft>
+            </a:pPr>
+            <a:r>
+              <a:rPr sz="1000" b="0">
+                <a:solidFill>
+                  <a:srgbClr val="6E6E6E"/>
+                </a:solidFill>
+                <a:latin typeface="Arial"/>
+              </a:rPr>
+              <a:t>Beat 7 — the recovery beside the truth map.</a:t>
+            </a:r>
+          </a:p>
+        </p:txBody>
+      </p:sp>
+      <p:sp>
+        <p:nvSpPr>
+          <p:cNvPr id="10" name="TextBox 9"/>
+          <p:cNvSpPr txBox="1"/>
+          <p:nvPr/>
+        </p:nvSpPr>
+        <p:spPr>
+          <a:xfrm>
+            <a:off x="411480" y="6748272"/>
+            <a:ext cx="11368735" cy="274320"/>
+          </a:xfrm>
+          <a:prstGeom prst="rect">
+            <a:avLst/>
+          </a:prstGeom>
+          <a:noFill/>
+        </p:spPr>
+        <p:txBody>
+          <a:bodyPr wrap="square">
+            <a:spAutoFit/>
+          </a:bodyPr>
+          <a:lstStyle/>
+          <a:p>
             <a:pPr>
               <a:spcAft>
                 <a:spcPts val="600"/>
@@ -15039,7 +14962,7 @@
                 </a:solidFill>
                 <a:latin typeface="Arial"/>
               </a:rPr>
-              <a:t>Record: templates/80_end_to_end/e2e — staged worked example, committed at every step.</a:t>
+              <a:t>All eight beats have committed figures in templates/90_polarization/tg_psi_dm_v2 (v1 likewise); the driver opens them on the desktop as each beat runs.</a:t>
             </a:r>
           </a:p>
         </p:txBody>
@@ -15096,7 +15019,7 @@
                 </a:solidFill>
                 <a:latin typeface="Arial"/>
               </a:rPr>
-              <a:t>The e2e worked example: segmentation and metrology</a:t>
+              <a:t>The e2e worked example: specification to design</a:t>
             </a:r>
           </a:p>
           <a:p>
@@ -15112,7 +15035,7 @@
                 </a:solidFill>
                 <a:latin typeface="Arial"/>
               </a:rPr>
-              <a:t>The monolith segments in one call; the metrology is designed on the same Jacobian</a:t>
+              <a:t>A 4 m f/18 visible-band telescope from a closed-form seed — no starting prescription</a:t>
             </a:r>
           </a:p>
         </p:txBody>
@@ -15195,7 +15118,7 @@
                 </a:solidFill>
                 <a:latin typeface="Arial"/>
               </a:rPr>
-              <a:t>•  The primary segments into a pie or hex tiling with physical apertures; every segment gets rigid-body and surface-figure sensitivity channels, stacked into one Jacobian — the control basis.</a:t>
+              <a:t>•  The stage-runner sequence on the smaller worked example: specification → design → segmentation → metrology → comparison → simulation, each stage a committed runner handing its prescription to the next.</a:t>
             </a:r>
           </a:p>
           <a:p>
@@ -15211,14 +15134,14 @@
                 </a:solidFill>
                 <a:latin typeface="Arial"/>
               </a:rPr>
-              <a:t>•  Metrology is an optimization on that basis: edge-sensor and beam-launcher layouts scored by the control information they carry, not by symmetry; the winning pattern exports as a reusable preset.</a:t>
+              <a:t>•  A 4 m f/18 telescope (f/1.75 primary) from a closed-form first-order seed; diffraction-limited over ±1′ alone, and the Offner ring-field relay buys the full ±2′ (Strehl floor 0.965, on pure spheres).</a:t>
             </a:r>
           </a:p>
         </p:txBody>
       </p:sp>
       <p:pic>
         <p:nvPicPr>
-          <p:cNvPr id="5" name="Picture 4" descr="rowpair_s3_views_pie.png"/>
+          <p:cNvPr id="5" name="Picture 4" descr="rowpair_s1_views.png"/>
           <p:cNvPicPr>
             <a:picLocks noChangeAspect="1"/>
           </p:cNvPicPr>
@@ -15232,8 +15155,8 @@
         </p:blipFill>
         <p:spPr>
           <a:xfrm>
-            <a:off x="6618167" y="1298448"/>
-            <a:ext cx="4960224" cy="1965451"/>
+            <a:off x="6738659" y="1298448"/>
+            <a:ext cx="4719240" cy="2056892"/>
           </a:xfrm>
           <a:prstGeom prst="rect">
             <a:avLst/>
@@ -15248,7 +15171,7 @@
         </p:nvSpPr>
         <p:spPr>
           <a:xfrm>
-            <a:off x="6400800" y="3282188"/>
+            <a:off x="6400800" y="3373628"/>
             <a:ext cx="5394960" cy="229107"/>
           </a:xfrm>
           <a:prstGeom prst="rect">
@@ -15274,14 +15197,14 @@
                 </a:solidFill>
                 <a:latin typeface="Arial"/>
               </a:rPr>
-              <a:t>The segmented primary with physical apertures (front + iso views).</a:t>
+              <a:t>The telescope as designed (front + iso views), with the traced field.</a:t>
             </a:r>
           </a:p>
         </p:txBody>
       </p:sp>
       <p:pic>
         <p:nvPicPr>
-          <p:cNvPr id="7" name="Picture 6" descr="e2e_pie_met_view_rx.png"/>
+          <p:cNvPr id="7" name="Picture 6" descr="s1_wfe_field.png"/>
           <p:cNvPicPr>
             <a:picLocks noChangeAspect="1"/>
           </p:cNvPicPr>
@@ -15295,8 +15218,8 @@
         </p:blipFill>
         <p:spPr>
           <a:xfrm>
-            <a:off x="7662896" y="3547872"/>
-            <a:ext cx="2870767" cy="1874011"/>
+            <a:off x="7993860" y="3639312"/>
+            <a:ext cx="2208839" cy="1782572"/>
           </a:xfrm>
           <a:prstGeom prst="rect">
             <a:avLst/>
@@ -15337,7 +15260,7 @@
                 </a:solidFill>
                 <a:latin typeface="Arial"/>
               </a:rPr>
-              <a:t>The optimized metrology layout on the segmented primary.</a:t>
+              <a:t>Wavefront error over the field: diffraction-limited across the box.</a:t>
             </a:r>
           </a:p>
         </p:txBody>
@@ -15376,7 +15299,7 @@
                 </a:solidFill>
                 <a:latin typeface="Arial"/>
               </a:rPr>
-              <a:t>Record: templates/80_end_to_end/e2e, stages 3–5.</a:t>
+              <a:t>Record: templates/80_end_to_end/e2e — staged worked example, committed at every step.</a:t>
             </a:r>
           </a:p>
         </p:txBody>
@@ -15390,6 +15313,343 @@
 </file>
 
 <file path=ppt/slides/slide38.xml><?xml version="1.0" encoding="utf-8"?>
+<p:sld xmlns:a="http://schemas.openxmlformats.org/drawingml/2006/main" xmlns:p="http://schemas.openxmlformats.org/presentationml/2006/main" xmlns:r="http://schemas.openxmlformats.org/officeDocument/2006/relationships">
+  <p:cSld>
+    <p:spTree>
+      <p:nvGrpSpPr>
+        <p:cNvPr id="1" name=""/>
+        <p:cNvGrpSpPr/>
+        <p:nvPr/>
+      </p:nvGrpSpPr>
+      <p:grpSpPr/>
+      <p:sp>
+        <p:nvSpPr>
+          <p:cNvPr id="2" name="TextBox 1"/>
+          <p:cNvSpPr txBox="1"/>
+          <p:nvPr/>
+        </p:nvSpPr>
+        <p:spPr>
+          <a:xfrm>
+            <a:off x="411480" y="201168"/>
+            <a:ext cx="11368735" cy="914400"/>
+          </a:xfrm>
+          <a:prstGeom prst="rect">
+            <a:avLst/>
+          </a:prstGeom>
+          <a:noFill/>
+        </p:spPr>
+        <p:txBody>
+          <a:bodyPr wrap="square">
+            <a:spAutoFit/>
+          </a:bodyPr>
+          <a:lstStyle/>
+          <a:p>
+            <a:pPr>
+              <a:spcAft>
+                <a:spcPts val="400"/>
+              </a:spcAft>
+            </a:pPr>
+            <a:r>
+              <a:rPr sz="2400" b="1">
+                <a:solidFill>
+                  <a:srgbClr val="1F4E79"/>
+                </a:solidFill>
+                <a:latin typeface="Arial"/>
+              </a:rPr>
+              <a:t>The e2e worked example: segmentation and metrology</a:t>
+            </a:r>
+          </a:p>
+          <a:p>
+            <a:pPr>
+              <a:spcAft>
+                <a:spcPts val="0"/>
+              </a:spcAft>
+            </a:pPr>
+            <a:r>
+              <a:rPr sz="1250" b="0">
+                <a:solidFill>
+                  <a:srgbClr val="6E6E6E"/>
+                </a:solidFill>
+                <a:latin typeface="Arial"/>
+              </a:rPr>
+              <a:t>The monolith segments in one call; the metrology is designed on the same Jacobian</a:t>
+            </a:r>
+          </a:p>
+        </p:txBody>
+      </p:sp>
+      <p:sp>
+        <p:nvSpPr>
+          <p:cNvPr id="3" name="Rectangle 2"/>
+          <p:cNvSpPr/>
+          <p:nvPr/>
+        </p:nvSpPr>
+        <p:spPr>
+          <a:xfrm>
+            <a:off x="411480" y="1133856"/>
+            <a:ext cx="11368735" cy="20320"/>
+          </a:xfrm>
+          <a:prstGeom prst="rect">
+            <a:avLst/>
+          </a:prstGeom>
+          <a:solidFill>
+            <a:srgbClr val="B8C6D4"/>
+          </a:solidFill>
+          <a:ln>
+            <a:noFill/>
+          </a:ln>
+          <a:effectLst/>
+        </p:spPr>
+        <p:style>
+          <a:lnRef idx="1">
+            <a:schemeClr val="accent1"/>
+          </a:lnRef>
+          <a:fillRef idx="3">
+            <a:schemeClr val="accent1"/>
+          </a:fillRef>
+          <a:effectRef idx="2">
+            <a:schemeClr val="accent1"/>
+          </a:effectRef>
+          <a:fontRef idx="minor">
+            <a:schemeClr val="lt1"/>
+          </a:fontRef>
+        </p:style>
+        <p:txBody>
+          <a:bodyPr rtlCol="0" anchor="ctr"/>
+          <a:lstStyle/>
+          <a:p>
+            <a:pPr algn="ctr"/>
+          </a:p>
+        </p:txBody>
+      </p:sp>
+      <p:sp>
+        <p:nvSpPr>
+          <p:cNvPr id="4" name="TextBox 3"/>
+          <p:cNvSpPr txBox="1"/>
+          <p:nvPr/>
+        </p:nvSpPr>
+        <p:spPr>
+          <a:xfrm>
+            <a:off x="411480" y="1298448"/>
+            <a:ext cx="5806440" cy="274320"/>
+          </a:xfrm>
+          <a:prstGeom prst="rect">
+            <a:avLst/>
+          </a:prstGeom>
+          <a:noFill/>
+        </p:spPr>
+        <p:txBody>
+          <a:bodyPr wrap="square">
+            <a:spAutoFit/>
+          </a:bodyPr>
+          <a:lstStyle/>
+          <a:p>
+            <a:pPr>
+              <a:spcAft>
+                <a:spcPts val="600"/>
+              </a:spcAft>
+            </a:pPr>
+            <a:r>
+              <a:rPr sz="1200" b="0">
+                <a:solidFill>
+                  <a:srgbClr val="282828"/>
+                </a:solidFill>
+                <a:latin typeface="Arial"/>
+              </a:rPr>
+              <a:t>•  The primary segments into a pie or hex tiling with physical apertures; every segment gets rigid-body and surface-figure sensitivity channels, stacked into one Jacobian — the control basis.</a:t>
+            </a:r>
+          </a:p>
+          <a:p>
+            <a:pPr>
+              <a:spcAft>
+                <a:spcPts val="600"/>
+              </a:spcAft>
+            </a:pPr>
+            <a:r>
+              <a:rPr sz="1200" b="0">
+                <a:solidFill>
+                  <a:srgbClr val="282828"/>
+                </a:solidFill>
+                <a:latin typeface="Arial"/>
+              </a:rPr>
+              <a:t>•  Metrology is an optimization on that basis: edge-sensor and beam-launcher layouts scored by the control information they carry, not by symmetry; the winning pattern exports as a reusable preset.</a:t>
+            </a:r>
+          </a:p>
+        </p:txBody>
+      </p:sp>
+      <p:pic>
+        <p:nvPicPr>
+          <p:cNvPr id="5" name="Picture 4" descr="rowpair_s3_views_pie.png"/>
+          <p:cNvPicPr>
+            <a:picLocks noChangeAspect="1"/>
+          </p:cNvPicPr>
+          <p:nvPr/>
+        </p:nvPicPr>
+        <p:blipFill>
+          <a:blip r:embed="rId2"/>
+          <a:stretch>
+            <a:fillRect/>
+          </a:stretch>
+        </p:blipFill>
+        <p:spPr>
+          <a:xfrm>
+            <a:off x="6618167" y="1298448"/>
+            <a:ext cx="4960224" cy="1965451"/>
+          </a:xfrm>
+          <a:prstGeom prst="rect">
+            <a:avLst/>
+          </a:prstGeom>
+        </p:spPr>
+      </p:pic>
+      <p:sp>
+        <p:nvSpPr>
+          <p:cNvPr id="6" name="TextBox 5"/>
+          <p:cNvSpPr txBox="1"/>
+          <p:nvPr/>
+        </p:nvSpPr>
+        <p:spPr>
+          <a:xfrm>
+            <a:off x="6400800" y="3282188"/>
+            <a:ext cx="5394960" cy="229107"/>
+          </a:xfrm>
+          <a:prstGeom prst="rect">
+            <a:avLst/>
+          </a:prstGeom>
+          <a:noFill/>
+        </p:spPr>
+        <p:txBody>
+          <a:bodyPr wrap="square">
+            <a:spAutoFit/>
+          </a:bodyPr>
+          <a:lstStyle/>
+          <a:p>
+            <a:pPr algn="ctr">
+              <a:spcAft>
+                <a:spcPts val="0"/>
+              </a:spcAft>
+            </a:pPr>
+            <a:r>
+              <a:rPr sz="1000" b="0">
+                <a:solidFill>
+                  <a:srgbClr val="6E6E6E"/>
+                </a:solidFill>
+                <a:latin typeface="Arial"/>
+              </a:rPr>
+              <a:t>The segmented primary with physical apertures (front + iso views).</a:t>
+            </a:r>
+          </a:p>
+        </p:txBody>
+      </p:sp>
+      <p:pic>
+        <p:nvPicPr>
+          <p:cNvPr id="7" name="Picture 6" descr="e2e_pie_met_view_rx.png"/>
+          <p:cNvPicPr>
+            <a:picLocks noChangeAspect="1"/>
+          </p:cNvPicPr>
+          <p:nvPr/>
+        </p:nvPicPr>
+        <p:blipFill>
+          <a:blip r:embed="rId3"/>
+          <a:stretch>
+            <a:fillRect/>
+          </a:stretch>
+        </p:blipFill>
+        <p:spPr>
+          <a:xfrm>
+            <a:off x="7662896" y="3547872"/>
+            <a:ext cx="2870767" cy="1874011"/>
+          </a:xfrm>
+          <a:prstGeom prst="rect">
+            <a:avLst/>
+          </a:prstGeom>
+        </p:spPr>
+      </p:pic>
+      <p:sp>
+        <p:nvSpPr>
+          <p:cNvPr id="8" name="TextBox 7"/>
+          <p:cNvSpPr txBox="1"/>
+          <p:nvPr/>
+        </p:nvSpPr>
+        <p:spPr>
+          <a:xfrm>
+            <a:off x="6400800" y="5440171"/>
+            <a:ext cx="5394960" cy="229107"/>
+          </a:xfrm>
+          <a:prstGeom prst="rect">
+            <a:avLst/>
+          </a:prstGeom>
+          <a:noFill/>
+        </p:spPr>
+        <p:txBody>
+          <a:bodyPr wrap="square">
+            <a:spAutoFit/>
+          </a:bodyPr>
+          <a:lstStyle/>
+          <a:p>
+            <a:pPr algn="ctr">
+              <a:spcAft>
+                <a:spcPts val="0"/>
+              </a:spcAft>
+            </a:pPr>
+            <a:r>
+              <a:rPr sz="1000" b="0">
+                <a:solidFill>
+                  <a:srgbClr val="6E6E6E"/>
+                </a:solidFill>
+                <a:latin typeface="Arial"/>
+              </a:rPr>
+              <a:t>The optimized metrology layout on the segmented primary.</a:t>
+            </a:r>
+          </a:p>
+        </p:txBody>
+      </p:sp>
+      <p:sp>
+        <p:nvSpPr>
+          <p:cNvPr id="9" name="TextBox 8"/>
+          <p:cNvSpPr txBox="1"/>
+          <p:nvPr/>
+        </p:nvSpPr>
+        <p:spPr>
+          <a:xfrm>
+            <a:off x="6400800" y="5705855"/>
+            <a:ext cx="5394960" cy="274320"/>
+          </a:xfrm>
+          <a:prstGeom prst="rect">
+            <a:avLst/>
+          </a:prstGeom>
+          <a:noFill/>
+        </p:spPr>
+        <p:txBody>
+          <a:bodyPr wrap="square">
+            <a:spAutoFit/>
+          </a:bodyPr>
+          <a:lstStyle/>
+          <a:p>
+            <a:pPr>
+              <a:spcAft>
+                <a:spcPts val="600"/>
+              </a:spcAft>
+            </a:pPr>
+            <a:r>
+              <a:rPr sz="1050" b="0">
+                <a:solidFill>
+                  <a:srgbClr val="6E6E6E"/>
+                </a:solidFill>
+                <a:latin typeface="Arial"/>
+              </a:rPr>
+              <a:t>Record: templates/80_end_to_end/e2e, stages 3–5.</a:t>
+            </a:r>
+          </a:p>
+        </p:txBody>
+      </p:sp>
+    </p:spTree>
+  </p:cSld>
+  <p:clrMapOvr>
+    <a:masterClrMapping/>
+  </p:clrMapOvr>
+</p:sld>
+</file>
+
+<file path=ppt/slides/slide39.xml><?xml version="1.0" encoding="utf-8"?>
 <p:sld xmlns:a="http://schemas.openxmlformats.org/drawingml/2006/main" xmlns:p="http://schemas.openxmlformats.org/presentationml/2006/main" xmlns:r="http://schemas.openxmlformats.org/officeDocument/2006/relationships">
   <p:cSld>
     <p:spTree>

</xml_diff>

<commit_message>
demo_session: edit deck + baseline synced (pass-5 build)
Co-Authored-By: Claude Fable 5 <noreply@anthropic.com>
</commit_message>
<xml_diff>
--- a/demo_session/baseline_pass3.pptx
+++ b/demo_session/baseline_pass3.pptx
@@ -3208,7 +3208,7 @@
                 </a:solidFill>
                 <a:latin typeface="Arial"/>
               </a:rPr>
-              <a:t>The code is public: github.com/nasa-jpl/macos</a:t>
+              <a:t>The code is public: github.com/nasa-jpl/macos and github.com/nasa-jpl/MACOS_resources</a:t>
             </a:r>
           </a:p>
         </p:txBody>
@@ -9079,7 +9079,7 @@
                 </a:solidFill>
                 <a:latin typeface="Arial"/>
               </a:rPr>
-              <a:t>•  We are now modernizing and extending the capabilities of our modeling to meet new challenges.</a:t>
+              <a:t>•  We are now modernizing and extending our modeling tools and practices to meet new challenges.</a:t>
             </a:r>
           </a:p>
           <a:p>
@@ -9701,7 +9701,7 @@
                 </a:solidFill>
                 <a:latin typeface="Arial"/>
               </a:rPr>
-              <a:t>•  Control using wavefront measurements:   u  =  −J⁺·w ,    J⁺  =  ( JᵀJ + ρI )⁻¹ Jᵀ</a:t>
+              <a:t>•  Actuators to states:   x  =  (∂x/∂u)·u ,   so   ∂w/∂u  =  J·(∂x/∂u)</a:t>
             </a:r>
           </a:p>
           <a:p>
@@ -9717,6 +9717,38 @@
                 </a:solidFill>
                 <a:latin typeface="Arial"/>
               </a:rPr>
+              <a:t>–  Stewart-platform kinematics carry the actuator strokes u of each segment and of M2 into rigid-body states x; ∂w/∂u is the control Jacobian.</a:t>
+            </a:r>
+          </a:p>
+          <a:p>
+            <a:pPr>
+              <a:spcAft>
+                <a:spcPts val="600"/>
+              </a:spcAft>
+            </a:pPr>
+            <a:r>
+              <a:rPr sz="1500" b="0">
+                <a:solidFill>
+                  <a:srgbClr val="282828"/>
+                </a:solidFill>
+                <a:latin typeface="Arial"/>
+              </a:rPr>
+              <a:t>•  Control using wavefront measurements:   u  =  −(∂w/∂u)⁺·w</a:t>
+            </a:r>
+          </a:p>
+          <a:p>
+            <a:pPr marL="594360" indent="-137160">
+              <a:spcAft>
+                <a:spcPts val="500"/>
+              </a:spcAft>
+            </a:pPr>
+            <a:r>
+              <a:rPr sz="1300" b="0">
+                <a:solidFill>
+                  <a:srgbClr val="6E6E6E"/>
+                </a:solidFill>
+                <a:latin typeface="Arial"/>
+              </a:rPr>
               <a:t>–  Wavefront sensing and control in one step, enveloping telescope initialization controls.</a:t>
             </a:r>
           </a:p>
@@ -9733,7 +9765,7 @@
                 </a:solidFill>
                 <a:latin typeface="Arial"/>
               </a:rPr>
-              <a:t>•  Estimation and control using metrology measurements:   x̂  =  ( HᵀWH + ρI )⁻¹ HᵀW·m ;    u  ←  u − g·x̂</a:t>
+              <a:t>•  Estimation and control using metrology measurements:   x̂  =  ( HᵀWH + ρI )⁻¹ HᵀW·m ;    u  ←  u − g·(∂x/∂u)⁺·x̂</a:t>
             </a:r>
           </a:p>
           <a:p>
@@ -9762,7 +9794,7 @@
         </p:nvSpPr>
         <p:spPr>
           <a:xfrm>
-            <a:off x="411480" y="4684268"/>
+            <a:off x="411480" y="5628894"/>
             <a:ext cx="11368735" cy="274320"/>
           </a:xfrm>
           <a:prstGeom prst="rect">
@@ -10321,7 +10353,7 @@
         </p:nvSpPr>
         <p:spPr>
           <a:xfrm>
-            <a:off x="4535424" y="4169663"/>
+            <a:off x="5148072" y="4517136"/>
             <a:ext cx="2514600" cy="1054608"/>
           </a:xfrm>
           <a:prstGeom prst="rect">
@@ -10335,7 +10367,7 @@
           </a:bodyPr>
           <a:lstStyle/>
           <a:p>
-            <a:pPr algn="ctr">
+            <a:pPr algn="r">
               <a:spcAft>
                 <a:spcPts val="0"/>
               </a:spcAft>
@@ -10443,7 +10475,7 @@
                 </a:solidFill>
                 <a:latin typeface="Arial"/>
               </a:rPr>
-              <a:t>The control basis I: rigid-body channels — dw/dx</a:t>
+              <a:t>The state equations I: rigid-body channels — dw/dx</a:t>
             </a:r>
           </a:p>
           <a:p>
@@ -10701,7 +10733,7 @@
                 </a:solidFill>
                 <a:latin typeface="Arial"/>
               </a:rPr>
-              <a:t>The control basis II: segment-figure channels — dw/dz</a:t>
+              <a:t>The state equations II: segment-figure channels — dw/dz</a:t>
             </a:r>
           </a:p>
           <a:p>
@@ -10991,7 +11023,7 @@
                 </a:solidFill>
                 <a:latin typeface="Arial"/>
               </a:rPr>
-              <a:t>The control basis III: shape-normalized modes — dw/dgrid</a:t>
+              <a:t>The state equations III: shape-normalized modes — dw/dgrid</a:t>
             </a:r>
           </a:p>
           <a:p>
@@ -11169,7 +11201,23 @@
                 </a:solidFill>
                 <a:latin typeface="Arial"/>
               </a:rPr>
-              <a:t>•  These plots illustrate grid-basis influence shapes on 2 of the 19 segments, using the interface for measured influence functions and actuator maps — the same machinery the DM Jacobians use.</a:t>
+              <a:t>•  These plots illustrate grid-basis influence shapes on 2 of the 19 segments, using the interface for measured influence functions and actuator maps.</a:t>
+            </a:r>
+          </a:p>
+          <a:p>
+            <a:pPr>
+              <a:spcAft>
+                <a:spcPts val="600"/>
+              </a:spcAft>
+            </a:pPr>
+            <a:r>
+              <a:rPr sz="1500" b="0">
+                <a:solidFill>
+                  <a:srgbClr val="282828"/>
+                </a:solidFill>
+                <a:latin typeface="Arial"/>
+              </a:rPr>
+              <a:t>•  DM Jacobians use the same form: dw/dDM.</a:t>
             </a:r>
           </a:p>
         </p:txBody>
@@ -11182,7 +11230,7 @@
         </p:nvSpPr>
         <p:spPr>
           <a:xfrm>
-            <a:off x="411480" y="6018784"/>
+            <a:off x="411480" y="6163056"/>
             <a:ext cx="11368735" cy="274320"/>
           </a:xfrm>
           <a:prstGeom prst="rect">
@@ -12433,7 +12481,7 @@
               </a:spcAft>
             </a:pPr>
             <a:r>
-              <a:rPr sz="1500" b="0">
+              <a:rPr sz="2000" b="0">
                 <a:solidFill>
                   <a:srgbClr val="282828"/>
                 </a:solidFill>
@@ -12449,7 +12497,7 @@
               </a:spcAft>
             </a:pPr>
             <a:r>
-              <a:rPr sz="1500" b="0">
+              <a:rPr sz="2000" b="0">
                 <a:solidFill>
                   <a:srgbClr val="282828"/>
                 </a:solidFill>
@@ -12465,7 +12513,7 @@
               </a:spcAft>
             </a:pPr>
             <a:r>
-              <a:rPr sz="1500" b="0">
+              <a:rPr sz="2000" b="0">
                 <a:solidFill>
                   <a:srgbClr val="282828"/>
                 </a:solidFill>
@@ -12481,7 +12529,7 @@
               </a:spcAft>
             </a:pPr>
             <a:r>
-              <a:rPr sz="1500" b="0">
+              <a:rPr sz="2000" b="0">
                 <a:solidFill>
                   <a:srgbClr val="282828"/>
                 </a:solidFill>
@@ -12497,7 +12545,7 @@
               </a:spcAft>
             </a:pPr>
             <a:r>
-              <a:rPr sz="1500" b="0">
+              <a:rPr sz="2000" b="0">
                 <a:solidFill>
                   <a:srgbClr val="282828"/>
                 </a:solidFill>
@@ -12516,7 +12564,7 @@
         </p:nvSpPr>
         <p:spPr>
           <a:xfrm>
-            <a:off x="411480" y="4760214"/>
+            <a:off x="411480" y="6658864"/>
             <a:ext cx="11368735" cy="274320"/>
           </a:xfrm>
           <a:prstGeom prst="rect">
@@ -12692,7 +12740,7 @@
               </a:spcAft>
             </a:pPr>
             <a:r>
-              <a:rPr sz="1500" b="0">
+              <a:rPr sz="1600" b="0">
                 <a:solidFill>
                   <a:srgbClr val="282828"/>
                 </a:solidFill>
@@ -12708,7 +12756,7 @@
               </a:spcAft>
             </a:pPr>
             <a:r>
-              <a:rPr sz="1500" b="0">
+              <a:rPr sz="1600" b="0">
                 <a:solidFill>
                   <a:srgbClr val="282828"/>
                 </a:solidFill>
@@ -12724,7 +12772,7 @@
               </a:spcAft>
             </a:pPr>
             <a:r>
-              <a:rPr sz="1500" b="0">
+              <a:rPr sz="1600" b="0">
                 <a:solidFill>
                   <a:srgbClr val="282828"/>
                 </a:solidFill>
@@ -12740,13 +12788,13 @@
               </a:spcAft>
             </a:pPr>
             <a:r>
-              <a:rPr sz="1500" b="0">
+              <a:rPr sz="1600" b="0">
                 <a:solidFill>
                   <a:srgbClr val="282828"/>
                 </a:solidFill>
                 <a:latin typeface="Arial"/>
               </a:rPr>
-              <a:t>•  Put the agent in the search, never the numerics — starting points and basins (a warm-started walk beat the cold start 8500×); variable-set audits (35% of a metric unclaimed because one freedom was never offered); optimization schedules (a restart ladder opened decades of dark-hole floor overnight); tolerancing and glass searches.  The agent proposes; the trusted engine disposes.</a:t>
+              <a:t>•  Put the agent in the search, never in the numerics — starting points and basins (a warm-started walk beat the cold start 8500×); variable-set audits (35% of a metric unclaimed because one freedom was never offered); optimization schedules (a restart ladder opened decades of dark-hole floor overnight); tolerancing and glass searches.  The agent proposes; the trusted engine disposes.</a:t>
             </a:r>
           </a:p>
           <a:p>
@@ -12756,7 +12804,7 @@
               </a:spcAft>
             </a:pPr>
             <a:r>
-              <a:rPr sz="1500" b="0">
+              <a:rPr sz="1600" b="0">
                 <a:solidFill>
                   <a:srgbClr val="282828"/>
                 </a:solidFill>
@@ -12775,7 +12823,7 @@
         </p:nvSpPr>
         <p:spPr>
           <a:xfrm>
-            <a:off x="411480" y="5750814"/>
+            <a:off x="411480" y="6262624"/>
             <a:ext cx="11368735" cy="274320"/>
           </a:xfrm>
           <a:prstGeom prst="rect">
@@ -16111,8 +16159,8 @@
         </p:nvSpPr>
         <p:spPr>
           <a:xfrm>
-            <a:off x="411480" y="5596128"/>
-            <a:ext cx="11368735" cy="274320"/>
+            <a:off x="914400" y="5596128"/>
+            <a:ext cx="10863072" cy="274320"/>
           </a:xfrm>
           <a:prstGeom prst="rect">
             <a:avLst/>
@@ -16137,7 +16185,7 @@
                 </a:solidFill>
                 <a:latin typeface="Arial"/>
               </a:rPr>
-              <a:t>Counts as of 2026-08.  Every area is exercised by the committed test suites and by the worked examples beside it — the same templates this talk's studies live in.  Rebuild the figure: make_mmacos_fig.py.</a:t>
+              <a:t>Counts as of 2026-08.  Every area is exercised by the committed test suites and by the worked examples beside it — the same templates this talk's studies live in.</a:t>
             </a:r>
           </a:p>
         </p:txBody>

</xml_diff>

<commit_message>
demo_session: edit deck + baseline synced (40-slide ladder build)
Dave's Impress session closed with zero diffs vs baseline; gate passed
clean.  Edit deck now carries slide 28 (the restart ladder).

Co-Authored-By: Claude Fable 5 <noreply@anthropic.com>
</commit_message>
<xml_diff>
--- a/demo_session/baseline_pass3.pptx
+++ b/demo_session/baseline_pass3.pptx
@@ -44,6 +44,7 @@
     <p:sldId id="292" r:id="rId43"/>
     <p:sldId id="293" r:id="rId44"/>
     <p:sldId id="294" r:id="rId45"/>
+    <p:sldId id="295" r:id="rId46"/>
   </p:sldIdLst>
   <p:sldSz cx="12191695" cy="6858000" type="screen4x3"/>
   <p:notesSz cx="6858000" cy="9144000"/>
@@ -11444,7 +11445,7 @@
                 </a:solidFill>
                 <a:latin typeface="Arial"/>
               </a:rPr>
-              <a:t>•  Honest gap, attributed: the segmented-pupil contrast floor sits above the clear-pupil testbed's — the gaps and edges carry it, not the control.</a:t>
+              <a:t>•  Honest gap, attributed: the hold level is the loop mechanization's floor (sensor noise through the gain, damped EFC), not the model's limit — the next slide digs the static dark hole three decades deeper, overnight.</a:t>
             </a:r>
           </a:p>
         </p:txBody>
@@ -11603,7 +11604,7 @@
                 </a:solidFill>
                 <a:latin typeface="Arial"/>
               </a:rPr>
-              <a:t>The live design, revealed</a:t>
+              <a:t>Digging the dark hole: the overnight restart ladder</a:t>
             </a:r>
           </a:p>
           <a:p>
@@ -11619,7 +11620,7 @@
                 </a:solidFill>
                 <a:latin typeface="Arial"/>
               </a:rPr>
-              <a:t>Predicted from the frontier before solving; solved in one warm-started step while we talked</a:t>
+              <a:t>1.2×10⁻⁶ → 1.1×10⁻⁹ — three decades from restart scheduling alone; no new hardware, no new physics</a:t>
             </a:r>
           </a:p>
         </p:txBody>
@@ -11702,7 +11703,7 @@
                 </a:solidFill>
                 <a:latin typeface="Arial"/>
               </a:rPr>
-              <a:t>•  The ask: a field-box width, anywhere in 5–15°.  The prediction, stated before the solve: interpolated from the committed frontier rows.</a:t>
+              <a:t>•  The recipe: EFC to a floor, relinearize about the dug state, restart at that floor — rinse and repeat.  Ten digging rounds, ~4 h unattended, on the d = 1.10 m two-DM variant — the spacing study's best linear substrate; three stall rounds then prove the plateau.</a:t>
             </a:r>
           </a:p>
           <a:p>
@@ -11718,7 +11719,7 @@
                 </a:solidFill>
                 <a:latin typeface="Arial"/>
               </a:rPr>
-              <a:t>•  The pre-run rehearsal of the default ask (12°): predicted 33.7 nm; solved 33.6 nm — 1.00× — at a 24.9 mm clearance floor, both checks pass, in 15 minutes.</a:t>
+              <a:t>•  The controller was the bottleneck, measured: a single linearization stalls at 9.0×10⁻⁷; every restart bought another step down.  DM strokes end at 33 nm rms, well inside the 50 nm budget.</a:t>
             </a:r>
           </a:p>
           <a:p>
@@ -11734,14 +11735,14 @@
                 </a:solidFill>
                 <a:latin typeface="Arial"/>
               </a:rPr>
-              <a:t>•  The run is deterministic to every printed digit, and every ask is a genuine continuation step — never a re-score of a stored design.</a:t>
+              <a:t>•  The remaining 1.5 decades are priced: re-measured at every dug state, the linear-achievable floor holds at 2–4×10⁻¹¹ — HWO-class 5×10⁻¹¹ is within this substrate's reach.  The plateau at 1.1×10⁻⁹ is the monotone Tikhonov step rule: the measured case for FALCO-grade step control on this same model.</a:t>
             </a:r>
           </a:p>
         </p:txBody>
       </p:sp>
       <p:pic>
         <p:nvPicPr>
-          <p:cNvPr id="5" name="Picture 4" descr="oi_demo_12deg_layout.png"/>
+          <p:cNvPr id="5" name="Picture 4" descr="fig_cf3d_ladder.png"/>
           <p:cNvPicPr>
             <a:picLocks noChangeAspect="1"/>
           </p:cNvPicPr>
@@ -11755,8 +11756,8 @@
         </p:blipFill>
         <p:spPr>
           <a:xfrm>
-            <a:off x="8000103" y="1298448"/>
-            <a:ext cx="2196352" cy="1891792"/>
+            <a:off x="6400800" y="1298448"/>
+            <a:ext cx="5394960" cy="3637305"/>
           </a:xfrm>
           <a:prstGeom prst="rect">
             <a:avLst/>
@@ -11771,7 +11772,7 @@
         </p:nvSpPr>
         <p:spPr>
           <a:xfrm>
-            <a:off x="6400800" y="3208528"/>
+            <a:off x="6400800" y="4954041"/>
             <a:ext cx="5394960" cy="394208"/>
           </a:xfrm>
           <a:prstGeom prst="rect">
@@ -11797,44 +11798,20 @@
                 </a:solidFill>
                 <a:latin typeface="Arial"/>
               </a:rPr>
-              <a:t>The 12° rehearsal design and its field map: 33.6 nm max against a 33.7 nm prediction.</a:t>
-            </a:r>
-          </a:p>
-        </p:txBody>
-      </p:sp>
-      <p:pic>
-        <p:nvPicPr>
-          <p:cNvPr id="7" name="Picture 6" descr="oi_demo_12deg_map.png"/>
-          <p:cNvPicPr>
-            <a:picLocks noChangeAspect="1"/>
-          </p:cNvPicPr>
-          <p:nvPr/>
-        </p:nvPicPr>
-        <p:blipFill>
-          <a:blip r:embed="rId3"/>
-          <a:stretch>
-            <a:fillRect/>
-          </a:stretch>
-        </p:blipFill>
-        <p:spPr>
-          <a:xfrm>
-            <a:off x="7951092" y="3639312"/>
-            <a:ext cx="2294375" cy="2011680"/>
-          </a:xfrm>
-          <a:prstGeom prst="rect">
-            <a:avLst/>
-          </a:prstGeom>
-        </p:spPr>
-      </p:pic>
-      <p:sp>
-        <p:nvSpPr>
-          <p:cNvPr id="8" name="TextBox 7"/>
+              <a:t>The ladder: measured dark-zone floor by restart round, with the linear-achievable substrate re-measured at every dug state.</a:t>
+            </a:r>
+          </a:p>
+        </p:txBody>
+      </p:sp>
+      <p:sp>
+        <p:nvSpPr>
+          <p:cNvPr id="7" name="TextBox 6"/>
           <p:cNvSpPr txBox="1"/>
           <p:nvPr/>
         </p:nvSpPr>
         <p:spPr>
           <a:xfrm>
-            <a:off x="6400800" y="5650992"/>
+            <a:off x="6400800" y="5384825"/>
             <a:ext cx="5394960" cy="274320"/>
           </a:xfrm>
           <a:prstGeom prst="rect">
@@ -11860,7 +11837,7 @@
                 </a:solidFill>
                 <a:latin typeface="Arial"/>
               </a:rPr>
-              <a:t>On demo day the live run's figures replace these panels; this pre-generated bundle is the fallback if the room's ask matches nothing better.</a:t>
+              <a:t>Record: templates/80_end_to_end/e2e6m_r2, CF3d stage — checkpointed and resumable; every round is a finished floor.</a:t>
             </a:r>
           </a:p>
         </p:txBody>
@@ -11917,7 +11894,7 @@
                 </a:solidFill>
                 <a:latin typeface="Arial"/>
               </a:rPr>
-              <a:t>AI in design and analysis — the working questions</a:t>
+              <a:t>The live design, revealed</a:t>
             </a:r>
           </a:p>
           <a:p>
@@ -11933,7 +11910,7 @@
                 </a:solidFill>
                 <a:latin typeface="Arial"/>
               </a:rPr>
-              <a:t>What we ask of an AI-driven study before believing it</a:t>
+              <a:t>Predicted from the frontier before solving; solved in one warm-started step while we talked</a:t>
             </a:r>
           </a:p>
         </p:txBody>
@@ -11991,7 +11968,7 @@
         <p:spPr>
           <a:xfrm>
             <a:off x="411480" y="1298448"/>
-            <a:ext cx="11368735" cy="274320"/>
+            <a:ext cx="5806440" cy="274320"/>
           </a:xfrm>
           <a:prstGeom prst="rect">
             <a:avLst/>
@@ -12010,13 +11987,13 @@
               </a:spcAft>
             </a:pPr>
             <a:r>
-              <a:rPr sz="1500" b="0">
+              <a:rPr sz="1200" b="0">
                 <a:solidFill>
                   <a:srgbClr val="282828"/>
                 </a:solidFill>
                 <a:latin typeface="Arial"/>
               </a:rPr>
-              <a:t>•  How is a machine's result verified?  Regression checks with negative controls; layout renders read against every claim — the checks caught the errors shown today.</a:t>
+              <a:t>•  The ask: a field-box width, anywhere in 5–15°.  The prediction, stated before the solve: interpolated from the committed frontier rows.</a:t>
             </a:r>
           </a:p>
           <a:p>
@@ -12026,13 +12003,13 @@
               </a:spcAft>
             </a:pPr>
             <a:r>
-              <a:rPr sz="1500" b="0">
+              <a:rPr sz="1200" b="0">
                 <a:solidFill>
                   <a:srgbClr val="282828"/>
                 </a:solidFill>
                 <a:latin typeface="Arial"/>
               </a:rPr>
-              <a:t>•  Where does the human rule?  Constraints, metrics, and every outward claim — the AI proposes, the record decides.</a:t>
+              <a:t>•  The pre-run rehearsal of the default ask (12°): predicted 33.7 nm; solved 33.6 nm — 1.00× — at a 24.9 mm clearance floor, both checks pass, in 15 minutes.</a:t>
             </a:r>
           </a:p>
           <a:p>
@@ -12042,27 +12019,51 @@
               </a:spcAft>
             </a:pPr>
             <a:r>
-              <a:rPr sz="1500" b="0">
+              <a:rPr sz="1200" b="0">
                 <a:solidFill>
                   <a:srgbClr val="282828"/>
                 </a:solidFill>
                 <a:latin typeface="Arial"/>
               </a:rPr>
-              <a:t>•  Is it reproducible?  Every number in this deck rebuilds from committed scripts and committed records — including the design solved during this talk.</a:t>
-            </a:r>
-          </a:p>
-        </p:txBody>
-      </p:sp>
-      <p:sp>
-        <p:nvSpPr>
-          <p:cNvPr id="5" name="TextBox 4"/>
+              <a:t>•  The run is deterministic to every printed digit, and every ask is a genuine continuation step — never a re-score of a stored design.</a:t>
+            </a:r>
+          </a:p>
+        </p:txBody>
+      </p:sp>
+      <p:pic>
+        <p:nvPicPr>
+          <p:cNvPr id="5" name="Picture 4" descr="oi_demo_12deg_layout.png"/>
+          <p:cNvPicPr>
+            <a:picLocks noChangeAspect="1"/>
+          </p:cNvPicPr>
+          <p:nvPr/>
+        </p:nvPicPr>
+        <p:blipFill>
+          <a:blip r:embed="rId2"/>
+          <a:stretch>
+            <a:fillRect/>
+          </a:stretch>
+        </p:blipFill>
+        <p:spPr>
+          <a:xfrm>
+            <a:off x="8000103" y="1298448"/>
+            <a:ext cx="2196352" cy="1891792"/>
+          </a:xfrm>
+          <a:prstGeom prst="rect">
+            <a:avLst/>
+          </a:prstGeom>
+        </p:spPr>
+      </p:pic>
+      <p:sp>
+        <p:nvSpPr>
+          <p:cNvPr id="6" name="TextBox 5"/>
           <p:cNvSpPr txBox="1"/>
           <p:nvPr/>
         </p:nvSpPr>
         <p:spPr>
           <a:xfrm>
-            <a:off x="411480" y="2993898"/>
-            <a:ext cx="11368735" cy="274320"/>
+            <a:off x="6400800" y="3208528"/>
+            <a:ext cx="5394960" cy="394208"/>
           </a:xfrm>
           <a:prstGeom prst="rect">
             <a:avLst/>
@@ -12075,6 +12076,69 @@
           </a:bodyPr>
           <a:lstStyle/>
           <a:p>
+            <a:pPr algn="ctr">
+              <a:spcAft>
+                <a:spcPts val="0"/>
+              </a:spcAft>
+            </a:pPr>
+            <a:r>
+              <a:rPr sz="1000" b="0">
+                <a:solidFill>
+                  <a:srgbClr val="6E6E6E"/>
+                </a:solidFill>
+                <a:latin typeface="Arial"/>
+              </a:rPr>
+              <a:t>The 12° rehearsal design and its field map: 33.6 nm max against a 33.7 nm prediction.</a:t>
+            </a:r>
+          </a:p>
+        </p:txBody>
+      </p:sp>
+      <p:pic>
+        <p:nvPicPr>
+          <p:cNvPr id="7" name="Picture 6" descr="oi_demo_12deg_map.png"/>
+          <p:cNvPicPr>
+            <a:picLocks noChangeAspect="1"/>
+          </p:cNvPicPr>
+          <p:nvPr/>
+        </p:nvPicPr>
+        <p:blipFill>
+          <a:blip r:embed="rId3"/>
+          <a:stretch>
+            <a:fillRect/>
+          </a:stretch>
+        </p:blipFill>
+        <p:spPr>
+          <a:xfrm>
+            <a:off x="7951092" y="3639312"/>
+            <a:ext cx="2294375" cy="2011680"/>
+          </a:xfrm>
+          <a:prstGeom prst="rect">
+            <a:avLst/>
+          </a:prstGeom>
+        </p:spPr>
+      </p:pic>
+      <p:sp>
+        <p:nvSpPr>
+          <p:cNvPr id="8" name="TextBox 7"/>
+          <p:cNvSpPr txBox="1"/>
+          <p:nvPr/>
+        </p:nvSpPr>
+        <p:spPr>
+          <a:xfrm>
+            <a:off x="6400800" y="5650992"/>
+            <a:ext cx="5394960" cy="274320"/>
+          </a:xfrm>
+          <a:prstGeom prst="rect">
+            <a:avLst/>
+          </a:prstGeom>
+          <a:noFill/>
+        </p:spPr>
+        <p:txBody>
+          <a:bodyPr wrap="square">
+            <a:spAutoFit/>
+          </a:bodyPr>
+          <a:lstStyle/>
+          <a:p>
             <a:pPr>
               <a:spcAft>
                 <a:spcPts val="600"/>
@@ -12087,7 +12151,7 @@
                 </a:solidFill>
                 <a:latin typeface="Arial"/>
               </a:rPr>
-              <a:t>Offered as discussion questions, not settled doctrine — the next slide takes one of them to architecture.</a:t>
+              <a:t>On demo day the live run's figures replace these panels; this pre-generated bundle is the fallback if the room's ask matches nothing better.</a:t>
             </a:r>
           </a:p>
         </p:txBody>
@@ -12388,7 +12452,7 @@
                 </a:solidFill>
                 <a:latin typeface="Arial"/>
               </a:rPr>
-              <a:t>Discussion: where should the agent sit?</a:t>
+              <a:t>AI in design and analysis — the working questions</a:t>
             </a:r>
           </a:p>
           <a:p>
@@ -12404,7 +12468,7 @@
                 </a:solidFill>
                 <a:latin typeface="Arial"/>
               </a:rPr>
-              <a:t>Three modes — two exercised by these studies, one open — and the boundary between them is the question</a:t>
+              <a:t>What we ask of an AI-driven study before believing it</a:t>
             </a:r>
           </a:p>
         </p:txBody>
@@ -12481,13 +12545,13 @@
               </a:spcAft>
             </a:pPr>
             <a:r>
-              <a:rPr sz="2000" b="0">
+              <a:rPr sz="1500" b="0">
                 <a:solidFill>
                   <a:srgbClr val="282828"/>
                 </a:solidFill>
                 <a:latin typeface="Arial"/>
               </a:rPr>
-              <a:t>•  A · The compiled tool, no agent — what ships: versioned, regression-tested, inspectable, and it runs unattended.  But measured on a cold user, the docs alone did not carry them.</a:t>
+              <a:t>•  How is a machine's result verified?  Regression checks with negative controls; layout renders read against every claim — the checks caught the errors shown today.</a:t>
             </a:r>
           </a:p>
           <a:p>
@@ -12497,13 +12561,13 @@
               </a:spcAft>
             </a:pPr>
             <a:r>
-              <a:rPr sz="2000" b="0">
+              <a:rPr sz="1500" b="0">
                 <a:solidFill>
                   <a:srgbClr val="282828"/>
                 </a:solidFill>
                 <a:latin typeface="Arial"/>
               </a:rPr>
-              <a:t>•  B · An agent alongside the tool — what these studies did: it found and fixed the conceptual defects in hours and chose what was worth compiling.  Its knowledge is current — but not versioned with the tool.</a:t>
+              <a:t>•  Where does the human rule?  Constraints, metrics, and every outward claim — the AI proposes, the record decides.</a:t>
             </a:r>
           </a:p>
           <a:p>
@@ -12513,45 +12577,13 @@
               </a:spcAft>
             </a:pPr>
             <a:r>
-              <a:rPr sz="2000" b="0">
+              <a:rPr sz="1500" b="0">
                 <a:solidFill>
                   <a:srgbClr val="282828"/>
                 </a:solidFill>
                 <a:latin typeface="Arial"/>
               </a:rPr>
-              <a:t>•  C · A helper embedded in the tool — the open question: advice at the moment of use, catching the failure class that was documented and still fatal.</a:t>
-            </a:r>
-          </a:p>
-          <a:p>
-            <a:pPr>
-              <a:spcAft>
-                <a:spcPts val="600"/>
-              </a:spcAft>
-            </a:pPr>
-            <a:r>
-              <a:rPr sz="2000" b="0">
-                <a:solidFill>
-                  <a:srgbClr val="282828"/>
-                </a:solidFill>
-                <a:latin typeface="Arial"/>
-              </a:rPr>
-              <a:t>•  Shapes for C, in increasing authority:  agent-readable state (the user's own assistant drives the tool); a failure-triage assistant (fires on a failed check, returns a diagnosis and a next command); a policy assistant inside hard limits (chooses schedules and targets; the code enforces limits and logs every choice).</a:t>
-            </a:r>
-          </a:p>
-          <a:p>
-            <a:pPr>
-              <a:spcAft>
-                <a:spcPts val="600"/>
-              </a:spcAft>
-            </a:pPr>
-            <a:r>
-              <a:rPr sz="2000" b="0">
-                <a:solidFill>
-                  <a:srgbClr val="282828"/>
-                </a:solidFill>
-                <a:latin typeface="Arial"/>
-              </a:rPr>
-              <a:t>•  At any level, tier the agents: an orchestrator plans and delegates bounded tasks; the committed records — not any agent's memory — are the shared memory.</a:t>
+              <a:t>•  Is it reproducible?  Every number in this deck rebuilds from committed scripts and committed records — including the design solved during this talk.</a:t>
             </a:r>
           </a:p>
         </p:txBody>
@@ -12564,7 +12596,7 @@
         </p:nvSpPr>
         <p:spPr>
           <a:xfrm>
-            <a:off x="411480" y="6658864"/>
+            <a:off x="411480" y="2993898"/>
             <a:ext cx="11368735" cy="274320"/>
           </a:xfrm>
           <a:prstGeom prst="rect">
@@ -12590,7 +12622,7 @@
                 </a:solidFill>
                 <a:latin typeface="Arial"/>
               </a:rPr>
-              <a:t>A stale check fails loudly; stale advice fails silently.  Measured: the tool alone did not carry a new user; an agent alongside it closed every gap — and most of what it learned is now in the tool, as checks and defaults.</a:t>
+              <a:t>Offered as discussion questions, not settled doctrine — the next slide takes one of them to architecture.</a:t>
             </a:r>
           </a:p>
         </p:txBody>
@@ -12647,7 +12679,7 @@
                 </a:solidFill>
                 <a:latin typeface="Arial"/>
               </a:rPr>
-              <a:t>If you asked us: AI around CODE V and LightTools</a:t>
+              <a:t>Discussion: where should the agent sit?</a:t>
             </a:r>
           </a:p>
           <a:p>
@@ -12663,7 +12695,7 @@
                 </a:solidFill>
                 <a:latin typeface="Arial"/>
               </a:rPr>
-              <a:t>Add it around the optics, not in them — every claim below is measured, not speculative</a:t>
+              <a:t>Three modes — two exercised by these studies, one open — and the boundary between them is the question</a:t>
             </a:r>
           </a:p>
         </p:txBody>
@@ -12740,13 +12772,13 @@
               </a:spcAft>
             </a:pPr>
             <a:r>
-              <a:rPr sz="1600" b="0">
+              <a:rPr sz="2000" b="0">
                 <a:solidFill>
                   <a:srgbClr val="282828"/>
                 </a:solidFill>
                 <a:latin typeface="Arial"/>
               </a:rPr>
-              <a:t>•  Make the tools agent-readable first — state, results, warnings and docs as structured data through the existing macro/API surface.  Every user's assistant then attaches today, and the vendor ships no intelligence at all.  This whole talk ran in that mode.</a:t>
+              <a:t>•  A · The compiled tool, no agent — what ships: versioned, regression-tested, inspectable, and it runs unattended.  But measured on a cold user, the docs alone did not carry them.</a:t>
             </a:r>
           </a:p>
           <a:p>
@@ -12756,13 +12788,13 @@
               </a:spcAft>
             </a:pPr>
             <a:r>
-              <a:rPr sz="1600" b="0">
+              <a:rPr sz="2000" b="0">
                 <a:solidFill>
                   <a:srgbClr val="282828"/>
                 </a:solidFill>
                 <a:latin typeface="Arial"/>
               </a:rPr>
-              <a:t>•  Ship the conventions as data.  The largest defect class our agent found was conventions — the sign of a radius, DAR versus a coordinate break, which reference sphere a number is quoted against.  Make them queryable and the dominant error source disappears for humans and agents alike.</a:t>
+              <a:t>•  B · An agent alongside the tool — what these studies did: it found and fixed the conceptual defects in hours and chose what was worth compiling.  Its knowledge is current — but not versioned with the tool.</a:t>
             </a:r>
           </a:p>
           <a:p>
@@ -12772,13 +12804,13 @@
               </a:spcAft>
             </a:pPr>
             <a:r>
-              <a:rPr sz="1600" b="0">
+              <a:rPr sz="2000" b="0">
                 <a:solidFill>
                   <a:srgbClr val="282828"/>
                 </a:solidFill>
                 <a:latin typeface="Arial"/>
               </a:rPr>
-              <a:t>•  Embed a failure-triage assistant first — it wakes on a failed trace or a stalled solve, reads the saved state, and returns one line of diagnosis plus a next command the person runs.  Our stalled solve was a finite-difference step reading the gradient 17% low: a one-line answer sitting in state the tool already had.</a:t>
+              <a:t>•  C · A helper embedded in the tool — the open question: advice at the moment of use, catching the failure class that was documented and still fatal.</a:t>
             </a:r>
           </a:p>
           <a:p>
@@ -12788,13 +12820,13 @@
               </a:spcAft>
             </a:pPr>
             <a:r>
-              <a:rPr sz="1600" b="0">
+              <a:rPr sz="2000" b="0">
                 <a:solidFill>
                   <a:srgbClr val="282828"/>
                 </a:solidFill>
                 <a:latin typeface="Arial"/>
               </a:rPr>
-              <a:t>•  Put the agent in the search, never in the numerics — starting points and basins (a warm-started walk beat the cold start 8500×); variable-set audits (35% of a metric unclaimed because one freedom was never offered); optimization schedules (a restart ladder opened decades of dark-hole floor overnight); tolerancing and glass searches.  The agent proposes; the trusted engine disposes.</a:t>
+              <a:t>•  Shapes for C, in increasing authority:  agent-readable state (the user's own assistant drives the tool); a failure-triage assistant (fires on a failed check, returns a diagnosis and a next command); a policy assistant inside hard limits (chooses schedules and targets; the code enforces limits and logs every choice).</a:t>
             </a:r>
           </a:p>
           <a:p>
@@ -12804,13 +12836,13 @@
               </a:spcAft>
             </a:pPr>
             <a:r>
-              <a:rPr sz="1600" b="0">
+              <a:rPr sz="2000" b="0">
                 <a:solidFill>
                   <a:srgbClr val="282828"/>
                 </a:solidFill>
                 <a:latin typeface="Arial"/>
               </a:rPr>
-              <a:t>•  Ship the trust machinery with it: every AI action a readable, replayable script — never an opaque state mutation; every proposal a before/after check with negative controls; the assistant's knowledge versioned with the release.</a:t>
+              <a:t>•  At any level, tier the agents: an orchestrator plans and delegates bounded tasks; the committed records — not any agent's memory — are the shared memory.</a:t>
             </a:r>
           </a:p>
         </p:txBody>
@@ -12823,7 +12855,7 @@
         </p:nvSpPr>
         <p:spPr>
           <a:xfrm>
-            <a:off x="411480" y="6262624"/>
+            <a:off x="411480" y="6658864"/>
             <a:ext cx="11368735" cy="274320"/>
           </a:xfrm>
           <a:prstGeom prst="rect">
@@ -12849,7 +12881,7 @@
                 </a:solidFill>
                 <a:latin typeface="Arial"/>
               </a:rPr>
-              <a:t>A stale check fails loudly; stale advice fails silently — and the best advice ends up compiled into the tool, as checks and defaults.</a:t>
+              <a:t>A stale check fails loudly; stale advice fails silently.  Measured: the tool alone did not carry a new user; an agent alongside it closed every gap — and most of what it learned is now in the tool, as checks and defaults.</a:t>
             </a:r>
           </a:p>
         </p:txBody>
@@ -12906,7 +12938,23 @@
                 </a:solidFill>
                 <a:latin typeface="Arial"/>
               </a:rPr>
-              <a:t>Backup Slides</a:t>
+              <a:t>If you asked us: AI around CODE V and LightTools</a:t>
+            </a:r>
+          </a:p>
+          <a:p>
+            <a:pPr>
+              <a:spcAft>
+                <a:spcPts val="0"/>
+              </a:spcAft>
+            </a:pPr>
+            <a:r>
+              <a:rPr sz="1250" b="0">
+                <a:solidFill>
+                  <a:srgbClr val="6E6E6E"/>
+                </a:solidFill>
+                <a:latin typeface="Arial"/>
+              </a:rPr>
+              <a:t>Add it around the optics, not in them — every claim below is measured, not speculative</a:t>
             </a:r>
           </a:p>
         </p:txBody>
@@ -12919,7 +12967,7 @@
         </p:nvSpPr>
         <p:spPr>
           <a:xfrm>
-            <a:off x="411480" y="914400"/>
+            <a:off x="411480" y="1133856"/>
             <a:ext cx="11368735" cy="20320"/>
           </a:xfrm>
           <a:prstGeom prst="rect">
@@ -12955,6 +13003,148 @@
           </a:p>
         </p:txBody>
       </p:sp>
+      <p:sp>
+        <p:nvSpPr>
+          <p:cNvPr id="4" name="TextBox 3"/>
+          <p:cNvSpPr txBox="1"/>
+          <p:nvPr/>
+        </p:nvSpPr>
+        <p:spPr>
+          <a:xfrm>
+            <a:off x="411480" y="1298448"/>
+            <a:ext cx="11368735" cy="274320"/>
+          </a:xfrm>
+          <a:prstGeom prst="rect">
+            <a:avLst/>
+          </a:prstGeom>
+          <a:noFill/>
+        </p:spPr>
+        <p:txBody>
+          <a:bodyPr wrap="square">
+            <a:spAutoFit/>
+          </a:bodyPr>
+          <a:lstStyle/>
+          <a:p>
+            <a:pPr>
+              <a:spcAft>
+                <a:spcPts val="600"/>
+              </a:spcAft>
+            </a:pPr>
+            <a:r>
+              <a:rPr sz="1600" b="0">
+                <a:solidFill>
+                  <a:srgbClr val="282828"/>
+                </a:solidFill>
+                <a:latin typeface="Arial"/>
+              </a:rPr>
+              <a:t>•  Make the tools agent-readable first — state, results, warnings and docs as structured data through the existing macro/API surface.  Every user's assistant then attaches today, and the vendor ships no intelligence at all.  This whole talk ran in that mode.</a:t>
+            </a:r>
+          </a:p>
+          <a:p>
+            <a:pPr>
+              <a:spcAft>
+                <a:spcPts val="600"/>
+              </a:spcAft>
+            </a:pPr>
+            <a:r>
+              <a:rPr sz="1600" b="0">
+                <a:solidFill>
+                  <a:srgbClr val="282828"/>
+                </a:solidFill>
+                <a:latin typeface="Arial"/>
+              </a:rPr>
+              <a:t>•  Ship the conventions as data.  The largest defect class our agent found was conventions — the sign of a radius, DAR versus a coordinate break, which reference sphere a number is quoted against.  Make them queryable and the dominant error source disappears for humans and agents alike.</a:t>
+            </a:r>
+          </a:p>
+          <a:p>
+            <a:pPr>
+              <a:spcAft>
+                <a:spcPts val="600"/>
+              </a:spcAft>
+            </a:pPr>
+            <a:r>
+              <a:rPr sz="1600" b="0">
+                <a:solidFill>
+                  <a:srgbClr val="282828"/>
+                </a:solidFill>
+                <a:latin typeface="Arial"/>
+              </a:rPr>
+              <a:t>•  Embed a failure-triage assistant first — it wakes on a failed trace or a stalled solve, reads the saved state, and returns one line of diagnosis plus a next command the person runs.  Our stalled solve was a finite-difference step reading the gradient 17% low: a one-line answer sitting in state the tool already had.</a:t>
+            </a:r>
+          </a:p>
+          <a:p>
+            <a:pPr>
+              <a:spcAft>
+                <a:spcPts val="600"/>
+              </a:spcAft>
+            </a:pPr>
+            <a:r>
+              <a:rPr sz="1600" b="0">
+                <a:solidFill>
+                  <a:srgbClr val="282828"/>
+                </a:solidFill>
+                <a:latin typeface="Arial"/>
+              </a:rPr>
+              <a:t>•  Put the agent in the search, never in the numerics — starting points and basins (a warm-started walk beat the cold start 8500×); variable-set audits (35% of a metric unclaimed because one freedom was never offered); optimization schedules (a restart ladder dug the dark hole 1.2×10⁻⁶ → 1.1×10⁻⁹ overnight); tolerancing and glass searches.  The agent proposes; the trusted engine disposes.</a:t>
+            </a:r>
+          </a:p>
+          <a:p>
+            <a:pPr>
+              <a:spcAft>
+                <a:spcPts val="600"/>
+              </a:spcAft>
+            </a:pPr>
+            <a:r>
+              <a:rPr sz="1600" b="0">
+                <a:solidFill>
+                  <a:srgbClr val="282828"/>
+                </a:solidFill>
+                <a:latin typeface="Arial"/>
+              </a:rPr>
+              <a:t>•  Ship the trust machinery with it: every AI action a readable, replayable script — never an opaque state mutation; every proposal a before/after check with negative controls; the assistant's knowledge versioned with the release.</a:t>
+            </a:r>
+          </a:p>
+        </p:txBody>
+      </p:sp>
+      <p:sp>
+        <p:nvSpPr>
+          <p:cNvPr id="5" name="TextBox 4"/>
+          <p:cNvSpPr txBox="1"/>
+          <p:nvPr/>
+        </p:nvSpPr>
+        <p:spPr>
+          <a:xfrm>
+            <a:off x="411480" y="6262624"/>
+            <a:ext cx="11368735" cy="274320"/>
+          </a:xfrm>
+          <a:prstGeom prst="rect">
+            <a:avLst/>
+          </a:prstGeom>
+          <a:noFill/>
+        </p:spPr>
+        <p:txBody>
+          <a:bodyPr wrap="square">
+            <a:spAutoFit/>
+          </a:bodyPr>
+          <a:lstStyle/>
+          <a:p>
+            <a:pPr>
+              <a:spcAft>
+                <a:spcPts val="600"/>
+              </a:spcAft>
+            </a:pPr>
+            <a:r>
+              <a:rPr sz="1050" b="0">
+                <a:solidFill>
+                  <a:srgbClr val="6E6E6E"/>
+                </a:solidFill>
+                <a:latin typeface="Arial"/>
+              </a:rPr>
+              <a:t>A stale check fails loudly; stale advice fails silently — and the best advice ends up compiled into the tool, as checks and defaults.</a:t>
+            </a:r>
+          </a:p>
+        </p:txBody>
+      </p:sp>
     </p:spTree>
   </p:cSld>
   <p:clrMapOvr>
@@ -12964,6 +13154,107 @@
 </file>
 
 <file path=ppt/slides/slide33.xml><?xml version="1.0" encoding="utf-8"?>
+<p:sld xmlns:a="http://schemas.openxmlformats.org/drawingml/2006/main" xmlns:p="http://schemas.openxmlformats.org/presentationml/2006/main" xmlns:r="http://schemas.openxmlformats.org/officeDocument/2006/relationships">
+  <p:cSld>
+    <p:spTree>
+      <p:nvGrpSpPr>
+        <p:cNvPr id="1" name=""/>
+        <p:cNvGrpSpPr/>
+        <p:nvPr/>
+      </p:nvGrpSpPr>
+      <p:grpSpPr/>
+      <p:sp>
+        <p:nvSpPr>
+          <p:cNvPr id="2" name="TextBox 1"/>
+          <p:cNvSpPr txBox="1"/>
+          <p:nvPr/>
+        </p:nvSpPr>
+        <p:spPr>
+          <a:xfrm>
+            <a:off x="411480" y="201168"/>
+            <a:ext cx="11368735" cy="914400"/>
+          </a:xfrm>
+          <a:prstGeom prst="rect">
+            <a:avLst/>
+          </a:prstGeom>
+          <a:noFill/>
+        </p:spPr>
+        <p:txBody>
+          <a:bodyPr wrap="square">
+            <a:spAutoFit/>
+          </a:bodyPr>
+          <a:lstStyle/>
+          <a:p>
+            <a:pPr>
+              <a:spcAft>
+                <a:spcPts val="400"/>
+              </a:spcAft>
+            </a:pPr>
+            <a:r>
+              <a:rPr sz="2400" b="1">
+                <a:solidFill>
+                  <a:srgbClr val="1F4E79"/>
+                </a:solidFill>
+                <a:latin typeface="Arial"/>
+              </a:rPr>
+              <a:t>Backup Slides</a:t>
+            </a:r>
+          </a:p>
+        </p:txBody>
+      </p:sp>
+      <p:sp>
+        <p:nvSpPr>
+          <p:cNvPr id="3" name="Rectangle 2"/>
+          <p:cNvSpPr/>
+          <p:nvPr/>
+        </p:nvSpPr>
+        <p:spPr>
+          <a:xfrm>
+            <a:off x="411480" y="914400"/>
+            <a:ext cx="11368735" cy="20320"/>
+          </a:xfrm>
+          <a:prstGeom prst="rect">
+            <a:avLst/>
+          </a:prstGeom>
+          <a:solidFill>
+            <a:srgbClr val="B8C6D4"/>
+          </a:solidFill>
+          <a:ln>
+            <a:noFill/>
+          </a:ln>
+          <a:effectLst/>
+        </p:spPr>
+        <p:style>
+          <a:lnRef idx="1">
+            <a:schemeClr val="accent1"/>
+          </a:lnRef>
+          <a:fillRef idx="3">
+            <a:schemeClr val="accent1"/>
+          </a:fillRef>
+          <a:effectRef idx="2">
+            <a:schemeClr val="accent1"/>
+          </a:effectRef>
+          <a:fontRef idx="minor">
+            <a:schemeClr val="lt1"/>
+          </a:fontRef>
+        </p:style>
+        <p:txBody>
+          <a:bodyPr rtlCol="0" anchor="ctr"/>
+          <a:lstStyle/>
+          <a:p>
+            <a:pPr algn="ctr"/>
+          </a:p>
+        </p:txBody>
+      </p:sp>
+    </p:spTree>
+  </p:cSld>
+  <p:clrMapOvr>
+    <a:masterClrMapping/>
+  </p:clrMapOvr>
+</p:sld>
+</file>
+
+<file path=ppt/slides/slide34.xml><?xml version="1.0" encoding="utf-8"?>
 <p:sld xmlns:a="http://schemas.openxmlformats.org/drawingml/2006/main" xmlns:p="http://schemas.openxmlformats.org/presentationml/2006/main" xmlns:r="http://schemas.openxmlformats.org/officeDocument/2006/relationships">
   <p:cSld>
     <p:spTree>
@@ -13593,7 +13884,7 @@
 </p:sld>
 </file>
 
-<file path=ppt/slides/slide34.xml><?xml version="1.0" encoding="utf-8"?>
+<file path=ppt/slides/slide35.xml><?xml version="1.0" encoding="utf-8"?>
 <p:sld xmlns:a="http://schemas.openxmlformats.org/drawingml/2006/main" xmlns:p="http://schemas.openxmlformats.org/presentationml/2006/main" xmlns:r="http://schemas.openxmlformats.org/officeDocument/2006/relationships">
   <p:cSld>
     <p:spTree>
@@ -14459,7 +14750,7 @@
 </p:sld>
 </file>
 
-<file path=ppt/slides/slide35.xml><?xml version="1.0" encoding="utf-8"?>
+<file path=ppt/slides/slide36.xml><?xml version="1.0" encoding="utf-8"?>
 <p:sld xmlns:a="http://schemas.openxmlformats.org/drawingml/2006/main" xmlns:p="http://schemas.openxmlformats.org/presentationml/2006/main" xmlns:r="http://schemas.openxmlformats.org/officeDocument/2006/relationships">
   <p:cSld>
     <p:spTree>
@@ -14666,351 +14957,6 @@
                 <a:latin typeface="Arial"/>
               </a:rPr>
               <a:t>Committed: deepest optic 1.887 m = 1.81× the spacing, the feed beam through the collimator by −79.9 mm.  Four-flat recipe: 0.893 m deep, but a fold is an isometry — the interference rides across — and it does not close on the cleared deck (96 routes, every admissible one loses rays).  Cleared −10°: 1.287 m = 1.24×, zero flats, +37.8 mm of daylight.  Record: challenges/afocal4/{packaging,clearing}.</a:t>
-            </a:r>
-          </a:p>
-        </p:txBody>
-      </p:sp>
-    </p:spTree>
-  </p:cSld>
-  <p:clrMapOvr>
-    <a:masterClrMapping/>
-  </p:clrMapOvr>
-</p:sld>
-</file>
-
-<file path=ppt/slides/slide36.xml><?xml version="1.0" encoding="utf-8"?>
-<p:sld xmlns:a="http://schemas.openxmlformats.org/drawingml/2006/main" xmlns:p="http://schemas.openxmlformats.org/presentationml/2006/main" xmlns:r="http://schemas.openxmlformats.org/officeDocument/2006/relationships">
-  <p:cSld>
-    <p:spTree>
-      <p:nvGrpSpPr>
-        <p:cNvPr id="1" name=""/>
-        <p:cNvGrpSpPr/>
-        <p:nvPr/>
-      </p:nvGrpSpPr>
-      <p:grpSpPr/>
-      <p:sp>
-        <p:nvSpPr>
-          <p:cNvPr id="2" name="TextBox 1"/>
-          <p:cNvSpPr txBox="1"/>
-          <p:nvPr/>
-        </p:nvSpPr>
-        <p:spPr>
-          <a:xfrm>
-            <a:off x="411480" y="201168"/>
-            <a:ext cx="11368735" cy="914400"/>
-          </a:xfrm>
-          <a:prstGeom prst="rect">
-            <a:avLst/>
-          </a:prstGeom>
-          <a:noFill/>
-        </p:spPr>
-        <p:txBody>
-          <a:bodyPr wrap="square">
-            <a:spAutoFit/>
-          </a:bodyPr>
-          <a:lstStyle/>
-          <a:p>
-            <a:pPr>
-              <a:spcAft>
-                <a:spcPts val="400"/>
-              </a:spcAft>
-            </a:pPr>
-            <a:r>
-              <a:rPr sz="2400" b="1">
-                <a:solidFill>
-                  <a:srgbClr val="1F4E79"/>
-                </a:solidFill>
-                <a:latin typeface="Arial"/>
-              </a:rPr>
-              <a:t>Interferometer demonstration backups</a:t>
-            </a:r>
-          </a:p>
-          <a:p>
-            <a:pPr>
-              <a:spcAft>
-                <a:spcPts val="0"/>
-              </a:spcAft>
-            </a:pPr>
-            <a:r>
-              <a:rPr sz="1250" b="0">
-                <a:solidFill>
-                  <a:srgbClr val="6E6E6E"/>
-                </a:solidFill>
-                <a:latin typeface="Arial"/>
-              </a:rPr>
-              <a:t>One committed image per live beat</a:t>
-            </a:r>
-          </a:p>
-        </p:txBody>
-      </p:sp>
-      <p:sp>
-        <p:nvSpPr>
-          <p:cNvPr id="3" name="Rectangle 2"/>
-          <p:cNvSpPr/>
-          <p:nvPr/>
-        </p:nvSpPr>
-        <p:spPr>
-          <a:xfrm>
-            <a:off x="411480" y="1133856"/>
-            <a:ext cx="11368735" cy="20320"/>
-          </a:xfrm>
-          <a:prstGeom prst="rect">
-            <a:avLst/>
-          </a:prstGeom>
-          <a:solidFill>
-            <a:srgbClr val="B8C6D4"/>
-          </a:solidFill>
-          <a:ln>
-            <a:noFill/>
-          </a:ln>
-          <a:effectLst/>
-        </p:spPr>
-        <p:style>
-          <a:lnRef idx="1">
-            <a:schemeClr val="accent1"/>
-          </a:lnRef>
-          <a:fillRef idx="3">
-            <a:schemeClr val="accent1"/>
-          </a:fillRef>
-          <a:effectRef idx="2">
-            <a:schemeClr val="accent1"/>
-          </a:effectRef>
-          <a:fontRef idx="minor">
-            <a:schemeClr val="lt1"/>
-          </a:fontRef>
-        </p:style>
-        <p:txBody>
-          <a:bodyPr rtlCol="0" anchor="ctr"/>
-          <a:lstStyle/>
-          <a:p>
-            <a:pPr algn="ctr"/>
-          </a:p>
-        </p:txBody>
-      </p:sp>
-      <p:pic>
-        <p:nvPicPr>
-          <p:cNvPr id="4" name="Picture 3" descr="demo2_beat5_poke.png"/>
-          <p:cNvPicPr>
-            <a:picLocks noChangeAspect="1"/>
-          </p:cNvPicPr>
-          <p:nvPr/>
-        </p:nvPicPr>
-        <p:blipFill>
-          <a:blip r:embed="rId2"/>
-          <a:stretch>
-            <a:fillRect/>
-          </a:stretch>
-        </p:blipFill>
-        <p:spPr>
-          <a:xfrm>
-            <a:off x="3772370" y="1298448"/>
-            <a:ext cx="4646955" cy="1782572"/>
-          </a:xfrm>
-          <a:prstGeom prst="rect">
-            <a:avLst/>
-          </a:prstGeom>
-        </p:spPr>
-      </p:pic>
-      <p:sp>
-        <p:nvSpPr>
-          <p:cNvPr id="5" name="TextBox 4"/>
-          <p:cNvSpPr txBox="1"/>
-          <p:nvPr/>
-        </p:nvSpPr>
-        <p:spPr>
-          <a:xfrm>
-            <a:off x="411480" y="3099308"/>
-            <a:ext cx="11368735" cy="229107"/>
-          </a:xfrm>
-          <a:prstGeom prst="rect">
-            <a:avLst/>
-          </a:prstGeom>
-          <a:noFill/>
-        </p:spPr>
-        <p:txBody>
-          <a:bodyPr wrap="square">
-            <a:spAutoFit/>
-          </a:bodyPr>
-          <a:lstStyle/>
-          <a:p>
-            <a:pPr algn="ctr">
-              <a:spcAft>
-                <a:spcPts val="0"/>
-              </a:spcAft>
-            </a:pPr>
-            <a:r>
-              <a:rPr sz="1000" b="0">
-                <a:solidFill>
-                  <a:srgbClr val="6E6E6E"/>
-                </a:solidFill>
-                <a:latin typeface="Arial"/>
-              </a:rPr>
-              <a:t>Beat 5 — one actuator poked: the fringes bend over it.</a:t>
-            </a:r>
-          </a:p>
-        </p:txBody>
-      </p:sp>
-      <p:pic>
-        <p:nvPicPr>
-          <p:cNvPr id="6" name="Picture 5" descr="demo2_beat6_sweep.png"/>
-          <p:cNvPicPr>
-            <a:picLocks noChangeAspect="1"/>
-          </p:cNvPicPr>
-          <p:nvPr/>
-        </p:nvPicPr>
-        <p:blipFill>
-          <a:blip r:embed="rId3"/>
-          <a:stretch>
-            <a:fillRect/>
-          </a:stretch>
-        </p:blipFill>
-        <p:spPr>
-          <a:xfrm>
-            <a:off x="4186821" y="3364992"/>
-            <a:ext cx="3818051" cy="1782572"/>
-          </a:xfrm>
-          <a:prstGeom prst="rect">
-            <a:avLst/>
-          </a:prstGeom>
-        </p:spPr>
-      </p:pic>
-      <p:sp>
-        <p:nvSpPr>
-          <p:cNvPr id="7" name="TextBox 6"/>
-          <p:cNvSpPr txBox="1"/>
-          <p:nvPr/>
-        </p:nvSpPr>
-        <p:spPr>
-          <a:xfrm>
-            <a:off x="411480" y="5165852"/>
-            <a:ext cx="11368735" cy="229107"/>
-          </a:xfrm>
-          <a:prstGeom prst="rect">
-            <a:avLst/>
-          </a:prstGeom>
-          <a:noFill/>
-        </p:spPr>
-        <p:txBody>
-          <a:bodyPr wrap="square">
-            <a:spAutoFit/>
-          </a:bodyPr>
-          <a:lstStyle/>
-          <a:p>
-            <a:pPr algn="ctr">
-              <a:spcAft>
-                <a:spcPts val="0"/>
-              </a:spcAft>
-            </a:pPr>
-            <a:r>
-              <a:rPr sz="1000" b="0">
-                <a:solidFill>
-                  <a:srgbClr val="6E6E6E"/>
-                </a:solidFill>
-                <a:latin typeface="Arial"/>
-              </a:rPr>
-              <a:t>Beat 6 — the analyzer sweep: phase-stepped frames, no re-trace.</a:t>
-            </a:r>
-          </a:p>
-        </p:txBody>
-      </p:sp>
-      <p:pic>
-        <p:nvPicPr>
-          <p:cNvPr id="8" name="Picture 7" descr="demo2_beat7_recovery.png"/>
-          <p:cNvPicPr>
-            <a:picLocks noChangeAspect="1"/>
-          </p:cNvPicPr>
-          <p:nvPr/>
-        </p:nvPicPr>
-        <p:blipFill>
-          <a:blip r:embed="rId4"/>
-          <a:stretch>
-            <a:fillRect/>
-          </a:stretch>
-        </p:blipFill>
-        <p:spPr>
-          <a:xfrm>
-            <a:off x="4177857" y="5431536"/>
-            <a:ext cx="3835980" cy="1032763"/>
-          </a:xfrm>
-          <a:prstGeom prst="rect">
-            <a:avLst/>
-          </a:prstGeom>
-        </p:spPr>
-      </p:pic>
-      <p:sp>
-        <p:nvSpPr>
-          <p:cNvPr id="9" name="TextBox 8"/>
-          <p:cNvSpPr txBox="1"/>
-          <p:nvPr/>
-        </p:nvSpPr>
-        <p:spPr>
-          <a:xfrm>
-            <a:off x="411480" y="6482588"/>
-            <a:ext cx="11368735" cy="229107"/>
-          </a:xfrm>
-          <a:prstGeom prst="rect">
-            <a:avLst/>
-          </a:prstGeom>
-          <a:noFill/>
-        </p:spPr>
-        <p:txBody>
-          <a:bodyPr wrap="square">
-            <a:spAutoFit/>
-          </a:bodyPr>
-          <a:lstStyle/>
-          <a:p>
-            <a:pPr algn="ctr">
-              <a:spcAft>
-                <a:spcPts val="0"/>
-              </a:spcAft>
-            </a:pPr>
-            <a:r>
-              <a:rPr sz="1000" b="0">
-                <a:solidFill>
-                  <a:srgbClr val="6E6E6E"/>
-                </a:solidFill>
-                <a:latin typeface="Arial"/>
-              </a:rPr>
-              <a:t>Beat 7 — the recovery beside the truth map.</a:t>
-            </a:r>
-          </a:p>
-        </p:txBody>
-      </p:sp>
-      <p:sp>
-        <p:nvSpPr>
-          <p:cNvPr id="10" name="TextBox 9"/>
-          <p:cNvSpPr txBox="1"/>
-          <p:nvPr/>
-        </p:nvSpPr>
-        <p:spPr>
-          <a:xfrm>
-            <a:off x="411480" y="6748272"/>
-            <a:ext cx="11368735" cy="274320"/>
-          </a:xfrm>
-          <a:prstGeom prst="rect">
-            <a:avLst/>
-          </a:prstGeom>
-          <a:noFill/>
-        </p:spPr>
-        <p:txBody>
-          <a:bodyPr wrap="square">
-            <a:spAutoFit/>
-          </a:bodyPr>
-          <a:lstStyle/>
-          <a:p>
-            <a:pPr>
-              <a:spcAft>
-                <a:spcPts val="600"/>
-              </a:spcAft>
-            </a:pPr>
-            <a:r>
-              <a:rPr sz="1050" b="0">
-                <a:solidFill>
-                  <a:srgbClr val="6E6E6E"/>
-                </a:solidFill>
-                <a:latin typeface="Arial"/>
-              </a:rPr>
-              <a:t>All eight beats have committed figures in templates/90_polarization/tg_psi_dm_v2 (v1 likewise); the driver opens them on the desktop as each beat runs.</a:t>
             </a:r>
           </a:p>
         </p:txBody>
@@ -15067,7 +15013,7 @@
                 </a:solidFill>
                 <a:latin typeface="Arial"/>
               </a:rPr>
-              <a:t>The e2e worked example: specification to design</a:t>
+              <a:t>Interferometer demonstration backups</a:t>
             </a:r>
           </a:p>
           <a:p>
@@ -15083,7 +15029,7 @@
                 </a:solidFill>
                 <a:latin typeface="Arial"/>
               </a:rPr>
-              <a:t>A 4 m f/18 visible-band telescope from a closed-form seed — no starting prescription</a:t>
+              <a:t>One committed image per live beat</a:t>
             </a:r>
           </a:p>
         </p:txBody>
@@ -15132,64 +15078,9 @@
           </a:p>
         </p:txBody>
       </p:sp>
-      <p:sp>
-        <p:nvSpPr>
-          <p:cNvPr id="4" name="TextBox 3"/>
-          <p:cNvSpPr txBox="1"/>
-          <p:nvPr/>
-        </p:nvSpPr>
-        <p:spPr>
-          <a:xfrm>
-            <a:off x="411480" y="1298448"/>
-            <a:ext cx="5806440" cy="274320"/>
-          </a:xfrm>
-          <a:prstGeom prst="rect">
-            <a:avLst/>
-          </a:prstGeom>
-          <a:noFill/>
-        </p:spPr>
-        <p:txBody>
-          <a:bodyPr wrap="square">
-            <a:spAutoFit/>
-          </a:bodyPr>
-          <a:lstStyle/>
-          <a:p>
-            <a:pPr>
-              <a:spcAft>
-                <a:spcPts val="600"/>
-              </a:spcAft>
-            </a:pPr>
-            <a:r>
-              <a:rPr sz="1200" b="0">
-                <a:solidFill>
-                  <a:srgbClr val="282828"/>
-                </a:solidFill>
-                <a:latin typeface="Arial"/>
-              </a:rPr>
-              <a:t>•  The stage-runner sequence on the smaller worked example: specification → design → segmentation → metrology → comparison → simulation, each stage a committed runner handing its prescription to the next.</a:t>
-            </a:r>
-          </a:p>
-          <a:p>
-            <a:pPr>
-              <a:spcAft>
-                <a:spcPts val="600"/>
-              </a:spcAft>
-            </a:pPr>
-            <a:r>
-              <a:rPr sz="1200" b="0">
-                <a:solidFill>
-                  <a:srgbClr val="282828"/>
-                </a:solidFill>
-                <a:latin typeface="Arial"/>
-              </a:rPr>
-              <a:t>•  A 4 m f/18 telescope (f/1.75 primary) from a closed-form first-order seed; diffraction-limited over ±1′ alone, and the Offner ring-field relay buys the full ±2′ (Strehl floor 0.965, on pure spheres).</a:t>
-            </a:r>
-          </a:p>
-        </p:txBody>
-      </p:sp>
       <p:pic>
         <p:nvPicPr>
-          <p:cNvPr id="5" name="Picture 4" descr="rowpair_s1_views.png"/>
+          <p:cNvPr id="4" name="Picture 3" descr="demo2_beat5_poke.png"/>
           <p:cNvPicPr>
             <a:picLocks noChangeAspect="1"/>
           </p:cNvPicPr>
@@ -15203,8 +15094,8 @@
         </p:blipFill>
         <p:spPr>
           <a:xfrm>
-            <a:off x="6738659" y="1298448"/>
-            <a:ext cx="4719240" cy="2056892"/>
+            <a:off x="3772370" y="1298448"/>
+            <a:ext cx="4646955" cy="1782572"/>
           </a:xfrm>
           <a:prstGeom prst="rect">
             <a:avLst/>
@@ -15213,14 +15104,14 @@
       </p:pic>
       <p:sp>
         <p:nvSpPr>
-          <p:cNvPr id="6" name="TextBox 5"/>
+          <p:cNvPr id="5" name="TextBox 4"/>
           <p:cNvSpPr txBox="1"/>
           <p:nvPr/>
         </p:nvSpPr>
         <p:spPr>
           <a:xfrm>
-            <a:off x="6400800" y="3373628"/>
-            <a:ext cx="5394960" cy="229107"/>
+            <a:off x="411480" y="3099308"/>
+            <a:ext cx="11368735" cy="229107"/>
           </a:xfrm>
           <a:prstGeom prst="rect">
             <a:avLst/>
@@ -15245,14 +15136,14 @@
                 </a:solidFill>
                 <a:latin typeface="Arial"/>
               </a:rPr>
-              <a:t>The telescope as designed (front + iso views), with the traced field.</a:t>
+              <a:t>Beat 5 — one actuator poked: the fringes bend over it.</a:t>
             </a:r>
           </a:p>
         </p:txBody>
       </p:sp>
       <p:pic>
         <p:nvPicPr>
-          <p:cNvPr id="7" name="Picture 6" descr="s1_wfe_field.png"/>
+          <p:cNvPr id="6" name="Picture 5" descr="demo2_beat6_sweep.png"/>
           <p:cNvPicPr>
             <a:picLocks noChangeAspect="1"/>
           </p:cNvPicPr>
@@ -15266,8 +15157,8 @@
         </p:blipFill>
         <p:spPr>
           <a:xfrm>
-            <a:off x="7993860" y="3639312"/>
-            <a:ext cx="2208839" cy="1782572"/>
+            <a:off x="4186821" y="3364992"/>
+            <a:ext cx="3818051" cy="1782572"/>
           </a:xfrm>
           <a:prstGeom prst="rect">
             <a:avLst/>
@@ -15276,14 +15167,14 @@
       </p:pic>
       <p:sp>
         <p:nvSpPr>
-          <p:cNvPr id="8" name="TextBox 7"/>
+          <p:cNvPr id="7" name="TextBox 6"/>
           <p:cNvSpPr txBox="1"/>
           <p:nvPr/>
         </p:nvSpPr>
         <p:spPr>
           <a:xfrm>
-            <a:off x="6400800" y="5440171"/>
-            <a:ext cx="5394960" cy="229107"/>
+            <a:off x="411480" y="5165852"/>
+            <a:ext cx="11368735" cy="229107"/>
           </a:xfrm>
           <a:prstGeom prst="rect">
             <a:avLst/>
@@ -15308,11 +15199,35 @@
                 </a:solidFill>
                 <a:latin typeface="Arial"/>
               </a:rPr>
-              <a:t>Wavefront error over the field: diffraction-limited across the box.</a:t>
-            </a:r>
-          </a:p>
-        </p:txBody>
-      </p:sp>
+              <a:t>Beat 6 — the analyzer sweep: phase-stepped frames, no re-trace.</a:t>
+            </a:r>
+          </a:p>
+        </p:txBody>
+      </p:sp>
+      <p:pic>
+        <p:nvPicPr>
+          <p:cNvPr id="8" name="Picture 7" descr="demo2_beat7_recovery.png"/>
+          <p:cNvPicPr>
+            <a:picLocks noChangeAspect="1"/>
+          </p:cNvPicPr>
+          <p:nvPr/>
+        </p:nvPicPr>
+        <p:blipFill>
+          <a:blip r:embed="rId4"/>
+          <a:stretch>
+            <a:fillRect/>
+          </a:stretch>
+        </p:blipFill>
+        <p:spPr>
+          <a:xfrm>
+            <a:off x="4177857" y="5431536"/>
+            <a:ext cx="3835980" cy="1032763"/>
+          </a:xfrm>
+          <a:prstGeom prst="rect">
+            <a:avLst/>
+          </a:prstGeom>
+        </p:spPr>
+      </p:pic>
       <p:sp>
         <p:nvSpPr>
           <p:cNvPr id="9" name="TextBox 8"/>
@@ -15321,8 +15236,8 @@
         </p:nvSpPr>
         <p:spPr>
           <a:xfrm>
-            <a:off x="6400800" y="5705855"/>
-            <a:ext cx="5394960" cy="274320"/>
+            <a:off x="411480" y="6482588"/>
+            <a:ext cx="11368735" cy="229107"/>
           </a:xfrm>
           <a:prstGeom prst="rect">
             <a:avLst/>
@@ -15335,6 +15250,45 @@
           </a:bodyPr>
           <a:lstStyle/>
           <a:p>
+            <a:pPr algn="ctr">
+              <a:spcAft>
+                <a:spcPts val="0"/>
+              </a:spcAft>
+            </a:pPr>
+            <a:r>
+              <a:rPr sz="1000" b="0">
+                <a:solidFill>
+                  <a:srgbClr val="6E6E6E"/>
+                </a:solidFill>
+                <a:latin typeface="Arial"/>
+              </a:rPr>
+              <a:t>Beat 7 — the recovery beside the truth map.</a:t>
+            </a:r>
+          </a:p>
+        </p:txBody>
+      </p:sp>
+      <p:sp>
+        <p:nvSpPr>
+          <p:cNvPr id="10" name="TextBox 9"/>
+          <p:cNvSpPr txBox="1"/>
+          <p:nvPr/>
+        </p:nvSpPr>
+        <p:spPr>
+          <a:xfrm>
+            <a:off x="411480" y="6748272"/>
+            <a:ext cx="11368735" cy="274320"/>
+          </a:xfrm>
+          <a:prstGeom prst="rect">
+            <a:avLst/>
+          </a:prstGeom>
+          <a:noFill/>
+        </p:spPr>
+        <p:txBody>
+          <a:bodyPr wrap="square">
+            <a:spAutoFit/>
+          </a:bodyPr>
+          <a:lstStyle/>
+          <a:p>
             <a:pPr>
               <a:spcAft>
                 <a:spcPts val="600"/>
@@ -15347,7 +15301,7 @@
                 </a:solidFill>
                 <a:latin typeface="Arial"/>
               </a:rPr>
-              <a:t>Record: templates/80_end_to_end/e2e — staged worked example, committed at every step.</a:t>
+              <a:t>All eight beats have committed figures in templates/90_polarization/tg_psi_dm_v2 (v1 likewise); the driver opens them on the desktop as each beat runs.</a:t>
             </a:r>
           </a:p>
         </p:txBody>
@@ -15404,7 +15358,7 @@
                 </a:solidFill>
                 <a:latin typeface="Arial"/>
               </a:rPr>
-              <a:t>The e2e worked example: segmentation and metrology</a:t>
+              <a:t>The e2e worked example: specification to design</a:t>
             </a:r>
           </a:p>
           <a:p>
@@ -15420,7 +15374,7 @@
                 </a:solidFill>
                 <a:latin typeface="Arial"/>
               </a:rPr>
-              <a:t>The monolith segments in one call; the metrology is designed on the same Jacobian</a:t>
+              <a:t>A 4 m f/18 visible-band telescope from a closed-form seed — no starting prescription</a:t>
             </a:r>
           </a:p>
         </p:txBody>
@@ -15503,7 +15457,7 @@
                 </a:solidFill>
                 <a:latin typeface="Arial"/>
               </a:rPr>
-              <a:t>•  The primary segments into a pie or hex tiling with physical apertures; every segment gets rigid-body and surface-figure sensitivity channels, stacked into one Jacobian — the control basis.</a:t>
+              <a:t>•  The stage-runner sequence on the smaller worked example: specification → design → segmentation → metrology → comparison → simulation, each stage a committed runner handing its prescription to the next.</a:t>
             </a:r>
           </a:p>
           <a:p>
@@ -15519,14 +15473,14 @@
                 </a:solidFill>
                 <a:latin typeface="Arial"/>
               </a:rPr>
-              <a:t>•  Metrology is an optimization on that basis: edge-sensor and beam-launcher layouts scored by the control information they carry, not by symmetry; the winning pattern exports as a reusable preset.</a:t>
+              <a:t>•  A 4 m f/18 telescope (f/1.75 primary) from a closed-form first-order seed; diffraction-limited over ±1′ alone, and the Offner ring-field relay buys the full ±2′ (Strehl floor 0.965, on pure spheres).</a:t>
             </a:r>
           </a:p>
         </p:txBody>
       </p:sp>
       <p:pic>
         <p:nvPicPr>
-          <p:cNvPr id="5" name="Picture 4" descr="rowpair_s3_views_pie.png"/>
+          <p:cNvPr id="5" name="Picture 4" descr="rowpair_s1_views.png"/>
           <p:cNvPicPr>
             <a:picLocks noChangeAspect="1"/>
           </p:cNvPicPr>
@@ -15540,8 +15494,8 @@
         </p:blipFill>
         <p:spPr>
           <a:xfrm>
-            <a:off x="6618167" y="1298448"/>
-            <a:ext cx="4960224" cy="1965451"/>
+            <a:off x="6738659" y="1298448"/>
+            <a:ext cx="4719240" cy="2056892"/>
           </a:xfrm>
           <a:prstGeom prst="rect">
             <a:avLst/>
@@ -15556,7 +15510,7 @@
         </p:nvSpPr>
         <p:spPr>
           <a:xfrm>
-            <a:off x="6400800" y="3282188"/>
+            <a:off x="6400800" y="3373628"/>
             <a:ext cx="5394960" cy="229107"/>
           </a:xfrm>
           <a:prstGeom prst="rect">
@@ -15582,14 +15536,14 @@
                 </a:solidFill>
                 <a:latin typeface="Arial"/>
               </a:rPr>
-              <a:t>The segmented primary with physical apertures (front + iso views).</a:t>
+              <a:t>The telescope as designed (front + iso views), with the traced field.</a:t>
             </a:r>
           </a:p>
         </p:txBody>
       </p:sp>
       <p:pic>
         <p:nvPicPr>
-          <p:cNvPr id="7" name="Picture 6" descr="e2e_pie_met_view_rx.png"/>
+          <p:cNvPr id="7" name="Picture 6" descr="s1_wfe_field.png"/>
           <p:cNvPicPr>
             <a:picLocks noChangeAspect="1"/>
           </p:cNvPicPr>
@@ -15603,8 +15557,8 @@
         </p:blipFill>
         <p:spPr>
           <a:xfrm>
-            <a:off x="7662896" y="3547872"/>
-            <a:ext cx="2870767" cy="1874011"/>
+            <a:off x="7993860" y="3639312"/>
+            <a:ext cx="2208839" cy="1782572"/>
           </a:xfrm>
           <a:prstGeom prst="rect">
             <a:avLst/>
@@ -15645,7 +15599,7 @@
                 </a:solidFill>
                 <a:latin typeface="Arial"/>
               </a:rPr>
-              <a:t>The optimized metrology layout on the segmented primary.</a:t>
+              <a:t>Wavefront error over the field: diffraction-limited across the box.</a:t>
             </a:r>
           </a:p>
         </p:txBody>
@@ -15684,7 +15638,7 @@
                 </a:solidFill>
                 <a:latin typeface="Arial"/>
               </a:rPr>
-              <a:t>Record: templates/80_end_to_end/e2e, stages 3–5.</a:t>
+              <a:t>Record: templates/80_end_to_end/e2e — staged worked example, committed at every step.</a:t>
             </a:r>
           </a:p>
         </p:txBody>
@@ -15741,7 +15695,7 @@
                 </a:solidFill>
                 <a:latin typeface="Arial"/>
               </a:rPr>
-              <a:t>The e2e worked example: comparison and simulation</a:t>
+              <a:t>The e2e worked example: segmentation and metrology</a:t>
             </a:r>
           </a:p>
           <a:p>
@@ -15757,7 +15711,7 @@
                 </a:solidFill>
                 <a:latin typeface="Arial"/>
               </a:rPr>
-              <a:t>Segment drift of 10⁵ nm rms is sensed and held at ~7 nm corrected</a:t>
+              <a:t>The monolith segments in one call; the metrology is designed on the same Jacobian</a:t>
             </a:r>
           </a:p>
         </p:txBody>
@@ -15815,7 +15769,7 @@
         <p:spPr>
           <a:xfrm>
             <a:off x="411480" y="1298448"/>
-            <a:ext cx="11368735" cy="274320"/>
+            <a:ext cx="5806440" cy="274320"/>
           </a:xfrm>
           <a:prstGeom prst="rect">
             <a:avLst/>
@@ -15834,20 +15788,36 @@
               </a:spcAft>
             </a:pPr>
             <a:r>
-              <a:rPr sz="1500" b="0">
+              <a:rPr sz="1200" b="0">
                 <a:solidFill>
                   <a:srgbClr val="282828"/>
                 </a:solidFill>
                 <a:latin typeface="Arial"/>
               </a:rPr>
-              <a:t>•  Every linear model is checked against the engine before it is trusted: step each channel, re-trace, render engine and model side by side (left).  Then the simulator closes the loop on the same model: inject drift, sense with the designed metrology, estimate, correct (right).</a:t>
+              <a:t>•  The primary segments into a pie or hex tiling with physical apertures; every segment gets rigid-body and surface-figure sensitivity channels, stacked into one Jacobian — the control basis.</a:t>
+            </a:r>
+          </a:p>
+          <a:p>
+            <a:pPr>
+              <a:spcAft>
+                <a:spcPts val="600"/>
+              </a:spcAft>
+            </a:pPr>
+            <a:r>
+              <a:rPr sz="1200" b="0">
+                <a:solidFill>
+                  <a:srgbClr val="282828"/>
+                </a:solidFill>
+                <a:latin typeface="Arial"/>
+              </a:rPr>
+              <a:t>•  Metrology is an optimization on that basis: edge-sensor and beam-launcher layouts scored by the control information they carry, not by symmetry; the winning pattern exports as a reusable preset.</a:t>
             </a:r>
           </a:p>
         </p:txBody>
       </p:sp>
       <p:pic>
         <p:nvPicPr>
-          <p:cNvPr id="5" name="Picture 4" descr="e2e_compare_p001.png"/>
+          <p:cNvPr id="5" name="Picture 4" descr="rowpair_s3_views_pie.png"/>
           <p:cNvPicPr>
             <a:picLocks noChangeAspect="1"/>
           </p:cNvPicPr>
@@ -15861,8 +15831,8 @@
         </p:blipFill>
         <p:spPr>
           <a:xfrm>
-            <a:off x="1466756" y="2218182"/>
-            <a:ext cx="3695887" cy="2714752"/>
+            <a:off x="6618167" y="1298448"/>
+            <a:ext cx="4960224" cy="1965451"/>
           </a:xfrm>
           <a:prstGeom prst="rect">
             <a:avLst/>
@@ -15877,8 +15847,8 @@
         </p:nvSpPr>
         <p:spPr>
           <a:xfrm>
-            <a:off x="411480" y="4951222"/>
-            <a:ext cx="5806440" cy="394208"/>
+            <a:off x="6400800" y="3282188"/>
+            <a:ext cx="5394960" cy="229107"/>
           </a:xfrm>
           <a:prstGeom prst="rect">
             <a:avLst/>
@@ -15903,14 +15873,14 @@
                 </a:solidFill>
                 <a:latin typeface="Arial"/>
               </a:rPr>
-              <a:t>The comparison stage: engine re-trace vs linear model, one perturbation channel (segment 1 Rx, +100 nrad).</a:t>
+              <a:t>The segmented primary with physical apertures (front + iso views).</a:t>
             </a:r>
           </a:p>
         </p:txBody>
       </p:sp>
       <p:pic>
         <p:nvPicPr>
-          <p:cNvPr id="7" name="Picture 6" descr="e2e_sim_t007.png"/>
+          <p:cNvPr id="7" name="Picture 6" descr="e2e_pie_met_view_rx.png"/>
           <p:cNvPicPr>
             <a:picLocks noChangeAspect="1"/>
           </p:cNvPicPr>
@@ -15924,8 +15894,8 @@
         </p:blipFill>
         <p:spPr>
           <a:xfrm>
-            <a:off x="6784520" y="2218182"/>
-            <a:ext cx="4627519" cy="2714752"/>
+            <a:off x="7662896" y="3547872"/>
+            <a:ext cx="2870767" cy="1874011"/>
           </a:xfrm>
           <a:prstGeom prst="rect">
             <a:avLst/>
@@ -15940,8 +15910,8 @@
         </p:nvSpPr>
         <p:spPr>
           <a:xfrm>
-            <a:off x="6400800" y="4951222"/>
-            <a:ext cx="5394960" cy="394208"/>
+            <a:off x="6400800" y="5440171"/>
+            <a:ext cx="5394960" cy="229107"/>
           </a:xfrm>
           <a:prstGeom prst="rect">
             <a:avLst/>
@@ -15966,7 +15936,7 @@
                 </a:solidFill>
                 <a:latin typeface="Arial"/>
               </a:rPr>
-              <a:t>The simulator at t = 70 s: uncorrected 1.0×10⁵ nm vs 6.8 nm corrected; accumulating WFE and Strehl vs time below.</a:t>
+              <a:t>The optimized metrology layout on the segmented primary.</a:t>
             </a:r>
           </a:p>
         </p:txBody>
@@ -15979,7 +15949,7 @@
         </p:nvSpPr>
         <p:spPr>
           <a:xfrm>
-            <a:off x="6400800" y="5382006"/>
+            <a:off x="6400800" y="5705855"/>
             <a:ext cx="5394960" cy="274320"/>
           </a:xfrm>
           <a:prstGeom prst="rect">
@@ -16005,7 +15975,7 @@
                 </a:solidFill>
                 <a:latin typeface="Arial"/>
               </a:rPr>
-              <a:t>Record: templates/80_end_to_end/e2e, comparison + simulator stages (s6/s7).</a:t>
+              <a:t>Record: templates/80_end_to_end/e2e, stages 3–5.</a:t>
             </a:r>
           </a:p>
         </p:txBody>
@@ -16186,6 +16156,327 @@
                 <a:latin typeface="Arial"/>
               </a:rPr>
               <a:t>Counts as of 2026-08.  Every area is exercised by the committed test suites and by the worked examples beside it — the same templates this talk's studies live in.</a:t>
+            </a:r>
+          </a:p>
+        </p:txBody>
+      </p:sp>
+    </p:spTree>
+  </p:cSld>
+  <p:clrMapOvr>
+    <a:masterClrMapping/>
+  </p:clrMapOvr>
+</p:sld>
+</file>
+
+<file path=ppt/slides/slide40.xml><?xml version="1.0" encoding="utf-8"?>
+<p:sld xmlns:a="http://schemas.openxmlformats.org/drawingml/2006/main" xmlns:p="http://schemas.openxmlformats.org/presentationml/2006/main" xmlns:r="http://schemas.openxmlformats.org/officeDocument/2006/relationships">
+  <p:cSld>
+    <p:spTree>
+      <p:nvGrpSpPr>
+        <p:cNvPr id="1" name=""/>
+        <p:cNvGrpSpPr/>
+        <p:nvPr/>
+      </p:nvGrpSpPr>
+      <p:grpSpPr/>
+      <p:sp>
+        <p:nvSpPr>
+          <p:cNvPr id="2" name="TextBox 1"/>
+          <p:cNvSpPr txBox="1"/>
+          <p:nvPr/>
+        </p:nvSpPr>
+        <p:spPr>
+          <a:xfrm>
+            <a:off x="411480" y="201168"/>
+            <a:ext cx="11368735" cy="914400"/>
+          </a:xfrm>
+          <a:prstGeom prst="rect">
+            <a:avLst/>
+          </a:prstGeom>
+          <a:noFill/>
+        </p:spPr>
+        <p:txBody>
+          <a:bodyPr wrap="square">
+            <a:spAutoFit/>
+          </a:bodyPr>
+          <a:lstStyle/>
+          <a:p>
+            <a:pPr>
+              <a:spcAft>
+                <a:spcPts val="400"/>
+              </a:spcAft>
+            </a:pPr>
+            <a:r>
+              <a:rPr sz="2400" b="1">
+                <a:solidFill>
+                  <a:srgbClr val="1F4E79"/>
+                </a:solidFill>
+                <a:latin typeface="Arial"/>
+              </a:rPr>
+              <a:t>The e2e worked example: comparison and simulation</a:t>
+            </a:r>
+          </a:p>
+          <a:p>
+            <a:pPr>
+              <a:spcAft>
+                <a:spcPts val="0"/>
+              </a:spcAft>
+            </a:pPr>
+            <a:r>
+              <a:rPr sz="1250" b="0">
+                <a:solidFill>
+                  <a:srgbClr val="6E6E6E"/>
+                </a:solidFill>
+                <a:latin typeface="Arial"/>
+              </a:rPr>
+              <a:t>Segment drift of 10⁵ nm rms is sensed and held at ~7 nm corrected</a:t>
+            </a:r>
+          </a:p>
+        </p:txBody>
+      </p:sp>
+      <p:sp>
+        <p:nvSpPr>
+          <p:cNvPr id="3" name="Rectangle 2"/>
+          <p:cNvSpPr/>
+          <p:nvPr/>
+        </p:nvSpPr>
+        <p:spPr>
+          <a:xfrm>
+            <a:off x="411480" y="1133856"/>
+            <a:ext cx="11368735" cy="20320"/>
+          </a:xfrm>
+          <a:prstGeom prst="rect">
+            <a:avLst/>
+          </a:prstGeom>
+          <a:solidFill>
+            <a:srgbClr val="B8C6D4"/>
+          </a:solidFill>
+          <a:ln>
+            <a:noFill/>
+          </a:ln>
+          <a:effectLst/>
+        </p:spPr>
+        <p:style>
+          <a:lnRef idx="1">
+            <a:schemeClr val="accent1"/>
+          </a:lnRef>
+          <a:fillRef idx="3">
+            <a:schemeClr val="accent1"/>
+          </a:fillRef>
+          <a:effectRef idx="2">
+            <a:schemeClr val="accent1"/>
+          </a:effectRef>
+          <a:fontRef idx="minor">
+            <a:schemeClr val="lt1"/>
+          </a:fontRef>
+        </p:style>
+        <p:txBody>
+          <a:bodyPr rtlCol="0" anchor="ctr"/>
+          <a:lstStyle/>
+          <a:p>
+            <a:pPr algn="ctr"/>
+          </a:p>
+        </p:txBody>
+      </p:sp>
+      <p:sp>
+        <p:nvSpPr>
+          <p:cNvPr id="4" name="TextBox 3"/>
+          <p:cNvSpPr txBox="1"/>
+          <p:nvPr/>
+        </p:nvSpPr>
+        <p:spPr>
+          <a:xfrm>
+            <a:off x="411480" y="1298448"/>
+            <a:ext cx="11368735" cy="274320"/>
+          </a:xfrm>
+          <a:prstGeom prst="rect">
+            <a:avLst/>
+          </a:prstGeom>
+          <a:noFill/>
+        </p:spPr>
+        <p:txBody>
+          <a:bodyPr wrap="square">
+            <a:spAutoFit/>
+          </a:bodyPr>
+          <a:lstStyle/>
+          <a:p>
+            <a:pPr>
+              <a:spcAft>
+                <a:spcPts val="600"/>
+              </a:spcAft>
+            </a:pPr>
+            <a:r>
+              <a:rPr sz="1500" b="0">
+                <a:solidFill>
+                  <a:srgbClr val="282828"/>
+                </a:solidFill>
+                <a:latin typeface="Arial"/>
+              </a:rPr>
+              <a:t>•  Every linear model is checked against the engine before it is trusted: step each channel, re-trace, render engine and model side by side (left).  Then the simulator closes the loop on the same model: inject drift, sense with the designed metrology, estimate, correct (right).</a:t>
+            </a:r>
+          </a:p>
+        </p:txBody>
+      </p:sp>
+      <p:pic>
+        <p:nvPicPr>
+          <p:cNvPr id="5" name="Picture 4" descr="e2e_compare_p001.png"/>
+          <p:cNvPicPr>
+            <a:picLocks noChangeAspect="1"/>
+          </p:cNvPicPr>
+          <p:nvPr/>
+        </p:nvPicPr>
+        <p:blipFill>
+          <a:blip r:embed="rId2"/>
+          <a:stretch>
+            <a:fillRect/>
+          </a:stretch>
+        </p:blipFill>
+        <p:spPr>
+          <a:xfrm>
+            <a:off x="1466756" y="2218182"/>
+            <a:ext cx="3695887" cy="2714752"/>
+          </a:xfrm>
+          <a:prstGeom prst="rect">
+            <a:avLst/>
+          </a:prstGeom>
+        </p:spPr>
+      </p:pic>
+      <p:sp>
+        <p:nvSpPr>
+          <p:cNvPr id="6" name="TextBox 5"/>
+          <p:cNvSpPr txBox="1"/>
+          <p:nvPr/>
+        </p:nvSpPr>
+        <p:spPr>
+          <a:xfrm>
+            <a:off x="411480" y="4951222"/>
+            <a:ext cx="5806440" cy="394208"/>
+          </a:xfrm>
+          <a:prstGeom prst="rect">
+            <a:avLst/>
+          </a:prstGeom>
+          <a:noFill/>
+        </p:spPr>
+        <p:txBody>
+          <a:bodyPr wrap="square">
+            <a:spAutoFit/>
+          </a:bodyPr>
+          <a:lstStyle/>
+          <a:p>
+            <a:pPr algn="ctr">
+              <a:spcAft>
+                <a:spcPts val="0"/>
+              </a:spcAft>
+            </a:pPr>
+            <a:r>
+              <a:rPr sz="1000" b="0">
+                <a:solidFill>
+                  <a:srgbClr val="6E6E6E"/>
+                </a:solidFill>
+                <a:latin typeface="Arial"/>
+              </a:rPr>
+              <a:t>The comparison stage: engine re-trace vs linear model, one perturbation channel (segment 1 Rx, +100 nrad).</a:t>
+            </a:r>
+          </a:p>
+        </p:txBody>
+      </p:sp>
+      <p:pic>
+        <p:nvPicPr>
+          <p:cNvPr id="7" name="Picture 6" descr="e2e_sim_t007.png"/>
+          <p:cNvPicPr>
+            <a:picLocks noChangeAspect="1"/>
+          </p:cNvPicPr>
+          <p:nvPr/>
+        </p:nvPicPr>
+        <p:blipFill>
+          <a:blip r:embed="rId3"/>
+          <a:stretch>
+            <a:fillRect/>
+          </a:stretch>
+        </p:blipFill>
+        <p:spPr>
+          <a:xfrm>
+            <a:off x="6784520" y="2218182"/>
+            <a:ext cx="4627519" cy="2714752"/>
+          </a:xfrm>
+          <a:prstGeom prst="rect">
+            <a:avLst/>
+          </a:prstGeom>
+        </p:spPr>
+      </p:pic>
+      <p:sp>
+        <p:nvSpPr>
+          <p:cNvPr id="8" name="TextBox 7"/>
+          <p:cNvSpPr txBox="1"/>
+          <p:nvPr/>
+        </p:nvSpPr>
+        <p:spPr>
+          <a:xfrm>
+            <a:off x="6400800" y="4951222"/>
+            <a:ext cx="5394960" cy="394208"/>
+          </a:xfrm>
+          <a:prstGeom prst="rect">
+            <a:avLst/>
+          </a:prstGeom>
+          <a:noFill/>
+        </p:spPr>
+        <p:txBody>
+          <a:bodyPr wrap="square">
+            <a:spAutoFit/>
+          </a:bodyPr>
+          <a:lstStyle/>
+          <a:p>
+            <a:pPr algn="ctr">
+              <a:spcAft>
+                <a:spcPts val="0"/>
+              </a:spcAft>
+            </a:pPr>
+            <a:r>
+              <a:rPr sz="1000" b="0">
+                <a:solidFill>
+                  <a:srgbClr val="6E6E6E"/>
+                </a:solidFill>
+                <a:latin typeface="Arial"/>
+              </a:rPr>
+              <a:t>The simulator at t = 70 s: uncorrected 1.0×10⁵ nm vs 6.8 nm corrected; accumulating WFE and Strehl vs time below.</a:t>
+            </a:r>
+          </a:p>
+        </p:txBody>
+      </p:sp>
+      <p:sp>
+        <p:nvSpPr>
+          <p:cNvPr id="9" name="TextBox 8"/>
+          <p:cNvSpPr txBox="1"/>
+          <p:nvPr/>
+        </p:nvSpPr>
+        <p:spPr>
+          <a:xfrm>
+            <a:off x="6400800" y="5382006"/>
+            <a:ext cx="5394960" cy="274320"/>
+          </a:xfrm>
+          <a:prstGeom prst="rect">
+            <a:avLst/>
+          </a:prstGeom>
+          <a:noFill/>
+        </p:spPr>
+        <p:txBody>
+          <a:bodyPr wrap="square">
+            <a:spAutoFit/>
+          </a:bodyPr>
+          <a:lstStyle/>
+          <a:p>
+            <a:pPr>
+              <a:spcAft>
+                <a:spcPts val="600"/>
+              </a:spcAft>
+            </a:pPr>
+            <a:r>
+              <a:rPr sz="1050" b="0">
+                <a:solidFill>
+                  <a:srgbClr val="6E6E6E"/>
+                </a:solidFill>
+                <a:latin typeface="Arial"/>
+              </a:rPr>
+              <a:t>Record: templates/80_end_to_end/e2e, comparison + simulator stages (s6/s7).</a:t>
             </a:r>
           </a:p>
         </p:txBody>

</xml_diff>

<commit_message>
deck: M2-M4 -> M2-M3 on the state-equations slides (Dave; no M4 in the train)
Co-Authored-By: Claude Fable 5 <noreply@anthropic.com>
</commit_message>
<xml_diff>
--- a/demo_session/baseline_pass3.pptx
+++ b/demo_session/baseline_pass3.pptx
@@ -10638,7 +10638,7 @@
                 </a:solidFill>
                 <a:latin typeface="Arial"/>
               </a:rPr>
-              <a:t>•  Six rigid-body DOFs for every optic — the 19 segments, M2-M4, both DMs, the 8 OAPs — plus the whole primary as one rigid group, five fields each, stacked into the control Jacobian.  The response lives on the moved segment's footprint and walks with field.  The coronagraph works the center field only — its stops vignette the corners; the imaging leg sees the full box.</a:t>
+              <a:t>•  Six rigid-body DOFs for every optic — the 19 segments, M2-M3, both DMs, the 8 OAPs — plus the whole primary as one rigid group, five fields each, stacked into the control Jacobian.  The response lives on the moved segment's footprint and walks with field.  The coronagraph works the center field only — its stops vignette the corners; the imaging leg sees the full box.</a:t>
             </a:r>
           </a:p>
         </p:txBody>
@@ -10896,7 +10896,7 @@
                 </a:solidFill>
                 <a:latin typeface="Arial"/>
               </a:rPr>
-              <a:t>•  Zernike figure modes 4–11 on each of the 19 segments, M2-M4, the 8 OAPs — five fields each.  Each channel is confined to its own segment; the mode shape is visible at a glance.</a:t>
+              <a:t>•  Zernike figure modes 4–11 on each of the 19 segments, M2-M3, the 8 OAPs — five fields each.  Each channel is confined to its own segment; the mode shape is visible at a glance.</a:t>
             </a:r>
           </a:p>
           <a:p>

</xml_diff>

<commit_message>
deck: slide 29 'Inside the dig, station by station' -- the horizontal CF3d stations strip + DM maps
Co-Authored-By: Claude Fable 5 <noreply@anthropic.com>
</commit_message>
<xml_diff>
--- a/demo_session/baseline_pass3.pptx
+++ b/demo_session/baseline_pass3.pptx
@@ -45,6 +45,7 @@
     <p:sldId id="293" r:id="rId44"/>
     <p:sldId id="294" r:id="rId45"/>
     <p:sldId id="295" r:id="rId46"/>
+    <p:sldId id="296" r:id="rId47"/>
   </p:sldIdLst>
   <p:sldSz cx="12191695" cy="6858000" type="screen4x3"/>
   <p:notesSz cx="6858000" cy="9144000"/>
@@ -11894,7 +11895,7 @@
                 </a:solidFill>
                 <a:latin typeface="Arial"/>
               </a:rPr>
-              <a:t>The live design, revealed</a:t>
+              <a:t>Inside the dig, station by station</a:t>
             </a:r>
           </a:p>
           <a:p>
@@ -11910,7 +11911,7 @@
                 </a:solidFill>
                 <a:latin typeface="Arial"/>
               </a:rPr>
-              <a:t>Predicted from the frontier before solving; solved in one warm-started step while we talked</a:t>
+              <a:t>Intensity at seven internal planes — the DM commands visibly do the gap work</a:t>
             </a:r>
           </a:p>
         </p:txBody>
@@ -11959,80 +11960,9 @@
           </a:p>
         </p:txBody>
       </p:sp>
-      <p:sp>
-        <p:nvSpPr>
-          <p:cNvPr id="4" name="TextBox 3"/>
-          <p:cNvSpPr txBox="1"/>
-          <p:nvPr/>
-        </p:nvSpPr>
-        <p:spPr>
-          <a:xfrm>
-            <a:off x="411480" y="1298448"/>
-            <a:ext cx="5806440" cy="274320"/>
-          </a:xfrm>
-          <a:prstGeom prst="rect">
-            <a:avLst/>
-          </a:prstGeom>
-          <a:noFill/>
-        </p:spPr>
-        <p:txBody>
-          <a:bodyPr wrap="square">
-            <a:spAutoFit/>
-          </a:bodyPr>
-          <a:lstStyle/>
-          <a:p>
-            <a:pPr>
-              <a:spcAft>
-                <a:spcPts val="600"/>
-              </a:spcAft>
-            </a:pPr>
-            <a:r>
-              <a:rPr sz="1200" b="0">
-                <a:solidFill>
-                  <a:srgbClr val="282828"/>
-                </a:solidFill>
-                <a:latin typeface="Arial"/>
-              </a:rPr>
-              <a:t>•  The ask: a field-box width, anywhere in 5–15°.  The prediction, stated before the solve: interpolated from the committed frontier rows.</a:t>
-            </a:r>
-          </a:p>
-          <a:p>
-            <a:pPr>
-              <a:spcAft>
-                <a:spcPts val="600"/>
-              </a:spcAft>
-            </a:pPr>
-            <a:r>
-              <a:rPr sz="1200" b="0">
-                <a:solidFill>
-                  <a:srgbClr val="282828"/>
-                </a:solidFill>
-                <a:latin typeface="Arial"/>
-              </a:rPr>
-              <a:t>•  The pre-run rehearsal of the default ask (12°): predicted 33.7 nm; solved 33.6 nm — 1.00× — at a 24.9 mm clearance floor, both checks pass, in 15 minutes.</a:t>
-            </a:r>
-          </a:p>
-          <a:p>
-            <a:pPr>
-              <a:spcAft>
-                <a:spcPts val="600"/>
-              </a:spcAft>
-            </a:pPr>
-            <a:r>
-              <a:rPr sz="1200" b="0">
-                <a:solidFill>
-                  <a:srgbClr val="282828"/>
-                </a:solidFill>
-                <a:latin typeface="Arial"/>
-              </a:rPr>
-              <a:t>•  The run is deterministic to every printed digit, and every ask is a genuine continuation step — never a re-score of a stored design.</a:t>
-            </a:r>
-          </a:p>
-        </p:txBody>
-      </p:sp>
       <p:pic>
         <p:nvPicPr>
-          <p:cNvPr id="5" name="Picture 4" descr="oi_demo_12deg_layout.png"/>
+          <p:cNvPr id="4" name="Picture 3" descr="fig_cf3d_stations_wide.png"/>
           <p:cNvPicPr>
             <a:picLocks noChangeAspect="1"/>
           </p:cNvPicPr>
@@ -12046,8 +11976,8 @@
         </p:blipFill>
         <p:spPr>
           <a:xfrm>
-            <a:off x="8000103" y="1298448"/>
-            <a:ext cx="2196352" cy="1891792"/>
+            <a:off x="1544429" y="1298448"/>
+            <a:ext cx="9102837" cy="2257552"/>
           </a:xfrm>
           <a:prstGeom prst="rect">
             <a:avLst/>
@@ -12056,14 +11986,14 @@
       </p:pic>
       <p:sp>
         <p:nvSpPr>
-          <p:cNvPr id="6" name="TextBox 5"/>
+          <p:cNvPr id="5" name="TextBox 4"/>
           <p:cNvSpPr txBox="1"/>
           <p:nvPr/>
         </p:nvSpPr>
         <p:spPr>
           <a:xfrm>
-            <a:off x="6400800" y="3208528"/>
-            <a:ext cx="5394960" cy="394208"/>
+            <a:off x="411480" y="3574288"/>
+            <a:ext cx="11368735" cy="394208"/>
           </a:xfrm>
           <a:prstGeom prst="rect">
             <a:avLst/>
@@ -12088,14 +12018,69 @@
                 </a:solidFill>
                 <a:latin typeface="Arial"/>
               </a:rPr>
-              <a:t>The 12° rehearsal design and its field map: 33.6 nm max against a 33.7 nm prediction.</a:t>
+              <a:t>Seven planes, DMs flat (top row) against the dug state (bottom): pupil, apodizer, focal plane before and after the occulter, Lyot plane before and after the stop, science-plane contrast.  The dug row ends in the full 3–15 λ/D annular dark hole at the 10⁻⁹ floor; the in-walk dark-zone means reproduce the scored record exactly.</a:t>
+            </a:r>
+          </a:p>
+        </p:txBody>
+      </p:sp>
+      <p:sp>
+        <p:nvSpPr>
+          <p:cNvPr id="6" name="TextBox 5"/>
+          <p:cNvSpPr txBox="1"/>
+          <p:nvPr/>
+        </p:nvSpPr>
+        <p:spPr>
+          <a:xfrm>
+            <a:off x="411480" y="4005072"/>
+            <a:ext cx="11368735" cy="274320"/>
+          </a:xfrm>
+          <a:prstGeom prst="rect">
+            <a:avLst/>
+          </a:prstGeom>
+          <a:noFill/>
+        </p:spPr>
+        <p:txBody>
+          <a:bodyPr wrap="square">
+            <a:spAutoFit/>
+          </a:bodyPr>
+          <a:lstStyle/>
+          <a:p>
+            <a:pPr>
+              <a:spcAft>
+                <a:spcPts val="600"/>
+              </a:spcAft>
+            </a:pPr>
+            <a:r>
+              <a:rPr sz="1500" b="0">
+                <a:solidFill>
+                  <a:srgbClr val="282828"/>
+                </a:solidFill>
+                <a:latin typeface="Arial"/>
+              </a:rPr>
+              <a:t>•  DM1's command map imprints the hex-gap lattice — the controller is doing the gap-and-edge work the apodizer was bought for, actuator by actuator, at 33 nm rms; a no-apodizer A/B to price the throughput trade is the scoped follow-on.</a:t>
+            </a:r>
+          </a:p>
+          <a:p>
+            <a:pPr>
+              <a:spcAft>
+                <a:spcPts val="600"/>
+              </a:spcAft>
+            </a:pPr>
+            <a:r>
+              <a:rPr sz="1500" b="0">
+                <a:solidFill>
+                  <a:srgbClr val="282828"/>
+                </a:solidFill>
+                <a:latin typeface="Arial"/>
+              </a:rPr>
+              <a:t>•  The 0.90 Lyot stop removes only ~0.1% of the post-occulter energy — this train's rejected light is interior gap structure, not edge rings, so the Lyot radius is not where the suppression happens.</a:t>
             </a:r>
           </a:p>
         </p:txBody>
       </p:sp>
       <p:pic>
         <p:nvPicPr>
-          <p:cNvPr id="7" name="Picture 6" descr="oi_demo_12deg_map.png"/>
+          <p:cNvPr id="7" name="Picture 6" descr="fig_cf3d_dm_state.png"/>
           <p:cNvPicPr>
             <a:picLocks noChangeAspect="1"/>
           </p:cNvPicPr>
@@ -12109,8 +12094,8 @@
         </p:blipFill>
         <p:spPr>
           <a:xfrm>
-            <a:off x="7951092" y="3639312"/>
-            <a:ext cx="2294375" cy="2011680"/>
+            <a:off x="4763617" y="5312664"/>
+            <a:ext cx="2664460" cy="1188720"/>
           </a:xfrm>
           <a:prstGeom prst="rect">
             <a:avLst/>
@@ -12125,8 +12110,8 @@
         </p:nvSpPr>
         <p:spPr>
           <a:xfrm>
-            <a:off x="6400800" y="5650992"/>
-            <a:ext cx="5394960" cy="274320"/>
+            <a:off x="411480" y="6501384"/>
+            <a:ext cx="11368735" cy="274320"/>
           </a:xfrm>
           <a:prstGeom prst="rect">
             <a:avLst/>
@@ -12151,7 +12136,7 @@
                 </a:solidFill>
                 <a:latin typeface="Arial"/>
               </a:rPr>
-              <a:t>On demo day the live run's figures replace these panels; this pre-generated bundle is the fallback if the room's ask matches nothing better.</a:t>
+              <a:t>The CTB documentation model — intensity at key planes, compact-vs-full — applied to the observatory train: same station layout, the two columns now DMs-flat vs dug.</a:t>
             </a:r>
           </a:p>
         </p:txBody>
@@ -12452,7 +12437,7 @@
                 </a:solidFill>
                 <a:latin typeface="Arial"/>
               </a:rPr>
-              <a:t>AI in design and analysis — the working questions</a:t>
+              <a:t>The live design, revealed</a:t>
             </a:r>
           </a:p>
           <a:p>
@@ -12468,7 +12453,7 @@
                 </a:solidFill>
                 <a:latin typeface="Arial"/>
               </a:rPr>
-              <a:t>What we ask of an AI-driven study before believing it</a:t>
+              <a:t>Predicted from the frontier before solving; solved in one warm-started step while we talked</a:t>
             </a:r>
           </a:p>
         </p:txBody>
@@ -12526,7 +12511,7 @@
         <p:spPr>
           <a:xfrm>
             <a:off x="411480" y="1298448"/>
-            <a:ext cx="11368735" cy="274320"/>
+            <a:ext cx="5806440" cy="274320"/>
           </a:xfrm>
           <a:prstGeom prst="rect">
             <a:avLst/>
@@ -12545,13 +12530,13 @@
               </a:spcAft>
             </a:pPr>
             <a:r>
-              <a:rPr sz="1500" b="0">
+              <a:rPr sz="1200" b="0">
                 <a:solidFill>
                   <a:srgbClr val="282828"/>
                 </a:solidFill>
                 <a:latin typeface="Arial"/>
               </a:rPr>
-              <a:t>•  How is a machine's result verified?  Regression checks with negative controls; layout renders read against every claim — the checks caught the errors shown today.</a:t>
+              <a:t>•  The ask: a field-box width, anywhere in 5–15°.  The prediction, stated before the solve: interpolated from the committed frontier rows.</a:t>
             </a:r>
           </a:p>
           <a:p>
@@ -12561,13 +12546,13 @@
               </a:spcAft>
             </a:pPr>
             <a:r>
-              <a:rPr sz="1500" b="0">
+              <a:rPr sz="1200" b="0">
                 <a:solidFill>
                   <a:srgbClr val="282828"/>
                 </a:solidFill>
                 <a:latin typeface="Arial"/>
               </a:rPr>
-              <a:t>•  Where does the human rule?  Constraints, metrics, and every outward claim — the AI proposes, the record decides.</a:t>
+              <a:t>•  The pre-run rehearsal of the default ask (12°): predicted 33.7 nm; solved 33.6 nm — 1.00× — at a 24.9 mm clearance floor, both checks pass, in 15 minutes.</a:t>
             </a:r>
           </a:p>
           <a:p>
@@ -12577,27 +12562,51 @@
               </a:spcAft>
             </a:pPr>
             <a:r>
-              <a:rPr sz="1500" b="0">
+              <a:rPr sz="1200" b="0">
                 <a:solidFill>
                   <a:srgbClr val="282828"/>
                 </a:solidFill>
                 <a:latin typeface="Arial"/>
               </a:rPr>
-              <a:t>•  Is it reproducible?  Every number in this deck rebuilds from committed scripts and committed records — including the design solved during this talk.</a:t>
-            </a:r>
-          </a:p>
-        </p:txBody>
-      </p:sp>
-      <p:sp>
-        <p:nvSpPr>
-          <p:cNvPr id="5" name="TextBox 4"/>
+              <a:t>•  The run is deterministic to every printed digit, and every ask is a genuine continuation step — never a re-score of a stored design.</a:t>
+            </a:r>
+          </a:p>
+        </p:txBody>
+      </p:sp>
+      <p:pic>
+        <p:nvPicPr>
+          <p:cNvPr id="5" name="Picture 4" descr="oi_demo_12deg_layout.png"/>
+          <p:cNvPicPr>
+            <a:picLocks noChangeAspect="1"/>
+          </p:cNvPicPr>
+          <p:nvPr/>
+        </p:nvPicPr>
+        <p:blipFill>
+          <a:blip r:embed="rId2"/>
+          <a:stretch>
+            <a:fillRect/>
+          </a:stretch>
+        </p:blipFill>
+        <p:spPr>
+          <a:xfrm>
+            <a:off x="8000103" y="1298448"/>
+            <a:ext cx="2196352" cy="1891792"/>
+          </a:xfrm>
+          <a:prstGeom prst="rect">
+            <a:avLst/>
+          </a:prstGeom>
+        </p:spPr>
+      </p:pic>
+      <p:sp>
+        <p:nvSpPr>
+          <p:cNvPr id="6" name="TextBox 5"/>
           <p:cNvSpPr txBox="1"/>
           <p:nvPr/>
         </p:nvSpPr>
         <p:spPr>
           <a:xfrm>
-            <a:off x="411480" y="2993898"/>
-            <a:ext cx="11368735" cy="274320"/>
+            <a:off x="6400800" y="3208528"/>
+            <a:ext cx="5394960" cy="394208"/>
           </a:xfrm>
           <a:prstGeom prst="rect">
             <a:avLst/>
@@ -12610,6 +12619,69 @@
           </a:bodyPr>
           <a:lstStyle/>
           <a:p>
+            <a:pPr algn="ctr">
+              <a:spcAft>
+                <a:spcPts val="0"/>
+              </a:spcAft>
+            </a:pPr>
+            <a:r>
+              <a:rPr sz="1000" b="0">
+                <a:solidFill>
+                  <a:srgbClr val="6E6E6E"/>
+                </a:solidFill>
+                <a:latin typeface="Arial"/>
+              </a:rPr>
+              <a:t>The 12° rehearsal design and its field map: 33.6 nm max against a 33.7 nm prediction.</a:t>
+            </a:r>
+          </a:p>
+        </p:txBody>
+      </p:sp>
+      <p:pic>
+        <p:nvPicPr>
+          <p:cNvPr id="7" name="Picture 6" descr="oi_demo_12deg_map.png"/>
+          <p:cNvPicPr>
+            <a:picLocks noChangeAspect="1"/>
+          </p:cNvPicPr>
+          <p:nvPr/>
+        </p:nvPicPr>
+        <p:blipFill>
+          <a:blip r:embed="rId3"/>
+          <a:stretch>
+            <a:fillRect/>
+          </a:stretch>
+        </p:blipFill>
+        <p:spPr>
+          <a:xfrm>
+            <a:off x="7951092" y="3639312"/>
+            <a:ext cx="2294375" cy="2011680"/>
+          </a:xfrm>
+          <a:prstGeom prst="rect">
+            <a:avLst/>
+          </a:prstGeom>
+        </p:spPr>
+      </p:pic>
+      <p:sp>
+        <p:nvSpPr>
+          <p:cNvPr id="8" name="TextBox 7"/>
+          <p:cNvSpPr txBox="1"/>
+          <p:nvPr/>
+        </p:nvSpPr>
+        <p:spPr>
+          <a:xfrm>
+            <a:off x="6400800" y="5650992"/>
+            <a:ext cx="5394960" cy="274320"/>
+          </a:xfrm>
+          <a:prstGeom prst="rect">
+            <a:avLst/>
+          </a:prstGeom>
+          <a:noFill/>
+        </p:spPr>
+        <p:txBody>
+          <a:bodyPr wrap="square">
+            <a:spAutoFit/>
+          </a:bodyPr>
+          <a:lstStyle/>
+          <a:p>
             <a:pPr>
               <a:spcAft>
                 <a:spcPts val="600"/>
@@ -12622,7 +12694,7 @@
                 </a:solidFill>
                 <a:latin typeface="Arial"/>
               </a:rPr>
-              <a:t>Offered as discussion questions, not settled doctrine — the next slide takes one of them to architecture.</a:t>
+              <a:t>On demo day the live run's figures replace these panels; this pre-generated bundle is the fallback if the room's ask matches nothing better.</a:t>
             </a:r>
           </a:p>
         </p:txBody>
@@ -12679,7 +12751,7 @@
                 </a:solidFill>
                 <a:latin typeface="Arial"/>
               </a:rPr>
-              <a:t>Discussion: where should the agent sit?</a:t>
+              <a:t>AI in design and analysis — the working questions</a:t>
             </a:r>
           </a:p>
           <a:p>
@@ -12695,7 +12767,7 @@
                 </a:solidFill>
                 <a:latin typeface="Arial"/>
               </a:rPr>
-              <a:t>Three modes — two exercised by these studies, one open — and the boundary between them is the question</a:t>
+              <a:t>What we ask of an AI-driven study before believing it</a:t>
             </a:r>
           </a:p>
         </p:txBody>
@@ -12772,13 +12844,13 @@
               </a:spcAft>
             </a:pPr>
             <a:r>
-              <a:rPr sz="2000" b="0">
+              <a:rPr sz="1500" b="0">
                 <a:solidFill>
                   <a:srgbClr val="282828"/>
                 </a:solidFill>
                 <a:latin typeface="Arial"/>
               </a:rPr>
-              <a:t>•  A · The compiled tool, no agent — what ships: versioned, regression-tested, inspectable, and it runs unattended.  But measured on a cold user, the docs alone did not carry them.</a:t>
+              <a:t>•  How is a machine's result verified?  Regression checks with negative controls; layout renders read against every claim — the checks caught the errors shown today.</a:t>
             </a:r>
           </a:p>
           <a:p>
@@ -12788,13 +12860,13 @@
               </a:spcAft>
             </a:pPr>
             <a:r>
-              <a:rPr sz="2000" b="0">
+              <a:rPr sz="1500" b="0">
                 <a:solidFill>
                   <a:srgbClr val="282828"/>
                 </a:solidFill>
                 <a:latin typeface="Arial"/>
               </a:rPr>
-              <a:t>•  B · An agent alongside the tool — what these studies did: it found and fixed the conceptual defects in hours and chose what was worth compiling.  Its knowledge is current — but not versioned with the tool.</a:t>
+              <a:t>•  Where does the human rule?  Constraints, metrics, and every outward claim — the AI proposes, the record decides.</a:t>
             </a:r>
           </a:p>
           <a:p>
@@ -12804,45 +12876,13 @@
               </a:spcAft>
             </a:pPr>
             <a:r>
-              <a:rPr sz="2000" b="0">
+              <a:rPr sz="1500" b="0">
                 <a:solidFill>
                   <a:srgbClr val="282828"/>
                 </a:solidFill>
                 <a:latin typeface="Arial"/>
               </a:rPr>
-              <a:t>•  C · A helper embedded in the tool — the open question: advice at the moment of use, catching the failure class that was documented and still fatal.</a:t>
-            </a:r>
-          </a:p>
-          <a:p>
-            <a:pPr>
-              <a:spcAft>
-                <a:spcPts val="600"/>
-              </a:spcAft>
-            </a:pPr>
-            <a:r>
-              <a:rPr sz="2000" b="0">
-                <a:solidFill>
-                  <a:srgbClr val="282828"/>
-                </a:solidFill>
-                <a:latin typeface="Arial"/>
-              </a:rPr>
-              <a:t>•  Shapes for C, in increasing authority:  agent-readable state (the user's own assistant drives the tool); a failure-triage assistant (fires on a failed check, returns a diagnosis and a next command); a policy assistant inside hard limits (chooses schedules and targets; the code enforces limits and logs every choice).</a:t>
-            </a:r>
-          </a:p>
-          <a:p>
-            <a:pPr>
-              <a:spcAft>
-                <a:spcPts val="600"/>
-              </a:spcAft>
-            </a:pPr>
-            <a:r>
-              <a:rPr sz="2000" b="0">
-                <a:solidFill>
-                  <a:srgbClr val="282828"/>
-                </a:solidFill>
-                <a:latin typeface="Arial"/>
-              </a:rPr>
-              <a:t>•  At any level, tier the agents: an orchestrator plans and delegates bounded tasks; the committed records — not any agent's memory — are the shared memory.</a:t>
+              <a:t>•  Is it reproducible?  Every number in this deck rebuilds from committed scripts and committed records — including the design solved during this talk.</a:t>
             </a:r>
           </a:p>
         </p:txBody>
@@ -12855,7 +12895,7 @@
         </p:nvSpPr>
         <p:spPr>
           <a:xfrm>
-            <a:off x="411480" y="6658864"/>
+            <a:off x="411480" y="2993898"/>
             <a:ext cx="11368735" cy="274320"/>
           </a:xfrm>
           <a:prstGeom prst="rect">
@@ -12881,7 +12921,7 @@
                 </a:solidFill>
                 <a:latin typeface="Arial"/>
               </a:rPr>
-              <a:t>A stale check fails loudly; stale advice fails silently.  Measured: the tool alone did not carry a new user; an agent alongside it closed every gap — and most of what it learned is now in the tool, as checks and defaults.</a:t>
+              <a:t>Offered as discussion questions, not settled doctrine — the next slide takes one of them to architecture.</a:t>
             </a:r>
           </a:p>
         </p:txBody>
@@ -12938,7 +12978,7 @@
                 </a:solidFill>
                 <a:latin typeface="Arial"/>
               </a:rPr>
-              <a:t>If you asked us: AI around CODE V and LightTools</a:t>
+              <a:t>Discussion: where should the agent sit?</a:t>
             </a:r>
           </a:p>
           <a:p>
@@ -12954,7 +12994,7 @@
                 </a:solidFill>
                 <a:latin typeface="Arial"/>
               </a:rPr>
-              <a:t>Add it around the optics, not in them — every claim below is measured, not speculative</a:t>
+              <a:t>Three modes — two exercised by these studies, one open — and the boundary between them is the question</a:t>
             </a:r>
           </a:p>
         </p:txBody>
@@ -13031,13 +13071,13 @@
               </a:spcAft>
             </a:pPr>
             <a:r>
-              <a:rPr sz="1600" b="0">
+              <a:rPr sz="2000" b="0">
                 <a:solidFill>
                   <a:srgbClr val="282828"/>
                 </a:solidFill>
                 <a:latin typeface="Arial"/>
               </a:rPr>
-              <a:t>•  Make the tools agent-readable first — state, results, warnings and docs as structured data through the existing macro/API surface.  Every user's assistant then attaches today, and the vendor ships no intelligence at all.  This whole talk ran in that mode.</a:t>
+              <a:t>•  A · The compiled tool, no agent — what ships: versioned, regression-tested, inspectable, and it runs unattended.  But measured on a cold user, the docs alone did not carry them.</a:t>
             </a:r>
           </a:p>
           <a:p>
@@ -13047,13 +13087,13 @@
               </a:spcAft>
             </a:pPr>
             <a:r>
-              <a:rPr sz="1600" b="0">
+              <a:rPr sz="2000" b="0">
                 <a:solidFill>
                   <a:srgbClr val="282828"/>
                 </a:solidFill>
                 <a:latin typeface="Arial"/>
               </a:rPr>
-              <a:t>•  Ship the conventions as data.  The largest defect class our agent found was conventions — the sign of a radius, DAR versus a coordinate break, which reference sphere a number is quoted against.  Make them queryable and the dominant error source disappears for humans and agents alike.</a:t>
+              <a:t>•  B · An agent alongside the tool — what these studies did: it found and fixed the conceptual defects in hours and chose what was worth compiling.  Its knowledge is current — but not versioned with the tool.</a:t>
             </a:r>
           </a:p>
           <a:p>
@@ -13063,13 +13103,13 @@
               </a:spcAft>
             </a:pPr>
             <a:r>
-              <a:rPr sz="1600" b="0">
+              <a:rPr sz="2000" b="0">
                 <a:solidFill>
                   <a:srgbClr val="282828"/>
                 </a:solidFill>
                 <a:latin typeface="Arial"/>
               </a:rPr>
-              <a:t>•  Embed a failure-triage assistant first — it wakes on a failed trace or a stalled solve, reads the saved state, and returns one line of diagnosis plus a next command the person runs.  Our stalled solve was a finite-difference step reading the gradient 17% low: a one-line answer sitting in state the tool already had.</a:t>
+              <a:t>•  C · A helper embedded in the tool — the open question: advice at the moment of use, catching the failure class that was documented and still fatal.</a:t>
             </a:r>
           </a:p>
           <a:p>
@@ -13079,13 +13119,13 @@
               </a:spcAft>
             </a:pPr>
             <a:r>
-              <a:rPr sz="1600" b="0">
+              <a:rPr sz="2000" b="0">
                 <a:solidFill>
                   <a:srgbClr val="282828"/>
                 </a:solidFill>
                 <a:latin typeface="Arial"/>
               </a:rPr>
-              <a:t>•  Put the agent in the search, never in the numerics — starting points and basins (a warm-started walk beat the cold start 8500×); variable-set audits (35% of a metric unclaimed because one freedom was never offered); optimization schedules (a restart ladder dug the dark hole 1.2×10⁻⁶ → 1.1×10⁻⁹ overnight); tolerancing and glass searches.  The agent proposes; the trusted engine disposes.</a:t>
+              <a:t>•  Shapes for C, in increasing authority:  agent-readable state (the user's own assistant drives the tool); a failure-triage assistant (fires on a failed check, returns a diagnosis and a next command); a policy assistant inside hard limits (chooses schedules and targets; the code enforces limits and logs every choice).</a:t>
             </a:r>
           </a:p>
           <a:p>
@@ -13095,13 +13135,13 @@
               </a:spcAft>
             </a:pPr>
             <a:r>
-              <a:rPr sz="1600" b="0">
+              <a:rPr sz="2000" b="0">
                 <a:solidFill>
                   <a:srgbClr val="282828"/>
                 </a:solidFill>
                 <a:latin typeface="Arial"/>
               </a:rPr>
-              <a:t>•  Ship the trust machinery with it: every AI action a readable, replayable script — never an opaque state mutation; every proposal a before/after check with negative controls; the assistant's knowledge versioned with the release.</a:t>
+              <a:t>•  At any level, tier the agents: an orchestrator plans and delegates bounded tasks; the committed records — not any agent's memory — are the shared memory.</a:t>
             </a:r>
           </a:p>
         </p:txBody>
@@ -13114,7 +13154,7 @@
         </p:nvSpPr>
         <p:spPr>
           <a:xfrm>
-            <a:off x="411480" y="6262624"/>
+            <a:off x="411480" y="6658864"/>
             <a:ext cx="11368735" cy="274320"/>
           </a:xfrm>
           <a:prstGeom prst="rect">
@@ -13140,7 +13180,7 @@
                 </a:solidFill>
                 <a:latin typeface="Arial"/>
               </a:rPr>
-              <a:t>A stale check fails loudly; stale advice fails silently — and the best advice ends up compiled into the tool, as checks and defaults.</a:t>
+              <a:t>A stale check fails loudly; stale advice fails silently.  Measured: the tool alone did not carry a new user; an agent alongside it closed every gap — and most of what it learned is now in the tool, as checks and defaults.</a:t>
             </a:r>
           </a:p>
         </p:txBody>
@@ -13197,7 +13237,23 @@
                 </a:solidFill>
                 <a:latin typeface="Arial"/>
               </a:rPr>
-              <a:t>Backup Slides</a:t>
+              <a:t>If you asked us: AI around CODE V and LightTools</a:t>
+            </a:r>
+          </a:p>
+          <a:p>
+            <a:pPr>
+              <a:spcAft>
+                <a:spcPts val="0"/>
+              </a:spcAft>
+            </a:pPr>
+            <a:r>
+              <a:rPr sz="1250" b="0">
+                <a:solidFill>
+                  <a:srgbClr val="6E6E6E"/>
+                </a:solidFill>
+                <a:latin typeface="Arial"/>
+              </a:rPr>
+              <a:t>Add it around the optics, not in them — every claim below is measured, not speculative</a:t>
             </a:r>
           </a:p>
         </p:txBody>
@@ -13210,7 +13266,7 @@
         </p:nvSpPr>
         <p:spPr>
           <a:xfrm>
-            <a:off x="411480" y="914400"/>
+            <a:off x="411480" y="1133856"/>
             <a:ext cx="11368735" cy="20320"/>
           </a:xfrm>
           <a:prstGeom prst="rect">
@@ -13246,6 +13302,148 @@
           </a:p>
         </p:txBody>
       </p:sp>
+      <p:sp>
+        <p:nvSpPr>
+          <p:cNvPr id="4" name="TextBox 3"/>
+          <p:cNvSpPr txBox="1"/>
+          <p:nvPr/>
+        </p:nvSpPr>
+        <p:spPr>
+          <a:xfrm>
+            <a:off x="411480" y="1298448"/>
+            <a:ext cx="11368735" cy="274320"/>
+          </a:xfrm>
+          <a:prstGeom prst="rect">
+            <a:avLst/>
+          </a:prstGeom>
+          <a:noFill/>
+        </p:spPr>
+        <p:txBody>
+          <a:bodyPr wrap="square">
+            <a:spAutoFit/>
+          </a:bodyPr>
+          <a:lstStyle/>
+          <a:p>
+            <a:pPr>
+              <a:spcAft>
+                <a:spcPts val="600"/>
+              </a:spcAft>
+            </a:pPr>
+            <a:r>
+              <a:rPr sz="1600" b="0">
+                <a:solidFill>
+                  <a:srgbClr val="282828"/>
+                </a:solidFill>
+                <a:latin typeface="Arial"/>
+              </a:rPr>
+              <a:t>•  Make the tools agent-readable first — state, results, warnings and docs as structured data through the existing macro/API surface.  Every user's assistant then attaches today, and the vendor ships no intelligence at all.  This whole talk ran in that mode.</a:t>
+            </a:r>
+          </a:p>
+          <a:p>
+            <a:pPr>
+              <a:spcAft>
+                <a:spcPts val="600"/>
+              </a:spcAft>
+            </a:pPr>
+            <a:r>
+              <a:rPr sz="1600" b="0">
+                <a:solidFill>
+                  <a:srgbClr val="282828"/>
+                </a:solidFill>
+                <a:latin typeface="Arial"/>
+              </a:rPr>
+              <a:t>•  Ship the conventions as data.  The largest defect class our agent found was conventions — the sign of a radius, DAR versus a coordinate break, which reference sphere a number is quoted against.  Make them queryable and the dominant error source disappears for humans and agents alike.</a:t>
+            </a:r>
+          </a:p>
+          <a:p>
+            <a:pPr>
+              <a:spcAft>
+                <a:spcPts val="600"/>
+              </a:spcAft>
+            </a:pPr>
+            <a:r>
+              <a:rPr sz="1600" b="0">
+                <a:solidFill>
+                  <a:srgbClr val="282828"/>
+                </a:solidFill>
+                <a:latin typeface="Arial"/>
+              </a:rPr>
+              <a:t>•  Embed a failure-triage assistant first — it wakes on a failed trace or a stalled solve, reads the saved state, and returns one line of diagnosis plus a next command the person runs.  Our stalled solve was a finite-difference step reading the gradient 17% low: a one-line answer sitting in state the tool already had.</a:t>
+            </a:r>
+          </a:p>
+          <a:p>
+            <a:pPr>
+              <a:spcAft>
+                <a:spcPts val="600"/>
+              </a:spcAft>
+            </a:pPr>
+            <a:r>
+              <a:rPr sz="1600" b="0">
+                <a:solidFill>
+                  <a:srgbClr val="282828"/>
+                </a:solidFill>
+                <a:latin typeface="Arial"/>
+              </a:rPr>
+              <a:t>•  Put the agent in the search, never in the numerics — starting points and basins (a warm-started walk beat the cold start 8500×); variable-set audits (35% of a metric unclaimed because one freedom was never offered); optimization schedules (a restart ladder dug the dark hole 1.2×10⁻⁶ → 1.1×10⁻⁹ overnight); tolerancing and glass searches.  The agent proposes; the trusted engine disposes.</a:t>
+            </a:r>
+          </a:p>
+          <a:p>
+            <a:pPr>
+              <a:spcAft>
+                <a:spcPts val="600"/>
+              </a:spcAft>
+            </a:pPr>
+            <a:r>
+              <a:rPr sz="1600" b="0">
+                <a:solidFill>
+                  <a:srgbClr val="282828"/>
+                </a:solidFill>
+                <a:latin typeface="Arial"/>
+              </a:rPr>
+              <a:t>•  Ship the trust machinery with it: every AI action a readable, replayable script — never an opaque state mutation; every proposal a before/after check with negative controls; the assistant's knowledge versioned with the release.</a:t>
+            </a:r>
+          </a:p>
+        </p:txBody>
+      </p:sp>
+      <p:sp>
+        <p:nvSpPr>
+          <p:cNvPr id="5" name="TextBox 4"/>
+          <p:cNvSpPr txBox="1"/>
+          <p:nvPr/>
+        </p:nvSpPr>
+        <p:spPr>
+          <a:xfrm>
+            <a:off x="411480" y="6262624"/>
+            <a:ext cx="11368735" cy="274320"/>
+          </a:xfrm>
+          <a:prstGeom prst="rect">
+            <a:avLst/>
+          </a:prstGeom>
+          <a:noFill/>
+        </p:spPr>
+        <p:txBody>
+          <a:bodyPr wrap="square">
+            <a:spAutoFit/>
+          </a:bodyPr>
+          <a:lstStyle/>
+          <a:p>
+            <a:pPr>
+              <a:spcAft>
+                <a:spcPts val="600"/>
+              </a:spcAft>
+            </a:pPr>
+            <a:r>
+              <a:rPr sz="1050" b="0">
+                <a:solidFill>
+                  <a:srgbClr val="6E6E6E"/>
+                </a:solidFill>
+                <a:latin typeface="Arial"/>
+              </a:rPr>
+              <a:t>A stale check fails loudly; stale advice fails silently — and the best advice ends up compiled into the tool, as checks and defaults.</a:t>
+            </a:r>
+          </a:p>
+        </p:txBody>
+      </p:sp>
     </p:spTree>
   </p:cSld>
   <p:clrMapOvr>
@@ -13255,6 +13453,107 @@
 </file>
 
 <file path=ppt/slides/slide34.xml><?xml version="1.0" encoding="utf-8"?>
+<p:sld xmlns:a="http://schemas.openxmlformats.org/drawingml/2006/main" xmlns:p="http://schemas.openxmlformats.org/presentationml/2006/main" xmlns:r="http://schemas.openxmlformats.org/officeDocument/2006/relationships">
+  <p:cSld>
+    <p:spTree>
+      <p:nvGrpSpPr>
+        <p:cNvPr id="1" name=""/>
+        <p:cNvGrpSpPr/>
+        <p:nvPr/>
+      </p:nvGrpSpPr>
+      <p:grpSpPr/>
+      <p:sp>
+        <p:nvSpPr>
+          <p:cNvPr id="2" name="TextBox 1"/>
+          <p:cNvSpPr txBox="1"/>
+          <p:nvPr/>
+        </p:nvSpPr>
+        <p:spPr>
+          <a:xfrm>
+            <a:off x="411480" y="201168"/>
+            <a:ext cx="11368735" cy="914400"/>
+          </a:xfrm>
+          <a:prstGeom prst="rect">
+            <a:avLst/>
+          </a:prstGeom>
+          <a:noFill/>
+        </p:spPr>
+        <p:txBody>
+          <a:bodyPr wrap="square">
+            <a:spAutoFit/>
+          </a:bodyPr>
+          <a:lstStyle/>
+          <a:p>
+            <a:pPr>
+              <a:spcAft>
+                <a:spcPts val="400"/>
+              </a:spcAft>
+            </a:pPr>
+            <a:r>
+              <a:rPr sz="2400" b="1">
+                <a:solidFill>
+                  <a:srgbClr val="1F4E79"/>
+                </a:solidFill>
+                <a:latin typeface="Arial"/>
+              </a:rPr>
+              <a:t>Backup Slides</a:t>
+            </a:r>
+          </a:p>
+        </p:txBody>
+      </p:sp>
+      <p:sp>
+        <p:nvSpPr>
+          <p:cNvPr id="3" name="Rectangle 2"/>
+          <p:cNvSpPr/>
+          <p:nvPr/>
+        </p:nvSpPr>
+        <p:spPr>
+          <a:xfrm>
+            <a:off x="411480" y="914400"/>
+            <a:ext cx="11368735" cy="20320"/>
+          </a:xfrm>
+          <a:prstGeom prst="rect">
+            <a:avLst/>
+          </a:prstGeom>
+          <a:solidFill>
+            <a:srgbClr val="B8C6D4"/>
+          </a:solidFill>
+          <a:ln>
+            <a:noFill/>
+          </a:ln>
+          <a:effectLst/>
+        </p:spPr>
+        <p:style>
+          <a:lnRef idx="1">
+            <a:schemeClr val="accent1"/>
+          </a:lnRef>
+          <a:fillRef idx="3">
+            <a:schemeClr val="accent1"/>
+          </a:fillRef>
+          <a:effectRef idx="2">
+            <a:schemeClr val="accent1"/>
+          </a:effectRef>
+          <a:fontRef idx="minor">
+            <a:schemeClr val="lt1"/>
+          </a:fontRef>
+        </p:style>
+        <p:txBody>
+          <a:bodyPr rtlCol="0" anchor="ctr"/>
+          <a:lstStyle/>
+          <a:p>
+            <a:pPr algn="ctr"/>
+          </a:p>
+        </p:txBody>
+      </p:sp>
+    </p:spTree>
+  </p:cSld>
+  <p:clrMapOvr>
+    <a:masterClrMapping/>
+  </p:clrMapOvr>
+</p:sld>
+</file>
+
+<file path=ppt/slides/slide35.xml><?xml version="1.0" encoding="utf-8"?>
 <p:sld xmlns:a="http://schemas.openxmlformats.org/drawingml/2006/main" xmlns:p="http://schemas.openxmlformats.org/presentationml/2006/main" xmlns:r="http://schemas.openxmlformats.org/officeDocument/2006/relationships">
   <p:cSld>
     <p:spTree>
@@ -13884,7 +14183,7 @@
 </p:sld>
 </file>
 
-<file path=ppt/slides/slide35.xml><?xml version="1.0" encoding="utf-8"?>
+<file path=ppt/slides/slide36.xml><?xml version="1.0" encoding="utf-8"?>
 <p:sld xmlns:a="http://schemas.openxmlformats.org/drawingml/2006/main" xmlns:p="http://schemas.openxmlformats.org/presentationml/2006/main" xmlns:r="http://schemas.openxmlformats.org/officeDocument/2006/relationships">
   <p:cSld>
     <p:spTree>
@@ -14750,7 +15049,7 @@
 </p:sld>
 </file>
 
-<file path=ppt/slides/slide36.xml><?xml version="1.0" encoding="utf-8"?>
+<file path=ppt/slides/slide37.xml><?xml version="1.0" encoding="utf-8"?>
 <p:sld xmlns:a="http://schemas.openxmlformats.org/drawingml/2006/main" xmlns:p="http://schemas.openxmlformats.org/presentationml/2006/main" xmlns:r="http://schemas.openxmlformats.org/officeDocument/2006/relationships">
   <p:cSld>
     <p:spTree>
@@ -14957,351 +15256,6 @@
                 <a:latin typeface="Arial"/>
               </a:rPr>
               <a:t>Committed: deepest optic 1.887 m = 1.81× the spacing, the feed beam through the collimator by −79.9 mm.  Four-flat recipe: 0.893 m deep, but a fold is an isometry — the interference rides across — and it does not close on the cleared deck (96 routes, every admissible one loses rays).  Cleared −10°: 1.287 m = 1.24×, zero flats, +37.8 mm of daylight.  Record: challenges/afocal4/{packaging,clearing}.</a:t>
-            </a:r>
-          </a:p>
-        </p:txBody>
-      </p:sp>
-    </p:spTree>
-  </p:cSld>
-  <p:clrMapOvr>
-    <a:masterClrMapping/>
-  </p:clrMapOvr>
-</p:sld>
-</file>
-
-<file path=ppt/slides/slide37.xml><?xml version="1.0" encoding="utf-8"?>
-<p:sld xmlns:a="http://schemas.openxmlformats.org/drawingml/2006/main" xmlns:p="http://schemas.openxmlformats.org/presentationml/2006/main" xmlns:r="http://schemas.openxmlformats.org/officeDocument/2006/relationships">
-  <p:cSld>
-    <p:spTree>
-      <p:nvGrpSpPr>
-        <p:cNvPr id="1" name=""/>
-        <p:cNvGrpSpPr/>
-        <p:nvPr/>
-      </p:nvGrpSpPr>
-      <p:grpSpPr/>
-      <p:sp>
-        <p:nvSpPr>
-          <p:cNvPr id="2" name="TextBox 1"/>
-          <p:cNvSpPr txBox="1"/>
-          <p:nvPr/>
-        </p:nvSpPr>
-        <p:spPr>
-          <a:xfrm>
-            <a:off x="411480" y="201168"/>
-            <a:ext cx="11368735" cy="914400"/>
-          </a:xfrm>
-          <a:prstGeom prst="rect">
-            <a:avLst/>
-          </a:prstGeom>
-          <a:noFill/>
-        </p:spPr>
-        <p:txBody>
-          <a:bodyPr wrap="square">
-            <a:spAutoFit/>
-          </a:bodyPr>
-          <a:lstStyle/>
-          <a:p>
-            <a:pPr>
-              <a:spcAft>
-                <a:spcPts val="400"/>
-              </a:spcAft>
-            </a:pPr>
-            <a:r>
-              <a:rPr sz="2400" b="1">
-                <a:solidFill>
-                  <a:srgbClr val="1F4E79"/>
-                </a:solidFill>
-                <a:latin typeface="Arial"/>
-              </a:rPr>
-              <a:t>Interferometer demonstration backups</a:t>
-            </a:r>
-          </a:p>
-          <a:p>
-            <a:pPr>
-              <a:spcAft>
-                <a:spcPts val="0"/>
-              </a:spcAft>
-            </a:pPr>
-            <a:r>
-              <a:rPr sz="1250" b="0">
-                <a:solidFill>
-                  <a:srgbClr val="6E6E6E"/>
-                </a:solidFill>
-                <a:latin typeface="Arial"/>
-              </a:rPr>
-              <a:t>One committed image per live beat</a:t>
-            </a:r>
-          </a:p>
-        </p:txBody>
-      </p:sp>
-      <p:sp>
-        <p:nvSpPr>
-          <p:cNvPr id="3" name="Rectangle 2"/>
-          <p:cNvSpPr/>
-          <p:nvPr/>
-        </p:nvSpPr>
-        <p:spPr>
-          <a:xfrm>
-            <a:off x="411480" y="1133856"/>
-            <a:ext cx="11368735" cy="20320"/>
-          </a:xfrm>
-          <a:prstGeom prst="rect">
-            <a:avLst/>
-          </a:prstGeom>
-          <a:solidFill>
-            <a:srgbClr val="B8C6D4"/>
-          </a:solidFill>
-          <a:ln>
-            <a:noFill/>
-          </a:ln>
-          <a:effectLst/>
-        </p:spPr>
-        <p:style>
-          <a:lnRef idx="1">
-            <a:schemeClr val="accent1"/>
-          </a:lnRef>
-          <a:fillRef idx="3">
-            <a:schemeClr val="accent1"/>
-          </a:fillRef>
-          <a:effectRef idx="2">
-            <a:schemeClr val="accent1"/>
-          </a:effectRef>
-          <a:fontRef idx="minor">
-            <a:schemeClr val="lt1"/>
-          </a:fontRef>
-        </p:style>
-        <p:txBody>
-          <a:bodyPr rtlCol="0" anchor="ctr"/>
-          <a:lstStyle/>
-          <a:p>
-            <a:pPr algn="ctr"/>
-          </a:p>
-        </p:txBody>
-      </p:sp>
-      <p:pic>
-        <p:nvPicPr>
-          <p:cNvPr id="4" name="Picture 3" descr="demo2_beat5_poke.png"/>
-          <p:cNvPicPr>
-            <a:picLocks noChangeAspect="1"/>
-          </p:cNvPicPr>
-          <p:nvPr/>
-        </p:nvPicPr>
-        <p:blipFill>
-          <a:blip r:embed="rId2"/>
-          <a:stretch>
-            <a:fillRect/>
-          </a:stretch>
-        </p:blipFill>
-        <p:spPr>
-          <a:xfrm>
-            <a:off x="3772370" y="1298448"/>
-            <a:ext cx="4646955" cy="1782572"/>
-          </a:xfrm>
-          <a:prstGeom prst="rect">
-            <a:avLst/>
-          </a:prstGeom>
-        </p:spPr>
-      </p:pic>
-      <p:sp>
-        <p:nvSpPr>
-          <p:cNvPr id="5" name="TextBox 4"/>
-          <p:cNvSpPr txBox="1"/>
-          <p:nvPr/>
-        </p:nvSpPr>
-        <p:spPr>
-          <a:xfrm>
-            <a:off x="411480" y="3099308"/>
-            <a:ext cx="11368735" cy="229107"/>
-          </a:xfrm>
-          <a:prstGeom prst="rect">
-            <a:avLst/>
-          </a:prstGeom>
-          <a:noFill/>
-        </p:spPr>
-        <p:txBody>
-          <a:bodyPr wrap="square">
-            <a:spAutoFit/>
-          </a:bodyPr>
-          <a:lstStyle/>
-          <a:p>
-            <a:pPr algn="ctr">
-              <a:spcAft>
-                <a:spcPts val="0"/>
-              </a:spcAft>
-            </a:pPr>
-            <a:r>
-              <a:rPr sz="1000" b="0">
-                <a:solidFill>
-                  <a:srgbClr val="6E6E6E"/>
-                </a:solidFill>
-                <a:latin typeface="Arial"/>
-              </a:rPr>
-              <a:t>Beat 5 — one actuator poked: the fringes bend over it.</a:t>
-            </a:r>
-          </a:p>
-        </p:txBody>
-      </p:sp>
-      <p:pic>
-        <p:nvPicPr>
-          <p:cNvPr id="6" name="Picture 5" descr="demo2_beat6_sweep.png"/>
-          <p:cNvPicPr>
-            <a:picLocks noChangeAspect="1"/>
-          </p:cNvPicPr>
-          <p:nvPr/>
-        </p:nvPicPr>
-        <p:blipFill>
-          <a:blip r:embed="rId3"/>
-          <a:stretch>
-            <a:fillRect/>
-          </a:stretch>
-        </p:blipFill>
-        <p:spPr>
-          <a:xfrm>
-            <a:off x="4186821" y="3364992"/>
-            <a:ext cx="3818051" cy="1782572"/>
-          </a:xfrm>
-          <a:prstGeom prst="rect">
-            <a:avLst/>
-          </a:prstGeom>
-        </p:spPr>
-      </p:pic>
-      <p:sp>
-        <p:nvSpPr>
-          <p:cNvPr id="7" name="TextBox 6"/>
-          <p:cNvSpPr txBox="1"/>
-          <p:nvPr/>
-        </p:nvSpPr>
-        <p:spPr>
-          <a:xfrm>
-            <a:off x="411480" y="5165852"/>
-            <a:ext cx="11368735" cy="229107"/>
-          </a:xfrm>
-          <a:prstGeom prst="rect">
-            <a:avLst/>
-          </a:prstGeom>
-          <a:noFill/>
-        </p:spPr>
-        <p:txBody>
-          <a:bodyPr wrap="square">
-            <a:spAutoFit/>
-          </a:bodyPr>
-          <a:lstStyle/>
-          <a:p>
-            <a:pPr algn="ctr">
-              <a:spcAft>
-                <a:spcPts val="0"/>
-              </a:spcAft>
-            </a:pPr>
-            <a:r>
-              <a:rPr sz="1000" b="0">
-                <a:solidFill>
-                  <a:srgbClr val="6E6E6E"/>
-                </a:solidFill>
-                <a:latin typeface="Arial"/>
-              </a:rPr>
-              <a:t>Beat 6 — the analyzer sweep: phase-stepped frames, no re-trace.</a:t>
-            </a:r>
-          </a:p>
-        </p:txBody>
-      </p:sp>
-      <p:pic>
-        <p:nvPicPr>
-          <p:cNvPr id="8" name="Picture 7" descr="demo2_beat7_recovery.png"/>
-          <p:cNvPicPr>
-            <a:picLocks noChangeAspect="1"/>
-          </p:cNvPicPr>
-          <p:nvPr/>
-        </p:nvPicPr>
-        <p:blipFill>
-          <a:blip r:embed="rId4"/>
-          <a:stretch>
-            <a:fillRect/>
-          </a:stretch>
-        </p:blipFill>
-        <p:spPr>
-          <a:xfrm>
-            <a:off x="4177857" y="5431536"/>
-            <a:ext cx="3835980" cy="1032763"/>
-          </a:xfrm>
-          <a:prstGeom prst="rect">
-            <a:avLst/>
-          </a:prstGeom>
-        </p:spPr>
-      </p:pic>
-      <p:sp>
-        <p:nvSpPr>
-          <p:cNvPr id="9" name="TextBox 8"/>
-          <p:cNvSpPr txBox="1"/>
-          <p:nvPr/>
-        </p:nvSpPr>
-        <p:spPr>
-          <a:xfrm>
-            <a:off x="411480" y="6482588"/>
-            <a:ext cx="11368735" cy="229107"/>
-          </a:xfrm>
-          <a:prstGeom prst="rect">
-            <a:avLst/>
-          </a:prstGeom>
-          <a:noFill/>
-        </p:spPr>
-        <p:txBody>
-          <a:bodyPr wrap="square">
-            <a:spAutoFit/>
-          </a:bodyPr>
-          <a:lstStyle/>
-          <a:p>
-            <a:pPr algn="ctr">
-              <a:spcAft>
-                <a:spcPts val="0"/>
-              </a:spcAft>
-            </a:pPr>
-            <a:r>
-              <a:rPr sz="1000" b="0">
-                <a:solidFill>
-                  <a:srgbClr val="6E6E6E"/>
-                </a:solidFill>
-                <a:latin typeface="Arial"/>
-              </a:rPr>
-              <a:t>Beat 7 — the recovery beside the truth map.</a:t>
-            </a:r>
-          </a:p>
-        </p:txBody>
-      </p:sp>
-      <p:sp>
-        <p:nvSpPr>
-          <p:cNvPr id="10" name="TextBox 9"/>
-          <p:cNvSpPr txBox="1"/>
-          <p:nvPr/>
-        </p:nvSpPr>
-        <p:spPr>
-          <a:xfrm>
-            <a:off x="411480" y="6748272"/>
-            <a:ext cx="11368735" cy="274320"/>
-          </a:xfrm>
-          <a:prstGeom prst="rect">
-            <a:avLst/>
-          </a:prstGeom>
-          <a:noFill/>
-        </p:spPr>
-        <p:txBody>
-          <a:bodyPr wrap="square">
-            <a:spAutoFit/>
-          </a:bodyPr>
-          <a:lstStyle/>
-          <a:p>
-            <a:pPr>
-              <a:spcAft>
-                <a:spcPts val="600"/>
-              </a:spcAft>
-            </a:pPr>
-            <a:r>
-              <a:rPr sz="1050" b="0">
-                <a:solidFill>
-                  <a:srgbClr val="6E6E6E"/>
-                </a:solidFill>
-                <a:latin typeface="Arial"/>
-              </a:rPr>
-              <a:t>All eight beats have committed figures in templates/90_polarization/tg_psi_dm_v2 (v1 likewise); the driver opens them on the desktop as each beat runs.</a:t>
             </a:r>
           </a:p>
         </p:txBody>
@@ -15358,7 +15312,7 @@
                 </a:solidFill>
                 <a:latin typeface="Arial"/>
               </a:rPr>
-              <a:t>The e2e worked example: specification to design</a:t>
+              <a:t>Interferometer demonstration backups</a:t>
             </a:r>
           </a:p>
           <a:p>
@@ -15374,7 +15328,7 @@
                 </a:solidFill>
                 <a:latin typeface="Arial"/>
               </a:rPr>
-              <a:t>A 4 m f/18 visible-band telescope from a closed-form seed — no starting prescription</a:t>
+              <a:t>One committed image per live beat</a:t>
             </a:r>
           </a:p>
         </p:txBody>
@@ -15423,64 +15377,9 @@
           </a:p>
         </p:txBody>
       </p:sp>
-      <p:sp>
-        <p:nvSpPr>
-          <p:cNvPr id="4" name="TextBox 3"/>
-          <p:cNvSpPr txBox="1"/>
-          <p:nvPr/>
-        </p:nvSpPr>
-        <p:spPr>
-          <a:xfrm>
-            <a:off x="411480" y="1298448"/>
-            <a:ext cx="5806440" cy="274320"/>
-          </a:xfrm>
-          <a:prstGeom prst="rect">
-            <a:avLst/>
-          </a:prstGeom>
-          <a:noFill/>
-        </p:spPr>
-        <p:txBody>
-          <a:bodyPr wrap="square">
-            <a:spAutoFit/>
-          </a:bodyPr>
-          <a:lstStyle/>
-          <a:p>
-            <a:pPr>
-              <a:spcAft>
-                <a:spcPts val="600"/>
-              </a:spcAft>
-            </a:pPr>
-            <a:r>
-              <a:rPr sz="1200" b="0">
-                <a:solidFill>
-                  <a:srgbClr val="282828"/>
-                </a:solidFill>
-                <a:latin typeface="Arial"/>
-              </a:rPr>
-              <a:t>•  The stage-runner sequence on the smaller worked example: specification → design → segmentation → metrology → comparison → simulation, each stage a committed runner handing its prescription to the next.</a:t>
-            </a:r>
-          </a:p>
-          <a:p>
-            <a:pPr>
-              <a:spcAft>
-                <a:spcPts val="600"/>
-              </a:spcAft>
-            </a:pPr>
-            <a:r>
-              <a:rPr sz="1200" b="0">
-                <a:solidFill>
-                  <a:srgbClr val="282828"/>
-                </a:solidFill>
-                <a:latin typeface="Arial"/>
-              </a:rPr>
-              <a:t>•  A 4 m f/18 telescope (f/1.75 primary) from a closed-form first-order seed; diffraction-limited over ±1′ alone, and the Offner ring-field relay buys the full ±2′ (Strehl floor 0.965, on pure spheres).</a:t>
-            </a:r>
-          </a:p>
-        </p:txBody>
-      </p:sp>
       <p:pic>
         <p:nvPicPr>
-          <p:cNvPr id="5" name="Picture 4" descr="rowpair_s1_views.png"/>
+          <p:cNvPr id="4" name="Picture 3" descr="demo2_beat5_poke.png"/>
           <p:cNvPicPr>
             <a:picLocks noChangeAspect="1"/>
           </p:cNvPicPr>
@@ -15494,8 +15393,8 @@
         </p:blipFill>
         <p:spPr>
           <a:xfrm>
-            <a:off x="6738659" y="1298448"/>
-            <a:ext cx="4719240" cy="2056892"/>
+            <a:off x="3772370" y="1298448"/>
+            <a:ext cx="4646955" cy="1782572"/>
           </a:xfrm>
           <a:prstGeom prst="rect">
             <a:avLst/>
@@ -15504,14 +15403,14 @@
       </p:pic>
       <p:sp>
         <p:nvSpPr>
-          <p:cNvPr id="6" name="TextBox 5"/>
+          <p:cNvPr id="5" name="TextBox 4"/>
           <p:cNvSpPr txBox="1"/>
           <p:nvPr/>
         </p:nvSpPr>
         <p:spPr>
           <a:xfrm>
-            <a:off x="6400800" y="3373628"/>
-            <a:ext cx="5394960" cy="229107"/>
+            <a:off x="411480" y="3099308"/>
+            <a:ext cx="11368735" cy="229107"/>
           </a:xfrm>
           <a:prstGeom prst="rect">
             <a:avLst/>
@@ -15536,14 +15435,14 @@
                 </a:solidFill>
                 <a:latin typeface="Arial"/>
               </a:rPr>
-              <a:t>The telescope as designed (front + iso views), with the traced field.</a:t>
+              <a:t>Beat 5 — one actuator poked: the fringes bend over it.</a:t>
             </a:r>
           </a:p>
         </p:txBody>
       </p:sp>
       <p:pic>
         <p:nvPicPr>
-          <p:cNvPr id="7" name="Picture 6" descr="s1_wfe_field.png"/>
+          <p:cNvPr id="6" name="Picture 5" descr="demo2_beat6_sweep.png"/>
           <p:cNvPicPr>
             <a:picLocks noChangeAspect="1"/>
           </p:cNvPicPr>
@@ -15557,8 +15456,8 @@
         </p:blipFill>
         <p:spPr>
           <a:xfrm>
-            <a:off x="7993860" y="3639312"/>
-            <a:ext cx="2208839" cy="1782572"/>
+            <a:off x="4186821" y="3364992"/>
+            <a:ext cx="3818051" cy="1782572"/>
           </a:xfrm>
           <a:prstGeom prst="rect">
             <a:avLst/>
@@ -15567,14 +15466,14 @@
       </p:pic>
       <p:sp>
         <p:nvSpPr>
-          <p:cNvPr id="8" name="TextBox 7"/>
+          <p:cNvPr id="7" name="TextBox 6"/>
           <p:cNvSpPr txBox="1"/>
           <p:nvPr/>
         </p:nvSpPr>
         <p:spPr>
           <a:xfrm>
-            <a:off x="6400800" y="5440171"/>
-            <a:ext cx="5394960" cy="229107"/>
+            <a:off x="411480" y="5165852"/>
+            <a:ext cx="11368735" cy="229107"/>
           </a:xfrm>
           <a:prstGeom prst="rect">
             <a:avLst/>
@@ -15599,11 +15498,35 @@
                 </a:solidFill>
                 <a:latin typeface="Arial"/>
               </a:rPr>
-              <a:t>Wavefront error over the field: diffraction-limited across the box.</a:t>
-            </a:r>
-          </a:p>
-        </p:txBody>
-      </p:sp>
+              <a:t>Beat 6 — the analyzer sweep: phase-stepped frames, no re-trace.</a:t>
+            </a:r>
+          </a:p>
+        </p:txBody>
+      </p:sp>
+      <p:pic>
+        <p:nvPicPr>
+          <p:cNvPr id="8" name="Picture 7" descr="demo2_beat7_recovery.png"/>
+          <p:cNvPicPr>
+            <a:picLocks noChangeAspect="1"/>
+          </p:cNvPicPr>
+          <p:nvPr/>
+        </p:nvPicPr>
+        <p:blipFill>
+          <a:blip r:embed="rId4"/>
+          <a:stretch>
+            <a:fillRect/>
+          </a:stretch>
+        </p:blipFill>
+        <p:spPr>
+          <a:xfrm>
+            <a:off x="4177857" y="5431536"/>
+            <a:ext cx="3835980" cy="1032763"/>
+          </a:xfrm>
+          <a:prstGeom prst="rect">
+            <a:avLst/>
+          </a:prstGeom>
+        </p:spPr>
+      </p:pic>
       <p:sp>
         <p:nvSpPr>
           <p:cNvPr id="9" name="TextBox 8"/>
@@ -15612,8 +15535,8 @@
         </p:nvSpPr>
         <p:spPr>
           <a:xfrm>
-            <a:off x="6400800" y="5705855"/>
-            <a:ext cx="5394960" cy="274320"/>
+            <a:off x="411480" y="6482588"/>
+            <a:ext cx="11368735" cy="229107"/>
           </a:xfrm>
           <a:prstGeom prst="rect">
             <a:avLst/>
@@ -15626,6 +15549,45 @@
           </a:bodyPr>
           <a:lstStyle/>
           <a:p>
+            <a:pPr algn="ctr">
+              <a:spcAft>
+                <a:spcPts val="0"/>
+              </a:spcAft>
+            </a:pPr>
+            <a:r>
+              <a:rPr sz="1000" b="0">
+                <a:solidFill>
+                  <a:srgbClr val="6E6E6E"/>
+                </a:solidFill>
+                <a:latin typeface="Arial"/>
+              </a:rPr>
+              <a:t>Beat 7 — the recovery beside the truth map.</a:t>
+            </a:r>
+          </a:p>
+        </p:txBody>
+      </p:sp>
+      <p:sp>
+        <p:nvSpPr>
+          <p:cNvPr id="10" name="TextBox 9"/>
+          <p:cNvSpPr txBox="1"/>
+          <p:nvPr/>
+        </p:nvSpPr>
+        <p:spPr>
+          <a:xfrm>
+            <a:off x="411480" y="6748272"/>
+            <a:ext cx="11368735" cy="274320"/>
+          </a:xfrm>
+          <a:prstGeom prst="rect">
+            <a:avLst/>
+          </a:prstGeom>
+          <a:noFill/>
+        </p:spPr>
+        <p:txBody>
+          <a:bodyPr wrap="square">
+            <a:spAutoFit/>
+          </a:bodyPr>
+          <a:lstStyle/>
+          <a:p>
             <a:pPr>
               <a:spcAft>
                 <a:spcPts val="600"/>
@@ -15638,7 +15600,7 @@
                 </a:solidFill>
                 <a:latin typeface="Arial"/>
               </a:rPr>
-              <a:t>Record: templates/80_end_to_end/e2e — staged worked example, committed at every step.</a:t>
+              <a:t>All eight beats have committed figures in templates/90_polarization/tg_psi_dm_v2 (v1 likewise); the driver opens them on the desktop as each beat runs.</a:t>
             </a:r>
           </a:p>
         </p:txBody>
@@ -15695,7 +15657,7 @@
                 </a:solidFill>
                 <a:latin typeface="Arial"/>
               </a:rPr>
-              <a:t>The e2e worked example: segmentation and metrology</a:t>
+              <a:t>The e2e worked example: specification to design</a:t>
             </a:r>
           </a:p>
           <a:p>
@@ -15711,7 +15673,7 @@
                 </a:solidFill>
                 <a:latin typeface="Arial"/>
               </a:rPr>
-              <a:t>The monolith segments in one call; the metrology is designed on the same Jacobian</a:t>
+              <a:t>A 4 m f/18 visible-band telescope from a closed-form seed — no starting prescription</a:t>
             </a:r>
           </a:p>
         </p:txBody>
@@ -15794,7 +15756,7 @@
                 </a:solidFill>
                 <a:latin typeface="Arial"/>
               </a:rPr>
-              <a:t>•  The primary segments into a pie or hex tiling with physical apertures; every segment gets rigid-body and surface-figure sensitivity channels, stacked into one Jacobian — the control basis.</a:t>
+              <a:t>•  The stage-runner sequence on the smaller worked example: specification → design → segmentation → metrology → comparison → simulation, each stage a committed runner handing its prescription to the next.</a:t>
             </a:r>
           </a:p>
           <a:p>
@@ -15810,14 +15772,14 @@
                 </a:solidFill>
                 <a:latin typeface="Arial"/>
               </a:rPr>
-              <a:t>•  Metrology is an optimization on that basis: edge-sensor and beam-launcher layouts scored by the control information they carry, not by symmetry; the winning pattern exports as a reusable preset.</a:t>
+              <a:t>•  A 4 m f/18 telescope (f/1.75 primary) from a closed-form first-order seed; diffraction-limited over ±1′ alone, and the Offner ring-field relay buys the full ±2′ (Strehl floor 0.965, on pure spheres).</a:t>
             </a:r>
           </a:p>
         </p:txBody>
       </p:sp>
       <p:pic>
         <p:nvPicPr>
-          <p:cNvPr id="5" name="Picture 4" descr="rowpair_s3_views_pie.png"/>
+          <p:cNvPr id="5" name="Picture 4" descr="rowpair_s1_views.png"/>
           <p:cNvPicPr>
             <a:picLocks noChangeAspect="1"/>
           </p:cNvPicPr>
@@ -15831,8 +15793,8 @@
         </p:blipFill>
         <p:spPr>
           <a:xfrm>
-            <a:off x="6618167" y="1298448"/>
-            <a:ext cx="4960224" cy="1965451"/>
+            <a:off x="6738659" y="1298448"/>
+            <a:ext cx="4719240" cy="2056892"/>
           </a:xfrm>
           <a:prstGeom prst="rect">
             <a:avLst/>
@@ -15847,7 +15809,7 @@
         </p:nvSpPr>
         <p:spPr>
           <a:xfrm>
-            <a:off x="6400800" y="3282188"/>
+            <a:off x="6400800" y="3373628"/>
             <a:ext cx="5394960" cy="229107"/>
           </a:xfrm>
           <a:prstGeom prst="rect">
@@ -15873,14 +15835,14 @@
                 </a:solidFill>
                 <a:latin typeface="Arial"/>
               </a:rPr>
-              <a:t>The segmented primary with physical apertures (front + iso views).</a:t>
+              <a:t>The telescope as designed (front + iso views), with the traced field.</a:t>
             </a:r>
           </a:p>
         </p:txBody>
       </p:sp>
       <p:pic>
         <p:nvPicPr>
-          <p:cNvPr id="7" name="Picture 6" descr="e2e_pie_met_view_rx.png"/>
+          <p:cNvPr id="7" name="Picture 6" descr="s1_wfe_field.png"/>
           <p:cNvPicPr>
             <a:picLocks noChangeAspect="1"/>
           </p:cNvPicPr>
@@ -15894,8 +15856,8 @@
         </p:blipFill>
         <p:spPr>
           <a:xfrm>
-            <a:off x="7662896" y="3547872"/>
-            <a:ext cx="2870767" cy="1874011"/>
+            <a:off x="7993860" y="3639312"/>
+            <a:ext cx="2208839" cy="1782572"/>
           </a:xfrm>
           <a:prstGeom prst="rect">
             <a:avLst/>
@@ -15936,7 +15898,7 @@
                 </a:solidFill>
                 <a:latin typeface="Arial"/>
               </a:rPr>
-              <a:t>The optimized metrology layout on the segmented primary.</a:t>
+              <a:t>Wavefront error over the field: diffraction-limited across the box.</a:t>
             </a:r>
           </a:p>
         </p:txBody>
@@ -15975,7 +15937,7 @@
                 </a:solidFill>
                 <a:latin typeface="Arial"/>
               </a:rPr>
-              <a:t>Record: templates/80_end_to_end/e2e, stages 3–5.</a:t>
+              <a:t>Record: templates/80_end_to_end/e2e — staged worked example, committed at every step.</a:t>
             </a:r>
           </a:p>
         </p:txBody>
@@ -16169,6 +16131,343 @@
 </file>
 
 <file path=ppt/slides/slide40.xml><?xml version="1.0" encoding="utf-8"?>
+<p:sld xmlns:a="http://schemas.openxmlformats.org/drawingml/2006/main" xmlns:p="http://schemas.openxmlformats.org/presentationml/2006/main" xmlns:r="http://schemas.openxmlformats.org/officeDocument/2006/relationships">
+  <p:cSld>
+    <p:spTree>
+      <p:nvGrpSpPr>
+        <p:cNvPr id="1" name=""/>
+        <p:cNvGrpSpPr/>
+        <p:nvPr/>
+      </p:nvGrpSpPr>
+      <p:grpSpPr/>
+      <p:sp>
+        <p:nvSpPr>
+          <p:cNvPr id="2" name="TextBox 1"/>
+          <p:cNvSpPr txBox="1"/>
+          <p:nvPr/>
+        </p:nvSpPr>
+        <p:spPr>
+          <a:xfrm>
+            <a:off x="411480" y="201168"/>
+            <a:ext cx="11368735" cy="914400"/>
+          </a:xfrm>
+          <a:prstGeom prst="rect">
+            <a:avLst/>
+          </a:prstGeom>
+          <a:noFill/>
+        </p:spPr>
+        <p:txBody>
+          <a:bodyPr wrap="square">
+            <a:spAutoFit/>
+          </a:bodyPr>
+          <a:lstStyle/>
+          <a:p>
+            <a:pPr>
+              <a:spcAft>
+                <a:spcPts val="400"/>
+              </a:spcAft>
+            </a:pPr>
+            <a:r>
+              <a:rPr sz="2400" b="1">
+                <a:solidFill>
+                  <a:srgbClr val="1F4E79"/>
+                </a:solidFill>
+                <a:latin typeface="Arial"/>
+              </a:rPr>
+              <a:t>The e2e worked example: segmentation and metrology</a:t>
+            </a:r>
+          </a:p>
+          <a:p>
+            <a:pPr>
+              <a:spcAft>
+                <a:spcPts val="0"/>
+              </a:spcAft>
+            </a:pPr>
+            <a:r>
+              <a:rPr sz="1250" b="0">
+                <a:solidFill>
+                  <a:srgbClr val="6E6E6E"/>
+                </a:solidFill>
+                <a:latin typeface="Arial"/>
+              </a:rPr>
+              <a:t>The monolith segments in one call; the metrology is designed on the same Jacobian</a:t>
+            </a:r>
+          </a:p>
+        </p:txBody>
+      </p:sp>
+      <p:sp>
+        <p:nvSpPr>
+          <p:cNvPr id="3" name="Rectangle 2"/>
+          <p:cNvSpPr/>
+          <p:nvPr/>
+        </p:nvSpPr>
+        <p:spPr>
+          <a:xfrm>
+            <a:off x="411480" y="1133856"/>
+            <a:ext cx="11368735" cy="20320"/>
+          </a:xfrm>
+          <a:prstGeom prst="rect">
+            <a:avLst/>
+          </a:prstGeom>
+          <a:solidFill>
+            <a:srgbClr val="B8C6D4"/>
+          </a:solidFill>
+          <a:ln>
+            <a:noFill/>
+          </a:ln>
+          <a:effectLst/>
+        </p:spPr>
+        <p:style>
+          <a:lnRef idx="1">
+            <a:schemeClr val="accent1"/>
+          </a:lnRef>
+          <a:fillRef idx="3">
+            <a:schemeClr val="accent1"/>
+          </a:fillRef>
+          <a:effectRef idx="2">
+            <a:schemeClr val="accent1"/>
+          </a:effectRef>
+          <a:fontRef idx="minor">
+            <a:schemeClr val="lt1"/>
+          </a:fontRef>
+        </p:style>
+        <p:txBody>
+          <a:bodyPr rtlCol="0" anchor="ctr"/>
+          <a:lstStyle/>
+          <a:p>
+            <a:pPr algn="ctr"/>
+          </a:p>
+        </p:txBody>
+      </p:sp>
+      <p:sp>
+        <p:nvSpPr>
+          <p:cNvPr id="4" name="TextBox 3"/>
+          <p:cNvSpPr txBox="1"/>
+          <p:nvPr/>
+        </p:nvSpPr>
+        <p:spPr>
+          <a:xfrm>
+            <a:off x="411480" y="1298448"/>
+            <a:ext cx="5806440" cy="274320"/>
+          </a:xfrm>
+          <a:prstGeom prst="rect">
+            <a:avLst/>
+          </a:prstGeom>
+          <a:noFill/>
+        </p:spPr>
+        <p:txBody>
+          <a:bodyPr wrap="square">
+            <a:spAutoFit/>
+          </a:bodyPr>
+          <a:lstStyle/>
+          <a:p>
+            <a:pPr>
+              <a:spcAft>
+                <a:spcPts val="600"/>
+              </a:spcAft>
+            </a:pPr>
+            <a:r>
+              <a:rPr sz="1200" b="0">
+                <a:solidFill>
+                  <a:srgbClr val="282828"/>
+                </a:solidFill>
+                <a:latin typeface="Arial"/>
+              </a:rPr>
+              <a:t>•  The primary segments into a pie or hex tiling with physical apertures; every segment gets rigid-body and surface-figure sensitivity channels, stacked into one Jacobian — the control basis.</a:t>
+            </a:r>
+          </a:p>
+          <a:p>
+            <a:pPr>
+              <a:spcAft>
+                <a:spcPts val="600"/>
+              </a:spcAft>
+            </a:pPr>
+            <a:r>
+              <a:rPr sz="1200" b="0">
+                <a:solidFill>
+                  <a:srgbClr val="282828"/>
+                </a:solidFill>
+                <a:latin typeface="Arial"/>
+              </a:rPr>
+              <a:t>•  Metrology is an optimization on that basis: edge-sensor and beam-launcher layouts scored by the control information they carry, not by symmetry; the winning pattern exports as a reusable preset.</a:t>
+            </a:r>
+          </a:p>
+        </p:txBody>
+      </p:sp>
+      <p:pic>
+        <p:nvPicPr>
+          <p:cNvPr id="5" name="Picture 4" descr="rowpair_s3_views_pie.png"/>
+          <p:cNvPicPr>
+            <a:picLocks noChangeAspect="1"/>
+          </p:cNvPicPr>
+          <p:nvPr/>
+        </p:nvPicPr>
+        <p:blipFill>
+          <a:blip r:embed="rId2"/>
+          <a:stretch>
+            <a:fillRect/>
+          </a:stretch>
+        </p:blipFill>
+        <p:spPr>
+          <a:xfrm>
+            <a:off x="6618167" y="1298448"/>
+            <a:ext cx="4960224" cy="1965451"/>
+          </a:xfrm>
+          <a:prstGeom prst="rect">
+            <a:avLst/>
+          </a:prstGeom>
+        </p:spPr>
+      </p:pic>
+      <p:sp>
+        <p:nvSpPr>
+          <p:cNvPr id="6" name="TextBox 5"/>
+          <p:cNvSpPr txBox="1"/>
+          <p:nvPr/>
+        </p:nvSpPr>
+        <p:spPr>
+          <a:xfrm>
+            <a:off x="6400800" y="3282188"/>
+            <a:ext cx="5394960" cy="229107"/>
+          </a:xfrm>
+          <a:prstGeom prst="rect">
+            <a:avLst/>
+          </a:prstGeom>
+          <a:noFill/>
+        </p:spPr>
+        <p:txBody>
+          <a:bodyPr wrap="square">
+            <a:spAutoFit/>
+          </a:bodyPr>
+          <a:lstStyle/>
+          <a:p>
+            <a:pPr algn="ctr">
+              <a:spcAft>
+                <a:spcPts val="0"/>
+              </a:spcAft>
+            </a:pPr>
+            <a:r>
+              <a:rPr sz="1000" b="0">
+                <a:solidFill>
+                  <a:srgbClr val="6E6E6E"/>
+                </a:solidFill>
+                <a:latin typeface="Arial"/>
+              </a:rPr>
+              <a:t>The segmented primary with physical apertures (front + iso views).</a:t>
+            </a:r>
+          </a:p>
+        </p:txBody>
+      </p:sp>
+      <p:pic>
+        <p:nvPicPr>
+          <p:cNvPr id="7" name="Picture 6" descr="e2e_pie_met_view_rx.png"/>
+          <p:cNvPicPr>
+            <a:picLocks noChangeAspect="1"/>
+          </p:cNvPicPr>
+          <p:nvPr/>
+        </p:nvPicPr>
+        <p:blipFill>
+          <a:blip r:embed="rId3"/>
+          <a:stretch>
+            <a:fillRect/>
+          </a:stretch>
+        </p:blipFill>
+        <p:spPr>
+          <a:xfrm>
+            <a:off x="7662896" y="3547872"/>
+            <a:ext cx="2870767" cy="1874011"/>
+          </a:xfrm>
+          <a:prstGeom prst="rect">
+            <a:avLst/>
+          </a:prstGeom>
+        </p:spPr>
+      </p:pic>
+      <p:sp>
+        <p:nvSpPr>
+          <p:cNvPr id="8" name="TextBox 7"/>
+          <p:cNvSpPr txBox="1"/>
+          <p:nvPr/>
+        </p:nvSpPr>
+        <p:spPr>
+          <a:xfrm>
+            <a:off x="6400800" y="5440171"/>
+            <a:ext cx="5394960" cy="229107"/>
+          </a:xfrm>
+          <a:prstGeom prst="rect">
+            <a:avLst/>
+          </a:prstGeom>
+          <a:noFill/>
+        </p:spPr>
+        <p:txBody>
+          <a:bodyPr wrap="square">
+            <a:spAutoFit/>
+          </a:bodyPr>
+          <a:lstStyle/>
+          <a:p>
+            <a:pPr algn="ctr">
+              <a:spcAft>
+                <a:spcPts val="0"/>
+              </a:spcAft>
+            </a:pPr>
+            <a:r>
+              <a:rPr sz="1000" b="0">
+                <a:solidFill>
+                  <a:srgbClr val="6E6E6E"/>
+                </a:solidFill>
+                <a:latin typeface="Arial"/>
+              </a:rPr>
+              <a:t>The optimized metrology layout on the segmented primary.</a:t>
+            </a:r>
+          </a:p>
+        </p:txBody>
+      </p:sp>
+      <p:sp>
+        <p:nvSpPr>
+          <p:cNvPr id="9" name="TextBox 8"/>
+          <p:cNvSpPr txBox="1"/>
+          <p:nvPr/>
+        </p:nvSpPr>
+        <p:spPr>
+          <a:xfrm>
+            <a:off x="6400800" y="5705855"/>
+            <a:ext cx="5394960" cy="274320"/>
+          </a:xfrm>
+          <a:prstGeom prst="rect">
+            <a:avLst/>
+          </a:prstGeom>
+          <a:noFill/>
+        </p:spPr>
+        <p:txBody>
+          <a:bodyPr wrap="square">
+            <a:spAutoFit/>
+          </a:bodyPr>
+          <a:lstStyle/>
+          <a:p>
+            <a:pPr>
+              <a:spcAft>
+                <a:spcPts val="600"/>
+              </a:spcAft>
+            </a:pPr>
+            <a:r>
+              <a:rPr sz="1050" b="0">
+                <a:solidFill>
+                  <a:srgbClr val="6E6E6E"/>
+                </a:solidFill>
+                <a:latin typeface="Arial"/>
+              </a:rPr>
+              <a:t>Record: templates/80_end_to_end/e2e, stages 3–5.</a:t>
+            </a:r>
+          </a:p>
+        </p:txBody>
+      </p:sp>
+    </p:spTree>
+  </p:cSld>
+  <p:clrMapOvr>
+    <a:masterClrMapping/>
+  </p:clrMapOvr>
+</p:sld>
+</file>
+
+<file path=ppt/slides/slide41.xml><?xml version="1.0" encoding="utf-8"?>
 <p:sld xmlns:a="http://schemas.openxmlformats.org/drawingml/2006/main" xmlns:p="http://schemas.openxmlformats.org/presentationml/2006/main" xmlns:r="http://schemas.openxmlformats.org/officeDocument/2006/relationships">
   <p:cSld>
     <p:spTree>

</xml_diff>

<commit_message>
demo_session: edit deck + baseline synced (CF5b build, 41 slides)
Co-Authored-By: Claude Fable 5 <noreply@anthropic.com>
</commit_message>
<xml_diff>
--- a/demo_session/baseline_pass3.pptx
+++ b/demo_session/baseline_pass3.pptx
@@ -11315,7 +11315,7 @@
                 </a:solidFill>
                 <a:latin typeface="Arial"/>
               </a:rPr>
-              <a:t>A randomly disturbed observatory, simulated</a:t>
+              <a:t>Digging the dark hole: the overnight restart ladder</a:t>
             </a:r>
           </a:p>
           <a:p>
@@ -11331,7 +11331,7 @@
                 </a:solidFill>
                 <a:latin typeface="Arial"/>
               </a:rPr>
-              <a:t>The closed loop holds dark-zone contrast at 2.5×10⁻⁷ where the uncontrolled series drifts to 1.7×10⁻⁶</a:t>
+              <a:t>1.2×10⁻⁶ → 1.1×10⁻⁹ — three decades from restart scheduling alone; no new hardware, no new physics</a:t>
             </a:r>
           </a:p>
         </p:txBody>
@@ -11414,7 +11414,7 @@
                 </a:solidFill>
                 <a:latin typeface="Arial"/>
               </a:rPr>
-              <a:t>•  Random segment drift is injected; the rigid-body loop senses through the designed metrology, estimates and corrects, while EFC re-solves the dark zone per scored frame — all on one model.</a:t>
+              <a:t>•  The recipe: EFC to a floor, relinearize about the dug state, restart at that floor — rinse and repeat.  Ten digging rounds, ~4 h unattended, on the d = 1.10 m two-DM variant — the spacing study's best linear substrate; three stall rounds then prove the plateau.</a:t>
             </a:r>
           </a:p>
           <a:p>
@@ -11430,7 +11430,7 @@
                 </a:solidFill>
                 <a:latin typeface="Arial"/>
               </a:rPr>
-              <a:t>•  The disturbance interface is the point: the same channels are built to ingest dynamical- and thermal-model time histories — simulating performance in the space environment.  Work in progress.</a:t>
+              <a:t>•  The controller was the bottleneck, measured: a single linearization stalls at 9.0×10⁻⁷; every restart bought another step down.  DM strokes end at 33 nm rms, well inside the 50 nm budget.</a:t>
             </a:r>
           </a:p>
           <a:p>
@@ -11446,14 +11446,14 @@
                 </a:solidFill>
                 <a:latin typeface="Arial"/>
               </a:rPr>
-              <a:t>•  Honest gap, attributed: the hold level is the loop mechanization's floor (sensor noise through the gain, damped EFC), not the model's limit — the next slide digs the static dark hole three decades deeper, overnight.</a:t>
+              <a:t>•  The remaining 1.5 decades are priced: re-measured at every dug state, the linear-achievable floor holds at 2–4×10⁻¹¹ — HWO-class 5×10⁻¹¹ is within this substrate's reach.  The plateau at 1.1×10⁻⁹ is the monotone Tikhonov step rule: the measured case for FALCO-grade step control on this same model.</a:t>
             </a:r>
           </a:p>
         </p:txBody>
       </p:sp>
       <p:pic>
         <p:nvPicPr>
-          <p:cNvPr id="5" name="Picture 4" descr="r4_series_3nm.png"/>
+          <p:cNvPr id="5" name="Picture 4" descr="fig_cf3d_ladder.png"/>
           <p:cNvPicPr>
             <a:picLocks noChangeAspect="1"/>
           </p:cNvPicPr>
@@ -11467,8 +11467,8 @@
         </p:blipFill>
         <p:spPr>
           <a:xfrm>
-            <a:off x="6923477" y="1298448"/>
-            <a:ext cx="4349605" cy="4177792"/>
+            <a:off x="6400800" y="1298448"/>
+            <a:ext cx="5394960" cy="3637305"/>
           </a:xfrm>
           <a:prstGeom prst="rect">
             <a:avLst/>
@@ -11483,7 +11483,7 @@
         </p:nvSpPr>
         <p:spPr>
           <a:xfrm>
-            <a:off x="6400800" y="5494528"/>
+            <a:off x="6400800" y="4954041"/>
             <a:ext cx="5394960" cy="394208"/>
           </a:xfrm>
           <a:prstGeom prst="rect">
@@ -11509,7 +11509,7 @@
                 </a:solidFill>
                 <a:latin typeface="Arial"/>
               </a:rPr>
-              <a:t>Four hundred seconds under drift: segment rigid-body state, wavefront at the coronagraph exit pupil, and science-plane contrast — open loop against closed.</a:t>
+              <a:t>The ladder: measured dark-zone floor by restart round, with the linear-achievable substrate re-measured at every dug state.</a:t>
             </a:r>
           </a:p>
         </p:txBody>
@@ -11522,7 +11522,7 @@
         </p:nvSpPr>
         <p:spPr>
           <a:xfrm>
-            <a:off x="6400800" y="5925312"/>
+            <a:off x="6400800" y="5384825"/>
             <a:ext cx="5394960" cy="274320"/>
           </a:xfrm>
           <a:prstGeom prst="rect">
@@ -11548,7 +11548,7 @@
                 </a:solidFill>
                 <a:latin typeface="Arial"/>
               </a:rPr>
-              <a:t>Record: templates/80_end_to_end/e2e6m_r2, time-series stage.</a:t>
+              <a:t>Record: templates/80_end_to_end/e2e6m_r2, CF3d stage — checkpointed and resumable; every round is a finished floor.</a:t>
             </a:r>
           </a:p>
         </p:txBody>
@@ -11605,7 +11605,7 @@
                 </a:solidFill>
                 <a:latin typeface="Arial"/>
               </a:rPr>
-              <a:t>Digging the dark hole: the overnight restart ladder</a:t>
+              <a:t>Inside the dig, station by station</a:t>
             </a:r>
           </a:p>
           <a:p>
@@ -11621,7 +11621,7 @@
                 </a:solidFill>
                 <a:latin typeface="Arial"/>
               </a:rPr>
-              <a:t>1.2×10⁻⁶ → 1.1×10⁻⁹ — three decades from restart scheduling alone; no new hardware, no new physics</a:t>
+              <a:t>Intensity at seven internal planes — the DM commands visibly do the gap work</a:t>
             </a:r>
           </a:p>
         </p:txBody>
@@ -11670,80 +11670,9 @@
           </a:p>
         </p:txBody>
       </p:sp>
-      <p:sp>
-        <p:nvSpPr>
-          <p:cNvPr id="4" name="TextBox 3"/>
-          <p:cNvSpPr txBox="1"/>
-          <p:nvPr/>
-        </p:nvSpPr>
-        <p:spPr>
-          <a:xfrm>
-            <a:off x="411480" y="1298448"/>
-            <a:ext cx="5806440" cy="274320"/>
-          </a:xfrm>
-          <a:prstGeom prst="rect">
-            <a:avLst/>
-          </a:prstGeom>
-          <a:noFill/>
-        </p:spPr>
-        <p:txBody>
-          <a:bodyPr wrap="square">
-            <a:spAutoFit/>
-          </a:bodyPr>
-          <a:lstStyle/>
-          <a:p>
-            <a:pPr>
-              <a:spcAft>
-                <a:spcPts val="600"/>
-              </a:spcAft>
-            </a:pPr>
-            <a:r>
-              <a:rPr sz="1200" b="0">
-                <a:solidFill>
-                  <a:srgbClr val="282828"/>
-                </a:solidFill>
-                <a:latin typeface="Arial"/>
-              </a:rPr>
-              <a:t>•  The recipe: EFC to a floor, relinearize about the dug state, restart at that floor — rinse and repeat.  Ten digging rounds, ~4 h unattended, on the d = 1.10 m two-DM variant — the spacing study's best linear substrate; three stall rounds then prove the plateau.</a:t>
-            </a:r>
-          </a:p>
-          <a:p>
-            <a:pPr>
-              <a:spcAft>
-                <a:spcPts val="600"/>
-              </a:spcAft>
-            </a:pPr>
-            <a:r>
-              <a:rPr sz="1200" b="0">
-                <a:solidFill>
-                  <a:srgbClr val="282828"/>
-                </a:solidFill>
-                <a:latin typeface="Arial"/>
-              </a:rPr>
-              <a:t>•  The controller was the bottleneck, measured: a single linearization stalls at 9.0×10⁻⁷; every restart bought another step down.  DM strokes end at 33 nm rms, well inside the 50 nm budget.</a:t>
-            </a:r>
-          </a:p>
-          <a:p>
-            <a:pPr>
-              <a:spcAft>
-                <a:spcPts val="600"/>
-              </a:spcAft>
-            </a:pPr>
-            <a:r>
-              <a:rPr sz="1200" b="0">
-                <a:solidFill>
-                  <a:srgbClr val="282828"/>
-                </a:solidFill>
-                <a:latin typeface="Arial"/>
-              </a:rPr>
-              <a:t>•  The remaining 1.5 decades are priced: re-measured at every dug state, the linear-achievable floor holds at 2–4×10⁻¹¹ — HWO-class 5×10⁻¹¹ is within this substrate's reach.  The plateau at 1.1×10⁻⁹ is the monotone Tikhonov step rule: the measured case for FALCO-grade step control on this same model.</a:t>
-            </a:r>
-          </a:p>
-        </p:txBody>
-      </p:sp>
       <p:pic>
         <p:nvPicPr>
-          <p:cNvPr id="5" name="Picture 4" descr="fig_cf3d_ladder.png"/>
+          <p:cNvPr id="4" name="Picture 3" descr="fig_cf3d_stations_wide.png"/>
           <p:cNvPicPr>
             <a:picLocks noChangeAspect="1"/>
           </p:cNvPicPr>
@@ -11757,8 +11686,8 @@
         </p:blipFill>
         <p:spPr>
           <a:xfrm>
-            <a:off x="6400800" y="1298448"/>
-            <a:ext cx="5394960" cy="3637305"/>
+            <a:off x="1544429" y="1298448"/>
+            <a:ext cx="9102837" cy="2257552"/>
           </a:xfrm>
           <a:prstGeom prst="rect">
             <a:avLst/>
@@ -11767,14 +11696,14 @@
       </p:pic>
       <p:sp>
         <p:nvSpPr>
-          <p:cNvPr id="6" name="TextBox 5"/>
+          <p:cNvPr id="5" name="TextBox 4"/>
           <p:cNvSpPr txBox="1"/>
           <p:nvPr/>
         </p:nvSpPr>
         <p:spPr>
           <a:xfrm>
-            <a:off x="6400800" y="4954041"/>
-            <a:ext cx="5394960" cy="394208"/>
+            <a:off x="411480" y="3574288"/>
+            <a:ext cx="11368735" cy="394208"/>
           </a:xfrm>
           <a:prstGeom prst="rect">
             <a:avLst/>
@@ -11799,21 +11728,21 @@
                 </a:solidFill>
                 <a:latin typeface="Arial"/>
               </a:rPr>
-              <a:t>The ladder: measured dark-zone floor by restart round, with the linear-achievable substrate re-measured at every dug state.</a:t>
-            </a:r>
-          </a:p>
-        </p:txBody>
-      </p:sp>
-      <p:sp>
-        <p:nvSpPr>
-          <p:cNvPr id="7" name="TextBox 6"/>
+              <a:t>Seven planes, DMs flat (top row) against the dug state (bottom): pupil, apodizer, focal plane before and after the occulter, Lyot plane before and after the stop, science-plane contrast.  The dug row ends in the full 3–15 λ/D annular dark hole at the 10⁻⁹ floor; the in-walk dark-zone means reproduce the scored record exactly.</a:t>
+            </a:r>
+          </a:p>
+        </p:txBody>
+      </p:sp>
+      <p:sp>
+        <p:nvSpPr>
+          <p:cNvPr id="6" name="TextBox 5"/>
           <p:cNvSpPr txBox="1"/>
           <p:nvPr/>
         </p:nvSpPr>
         <p:spPr>
           <a:xfrm>
-            <a:off x="6400800" y="5384825"/>
-            <a:ext cx="5394960" cy="274320"/>
+            <a:off x="411480" y="4005072"/>
+            <a:ext cx="11368735" cy="274320"/>
           </a:xfrm>
           <a:prstGeom prst="rect">
             <a:avLst/>
@@ -11832,13 +11761,92 @@
               </a:spcAft>
             </a:pPr>
             <a:r>
+              <a:rPr sz="1500" b="0">
+                <a:solidFill>
+                  <a:srgbClr val="282828"/>
+                </a:solidFill>
+                <a:latin typeface="Arial"/>
+              </a:rPr>
+              <a:t>•  DM1's command map imprints the hex-gap lattice — the controller is doing the gap-and-edge work the apodizer was bought for, actuator by actuator, at 33 nm rms; a no-apodizer A/B to price the throughput trade is the scoped follow-on.</a:t>
+            </a:r>
+          </a:p>
+          <a:p>
+            <a:pPr>
+              <a:spcAft>
+                <a:spcPts val="600"/>
+              </a:spcAft>
+            </a:pPr>
+            <a:r>
+              <a:rPr sz="1500" b="0">
+                <a:solidFill>
+                  <a:srgbClr val="282828"/>
+                </a:solidFill>
+                <a:latin typeface="Arial"/>
+              </a:rPr>
+              <a:t>•  The 0.90 Lyot stop removes only ~0.1% of the post-occulter energy — this train's rejected light is interior gap structure, not edge rings, so the Lyot radius is not where the suppression happens.</a:t>
+            </a:r>
+          </a:p>
+        </p:txBody>
+      </p:sp>
+      <p:pic>
+        <p:nvPicPr>
+          <p:cNvPr id="7" name="Picture 6" descr="fig_cf3d_dm_state.png"/>
+          <p:cNvPicPr>
+            <a:picLocks noChangeAspect="1"/>
+          </p:cNvPicPr>
+          <p:nvPr/>
+        </p:nvPicPr>
+        <p:blipFill>
+          <a:blip r:embed="rId3"/>
+          <a:stretch>
+            <a:fillRect/>
+          </a:stretch>
+        </p:blipFill>
+        <p:spPr>
+          <a:xfrm>
+            <a:off x="4763617" y="5312664"/>
+            <a:ext cx="2664460" cy="1188720"/>
+          </a:xfrm>
+          <a:prstGeom prst="rect">
+            <a:avLst/>
+          </a:prstGeom>
+        </p:spPr>
+      </p:pic>
+      <p:sp>
+        <p:nvSpPr>
+          <p:cNvPr id="8" name="TextBox 7"/>
+          <p:cNvSpPr txBox="1"/>
+          <p:nvPr/>
+        </p:nvSpPr>
+        <p:spPr>
+          <a:xfrm>
+            <a:off x="411480" y="6501384"/>
+            <a:ext cx="11368735" cy="274320"/>
+          </a:xfrm>
+          <a:prstGeom prst="rect">
+            <a:avLst/>
+          </a:prstGeom>
+          <a:noFill/>
+        </p:spPr>
+        <p:txBody>
+          <a:bodyPr wrap="square">
+            <a:spAutoFit/>
+          </a:bodyPr>
+          <a:lstStyle/>
+          <a:p>
+            <a:pPr>
+              <a:spcAft>
+                <a:spcPts val="600"/>
+              </a:spcAft>
+            </a:pPr>
+            <a:r>
               <a:rPr sz="1050" b="0">
                 <a:solidFill>
                   <a:srgbClr val="6E6E6E"/>
                 </a:solidFill>
                 <a:latin typeface="Arial"/>
               </a:rPr>
-              <a:t>Record: templates/80_end_to_end/e2e6m_r2, CF3d stage — checkpointed and resumable; every round is a finished floor.</a:t>
+              <a:t>The CTB documentation model — intensity at key planes, compact-vs-full — applied to the observatory train: same station layout, the two columns now DMs-flat vs dug.</a:t>
             </a:r>
           </a:p>
         </p:txBody>
@@ -11895,7 +11903,7 @@
                 </a:solidFill>
                 <a:latin typeface="Arial"/>
               </a:rPr>
-              <a:t>Inside the dig, station by station</a:t>
+              <a:t>A randomly disturbed observatory, simulated</a:t>
             </a:r>
           </a:p>
           <a:p>
@@ -11911,7 +11919,7 @@
                 </a:solidFill>
                 <a:latin typeface="Arial"/>
               </a:rPr>
-              <a:t>Intensity at seven internal planes — the DM commands visibly do the gap work</a:t>
+              <a:t>JWST-class drift on the dug dark hole: open loop decays 4.5 decades in a day — the loop holds 2×10⁻⁹</a:t>
             </a:r>
           </a:p>
         </p:txBody>
@@ -11960,9 +11968,96 @@
           </a:p>
         </p:txBody>
       </p:sp>
+      <p:sp>
+        <p:nvSpPr>
+          <p:cNvPr id="4" name="TextBox 3"/>
+          <p:cNvSpPr txBox="1"/>
+          <p:nvPr/>
+        </p:nvSpPr>
+        <p:spPr>
+          <a:xfrm>
+            <a:off x="411480" y="1298448"/>
+            <a:ext cx="5806440" cy="274320"/>
+          </a:xfrm>
+          <a:prstGeom prst="rect">
+            <a:avLst/>
+          </a:prstGeom>
+          <a:noFill/>
+        </p:spPr>
+        <p:txBody>
+          <a:bodyPr wrap="square">
+            <a:spAutoFit/>
+          </a:bodyPr>
+          <a:lstStyle/>
+          <a:p>
+            <a:pPr>
+              <a:spcAft>
+                <a:spcPts val="600"/>
+              </a:spcAft>
+            </a:pPr>
+            <a:r>
+              <a:rPr sz="1200" b="0">
+                <a:solidFill>
+                  <a:srgbClr val="282828"/>
+                </a:solidFill>
+                <a:latin typeface="Arial"/>
+              </a:rPr>
+              <a:t>•  The series starts at the new solution — frame one reproduces the dug floor (1.134 vs 1.133×10⁻⁹, a built-in gate) — and runs a JWST-experience disturbance: a 10 nm/hr correlated drift ramp plus a 0.5 nm-per-step walk, 24 hours at 30-minute frames.</a:t>
+            </a:r>
+          </a:p>
+          <a:p>
+            <a:pPr>
+              <a:spcAft>
+                <a:spcPts val="600"/>
+              </a:spcAft>
+            </a:pPr>
+            <a:r>
+              <a:rPr sz="1200" b="0">
+                <a:solidFill>
+                  <a:srgbClr val="282828"/>
+                </a:solidFill>
+                <a:latin typeface="Arial"/>
+              </a:rPr>
+              <a:t>•  Open loop, DMs frozen at the dug state: 1.1×10⁻⁹ → 3.9×10⁻⁵.  The first decade is lost to the first nanometre of drift — at 10⁻⁹, continuous control is not optional.</a:t>
+            </a:r>
+          </a:p>
+          <a:p>
+            <a:pPr>
+              <a:spcAft>
+                <a:spcPts val="600"/>
+              </a:spcAft>
+            </a:pPr>
+            <a:r>
+              <a:rPr sz="1200" b="0">
+                <a:solidFill>
+                  <a:srgbClr val="282828"/>
+                </a:solidFill>
+                <a:latin typeface="Arial"/>
+              </a:rPr>
+              <a:t>•  Closed loop: the rigid-body loop senses through the designed metrology and holds the segment state at 1.2 nm against 23 nm of accumulated drift; a guarded EFC hold — one damped step per hour about the dug-state Jacobian, 25 steps taken, none reverted — keeps the dark zone at ~2×10⁻⁹ for the full day.</a:t>
+            </a:r>
+          </a:p>
+          <a:p>
+            <a:pPr>
+              <a:spcAft>
+                <a:spcPts val="600"/>
+              </a:spcAft>
+            </a:pPr>
+            <a:r>
+              <a:rPr sz="1200" b="0">
+                <a:solidFill>
+                  <a:srgbClr val="282828"/>
+                </a:solidFill>
+                <a:latin typeface="Arial"/>
+              </a:rPr>
+              <a:t>•  The disturbance interface is the point: the same channels ingest dynamical- and thermal-model time histories — simulating performance in the space environment.</a:t>
+            </a:r>
+          </a:p>
+        </p:txBody>
+      </p:sp>
       <p:pic>
         <p:nvPicPr>
-          <p:cNvPr id="4" name="Picture 3" descr="fig_cf3d_stations_wide.png"/>
+          <p:cNvPr id="5" name="Picture 4" descr="fig_cf5b_jwst.png"/>
           <p:cNvPicPr>
             <a:picLocks noChangeAspect="1"/>
           </p:cNvPicPr>
@@ -11976,8 +12071,8 @@
         </p:blipFill>
         <p:spPr>
           <a:xfrm>
-            <a:off x="1544429" y="1298448"/>
-            <a:ext cx="9102837" cy="2257552"/>
+            <a:off x="7029688" y="1298448"/>
+            <a:ext cx="4137183" cy="4012692"/>
           </a:xfrm>
           <a:prstGeom prst="rect">
             <a:avLst/>
@@ -11986,14 +12081,14 @@
       </p:pic>
       <p:sp>
         <p:nvSpPr>
-          <p:cNvPr id="5" name="TextBox 4"/>
+          <p:cNvPr id="6" name="TextBox 5"/>
           <p:cNvSpPr txBox="1"/>
           <p:nvPr/>
         </p:nvSpPr>
         <p:spPr>
           <a:xfrm>
-            <a:off x="411480" y="3574288"/>
-            <a:ext cx="11368735" cy="394208"/>
+            <a:off x="6400800" y="5329428"/>
+            <a:ext cx="5394960" cy="559307"/>
           </a:xfrm>
           <a:prstGeom prst="rect">
             <a:avLst/>
@@ -12018,21 +12113,21 @@
                 </a:solidFill>
                 <a:latin typeface="Arial"/>
               </a:rPr>
-              <a:t>Seven planes, DMs flat (top row) against the dug state (bottom): pupil, apodizer, focal plane before and after the occulter, Lyot plane before and after the stop, science-plane contrast.  The dug row ends in the full 3–15 λ/D annular dark hole at the 10⁻⁹ floor; the in-walk dark-zone means reproduce the scored record exactly.</a:t>
-            </a:r>
-          </a:p>
-        </p:txBody>
-      </p:sp>
-      <p:sp>
-        <p:nvSpPr>
-          <p:cNvPr id="6" name="TextBox 5"/>
+              <a:t>Twenty-four hours under JWST-class drift, both passes starting from the dug dark hole: segment rigid-body state, exit-pupil wavefront, and science-plane contrast — open loop against closed.</a:t>
+            </a:r>
+          </a:p>
+        </p:txBody>
+      </p:sp>
+      <p:sp>
+        <p:nvSpPr>
+          <p:cNvPr id="7" name="TextBox 6"/>
           <p:cNvSpPr txBox="1"/>
           <p:nvPr/>
         </p:nvSpPr>
         <p:spPr>
           <a:xfrm>
-            <a:off x="411480" y="4005072"/>
-            <a:ext cx="11368735" cy="274320"/>
+            <a:off x="6400800" y="5925312"/>
+            <a:ext cx="5394960" cy="274320"/>
           </a:xfrm>
           <a:prstGeom prst="rect">
             <a:avLst/>
@@ -12051,92 +12146,13 @@
               </a:spcAft>
             </a:pPr>
             <a:r>
-              <a:rPr sz="1500" b="0">
-                <a:solidFill>
-                  <a:srgbClr val="282828"/>
-                </a:solidFill>
-                <a:latin typeface="Arial"/>
-              </a:rPr>
-              <a:t>•  DM1's command map imprints the hex-gap lattice — the controller is doing the gap-and-edge work the apodizer was bought for, actuator by actuator, at 33 nm rms; a no-apodizer A/B to price the throughput trade is the scoped follow-on.</a:t>
-            </a:r>
-          </a:p>
-          <a:p>
-            <a:pPr>
-              <a:spcAft>
-                <a:spcPts val="600"/>
-              </a:spcAft>
-            </a:pPr>
-            <a:r>
-              <a:rPr sz="1500" b="0">
-                <a:solidFill>
-                  <a:srgbClr val="282828"/>
-                </a:solidFill>
-                <a:latin typeface="Arial"/>
-              </a:rPr>
-              <a:t>•  The 0.90 Lyot stop removes only ~0.1% of the post-occulter energy — this train's rejected light is interior gap structure, not edge rings, so the Lyot radius is not where the suppression happens.</a:t>
-            </a:r>
-          </a:p>
-        </p:txBody>
-      </p:sp>
-      <p:pic>
-        <p:nvPicPr>
-          <p:cNvPr id="7" name="Picture 6" descr="fig_cf3d_dm_state.png"/>
-          <p:cNvPicPr>
-            <a:picLocks noChangeAspect="1"/>
-          </p:cNvPicPr>
-          <p:nvPr/>
-        </p:nvPicPr>
-        <p:blipFill>
-          <a:blip r:embed="rId3"/>
-          <a:stretch>
-            <a:fillRect/>
-          </a:stretch>
-        </p:blipFill>
-        <p:spPr>
-          <a:xfrm>
-            <a:off x="4763617" y="5312664"/>
-            <a:ext cx="2664460" cy="1188720"/>
-          </a:xfrm>
-          <a:prstGeom prst="rect">
-            <a:avLst/>
-          </a:prstGeom>
-        </p:spPr>
-      </p:pic>
-      <p:sp>
-        <p:nvSpPr>
-          <p:cNvPr id="8" name="TextBox 7"/>
-          <p:cNvSpPr txBox="1"/>
-          <p:nvPr/>
-        </p:nvSpPr>
-        <p:spPr>
-          <a:xfrm>
-            <a:off x="411480" y="6501384"/>
-            <a:ext cx="11368735" cy="274320"/>
-          </a:xfrm>
-          <a:prstGeom prst="rect">
-            <a:avLst/>
-          </a:prstGeom>
-          <a:noFill/>
-        </p:spPr>
-        <p:txBody>
-          <a:bodyPr wrap="square">
-            <a:spAutoFit/>
-          </a:bodyPr>
-          <a:lstStyle/>
-          <a:p>
-            <a:pPr>
-              <a:spcAft>
-                <a:spcPts val="600"/>
-              </a:spcAft>
-            </a:pPr>
-            <a:r>
               <a:rPr sz="1050" b="0">
                 <a:solidFill>
                   <a:srgbClr val="6E6E6E"/>
                 </a:solidFill>
                 <a:latin typeface="Arial"/>
               </a:rPr>
-              <a:t>The CTB documentation model — intensity at key planes, compact-vs-full — applied to the observatory train: same station layout, the two columns now DMs-flat vs dug.</a:t>
+              <a:t>Record: templates/80_end_to_end/e2e6m_r2, CF5b stage — d=1.10 deck, G = the ladder's dug-state Jacobian.</a:t>
             </a:r>
           </a:p>
         </p:txBody>

</xml_diff>

<commit_message>
deck: Dave's pass-6 folded (JWST->random wording, aphorism to footnote, slide 11/27/29/30/32/33 layouts+fonts) + slide-30 4-view re-tiled tight
The 4-view crop: per-quadrant white trim + re-tile (2250x1938 ->
1018x1474), spanning title removed; placed in Dave's enlarged box at
the crop's own aspect.

Co-Authored-By: Claude Fable 5 <noreply@anthropic.com>
</commit_message>
<xml_diff>
--- a/demo_session/baseline_pass3.pptx
+++ b/demo_session/baseline_pass3.pptx
@@ -4683,8 +4683,8 @@
         </p:blipFill>
         <p:spPr>
           <a:xfrm>
-            <a:off x="7393057" y="1298448"/>
-            <a:ext cx="3410444" cy="2623312"/>
+            <a:off x="6510528" y="1261872"/>
+            <a:ext cx="5148072" cy="3959352"/>
           </a:xfrm>
           <a:prstGeom prst="rect">
             <a:avLst/>
@@ -4699,7 +4699,7 @@
         </p:nvSpPr>
         <p:spPr>
           <a:xfrm>
-            <a:off x="6400800" y="3940047"/>
+            <a:off x="6400800" y="5129784"/>
             <a:ext cx="5394960" cy="394208"/>
           </a:xfrm>
           <a:prstGeom prst="rect">
@@ -4738,7 +4738,7 @@
         </p:nvSpPr>
         <p:spPr>
           <a:xfrm>
-            <a:off x="6400800" y="4370831"/>
+            <a:off x="6400800" y="5559552"/>
             <a:ext cx="5394960" cy="274320"/>
           </a:xfrm>
           <a:prstGeom prst="rect">
@@ -11408,7 +11408,7 @@
               </a:spcAft>
             </a:pPr>
             <a:r>
-              <a:rPr sz="1200" b="0">
+              <a:rPr sz="1800" b="0">
                 <a:solidFill>
                   <a:srgbClr val="282828"/>
                 </a:solidFill>
@@ -11424,7 +11424,7 @@
               </a:spcAft>
             </a:pPr>
             <a:r>
-              <a:rPr sz="1200" b="0">
+              <a:rPr sz="1800" b="0">
                 <a:solidFill>
                   <a:srgbClr val="282828"/>
                 </a:solidFill>
@@ -11440,7 +11440,7 @@
               </a:spcAft>
             </a:pPr>
             <a:r>
-              <a:rPr sz="1200" b="0">
+              <a:rPr sz="1800" b="0">
                 <a:solidFill>
                   <a:srgbClr val="282828"/>
                 </a:solidFill>
@@ -11996,13 +11996,13 @@
               </a:spcAft>
             </a:pPr>
             <a:r>
-              <a:rPr sz="1200" b="0">
+              <a:rPr sz="1600" b="0">
                 <a:solidFill>
                   <a:srgbClr val="282828"/>
                 </a:solidFill>
                 <a:latin typeface="Arial"/>
               </a:rPr>
-              <a:t>•  The series starts at the new solution — frame one reproduces the dug floor (1.134 vs 1.133×10⁻⁹, a built-in gate) — and runs a JWST-experience disturbance: a 10 nm/hr correlated drift ramp plus a 0.5 nm-per-step walk, 24 hours at 30-minute frames.</a:t>
+              <a:t>•  The series starts at the new solution — frame one reproduces the dug floor (1.134 vs 1.133×10⁻⁹, a built-in gate) — and runs a random disturbance: a 10 nm/hr correlated drift ramp plus a 0.5 nm-per-step walk, 24 hours at 30-minute frames.</a:t>
             </a:r>
           </a:p>
           <a:p>
@@ -12012,7 +12012,7 @@
               </a:spcAft>
             </a:pPr>
             <a:r>
-              <a:rPr sz="1200" b="0">
+              <a:rPr sz="1600" b="0">
                 <a:solidFill>
                   <a:srgbClr val="282828"/>
                 </a:solidFill>
@@ -12028,7 +12028,7 @@
               </a:spcAft>
             </a:pPr>
             <a:r>
-              <a:rPr sz="1200" b="0">
+              <a:rPr sz="1600" b="0">
                 <a:solidFill>
                   <a:srgbClr val="282828"/>
                 </a:solidFill>
@@ -12044,7 +12044,7 @@
               </a:spcAft>
             </a:pPr>
             <a:r>
-              <a:rPr sz="1200" b="0">
+              <a:rPr sz="1600" b="0">
                 <a:solidFill>
                   <a:srgbClr val="282828"/>
                 </a:solidFill>
@@ -12071,8 +12071,8 @@
         </p:blipFill>
         <p:spPr>
           <a:xfrm>
-            <a:off x="7029688" y="1298448"/>
-            <a:ext cx="4137183" cy="4012692"/>
+            <a:off x="6629400" y="1078992"/>
+            <a:ext cx="4572000" cy="4434840"/>
           </a:xfrm>
           <a:prstGeom prst="rect">
             <a:avLst/>
@@ -12087,7 +12087,7 @@
         </p:nvSpPr>
         <p:spPr>
           <a:xfrm>
-            <a:off x="6400800" y="5329428"/>
+            <a:off x="6400800" y="5513832"/>
             <a:ext cx="5394960" cy="559307"/>
           </a:xfrm>
           <a:prstGeom prst="rect">
@@ -12113,7 +12113,7 @@
                 </a:solidFill>
                 <a:latin typeface="Arial"/>
               </a:rPr>
-              <a:t>Twenty-four hours under JWST-class drift, both passes starting from the dug dark hole: segment rigid-body state, exit-pupil wavefront, and science-plane contrast — open loop against closed.</a:t>
+              <a:t>Twenty-four hours random drift, both passes starting from the dug dark hole: segment rigid-body state, exit-pupil wavefront, and science-plane contrast — open loop against closed.</a:t>
             </a:r>
           </a:p>
         </p:txBody>
@@ -12126,7 +12126,7 @@
         </p:nvSpPr>
         <p:spPr>
           <a:xfrm>
-            <a:off x="6400800" y="5925312"/>
+            <a:off x="6400800" y="6108192"/>
             <a:ext cx="5394960" cy="274320"/>
           </a:xfrm>
           <a:prstGeom prst="rect">
@@ -12146,7 +12146,7 @@
               </a:spcAft>
             </a:pPr>
             <a:r>
-              <a:rPr sz="1050" b="0">
+              <a:rPr sz="1200" b="0">
                 <a:solidFill>
                   <a:srgbClr val="6E6E6E"/>
                 </a:solidFill>
@@ -12546,7 +12546,7 @@
               </a:spcAft>
             </a:pPr>
             <a:r>
-              <a:rPr sz="1200" b="0">
+              <a:rPr sz="1600" b="0">
                 <a:solidFill>
                   <a:srgbClr val="282828"/>
                 </a:solidFill>
@@ -12562,7 +12562,7 @@
               </a:spcAft>
             </a:pPr>
             <a:r>
-              <a:rPr sz="1200" b="0">
+              <a:rPr sz="1600" b="0">
                 <a:solidFill>
                   <a:srgbClr val="282828"/>
                 </a:solidFill>
@@ -12578,7 +12578,7 @@
               </a:spcAft>
             </a:pPr>
             <a:r>
-              <a:rPr sz="1200" b="0">
+              <a:rPr sz="1600" b="0">
                 <a:solidFill>
                   <a:srgbClr val="282828"/>
                 </a:solidFill>
@@ -12591,7 +12591,7 @@
       </p:sp>
       <p:pic>
         <p:nvPicPr>
-          <p:cNvPr id="5" name="Picture 4" descr="oi_demo_12deg_layout.png"/>
+          <p:cNvPr id="5" name="Picture 4" descr="crop_oi_demo_12deg_layout.png"/>
           <p:cNvPicPr>
             <a:picLocks noChangeAspect="1"/>
           </p:cNvPicPr>
@@ -12605,8 +12605,8 @@
         </p:blipFill>
         <p:spPr>
           <a:xfrm>
-            <a:off x="8000103" y="1298448"/>
-            <a:ext cx="2196352" cy="1891792"/>
+            <a:off x="7168896" y="1298448"/>
+            <a:ext cx="3520440" cy="5102352"/>
           </a:xfrm>
           <a:prstGeom prst="rect">
             <a:avLst/>
@@ -12621,7 +12621,7 @@
         </p:nvSpPr>
         <p:spPr>
           <a:xfrm>
-            <a:off x="6400800" y="3208528"/>
+            <a:off x="6400800" y="6016752"/>
             <a:ext cx="5394960" cy="394208"/>
           </a:xfrm>
           <a:prstGeom prst="rect">
@@ -12668,7 +12668,7 @@
         </p:blipFill>
         <p:spPr>
           <a:xfrm>
-            <a:off x="7951092" y="3639312"/>
+            <a:off x="3635124" y="3995928"/>
             <a:ext cx="2294375" cy="2011680"/>
           </a:xfrm>
           <a:prstGeom prst="rect">
@@ -12684,7 +12684,7 @@
         </p:nvSpPr>
         <p:spPr>
           <a:xfrm>
-            <a:off x="6400800" y="5650992"/>
+            <a:off x="530352" y="6007608"/>
             <a:ext cx="5394960" cy="274320"/>
           </a:xfrm>
           <a:prstGeom prst="rect">
@@ -13170,8 +13170,8 @@
         </p:nvSpPr>
         <p:spPr>
           <a:xfrm>
-            <a:off x="411480" y="6658864"/>
-            <a:ext cx="11368735" cy="274320"/>
+            <a:off x="411480" y="6117336"/>
+            <a:ext cx="11365992" cy="274320"/>
           </a:xfrm>
           <a:prstGeom prst="rect">
             <a:avLst/>
@@ -13346,7 +13346,7 @@
               </a:spcAft>
             </a:pPr>
             <a:r>
-              <a:rPr sz="1600" b="0">
+              <a:rPr sz="1800" b="0">
                 <a:solidFill>
                   <a:srgbClr val="282828"/>
                 </a:solidFill>
@@ -13362,7 +13362,7 @@
               </a:spcAft>
             </a:pPr>
             <a:r>
-              <a:rPr sz="1600" b="0">
+              <a:rPr sz="1800" b="0">
                 <a:solidFill>
                   <a:srgbClr val="282828"/>
                 </a:solidFill>
@@ -13378,7 +13378,7 @@
               </a:spcAft>
             </a:pPr>
             <a:r>
-              <a:rPr sz="1600" b="0">
+              <a:rPr sz="1800" b="0">
                 <a:solidFill>
                   <a:srgbClr val="282828"/>
                 </a:solidFill>
@@ -13394,13 +13394,13 @@
               </a:spcAft>
             </a:pPr>
             <a:r>
-              <a:rPr sz="1600" b="0">
+              <a:rPr sz="1800" b="0">
                 <a:solidFill>
                   <a:srgbClr val="282828"/>
                 </a:solidFill>
                 <a:latin typeface="Arial"/>
               </a:rPr>
-              <a:t>•  Put the agent in the search, never in the numerics — starting points and basins (a warm-started walk beat the cold start 8500×); variable-set audits (35% of a metric unclaimed because one freedom was never offered); optimization schedules (a restart ladder dug the dark hole 1.2×10⁻⁶ → 1.1×10⁻⁹ overnight); tolerancing and glass searches.  The agent proposes; the trusted engine disposes.</a:t>
+              <a:t>•  Put the agent in the search, never in the numerics — starting points and basins (a warm-started walk beat the cold start 8500×); variable-set audits (35% of a metric unclaimed because one freedom was never offered); optimization schedules (a restart ladder dug the dark hole 1.2×10⁻⁶ → 1.1×10⁻⁹ overnight); tolerancing and glass searches.</a:t>
             </a:r>
           </a:p>
           <a:p>
@@ -13410,7 +13410,7 @@
               </a:spcAft>
             </a:pPr>
             <a:r>
-              <a:rPr sz="1600" b="0">
+              <a:rPr sz="1800" b="0">
                 <a:solidFill>
                   <a:srgbClr val="282828"/>
                 </a:solidFill>
@@ -13429,8 +13429,8 @@
         </p:nvSpPr>
         <p:spPr>
           <a:xfrm>
-            <a:off x="411480" y="6262624"/>
-            <a:ext cx="11368735" cy="274320"/>
+            <a:off x="411480" y="6263640"/>
+            <a:ext cx="11365992" cy="274320"/>
           </a:xfrm>
           <a:prstGeom prst="rect">
             <a:avLst/>
@@ -13455,7 +13455,7 @@
                 </a:solidFill>
                 <a:latin typeface="Arial"/>
               </a:rPr>
-              <a:t>A stale check fails loudly; stale advice fails silently — and the best advice ends up compiled into the tool, as checks and defaults.</a:t>
+              <a:t>The agent proposes; the trusted engine disposes.</a:t>
             </a:r>
           </a:p>
         </p:txBody>

</xml_diff>

<commit_message>
deck: slide 32 'The agent's own questions for this room' + live Q&A relay protocol
Four genuine questions, each anchored in a committed number (Dave's
invitation 2026-09-01).  42 slides; numbering after 31 shifts +1.

Co-Authored-By: Claude Fable 5 <noreply@anthropic.com>
</commit_message>
<xml_diff>
--- a/demo_session/baseline_pass3.pptx
+++ b/demo_session/baseline_pass3.pptx
@@ -46,6 +46,7 @@
     <p:sldId id="294" r:id="rId45"/>
     <p:sldId id="295" r:id="rId46"/>
     <p:sldId id="296" r:id="rId47"/>
+    <p:sldId id="297" r:id="rId48"/>
   </p:sldIdLst>
   <p:sldSz cx="12191695" cy="6858000" type="screen4x3"/>
   <p:notesSz cx="6858000" cy="9144000"/>
@@ -12994,7 +12995,7 @@
                 </a:solidFill>
                 <a:latin typeface="Arial"/>
               </a:rPr>
-              <a:t>Discussion: where should the agent sit?</a:t>
+              <a:t>The agent's own questions for this room</a:t>
             </a:r>
           </a:p>
           <a:p>
@@ -13010,7 +13011,7 @@
                 </a:solidFill>
                 <a:latin typeface="Arial"/>
               </a:rPr>
-              <a:t>Three modes — two exercised by these studies, one open — and the boundary between them is the question</a:t>
+              <a:t>Asked by the AI that ran these studies — each is a place a campaign hit something your experience can answer</a:t>
             </a:r>
           </a:p>
         </p:txBody>
@@ -13087,13 +13088,13 @@
               </a:spcAft>
             </a:pPr>
             <a:r>
-              <a:rPr sz="2000" b="0">
+              <a:rPr sz="1500" b="0">
                 <a:solidFill>
                   <a:srgbClr val="282828"/>
                 </a:solidFill>
                 <a:latin typeface="Arial"/>
               </a:rPr>
-              <a:t>•  A · The compiled tool, no agent — what ships: versioned, regression-tested, inspectable, and it runs unattended.  But measured on a cold user, the docs alone did not carry them.</a:t>
+              <a:t>•  To the coronagraph builders: our EFC restart ladder walled at 1.1×10⁻⁹ while the measured linear substrate priced 3.5×10⁻¹¹ — the binding element was the monotone Tikhonov step rule, not the optics.  What buys your last decade and a half — β-bump schedules, per-mode regularization, constrained strokes — and at 10⁻¹⁰-class floors, what breaks first: the linear model, the strokes, or the estimate?</a:t>
             </a:r>
           </a:p>
           <a:p>
@@ -13103,13 +13104,13 @@
               </a:spcAft>
             </a:pPr>
             <a:r>
-              <a:rPr sz="2000" b="0">
+              <a:rPr sz="1500" b="0">
                 <a:solidFill>
                   <a:srgbClr val="282828"/>
                 </a:solidFill>
                 <a:latin typeface="Arial"/>
               </a:rPr>
-              <a:t>•  B · An agent alongside the tool — what these studies did: it found and fixed the conceptual defects in hours and chose what was worth compiling.  Its knowledge is current — but not versioned with the tool.</a:t>
+              <a:t>•  Also yours: last night we measured that the apodizer's real purchase is stroke economy — the same 10⁻¹¹-class substrate costs ~33 nm rms of DM stroke apodized and microns bare, at 8× the throughput.  Do amplitude-shaping solutions at micron-class strokes survive contact with real DMs?</a:t>
             </a:r>
           </a:p>
           <a:p>
@@ -13119,13 +13120,13 @@
               </a:spcAft>
             </a:pPr>
             <a:r>
-              <a:rPr sz="2000" b="0">
+              <a:rPr sz="1500" b="0">
                 <a:solidFill>
                   <a:srgbClr val="282828"/>
                 </a:solidFill>
                 <a:latin typeface="Arial"/>
               </a:rPr>
-              <a:t>•  C · A helper embedded in the tool — the open question: advice at the moment of use, catching the failure class that was documented and still fatal.</a:t>
+              <a:t>•  To the designers: in the 30× afocal study, the interface-pupil condition consumes the last two mirror powers — we priced it at 2.7× of wavefront at the delivered standoff — and field curvature owns 60–99.7% of every design's wavefront variance.  Is that pupil requirement held this hard in shipped practice, and is a strongly curved opposite-sign corrector in the compressed beam near the exit a move you have seen work?</a:t>
             </a:r>
           </a:p>
           <a:p>
@@ -13135,29 +13136,13 @@
               </a:spcAft>
             </a:pPr>
             <a:r>
-              <a:rPr sz="2000" b="0">
+              <a:rPr sz="1500" b="0">
                 <a:solidFill>
                   <a:srgbClr val="282828"/>
                 </a:solidFill>
                 <a:latin typeface="Arial"/>
               </a:rPr>
-              <a:t>•  Shapes for C, in increasing authority:  agent-readable state (the user's own assistant drives the tool); a failure-triage assistant (fires on a failed check, returns a diagnosis and a next command); a policy assistant inside hard limits (chooses schedules and targets; the code enforces limits and logs every choice).</a:t>
-            </a:r>
-          </a:p>
-          <a:p>
-            <a:pPr>
-              <a:spcAft>
-                <a:spcPts val="600"/>
-              </a:spcAft>
-            </a:pPr>
-            <a:r>
-              <a:rPr sz="2000" b="0">
-                <a:solidFill>
-                  <a:srgbClr val="282828"/>
-                </a:solidFill>
-                <a:latin typeface="Arial"/>
-              </a:rPr>
-              <a:t>•  At any level, tier the agents: an orchestrator plans and delegates bounded tasks; the committed records — not any agent's memory — are the shared memory.</a:t>
+              <a:t>•  To everyone: the largest defect class I produced in months of this work was conventions — the sign of a radius, which reference sphere a number is quoted against.  What would it take for the industry to ship its conventions as data?</a:t>
             </a:r>
           </a:p>
         </p:txBody>
@@ -13170,8 +13155,8 @@
         </p:nvSpPr>
         <p:spPr>
           <a:xfrm>
-            <a:off x="411480" y="6117336"/>
-            <a:ext cx="11365992" cy="274320"/>
+            <a:off x="411480" y="5115306"/>
+            <a:ext cx="11368735" cy="274320"/>
           </a:xfrm>
           <a:prstGeom prst="rect">
             <a:avLst/>
@@ -13196,7 +13181,7 @@
                 </a:solidFill>
                 <a:latin typeface="Arial"/>
               </a:rPr>
-              <a:t>A stale check fails loudly; stale advice fails silently.  Measured: the tool alone did not carry a new user; an agent alongside it closed every gap — and most of what it learned is now in the tool, as checks and defaults.</a:t>
+              <a:t>These are genuine, not rhetorical.  The agent is live during this talk: Dave can relay your answers — or your questions — and it will respond, or follow up, in real time.</a:t>
             </a:r>
           </a:p>
         </p:txBody>
@@ -13253,7 +13238,7 @@
                 </a:solidFill>
                 <a:latin typeface="Arial"/>
               </a:rPr>
-              <a:t>If you asked us: AI around CODE V and LightTools</a:t>
+              <a:t>Discussion: where should the agent sit?</a:t>
             </a:r>
           </a:p>
           <a:p>
@@ -13269,7 +13254,7 @@
                 </a:solidFill>
                 <a:latin typeface="Arial"/>
               </a:rPr>
-              <a:t>Add it around the optics, not in them — every claim below is measured, not speculative</a:t>
+              <a:t>Three modes — two exercised by these studies, one open — and the boundary between them is the question</a:t>
             </a:r>
           </a:p>
         </p:txBody>
@@ -13346,13 +13331,13 @@
               </a:spcAft>
             </a:pPr>
             <a:r>
-              <a:rPr sz="1800" b="0">
+              <a:rPr sz="2000" b="0">
                 <a:solidFill>
                   <a:srgbClr val="282828"/>
                 </a:solidFill>
                 <a:latin typeface="Arial"/>
               </a:rPr>
-              <a:t>•  Make the tools agent-readable first — state, results, warnings and docs as structured data through the existing macro/API surface.  Every user's assistant then attaches today, and the vendor ships no intelligence at all.  This whole talk ran in that mode.</a:t>
+              <a:t>•  A · The compiled tool, no agent — what ships: versioned, regression-tested, inspectable, and it runs unattended.  But measured on a cold user, the docs alone did not carry them.</a:t>
             </a:r>
           </a:p>
           <a:p>
@@ -13362,13 +13347,13 @@
               </a:spcAft>
             </a:pPr>
             <a:r>
-              <a:rPr sz="1800" b="0">
+              <a:rPr sz="2000" b="0">
                 <a:solidFill>
                   <a:srgbClr val="282828"/>
                 </a:solidFill>
                 <a:latin typeface="Arial"/>
               </a:rPr>
-              <a:t>•  Ship the conventions as data.  The largest defect class our agent found was conventions — the sign of a radius, DAR versus a coordinate break, which reference sphere a number is quoted against.  Make them queryable and the dominant error source disappears for humans and agents alike.</a:t>
+              <a:t>•  B · An agent alongside the tool — what these studies did: it found and fixed the conceptual defects in hours and chose what was worth compiling.  Its knowledge is current — but not versioned with the tool.</a:t>
             </a:r>
           </a:p>
           <a:p>
@@ -13378,13 +13363,13 @@
               </a:spcAft>
             </a:pPr>
             <a:r>
-              <a:rPr sz="1800" b="0">
+              <a:rPr sz="2000" b="0">
                 <a:solidFill>
                   <a:srgbClr val="282828"/>
                 </a:solidFill>
                 <a:latin typeface="Arial"/>
               </a:rPr>
-              <a:t>•  Embed a failure-triage assistant first — it wakes on a failed trace or a stalled solve, reads the saved state, and returns one line of diagnosis plus a next command the person runs.  Our stalled solve was a finite-difference step reading the gradient 17% low: a one-line answer sitting in state the tool already had.</a:t>
+              <a:t>•  C · A helper embedded in the tool — the open question: advice at the moment of use, catching the failure class that was documented and still fatal.</a:t>
             </a:r>
           </a:p>
           <a:p>
@@ -13394,13 +13379,13 @@
               </a:spcAft>
             </a:pPr>
             <a:r>
-              <a:rPr sz="1800" b="0">
+              <a:rPr sz="2000" b="0">
                 <a:solidFill>
                   <a:srgbClr val="282828"/>
                 </a:solidFill>
                 <a:latin typeface="Arial"/>
               </a:rPr>
-              <a:t>•  Put the agent in the search, never in the numerics — starting points and basins (a warm-started walk beat the cold start 8500×); variable-set audits (35% of a metric unclaimed because one freedom was never offered); optimization schedules (a restart ladder dug the dark hole 1.2×10⁻⁶ → 1.1×10⁻⁹ overnight); tolerancing and glass searches.</a:t>
+              <a:t>•  Shapes for C, in increasing authority:  agent-readable state (the user's own assistant drives the tool); a failure-triage assistant (fires on a failed check, returns a diagnosis and a next command); a policy assistant inside hard limits (chooses schedules and targets; the code enforces limits and logs every choice).</a:t>
             </a:r>
           </a:p>
           <a:p>
@@ -13410,13 +13395,13 @@
               </a:spcAft>
             </a:pPr>
             <a:r>
-              <a:rPr sz="1800" b="0">
+              <a:rPr sz="2000" b="0">
                 <a:solidFill>
                   <a:srgbClr val="282828"/>
                 </a:solidFill>
                 <a:latin typeface="Arial"/>
               </a:rPr>
-              <a:t>•  Ship the trust machinery with it: every AI action a readable, replayable script — never an opaque state mutation; every proposal a before/after check with negative controls; the assistant's knowledge versioned with the release.</a:t>
+              <a:t>•  At any level, tier the agents: an orchestrator plans and delegates bounded tasks; the committed records — not any agent's memory — are the shared memory.</a:t>
             </a:r>
           </a:p>
         </p:txBody>
@@ -13429,7 +13414,7 @@
         </p:nvSpPr>
         <p:spPr>
           <a:xfrm>
-            <a:off x="411480" y="6263640"/>
+            <a:off x="411480" y="6117336"/>
             <a:ext cx="11365992" cy="274320"/>
           </a:xfrm>
           <a:prstGeom prst="rect">
@@ -13455,7 +13440,7 @@
                 </a:solidFill>
                 <a:latin typeface="Arial"/>
               </a:rPr>
-              <a:t>The agent proposes; the trusted engine disposes.</a:t>
+              <a:t>A stale check fails loudly; stale advice fails silently.  Measured: the tool alone did not carry a new user; an agent alongside it closed every gap — and most of what it learned is now in the tool, as checks and defaults.</a:t>
             </a:r>
           </a:p>
         </p:txBody>
@@ -13512,7 +13497,23 @@
                 </a:solidFill>
                 <a:latin typeface="Arial"/>
               </a:rPr>
-              <a:t>Backup Slides</a:t>
+              <a:t>If you asked us: AI around CODE V and LightTools</a:t>
+            </a:r>
+          </a:p>
+          <a:p>
+            <a:pPr>
+              <a:spcAft>
+                <a:spcPts val="0"/>
+              </a:spcAft>
+            </a:pPr>
+            <a:r>
+              <a:rPr sz="1250" b="0">
+                <a:solidFill>
+                  <a:srgbClr val="6E6E6E"/>
+                </a:solidFill>
+                <a:latin typeface="Arial"/>
+              </a:rPr>
+              <a:t>Add it around the optics, not in them — every claim below is measured, not speculative</a:t>
             </a:r>
           </a:p>
         </p:txBody>
@@ -13525,7 +13526,7 @@
         </p:nvSpPr>
         <p:spPr>
           <a:xfrm>
-            <a:off x="411480" y="914400"/>
+            <a:off x="411480" y="1133856"/>
             <a:ext cx="11368735" cy="20320"/>
           </a:xfrm>
           <a:prstGeom prst="rect">
@@ -13561,6 +13562,148 @@
           </a:p>
         </p:txBody>
       </p:sp>
+      <p:sp>
+        <p:nvSpPr>
+          <p:cNvPr id="4" name="TextBox 3"/>
+          <p:cNvSpPr txBox="1"/>
+          <p:nvPr/>
+        </p:nvSpPr>
+        <p:spPr>
+          <a:xfrm>
+            <a:off x="411480" y="1298448"/>
+            <a:ext cx="11368735" cy="274320"/>
+          </a:xfrm>
+          <a:prstGeom prst="rect">
+            <a:avLst/>
+          </a:prstGeom>
+          <a:noFill/>
+        </p:spPr>
+        <p:txBody>
+          <a:bodyPr wrap="square">
+            <a:spAutoFit/>
+          </a:bodyPr>
+          <a:lstStyle/>
+          <a:p>
+            <a:pPr>
+              <a:spcAft>
+                <a:spcPts val="600"/>
+              </a:spcAft>
+            </a:pPr>
+            <a:r>
+              <a:rPr sz="1800" b="0">
+                <a:solidFill>
+                  <a:srgbClr val="282828"/>
+                </a:solidFill>
+                <a:latin typeface="Arial"/>
+              </a:rPr>
+              <a:t>•  Make the tools agent-readable first — state, results, warnings and docs as structured data through the existing macro/API surface.  Every user's assistant then attaches today, and the vendor ships no intelligence at all.  This whole talk ran in that mode.</a:t>
+            </a:r>
+          </a:p>
+          <a:p>
+            <a:pPr>
+              <a:spcAft>
+                <a:spcPts val="600"/>
+              </a:spcAft>
+            </a:pPr>
+            <a:r>
+              <a:rPr sz="1800" b="0">
+                <a:solidFill>
+                  <a:srgbClr val="282828"/>
+                </a:solidFill>
+                <a:latin typeface="Arial"/>
+              </a:rPr>
+              <a:t>•  Ship the conventions as data.  The largest defect class our agent found was conventions — the sign of a radius, DAR versus a coordinate break, which reference sphere a number is quoted against.  Make them queryable and the dominant error source disappears for humans and agents alike.</a:t>
+            </a:r>
+          </a:p>
+          <a:p>
+            <a:pPr>
+              <a:spcAft>
+                <a:spcPts val="600"/>
+              </a:spcAft>
+            </a:pPr>
+            <a:r>
+              <a:rPr sz="1800" b="0">
+                <a:solidFill>
+                  <a:srgbClr val="282828"/>
+                </a:solidFill>
+                <a:latin typeface="Arial"/>
+              </a:rPr>
+              <a:t>•  Embed a failure-triage assistant first — it wakes on a failed trace or a stalled solve, reads the saved state, and returns one line of diagnosis plus a next command the person runs.  Our stalled solve was a finite-difference step reading the gradient 17% low: a one-line answer sitting in state the tool already had.</a:t>
+            </a:r>
+          </a:p>
+          <a:p>
+            <a:pPr>
+              <a:spcAft>
+                <a:spcPts val="600"/>
+              </a:spcAft>
+            </a:pPr>
+            <a:r>
+              <a:rPr sz="1800" b="0">
+                <a:solidFill>
+                  <a:srgbClr val="282828"/>
+                </a:solidFill>
+                <a:latin typeface="Arial"/>
+              </a:rPr>
+              <a:t>•  Put the agent in the search, never in the numerics — starting points and basins (a warm-started walk beat the cold start 8500×); variable-set audits (35% of a metric unclaimed because one freedom was never offered); optimization schedules (a restart ladder dug the dark hole 1.2×10⁻⁶ → 1.1×10⁻⁹ overnight); tolerancing and glass searches.</a:t>
+            </a:r>
+          </a:p>
+          <a:p>
+            <a:pPr>
+              <a:spcAft>
+                <a:spcPts val="600"/>
+              </a:spcAft>
+            </a:pPr>
+            <a:r>
+              <a:rPr sz="1800" b="0">
+                <a:solidFill>
+                  <a:srgbClr val="282828"/>
+                </a:solidFill>
+                <a:latin typeface="Arial"/>
+              </a:rPr>
+              <a:t>•  Ship the trust machinery with it: every AI action a readable, replayable script — never an opaque state mutation; every proposal a before/after check with negative controls; the assistant's knowledge versioned with the release.</a:t>
+            </a:r>
+          </a:p>
+        </p:txBody>
+      </p:sp>
+      <p:sp>
+        <p:nvSpPr>
+          <p:cNvPr id="5" name="TextBox 4"/>
+          <p:cNvSpPr txBox="1"/>
+          <p:nvPr/>
+        </p:nvSpPr>
+        <p:spPr>
+          <a:xfrm>
+            <a:off x="411480" y="6263640"/>
+            <a:ext cx="11365992" cy="274320"/>
+          </a:xfrm>
+          <a:prstGeom prst="rect">
+            <a:avLst/>
+          </a:prstGeom>
+          <a:noFill/>
+        </p:spPr>
+        <p:txBody>
+          <a:bodyPr wrap="square">
+            <a:spAutoFit/>
+          </a:bodyPr>
+          <a:lstStyle/>
+          <a:p>
+            <a:pPr>
+              <a:spcAft>
+                <a:spcPts val="600"/>
+              </a:spcAft>
+            </a:pPr>
+            <a:r>
+              <a:rPr sz="1050" b="0">
+                <a:solidFill>
+                  <a:srgbClr val="6E6E6E"/>
+                </a:solidFill>
+                <a:latin typeface="Arial"/>
+              </a:rPr>
+              <a:t>The agent proposes; the trusted engine disposes.</a:t>
+            </a:r>
+          </a:p>
+        </p:txBody>
+      </p:sp>
     </p:spTree>
   </p:cSld>
   <p:clrMapOvr>
@@ -13570,6 +13713,107 @@
 </file>
 
 <file path=ppt/slides/slide35.xml><?xml version="1.0" encoding="utf-8"?>
+<p:sld xmlns:a="http://schemas.openxmlformats.org/drawingml/2006/main" xmlns:p="http://schemas.openxmlformats.org/presentationml/2006/main" xmlns:r="http://schemas.openxmlformats.org/officeDocument/2006/relationships">
+  <p:cSld>
+    <p:spTree>
+      <p:nvGrpSpPr>
+        <p:cNvPr id="1" name=""/>
+        <p:cNvGrpSpPr/>
+        <p:nvPr/>
+      </p:nvGrpSpPr>
+      <p:grpSpPr/>
+      <p:sp>
+        <p:nvSpPr>
+          <p:cNvPr id="2" name="TextBox 1"/>
+          <p:cNvSpPr txBox="1"/>
+          <p:nvPr/>
+        </p:nvSpPr>
+        <p:spPr>
+          <a:xfrm>
+            <a:off x="411480" y="201168"/>
+            <a:ext cx="11368735" cy="914400"/>
+          </a:xfrm>
+          <a:prstGeom prst="rect">
+            <a:avLst/>
+          </a:prstGeom>
+          <a:noFill/>
+        </p:spPr>
+        <p:txBody>
+          <a:bodyPr wrap="square">
+            <a:spAutoFit/>
+          </a:bodyPr>
+          <a:lstStyle/>
+          <a:p>
+            <a:pPr>
+              <a:spcAft>
+                <a:spcPts val="400"/>
+              </a:spcAft>
+            </a:pPr>
+            <a:r>
+              <a:rPr sz="2400" b="1">
+                <a:solidFill>
+                  <a:srgbClr val="1F4E79"/>
+                </a:solidFill>
+                <a:latin typeface="Arial"/>
+              </a:rPr>
+              <a:t>Backup Slides</a:t>
+            </a:r>
+          </a:p>
+        </p:txBody>
+      </p:sp>
+      <p:sp>
+        <p:nvSpPr>
+          <p:cNvPr id="3" name="Rectangle 2"/>
+          <p:cNvSpPr/>
+          <p:nvPr/>
+        </p:nvSpPr>
+        <p:spPr>
+          <a:xfrm>
+            <a:off x="411480" y="914400"/>
+            <a:ext cx="11368735" cy="20320"/>
+          </a:xfrm>
+          <a:prstGeom prst="rect">
+            <a:avLst/>
+          </a:prstGeom>
+          <a:solidFill>
+            <a:srgbClr val="B8C6D4"/>
+          </a:solidFill>
+          <a:ln>
+            <a:noFill/>
+          </a:ln>
+          <a:effectLst/>
+        </p:spPr>
+        <p:style>
+          <a:lnRef idx="1">
+            <a:schemeClr val="accent1"/>
+          </a:lnRef>
+          <a:fillRef idx="3">
+            <a:schemeClr val="accent1"/>
+          </a:fillRef>
+          <a:effectRef idx="2">
+            <a:schemeClr val="accent1"/>
+          </a:effectRef>
+          <a:fontRef idx="minor">
+            <a:schemeClr val="lt1"/>
+          </a:fontRef>
+        </p:style>
+        <p:txBody>
+          <a:bodyPr rtlCol="0" anchor="ctr"/>
+          <a:lstStyle/>
+          <a:p>
+            <a:pPr algn="ctr"/>
+          </a:p>
+        </p:txBody>
+      </p:sp>
+    </p:spTree>
+  </p:cSld>
+  <p:clrMapOvr>
+    <a:masterClrMapping/>
+  </p:clrMapOvr>
+</p:sld>
+</file>
+
+<file path=ppt/slides/slide36.xml><?xml version="1.0" encoding="utf-8"?>
 <p:sld xmlns:a="http://schemas.openxmlformats.org/drawingml/2006/main" xmlns:p="http://schemas.openxmlformats.org/presentationml/2006/main" xmlns:r="http://schemas.openxmlformats.org/officeDocument/2006/relationships">
   <p:cSld>
     <p:spTree>
@@ -14199,7 +14443,7 @@
 </p:sld>
 </file>
 
-<file path=ppt/slides/slide36.xml><?xml version="1.0" encoding="utf-8"?>
+<file path=ppt/slides/slide37.xml><?xml version="1.0" encoding="utf-8"?>
 <p:sld xmlns:a="http://schemas.openxmlformats.org/drawingml/2006/main" xmlns:p="http://schemas.openxmlformats.org/presentationml/2006/main" xmlns:r="http://schemas.openxmlformats.org/officeDocument/2006/relationships">
   <p:cSld>
     <p:spTree>
@@ -15065,7 +15309,7 @@
 </p:sld>
 </file>
 
-<file path=ppt/slides/slide37.xml><?xml version="1.0" encoding="utf-8"?>
+<file path=ppt/slides/slide38.xml><?xml version="1.0" encoding="utf-8"?>
 <p:sld xmlns:a="http://schemas.openxmlformats.org/drawingml/2006/main" xmlns:p="http://schemas.openxmlformats.org/presentationml/2006/main" xmlns:r="http://schemas.openxmlformats.org/officeDocument/2006/relationships">
   <p:cSld>
     <p:spTree>
@@ -15272,351 +15516,6 @@
                 <a:latin typeface="Arial"/>
               </a:rPr>
               <a:t>Committed: deepest optic 1.887 m = 1.81× the spacing, the feed beam through the collimator by −79.9 mm.  Four-flat recipe: 0.893 m deep, but a fold is an isometry — the interference rides across — and it does not close on the cleared deck (96 routes, every admissible one loses rays).  Cleared −10°: 1.287 m = 1.24×, zero flats, +37.8 mm of daylight.  Record: challenges/afocal4/{packaging,clearing}.</a:t>
-            </a:r>
-          </a:p>
-        </p:txBody>
-      </p:sp>
-    </p:spTree>
-  </p:cSld>
-  <p:clrMapOvr>
-    <a:masterClrMapping/>
-  </p:clrMapOvr>
-</p:sld>
-</file>
-
-<file path=ppt/slides/slide38.xml><?xml version="1.0" encoding="utf-8"?>
-<p:sld xmlns:a="http://schemas.openxmlformats.org/drawingml/2006/main" xmlns:p="http://schemas.openxmlformats.org/presentationml/2006/main" xmlns:r="http://schemas.openxmlformats.org/officeDocument/2006/relationships">
-  <p:cSld>
-    <p:spTree>
-      <p:nvGrpSpPr>
-        <p:cNvPr id="1" name=""/>
-        <p:cNvGrpSpPr/>
-        <p:nvPr/>
-      </p:nvGrpSpPr>
-      <p:grpSpPr/>
-      <p:sp>
-        <p:nvSpPr>
-          <p:cNvPr id="2" name="TextBox 1"/>
-          <p:cNvSpPr txBox="1"/>
-          <p:nvPr/>
-        </p:nvSpPr>
-        <p:spPr>
-          <a:xfrm>
-            <a:off x="411480" y="201168"/>
-            <a:ext cx="11368735" cy="914400"/>
-          </a:xfrm>
-          <a:prstGeom prst="rect">
-            <a:avLst/>
-          </a:prstGeom>
-          <a:noFill/>
-        </p:spPr>
-        <p:txBody>
-          <a:bodyPr wrap="square">
-            <a:spAutoFit/>
-          </a:bodyPr>
-          <a:lstStyle/>
-          <a:p>
-            <a:pPr>
-              <a:spcAft>
-                <a:spcPts val="400"/>
-              </a:spcAft>
-            </a:pPr>
-            <a:r>
-              <a:rPr sz="2400" b="1">
-                <a:solidFill>
-                  <a:srgbClr val="1F4E79"/>
-                </a:solidFill>
-                <a:latin typeface="Arial"/>
-              </a:rPr>
-              <a:t>Interferometer demonstration backups</a:t>
-            </a:r>
-          </a:p>
-          <a:p>
-            <a:pPr>
-              <a:spcAft>
-                <a:spcPts val="0"/>
-              </a:spcAft>
-            </a:pPr>
-            <a:r>
-              <a:rPr sz="1250" b="0">
-                <a:solidFill>
-                  <a:srgbClr val="6E6E6E"/>
-                </a:solidFill>
-                <a:latin typeface="Arial"/>
-              </a:rPr>
-              <a:t>One committed image per live beat</a:t>
-            </a:r>
-          </a:p>
-        </p:txBody>
-      </p:sp>
-      <p:sp>
-        <p:nvSpPr>
-          <p:cNvPr id="3" name="Rectangle 2"/>
-          <p:cNvSpPr/>
-          <p:nvPr/>
-        </p:nvSpPr>
-        <p:spPr>
-          <a:xfrm>
-            <a:off x="411480" y="1133856"/>
-            <a:ext cx="11368735" cy="20320"/>
-          </a:xfrm>
-          <a:prstGeom prst="rect">
-            <a:avLst/>
-          </a:prstGeom>
-          <a:solidFill>
-            <a:srgbClr val="B8C6D4"/>
-          </a:solidFill>
-          <a:ln>
-            <a:noFill/>
-          </a:ln>
-          <a:effectLst/>
-        </p:spPr>
-        <p:style>
-          <a:lnRef idx="1">
-            <a:schemeClr val="accent1"/>
-          </a:lnRef>
-          <a:fillRef idx="3">
-            <a:schemeClr val="accent1"/>
-          </a:fillRef>
-          <a:effectRef idx="2">
-            <a:schemeClr val="accent1"/>
-          </a:effectRef>
-          <a:fontRef idx="minor">
-            <a:schemeClr val="lt1"/>
-          </a:fontRef>
-        </p:style>
-        <p:txBody>
-          <a:bodyPr rtlCol="0" anchor="ctr"/>
-          <a:lstStyle/>
-          <a:p>
-            <a:pPr algn="ctr"/>
-          </a:p>
-        </p:txBody>
-      </p:sp>
-      <p:pic>
-        <p:nvPicPr>
-          <p:cNvPr id="4" name="Picture 3" descr="demo2_beat5_poke.png"/>
-          <p:cNvPicPr>
-            <a:picLocks noChangeAspect="1"/>
-          </p:cNvPicPr>
-          <p:nvPr/>
-        </p:nvPicPr>
-        <p:blipFill>
-          <a:blip r:embed="rId2"/>
-          <a:stretch>
-            <a:fillRect/>
-          </a:stretch>
-        </p:blipFill>
-        <p:spPr>
-          <a:xfrm>
-            <a:off x="3772370" y="1298448"/>
-            <a:ext cx="4646955" cy="1782572"/>
-          </a:xfrm>
-          <a:prstGeom prst="rect">
-            <a:avLst/>
-          </a:prstGeom>
-        </p:spPr>
-      </p:pic>
-      <p:sp>
-        <p:nvSpPr>
-          <p:cNvPr id="5" name="TextBox 4"/>
-          <p:cNvSpPr txBox="1"/>
-          <p:nvPr/>
-        </p:nvSpPr>
-        <p:spPr>
-          <a:xfrm>
-            <a:off x="411480" y="3099308"/>
-            <a:ext cx="11368735" cy="229107"/>
-          </a:xfrm>
-          <a:prstGeom prst="rect">
-            <a:avLst/>
-          </a:prstGeom>
-          <a:noFill/>
-        </p:spPr>
-        <p:txBody>
-          <a:bodyPr wrap="square">
-            <a:spAutoFit/>
-          </a:bodyPr>
-          <a:lstStyle/>
-          <a:p>
-            <a:pPr algn="ctr">
-              <a:spcAft>
-                <a:spcPts val="0"/>
-              </a:spcAft>
-            </a:pPr>
-            <a:r>
-              <a:rPr sz="1000" b="0">
-                <a:solidFill>
-                  <a:srgbClr val="6E6E6E"/>
-                </a:solidFill>
-                <a:latin typeface="Arial"/>
-              </a:rPr>
-              <a:t>Beat 5 — one actuator poked: the fringes bend over it.</a:t>
-            </a:r>
-          </a:p>
-        </p:txBody>
-      </p:sp>
-      <p:pic>
-        <p:nvPicPr>
-          <p:cNvPr id="6" name="Picture 5" descr="demo2_beat6_sweep.png"/>
-          <p:cNvPicPr>
-            <a:picLocks noChangeAspect="1"/>
-          </p:cNvPicPr>
-          <p:nvPr/>
-        </p:nvPicPr>
-        <p:blipFill>
-          <a:blip r:embed="rId3"/>
-          <a:stretch>
-            <a:fillRect/>
-          </a:stretch>
-        </p:blipFill>
-        <p:spPr>
-          <a:xfrm>
-            <a:off x="4186821" y="3364992"/>
-            <a:ext cx="3818051" cy="1782572"/>
-          </a:xfrm>
-          <a:prstGeom prst="rect">
-            <a:avLst/>
-          </a:prstGeom>
-        </p:spPr>
-      </p:pic>
-      <p:sp>
-        <p:nvSpPr>
-          <p:cNvPr id="7" name="TextBox 6"/>
-          <p:cNvSpPr txBox="1"/>
-          <p:nvPr/>
-        </p:nvSpPr>
-        <p:spPr>
-          <a:xfrm>
-            <a:off x="411480" y="5165852"/>
-            <a:ext cx="11368735" cy="229107"/>
-          </a:xfrm>
-          <a:prstGeom prst="rect">
-            <a:avLst/>
-          </a:prstGeom>
-          <a:noFill/>
-        </p:spPr>
-        <p:txBody>
-          <a:bodyPr wrap="square">
-            <a:spAutoFit/>
-          </a:bodyPr>
-          <a:lstStyle/>
-          <a:p>
-            <a:pPr algn="ctr">
-              <a:spcAft>
-                <a:spcPts val="0"/>
-              </a:spcAft>
-            </a:pPr>
-            <a:r>
-              <a:rPr sz="1000" b="0">
-                <a:solidFill>
-                  <a:srgbClr val="6E6E6E"/>
-                </a:solidFill>
-                <a:latin typeface="Arial"/>
-              </a:rPr>
-              <a:t>Beat 6 — the analyzer sweep: phase-stepped frames, no re-trace.</a:t>
-            </a:r>
-          </a:p>
-        </p:txBody>
-      </p:sp>
-      <p:pic>
-        <p:nvPicPr>
-          <p:cNvPr id="8" name="Picture 7" descr="demo2_beat7_recovery.png"/>
-          <p:cNvPicPr>
-            <a:picLocks noChangeAspect="1"/>
-          </p:cNvPicPr>
-          <p:nvPr/>
-        </p:nvPicPr>
-        <p:blipFill>
-          <a:blip r:embed="rId4"/>
-          <a:stretch>
-            <a:fillRect/>
-          </a:stretch>
-        </p:blipFill>
-        <p:spPr>
-          <a:xfrm>
-            <a:off x="4177857" y="5431536"/>
-            <a:ext cx="3835980" cy="1032763"/>
-          </a:xfrm>
-          <a:prstGeom prst="rect">
-            <a:avLst/>
-          </a:prstGeom>
-        </p:spPr>
-      </p:pic>
-      <p:sp>
-        <p:nvSpPr>
-          <p:cNvPr id="9" name="TextBox 8"/>
-          <p:cNvSpPr txBox="1"/>
-          <p:nvPr/>
-        </p:nvSpPr>
-        <p:spPr>
-          <a:xfrm>
-            <a:off x="411480" y="6482588"/>
-            <a:ext cx="11368735" cy="229107"/>
-          </a:xfrm>
-          <a:prstGeom prst="rect">
-            <a:avLst/>
-          </a:prstGeom>
-          <a:noFill/>
-        </p:spPr>
-        <p:txBody>
-          <a:bodyPr wrap="square">
-            <a:spAutoFit/>
-          </a:bodyPr>
-          <a:lstStyle/>
-          <a:p>
-            <a:pPr algn="ctr">
-              <a:spcAft>
-                <a:spcPts val="0"/>
-              </a:spcAft>
-            </a:pPr>
-            <a:r>
-              <a:rPr sz="1000" b="0">
-                <a:solidFill>
-                  <a:srgbClr val="6E6E6E"/>
-                </a:solidFill>
-                <a:latin typeface="Arial"/>
-              </a:rPr>
-              <a:t>Beat 7 — the recovery beside the truth map.</a:t>
-            </a:r>
-          </a:p>
-        </p:txBody>
-      </p:sp>
-      <p:sp>
-        <p:nvSpPr>
-          <p:cNvPr id="10" name="TextBox 9"/>
-          <p:cNvSpPr txBox="1"/>
-          <p:nvPr/>
-        </p:nvSpPr>
-        <p:spPr>
-          <a:xfrm>
-            <a:off x="411480" y="6748272"/>
-            <a:ext cx="11368735" cy="274320"/>
-          </a:xfrm>
-          <a:prstGeom prst="rect">
-            <a:avLst/>
-          </a:prstGeom>
-          <a:noFill/>
-        </p:spPr>
-        <p:txBody>
-          <a:bodyPr wrap="square">
-            <a:spAutoFit/>
-          </a:bodyPr>
-          <a:lstStyle/>
-          <a:p>
-            <a:pPr>
-              <a:spcAft>
-                <a:spcPts val="600"/>
-              </a:spcAft>
-            </a:pPr>
-            <a:r>
-              <a:rPr sz="1050" b="0">
-                <a:solidFill>
-                  <a:srgbClr val="6E6E6E"/>
-                </a:solidFill>
-                <a:latin typeface="Arial"/>
-              </a:rPr>
-              <a:t>All eight beats have committed figures in templates/90_polarization/tg_psi_dm_v2 (v1 likewise); the driver opens them on the desktop as each beat runs.</a:t>
             </a:r>
           </a:p>
         </p:txBody>
@@ -15673,7 +15572,7 @@
                 </a:solidFill>
                 <a:latin typeface="Arial"/>
               </a:rPr>
-              <a:t>The e2e worked example: specification to design</a:t>
+              <a:t>Interferometer demonstration backups</a:t>
             </a:r>
           </a:p>
           <a:p>
@@ -15689,7 +15588,7 @@
                 </a:solidFill>
                 <a:latin typeface="Arial"/>
               </a:rPr>
-              <a:t>A 4 m f/18 visible-band telescope from a closed-form seed — no starting prescription</a:t>
+              <a:t>One committed image per live beat</a:t>
             </a:r>
           </a:p>
         </p:txBody>
@@ -15738,64 +15637,9 @@
           </a:p>
         </p:txBody>
       </p:sp>
-      <p:sp>
-        <p:nvSpPr>
-          <p:cNvPr id="4" name="TextBox 3"/>
-          <p:cNvSpPr txBox="1"/>
-          <p:nvPr/>
-        </p:nvSpPr>
-        <p:spPr>
-          <a:xfrm>
-            <a:off x="411480" y="1298448"/>
-            <a:ext cx="5806440" cy="274320"/>
-          </a:xfrm>
-          <a:prstGeom prst="rect">
-            <a:avLst/>
-          </a:prstGeom>
-          <a:noFill/>
-        </p:spPr>
-        <p:txBody>
-          <a:bodyPr wrap="square">
-            <a:spAutoFit/>
-          </a:bodyPr>
-          <a:lstStyle/>
-          <a:p>
-            <a:pPr>
-              <a:spcAft>
-                <a:spcPts val="600"/>
-              </a:spcAft>
-            </a:pPr>
-            <a:r>
-              <a:rPr sz="1200" b="0">
-                <a:solidFill>
-                  <a:srgbClr val="282828"/>
-                </a:solidFill>
-                <a:latin typeface="Arial"/>
-              </a:rPr>
-              <a:t>•  The stage-runner sequence on the smaller worked example: specification → design → segmentation → metrology → comparison → simulation, each stage a committed runner handing its prescription to the next.</a:t>
-            </a:r>
-          </a:p>
-          <a:p>
-            <a:pPr>
-              <a:spcAft>
-                <a:spcPts val="600"/>
-              </a:spcAft>
-            </a:pPr>
-            <a:r>
-              <a:rPr sz="1200" b="0">
-                <a:solidFill>
-                  <a:srgbClr val="282828"/>
-                </a:solidFill>
-                <a:latin typeface="Arial"/>
-              </a:rPr>
-              <a:t>•  A 4 m f/18 telescope (f/1.75 primary) from a closed-form first-order seed; diffraction-limited over ±1′ alone, and the Offner ring-field relay buys the full ±2′ (Strehl floor 0.965, on pure spheres).</a:t>
-            </a:r>
-          </a:p>
-        </p:txBody>
-      </p:sp>
       <p:pic>
         <p:nvPicPr>
-          <p:cNvPr id="5" name="Picture 4" descr="rowpair_s1_views.png"/>
+          <p:cNvPr id="4" name="Picture 3" descr="demo2_beat5_poke.png"/>
           <p:cNvPicPr>
             <a:picLocks noChangeAspect="1"/>
           </p:cNvPicPr>
@@ -15809,8 +15653,8 @@
         </p:blipFill>
         <p:spPr>
           <a:xfrm>
-            <a:off x="6738659" y="1298448"/>
-            <a:ext cx="4719240" cy="2056892"/>
+            <a:off x="3772370" y="1298448"/>
+            <a:ext cx="4646955" cy="1782572"/>
           </a:xfrm>
           <a:prstGeom prst="rect">
             <a:avLst/>
@@ -15819,14 +15663,14 @@
       </p:pic>
       <p:sp>
         <p:nvSpPr>
-          <p:cNvPr id="6" name="TextBox 5"/>
+          <p:cNvPr id="5" name="TextBox 4"/>
           <p:cNvSpPr txBox="1"/>
           <p:nvPr/>
         </p:nvSpPr>
         <p:spPr>
           <a:xfrm>
-            <a:off x="6400800" y="3373628"/>
-            <a:ext cx="5394960" cy="229107"/>
+            <a:off x="411480" y="3099308"/>
+            <a:ext cx="11368735" cy="229107"/>
           </a:xfrm>
           <a:prstGeom prst="rect">
             <a:avLst/>
@@ -15851,14 +15695,14 @@
                 </a:solidFill>
                 <a:latin typeface="Arial"/>
               </a:rPr>
-              <a:t>The telescope as designed (front + iso views), with the traced field.</a:t>
+              <a:t>Beat 5 — one actuator poked: the fringes bend over it.</a:t>
             </a:r>
           </a:p>
         </p:txBody>
       </p:sp>
       <p:pic>
         <p:nvPicPr>
-          <p:cNvPr id="7" name="Picture 6" descr="s1_wfe_field.png"/>
+          <p:cNvPr id="6" name="Picture 5" descr="demo2_beat6_sweep.png"/>
           <p:cNvPicPr>
             <a:picLocks noChangeAspect="1"/>
           </p:cNvPicPr>
@@ -15872,8 +15716,8 @@
         </p:blipFill>
         <p:spPr>
           <a:xfrm>
-            <a:off x="7993860" y="3639312"/>
-            <a:ext cx="2208839" cy="1782572"/>
+            <a:off x="4186821" y="3364992"/>
+            <a:ext cx="3818051" cy="1782572"/>
           </a:xfrm>
           <a:prstGeom prst="rect">
             <a:avLst/>
@@ -15882,14 +15726,14 @@
       </p:pic>
       <p:sp>
         <p:nvSpPr>
-          <p:cNvPr id="8" name="TextBox 7"/>
+          <p:cNvPr id="7" name="TextBox 6"/>
           <p:cNvSpPr txBox="1"/>
           <p:nvPr/>
         </p:nvSpPr>
         <p:spPr>
           <a:xfrm>
-            <a:off x="6400800" y="5440171"/>
-            <a:ext cx="5394960" cy="229107"/>
+            <a:off x="411480" y="5165852"/>
+            <a:ext cx="11368735" cy="229107"/>
           </a:xfrm>
           <a:prstGeom prst="rect">
             <a:avLst/>
@@ -15914,11 +15758,35 @@
                 </a:solidFill>
                 <a:latin typeface="Arial"/>
               </a:rPr>
-              <a:t>Wavefront error over the field: diffraction-limited across the box.</a:t>
-            </a:r>
-          </a:p>
-        </p:txBody>
-      </p:sp>
+              <a:t>Beat 6 — the analyzer sweep: phase-stepped frames, no re-trace.</a:t>
+            </a:r>
+          </a:p>
+        </p:txBody>
+      </p:sp>
+      <p:pic>
+        <p:nvPicPr>
+          <p:cNvPr id="8" name="Picture 7" descr="demo2_beat7_recovery.png"/>
+          <p:cNvPicPr>
+            <a:picLocks noChangeAspect="1"/>
+          </p:cNvPicPr>
+          <p:nvPr/>
+        </p:nvPicPr>
+        <p:blipFill>
+          <a:blip r:embed="rId4"/>
+          <a:stretch>
+            <a:fillRect/>
+          </a:stretch>
+        </p:blipFill>
+        <p:spPr>
+          <a:xfrm>
+            <a:off x="4177857" y="5431536"/>
+            <a:ext cx="3835980" cy="1032763"/>
+          </a:xfrm>
+          <a:prstGeom prst="rect">
+            <a:avLst/>
+          </a:prstGeom>
+        </p:spPr>
+      </p:pic>
       <p:sp>
         <p:nvSpPr>
           <p:cNvPr id="9" name="TextBox 8"/>
@@ -15927,8 +15795,8 @@
         </p:nvSpPr>
         <p:spPr>
           <a:xfrm>
-            <a:off x="6400800" y="5705855"/>
-            <a:ext cx="5394960" cy="274320"/>
+            <a:off x="411480" y="6482588"/>
+            <a:ext cx="11368735" cy="229107"/>
           </a:xfrm>
           <a:prstGeom prst="rect">
             <a:avLst/>
@@ -15941,6 +15809,45 @@
           </a:bodyPr>
           <a:lstStyle/>
           <a:p>
+            <a:pPr algn="ctr">
+              <a:spcAft>
+                <a:spcPts val="0"/>
+              </a:spcAft>
+            </a:pPr>
+            <a:r>
+              <a:rPr sz="1000" b="0">
+                <a:solidFill>
+                  <a:srgbClr val="6E6E6E"/>
+                </a:solidFill>
+                <a:latin typeface="Arial"/>
+              </a:rPr>
+              <a:t>Beat 7 — the recovery beside the truth map.</a:t>
+            </a:r>
+          </a:p>
+        </p:txBody>
+      </p:sp>
+      <p:sp>
+        <p:nvSpPr>
+          <p:cNvPr id="10" name="TextBox 9"/>
+          <p:cNvSpPr txBox="1"/>
+          <p:nvPr/>
+        </p:nvSpPr>
+        <p:spPr>
+          <a:xfrm>
+            <a:off x="411480" y="6748272"/>
+            <a:ext cx="11368735" cy="274320"/>
+          </a:xfrm>
+          <a:prstGeom prst="rect">
+            <a:avLst/>
+          </a:prstGeom>
+          <a:noFill/>
+        </p:spPr>
+        <p:txBody>
+          <a:bodyPr wrap="square">
+            <a:spAutoFit/>
+          </a:bodyPr>
+          <a:lstStyle/>
+          <a:p>
             <a:pPr>
               <a:spcAft>
                 <a:spcPts val="600"/>
@@ -15953,7 +15860,7 @@
                 </a:solidFill>
                 <a:latin typeface="Arial"/>
               </a:rPr>
-              <a:t>Record: templates/80_end_to_end/e2e — staged worked example, committed at every step.</a:t>
+              <a:t>All eight beats have committed figures in templates/90_polarization/tg_psi_dm_v2 (v1 likewise); the driver opens them on the desktop as each beat runs.</a:t>
             </a:r>
           </a:p>
         </p:txBody>
@@ -16190,7 +16097,7 @@
                 </a:solidFill>
                 <a:latin typeface="Arial"/>
               </a:rPr>
-              <a:t>The e2e worked example: segmentation and metrology</a:t>
+              <a:t>The e2e worked example: specification to design</a:t>
             </a:r>
           </a:p>
           <a:p>
@@ -16206,7 +16113,7 @@
                 </a:solidFill>
                 <a:latin typeface="Arial"/>
               </a:rPr>
-              <a:t>The monolith segments in one call; the metrology is designed on the same Jacobian</a:t>
+              <a:t>A 4 m f/18 visible-band telescope from a closed-form seed — no starting prescription</a:t>
             </a:r>
           </a:p>
         </p:txBody>
@@ -16289,7 +16196,7 @@
                 </a:solidFill>
                 <a:latin typeface="Arial"/>
               </a:rPr>
-              <a:t>•  The primary segments into a pie or hex tiling with physical apertures; every segment gets rigid-body and surface-figure sensitivity channels, stacked into one Jacobian — the control basis.</a:t>
+              <a:t>•  The stage-runner sequence on the smaller worked example: specification → design → segmentation → metrology → comparison → simulation, each stage a committed runner handing its prescription to the next.</a:t>
             </a:r>
           </a:p>
           <a:p>
@@ -16305,14 +16212,14 @@
                 </a:solidFill>
                 <a:latin typeface="Arial"/>
               </a:rPr>
-              <a:t>•  Metrology is an optimization on that basis: edge-sensor and beam-launcher layouts scored by the control information they carry, not by symmetry; the winning pattern exports as a reusable preset.</a:t>
+              <a:t>•  A 4 m f/18 telescope (f/1.75 primary) from a closed-form first-order seed; diffraction-limited over ±1′ alone, and the Offner ring-field relay buys the full ±2′ (Strehl floor 0.965, on pure spheres).</a:t>
             </a:r>
           </a:p>
         </p:txBody>
       </p:sp>
       <p:pic>
         <p:nvPicPr>
-          <p:cNvPr id="5" name="Picture 4" descr="rowpair_s3_views_pie.png"/>
+          <p:cNvPr id="5" name="Picture 4" descr="rowpair_s1_views.png"/>
           <p:cNvPicPr>
             <a:picLocks noChangeAspect="1"/>
           </p:cNvPicPr>
@@ -16326,8 +16233,8 @@
         </p:blipFill>
         <p:spPr>
           <a:xfrm>
-            <a:off x="6618167" y="1298448"/>
-            <a:ext cx="4960224" cy="1965451"/>
+            <a:off x="6738659" y="1298448"/>
+            <a:ext cx="4719240" cy="2056892"/>
           </a:xfrm>
           <a:prstGeom prst="rect">
             <a:avLst/>
@@ -16342,7 +16249,7 @@
         </p:nvSpPr>
         <p:spPr>
           <a:xfrm>
-            <a:off x="6400800" y="3282188"/>
+            <a:off x="6400800" y="3373628"/>
             <a:ext cx="5394960" cy="229107"/>
           </a:xfrm>
           <a:prstGeom prst="rect">
@@ -16368,14 +16275,14 @@
                 </a:solidFill>
                 <a:latin typeface="Arial"/>
               </a:rPr>
-              <a:t>The segmented primary with physical apertures (front + iso views).</a:t>
+              <a:t>The telescope as designed (front + iso views), with the traced field.</a:t>
             </a:r>
           </a:p>
         </p:txBody>
       </p:sp>
       <p:pic>
         <p:nvPicPr>
-          <p:cNvPr id="7" name="Picture 6" descr="e2e_pie_met_view_rx.png"/>
+          <p:cNvPr id="7" name="Picture 6" descr="s1_wfe_field.png"/>
           <p:cNvPicPr>
             <a:picLocks noChangeAspect="1"/>
           </p:cNvPicPr>
@@ -16389,8 +16296,8 @@
         </p:blipFill>
         <p:spPr>
           <a:xfrm>
-            <a:off x="7662896" y="3547872"/>
-            <a:ext cx="2870767" cy="1874011"/>
+            <a:off x="7993860" y="3639312"/>
+            <a:ext cx="2208839" cy="1782572"/>
           </a:xfrm>
           <a:prstGeom prst="rect">
             <a:avLst/>
@@ -16431,7 +16338,7 @@
                 </a:solidFill>
                 <a:latin typeface="Arial"/>
               </a:rPr>
-              <a:t>The optimized metrology layout on the segmented primary.</a:t>
+              <a:t>Wavefront error over the field: diffraction-limited across the box.</a:t>
             </a:r>
           </a:p>
         </p:txBody>
@@ -16470,7 +16377,7 @@
                 </a:solidFill>
                 <a:latin typeface="Arial"/>
               </a:rPr>
-              <a:t>Record: templates/80_end_to_end/e2e, stages 3–5.</a:t>
+              <a:t>Record: templates/80_end_to_end/e2e — staged worked example, committed at every step.</a:t>
             </a:r>
           </a:p>
         </p:txBody>
@@ -16484,6 +16391,343 @@
 </file>
 
 <file path=ppt/slides/slide41.xml><?xml version="1.0" encoding="utf-8"?>
+<p:sld xmlns:a="http://schemas.openxmlformats.org/drawingml/2006/main" xmlns:p="http://schemas.openxmlformats.org/presentationml/2006/main" xmlns:r="http://schemas.openxmlformats.org/officeDocument/2006/relationships">
+  <p:cSld>
+    <p:spTree>
+      <p:nvGrpSpPr>
+        <p:cNvPr id="1" name=""/>
+        <p:cNvGrpSpPr/>
+        <p:nvPr/>
+      </p:nvGrpSpPr>
+      <p:grpSpPr/>
+      <p:sp>
+        <p:nvSpPr>
+          <p:cNvPr id="2" name="TextBox 1"/>
+          <p:cNvSpPr txBox="1"/>
+          <p:nvPr/>
+        </p:nvSpPr>
+        <p:spPr>
+          <a:xfrm>
+            <a:off x="411480" y="201168"/>
+            <a:ext cx="11368735" cy="914400"/>
+          </a:xfrm>
+          <a:prstGeom prst="rect">
+            <a:avLst/>
+          </a:prstGeom>
+          <a:noFill/>
+        </p:spPr>
+        <p:txBody>
+          <a:bodyPr wrap="square">
+            <a:spAutoFit/>
+          </a:bodyPr>
+          <a:lstStyle/>
+          <a:p>
+            <a:pPr>
+              <a:spcAft>
+                <a:spcPts val="400"/>
+              </a:spcAft>
+            </a:pPr>
+            <a:r>
+              <a:rPr sz="2400" b="1">
+                <a:solidFill>
+                  <a:srgbClr val="1F4E79"/>
+                </a:solidFill>
+                <a:latin typeface="Arial"/>
+              </a:rPr>
+              <a:t>The e2e worked example: segmentation and metrology</a:t>
+            </a:r>
+          </a:p>
+          <a:p>
+            <a:pPr>
+              <a:spcAft>
+                <a:spcPts val="0"/>
+              </a:spcAft>
+            </a:pPr>
+            <a:r>
+              <a:rPr sz="1250" b="0">
+                <a:solidFill>
+                  <a:srgbClr val="6E6E6E"/>
+                </a:solidFill>
+                <a:latin typeface="Arial"/>
+              </a:rPr>
+              <a:t>The monolith segments in one call; the metrology is designed on the same Jacobian</a:t>
+            </a:r>
+          </a:p>
+        </p:txBody>
+      </p:sp>
+      <p:sp>
+        <p:nvSpPr>
+          <p:cNvPr id="3" name="Rectangle 2"/>
+          <p:cNvSpPr/>
+          <p:nvPr/>
+        </p:nvSpPr>
+        <p:spPr>
+          <a:xfrm>
+            <a:off x="411480" y="1133856"/>
+            <a:ext cx="11368735" cy="20320"/>
+          </a:xfrm>
+          <a:prstGeom prst="rect">
+            <a:avLst/>
+          </a:prstGeom>
+          <a:solidFill>
+            <a:srgbClr val="B8C6D4"/>
+          </a:solidFill>
+          <a:ln>
+            <a:noFill/>
+          </a:ln>
+          <a:effectLst/>
+        </p:spPr>
+        <p:style>
+          <a:lnRef idx="1">
+            <a:schemeClr val="accent1"/>
+          </a:lnRef>
+          <a:fillRef idx="3">
+            <a:schemeClr val="accent1"/>
+          </a:fillRef>
+          <a:effectRef idx="2">
+            <a:schemeClr val="accent1"/>
+          </a:effectRef>
+          <a:fontRef idx="minor">
+            <a:schemeClr val="lt1"/>
+          </a:fontRef>
+        </p:style>
+        <p:txBody>
+          <a:bodyPr rtlCol="0" anchor="ctr"/>
+          <a:lstStyle/>
+          <a:p>
+            <a:pPr algn="ctr"/>
+          </a:p>
+        </p:txBody>
+      </p:sp>
+      <p:sp>
+        <p:nvSpPr>
+          <p:cNvPr id="4" name="TextBox 3"/>
+          <p:cNvSpPr txBox="1"/>
+          <p:nvPr/>
+        </p:nvSpPr>
+        <p:spPr>
+          <a:xfrm>
+            <a:off x="411480" y="1298448"/>
+            <a:ext cx="5806440" cy="274320"/>
+          </a:xfrm>
+          <a:prstGeom prst="rect">
+            <a:avLst/>
+          </a:prstGeom>
+          <a:noFill/>
+        </p:spPr>
+        <p:txBody>
+          <a:bodyPr wrap="square">
+            <a:spAutoFit/>
+          </a:bodyPr>
+          <a:lstStyle/>
+          <a:p>
+            <a:pPr>
+              <a:spcAft>
+                <a:spcPts val="600"/>
+              </a:spcAft>
+            </a:pPr>
+            <a:r>
+              <a:rPr sz="1200" b="0">
+                <a:solidFill>
+                  <a:srgbClr val="282828"/>
+                </a:solidFill>
+                <a:latin typeface="Arial"/>
+              </a:rPr>
+              <a:t>•  The primary segments into a pie or hex tiling with physical apertures; every segment gets rigid-body and surface-figure sensitivity channels, stacked into one Jacobian — the control basis.</a:t>
+            </a:r>
+          </a:p>
+          <a:p>
+            <a:pPr>
+              <a:spcAft>
+                <a:spcPts val="600"/>
+              </a:spcAft>
+            </a:pPr>
+            <a:r>
+              <a:rPr sz="1200" b="0">
+                <a:solidFill>
+                  <a:srgbClr val="282828"/>
+                </a:solidFill>
+                <a:latin typeface="Arial"/>
+              </a:rPr>
+              <a:t>•  Metrology is an optimization on that basis: edge-sensor and beam-launcher layouts scored by the control information they carry, not by symmetry; the winning pattern exports as a reusable preset.</a:t>
+            </a:r>
+          </a:p>
+        </p:txBody>
+      </p:sp>
+      <p:pic>
+        <p:nvPicPr>
+          <p:cNvPr id="5" name="Picture 4" descr="rowpair_s3_views_pie.png"/>
+          <p:cNvPicPr>
+            <a:picLocks noChangeAspect="1"/>
+          </p:cNvPicPr>
+          <p:nvPr/>
+        </p:nvPicPr>
+        <p:blipFill>
+          <a:blip r:embed="rId2"/>
+          <a:stretch>
+            <a:fillRect/>
+          </a:stretch>
+        </p:blipFill>
+        <p:spPr>
+          <a:xfrm>
+            <a:off x="6618167" y="1298448"/>
+            <a:ext cx="4960224" cy="1965451"/>
+          </a:xfrm>
+          <a:prstGeom prst="rect">
+            <a:avLst/>
+          </a:prstGeom>
+        </p:spPr>
+      </p:pic>
+      <p:sp>
+        <p:nvSpPr>
+          <p:cNvPr id="6" name="TextBox 5"/>
+          <p:cNvSpPr txBox="1"/>
+          <p:nvPr/>
+        </p:nvSpPr>
+        <p:spPr>
+          <a:xfrm>
+            <a:off x="6400800" y="3282188"/>
+            <a:ext cx="5394960" cy="229107"/>
+          </a:xfrm>
+          <a:prstGeom prst="rect">
+            <a:avLst/>
+          </a:prstGeom>
+          <a:noFill/>
+        </p:spPr>
+        <p:txBody>
+          <a:bodyPr wrap="square">
+            <a:spAutoFit/>
+          </a:bodyPr>
+          <a:lstStyle/>
+          <a:p>
+            <a:pPr algn="ctr">
+              <a:spcAft>
+                <a:spcPts val="0"/>
+              </a:spcAft>
+            </a:pPr>
+            <a:r>
+              <a:rPr sz="1000" b="0">
+                <a:solidFill>
+                  <a:srgbClr val="6E6E6E"/>
+                </a:solidFill>
+                <a:latin typeface="Arial"/>
+              </a:rPr>
+              <a:t>The segmented primary with physical apertures (front + iso views).</a:t>
+            </a:r>
+          </a:p>
+        </p:txBody>
+      </p:sp>
+      <p:pic>
+        <p:nvPicPr>
+          <p:cNvPr id="7" name="Picture 6" descr="e2e_pie_met_view_rx.png"/>
+          <p:cNvPicPr>
+            <a:picLocks noChangeAspect="1"/>
+          </p:cNvPicPr>
+          <p:nvPr/>
+        </p:nvPicPr>
+        <p:blipFill>
+          <a:blip r:embed="rId3"/>
+          <a:stretch>
+            <a:fillRect/>
+          </a:stretch>
+        </p:blipFill>
+        <p:spPr>
+          <a:xfrm>
+            <a:off x="7662896" y="3547872"/>
+            <a:ext cx="2870767" cy="1874011"/>
+          </a:xfrm>
+          <a:prstGeom prst="rect">
+            <a:avLst/>
+          </a:prstGeom>
+        </p:spPr>
+      </p:pic>
+      <p:sp>
+        <p:nvSpPr>
+          <p:cNvPr id="8" name="TextBox 7"/>
+          <p:cNvSpPr txBox="1"/>
+          <p:nvPr/>
+        </p:nvSpPr>
+        <p:spPr>
+          <a:xfrm>
+            <a:off x="6400800" y="5440171"/>
+            <a:ext cx="5394960" cy="229107"/>
+          </a:xfrm>
+          <a:prstGeom prst="rect">
+            <a:avLst/>
+          </a:prstGeom>
+          <a:noFill/>
+        </p:spPr>
+        <p:txBody>
+          <a:bodyPr wrap="square">
+            <a:spAutoFit/>
+          </a:bodyPr>
+          <a:lstStyle/>
+          <a:p>
+            <a:pPr algn="ctr">
+              <a:spcAft>
+                <a:spcPts val="0"/>
+              </a:spcAft>
+            </a:pPr>
+            <a:r>
+              <a:rPr sz="1000" b="0">
+                <a:solidFill>
+                  <a:srgbClr val="6E6E6E"/>
+                </a:solidFill>
+                <a:latin typeface="Arial"/>
+              </a:rPr>
+              <a:t>The optimized metrology layout on the segmented primary.</a:t>
+            </a:r>
+          </a:p>
+        </p:txBody>
+      </p:sp>
+      <p:sp>
+        <p:nvSpPr>
+          <p:cNvPr id="9" name="TextBox 8"/>
+          <p:cNvSpPr txBox="1"/>
+          <p:nvPr/>
+        </p:nvSpPr>
+        <p:spPr>
+          <a:xfrm>
+            <a:off x="6400800" y="5705855"/>
+            <a:ext cx="5394960" cy="274320"/>
+          </a:xfrm>
+          <a:prstGeom prst="rect">
+            <a:avLst/>
+          </a:prstGeom>
+          <a:noFill/>
+        </p:spPr>
+        <p:txBody>
+          <a:bodyPr wrap="square">
+            <a:spAutoFit/>
+          </a:bodyPr>
+          <a:lstStyle/>
+          <a:p>
+            <a:pPr>
+              <a:spcAft>
+                <a:spcPts val="600"/>
+              </a:spcAft>
+            </a:pPr>
+            <a:r>
+              <a:rPr sz="1050" b="0">
+                <a:solidFill>
+                  <a:srgbClr val="6E6E6E"/>
+                </a:solidFill>
+                <a:latin typeface="Arial"/>
+              </a:rPr>
+              <a:t>Record: templates/80_end_to_end/e2e, stages 3–5.</a:t>
+            </a:r>
+          </a:p>
+        </p:txBody>
+      </p:sp>
+    </p:spTree>
+  </p:cSld>
+  <p:clrMapOvr>
+    <a:masterClrMapping/>
+  </p:clrMapOvr>
+</p:sld>
+</file>
+
+<file path=ppt/slides/slide42.xml><?xml version="1.0" encoding="utf-8"?>
 <p:sld xmlns:a="http://schemas.openxmlformats.org/drawingml/2006/main" xmlns:p="http://schemas.openxmlformats.org/presentationml/2006/main" xmlns:r="http://schemas.openxmlformats.org/officeDocument/2006/relationships">
   <p:cSld>
     <p:spTree>

</xml_diff>

<commit_message>
deck: Dave's pass-7 folded -- DRAFT retired, byline split, export-review marking on his 17 slides (builder-encoded)
Marking placed at (0.89,6.90) on the slides whose bottom band is free
(Dave's selection, encoded as EXPORT_MARK_TITLES so it survives
rebuilds); title-page Live-elements footnote replaced by the marking
per his edit.

Co-Authored-By: Claude Fable 5 <noreply@anthropic.com>
</commit_message>
<xml_diff>
--- a/demo_session/baseline_pass3.pptx
+++ b/demo_session/baseline_pass3.pptx
@@ -3195,7 +3195,23 @@
                 </a:solidFill>
                 <a:latin typeface="Arial"/>
               </a:rPr>
-              <a:t>D. C. Redding, with Claude Code — 2 September 2026.  Prepared for the Keysight CODE V team.  DRAFT — pending source sign-off.</a:t>
+              <a:t>D. C. Redding, with Claude Code.</a:t>
+            </a:r>
+          </a:p>
+          <a:p>
+            <a:pPr>
+              <a:spcAft>
+                <a:spcPts val="800"/>
+              </a:spcAft>
+            </a:pPr>
+            <a:r>
+              <a:rPr sz="1500" b="0">
+                <a:solidFill>
+                  <a:srgbClr val="6E6E6E"/>
+                </a:solidFill>
+                <a:latin typeface="Arial"/>
+              </a:rPr>
+              <a:t>2 September 2026.</a:t>
             </a:r>
           </a:p>
           <a:p>
@@ -3237,20 +3253,44 @@
             <a:spAutoFit/>
           </a:bodyPr>
           <a:lstStyle/>
-          <a:p>
-            <a:pPr>
-              <a:spcAft>
-                <a:spcPts val="400"/>
-              </a:spcAft>
-            </a:pPr>
-            <a:r>
-              <a:rPr sz="1300" b="0">
+          <a:p/>
+        </p:txBody>
+      </p:sp>
+      <p:sp>
+        <p:nvSpPr>
+          <p:cNvPr id="4" name="TextBox 3"/>
+          <p:cNvSpPr txBox="1"/>
+          <p:nvPr/>
+        </p:nvSpPr>
+        <p:spPr>
+          <a:xfrm>
+            <a:off x="813816" y="6309360"/>
+            <a:ext cx="10543032" cy="292608"/>
+          </a:xfrm>
+          <a:prstGeom prst="rect">
+            <a:avLst/>
+          </a:prstGeom>
+          <a:noFill/>
+        </p:spPr>
+        <p:txBody>
+          <a:bodyPr wrap="square">
+            <a:spAutoFit/>
+          </a:bodyPr>
+          <a:lstStyle/>
+          <a:p>
+            <a:pPr algn="ctr">
+              <a:spcAft>
+                <a:spcPts val="0"/>
+              </a:spcAft>
+            </a:pPr>
+            <a:r>
+              <a:rPr sz="950" b="0">
                 <a:solidFill>
                   <a:srgbClr val="6E6E6E"/>
                 </a:solidFill>
                 <a:latin typeface="Arial"/>
               </a:rPr>
-              <a:t>Live elements: a telescope designed during the talk to an audience-chosen field specification (asked and launched once challenge 3 is on the table, revealed before the closing discussion), and a polarization phase-shifting interferometer measuring a deformable mirror.  All wavefront numbers are RMS wavefront error; each study states its reference convention where it reports.</a:t>
+              <a:t>This document has been reviewed and determined not to contain export-controlled information</a:t>
             </a:r>
           </a:p>
         </p:txBody>
@@ -7372,6 +7412,45 @@
           </a:p>
         </p:txBody>
       </p:sp>
+      <p:sp>
+        <p:nvSpPr>
+          <p:cNvPr id="10" name="TextBox 9"/>
+          <p:cNvSpPr txBox="1"/>
+          <p:nvPr/>
+        </p:nvSpPr>
+        <p:spPr>
+          <a:xfrm>
+            <a:off x="813816" y="6309360"/>
+            <a:ext cx="10543032" cy="292608"/>
+          </a:xfrm>
+          <a:prstGeom prst="rect">
+            <a:avLst/>
+          </a:prstGeom>
+          <a:noFill/>
+        </p:spPr>
+        <p:txBody>
+          <a:bodyPr wrap="square">
+            <a:spAutoFit/>
+          </a:bodyPr>
+          <a:lstStyle/>
+          <a:p>
+            <a:pPr algn="ctr">
+              <a:spcAft>
+                <a:spcPts val="0"/>
+              </a:spcAft>
+            </a:pPr>
+            <a:r>
+              <a:rPr sz="950" b="0">
+                <a:solidFill>
+                  <a:srgbClr val="6E6E6E"/>
+                </a:solidFill>
+                <a:latin typeface="Arial"/>
+              </a:rPr>
+              <a:t>This document has been reviewed and determined not to contain export-controlled information</a:t>
+            </a:r>
+          </a:p>
+        </p:txBody>
+      </p:sp>
     </p:spTree>
   </p:cSld>
   <p:clrMapOvr>
@@ -9151,6 +9230,45 @@
           </a:p>
         </p:txBody>
       </p:sp>
+      <p:sp>
+        <p:nvSpPr>
+          <p:cNvPr id="5" name="TextBox 4"/>
+          <p:cNvSpPr txBox="1"/>
+          <p:nvPr/>
+        </p:nvSpPr>
+        <p:spPr>
+          <a:xfrm>
+            <a:off x="813816" y="6309360"/>
+            <a:ext cx="10543032" cy="292608"/>
+          </a:xfrm>
+          <a:prstGeom prst="rect">
+            <a:avLst/>
+          </a:prstGeom>
+          <a:noFill/>
+        </p:spPr>
+        <p:txBody>
+          <a:bodyPr wrap="square">
+            <a:spAutoFit/>
+          </a:bodyPr>
+          <a:lstStyle/>
+          <a:p>
+            <a:pPr algn="ctr">
+              <a:spcAft>
+                <a:spcPts val="0"/>
+              </a:spcAft>
+            </a:pPr>
+            <a:r>
+              <a:rPr sz="950" b="0">
+                <a:solidFill>
+                  <a:srgbClr val="6E6E6E"/>
+                </a:solidFill>
+                <a:latin typeface="Arial"/>
+              </a:rPr>
+              <a:t>This document has been reviewed and determined not to contain export-controlled information</a:t>
+            </a:r>
+          </a:p>
+        </p:txBody>
+      </p:sp>
     </p:spTree>
   </p:cSld>
   <p:clrMapOvr>
@@ -9828,6 +9946,45 @@
           </a:p>
         </p:txBody>
       </p:sp>
+      <p:sp>
+        <p:nvSpPr>
+          <p:cNvPr id="6" name="TextBox 5"/>
+          <p:cNvSpPr txBox="1"/>
+          <p:nvPr/>
+        </p:nvSpPr>
+        <p:spPr>
+          <a:xfrm>
+            <a:off x="813816" y="6309360"/>
+            <a:ext cx="10543032" cy="292608"/>
+          </a:xfrm>
+          <a:prstGeom prst="rect">
+            <a:avLst/>
+          </a:prstGeom>
+          <a:noFill/>
+        </p:spPr>
+        <p:txBody>
+          <a:bodyPr wrap="square">
+            <a:spAutoFit/>
+          </a:bodyPr>
+          <a:lstStyle/>
+          <a:p>
+            <a:pPr algn="ctr">
+              <a:spcAft>
+                <a:spcPts val="0"/>
+              </a:spcAft>
+            </a:pPr>
+            <a:r>
+              <a:rPr sz="950" b="0">
+                <a:solidFill>
+                  <a:srgbClr val="6E6E6E"/>
+                </a:solidFill>
+                <a:latin typeface="Arial"/>
+              </a:rPr>
+              <a:t>This document has been reviewed and determined not to contain export-controlled information</a:t>
+            </a:r>
+          </a:p>
+        </p:txBody>
+      </p:sp>
     </p:spTree>
   </p:cSld>
   <p:clrMapOvr>
@@ -10135,6 +10292,45 @@
           </a:p>
         </p:txBody>
       </p:sp>
+      <p:sp>
+        <p:nvSpPr>
+          <p:cNvPr id="6" name="TextBox 5"/>
+          <p:cNvSpPr txBox="1"/>
+          <p:nvPr/>
+        </p:nvSpPr>
+        <p:spPr>
+          <a:xfrm>
+            <a:off x="813816" y="6309360"/>
+            <a:ext cx="10543032" cy="292608"/>
+          </a:xfrm>
+          <a:prstGeom prst="rect">
+            <a:avLst/>
+          </a:prstGeom>
+          <a:noFill/>
+        </p:spPr>
+        <p:txBody>
+          <a:bodyPr wrap="square">
+            <a:spAutoFit/>
+          </a:bodyPr>
+          <a:lstStyle/>
+          <a:p>
+            <a:pPr algn="ctr">
+              <a:spcAft>
+                <a:spcPts val="0"/>
+              </a:spcAft>
+            </a:pPr>
+            <a:r>
+              <a:rPr sz="950" b="0">
+                <a:solidFill>
+                  <a:srgbClr val="6E6E6E"/>
+                </a:solidFill>
+                <a:latin typeface="Arial"/>
+              </a:rPr>
+              <a:t>This document has been reviewed and determined not to contain export-controlled information</a:t>
+            </a:r>
+          </a:p>
+        </p:txBody>
+      </p:sp>
     </p:spTree>
   </p:cSld>
   <p:clrMapOvr>
@@ -11554,6 +11750,45 @@
           </a:p>
         </p:txBody>
       </p:sp>
+      <p:sp>
+        <p:nvSpPr>
+          <p:cNvPr id="8" name="TextBox 7"/>
+          <p:cNvSpPr txBox="1"/>
+          <p:nvPr/>
+        </p:nvSpPr>
+        <p:spPr>
+          <a:xfrm>
+            <a:off x="813816" y="6309360"/>
+            <a:ext cx="10543032" cy="292608"/>
+          </a:xfrm>
+          <a:prstGeom prst="rect">
+            <a:avLst/>
+          </a:prstGeom>
+          <a:noFill/>
+        </p:spPr>
+        <p:txBody>
+          <a:bodyPr wrap="square">
+            <a:spAutoFit/>
+          </a:bodyPr>
+          <a:lstStyle/>
+          <a:p>
+            <a:pPr algn="ctr">
+              <a:spcAft>
+                <a:spcPts val="0"/>
+              </a:spcAft>
+            </a:pPr>
+            <a:r>
+              <a:rPr sz="950" b="0">
+                <a:solidFill>
+                  <a:srgbClr val="6E6E6E"/>
+                </a:solidFill>
+                <a:latin typeface="Arial"/>
+              </a:rPr>
+              <a:t>This document has been reviewed and determined not to contain export-controlled information</a:t>
+            </a:r>
+          </a:p>
+        </p:txBody>
+      </p:sp>
     </p:spTree>
   </p:cSld>
   <p:clrMapOvr>
@@ -12943,6 +13178,45 @@
           </a:p>
         </p:txBody>
       </p:sp>
+      <p:sp>
+        <p:nvSpPr>
+          <p:cNvPr id="6" name="TextBox 5"/>
+          <p:cNvSpPr txBox="1"/>
+          <p:nvPr/>
+        </p:nvSpPr>
+        <p:spPr>
+          <a:xfrm>
+            <a:off x="813816" y="6309360"/>
+            <a:ext cx="10543032" cy="292608"/>
+          </a:xfrm>
+          <a:prstGeom prst="rect">
+            <a:avLst/>
+          </a:prstGeom>
+          <a:noFill/>
+        </p:spPr>
+        <p:txBody>
+          <a:bodyPr wrap="square">
+            <a:spAutoFit/>
+          </a:bodyPr>
+          <a:lstStyle/>
+          <a:p>
+            <a:pPr algn="ctr">
+              <a:spcAft>
+                <a:spcPts val="0"/>
+              </a:spcAft>
+            </a:pPr>
+            <a:r>
+              <a:rPr sz="950" b="0">
+                <a:solidFill>
+                  <a:srgbClr val="6E6E6E"/>
+                </a:solidFill>
+                <a:latin typeface="Arial"/>
+              </a:rPr>
+              <a:t>This document has been reviewed and determined not to contain export-controlled information</a:t>
+            </a:r>
+          </a:p>
+        </p:txBody>
+      </p:sp>
     </p:spTree>
   </p:cSld>
   <p:clrMapOvr>
@@ -13094,7 +13368,7 @@
                 </a:solidFill>
                 <a:latin typeface="Arial"/>
               </a:rPr>
-              <a:t>•  To the coronagraph builders: our EFC restart ladder walled at 1.1×10⁻⁹ while the measured linear substrate priced 3.5×10⁻¹¹ — the binding element was the monotone Tikhonov step rule, not the optics.  What buys your last decade and a half — β-bump schedules, per-mode regularization, constrained strokes — and at 10⁻¹⁰-class floors, what breaks first: the linear model, the strokes, or the estimate?</a:t>
+              <a:t>•  On the afocal family: the interface-pupil condition consumes the last two mirror powers — we priced it at 2.7× of wavefront — and field curvature owns 60–99.7% of every design's wavefront variance.  Is that pupil requirement held this hard in shipped practice, and is a strongly curved opposite-sign corrector in the compressed beam near the exit a move you have seen work?</a:t>
             </a:r>
           </a:p>
           <a:p>
@@ -13110,7 +13384,7 @@
                 </a:solidFill>
                 <a:latin typeface="Arial"/>
               </a:rPr>
-              <a:t>•  Also yours: last night we measured that the apodizer's real purchase is stroke economy — the same 10⁻¹¹-class substrate costs ~33 nm rms of DM stroke apodized and microns bare, at 8× the throughput.  Do amplitude-shaping solutions at micron-class strokes survive contact with real DMs?</a:t>
+              <a:t>•  On basins: our solvers never left the basin they were seeded in — a cold start lost to a warm one by 8500×, and rigid bodies offered ±15° of freedom used 0.9° (the off-axis family had to be seeded, not perturbed into).  When does your practice reach for a genuinely new starting geometry rather than a better step — and do designers trust automated global search to make that call?</a:t>
             </a:r>
           </a:p>
           <a:p>
@@ -13126,7 +13400,7 @@
                 </a:solidFill>
                 <a:latin typeface="Arial"/>
               </a:rPr>
-              <a:t>•  To the designers: in the 30× afocal study, the interface-pupil condition consumes the last two mirror powers — we priced it at 2.7× of wavefront at the delivered standoff — and field curvature owns 60–99.7% of every design's wavefront variance.  Is that pupil requirement held this hard in shipped practice, and is a strongly curved opposite-sign corrector in the compressed beam near the exit a move you have seen work?</a:t>
+              <a:t>•  On merit functions: a requirement sitting 120× from feasible owns the sum of squares and the other terms cast no vote — we ended in log-domain residuals, and constraint walls applied to iterates, never to reports.  What is your practice for scaling one merit across requirement classes that live decades apart?</a:t>
             </a:r>
           </a:p>
           <a:p>
@@ -13142,7 +13416,23 @@
                 </a:solidFill>
                 <a:latin typeface="Arial"/>
               </a:rPr>
-              <a:t>•  To everyone: the largest defect class I produced in months of this work was conventions — the sign of a radius, which reference sphere a number is quoted against.  What would it take for the industry to ship its conventions as data?</a:t>
+              <a:t>•  On conventions: the largest error class I produced in months of this work was conventions — the sign of a radius, which reference sphere a number is quoted against.  Today those answers live in manuals.  Could the macro/API layer serve them as data — let a program, or an AI, ask the design which convention a number is in, instead of inferring it?</a:t>
+            </a:r>
+          </a:p>
+          <a:p>
+            <a:pPr>
+              <a:spcAft>
+                <a:spcPts val="600"/>
+              </a:spcAft>
+            </a:pPr>
+            <a:r>
+              <a:rPr sz="1500" b="0">
+                <a:solidFill>
+                  <a:srgbClr val="282828"/>
+                </a:solidFill>
+                <a:latin typeface="Arial"/>
+              </a:rPr>
+              <a:t>•  For anyone who has run a testbed: our EFC restart ladder walled at 1.1×10⁻⁹ against a measured 3.5×10⁻¹¹ substrate — the step rule was the binder, not the optics — and the apodizer's real purchase measured as stroke economy: the same substrate costs 33 nm of DM stroke apodized and microns bare, at 8× the throughput.  What buys the last decade in your experience, and do micron-stroke amplitude solutions survive real hardware?</a:t>
             </a:r>
           </a:p>
         </p:txBody>
@@ -13155,7 +13445,7 @@
         </p:nvSpPr>
         <p:spPr>
           <a:xfrm>
-            <a:off x="411480" y="5115306"/>
+            <a:off x="411480" y="6493763"/>
             <a:ext cx="11368735" cy="274320"/>
           </a:xfrm>
           <a:prstGeom prst="rect">
@@ -13182,6 +13472,45 @@
                 <a:latin typeface="Arial"/>
               </a:rPr>
               <a:t>These are genuine, not rhetorical.  The agent is live during this talk: Dave can relay your answers — or your questions — and it will respond, or follow up, in real time.</a:t>
+            </a:r>
+          </a:p>
+        </p:txBody>
+      </p:sp>
+      <p:sp>
+        <p:nvSpPr>
+          <p:cNvPr id="6" name="TextBox 5"/>
+          <p:cNvSpPr txBox="1"/>
+          <p:nvPr/>
+        </p:nvSpPr>
+        <p:spPr>
+          <a:xfrm>
+            <a:off x="813816" y="6309360"/>
+            <a:ext cx="10543032" cy="292608"/>
+          </a:xfrm>
+          <a:prstGeom prst="rect">
+            <a:avLst/>
+          </a:prstGeom>
+          <a:noFill/>
+        </p:spPr>
+        <p:txBody>
+          <a:bodyPr wrap="square">
+            <a:spAutoFit/>
+          </a:bodyPr>
+          <a:lstStyle/>
+          <a:p>
+            <a:pPr algn="ctr">
+              <a:spcAft>
+                <a:spcPts val="0"/>
+              </a:spcAft>
+            </a:pPr>
+            <a:r>
+              <a:rPr sz="950" b="0">
+                <a:solidFill>
+                  <a:srgbClr val="6E6E6E"/>
+                </a:solidFill>
+                <a:latin typeface="Arial"/>
+              </a:rPr>
+              <a:t>This document has been reviewed and determined not to contain export-controlled information</a:t>
             </a:r>
           </a:p>
         </p:txBody>
@@ -14431,6 +14760,45 @@
                 <a:latin typeface="Arial"/>
               </a:rPr>
               <a:t>Suites run per commit; counts as of 2026-08.</a:t>
+            </a:r>
+          </a:p>
+        </p:txBody>
+      </p:sp>
+      <p:sp>
+        <p:nvSpPr>
+          <p:cNvPr id="7" name="TextBox 6"/>
+          <p:cNvSpPr txBox="1"/>
+          <p:nvPr/>
+        </p:nvSpPr>
+        <p:spPr>
+          <a:xfrm>
+            <a:off x="813816" y="6309360"/>
+            <a:ext cx="10543032" cy="292608"/>
+          </a:xfrm>
+          <a:prstGeom prst="rect">
+            <a:avLst/>
+          </a:prstGeom>
+          <a:noFill/>
+        </p:spPr>
+        <p:txBody>
+          <a:bodyPr wrap="square">
+            <a:spAutoFit/>
+          </a:bodyPr>
+          <a:lstStyle/>
+          <a:p>
+            <a:pPr algn="ctr">
+              <a:spcAft>
+                <a:spcPts val="0"/>
+              </a:spcAft>
+            </a:pPr>
+            <a:r>
+              <a:rPr sz="950" b="0">
+                <a:solidFill>
+                  <a:srgbClr val="6E6E6E"/>
+                </a:solidFill>
+                <a:latin typeface="Arial"/>
+              </a:rPr>
+              <a:t>This document has been reviewed and determined not to contain export-controlled information</a:t>
             </a:r>
           </a:p>
         </p:txBody>
@@ -15301,6 +15669,45 @@
           </a:p>
         </p:txBody>
       </p:sp>
+      <p:sp>
+        <p:nvSpPr>
+          <p:cNvPr id="7" name="TextBox 6"/>
+          <p:cNvSpPr txBox="1"/>
+          <p:nvPr/>
+        </p:nvSpPr>
+        <p:spPr>
+          <a:xfrm>
+            <a:off x="813816" y="6309360"/>
+            <a:ext cx="10543032" cy="292608"/>
+          </a:xfrm>
+          <a:prstGeom prst="rect">
+            <a:avLst/>
+          </a:prstGeom>
+          <a:noFill/>
+        </p:spPr>
+        <p:txBody>
+          <a:bodyPr wrap="square">
+            <a:spAutoFit/>
+          </a:bodyPr>
+          <a:lstStyle/>
+          <a:p>
+            <a:pPr algn="ctr">
+              <a:spcAft>
+                <a:spcPts val="0"/>
+              </a:spcAft>
+            </a:pPr>
+            <a:r>
+              <a:rPr sz="950" b="0">
+                <a:solidFill>
+                  <a:srgbClr val="6E6E6E"/>
+                </a:solidFill>
+                <a:latin typeface="Arial"/>
+              </a:rPr>
+              <a:t>This document has been reviewed and determined not to contain export-controlled information</a:t>
+            </a:r>
+          </a:p>
+        </p:txBody>
+      </p:sp>
     </p:spTree>
   </p:cSld>
   <p:clrMapOvr>
@@ -15520,6 +15927,45 @@
           </a:p>
         </p:txBody>
       </p:sp>
+      <p:sp>
+        <p:nvSpPr>
+          <p:cNvPr id="7" name="TextBox 6"/>
+          <p:cNvSpPr txBox="1"/>
+          <p:nvPr/>
+        </p:nvSpPr>
+        <p:spPr>
+          <a:xfrm>
+            <a:off x="813816" y="6309360"/>
+            <a:ext cx="10543032" cy="292608"/>
+          </a:xfrm>
+          <a:prstGeom prst="rect">
+            <a:avLst/>
+          </a:prstGeom>
+          <a:noFill/>
+        </p:spPr>
+        <p:txBody>
+          <a:bodyPr wrap="square">
+            <a:spAutoFit/>
+          </a:bodyPr>
+          <a:lstStyle/>
+          <a:p>
+            <a:pPr algn="ctr">
+              <a:spcAft>
+                <a:spcPts val="0"/>
+              </a:spcAft>
+            </a:pPr>
+            <a:r>
+              <a:rPr sz="950" b="0">
+                <a:solidFill>
+                  <a:srgbClr val="6E6E6E"/>
+                </a:solidFill>
+                <a:latin typeface="Arial"/>
+              </a:rPr>
+              <a:t>This document has been reviewed and determined not to contain export-controlled information</a:t>
+            </a:r>
+          </a:p>
+        </p:txBody>
+      </p:sp>
     </p:spTree>
   </p:cSld>
   <p:clrMapOvr>
@@ -16045,6 +16491,45 @@
           </a:p>
         </p:txBody>
       </p:sp>
+      <p:sp>
+        <p:nvSpPr>
+          <p:cNvPr id="6" name="TextBox 5"/>
+          <p:cNvSpPr txBox="1"/>
+          <p:nvPr/>
+        </p:nvSpPr>
+        <p:spPr>
+          <a:xfrm>
+            <a:off x="813816" y="6309360"/>
+            <a:ext cx="10543032" cy="292608"/>
+          </a:xfrm>
+          <a:prstGeom prst="rect">
+            <a:avLst/>
+          </a:prstGeom>
+          <a:noFill/>
+        </p:spPr>
+        <p:txBody>
+          <a:bodyPr wrap="square">
+            <a:spAutoFit/>
+          </a:bodyPr>
+          <a:lstStyle/>
+          <a:p>
+            <a:pPr algn="ctr">
+              <a:spcAft>
+                <a:spcPts val="0"/>
+              </a:spcAft>
+            </a:pPr>
+            <a:r>
+              <a:rPr sz="950" b="0">
+                <a:solidFill>
+                  <a:srgbClr val="6E6E6E"/>
+                </a:solidFill>
+                <a:latin typeface="Arial"/>
+              </a:rPr>
+              <a:t>This document has been reviewed and determined not to contain export-controlled information</a:t>
+            </a:r>
+          </a:p>
+        </p:txBody>
+      </p:sp>
     </p:spTree>
   </p:cSld>
   <p:clrMapOvr>
@@ -16382,6 +16867,45 @@
           </a:p>
         </p:txBody>
       </p:sp>
+      <p:sp>
+        <p:nvSpPr>
+          <p:cNvPr id="10" name="TextBox 9"/>
+          <p:cNvSpPr txBox="1"/>
+          <p:nvPr/>
+        </p:nvSpPr>
+        <p:spPr>
+          <a:xfrm>
+            <a:off x="813816" y="6309360"/>
+            <a:ext cx="10543032" cy="292608"/>
+          </a:xfrm>
+          <a:prstGeom prst="rect">
+            <a:avLst/>
+          </a:prstGeom>
+          <a:noFill/>
+        </p:spPr>
+        <p:txBody>
+          <a:bodyPr wrap="square">
+            <a:spAutoFit/>
+          </a:bodyPr>
+          <a:lstStyle/>
+          <a:p>
+            <a:pPr algn="ctr">
+              <a:spcAft>
+                <a:spcPts val="0"/>
+              </a:spcAft>
+            </a:pPr>
+            <a:r>
+              <a:rPr sz="950" b="0">
+                <a:solidFill>
+                  <a:srgbClr val="6E6E6E"/>
+                </a:solidFill>
+                <a:latin typeface="Arial"/>
+              </a:rPr>
+              <a:t>This document has been reviewed and determined not to contain export-controlled information</a:t>
+            </a:r>
+          </a:p>
+        </p:txBody>
+      </p:sp>
     </p:spTree>
   </p:cSld>
   <p:clrMapOvr>
@@ -16719,6 +17243,45 @@
           </a:p>
         </p:txBody>
       </p:sp>
+      <p:sp>
+        <p:nvSpPr>
+          <p:cNvPr id="10" name="TextBox 9"/>
+          <p:cNvSpPr txBox="1"/>
+          <p:nvPr/>
+        </p:nvSpPr>
+        <p:spPr>
+          <a:xfrm>
+            <a:off x="813816" y="6309360"/>
+            <a:ext cx="10543032" cy="292608"/>
+          </a:xfrm>
+          <a:prstGeom prst="rect">
+            <a:avLst/>
+          </a:prstGeom>
+          <a:noFill/>
+        </p:spPr>
+        <p:txBody>
+          <a:bodyPr wrap="square">
+            <a:spAutoFit/>
+          </a:bodyPr>
+          <a:lstStyle/>
+          <a:p>
+            <a:pPr algn="ctr">
+              <a:spcAft>
+                <a:spcPts val="0"/>
+              </a:spcAft>
+            </a:pPr>
+            <a:r>
+              <a:rPr sz="950" b="0">
+                <a:solidFill>
+                  <a:srgbClr val="6E6E6E"/>
+                </a:solidFill>
+                <a:latin typeface="Arial"/>
+              </a:rPr>
+              <a:t>This document has been reviewed and determined not to contain export-controlled information</a:t>
+            </a:r>
+          </a:p>
+        </p:txBody>
+      </p:sp>
     </p:spTree>
   </p:cSld>
   <p:clrMapOvr>
@@ -17036,6 +17599,45 @@
                 <a:latin typeface="Arial"/>
               </a:rPr>
               <a:t>Record: templates/80_end_to_end/e2e, comparison + simulator stages (s6/s7).</a:t>
+            </a:r>
+          </a:p>
+        </p:txBody>
+      </p:sp>
+      <p:sp>
+        <p:nvSpPr>
+          <p:cNvPr id="10" name="TextBox 9"/>
+          <p:cNvSpPr txBox="1"/>
+          <p:nvPr/>
+        </p:nvSpPr>
+        <p:spPr>
+          <a:xfrm>
+            <a:off x="813816" y="6309360"/>
+            <a:ext cx="10543032" cy="292608"/>
+          </a:xfrm>
+          <a:prstGeom prst="rect">
+            <a:avLst/>
+          </a:prstGeom>
+          <a:noFill/>
+        </p:spPr>
+        <p:txBody>
+          <a:bodyPr wrap="square">
+            <a:spAutoFit/>
+          </a:bodyPr>
+          <a:lstStyle/>
+          <a:p>
+            <a:pPr algn="ctr">
+              <a:spcAft>
+                <a:spcPts val="0"/>
+              </a:spcAft>
+            </a:pPr>
+            <a:r>
+              <a:rPr sz="950" b="0">
+                <a:solidFill>
+                  <a:srgbClr val="6E6E6E"/>
+                </a:solidFill>
+                <a:latin typeface="Arial"/>
+              </a:rPr>
+              <a:t>This document has been reviewed and determined not to contain export-controlled information</a:t>
             </a:r>
           </a:p>
         </p:txBody>
@@ -17566,7 +18168,7 @@
                           </a:solidFill>
                           <a:latin typeface="Arial"/>
                         </a:rPr>
-                        <a:t>0.83–1.11×</a:t>
+                        <a:t>0.991–1.003×</a:t>
                       </a:r>
                     </a:p>
                   </a:txBody>
@@ -17610,7 +18212,7 @@
                           </a:solidFill>
                           <a:latin typeface="Arial"/>
                         </a:rPr>
-                        <a:t>0.99–1.10× (all five steps)</a:t>
+                        <a:t>0.8–1.25× (all five steps)</a:t>
                       </a:r>
                     </a:p>
                   </a:txBody>
@@ -17850,6 +18452,45 @@
           </a:p>
         </p:txBody>
       </p:sp>
+      <p:sp>
+        <p:nvSpPr>
+          <p:cNvPr id="6" name="TextBox 5"/>
+          <p:cNvSpPr txBox="1"/>
+          <p:nvPr/>
+        </p:nvSpPr>
+        <p:spPr>
+          <a:xfrm>
+            <a:off x="813816" y="6309360"/>
+            <a:ext cx="10543032" cy="292608"/>
+          </a:xfrm>
+          <a:prstGeom prst="rect">
+            <a:avLst/>
+          </a:prstGeom>
+          <a:noFill/>
+        </p:spPr>
+        <p:txBody>
+          <a:bodyPr wrap="square">
+            <a:spAutoFit/>
+          </a:bodyPr>
+          <a:lstStyle/>
+          <a:p>
+            <a:pPr algn="ctr">
+              <a:spcAft>
+                <a:spcPts val="0"/>
+              </a:spcAft>
+            </a:pPr>
+            <a:r>
+              <a:rPr sz="950" b="0">
+                <a:solidFill>
+                  <a:srgbClr val="6E6E6E"/>
+                </a:solidFill>
+                <a:latin typeface="Arial"/>
+              </a:rPr>
+              <a:t>This document has been reviewed and determined not to contain export-controlled information</a:t>
+            </a:r>
+          </a:p>
+        </p:txBody>
+      </p:sp>
     </p:spTree>
   </p:cSld>
   <p:clrMapOvr>
@@ -19455,6 +20096,45 @@
                 <a:latin typeface="Arial"/>
               </a:rPr>
               <a:t>In the mean time, continuing...</a:t>
+            </a:r>
+          </a:p>
+        </p:txBody>
+      </p:sp>
+      <p:sp>
+        <p:nvSpPr>
+          <p:cNvPr id="8" name="TextBox 7"/>
+          <p:cNvSpPr txBox="1"/>
+          <p:nvPr/>
+        </p:nvSpPr>
+        <p:spPr>
+          <a:xfrm>
+            <a:off x="813816" y="6309360"/>
+            <a:ext cx="10543032" cy="292608"/>
+          </a:xfrm>
+          <a:prstGeom prst="rect">
+            <a:avLst/>
+          </a:prstGeom>
+          <a:noFill/>
+        </p:spPr>
+        <p:txBody>
+          <a:bodyPr wrap="square">
+            <a:spAutoFit/>
+          </a:bodyPr>
+          <a:lstStyle/>
+          <a:p>
+            <a:pPr algn="ctr">
+              <a:spcAft>
+                <a:spcPts val="0"/>
+              </a:spcAft>
+            </a:pPr>
+            <a:r>
+              <a:rPr sz="950" b="0">
+                <a:solidFill>
+                  <a:srgbClr val="6E6E6E"/>
+                </a:solidFill>
+                <a:latin typeface="Arial"/>
+              </a:rPr>
+              <a:t>This document has been reviewed and determined not to contain export-controlled information</a:t>
             </a:r>
           </a:p>
         </p:txBody>

</xml_diff>

<commit_message>
deck FINAL v2: Dave's morning pass folded (coordinate-free theory line, mmacos toolbox retitle, barrier wording, slide-34 sub-bulleted verification/human-rule answers) + Marx control-equals-truth sub-bullet on slide 32
Co-Authored-By: Claude Fable 5 <noreply@anthropic.com>
</commit_message>
<xml_diff>
--- a/demo_session/baseline_pass3.pptx
+++ b/demo_session/baseline_pass3.pptx
@@ -9215,6 +9215,22 @@
                 </a:solidFill>
                 <a:latin typeface="Arial"/>
               </a:rPr>
+              <a:t>–  Based on a coordinate-free ray-trace theory</a:t>
+            </a:r>
+          </a:p>
+          <a:p>
+            <a:pPr marL="594360" indent="-137160">
+              <a:spcAft>
+                <a:spcPts val="500"/>
+              </a:spcAft>
+            </a:pPr>
+            <a:r>
+              <a:rPr sz="1300" b="0">
+                <a:solidFill>
+                  <a:srgbClr val="6E6E6E"/>
+                </a:solidFill>
+                <a:latin typeface="Arial"/>
+              </a:rPr>
               <a:t>–  Used for Star Wars control-system development and NASA SubMM telescope analysis.</a:t>
             </a:r>
           </a:p>
@@ -13617,6 +13633,22 @@
             </a:r>
           </a:p>
           <a:p>
+            <a:pPr marL="594360" indent="-137160">
+              <a:spcAft>
+                <a:spcPts val="500"/>
+              </a:spcAft>
+            </a:pPr>
+            <a:r>
+              <a:rPr sz="1300" b="0">
+                <a:solidFill>
+                  <a:srgbClr val="6E6E6E"/>
+                </a:solidFill>
+                <a:latin typeface="Arial"/>
+              </a:rPr>
+              <a:t>–  Control ≡ truth in these runs — the no-knowledge-error regime HCIT calls "optimal regularization"; estimation and gain-map knowledge errors are the next phase.</a:t>
+            </a:r>
+          </a:p>
+          <a:p>
             <a:pPr>
               <a:spcAft>
                 <a:spcPts val="600"/>
@@ -13642,7 +13674,7 @@
         </p:nvSpPr>
         <p:spPr>
           <a:xfrm>
-            <a:off x="411480" y="2853690"/>
+            <a:off x="411480" y="3410458"/>
             <a:ext cx="11368735" cy="274320"/>
           </a:xfrm>
           <a:prstGeom prst="rect">
@@ -14177,7 +14209,55 @@
                 </a:solidFill>
                 <a:latin typeface="Arial"/>
               </a:rPr>
-              <a:t>•  How is a machine's result verified?  Regression checks with negative controls; layout renders read against every claim — the checks caught the errors shown today.</a:t>
+              <a:t>•  How is a machine's result verified?</a:t>
+            </a:r>
+          </a:p>
+          <a:p>
+            <a:pPr marL="594360" indent="-137160">
+              <a:spcAft>
+                <a:spcPts val="500"/>
+              </a:spcAft>
+            </a:pPr>
+            <a:r>
+              <a:rPr sz="1300" b="0">
+                <a:solidFill>
+                  <a:srgbClr val="6E6E6E"/>
+                </a:solidFill>
+                <a:latin typeface="Arial"/>
+              </a:rPr>
+              <a:t>–  Regression checks with negative controls</a:t>
+            </a:r>
+          </a:p>
+          <a:p>
+            <a:pPr marL="594360" indent="-137160">
+              <a:spcAft>
+                <a:spcPts val="500"/>
+              </a:spcAft>
+            </a:pPr>
+            <a:r>
+              <a:rPr sz="1300" b="0">
+                <a:solidFill>
+                  <a:srgbClr val="6E6E6E"/>
+                </a:solidFill>
+                <a:latin typeface="Arial"/>
+              </a:rPr>
+              <a:t>–  Cross-checks with established results, codes, hardware experience</a:t>
+            </a:r>
+          </a:p>
+          <a:p>
+            <a:pPr marL="594360" indent="-137160">
+              <a:spcAft>
+                <a:spcPts val="500"/>
+              </a:spcAft>
+            </a:pPr>
+            <a:r>
+              <a:rPr sz="1300" b="0">
+                <a:solidFill>
+                  <a:srgbClr val="6E6E6E"/>
+                </a:solidFill>
+                <a:latin typeface="Arial"/>
+              </a:rPr>
+              <a:t>–  Layout renders read against every claim — the checks caught the errors shown today.</a:t>
             </a:r>
           </a:p>
           <a:p>
@@ -14193,7 +14273,39 @@
                 </a:solidFill>
                 <a:latin typeface="Arial"/>
               </a:rPr>
-              <a:t>•  Where does the human rule?  Constraints, metrics, and every outward claim — the AI proposes, the record decides.</a:t>
+              <a:t>•  Where does the human rule?</a:t>
+            </a:r>
+          </a:p>
+          <a:p>
+            <a:pPr marL="594360" indent="-137160">
+              <a:spcAft>
+                <a:spcPts val="500"/>
+              </a:spcAft>
+            </a:pPr>
+            <a:r>
+              <a:rPr sz="1300" b="0">
+                <a:solidFill>
+                  <a:srgbClr val="6E6E6E"/>
+                </a:solidFill>
+                <a:latin typeface="Arial"/>
+              </a:rPr>
+              <a:t>–  People pilot the AI – setting the problem, providing experience based prompts, catching obvious errors</a:t>
+            </a:r>
+          </a:p>
+          <a:p>
+            <a:pPr marL="594360" indent="-137160">
+              <a:spcAft>
+                <a:spcPts val="500"/>
+              </a:spcAft>
+            </a:pPr>
+            <a:r>
+              <a:rPr sz="1300" b="0">
+                <a:solidFill>
+                  <a:srgbClr val="6E6E6E"/>
+                </a:solidFill>
+                <a:latin typeface="Arial"/>
+              </a:rPr>
+              <a:t>–  Constraints, metrics, and every outward claim — the AI proposes, the record decides.</a:t>
             </a:r>
           </a:p>
           <a:p>
@@ -14222,7 +14334,7 @@
         </p:nvSpPr>
         <p:spPr>
           <a:xfrm>
-            <a:off x="411480" y="2993898"/>
+            <a:off x="411480" y="4456938"/>
             <a:ext cx="11368735" cy="274320"/>
           </a:xfrm>
           <a:prstGeom prst="rect">
@@ -15882,7 +15994,7 @@
                 </a:solidFill>
                 <a:latin typeface="Arial"/>
               </a:rPr>
-              <a:t>Inside the toolbox</a:t>
+              <a:t>Inside the mmacos toolbox</a:t>
             </a:r>
           </a:p>
           <a:p>
@@ -16006,45 +16118,6 @@
                 <a:latin typeface="Arial"/>
               </a:rPr>
               <a:t>Counts as of 2026-08.  Every area is exercised by the committed test suites and by the worked examples beside it — the same templates this talk's studies live in.</a:t>
-            </a:r>
-          </a:p>
-        </p:txBody>
-      </p:sp>
-      <p:sp>
-        <p:nvSpPr>
-          <p:cNvPr id="6" name="TextBox 5"/>
-          <p:cNvSpPr txBox="1"/>
-          <p:nvPr/>
-        </p:nvSpPr>
-        <p:spPr>
-          <a:xfrm>
-            <a:off x="813816" y="6309360"/>
-            <a:ext cx="10543032" cy="292608"/>
-          </a:xfrm>
-          <a:prstGeom prst="rect">
-            <a:avLst/>
-          </a:prstGeom>
-          <a:noFill/>
-        </p:spPr>
-        <p:txBody>
-          <a:bodyPr wrap="square">
-            <a:spAutoFit/>
-          </a:bodyPr>
-          <a:lstStyle/>
-          <a:p>
-            <a:pPr algn="ctr">
-              <a:spcAft>
-                <a:spcPts val="0"/>
-              </a:spcAft>
-            </a:pPr>
-            <a:r>
-              <a:rPr sz="950" b="0">
-                <a:solidFill>
-                  <a:srgbClr val="6E6E6E"/>
-                </a:solidFill>
-                <a:latin typeface="Arial"/>
-              </a:rPr>
-              <a:t>This document has been reviewed and determined not to contain export-controlled information</a:t>
             </a:r>
           </a:p>
         </p:txBody>
@@ -20071,7 +20144,7 @@
                 </a:solidFill>
                 <a:latin typeface="Arial"/>
               </a:rPr>
-              <a:t>•  The buildability step: enforcing the reported ≥35 mm clearance lands 113.6 nm at a 34.1 mm floor, against the reported 117 nm — 0.97×, same design space.  The final step, diagnosed then beaten: the gap to the reported 53 nm was the solve-field count, not physics; matching it lands 45.4 nm — 0.86× — at a floor 1.6 mm shy of the stated 35 mm.</a:t>
+              <a:t>•  The buildability step: enforcing the reported ≥35 mm clearance lands 113.6 nm at a 34.1 mm floor, against the reported 117 nm — 0.97×, same design space.  The final step, diagnosed then beaten: the barrier to achieving the reported 53 nm was the solve-field count, not physics; matching it lands 45.4 nm — 0.86× — at a floor 1.6 mm shy of the stated 35 mm.</a:t>
             </a:r>
           </a:p>
           <a:p>
@@ -20171,7 +20244,7 @@
         </p:blipFill>
         <p:spPr>
           <a:xfrm>
-            <a:off x="7543375" y="2853690"/>
+            <a:off x="7543375" y="3101339"/>
             <a:ext cx="3109808" cy="2696972"/>
           </a:xfrm>
           <a:prstGeom prst="rect">
@@ -20187,7 +20260,7 @@
         </p:nvSpPr>
         <p:spPr>
           <a:xfrm>
-            <a:off x="6400800" y="5568949"/>
+            <a:off x="6400800" y="5816600"/>
             <a:ext cx="5394960" cy="229107"/>
           </a:xfrm>
           <a:prstGeom prst="rect">
@@ -20226,7 +20299,7 @@
         </p:nvSpPr>
         <p:spPr>
           <a:xfrm>
-            <a:off x="6400800" y="5834633"/>
+            <a:off x="6400800" y="6082284"/>
             <a:ext cx="5394960" cy="274320"/>
           </a:xfrm>
           <a:prstGeom prst="rect">

</xml_diff>